<commit_message>
Add Ch02 figures for model comparisons
</commit_message>
<xml_diff>
--- a/figures/figures.pptx
+++ b/figures/figures.pptx
@@ -5,13 +5,14 @@
     <p:sldMasterId id="2147483660" r:id="rId1"/>
   </p:sldMasterIdLst>
   <p:notesMasterIdLst>
-    <p:notesMasterId r:id="rId6"/>
+    <p:notesMasterId r:id="rId7"/>
   </p:notesMasterIdLst>
   <p:sldIdLst>
     <p:sldId id="258" r:id="rId2"/>
     <p:sldId id="256" r:id="rId3"/>
-    <p:sldId id="259" r:id="rId4"/>
-    <p:sldId id="257" r:id="rId5"/>
+    <p:sldId id="260" r:id="rId4"/>
+    <p:sldId id="259" r:id="rId5"/>
+    <p:sldId id="257" r:id="rId6"/>
   </p:sldIdLst>
   <p:sldSz cx="12192000" cy="6858000"/>
   <p:notesSz cx="6858000" cy="9144000"/>
@@ -121,6 +122,7 @@
         <p14:section name="Chapter 1" id="{4FFEF0E2-5833-4089-8860-99F4B2E194C0}">
           <p14:sldIdLst>
             <p14:sldId id="256"/>
+            <p14:sldId id="260"/>
             <p14:sldId id="259"/>
           </p14:sldIdLst>
         </p14:section>
@@ -220,7 +222,7 @@
           <a:p>
             <a:fld id="{DAABB0E5-6D8D-4DEE-B75F-67010CF2307C}" type="datetimeFigureOut">
               <a:rPr lang="en-US" smtClean="0"/>
-              <a:t>1/26/2026</a:t>
+              <a:t>1/31/2026</a:t>
             </a:fld>
             <a:endParaRPr lang="en-US"/>
           </a:p>
@@ -755,7 +757,7 @@
           <a:p>
             <a:fld id="{1D549D2C-39EA-4769-BF7E-31FE52D82078}" type="slidenum">
               <a:rPr lang="en-US" smtClean="0"/>
-              <a:t>3</a:t>
+              <a:t>4</a:t>
             </a:fld>
             <a:endParaRPr lang="en-US"/>
           </a:p>
@@ -905,7 +907,7 @@
           <a:p>
             <a:fld id="{B84C5C40-2055-49AF-9028-5DA79E75E391}" type="datetimeFigureOut">
               <a:rPr lang="en-US" smtClean="0"/>
-              <a:t>1/26/2026</a:t>
+              <a:t>1/31/2026</a:t>
             </a:fld>
             <a:endParaRPr lang="en-US"/>
           </a:p>
@@ -1075,7 +1077,7 @@
           <a:p>
             <a:fld id="{B84C5C40-2055-49AF-9028-5DA79E75E391}" type="datetimeFigureOut">
               <a:rPr lang="en-US" smtClean="0"/>
-              <a:t>1/26/2026</a:t>
+              <a:t>1/31/2026</a:t>
             </a:fld>
             <a:endParaRPr lang="en-US"/>
           </a:p>
@@ -1255,7 +1257,7 @@
           <a:p>
             <a:fld id="{B84C5C40-2055-49AF-9028-5DA79E75E391}" type="datetimeFigureOut">
               <a:rPr lang="en-US" smtClean="0"/>
-              <a:t>1/26/2026</a:t>
+              <a:t>1/31/2026</a:t>
             </a:fld>
             <a:endParaRPr lang="en-US"/>
           </a:p>
@@ -1425,7 +1427,7 @@
           <a:p>
             <a:fld id="{B84C5C40-2055-49AF-9028-5DA79E75E391}" type="datetimeFigureOut">
               <a:rPr lang="en-US" smtClean="0"/>
-              <a:t>1/26/2026</a:t>
+              <a:t>1/31/2026</a:t>
             </a:fld>
             <a:endParaRPr lang="en-US"/>
           </a:p>
@@ -1671,7 +1673,7 @@
           <a:p>
             <a:fld id="{B84C5C40-2055-49AF-9028-5DA79E75E391}" type="datetimeFigureOut">
               <a:rPr lang="en-US" smtClean="0"/>
-              <a:t>1/26/2026</a:t>
+              <a:t>1/31/2026</a:t>
             </a:fld>
             <a:endParaRPr lang="en-US"/>
           </a:p>
@@ -1903,7 +1905,7 @@
           <a:p>
             <a:fld id="{B84C5C40-2055-49AF-9028-5DA79E75E391}" type="datetimeFigureOut">
               <a:rPr lang="en-US" smtClean="0"/>
-              <a:t>1/26/2026</a:t>
+              <a:t>1/31/2026</a:t>
             </a:fld>
             <a:endParaRPr lang="en-US"/>
           </a:p>
@@ -2270,7 +2272,7 @@
           <a:p>
             <a:fld id="{B84C5C40-2055-49AF-9028-5DA79E75E391}" type="datetimeFigureOut">
               <a:rPr lang="en-US" smtClean="0"/>
-              <a:t>1/26/2026</a:t>
+              <a:t>1/31/2026</a:t>
             </a:fld>
             <a:endParaRPr lang="en-US"/>
           </a:p>
@@ -2388,7 +2390,7 @@
           <a:p>
             <a:fld id="{B84C5C40-2055-49AF-9028-5DA79E75E391}" type="datetimeFigureOut">
               <a:rPr lang="en-US" smtClean="0"/>
-              <a:t>1/26/2026</a:t>
+              <a:t>1/31/2026</a:t>
             </a:fld>
             <a:endParaRPr lang="en-US"/>
           </a:p>
@@ -2483,7 +2485,7 @@
           <a:p>
             <a:fld id="{B84C5C40-2055-49AF-9028-5DA79E75E391}" type="datetimeFigureOut">
               <a:rPr lang="en-US" smtClean="0"/>
-              <a:t>1/26/2026</a:t>
+              <a:t>1/31/2026</a:t>
             </a:fld>
             <a:endParaRPr lang="en-US"/>
           </a:p>
@@ -2760,7 +2762,7 @@
           <a:p>
             <a:fld id="{B84C5C40-2055-49AF-9028-5DA79E75E391}" type="datetimeFigureOut">
               <a:rPr lang="en-US" smtClean="0"/>
-              <a:t>1/26/2026</a:t>
+              <a:t>1/31/2026</a:t>
             </a:fld>
             <a:endParaRPr lang="en-US"/>
           </a:p>
@@ -3017,7 +3019,7 @@
           <a:p>
             <a:fld id="{B84C5C40-2055-49AF-9028-5DA79E75E391}" type="datetimeFigureOut">
               <a:rPr lang="en-US" smtClean="0"/>
-              <a:t>1/26/2026</a:t>
+              <a:t>1/31/2026</a:t>
             </a:fld>
             <a:endParaRPr lang="en-US"/>
           </a:p>
@@ -3230,7 +3232,7 @@
           <a:p>
             <a:fld id="{B84C5C40-2055-49AF-9028-5DA79E75E391}" type="datetimeFigureOut">
               <a:rPr lang="en-US" smtClean="0"/>
-              <a:t>1/26/2026</a:t>
+              <a:t>1/31/2026</a:t>
             </a:fld>
             <a:endParaRPr lang="en-US"/>
           </a:p>
@@ -4355,6 +4357,659 @@
       </p:grpSpPr>
       <p:sp>
         <p:nvSpPr>
+          <p:cNvPr id="2" name="Rectangle: Rounded Corners 1">
+            <a:extLst>
+              <a:ext uri="{FF2B5EF4-FFF2-40B4-BE49-F238E27FC236}">
+                <a16:creationId xmlns:a16="http://schemas.microsoft.com/office/drawing/2014/main" id="{ED732446-F0F6-0ACF-647A-3BC33E7C3D60}"/>
+              </a:ext>
+            </a:extLst>
+          </p:cNvPr>
+          <p:cNvSpPr/>
+          <p:nvPr/>
+        </p:nvSpPr>
+        <p:spPr>
+          <a:xfrm>
+            <a:off x="962567" y="281940"/>
+            <a:ext cx="10552099" cy="6187439"/>
+          </a:xfrm>
+          <a:prstGeom prst="roundRect">
+            <a:avLst>
+              <a:gd name="adj" fmla="val 5234"/>
+            </a:avLst>
+          </a:prstGeom>
+          <a:solidFill>
+            <a:schemeClr val="bg1"/>
+          </a:solidFill>
+          <a:ln>
+            <a:solidFill>
+              <a:schemeClr val="tx1"/>
+            </a:solidFill>
+          </a:ln>
+        </p:spPr>
+        <p:style>
+          <a:lnRef idx="2">
+            <a:schemeClr val="accent1">
+              <a:shade val="15000"/>
+            </a:schemeClr>
+          </a:lnRef>
+          <a:fillRef idx="1">
+            <a:schemeClr val="accent1"/>
+          </a:fillRef>
+          <a:effectRef idx="0">
+            <a:schemeClr val="accent1"/>
+          </a:effectRef>
+          <a:fontRef idx="minor">
+            <a:schemeClr val="lt1"/>
+          </a:fontRef>
+        </p:style>
+        <p:txBody>
+          <a:bodyPr rtlCol="0" anchor="t"/>
+          <a:lstStyle/>
+          <a:p>
+            <a:pPr algn="ctr"/>
+            <a:r>
+              <a:rPr lang="en-US" dirty="0">
+                <a:solidFill>
+                  <a:schemeClr val="tx1"/>
+                </a:solidFill>
+              </a:rPr>
+              <a:t>Example Models</a:t>
+            </a:r>
+          </a:p>
+        </p:txBody>
+      </p:sp>
+      <p:sp>
+        <p:nvSpPr>
+          <p:cNvPr id="3" name="Rectangle: Rounded Corners 2">
+            <a:extLst>
+              <a:ext uri="{FF2B5EF4-FFF2-40B4-BE49-F238E27FC236}">
+                <a16:creationId xmlns:a16="http://schemas.microsoft.com/office/drawing/2014/main" id="{5574ED1F-143F-F0C3-860B-D1D1A94B8038}"/>
+              </a:ext>
+            </a:extLst>
+          </p:cNvPr>
+          <p:cNvSpPr/>
+          <p:nvPr/>
+        </p:nvSpPr>
+        <p:spPr>
+          <a:xfrm>
+            <a:off x="4778916" y="1188720"/>
+            <a:ext cx="2634168" cy="2335531"/>
+          </a:xfrm>
+          <a:prstGeom prst="roundRect">
+            <a:avLst/>
+          </a:prstGeom>
+          <a:solidFill>
+            <a:srgbClr val="E5F1F8"/>
+          </a:solidFill>
+          <a:ln>
+            <a:solidFill>
+              <a:schemeClr val="tx1"/>
+            </a:solidFill>
+          </a:ln>
+        </p:spPr>
+        <p:style>
+          <a:lnRef idx="2">
+            <a:schemeClr val="accent1">
+              <a:shade val="15000"/>
+            </a:schemeClr>
+          </a:lnRef>
+          <a:fillRef idx="1">
+            <a:schemeClr val="accent1"/>
+          </a:fillRef>
+          <a:effectRef idx="0">
+            <a:schemeClr val="accent1"/>
+          </a:effectRef>
+          <a:fontRef idx="minor">
+            <a:schemeClr val="lt1"/>
+          </a:fontRef>
+        </p:style>
+        <p:txBody>
+          <a:bodyPr rtlCol="0" anchor="t"/>
+          <a:lstStyle/>
+          <a:p>
+            <a:pPr algn="ctr"/>
+            <a:r>
+              <a:rPr lang="en-US" dirty="0">
+                <a:solidFill>
+                  <a:schemeClr val="tx1"/>
+                </a:solidFill>
+              </a:rPr>
+              <a:t>Anthropic</a:t>
+            </a:r>
+          </a:p>
+        </p:txBody>
+      </p:sp>
+      <p:sp>
+        <p:nvSpPr>
+          <p:cNvPr id="4" name="Rectangle: Rounded Corners 3">
+            <a:extLst>
+              <a:ext uri="{FF2B5EF4-FFF2-40B4-BE49-F238E27FC236}">
+                <a16:creationId xmlns:a16="http://schemas.microsoft.com/office/drawing/2014/main" id="{CB92B3E5-A0FB-4F52-03FE-A3994B4A676E}"/>
+              </a:ext>
+            </a:extLst>
+          </p:cNvPr>
+          <p:cNvSpPr/>
+          <p:nvPr/>
+        </p:nvSpPr>
+        <p:spPr>
+          <a:xfrm>
+            <a:off x="1553658" y="1188720"/>
+            <a:ext cx="2634168" cy="2335531"/>
+          </a:xfrm>
+          <a:prstGeom prst="roundRect">
+            <a:avLst/>
+          </a:prstGeom>
+          <a:solidFill>
+            <a:srgbClr val="E5F1F8"/>
+          </a:solidFill>
+          <a:ln>
+            <a:solidFill>
+              <a:schemeClr val="tx1"/>
+            </a:solidFill>
+          </a:ln>
+        </p:spPr>
+        <p:style>
+          <a:lnRef idx="2">
+            <a:schemeClr val="accent1">
+              <a:shade val="15000"/>
+            </a:schemeClr>
+          </a:lnRef>
+          <a:fillRef idx="1">
+            <a:schemeClr val="accent1"/>
+          </a:fillRef>
+          <a:effectRef idx="0">
+            <a:schemeClr val="accent1"/>
+          </a:effectRef>
+          <a:fontRef idx="minor">
+            <a:schemeClr val="lt1"/>
+          </a:fontRef>
+        </p:style>
+        <p:txBody>
+          <a:bodyPr rtlCol="0" anchor="t"/>
+          <a:lstStyle/>
+          <a:p>
+            <a:pPr algn="ctr"/>
+            <a:r>
+              <a:rPr lang="en-US" dirty="0">
+                <a:solidFill>
+                  <a:schemeClr val="tx1"/>
+                </a:solidFill>
+              </a:rPr>
+              <a:t>Azure OpenAI</a:t>
+            </a:r>
+          </a:p>
+        </p:txBody>
+      </p:sp>
+      <p:sp>
+        <p:nvSpPr>
+          <p:cNvPr id="5" name="Rectangle: Rounded Corners 4">
+            <a:extLst>
+              <a:ext uri="{FF2B5EF4-FFF2-40B4-BE49-F238E27FC236}">
+                <a16:creationId xmlns:a16="http://schemas.microsoft.com/office/drawing/2014/main" id="{ACE8A258-9DE7-F4AF-1449-211286E0D11E}"/>
+              </a:ext>
+            </a:extLst>
+          </p:cNvPr>
+          <p:cNvSpPr/>
+          <p:nvPr/>
+        </p:nvSpPr>
+        <p:spPr>
+          <a:xfrm>
+            <a:off x="8004174" y="1188720"/>
+            <a:ext cx="2634168" cy="2335531"/>
+          </a:xfrm>
+          <a:prstGeom prst="roundRect">
+            <a:avLst/>
+          </a:prstGeom>
+          <a:solidFill>
+            <a:srgbClr val="E5F1F8"/>
+          </a:solidFill>
+          <a:ln>
+            <a:solidFill>
+              <a:schemeClr val="tx1"/>
+            </a:solidFill>
+          </a:ln>
+        </p:spPr>
+        <p:style>
+          <a:lnRef idx="2">
+            <a:schemeClr val="accent1">
+              <a:shade val="15000"/>
+            </a:schemeClr>
+          </a:lnRef>
+          <a:fillRef idx="1">
+            <a:schemeClr val="accent1"/>
+          </a:fillRef>
+          <a:effectRef idx="0">
+            <a:schemeClr val="accent1"/>
+          </a:effectRef>
+          <a:fontRef idx="minor">
+            <a:schemeClr val="lt1"/>
+          </a:fontRef>
+        </p:style>
+        <p:txBody>
+          <a:bodyPr rtlCol="0" anchor="t"/>
+          <a:lstStyle/>
+          <a:p>
+            <a:pPr algn="ctr"/>
+            <a:r>
+              <a:rPr lang="en-US" dirty="0">
+                <a:solidFill>
+                  <a:schemeClr val="tx1"/>
+                </a:solidFill>
+              </a:rPr>
+              <a:t>Microsoft</a:t>
+            </a:r>
+          </a:p>
+        </p:txBody>
+      </p:sp>
+      <p:sp>
+        <p:nvSpPr>
+          <p:cNvPr id="6" name="Rectangle: Rounded Corners 5">
+            <a:extLst>
+              <a:ext uri="{FF2B5EF4-FFF2-40B4-BE49-F238E27FC236}">
+                <a16:creationId xmlns:a16="http://schemas.microsoft.com/office/drawing/2014/main" id="{417ADCD0-E7DE-9B18-898C-7D55B783F694}"/>
+              </a:ext>
+            </a:extLst>
+          </p:cNvPr>
+          <p:cNvSpPr/>
+          <p:nvPr/>
+        </p:nvSpPr>
+        <p:spPr>
+          <a:xfrm>
+            <a:off x="4778916" y="3653789"/>
+            <a:ext cx="2634168" cy="2335531"/>
+          </a:xfrm>
+          <a:prstGeom prst="roundRect">
+            <a:avLst/>
+          </a:prstGeom>
+          <a:solidFill>
+            <a:srgbClr val="E5F1F8"/>
+          </a:solidFill>
+          <a:ln>
+            <a:solidFill>
+              <a:schemeClr val="tx1"/>
+            </a:solidFill>
+          </a:ln>
+        </p:spPr>
+        <p:style>
+          <a:lnRef idx="2">
+            <a:schemeClr val="accent1">
+              <a:shade val="15000"/>
+            </a:schemeClr>
+          </a:lnRef>
+          <a:fillRef idx="1">
+            <a:schemeClr val="accent1"/>
+          </a:fillRef>
+          <a:effectRef idx="0">
+            <a:schemeClr val="accent1"/>
+          </a:effectRef>
+          <a:fontRef idx="minor">
+            <a:schemeClr val="lt1"/>
+          </a:fontRef>
+        </p:style>
+        <p:txBody>
+          <a:bodyPr rtlCol="0" anchor="t"/>
+          <a:lstStyle/>
+          <a:p>
+            <a:pPr algn="ctr"/>
+            <a:r>
+              <a:rPr lang="en-US" dirty="0">
+                <a:solidFill>
+                  <a:schemeClr val="tx1"/>
+                </a:solidFill>
+              </a:rPr>
+              <a:t>Mistral AI</a:t>
+            </a:r>
+          </a:p>
+        </p:txBody>
+      </p:sp>
+      <p:sp>
+        <p:nvSpPr>
+          <p:cNvPr id="7" name="Rectangle: Rounded Corners 6">
+            <a:extLst>
+              <a:ext uri="{FF2B5EF4-FFF2-40B4-BE49-F238E27FC236}">
+                <a16:creationId xmlns:a16="http://schemas.microsoft.com/office/drawing/2014/main" id="{A55125DD-7A11-66B1-DDF5-ECD5D6C1F69B}"/>
+              </a:ext>
+            </a:extLst>
+          </p:cNvPr>
+          <p:cNvSpPr/>
+          <p:nvPr/>
+        </p:nvSpPr>
+        <p:spPr>
+          <a:xfrm>
+            <a:off x="1553658" y="3653789"/>
+            <a:ext cx="2634168" cy="2335531"/>
+          </a:xfrm>
+          <a:prstGeom prst="roundRect">
+            <a:avLst/>
+          </a:prstGeom>
+          <a:solidFill>
+            <a:srgbClr val="E5F1F8"/>
+          </a:solidFill>
+          <a:ln>
+            <a:solidFill>
+              <a:schemeClr val="tx1"/>
+            </a:solidFill>
+          </a:ln>
+        </p:spPr>
+        <p:style>
+          <a:lnRef idx="2">
+            <a:schemeClr val="accent1">
+              <a:shade val="15000"/>
+            </a:schemeClr>
+          </a:lnRef>
+          <a:fillRef idx="1">
+            <a:schemeClr val="accent1"/>
+          </a:fillRef>
+          <a:effectRef idx="0">
+            <a:schemeClr val="accent1"/>
+          </a:effectRef>
+          <a:fontRef idx="minor">
+            <a:schemeClr val="lt1"/>
+          </a:fontRef>
+        </p:style>
+        <p:txBody>
+          <a:bodyPr rtlCol="0" anchor="t"/>
+          <a:lstStyle/>
+          <a:p>
+            <a:pPr algn="ctr"/>
+            <a:r>
+              <a:rPr lang="en-US" dirty="0">
+                <a:solidFill>
+                  <a:schemeClr val="tx1"/>
+                </a:solidFill>
+              </a:rPr>
+              <a:t>Meta</a:t>
+            </a:r>
+          </a:p>
+        </p:txBody>
+      </p:sp>
+      <p:sp>
+        <p:nvSpPr>
+          <p:cNvPr id="8" name="Rectangle: Rounded Corners 7">
+            <a:extLst>
+              <a:ext uri="{FF2B5EF4-FFF2-40B4-BE49-F238E27FC236}">
+                <a16:creationId xmlns:a16="http://schemas.microsoft.com/office/drawing/2014/main" id="{4D8433B6-E222-52DE-3420-6BC81E4D9945}"/>
+              </a:ext>
+            </a:extLst>
+          </p:cNvPr>
+          <p:cNvSpPr/>
+          <p:nvPr/>
+        </p:nvSpPr>
+        <p:spPr>
+          <a:xfrm>
+            <a:off x="8004174" y="3653789"/>
+            <a:ext cx="2634168" cy="2335531"/>
+          </a:xfrm>
+          <a:prstGeom prst="roundRect">
+            <a:avLst/>
+          </a:prstGeom>
+          <a:solidFill>
+            <a:srgbClr val="E5F1F8"/>
+          </a:solidFill>
+          <a:ln>
+            <a:solidFill>
+              <a:schemeClr val="tx1"/>
+            </a:solidFill>
+          </a:ln>
+        </p:spPr>
+        <p:style>
+          <a:lnRef idx="2">
+            <a:schemeClr val="accent1">
+              <a:shade val="15000"/>
+            </a:schemeClr>
+          </a:lnRef>
+          <a:fillRef idx="1">
+            <a:schemeClr val="accent1"/>
+          </a:fillRef>
+          <a:effectRef idx="0">
+            <a:schemeClr val="accent1"/>
+          </a:effectRef>
+          <a:fontRef idx="minor">
+            <a:schemeClr val="lt1"/>
+          </a:fontRef>
+        </p:style>
+        <p:txBody>
+          <a:bodyPr rtlCol="0" anchor="t"/>
+          <a:lstStyle/>
+          <a:p>
+            <a:pPr algn="ctr"/>
+            <a:r>
+              <a:rPr lang="en-US" dirty="0">
+                <a:solidFill>
+                  <a:schemeClr val="tx1"/>
+                </a:solidFill>
+              </a:rPr>
+              <a:t>DeepSeek</a:t>
+            </a:r>
+          </a:p>
+        </p:txBody>
+      </p:sp>
+      <p:sp>
+        <p:nvSpPr>
+          <p:cNvPr id="10" name="Rectangle: Rounded Corners 9">
+            <a:extLst>
+              <a:ext uri="{FF2B5EF4-FFF2-40B4-BE49-F238E27FC236}">
+                <a16:creationId xmlns:a16="http://schemas.microsoft.com/office/drawing/2014/main" id="{02E5EA1C-587E-4A45-E606-F67DF515B407}"/>
+              </a:ext>
+            </a:extLst>
+          </p:cNvPr>
+          <p:cNvSpPr/>
+          <p:nvPr/>
+        </p:nvSpPr>
+        <p:spPr>
+          <a:xfrm>
+            <a:off x="1790700" y="1882140"/>
+            <a:ext cx="2111892" cy="322508"/>
+          </a:xfrm>
+          <a:prstGeom prst="roundRect">
+            <a:avLst>
+              <a:gd name="adj" fmla="val 50000"/>
+            </a:avLst>
+          </a:prstGeom>
+          <a:solidFill>
+            <a:srgbClr val="B2D4EB"/>
+          </a:solidFill>
+          <a:ln>
+            <a:solidFill>
+              <a:schemeClr val="tx1"/>
+            </a:solidFill>
+          </a:ln>
+        </p:spPr>
+        <p:style>
+          <a:lnRef idx="2">
+            <a:schemeClr val="accent1">
+              <a:shade val="15000"/>
+            </a:schemeClr>
+          </a:lnRef>
+          <a:fillRef idx="1">
+            <a:schemeClr val="accent1"/>
+          </a:fillRef>
+          <a:effectRef idx="0">
+            <a:schemeClr val="accent1"/>
+          </a:effectRef>
+          <a:fontRef idx="minor">
+            <a:schemeClr val="lt1"/>
+          </a:fontRef>
+        </p:style>
+        <p:txBody>
+          <a:bodyPr rtlCol="0" anchor="ctr"/>
+          <a:lstStyle/>
+          <a:p>
+            <a:pPr algn="ctr"/>
+            <a:r>
+              <a:rPr lang="en-US" dirty="0" err="1">
+                <a:solidFill>
+                  <a:schemeClr val="tx1"/>
+                </a:solidFill>
+              </a:rPr>
+              <a:t>gpt</a:t>
+            </a:r>
+            <a:endParaRPr lang="en-US" i="1" dirty="0">
+              <a:solidFill>
+                <a:schemeClr val="tx1"/>
+              </a:solidFill>
+            </a:endParaRPr>
+          </a:p>
+        </p:txBody>
+      </p:sp>
+      <p:sp>
+        <p:nvSpPr>
+          <p:cNvPr id="11" name="Rectangle: Rounded Corners 10">
+            <a:extLst>
+              <a:ext uri="{FF2B5EF4-FFF2-40B4-BE49-F238E27FC236}">
+                <a16:creationId xmlns:a16="http://schemas.microsoft.com/office/drawing/2014/main" id="{E11D9861-1EDA-793B-0AA0-18BFA52ACCE4}"/>
+              </a:ext>
+            </a:extLst>
+          </p:cNvPr>
+          <p:cNvSpPr/>
+          <p:nvPr/>
+        </p:nvSpPr>
+        <p:spPr>
+          <a:xfrm>
+            <a:off x="1790700" y="2380687"/>
+            <a:ext cx="2111892" cy="322508"/>
+          </a:xfrm>
+          <a:prstGeom prst="roundRect">
+            <a:avLst>
+              <a:gd name="adj" fmla="val 50000"/>
+            </a:avLst>
+          </a:prstGeom>
+          <a:solidFill>
+            <a:srgbClr val="B2D4EB"/>
+          </a:solidFill>
+          <a:ln>
+            <a:solidFill>
+              <a:schemeClr val="tx1"/>
+            </a:solidFill>
+          </a:ln>
+        </p:spPr>
+        <p:style>
+          <a:lnRef idx="2">
+            <a:schemeClr val="accent1">
+              <a:shade val="15000"/>
+            </a:schemeClr>
+          </a:lnRef>
+          <a:fillRef idx="1">
+            <a:schemeClr val="accent1"/>
+          </a:fillRef>
+          <a:effectRef idx="0">
+            <a:schemeClr val="accent1"/>
+          </a:effectRef>
+          <a:fontRef idx="minor">
+            <a:schemeClr val="lt1"/>
+          </a:fontRef>
+        </p:style>
+        <p:txBody>
+          <a:bodyPr rtlCol="0" anchor="ctr"/>
+          <a:lstStyle/>
+          <a:p>
+            <a:pPr algn="ctr"/>
+            <a:r>
+              <a:rPr lang="en-US" dirty="0">
+                <a:solidFill>
+                  <a:schemeClr val="tx1"/>
+                </a:solidFill>
+              </a:rPr>
+              <a:t>o</a:t>
+            </a:r>
+          </a:p>
+        </p:txBody>
+      </p:sp>
+      <p:sp>
+        <p:nvSpPr>
+          <p:cNvPr id="12" name="Rectangle: Rounded Corners 11">
+            <a:extLst>
+              <a:ext uri="{FF2B5EF4-FFF2-40B4-BE49-F238E27FC236}">
+                <a16:creationId xmlns:a16="http://schemas.microsoft.com/office/drawing/2014/main" id="{46BFDC7A-CED3-C375-66E6-683B9E52EDD1}"/>
+              </a:ext>
+            </a:extLst>
+          </p:cNvPr>
+          <p:cNvSpPr/>
+          <p:nvPr/>
+        </p:nvSpPr>
+        <p:spPr>
+          <a:xfrm>
+            <a:off x="1790700" y="2879234"/>
+            <a:ext cx="2111892" cy="322508"/>
+          </a:xfrm>
+          <a:prstGeom prst="roundRect">
+            <a:avLst>
+              <a:gd name="adj" fmla="val 50000"/>
+            </a:avLst>
+          </a:prstGeom>
+          <a:solidFill>
+            <a:srgbClr val="B2D4EB"/>
+          </a:solidFill>
+          <a:ln>
+            <a:solidFill>
+              <a:schemeClr val="tx1"/>
+            </a:solidFill>
+          </a:ln>
+        </p:spPr>
+        <p:style>
+          <a:lnRef idx="2">
+            <a:schemeClr val="accent1">
+              <a:shade val="15000"/>
+            </a:schemeClr>
+          </a:lnRef>
+          <a:fillRef idx="1">
+            <a:schemeClr val="accent1"/>
+          </a:fillRef>
+          <a:effectRef idx="0">
+            <a:schemeClr val="accent1"/>
+          </a:effectRef>
+          <a:fontRef idx="minor">
+            <a:schemeClr val="lt1"/>
+          </a:fontRef>
+        </p:style>
+        <p:txBody>
+          <a:bodyPr rtlCol="0" anchor="ctr"/>
+          <a:lstStyle/>
+          <a:p>
+            <a:pPr algn="ctr"/>
+            <a:r>
+              <a:rPr lang="en-US" dirty="0">
+                <a:solidFill>
+                  <a:schemeClr val="tx1"/>
+                </a:solidFill>
+              </a:rPr>
+              <a:t>sora</a:t>
+            </a:r>
+          </a:p>
+        </p:txBody>
+      </p:sp>
+    </p:spTree>
+    <p:extLst>
+      <p:ext uri="{BB962C8B-B14F-4D97-AF65-F5344CB8AC3E}">
+        <p14:creationId xmlns:p14="http://schemas.microsoft.com/office/powerpoint/2010/main" val="2145715379"/>
+      </p:ext>
+    </p:extLst>
+  </p:cSld>
+  <p:clrMapOvr>
+    <a:masterClrMapping/>
+  </p:clrMapOvr>
+</p:sld>
+</file>
+
+<file path=ppt/slides/slide4.xml><?xml version="1.0" encoding="utf-8"?>
+<p:sld xmlns:a="http://schemas.openxmlformats.org/drawingml/2006/main" xmlns:r="http://schemas.openxmlformats.org/officeDocument/2006/relationships" xmlns:p="http://schemas.openxmlformats.org/presentationml/2006/main">
+  <p:cSld>
+    <p:spTree>
+      <p:nvGrpSpPr>
+        <p:cNvPr id="1" name=""/>
+        <p:cNvGrpSpPr/>
+        <p:nvPr/>
+      </p:nvGrpSpPr>
+      <p:grpSpPr>
+        <a:xfrm>
+          <a:off x="0" y="0"/>
+          <a:ext cx="0" cy="0"/>
+          <a:chOff x="0" y="0"/>
+          <a:chExt cx="0" cy="0"/>
+        </a:xfrm>
+      </p:grpSpPr>
+      <p:sp>
+        <p:nvSpPr>
           <p:cNvPr id="5" name="TextBox 4">
             <a:extLst>
               <a:ext uri="{FF2B5EF4-FFF2-40B4-BE49-F238E27FC236}">
@@ -4472,7 +5127,7 @@
 </p:sld>
 </file>
 
-<file path=ppt/slides/slide4.xml><?xml version="1.0" encoding="utf-8"?>
+<file path=ppt/slides/slide5.xml><?xml version="1.0" encoding="utf-8"?>
 <p:sld xmlns:a="http://schemas.openxmlformats.org/drawingml/2006/main" xmlns:r="http://schemas.openxmlformats.org/officeDocument/2006/relationships" xmlns:p="http://schemas.openxmlformats.org/presentationml/2006/main">
   <p:cSld>
     <p:spTree>

</xml_diff>

<commit_message>
Rename and reorg figures
</commit_message>
<xml_diff>
--- a/figures/figures.pptx
+++ b/figures/figures.pptx
@@ -5,15 +5,17 @@
     <p:sldMasterId id="2147483660" r:id="rId1"/>
   </p:sldMasterIdLst>
   <p:notesMasterIdLst>
-    <p:notesMasterId r:id="rId8"/>
+    <p:notesMasterId r:id="rId10"/>
   </p:notesMasterIdLst>
   <p:sldIdLst>
     <p:sldId id="258" r:id="rId2"/>
     <p:sldId id="256" r:id="rId3"/>
-    <p:sldId id="260" r:id="rId4"/>
-    <p:sldId id="259" r:id="rId5"/>
-    <p:sldId id="261" r:id="rId6"/>
-    <p:sldId id="257" r:id="rId7"/>
+    <p:sldId id="262" r:id="rId4"/>
+    <p:sldId id="263" r:id="rId5"/>
+    <p:sldId id="260" r:id="rId6"/>
+    <p:sldId id="259" r:id="rId7"/>
+    <p:sldId id="261" r:id="rId8"/>
+    <p:sldId id="257" r:id="rId9"/>
   </p:sldIdLst>
   <p:sldSz cx="12192000" cy="6858000"/>
   <p:notesSz cx="6858000" cy="9144000"/>
@@ -123,6 +125,8 @@
         <p14:section name="Chapter 1" id="{4FFEF0E2-5833-4089-8860-99F4B2E194C0}">
           <p14:sldIdLst>
             <p14:sldId id="256"/>
+            <p14:sldId id="262"/>
+            <p14:sldId id="263"/>
             <p14:sldId id="260"/>
             <p14:sldId id="259"/>
           </p14:sldIdLst>
@@ -228,7 +232,7 @@
           <a:p>
             <a:fld id="{DAABB0E5-6D8D-4DEE-B75F-67010CF2307C}" type="datetimeFigureOut">
               <a:rPr lang="en-US" smtClean="0"/>
-              <a:t>2/6/2026</a:t>
+              <a:t>2/12/2026</a:t>
             </a:fld>
             <a:endParaRPr lang="en-US"/>
           </a:p>
@@ -763,7 +767,7 @@
           <a:p>
             <a:fld id="{1D549D2C-39EA-4769-BF7E-31FE52D82078}" type="slidenum">
               <a:rPr lang="en-US" smtClean="0"/>
-              <a:t>4</a:t>
+              <a:t>6</a:t>
             </a:fld>
             <a:endParaRPr lang="en-US"/>
           </a:p>
@@ -913,7 +917,7 @@
           <a:p>
             <a:fld id="{B84C5C40-2055-49AF-9028-5DA79E75E391}" type="datetimeFigureOut">
               <a:rPr lang="en-US" smtClean="0"/>
-              <a:t>2/6/2026</a:t>
+              <a:t>2/12/2026</a:t>
             </a:fld>
             <a:endParaRPr lang="en-US"/>
           </a:p>
@@ -1083,7 +1087,7 @@
           <a:p>
             <a:fld id="{B84C5C40-2055-49AF-9028-5DA79E75E391}" type="datetimeFigureOut">
               <a:rPr lang="en-US" smtClean="0"/>
-              <a:t>2/6/2026</a:t>
+              <a:t>2/12/2026</a:t>
             </a:fld>
             <a:endParaRPr lang="en-US"/>
           </a:p>
@@ -1263,7 +1267,7 @@
           <a:p>
             <a:fld id="{B84C5C40-2055-49AF-9028-5DA79E75E391}" type="datetimeFigureOut">
               <a:rPr lang="en-US" smtClean="0"/>
-              <a:t>2/6/2026</a:t>
+              <a:t>2/12/2026</a:t>
             </a:fld>
             <a:endParaRPr lang="en-US"/>
           </a:p>
@@ -1433,7 +1437,7 @@
           <a:p>
             <a:fld id="{B84C5C40-2055-49AF-9028-5DA79E75E391}" type="datetimeFigureOut">
               <a:rPr lang="en-US" smtClean="0"/>
-              <a:t>2/6/2026</a:t>
+              <a:t>2/12/2026</a:t>
             </a:fld>
             <a:endParaRPr lang="en-US"/>
           </a:p>
@@ -1679,7 +1683,7 @@
           <a:p>
             <a:fld id="{B84C5C40-2055-49AF-9028-5DA79E75E391}" type="datetimeFigureOut">
               <a:rPr lang="en-US" smtClean="0"/>
-              <a:t>2/6/2026</a:t>
+              <a:t>2/12/2026</a:t>
             </a:fld>
             <a:endParaRPr lang="en-US"/>
           </a:p>
@@ -1911,7 +1915,7 @@
           <a:p>
             <a:fld id="{B84C5C40-2055-49AF-9028-5DA79E75E391}" type="datetimeFigureOut">
               <a:rPr lang="en-US" smtClean="0"/>
-              <a:t>2/6/2026</a:t>
+              <a:t>2/12/2026</a:t>
             </a:fld>
             <a:endParaRPr lang="en-US"/>
           </a:p>
@@ -2278,7 +2282,7 @@
           <a:p>
             <a:fld id="{B84C5C40-2055-49AF-9028-5DA79E75E391}" type="datetimeFigureOut">
               <a:rPr lang="en-US" smtClean="0"/>
-              <a:t>2/6/2026</a:t>
+              <a:t>2/12/2026</a:t>
             </a:fld>
             <a:endParaRPr lang="en-US"/>
           </a:p>
@@ -2396,7 +2400,7 @@
           <a:p>
             <a:fld id="{B84C5C40-2055-49AF-9028-5DA79E75E391}" type="datetimeFigureOut">
               <a:rPr lang="en-US" smtClean="0"/>
-              <a:t>2/6/2026</a:t>
+              <a:t>2/12/2026</a:t>
             </a:fld>
             <a:endParaRPr lang="en-US"/>
           </a:p>
@@ -2491,7 +2495,7 @@
           <a:p>
             <a:fld id="{B84C5C40-2055-49AF-9028-5DA79E75E391}" type="datetimeFigureOut">
               <a:rPr lang="en-US" smtClean="0"/>
-              <a:t>2/6/2026</a:t>
+              <a:t>2/12/2026</a:t>
             </a:fld>
             <a:endParaRPr lang="en-US"/>
           </a:p>
@@ -2768,7 +2772,7 @@
           <a:p>
             <a:fld id="{B84C5C40-2055-49AF-9028-5DA79E75E391}" type="datetimeFigureOut">
               <a:rPr lang="en-US" smtClean="0"/>
-              <a:t>2/6/2026</a:t>
+              <a:t>2/12/2026</a:t>
             </a:fld>
             <a:endParaRPr lang="en-US"/>
           </a:p>
@@ -3025,7 +3029,7 @@
           <a:p>
             <a:fld id="{B84C5C40-2055-49AF-9028-5DA79E75E391}" type="datetimeFigureOut">
               <a:rPr lang="en-US" smtClean="0"/>
-              <a:t>2/6/2026</a:t>
+              <a:t>2/12/2026</a:t>
             </a:fld>
             <a:endParaRPr lang="en-US"/>
           </a:p>
@@ -3238,7 +3242,7 @@
           <a:p>
             <a:fld id="{B84C5C40-2055-49AF-9028-5DA79E75E391}" type="datetimeFigureOut">
               <a:rPr lang="en-US" smtClean="0"/>
-              <a:t>2/6/2026</a:t>
+              <a:t>2/12/2026</a:t>
             </a:fld>
             <a:endParaRPr lang="en-US"/>
           </a:p>
@@ -4366,7 +4370,7 @@
           <p:cNvPr id="2" name="Rectangle: Rounded Corners 1">
             <a:extLst>
               <a:ext uri="{FF2B5EF4-FFF2-40B4-BE49-F238E27FC236}">
-                <a16:creationId xmlns:a16="http://schemas.microsoft.com/office/drawing/2014/main" id="{ED732446-F0F6-0ACF-647A-3BC33E7C3D60}"/>
+                <a16:creationId xmlns:a16="http://schemas.microsoft.com/office/drawing/2014/main" id="{B093A9C9-AC19-13DF-070B-47915CA16540}"/>
               </a:ext>
             </a:extLst>
           </p:cNvPr>
@@ -4375,8 +4379,8 @@
         </p:nvSpPr>
         <p:spPr>
           <a:xfrm>
-            <a:off x="962567" y="281940"/>
-            <a:ext cx="10552099" cy="6187439"/>
+            <a:off x="2933281" y="496097"/>
+            <a:ext cx="6325438" cy="974563"/>
           </a:xfrm>
           <a:prstGeom prst="roundRect">
             <a:avLst>
@@ -4409,7 +4413,7 @@
           </a:fontRef>
         </p:style>
         <p:txBody>
-          <a:bodyPr rtlCol="0" anchor="t"/>
+          <a:bodyPr rtlCol="0" anchor="ctr"/>
           <a:lstStyle/>
           <a:p>
             <a:pPr algn="ctr"/>
@@ -4419,7 +4423,7 @@
                   <a:schemeClr val="tx1"/>
                 </a:solidFill>
               </a:rPr>
-              <a:t>Example Models</a:t>
+              <a:t>Retrieval Agents: Query analysis and planning</a:t>
             </a:r>
           </a:p>
         </p:txBody>
@@ -4429,7 +4433,7 @@
           <p:cNvPr id="3" name="Rectangle: Rounded Corners 2">
             <a:extLst>
               <a:ext uri="{FF2B5EF4-FFF2-40B4-BE49-F238E27FC236}">
-                <a16:creationId xmlns:a16="http://schemas.microsoft.com/office/drawing/2014/main" id="{5574ED1F-143F-F0C3-860B-D1D1A94B8038}"/>
+                <a16:creationId xmlns:a16="http://schemas.microsoft.com/office/drawing/2014/main" id="{1872BA75-F1E5-3FE4-8499-99490E2C15B3}"/>
               </a:ext>
             </a:extLst>
           </p:cNvPr>
@@ -4438,379 +4442,11 @@
         </p:nvSpPr>
         <p:spPr>
           <a:xfrm>
-            <a:off x="4778916" y="1188720"/>
-            <a:ext cx="2634168" cy="2335531"/>
+            <a:off x="4805537" y="311431"/>
+            <a:ext cx="2580925" cy="369332"/>
           </a:xfrm>
           <a:prstGeom prst="roundRect">
             <a:avLst/>
-          </a:prstGeom>
-          <a:solidFill>
-            <a:srgbClr val="E5F1F8"/>
-          </a:solidFill>
-          <a:ln>
-            <a:solidFill>
-              <a:schemeClr val="tx1"/>
-            </a:solidFill>
-          </a:ln>
-        </p:spPr>
-        <p:style>
-          <a:lnRef idx="2">
-            <a:schemeClr val="accent1">
-              <a:shade val="15000"/>
-            </a:schemeClr>
-          </a:lnRef>
-          <a:fillRef idx="1">
-            <a:schemeClr val="accent1"/>
-          </a:fillRef>
-          <a:effectRef idx="0">
-            <a:schemeClr val="accent1"/>
-          </a:effectRef>
-          <a:fontRef idx="minor">
-            <a:schemeClr val="lt1"/>
-          </a:fontRef>
-        </p:style>
-        <p:txBody>
-          <a:bodyPr rtlCol="0" anchor="t"/>
-          <a:lstStyle/>
-          <a:p>
-            <a:pPr algn="ctr"/>
-            <a:r>
-              <a:rPr lang="en-US" dirty="0">
-                <a:solidFill>
-                  <a:schemeClr val="tx1"/>
-                </a:solidFill>
-              </a:rPr>
-              <a:t>Anthropic</a:t>
-            </a:r>
-          </a:p>
-        </p:txBody>
-      </p:sp>
-      <p:sp>
-        <p:nvSpPr>
-          <p:cNvPr id="4" name="Rectangle: Rounded Corners 3">
-            <a:extLst>
-              <a:ext uri="{FF2B5EF4-FFF2-40B4-BE49-F238E27FC236}">
-                <a16:creationId xmlns:a16="http://schemas.microsoft.com/office/drawing/2014/main" id="{CB92B3E5-A0FB-4F52-03FE-A3994B4A676E}"/>
-              </a:ext>
-            </a:extLst>
-          </p:cNvPr>
-          <p:cNvSpPr/>
-          <p:nvPr/>
-        </p:nvSpPr>
-        <p:spPr>
-          <a:xfrm>
-            <a:off x="1553658" y="1188720"/>
-            <a:ext cx="2634168" cy="2335531"/>
-          </a:xfrm>
-          <a:prstGeom prst="roundRect">
-            <a:avLst/>
-          </a:prstGeom>
-          <a:solidFill>
-            <a:srgbClr val="E5F1F8"/>
-          </a:solidFill>
-          <a:ln>
-            <a:solidFill>
-              <a:schemeClr val="tx1"/>
-            </a:solidFill>
-          </a:ln>
-        </p:spPr>
-        <p:style>
-          <a:lnRef idx="2">
-            <a:schemeClr val="accent1">
-              <a:shade val="15000"/>
-            </a:schemeClr>
-          </a:lnRef>
-          <a:fillRef idx="1">
-            <a:schemeClr val="accent1"/>
-          </a:fillRef>
-          <a:effectRef idx="0">
-            <a:schemeClr val="accent1"/>
-          </a:effectRef>
-          <a:fontRef idx="minor">
-            <a:schemeClr val="lt1"/>
-          </a:fontRef>
-        </p:style>
-        <p:txBody>
-          <a:bodyPr rtlCol="0" anchor="t"/>
-          <a:lstStyle/>
-          <a:p>
-            <a:pPr algn="ctr"/>
-            <a:r>
-              <a:rPr lang="en-US" dirty="0">
-                <a:solidFill>
-                  <a:schemeClr val="tx1"/>
-                </a:solidFill>
-              </a:rPr>
-              <a:t>Azure OpenAI</a:t>
-            </a:r>
-          </a:p>
-        </p:txBody>
-      </p:sp>
-      <p:sp>
-        <p:nvSpPr>
-          <p:cNvPr id="5" name="Rectangle: Rounded Corners 4">
-            <a:extLst>
-              <a:ext uri="{FF2B5EF4-FFF2-40B4-BE49-F238E27FC236}">
-                <a16:creationId xmlns:a16="http://schemas.microsoft.com/office/drawing/2014/main" id="{ACE8A258-9DE7-F4AF-1449-211286E0D11E}"/>
-              </a:ext>
-            </a:extLst>
-          </p:cNvPr>
-          <p:cNvSpPr/>
-          <p:nvPr/>
-        </p:nvSpPr>
-        <p:spPr>
-          <a:xfrm>
-            <a:off x="8004174" y="1188720"/>
-            <a:ext cx="2634168" cy="2335531"/>
-          </a:xfrm>
-          <a:prstGeom prst="roundRect">
-            <a:avLst/>
-          </a:prstGeom>
-          <a:solidFill>
-            <a:srgbClr val="E5F1F8"/>
-          </a:solidFill>
-          <a:ln>
-            <a:solidFill>
-              <a:schemeClr val="tx1"/>
-            </a:solidFill>
-          </a:ln>
-        </p:spPr>
-        <p:style>
-          <a:lnRef idx="2">
-            <a:schemeClr val="accent1">
-              <a:shade val="15000"/>
-            </a:schemeClr>
-          </a:lnRef>
-          <a:fillRef idx="1">
-            <a:schemeClr val="accent1"/>
-          </a:fillRef>
-          <a:effectRef idx="0">
-            <a:schemeClr val="accent1"/>
-          </a:effectRef>
-          <a:fontRef idx="minor">
-            <a:schemeClr val="lt1"/>
-          </a:fontRef>
-        </p:style>
-        <p:txBody>
-          <a:bodyPr rtlCol="0" anchor="t"/>
-          <a:lstStyle/>
-          <a:p>
-            <a:pPr algn="ctr"/>
-            <a:r>
-              <a:rPr lang="en-US" dirty="0">
-                <a:solidFill>
-                  <a:schemeClr val="tx1"/>
-                </a:solidFill>
-              </a:rPr>
-              <a:t>Microsoft</a:t>
-            </a:r>
-          </a:p>
-        </p:txBody>
-      </p:sp>
-      <p:sp>
-        <p:nvSpPr>
-          <p:cNvPr id="6" name="Rectangle: Rounded Corners 5">
-            <a:extLst>
-              <a:ext uri="{FF2B5EF4-FFF2-40B4-BE49-F238E27FC236}">
-                <a16:creationId xmlns:a16="http://schemas.microsoft.com/office/drawing/2014/main" id="{417ADCD0-E7DE-9B18-898C-7D55B783F694}"/>
-              </a:ext>
-            </a:extLst>
-          </p:cNvPr>
-          <p:cNvSpPr/>
-          <p:nvPr/>
-        </p:nvSpPr>
-        <p:spPr>
-          <a:xfrm>
-            <a:off x="4778916" y="3653789"/>
-            <a:ext cx="2634168" cy="2335531"/>
-          </a:xfrm>
-          <a:prstGeom prst="roundRect">
-            <a:avLst/>
-          </a:prstGeom>
-          <a:solidFill>
-            <a:srgbClr val="E5F1F8"/>
-          </a:solidFill>
-          <a:ln>
-            <a:solidFill>
-              <a:schemeClr val="tx1"/>
-            </a:solidFill>
-          </a:ln>
-        </p:spPr>
-        <p:style>
-          <a:lnRef idx="2">
-            <a:schemeClr val="accent1">
-              <a:shade val="15000"/>
-            </a:schemeClr>
-          </a:lnRef>
-          <a:fillRef idx="1">
-            <a:schemeClr val="accent1"/>
-          </a:fillRef>
-          <a:effectRef idx="0">
-            <a:schemeClr val="accent1"/>
-          </a:effectRef>
-          <a:fontRef idx="minor">
-            <a:schemeClr val="lt1"/>
-          </a:fontRef>
-        </p:style>
-        <p:txBody>
-          <a:bodyPr rtlCol="0" anchor="t"/>
-          <a:lstStyle/>
-          <a:p>
-            <a:pPr algn="ctr"/>
-            <a:r>
-              <a:rPr lang="en-US" dirty="0">
-                <a:solidFill>
-                  <a:schemeClr val="tx1"/>
-                </a:solidFill>
-              </a:rPr>
-              <a:t>Mistral AI</a:t>
-            </a:r>
-          </a:p>
-        </p:txBody>
-      </p:sp>
-      <p:sp>
-        <p:nvSpPr>
-          <p:cNvPr id="7" name="Rectangle: Rounded Corners 6">
-            <a:extLst>
-              <a:ext uri="{FF2B5EF4-FFF2-40B4-BE49-F238E27FC236}">
-                <a16:creationId xmlns:a16="http://schemas.microsoft.com/office/drawing/2014/main" id="{A55125DD-7A11-66B1-DDF5-ECD5D6C1F69B}"/>
-              </a:ext>
-            </a:extLst>
-          </p:cNvPr>
-          <p:cNvSpPr/>
-          <p:nvPr/>
-        </p:nvSpPr>
-        <p:spPr>
-          <a:xfrm>
-            <a:off x="1553658" y="3653789"/>
-            <a:ext cx="2634168" cy="2335531"/>
-          </a:xfrm>
-          <a:prstGeom prst="roundRect">
-            <a:avLst/>
-          </a:prstGeom>
-          <a:solidFill>
-            <a:srgbClr val="E5F1F8"/>
-          </a:solidFill>
-          <a:ln>
-            <a:solidFill>
-              <a:schemeClr val="tx1"/>
-            </a:solidFill>
-          </a:ln>
-        </p:spPr>
-        <p:style>
-          <a:lnRef idx="2">
-            <a:schemeClr val="accent1">
-              <a:shade val="15000"/>
-            </a:schemeClr>
-          </a:lnRef>
-          <a:fillRef idx="1">
-            <a:schemeClr val="accent1"/>
-          </a:fillRef>
-          <a:effectRef idx="0">
-            <a:schemeClr val="accent1"/>
-          </a:effectRef>
-          <a:fontRef idx="minor">
-            <a:schemeClr val="lt1"/>
-          </a:fontRef>
-        </p:style>
-        <p:txBody>
-          <a:bodyPr rtlCol="0" anchor="t"/>
-          <a:lstStyle/>
-          <a:p>
-            <a:pPr algn="ctr"/>
-            <a:r>
-              <a:rPr lang="en-US" dirty="0">
-                <a:solidFill>
-                  <a:schemeClr val="tx1"/>
-                </a:solidFill>
-              </a:rPr>
-              <a:t>Meta</a:t>
-            </a:r>
-          </a:p>
-        </p:txBody>
-      </p:sp>
-      <p:sp>
-        <p:nvSpPr>
-          <p:cNvPr id="8" name="Rectangle: Rounded Corners 7">
-            <a:extLst>
-              <a:ext uri="{FF2B5EF4-FFF2-40B4-BE49-F238E27FC236}">
-                <a16:creationId xmlns:a16="http://schemas.microsoft.com/office/drawing/2014/main" id="{4D8433B6-E222-52DE-3420-6BC81E4D9945}"/>
-              </a:ext>
-            </a:extLst>
-          </p:cNvPr>
-          <p:cNvSpPr/>
-          <p:nvPr/>
-        </p:nvSpPr>
-        <p:spPr>
-          <a:xfrm>
-            <a:off x="8004174" y="3653789"/>
-            <a:ext cx="2634168" cy="2335531"/>
-          </a:xfrm>
-          <a:prstGeom prst="roundRect">
-            <a:avLst/>
-          </a:prstGeom>
-          <a:solidFill>
-            <a:srgbClr val="E5F1F8"/>
-          </a:solidFill>
-          <a:ln>
-            <a:solidFill>
-              <a:schemeClr val="tx1"/>
-            </a:solidFill>
-          </a:ln>
-        </p:spPr>
-        <p:style>
-          <a:lnRef idx="2">
-            <a:schemeClr val="accent1">
-              <a:shade val="15000"/>
-            </a:schemeClr>
-          </a:lnRef>
-          <a:fillRef idx="1">
-            <a:schemeClr val="accent1"/>
-          </a:fillRef>
-          <a:effectRef idx="0">
-            <a:schemeClr val="accent1"/>
-          </a:effectRef>
-          <a:fontRef idx="minor">
-            <a:schemeClr val="lt1"/>
-          </a:fontRef>
-        </p:style>
-        <p:txBody>
-          <a:bodyPr rtlCol="0" anchor="t"/>
-          <a:lstStyle/>
-          <a:p>
-            <a:pPr algn="ctr"/>
-            <a:r>
-              <a:rPr lang="en-US" dirty="0">
-                <a:solidFill>
-                  <a:schemeClr val="tx1"/>
-                </a:solidFill>
-              </a:rPr>
-              <a:t>DeepSeek</a:t>
-            </a:r>
-          </a:p>
-        </p:txBody>
-      </p:sp>
-      <p:sp>
-        <p:nvSpPr>
-          <p:cNvPr id="10" name="Rectangle: Rounded Corners 9">
-            <a:extLst>
-              <a:ext uri="{FF2B5EF4-FFF2-40B4-BE49-F238E27FC236}">
-                <a16:creationId xmlns:a16="http://schemas.microsoft.com/office/drawing/2014/main" id="{02E5EA1C-587E-4A45-E606-F67DF515B407}"/>
-              </a:ext>
-            </a:extLst>
-          </p:cNvPr>
-          <p:cNvSpPr/>
-          <p:nvPr/>
-        </p:nvSpPr>
-        <p:spPr>
-          <a:xfrm>
-            <a:off x="1790700" y="1882140"/>
-            <a:ext cx="2111892" cy="322508"/>
-          </a:xfrm>
-          <a:prstGeom prst="roundRect">
-            <a:avLst>
-              <a:gd name="adj" fmla="val 50000"/>
-            </a:avLst>
           </a:prstGeom>
           <a:solidFill>
             <a:srgbClr val="B2D4EB"/>
@@ -4843,12 +4479,12 @@
           <a:p>
             <a:pPr algn="ctr"/>
             <a:r>
-              <a:rPr lang="en-US" dirty="0" err="1">
+              <a:rPr lang="en-US" dirty="0">
                 <a:solidFill>
                   <a:schemeClr val="tx1"/>
                 </a:solidFill>
               </a:rPr>
-              <a:t>gpt</a:t>
+              <a:t>Agent Layer</a:t>
             </a:r>
             <a:endParaRPr lang="en-US" i="1" dirty="0">
               <a:solidFill>
@@ -4860,10 +4496,10 @@
       </p:sp>
       <p:sp>
         <p:nvSpPr>
-          <p:cNvPr id="11" name="Rectangle: Rounded Corners 10">
+          <p:cNvPr id="5" name="Rectangle: Rounded Corners 4">
             <a:extLst>
               <a:ext uri="{FF2B5EF4-FFF2-40B4-BE49-F238E27FC236}">
-                <a16:creationId xmlns:a16="http://schemas.microsoft.com/office/drawing/2014/main" id="{E11D9861-1EDA-793B-0AA0-18BFA52ACCE4}"/>
+                <a16:creationId xmlns:a16="http://schemas.microsoft.com/office/drawing/2014/main" id="{3854ADE8-F06B-9F26-91C2-3A9892E48DAE}"/>
               </a:ext>
             </a:extLst>
           </p:cNvPr>
@@ -4872,13 +4508,71 @@
         </p:nvSpPr>
         <p:spPr>
           <a:xfrm>
-            <a:off x="1790700" y="2380687"/>
-            <a:ext cx="2111892" cy="322508"/>
+            <a:off x="2933281" y="1839992"/>
+            <a:ext cx="6325438" cy="974563"/>
           </a:xfrm>
           <a:prstGeom prst="roundRect">
             <a:avLst>
-              <a:gd name="adj" fmla="val 50000"/>
+              <a:gd name="adj" fmla="val 5234"/>
             </a:avLst>
+          </a:prstGeom>
+          <a:solidFill>
+            <a:schemeClr val="bg1"/>
+          </a:solidFill>
+          <a:ln>
+            <a:solidFill>
+              <a:schemeClr val="tx1"/>
+            </a:solidFill>
+          </a:ln>
+        </p:spPr>
+        <p:style>
+          <a:lnRef idx="2">
+            <a:schemeClr val="accent1">
+              <a:shade val="15000"/>
+            </a:schemeClr>
+          </a:lnRef>
+          <a:fillRef idx="1">
+            <a:schemeClr val="accent1"/>
+          </a:fillRef>
+          <a:effectRef idx="0">
+            <a:schemeClr val="accent1"/>
+          </a:effectRef>
+          <a:fontRef idx="minor">
+            <a:schemeClr val="lt1"/>
+          </a:fontRef>
+        </p:style>
+        <p:txBody>
+          <a:bodyPr rtlCol="0" anchor="ctr"/>
+          <a:lstStyle/>
+          <a:p>
+            <a:pPr algn="ctr"/>
+            <a:endParaRPr lang="en-US" dirty="0">
+              <a:solidFill>
+                <a:schemeClr val="tx1"/>
+              </a:solidFill>
+            </a:endParaRPr>
+          </a:p>
+        </p:txBody>
+      </p:sp>
+      <p:sp>
+        <p:nvSpPr>
+          <p:cNvPr id="6" name="Rectangle: Rounded Corners 5">
+            <a:extLst>
+              <a:ext uri="{FF2B5EF4-FFF2-40B4-BE49-F238E27FC236}">
+                <a16:creationId xmlns:a16="http://schemas.microsoft.com/office/drawing/2014/main" id="{0CD6471B-9868-9E31-CDE5-11FB5406EC6D}"/>
+              </a:ext>
+            </a:extLst>
+          </p:cNvPr>
+          <p:cNvSpPr/>
+          <p:nvPr/>
+        </p:nvSpPr>
+        <p:spPr>
+          <a:xfrm>
+            <a:off x="4805537" y="1655326"/>
+            <a:ext cx="2580925" cy="369332"/>
+          </a:xfrm>
+          <a:prstGeom prst="roundRect">
+            <a:avLst/>
           </a:prstGeom>
           <a:solidFill>
             <a:srgbClr val="B2D4EB"/>
@@ -4916,17 +4610,22 @@
                   <a:schemeClr val="tx1"/>
                 </a:solidFill>
               </a:rPr>
-              <a:t>o</a:t>
-            </a:r>
-          </a:p>
-        </p:txBody>
-      </p:sp>
-      <p:sp>
-        <p:nvSpPr>
-          <p:cNvPr id="12" name="Rectangle: Rounded Corners 11">
+              <a:t>Router Layer</a:t>
+            </a:r>
+            <a:endParaRPr lang="en-US" i="1" dirty="0">
+              <a:solidFill>
+                <a:schemeClr val="tx1"/>
+              </a:solidFill>
+            </a:endParaRPr>
+          </a:p>
+        </p:txBody>
+      </p:sp>
+      <p:sp>
+        <p:nvSpPr>
+          <p:cNvPr id="7" name="Rectangle: Rounded Corners 6">
             <a:extLst>
               <a:ext uri="{FF2B5EF4-FFF2-40B4-BE49-F238E27FC236}">
-                <a16:creationId xmlns:a16="http://schemas.microsoft.com/office/drawing/2014/main" id="{46BFDC7A-CED3-C375-66E6-683B9E52EDD1}"/>
+                <a16:creationId xmlns:a16="http://schemas.microsoft.com/office/drawing/2014/main" id="{FEBB63F4-ED09-21FE-8751-04E01AFF0D06}"/>
               </a:ext>
             </a:extLst>
           </p:cNvPr>
@@ -4935,13 +4634,71 @@
         </p:nvSpPr>
         <p:spPr>
           <a:xfrm>
-            <a:off x="1790700" y="2879234"/>
-            <a:ext cx="2111892" cy="322508"/>
+            <a:off x="2933281" y="3183887"/>
+            <a:ext cx="6325438" cy="974563"/>
           </a:xfrm>
           <a:prstGeom prst="roundRect">
             <a:avLst>
-              <a:gd name="adj" fmla="val 50000"/>
+              <a:gd name="adj" fmla="val 5234"/>
             </a:avLst>
+          </a:prstGeom>
+          <a:solidFill>
+            <a:schemeClr val="bg1"/>
+          </a:solidFill>
+          <a:ln>
+            <a:solidFill>
+              <a:schemeClr val="tx1"/>
+            </a:solidFill>
+          </a:ln>
+        </p:spPr>
+        <p:style>
+          <a:lnRef idx="2">
+            <a:schemeClr val="accent1">
+              <a:shade val="15000"/>
+            </a:schemeClr>
+          </a:lnRef>
+          <a:fillRef idx="1">
+            <a:schemeClr val="accent1"/>
+          </a:fillRef>
+          <a:effectRef idx="0">
+            <a:schemeClr val="accent1"/>
+          </a:effectRef>
+          <a:fontRef idx="minor">
+            <a:schemeClr val="lt1"/>
+          </a:fontRef>
+        </p:style>
+        <p:txBody>
+          <a:bodyPr rtlCol="0" anchor="ctr"/>
+          <a:lstStyle/>
+          <a:p>
+            <a:pPr algn="ctr"/>
+            <a:endParaRPr lang="en-US" dirty="0">
+              <a:solidFill>
+                <a:schemeClr val="tx1"/>
+              </a:solidFill>
+            </a:endParaRPr>
+          </a:p>
+        </p:txBody>
+      </p:sp>
+      <p:sp>
+        <p:nvSpPr>
+          <p:cNvPr id="8" name="Rectangle: Rounded Corners 7">
+            <a:extLst>
+              <a:ext uri="{FF2B5EF4-FFF2-40B4-BE49-F238E27FC236}">
+                <a16:creationId xmlns:a16="http://schemas.microsoft.com/office/drawing/2014/main" id="{64887E38-DD48-A03C-B28D-2E196FFD81D6}"/>
+              </a:ext>
+            </a:extLst>
+          </p:cNvPr>
+          <p:cNvSpPr/>
+          <p:nvPr/>
+        </p:nvSpPr>
+        <p:spPr>
+          <a:xfrm>
+            <a:off x="4805537" y="2999221"/>
+            <a:ext cx="2580925" cy="369332"/>
+          </a:xfrm>
+          <a:prstGeom prst="roundRect">
+            <a:avLst/>
           </a:prstGeom>
           <a:solidFill>
             <a:srgbClr val="B2D4EB"/>
@@ -4979,15 +4736,797 @@
                   <a:schemeClr val="tx1"/>
                 </a:solidFill>
               </a:rPr>
-              <a:t>sora</a:t>
-            </a:r>
-          </a:p>
-        </p:txBody>
-      </p:sp>
+              <a:t>Tool Layer</a:t>
+            </a:r>
+            <a:endParaRPr lang="en-US" i="1" dirty="0">
+              <a:solidFill>
+                <a:schemeClr val="tx1"/>
+              </a:solidFill>
+            </a:endParaRPr>
+          </a:p>
+        </p:txBody>
+      </p:sp>
+      <p:sp>
+        <p:nvSpPr>
+          <p:cNvPr id="9" name="Rectangle: Rounded Corners 8">
+            <a:extLst>
+              <a:ext uri="{FF2B5EF4-FFF2-40B4-BE49-F238E27FC236}">
+                <a16:creationId xmlns:a16="http://schemas.microsoft.com/office/drawing/2014/main" id="{61179975-6D14-9A73-F6AF-EB48BB4B01D5}"/>
+              </a:ext>
+            </a:extLst>
+          </p:cNvPr>
+          <p:cNvSpPr/>
+          <p:nvPr/>
+        </p:nvSpPr>
+        <p:spPr>
+          <a:xfrm>
+            <a:off x="2933281" y="4527782"/>
+            <a:ext cx="6325438" cy="974563"/>
+          </a:xfrm>
+          <a:prstGeom prst="roundRect">
+            <a:avLst>
+              <a:gd name="adj" fmla="val 5234"/>
+            </a:avLst>
+          </a:prstGeom>
+          <a:solidFill>
+            <a:schemeClr val="bg1"/>
+          </a:solidFill>
+          <a:ln>
+            <a:solidFill>
+              <a:schemeClr val="tx1"/>
+            </a:solidFill>
+          </a:ln>
+        </p:spPr>
+        <p:style>
+          <a:lnRef idx="2">
+            <a:schemeClr val="accent1">
+              <a:shade val="15000"/>
+            </a:schemeClr>
+          </a:lnRef>
+          <a:fillRef idx="1">
+            <a:schemeClr val="accent1"/>
+          </a:fillRef>
+          <a:effectRef idx="0">
+            <a:schemeClr val="accent1"/>
+          </a:effectRef>
+          <a:fontRef idx="minor">
+            <a:schemeClr val="lt1"/>
+          </a:fontRef>
+        </p:style>
+        <p:txBody>
+          <a:bodyPr rtlCol="0" anchor="ctr"/>
+          <a:lstStyle/>
+          <a:p>
+            <a:pPr algn="ctr"/>
+            <a:endParaRPr lang="en-US" dirty="0">
+              <a:solidFill>
+                <a:schemeClr val="tx1"/>
+              </a:solidFill>
+            </a:endParaRPr>
+          </a:p>
+        </p:txBody>
+      </p:sp>
+      <p:sp>
+        <p:nvSpPr>
+          <p:cNvPr id="10" name="Rectangle: Rounded Corners 9">
+            <a:extLst>
+              <a:ext uri="{FF2B5EF4-FFF2-40B4-BE49-F238E27FC236}">
+                <a16:creationId xmlns:a16="http://schemas.microsoft.com/office/drawing/2014/main" id="{A87A8A04-A0EB-0635-5D50-4C591A01FD85}"/>
+              </a:ext>
+            </a:extLst>
+          </p:cNvPr>
+          <p:cNvSpPr/>
+          <p:nvPr/>
+        </p:nvSpPr>
+        <p:spPr>
+          <a:xfrm>
+            <a:off x="4805537" y="4343116"/>
+            <a:ext cx="2580925" cy="369332"/>
+          </a:xfrm>
+          <a:prstGeom prst="roundRect">
+            <a:avLst/>
+          </a:prstGeom>
+          <a:solidFill>
+            <a:srgbClr val="B2D4EB"/>
+          </a:solidFill>
+          <a:ln>
+            <a:solidFill>
+              <a:schemeClr val="tx1"/>
+            </a:solidFill>
+          </a:ln>
+        </p:spPr>
+        <p:style>
+          <a:lnRef idx="2">
+            <a:schemeClr val="accent1">
+              <a:shade val="15000"/>
+            </a:schemeClr>
+          </a:lnRef>
+          <a:fillRef idx="1">
+            <a:schemeClr val="accent1"/>
+          </a:fillRef>
+          <a:effectRef idx="0">
+            <a:schemeClr val="accent1"/>
+          </a:effectRef>
+          <a:fontRef idx="minor">
+            <a:schemeClr val="lt1"/>
+          </a:fontRef>
+        </p:style>
+        <p:txBody>
+          <a:bodyPr rtlCol="0" anchor="ctr"/>
+          <a:lstStyle/>
+          <a:p>
+            <a:pPr algn="ctr"/>
+            <a:r>
+              <a:rPr lang="en-US" dirty="0">
+                <a:solidFill>
+                  <a:schemeClr val="tx1"/>
+                </a:solidFill>
+              </a:rPr>
+              <a:t>Results Layer</a:t>
+            </a:r>
+            <a:endParaRPr lang="en-US" i="1" dirty="0">
+              <a:solidFill>
+                <a:schemeClr val="tx1"/>
+              </a:solidFill>
+            </a:endParaRPr>
+          </a:p>
+        </p:txBody>
+      </p:sp>
+      <p:sp>
+        <p:nvSpPr>
+          <p:cNvPr id="11" name="Rectangle: Rounded Corners 10">
+            <a:extLst>
+              <a:ext uri="{FF2B5EF4-FFF2-40B4-BE49-F238E27FC236}">
+                <a16:creationId xmlns:a16="http://schemas.microsoft.com/office/drawing/2014/main" id="{F5DF5948-C971-4B39-A3BE-2153A8EEA636}"/>
+              </a:ext>
+            </a:extLst>
+          </p:cNvPr>
+          <p:cNvSpPr/>
+          <p:nvPr/>
+        </p:nvSpPr>
+        <p:spPr>
+          <a:xfrm>
+            <a:off x="2933281" y="5687011"/>
+            <a:ext cx="6325438" cy="369332"/>
+          </a:xfrm>
+          <a:prstGeom prst="roundRect">
+            <a:avLst/>
+          </a:prstGeom>
+          <a:solidFill>
+            <a:srgbClr val="B2D4EB"/>
+          </a:solidFill>
+          <a:ln>
+            <a:solidFill>
+              <a:schemeClr val="tx1"/>
+            </a:solidFill>
+          </a:ln>
+        </p:spPr>
+        <p:style>
+          <a:lnRef idx="2">
+            <a:schemeClr val="accent1">
+              <a:shade val="15000"/>
+            </a:schemeClr>
+          </a:lnRef>
+          <a:fillRef idx="1">
+            <a:schemeClr val="accent1"/>
+          </a:fillRef>
+          <a:effectRef idx="0">
+            <a:schemeClr val="accent1"/>
+          </a:effectRef>
+          <a:fontRef idx="minor">
+            <a:schemeClr val="lt1"/>
+          </a:fontRef>
+        </p:style>
+        <p:txBody>
+          <a:bodyPr rtlCol="0" anchor="ctr"/>
+          <a:lstStyle/>
+          <a:p>
+            <a:pPr algn="ctr"/>
+            <a:r>
+              <a:rPr lang="en-US" dirty="0">
+                <a:solidFill>
+                  <a:schemeClr val="tx1"/>
+                </a:solidFill>
+              </a:rPr>
+              <a:t>LLM Integration: Response Synthesis and Answering</a:t>
+            </a:r>
+            <a:endParaRPr lang="en-US" i="1" dirty="0">
+              <a:solidFill>
+                <a:schemeClr val="tx1"/>
+              </a:solidFill>
+            </a:endParaRPr>
+          </a:p>
+        </p:txBody>
+      </p:sp>
+      <p:graphicFrame>
+        <p:nvGraphicFramePr>
+          <p:cNvPr id="12" name="Table 11">
+            <a:extLst>
+              <a:ext uri="{FF2B5EF4-FFF2-40B4-BE49-F238E27FC236}">
+                <a16:creationId xmlns:a16="http://schemas.microsoft.com/office/drawing/2014/main" id="{488841C4-B7C7-9477-522B-816A130D4639}"/>
+              </a:ext>
+            </a:extLst>
+          </p:cNvPr>
+          <p:cNvGraphicFramePr>
+            <a:graphicFrameLocks noGrp="1"/>
+          </p:cNvGraphicFramePr>
+          <p:nvPr>
+            <p:extLst>
+              <p:ext uri="{D42A27DB-BD31-4B8C-83A1-F6EECF244321}">
+                <p14:modId xmlns:p14="http://schemas.microsoft.com/office/powerpoint/2010/main" val="1502256614"/>
+              </p:ext>
+            </p:extLst>
+          </p:nvPr>
+        </p:nvGraphicFramePr>
+        <p:xfrm>
+          <a:off x="3122928" y="2099566"/>
+          <a:ext cx="5946141" cy="640080"/>
+        </p:xfrm>
+        <a:graphic>
+          <a:graphicData uri="http://schemas.openxmlformats.org/drawingml/2006/table">
+            <a:tbl>
+              <a:tblPr firstRow="1" bandRow="1">
+                <a:tableStyleId>{5C22544A-7EE6-4342-B048-85BDC9FD1C3A}</a:tableStyleId>
+              </a:tblPr>
+              <a:tblGrid>
+                <a:gridCol w="1982047">
+                  <a:extLst>
+                    <a:ext uri="{9D8B030D-6E8A-4147-A177-3AD203B41FA5}">
+                      <a16:colId xmlns:a16="http://schemas.microsoft.com/office/drawing/2014/main" val="3167127258"/>
+                    </a:ext>
+                  </a:extLst>
+                </a:gridCol>
+                <a:gridCol w="1982047">
+                  <a:extLst>
+                    <a:ext uri="{9D8B030D-6E8A-4147-A177-3AD203B41FA5}">
+                      <a16:colId xmlns:a16="http://schemas.microsoft.com/office/drawing/2014/main" val="1913894467"/>
+                    </a:ext>
+                  </a:extLst>
+                </a:gridCol>
+                <a:gridCol w="1982047">
+                  <a:extLst>
+                    <a:ext uri="{9D8B030D-6E8A-4147-A177-3AD203B41FA5}">
+                      <a16:colId xmlns:a16="http://schemas.microsoft.com/office/drawing/2014/main" val="304178738"/>
+                    </a:ext>
+                  </a:extLst>
+                </a:gridCol>
+              </a:tblGrid>
+              <a:tr h="370840">
+                <a:tc>
+                  <a:txBody>
+                    <a:bodyPr/>
+                    <a:lstStyle/>
+                    <a:p>
+                      <a:pPr algn="ctr"/>
+                      <a:r>
+                        <a:rPr lang="en-US" dirty="0">
+                          <a:solidFill>
+                            <a:sysClr val="windowText" lastClr="000000"/>
+                          </a:solidFill>
+                        </a:rPr>
+                        <a:t>SQL DB:</a:t>
+                      </a:r>
+                    </a:p>
+                    <a:p>
+                      <a:pPr algn="ctr"/>
+                      <a:r>
+                        <a:rPr lang="en-US" b="0" dirty="0">
+                          <a:solidFill>
+                            <a:sysClr val="windowText" lastClr="000000"/>
+                          </a:solidFill>
+                        </a:rPr>
+                        <a:t>Patient Data</a:t>
+                      </a:r>
+                    </a:p>
+                  </a:txBody>
+                  <a:tcPr anchor="ctr">
+                    <a:lnL w="12700" cmpd="sng">
+                      <a:noFill/>
+                    </a:lnL>
+                    <a:lnR w="12700" cmpd="sng">
+                      <a:noFill/>
+                    </a:lnR>
+                    <a:lnT w="12700" cmpd="sng">
+                      <a:noFill/>
+                    </a:lnT>
+                    <a:lnB w="38100" cmpd="sng">
+                      <a:noFill/>
+                    </a:lnB>
+                    <a:lnTlToBr w="12700" cmpd="sng">
+                      <a:noFill/>
+                      <a:prstDash val="solid"/>
+                    </a:lnTlToBr>
+                    <a:lnBlToTr w="12700" cmpd="sng">
+                      <a:noFill/>
+                      <a:prstDash val="solid"/>
+                    </a:lnBlToTr>
+                    <a:noFill/>
+                  </a:tcPr>
+                </a:tc>
+                <a:tc>
+                  <a:txBody>
+                    <a:bodyPr/>
+                    <a:lstStyle/>
+                    <a:p>
+                      <a:pPr algn="ctr"/>
+                      <a:r>
+                        <a:rPr lang="en-US" dirty="0">
+                          <a:solidFill>
+                            <a:sysClr val="windowText" lastClr="000000"/>
+                          </a:solidFill>
+                        </a:rPr>
+                        <a:t>Vector DB:</a:t>
+                      </a:r>
+                    </a:p>
+                    <a:p>
+                      <a:pPr algn="ctr"/>
+                      <a:r>
+                        <a:rPr lang="en-US" b="0" dirty="0">
+                          <a:solidFill>
+                            <a:sysClr val="windowText" lastClr="000000"/>
+                          </a:solidFill>
+                        </a:rPr>
+                        <a:t>JSON Data</a:t>
+                      </a:r>
+                    </a:p>
+                  </a:txBody>
+                  <a:tcPr anchor="ctr">
+                    <a:lnL w="12700" cmpd="sng">
+                      <a:noFill/>
+                    </a:lnL>
+                    <a:lnR w="12700" cmpd="sng">
+                      <a:noFill/>
+                    </a:lnR>
+                    <a:lnT w="12700" cmpd="sng">
+                      <a:noFill/>
+                    </a:lnT>
+                    <a:lnB w="38100" cmpd="sng">
+                      <a:noFill/>
+                    </a:lnB>
+                    <a:lnTlToBr w="12700" cmpd="sng">
+                      <a:noFill/>
+                      <a:prstDash val="solid"/>
+                    </a:lnTlToBr>
+                    <a:lnBlToTr w="12700" cmpd="sng">
+                      <a:noFill/>
+                      <a:prstDash val="solid"/>
+                    </a:lnBlToTr>
+                    <a:noFill/>
+                  </a:tcPr>
+                </a:tc>
+                <a:tc>
+                  <a:txBody>
+                    <a:bodyPr/>
+                    <a:lstStyle/>
+                    <a:p>
+                      <a:pPr algn="ctr"/>
+                      <a:r>
+                        <a:rPr lang="en-US" dirty="0">
+                          <a:solidFill>
+                            <a:sysClr val="windowText" lastClr="000000"/>
+                          </a:solidFill>
+                        </a:rPr>
+                        <a:t>Web Search:</a:t>
+                      </a:r>
+                    </a:p>
+                    <a:p>
+                      <a:pPr algn="ctr"/>
+                      <a:r>
+                        <a:rPr lang="en-US" b="0" dirty="0">
+                          <a:solidFill>
+                            <a:sysClr val="windowText" lastClr="000000"/>
+                          </a:solidFill>
+                        </a:rPr>
+                        <a:t>Latest Data</a:t>
+                      </a:r>
+                    </a:p>
+                  </a:txBody>
+                  <a:tcPr anchor="ctr">
+                    <a:lnL w="12700" cmpd="sng">
+                      <a:noFill/>
+                    </a:lnL>
+                    <a:lnR w="12700" cmpd="sng">
+                      <a:noFill/>
+                    </a:lnR>
+                    <a:lnT w="12700" cmpd="sng">
+                      <a:noFill/>
+                    </a:lnT>
+                    <a:lnB w="38100" cmpd="sng">
+                      <a:noFill/>
+                    </a:lnB>
+                    <a:lnTlToBr w="12700" cmpd="sng">
+                      <a:noFill/>
+                      <a:prstDash val="solid"/>
+                    </a:lnTlToBr>
+                    <a:lnBlToTr w="12700" cmpd="sng">
+                      <a:noFill/>
+                      <a:prstDash val="solid"/>
+                    </a:lnBlToTr>
+                    <a:noFill/>
+                  </a:tcPr>
+                </a:tc>
+                <a:extLst>
+                  <a:ext uri="{0D108BD9-81ED-4DB2-BD59-A6C34878D82A}">
+                    <a16:rowId xmlns:a16="http://schemas.microsoft.com/office/drawing/2014/main" val="2068122310"/>
+                  </a:ext>
+                </a:extLst>
+              </a:tr>
+            </a:tbl>
+          </a:graphicData>
+        </a:graphic>
+      </p:graphicFrame>
+      <p:graphicFrame>
+        <p:nvGraphicFramePr>
+          <p:cNvPr id="13" name="Table 12">
+            <a:extLst>
+              <a:ext uri="{FF2B5EF4-FFF2-40B4-BE49-F238E27FC236}">
+                <a16:creationId xmlns:a16="http://schemas.microsoft.com/office/drawing/2014/main" id="{F7701C1B-CC03-0FF1-A238-E5DE6E423CF0}"/>
+              </a:ext>
+            </a:extLst>
+          </p:cNvPr>
+          <p:cNvGraphicFramePr>
+            <a:graphicFrameLocks noGrp="1"/>
+          </p:cNvGraphicFramePr>
+          <p:nvPr>
+            <p:extLst>
+              <p:ext uri="{D42A27DB-BD31-4B8C-83A1-F6EECF244321}">
+                <p14:modId xmlns:p14="http://schemas.microsoft.com/office/powerpoint/2010/main" val="2692346733"/>
+              </p:ext>
+            </p:extLst>
+          </p:nvPr>
+        </p:nvGraphicFramePr>
+        <p:xfrm>
+          <a:off x="3122927" y="3552465"/>
+          <a:ext cx="5946141" cy="370840"/>
+        </p:xfrm>
+        <a:graphic>
+          <a:graphicData uri="http://schemas.openxmlformats.org/drawingml/2006/table">
+            <a:tbl>
+              <a:tblPr firstRow="1" bandRow="1">
+                <a:tableStyleId>{5C22544A-7EE6-4342-B048-85BDC9FD1C3A}</a:tableStyleId>
+              </a:tblPr>
+              <a:tblGrid>
+                <a:gridCol w="1982047">
+                  <a:extLst>
+                    <a:ext uri="{9D8B030D-6E8A-4147-A177-3AD203B41FA5}">
+                      <a16:colId xmlns:a16="http://schemas.microsoft.com/office/drawing/2014/main" val="3167127258"/>
+                    </a:ext>
+                  </a:extLst>
+                </a:gridCol>
+                <a:gridCol w="1982047">
+                  <a:extLst>
+                    <a:ext uri="{9D8B030D-6E8A-4147-A177-3AD203B41FA5}">
+                      <a16:colId xmlns:a16="http://schemas.microsoft.com/office/drawing/2014/main" val="1913894467"/>
+                    </a:ext>
+                  </a:extLst>
+                </a:gridCol>
+                <a:gridCol w="1982047">
+                  <a:extLst>
+                    <a:ext uri="{9D8B030D-6E8A-4147-A177-3AD203B41FA5}">
+                      <a16:colId xmlns:a16="http://schemas.microsoft.com/office/drawing/2014/main" val="304178738"/>
+                    </a:ext>
+                  </a:extLst>
+                </a:gridCol>
+              </a:tblGrid>
+              <a:tr h="370840">
+                <a:tc>
+                  <a:txBody>
+                    <a:bodyPr/>
+                    <a:lstStyle/>
+                    <a:p>
+                      <a:pPr algn="ctr"/>
+                      <a:r>
+                        <a:rPr lang="en-US" b="0" dirty="0">
+                          <a:solidFill>
+                            <a:sysClr val="windowText" lastClr="000000"/>
+                          </a:solidFill>
+                        </a:rPr>
+                        <a:t>SQL DB Tool</a:t>
+                      </a:r>
+                    </a:p>
+                  </a:txBody>
+                  <a:tcPr anchor="ctr">
+                    <a:lnL w="12700" cmpd="sng">
+                      <a:noFill/>
+                    </a:lnL>
+                    <a:lnR w="12700" cmpd="sng">
+                      <a:noFill/>
+                    </a:lnR>
+                    <a:lnT w="12700" cmpd="sng">
+                      <a:noFill/>
+                    </a:lnT>
+                    <a:lnB w="38100" cmpd="sng">
+                      <a:noFill/>
+                    </a:lnB>
+                    <a:lnTlToBr w="12700" cmpd="sng">
+                      <a:noFill/>
+                      <a:prstDash val="solid"/>
+                    </a:lnTlToBr>
+                    <a:lnBlToTr w="12700" cmpd="sng">
+                      <a:noFill/>
+                      <a:prstDash val="solid"/>
+                    </a:lnBlToTr>
+                    <a:noFill/>
+                  </a:tcPr>
+                </a:tc>
+                <a:tc>
+                  <a:txBody>
+                    <a:bodyPr/>
+                    <a:lstStyle/>
+                    <a:p>
+                      <a:pPr algn="ctr"/>
+                      <a:r>
+                        <a:rPr lang="en-US" b="0" dirty="0">
+                          <a:solidFill>
+                            <a:sysClr val="windowText" lastClr="000000"/>
+                          </a:solidFill>
+                        </a:rPr>
+                        <a:t>Cosmos DB Tool</a:t>
+                      </a:r>
+                    </a:p>
+                  </a:txBody>
+                  <a:tcPr anchor="ctr">
+                    <a:lnL w="12700" cmpd="sng">
+                      <a:noFill/>
+                    </a:lnL>
+                    <a:lnR w="12700" cmpd="sng">
+                      <a:noFill/>
+                    </a:lnR>
+                    <a:lnT w="12700" cmpd="sng">
+                      <a:noFill/>
+                    </a:lnT>
+                    <a:lnB w="38100" cmpd="sng">
+                      <a:noFill/>
+                    </a:lnB>
+                    <a:lnTlToBr w="12700" cmpd="sng">
+                      <a:noFill/>
+                      <a:prstDash val="solid"/>
+                    </a:lnTlToBr>
+                    <a:lnBlToTr w="12700" cmpd="sng">
+                      <a:noFill/>
+                      <a:prstDash val="solid"/>
+                    </a:lnBlToTr>
+                    <a:noFill/>
+                  </a:tcPr>
+                </a:tc>
+                <a:tc>
+                  <a:txBody>
+                    <a:bodyPr/>
+                    <a:lstStyle/>
+                    <a:p>
+                      <a:pPr algn="ctr"/>
+                      <a:r>
+                        <a:rPr lang="en-US" b="0" dirty="0">
+                          <a:solidFill>
+                            <a:sysClr val="windowText" lastClr="000000"/>
+                          </a:solidFill>
+                        </a:rPr>
+                        <a:t>Web Search Tool</a:t>
+                      </a:r>
+                    </a:p>
+                  </a:txBody>
+                  <a:tcPr anchor="ctr">
+                    <a:lnL w="12700" cmpd="sng">
+                      <a:noFill/>
+                    </a:lnL>
+                    <a:lnR w="12700" cmpd="sng">
+                      <a:noFill/>
+                    </a:lnR>
+                    <a:lnT w="12700" cmpd="sng">
+                      <a:noFill/>
+                    </a:lnT>
+                    <a:lnB w="38100" cmpd="sng">
+                      <a:noFill/>
+                    </a:lnB>
+                    <a:lnTlToBr w="12700" cmpd="sng">
+                      <a:noFill/>
+                      <a:prstDash val="solid"/>
+                    </a:lnTlToBr>
+                    <a:lnBlToTr w="12700" cmpd="sng">
+                      <a:noFill/>
+                      <a:prstDash val="solid"/>
+                    </a:lnBlToTr>
+                    <a:noFill/>
+                  </a:tcPr>
+                </a:tc>
+                <a:extLst>
+                  <a:ext uri="{0D108BD9-81ED-4DB2-BD59-A6C34878D82A}">
+                    <a16:rowId xmlns:a16="http://schemas.microsoft.com/office/drawing/2014/main" val="2068122310"/>
+                  </a:ext>
+                </a:extLst>
+              </a:tr>
+            </a:tbl>
+          </a:graphicData>
+        </a:graphic>
+      </p:graphicFrame>
+      <p:graphicFrame>
+        <p:nvGraphicFramePr>
+          <p:cNvPr id="14" name="Table 13">
+            <a:extLst>
+              <a:ext uri="{FF2B5EF4-FFF2-40B4-BE49-F238E27FC236}">
+                <a16:creationId xmlns:a16="http://schemas.microsoft.com/office/drawing/2014/main" id="{A600B530-2DEF-F4FD-A3B5-2DF7667730DC}"/>
+              </a:ext>
+            </a:extLst>
+          </p:cNvPr>
+          <p:cNvGraphicFramePr>
+            <a:graphicFrameLocks noGrp="1"/>
+          </p:cNvGraphicFramePr>
+          <p:nvPr>
+            <p:extLst>
+              <p:ext uri="{D42A27DB-BD31-4B8C-83A1-F6EECF244321}">
+                <p14:modId xmlns:p14="http://schemas.microsoft.com/office/powerpoint/2010/main" val="1853539689"/>
+              </p:ext>
+            </p:extLst>
+          </p:nvPr>
+        </p:nvGraphicFramePr>
+        <p:xfrm>
+          <a:off x="3122926" y="4897114"/>
+          <a:ext cx="5946141" cy="370840"/>
+        </p:xfrm>
+        <a:graphic>
+          <a:graphicData uri="http://schemas.openxmlformats.org/drawingml/2006/table">
+            <a:tbl>
+              <a:tblPr firstRow="1" bandRow="1">
+                <a:tableStyleId>{5C22544A-7EE6-4342-B048-85BDC9FD1C3A}</a:tableStyleId>
+              </a:tblPr>
+              <a:tblGrid>
+                <a:gridCol w="1982047">
+                  <a:extLst>
+                    <a:ext uri="{9D8B030D-6E8A-4147-A177-3AD203B41FA5}">
+                      <a16:colId xmlns:a16="http://schemas.microsoft.com/office/drawing/2014/main" val="3167127258"/>
+                    </a:ext>
+                  </a:extLst>
+                </a:gridCol>
+                <a:gridCol w="1982047">
+                  <a:extLst>
+                    <a:ext uri="{9D8B030D-6E8A-4147-A177-3AD203B41FA5}">
+                      <a16:colId xmlns:a16="http://schemas.microsoft.com/office/drawing/2014/main" val="1913894467"/>
+                    </a:ext>
+                  </a:extLst>
+                </a:gridCol>
+                <a:gridCol w="1982047">
+                  <a:extLst>
+                    <a:ext uri="{9D8B030D-6E8A-4147-A177-3AD203B41FA5}">
+                      <a16:colId xmlns:a16="http://schemas.microsoft.com/office/drawing/2014/main" val="304178738"/>
+                    </a:ext>
+                  </a:extLst>
+                </a:gridCol>
+              </a:tblGrid>
+              <a:tr h="370840">
+                <a:tc>
+                  <a:txBody>
+                    <a:bodyPr/>
+                    <a:lstStyle/>
+                    <a:p>
+                      <a:pPr algn="ctr"/>
+                      <a:r>
+                        <a:rPr lang="en-US" b="0" dirty="0">
+                          <a:solidFill>
+                            <a:sysClr val="windowText" lastClr="000000"/>
+                          </a:solidFill>
+                        </a:rPr>
+                        <a:t>SQL DB results</a:t>
+                      </a:r>
+                    </a:p>
+                  </a:txBody>
+                  <a:tcPr anchor="ctr">
+                    <a:lnL w="12700" cmpd="sng">
+                      <a:noFill/>
+                    </a:lnL>
+                    <a:lnR w="12700" cmpd="sng">
+                      <a:noFill/>
+                    </a:lnR>
+                    <a:lnT w="12700" cmpd="sng">
+                      <a:noFill/>
+                    </a:lnT>
+                    <a:lnB w="38100" cmpd="sng">
+                      <a:noFill/>
+                    </a:lnB>
+                    <a:lnTlToBr w="12700" cmpd="sng">
+                      <a:noFill/>
+                      <a:prstDash val="solid"/>
+                    </a:lnTlToBr>
+                    <a:lnBlToTr w="12700" cmpd="sng">
+                      <a:noFill/>
+                      <a:prstDash val="solid"/>
+                    </a:lnBlToTr>
+                    <a:noFill/>
+                  </a:tcPr>
+                </a:tc>
+                <a:tc>
+                  <a:txBody>
+                    <a:bodyPr/>
+                    <a:lstStyle/>
+                    <a:p>
+                      <a:pPr algn="ctr"/>
+                      <a:r>
+                        <a:rPr lang="en-US" b="0" dirty="0">
+                          <a:solidFill>
+                            <a:sysClr val="windowText" lastClr="000000"/>
+                          </a:solidFill>
+                        </a:rPr>
+                        <a:t>Vector search results</a:t>
+                      </a:r>
+                    </a:p>
+                  </a:txBody>
+                  <a:tcPr anchor="ctr">
+                    <a:lnL w="12700" cmpd="sng">
+                      <a:noFill/>
+                    </a:lnL>
+                    <a:lnR w="12700" cmpd="sng">
+                      <a:noFill/>
+                    </a:lnR>
+                    <a:lnT w="12700" cmpd="sng">
+                      <a:noFill/>
+                    </a:lnT>
+                    <a:lnB w="38100" cmpd="sng">
+                      <a:noFill/>
+                    </a:lnB>
+                    <a:lnTlToBr w="12700" cmpd="sng">
+                      <a:noFill/>
+                      <a:prstDash val="solid"/>
+                    </a:lnTlToBr>
+                    <a:lnBlToTr w="12700" cmpd="sng">
+                      <a:noFill/>
+                      <a:prstDash val="solid"/>
+                    </a:lnBlToTr>
+                    <a:noFill/>
+                  </a:tcPr>
+                </a:tc>
+                <a:tc>
+                  <a:txBody>
+                    <a:bodyPr/>
+                    <a:lstStyle/>
+                    <a:p>
+                      <a:pPr algn="ctr"/>
+                      <a:r>
+                        <a:rPr lang="en-US" b="0" dirty="0">
+                          <a:solidFill>
+                            <a:sysClr val="windowText" lastClr="000000"/>
+                          </a:solidFill>
+                        </a:rPr>
+                        <a:t>Web search results</a:t>
+                      </a:r>
+                    </a:p>
+                  </a:txBody>
+                  <a:tcPr anchor="ctr">
+                    <a:lnL w="12700" cmpd="sng">
+                      <a:noFill/>
+                    </a:lnL>
+                    <a:lnR w="12700" cmpd="sng">
+                      <a:noFill/>
+                    </a:lnR>
+                    <a:lnT w="12700" cmpd="sng">
+                      <a:noFill/>
+                    </a:lnT>
+                    <a:lnB w="38100" cmpd="sng">
+                      <a:noFill/>
+                    </a:lnB>
+                    <a:lnTlToBr w="12700" cmpd="sng">
+                      <a:noFill/>
+                      <a:prstDash val="solid"/>
+                    </a:lnTlToBr>
+                    <a:lnBlToTr w="12700" cmpd="sng">
+                      <a:noFill/>
+                      <a:prstDash val="solid"/>
+                    </a:lnBlToTr>
+                    <a:noFill/>
+                  </a:tcPr>
+                </a:tc>
+                <a:extLst>
+                  <a:ext uri="{0D108BD9-81ED-4DB2-BD59-A6C34878D82A}">
+                    <a16:rowId xmlns:a16="http://schemas.microsoft.com/office/drawing/2014/main" val="2068122310"/>
+                  </a:ext>
+                </a:extLst>
+              </a:tr>
+            </a:tbl>
+          </a:graphicData>
+        </a:graphic>
+      </p:graphicFrame>
     </p:spTree>
     <p:extLst>
       <p:ext uri="{BB962C8B-B14F-4D97-AF65-F5344CB8AC3E}">
-        <p14:creationId xmlns:p14="http://schemas.microsoft.com/office/powerpoint/2010/main" val="2145715379"/>
+        <p14:creationId xmlns:p14="http://schemas.microsoft.com/office/powerpoint/2010/main" val="3488000674"/>
       </p:ext>
     </p:extLst>
   </p:cSld>
@@ -5016,6 +5555,1755 @@
       </p:grpSpPr>
       <p:sp>
         <p:nvSpPr>
+          <p:cNvPr id="2" name="Rectangle: Rounded Corners 1">
+            <a:extLst>
+              <a:ext uri="{FF2B5EF4-FFF2-40B4-BE49-F238E27FC236}">
+                <a16:creationId xmlns:a16="http://schemas.microsoft.com/office/drawing/2014/main" id="{2373B790-295F-D9C9-ECAF-274F835713B8}"/>
+              </a:ext>
+            </a:extLst>
+          </p:cNvPr>
+          <p:cNvSpPr/>
+          <p:nvPr/>
+        </p:nvSpPr>
+        <p:spPr>
+          <a:xfrm>
+            <a:off x="1683600" y="1280957"/>
+            <a:ext cx="8633879" cy="3298663"/>
+          </a:xfrm>
+          <a:prstGeom prst="roundRect">
+            <a:avLst>
+              <a:gd name="adj" fmla="val 5234"/>
+            </a:avLst>
+          </a:prstGeom>
+          <a:solidFill>
+            <a:schemeClr val="bg1"/>
+          </a:solidFill>
+          <a:ln>
+            <a:solidFill>
+              <a:schemeClr val="tx1"/>
+            </a:solidFill>
+          </a:ln>
+        </p:spPr>
+        <p:style>
+          <a:lnRef idx="2">
+            <a:schemeClr val="accent1">
+              <a:shade val="15000"/>
+            </a:schemeClr>
+          </a:lnRef>
+          <a:fillRef idx="1">
+            <a:schemeClr val="accent1"/>
+          </a:fillRef>
+          <a:effectRef idx="0">
+            <a:schemeClr val="accent1"/>
+          </a:effectRef>
+          <a:fontRef idx="minor">
+            <a:schemeClr val="lt1"/>
+          </a:fontRef>
+        </p:style>
+        <p:txBody>
+          <a:bodyPr rtlCol="0" anchor="ctr"/>
+          <a:lstStyle/>
+          <a:p>
+            <a:pPr algn="ctr"/>
+            <a:endParaRPr lang="en-US" dirty="0">
+              <a:solidFill>
+                <a:schemeClr val="tx1"/>
+              </a:solidFill>
+            </a:endParaRPr>
+          </a:p>
+        </p:txBody>
+      </p:sp>
+      <p:sp>
+        <p:nvSpPr>
+          <p:cNvPr id="3" name="Rectangle: Rounded Corners 2">
+            <a:extLst>
+              <a:ext uri="{FF2B5EF4-FFF2-40B4-BE49-F238E27FC236}">
+                <a16:creationId xmlns:a16="http://schemas.microsoft.com/office/drawing/2014/main" id="{AF807674-F982-3E42-18FF-10D7E9818E10}"/>
+              </a:ext>
+            </a:extLst>
+          </p:cNvPr>
+          <p:cNvSpPr/>
+          <p:nvPr/>
+        </p:nvSpPr>
+        <p:spPr>
+          <a:xfrm>
+            <a:off x="3993377" y="4394954"/>
+            <a:ext cx="4014323" cy="369332"/>
+          </a:xfrm>
+          <a:prstGeom prst="roundRect">
+            <a:avLst/>
+          </a:prstGeom>
+          <a:solidFill>
+            <a:srgbClr val="B2D4EB"/>
+          </a:solidFill>
+          <a:ln>
+            <a:solidFill>
+              <a:schemeClr val="tx1"/>
+            </a:solidFill>
+          </a:ln>
+        </p:spPr>
+        <p:style>
+          <a:lnRef idx="2">
+            <a:schemeClr val="accent1">
+              <a:shade val="15000"/>
+            </a:schemeClr>
+          </a:lnRef>
+          <a:fillRef idx="1">
+            <a:schemeClr val="accent1"/>
+          </a:fillRef>
+          <a:effectRef idx="0">
+            <a:schemeClr val="accent1"/>
+          </a:effectRef>
+          <a:fontRef idx="minor">
+            <a:schemeClr val="lt1"/>
+          </a:fontRef>
+        </p:style>
+        <p:txBody>
+          <a:bodyPr rtlCol="0" anchor="ctr"/>
+          <a:lstStyle/>
+          <a:p>
+            <a:pPr algn="ctr"/>
+            <a:r>
+              <a:rPr lang="en-US" dirty="0">
+                <a:solidFill>
+                  <a:schemeClr val="tx1"/>
+                </a:solidFill>
+              </a:rPr>
+              <a:t>Security, Compliance, and Governance</a:t>
+            </a:r>
+            <a:endParaRPr lang="en-US" i="1" dirty="0">
+              <a:solidFill>
+                <a:schemeClr val="tx1"/>
+              </a:solidFill>
+            </a:endParaRPr>
+          </a:p>
+        </p:txBody>
+      </p:sp>
+      <p:sp>
+        <p:nvSpPr>
+          <p:cNvPr id="4" name="Rectangle: Rounded Corners 3">
+            <a:extLst>
+              <a:ext uri="{FF2B5EF4-FFF2-40B4-BE49-F238E27FC236}">
+                <a16:creationId xmlns:a16="http://schemas.microsoft.com/office/drawing/2014/main" id="{6504FE7B-F946-B4E5-5540-DCBF24C5EE02}"/>
+              </a:ext>
+            </a:extLst>
+          </p:cNvPr>
+          <p:cNvSpPr/>
+          <p:nvPr/>
+        </p:nvSpPr>
+        <p:spPr>
+          <a:xfrm>
+            <a:off x="2120712" y="1629580"/>
+            <a:ext cx="1097280" cy="1097280"/>
+          </a:xfrm>
+          <a:prstGeom prst="roundRect">
+            <a:avLst/>
+          </a:prstGeom>
+          <a:solidFill>
+            <a:srgbClr val="E5F1F8"/>
+          </a:solidFill>
+          <a:ln>
+            <a:solidFill>
+              <a:schemeClr val="tx1"/>
+            </a:solidFill>
+          </a:ln>
+        </p:spPr>
+        <p:style>
+          <a:lnRef idx="2">
+            <a:schemeClr val="accent1">
+              <a:shade val="15000"/>
+            </a:schemeClr>
+          </a:lnRef>
+          <a:fillRef idx="1">
+            <a:schemeClr val="accent1"/>
+          </a:fillRef>
+          <a:effectRef idx="0">
+            <a:schemeClr val="accent1"/>
+          </a:effectRef>
+          <a:fontRef idx="minor">
+            <a:schemeClr val="lt1"/>
+          </a:fontRef>
+        </p:style>
+        <p:txBody>
+          <a:bodyPr rtlCol="0" anchor="b"/>
+          <a:lstStyle/>
+          <a:p>
+            <a:pPr algn="ctr"/>
+            <a:r>
+              <a:rPr lang="en-US" dirty="0">
+                <a:solidFill>
+                  <a:schemeClr val="tx1"/>
+                </a:solidFill>
+              </a:rPr>
+              <a:t>Models</a:t>
+            </a:r>
+          </a:p>
+        </p:txBody>
+      </p:sp>
+      <p:sp>
+        <p:nvSpPr>
+          <p:cNvPr id="5" name="Rectangle: Rounded Corners 4">
+            <a:extLst>
+              <a:ext uri="{FF2B5EF4-FFF2-40B4-BE49-F238E27FC236}">
+                <a16:creationId xmlns:a16="http://schemas.microsoft.com/office/drawing/2014/main" id="{CCD72E2D-BA5E-4BD0-251B-D709E59BA6AA}"/>
+              </a:ext>
+            </a:extLst>
+          </p:cNvPr>
+          <p:cNvSpPr/>
+          <p:nvPr/>
+        </p:nvSpPr>
+        <p:spPr>
+          <a:xfrm>
+            <a:off x="5547360" y="1629580"/>
+            <a:ext cx="1097280" cy="1097280"/>
+          </a:xfrm>
+          <a:prstGeom prst="roundRect">
+            <a:avLst/>
+          </a:prstGeom>
+          <a:solidFill>
+            <a:srgbClr val="E5F1F8"/>
+          </a:solidFill>
+          <a:ln>
+            <a:solidFill>
+              <a:schemeClr val="tx1"/>
+            </a:solidFill>
+          </a:ln>
+        </p:spPr>
+        <p:style>
+          <a:lnRef idx="2">
+            <a:schemeClr val="accent1">
+              <a:shade val="15000"/>
+            </a:schemeClr>
+          </a:lnRef>
+          <a:fillRef idx="1">
+            <a:schemeClr val="accent1"/>
+          </a:fillRef>
+          <a:effectRef idx="0">
+            <a:schemeClr val="accent1"/>
+          </a:effectRef>
+          <a:fontRef idx="minor">
+            <a:schemeClr val="lt1"/>
+          </a:fontRef>
+        </p:style>
+        <p:txBody>
+          <a:bodyPr rtlCol="0" anchor="b"/>
+          <a:lstStyle/>
+          <a:p>
+            <a:pPr algn="ctr"/>
+            <a:r>
+              <a:rPr lang="en-US" dirty="0">
+                <a:solidFill>
+                  <a:schemeClr val="tx1"/>
+                </a:solidFill>
+              </a:rPr>
+              <a:t>IQ</a:t>
+            </a:r>
+          </a:p>
+        </p:txBody>
+      </p:sp>
+      <p:sp>
+        <p:nvSpPr>
+          <p:cNvPr id="6" name="Rectangle: Rounded Corners 5">
+            <a:extLst>
+              <a:ext uri="{FF2B5EF4-FFF2-40B4-BE49-F238E27FC236}">
+                <a16:creationId xmlns:a16="http://schemas.microsoft.com/office/drawing/2014/main" id="{8A00E6D5-7A21-352C-E165-8534FCB5922A}"/>
+              </a:ext>
+            </a:extLst>
+          </p:cNvPr>
+          <p:cNvSpPr/>
+          <p:nvPr/>
+        </p:nvSpPr>
+        <p:spPr>
+          <a:xfrm>
+            <a:off x="3834036" y="1629580"/>
+            <a:ext cx="1097280" cy="1097280"/>
+          </a:xfrm>
+          <a:prstGeom prst="roundRect">
+            <a:avLst/>
+          </a:prstGeom>
+          <a:solidFill>
+            <a:srgbClr val="E5F1F8"/>
+          </a:solidFill>
+          <a:ln>
+            <a:solidFill>
+              <a:schemeClr val="tx1"/>
+            </a:solidFill>
+          </a:ln>
+        </p:spPr>
+        <p:style>
+          <a:lnRef idx="2">
+            <a:schemeClr val="accent1">
+              <a:shade val="15000"/>
+            </a:schemeClr>
+          </a:lnRef>
+          <a:fillRef idx="1">
+            <a:schemeClr val="accent1"/>
+          </a:fillRef>
+          <a:effectRef idx="0">
+            <a:schemeClr val="accent1"/>
+          </a:effectRef>
+          <a:fontRef idx="minor">
+            <a:schemeClr val="lt1"/>
+          </a:fontRef>
+        </p:style>
+        <p:txBody>
+          <a:bodyPr rtlCol="0" anchor="b"/>
+          <a:lstStyle/>
+          <a:p>
+            <a:pPr algn="ctr"/>
+            <a:r>
+              <a:rPr lang="en-US" dirty="0">
+                <a:solidFill>
+                  <a:schemeClr val="tx1"/>
+                </a:solidFill>
+              </a:rPr>
+              <a:t>Agents</a:t>
+            </a:r>
+          </a:p>
+        </p:txBody>
+      </p:sp>
+      <p:sp>
+        <p:nvSpPr>
+          <p:cNvPr id="7" name="Rectangle: Rounded Corners 6">
+            <a:extLst>
+              <a:ext uri="{FF2B5EF4-FFF2-40B4-BE49-F238E27FC236}">
+                <a16:creationId xmlns:a16="http://schemas.microsoft.com/office/drawing/2014/main" id="{FEFF2ADF-7ABC-2B4F-15DA-147A653CA05E}"/>
+              </a:ext>
+            </a:extLst>
+          </p:cNvPr>
+          <p:cNvSpPr/>
+          <p:nvPr/>
+        </p:nvSpPr>
+        <p:spPr>
+          <a:xfrm>
+            <a:off x="7260684" y="1629580"/>
+            <a:ext cx="1097280" cy="1097280"/>
+          </a:xfrm>
+          <a:prstGeom prst="roundRect">
+            <a:avLst/>
+          </a:prstGeom>
+          <a:solidFill>
+            <a:srgbClr val="E5F1F8"/>
+          </a:solidFill>
+          <a:ln>
+            <a:solidFill>
+              <a:schemeClr val="tx1"/>
+            </a:solidFill>
+          </a:ln>
+        </p:spPr>
+        <p:style>
+          <a:lnRef idx="2">
+            <a:schemeClr val="accent1">
+              <a:shade val="15000"/>
+            </a:schemeClr>
+          </a:lnRef>
+          <a:fillRef idx="1">
+            <a:schemeClr val="accent1"/>
+          </a:fillRef>
+          <a:effectRef idx="0">
+            <a:schemeClr val="accent1"/>
+          </a:effectRef>
+          <a:fontRef idx="minor">
+            <a:schemeClr val="lt1"/>
+          </a:fontRef>
+        </p:style>
+        <p:txBody>
+          <a:bodyPr rtlCol="0" anchor="b"/>
+          <a:lstStyle/>
+          <a:p>
+            <a:pPr algn="ctr"/>
+            <a:r>
+              <a:rPr lang="en-US" dirty="0">
+                <a:solidFill>
+                  <a:schemeClr val="tx1"/>
+                </a:solidFill>
+              </a:rPr>
+              <a:t>Tools</a:t>
+            </a:r>
+          </a:p>
+        </p:txBody>
+      </p:sp>
+      <p:sp>
+        <p:nvSpPr>
+          <p:cNvPr id="8" name="Rectangle: Rounded Corners 7">
+            <a:extLst>
+              <a:ext uri="{FF2B5EF4-FFF2-40B4-BE49-F238E27FC236}">
+                <a16:creationId xmlns:a16="http://schemas.microsoft.com/office/drawing/2014/main" id="{B911A12B-43CF-B03D-9C15-EC0C073F267F}"/>
+              </a:ext>
+            </a:extLst>
+          </p:cNvPr>
+          <p:cNvSpPr/>
+          <p:nvPr/>
+        </p:nvSpPr>
+        <p:spPr>
+          <a:xfrm>
+            <a:off x="8974008" y="1629580"/>
+            <a:ext cx="1097280" cy="1097280"/>
+          </a:xfrm>
+          <a:prstGeom prst="roundRect">
+            <a:avLst/>
+          </a:prstGeom>
+          <a:solidFill>
+            <a:srgbClr val="E5F1F8"/>
+          </a:solidFill>
+          <a:ln>
+            <a:solidFill>
+              <a:schemeClr val="tx1"/>
+            </a:solidFill>
+          </a:ln>
+        </p:spPr>
+        <p:style>
+          <a:lnRef idx="2">
+            <a:schemeClr val="accent1">
+              <a:shade val="15000"/>
+            </a:schemeClr>
+          </a:lnRef>
+          <a:fillRef idx="1">
+            <a:schemeClr val="accent1"/>
+          </a:fillRef>
+          <a:effectRef idx="0">
+            <a:schemeClr val="accent1"/>
+          </a:effectRef>
+          <a:fontRef idx="minor">
+            <a:schemeClr val="lt1"/>
+          </a:fontRef>
+        </p:style>
+        <p:txBody>
+          <a:bodyPr rtlCol="0" anchor="b"/>
+          <a:lstStyle/>
+          <a:p>
+            <a:pPr algn="ctr"/>
+            <a:r>
+              <a:rPr lang="en-US" dirty="0">
+                <a:solidFill>
+                  <a:schemeClr val="tx1"/>
+                </a:solidFill>
+              </a:rPr>
+              <a:t>Local</a:t>
+            </a:r>
+          </a:p>
+        </p:txBody>
+      </p:sp>
+      <p:sp>
+        <p:nvSpPr>
+          <p:cNvPr id="9" name="Rectangle: Rounded Corners 8">
+            <a:extLst>
+              <a:ext uri="{FF2B5EF4-FFF2-40B4-BE49-F238E27FC236}">
+                <a16:creationId xmlns:a16="http://schemas.microsoft.com/office/drawing/2014/main" id="{29E82D6B-67A5-FB5E-86C8-E494906EBA72}"/>
+              </a:ext>
+            </a:extLst>
+          </p:cNvPr>
+          <p:cNvSpPr/>
+          <p:nvPr/>
+        </p:nvSpPr>
+        <p:spPr>
+          <a:xfrm>
+            <a:off x="2120712" y="3075483"/>
+            <a:ext cx="7950576" cy="521732"/>
+          </a:xfrm>
+          <a:prstGeom prst="roundRect">
+            <a:avLst/>
+          </a:prstGeom>
+          <a:solidFill>
+            <a:srgbClr val="E5F1F8"/>
+          </a:solidFill>
+          <a:ln>
+            <a:solidFill>
+              <a:schemeClr val="tx1"/>
+            </a:solidFill>
+          </a:ln>
+        </p:spPr>
+        <p:style>
+          <a:lnRef idx="2">
+            <a:schemeClr val="accent1">
+              <a:shade val="15000"/>
+            </a:schemeClr>
+          </a:lnRef>
+          <a:fillRef idx="1">
+            <a:schemeClr val="accent1"/>
+          </a:fillRef>
+          <a:effectRef idx="0">
+            <a:schemeClr val="accent1"/>
+          </a:effectRef>
+          <a:fontRef idx="minor">
+            <a:schemeClr val="lt1"/>
+          </a:fontRef>
+        </p:style>
+        <p:txBody>
+          <a:bodyPr rtlCol="0" anchor="ctr"/>
+          <a:lstStyle/>
+          <a:p>
+            <a:pPr algn="ctr"/>
+            <a:r>
+              <a:rPr lang="en-US" dirty="0">
+                <a:solidFill>
+                  <a:schemeClr val="tx1"/>
+                </a:solidFill>
+              </a:rPr>
+              <a:t>Control Plane</a:t>
+            </a:r>
+          </a:p>
+        </p:txBody>
+      </p:sp>
+      <p:sp>
+        <p:nvSpPr>
+          <p:cNvPr id="10" name="Rectangle: Rounded Corners 9">
+            <a:extLst>
+              <a:ext uri="{FF2B5EF4-FFF2-40B4-BE49-F238E27FC236}">
+                <a16:creationId xmlns:a16="http://schemas.microsoft.com/office/drawing/2014/main" id="{B8A0002D-68DE-F2E3-7AE8-155E2AE2F385}"/>
+              </a:ext>
+            </a:extLst>
+          </p:cNvPr>
+          <p:cNvSpPr/>
+          <p:nvPr/>
+        </p:nvSpPr>
+        <p:spPr>
+          <a:xfrm>
+            <a:off x="2120712" y="3903751"/>
+            <a:ext cx="1097280" cy="369332"/>
+          </a:xfrm>
+          <a:prstGeom prst="roundRect">
+            <a:avLst>
+              <a:gd name="adj" fmla="val 50000"/>
+            </a:avLst>
+          </a:prstGeom>
+          <a:solidFill>
+            <a:srgbClr val="B2D4EB"/>
+          </a:solidFill>
+          <a:ln>
+            <a:solidFill>
+              <a:schemeClr val="tx1"/>
+            </a:solidFill>
+          </a:ln>
+        </p:spPr>
+        <p:style>
+          <a:lnRef idx="2">
+            <a:schemeClr val="accent1">
+              <a:shade val="15000"/>
+            </a:schemeClr>
+          </a:lnRef>
+          <a:fillRef idx="1">
+            <a:schemeClr val="accent1"/>
+          </a:fillRef>
+          <a:effectRef idx="0">
+            <a:schemeClr val="accent1"/>
+          </a:effectRef>
+          <a:fontRef idx="minor">
+            <a:schemeClr val="lt1"/>
+          </a:fontRef>
+        </p:style>
+        <p:txBody>
+          <a:bodyPr rtlCol="0" anchor="ctr"/>
+          <a:lstStyle/>
+          <a:p>
+            <a:pPr algn="ctr"/>
+            <a:r>
+              <a:rPr lang="en-US" dirty="0">
+                <a:solidFill>
+                  <a:schemeClr val="tx1"/>
+                </a:solidFill>
+              </a:rPr>
+              <a:t>Cloud</a:t>
+            </a:r>
+            <a:endParaRPr lang="en-US" i="1" dirty="0">
+              <a:solidFill>
+                <a:schemeClr val="tx1"/>
+              </a:solidFill>
+            </a:endParaRPr>
+          </a:p>
+        </p:txBody>
+      </p:sp>
+      <p:sp>
+        <p:nvSpPr>
+          <p:cNvPr id="11" name="Rectangle: Rounded Corners 10">
+            <a:extLst>
+              <a:ext uri="{FF2B5EF4-FFF2-40B4-BE49-F238E27FC236}">
+                <a16:creationId xmlns:a16="http://schemas.microsoft.com/office/drawing/2014/main" id="{275A5F02-D45E-7075-0A8E-DE47614A9350}"/>
+              </a:ext>
+            </a:extLst>
+          </p:cNvPr>
+          <p:cNvSpPr/>
+          <p:nvPr/>
+        </p:nvSpPr>
+        <p:spPr>
+          <a:xfrm>
+            <a:off x="8974008" y="3900228"/>
+            <a:ext cx="1097280" cy="369332"/>
+          </a:xfrm>
+          <a:prstGeom prst="roundRect">
+            <a:avLst>
+              <a:gd name="adj" fmla="val 50000"/>
+            </a:avLst>
+          </a:prstGeom>
+          <a:solidFill>
+            <a:srgbClr val="B2D4EB"/>
+          </a:solidFill>
+          <a:ln>
+            <a:solidFill>
+              <a:schemeClr val="tx1"/>
+            </a:solidFill>
+          </a:ln>
+        </p:spPr>
+        <p:style>
+          <a:lnRef idx="2">
+            <a:schemeClr val="accent1">
+              <a:shade val="15000"/>
+            </a:schemeClr>
+          </a:lnRef>
+          <a:fillRef idx="1">
+            <a:schemeClr val="accent1"/>
+          </a:fillRef>
+          <a:effectRef idx="0">
+            <a:schemeClr val="accent1"/>
+          </a:effectRef>
+          <a:fontRef idx="minor">
+            <a:schemeClr val="lt1"/>
+          </a:fontRef>
+        </p:style>
+        <p:txBody>
+          <a:bodyPr rtlCol="0" anchor="ctr"/>
+          <a:lstStyle/>
+          <a:p>
+            <a:pPr algn="ctr"/>
+            <a:r>
+              <a:rPr lang="en-US" dirty="0">
+                <a:solidFill>
+                  <a:schemeClr val="tx1"/>
+                </a:solidFill>
+              </a:rPr>
+              <a:t>Edge</a:t>
+            </a:r>
+            <a:endParaRPr lang="en-US" i="1" dirty="0">
+              <a:solidFill>
+                <a:schemeClr val="tx1"/>
+              </a:solidFill>
+            </a:endParaRPr>
+          </a:p>
+        </p:txBody>
+      </p:sp>
+      <p:cxnSp>
+        <p:nvCxnSpPr>
+          <p:cNvPr id="12" name="Straight Arrow Connector 11">
+            <a:extLst>
+              <a:ext uri="{FF2B5EF4-FFF2-40B4-BE49-F238E27FC236}">
+                <a16:creationId xmlns:a16="http://schemas.microsoft.com/office/drawing/2014/main" id="{059E589C-158C-8464-335B-8E038EB59CAF}"/>
+              </a:ext>
+            </a:extLst>
+          </p:cNvPr>
+          <p:cNvCxnSpPr>
+            <a:cxnSpLocks/>
+            <a:stCxn id="10" idx="3"/>
+            <a:endCxn id="11" idx="1"/>
+          </p:cNvCxnSpPr>
+          <p:nvPr/>
+        </p:nvCxnSpPr>
+        <p:spPr>
+          <a:xfrm flipV="1">
+            <a:off x="3217992" y="4084894"/>
+            <a:ext cx="5756016" cy="3523"/>
+          </a:xfrm>
+          <a:prstGeom prst="straightConnector1">
+            <a:avLst/>
+          </a:prstGeom>
+          <a:ln>
+            <a:solidFill>
+              <a:schemeClr val="tx1"/>
+            </a:solidFill>
+            <a:prstDash val="solid"/>
+            <a:headEnd type="triangle" w="lg" len="lg"/>
+            <a:tailEnd type="triangle" w="lg" len="lg"/>
+          </a:ln>
+        </p:spPr>
+        <p:style>
+          <a:lnRef idx="2">
+            <a:schemeClr val="accent1"/>
+          </a:lnRef>
+          <a:fillRef idx="0">
+            <a:schemeClr val="accent1"/>
+          </a:fillRef>
+          <a:effectRef idx="1">
+            <a:schemeClr val="accent1"/>
+          </a:effectRef>
+          <a:fontRef idx="minor">
+            <a:schemeClr val="tx1"/>
+          </a:fontRef>
+        </p:style>
+      </p:cxnSp>
+      <p:pic>
+        <p:nvPicPr>
+          <p:cNvPr id="1030" name="Picture 6">
+            <a:extLst>
+              <a:ext uri="{FF2B5EF4-FFF2-40B4-BE49-F238E27FC236}">
+                <a16:creationId xmlns:a16="http://schemas.microsoft.com/office/drawing/2014/main" id="{8D6EF364-A0CD-1E0B-E3D9-D7610B0BA01B}"/>
+              </a:ext>
+            </a:extLst>
+          </p:cNvPr>
+          <p:cNvPicPr>
+            <a:picLocks noChangeAspect="1" noChangeArrowheads="1"/>
+          </p:cNvPicPr>
+          <p:nvPr/>
+        </p:nvPicPr>
+        <p:blipFill>
+          <a:blip r:embed="rId2">
+            <a:extLst>
+              <a:ext uri="{28A0092B-C50C-407E-A947-70E740481C1C}">
+                <a14:useLocalDpi xmlns:a14="http://schemas.microsoft.com/office/drawing/2010/main" val="0"/>
+              </a:ext>
+            </a:extLst>
+          </a:blip>
+          <a:srcRect/>
+          <a:stretch>
+            <a:fillRect/>
+          </a:stretch>
+        </p:blipFill>
+        <p:spPr bwMode="auto">
+          <a:xfrm>
+            <a:off x="2326452" y="1698160"/>
+            <a:ext cx="685800" cy="685800"/>
+          </a:xfrm>
+          <a:prstGeom prst="rect">
+            <a:avLst/>
+          </a:prstGeom>
+          <a:noFill/>
+          <a:extLst>
+            <a:ext uri="{909E8E84-426E-40DD-AFC4-6F175D3DCCD1}">
+              <a14:hiddenFill xmlns:a14="http://schemas.microsoft.com/office/drawing/2010/main">
+                <a:solidFill>
+                  <a:srgbClr val="FFFFFF"/>
+                </a:solidFill>
+              </a14:hiddenFill>
+            </a:ext>
+          </a:extLst>
+        </p:spPr>
+      </p:pic>
+      <p:pic>
+        <p:nvPicPr>
+          <p:cNvPr id="1034" name="Picture 10">
+            <a:extLst>
+              <a:ext uri="{FF2B5EF4-FFF2-40B4-BE49-F238E27FC236}">
+                <a16:creationId xmlns:a16="http://schemas.microsoft.com/office/drawing/2014/main" id="{584812A5-BC6A-1A0C-EC5F-293C5EE9341F}"/>
+              </a:ext>
+            </a:extLst>
+          </p:cNvPr>
+          <p:cNvPicPr>
+            <a:picLocks noChangeAspect="1" noChangeArrowheads="1"/>
+          </p:cNvPicPr>
+          <p:nvPr/>
+        </p:nvPicPr>
+        <p:blipFill>
+          <a:blip r:embed="rId3">
+            <a:extLst>
+              <a:ext uri="{28A0092B-C50C-407E-A947-70E740481C1C}">
+                <a14:useLocalDpi xmlns:a14="http://schemas.microsoft.com/office/drawing/2010/main" val="0"/>
+              </a:ext>
+            </a:extLst>
+          </a:blip>
+          <a:srcRect/>
+          <a:stretch>
+            <a:fillRect/>
+          </a:stretch>
+        </p:blipFill>
+        <p:spPr bwMode="auto">
+          <a:xfrm>
+            <a:off x="5753100" y="1698160"/>
+            <a:ext cx="685800" cy="685800"/>
+          </a:xfrm>
+          <a:prstGeom prst="rect">
+            <a:avLst/>
+          </a:prstGeom>
+          <a:noFill/>
+          <a:extLst>
+            <a:ext uri="{909E8E84-426E-40DD-AFC4-6F175D3DCCD1}">
+              <a14:hiddenFill xmlns:a14="http://schemas.microsoft.com/office/drawing/2010/main">
+                <a:solidFill>
+                  <a:srgbClr val="FFFFFF"/>
+                </a:solidFill>
+              </a14:hiddenFill>
+            </a:ext>
+          </a:extLst>
+        </p:spPr>
+      </p:pic>
+      <p:sp>
+        <p:nvSpPr>
+          <p:cNvPr id="16" name="TextBox 15">
+            <a:extLst>
+              <a:ext uri="{FF2B5EF4-FFF2-40B4-BE49-F238E27FC236}">
+                <a16:creationId xmlns:a16="http://schemas.microsoft.com/office/drawing/2014/main" id="{75C2BE62-4319-90A2-F77A-43FBCCB45A92}"/>
+              </a:ext>
+            </a:extLst>
+          </p:cNvPr>
+          <p:cNvSpPr txBox="1"/>
+          <p:nvPr/>
+        </p:nvSpPr>
+        <p:spPr>
+          <a:xfrm>
+            <a:off x="169992" y="6374146"/>
+            <a:ext cx="6096000" cy="369332"/>
+          </a:xfrm>
+          <a:prstGeom prst="rect">
+            <a:avLst/>
+          </a:prstGeom>
+          <a:noFill/>
+        </p:spPr>
+        <p:txBody>
+          <a:bodyPr wrap="square">
+            <a:spAutoFit/>
+          </a:bodyPr>
+          <a:lstStyle/>
+          <a:p>
+            <a:r>
+              <a:rPr lang="en-US" dirty="0">
+                <a:hlinkClick r:id="rId4"/>
+              </a:rPr>
+              <a:t>Microsoft Foundry documentation | Microsoft Learn</a:t>
+            </a:r>
+            <a:endParaRPr lang="en-US" dirty="0"/>
+          </a:p>
+        </p:txBody>
+      </p:sp>
+      <p:pic>
+        <p:nvPicPr>
+          <p:cNvPr id="1036" name="Picture 12">
+            <a:extLst>
+              <a:ext uri="{FF2B5EF4-FFF2-40B4-BE49-F238E27FC236}">
+                <a16:creationId xmlns:a16="http://schemas.microsoft.com/office/drawing/2014/main" id="{2C06DA4A-A0CA-3F11-FBF2-7675DC8920F6}"/>
+              </a:ext>
+            </a:extLst>
+          </p:cNvPr>
+          <p:cNvPicPr>
+            <a:picLocks noChangeAspect="1" noChangeArrowheads="1"/>
+          </p:cNvPicPr>
+          <p:nvPr/>
+        </p:nvPicPr>
+        <p:blipFill>
+          <a:blip r:embed="rId5">
+            <a:extLst>
+              <a:ext uri="{28A0092B-C50C-407E-A947-70E740481C1C}">
+                <a14:useLocalDpi xmlns:a14="http://schemas.microsoft.com/office/drawing/2010/main" val="0"/>
+              </a:ext>
+            </a:extLst>
+          </a:blip>
+          <a:srcRect/>
+          <a:stretch>
+            <a:fillRect/>
+          </a:stretch>
+        </p:blipFill>
+        <p:spPr bwMode="auto">
+          <a:xfrm>
+            <a:off x="9179748" y="1698160"/>
+            <a:ext cx="685800" cy="685800"/>
+          </a:xfrm>
+          <a:prstGeom prst="rect">
+            <a:avLst/>
+          </a:prstGeom>
+          <a:noFill/>
+          <a:extLst>
+            <a:ext uri="{909E8E84-426E-40DD-AFC4-6F175D3DCCD1}">
+              <a14:hiddenFill xmlns:a14="http://schemas.microsoft.com/office/drawing/2010/main">
+                <a:solidFill>
+                  <a:srgbClr val="FFFFFF"/>
+                </a:solidFill>
+              </a14:hiddenFill>
+            </a:ext>
+          </a:extLst>
+        </p:spPr>
+      </p:pic>
+      <p:pic>
+        <p:nvPicPr>
+          <p:cNvPr id="1038" name="Picture 14">
+            <a:extLst>
+              <a:ext uri="{FF2B5EF4-FFF2-40B4-BE49-F238E27FC236}">
+                <a16:creationId xmlns:a16="http://schemas.microsoft.com/office/drawing/2014/main" id="{BBE57FCA-085E-B37C-A718-A5115481F51F}"/>
+              </a:ext>
+            </a:extLst>
+          </p:cNvPr>
+          <p:cNvPicPr>
+            <a:picLocks noChangeAspect="1" noChangeArrowheads="1"/>
+          </p:cNvPicPr>
+          <p:nvPr/>
+        </p:nvPicPr>
+        <p:blipFill>
+          <a:blip r:embed="rId6">
+            <a:extLst>
+              <a:ext uri="{28A0092B-C50C-407E-A947-70E740481C1C}">
+                <a14:useLocalDpi xmlns:a14="http://schemas.microsoft.com/office/drawing/2010/main" val="0"/>
+              </a:ext>
+            </a:extLst>
+          </a:blip>
+          <a:srcRect/>
+          <a:stretch>
+            <a:fillRect/>
+          </a:stretch>
+        </p:blipFill>
+        <p:spPr bwMode="auto">
+          <a:xfrm>
+            <a:off x="7466424" y="1698160"/>
+            <a:ext cx="685800" cy="685800"/>
+          </a:xfrm>
+          <a:prstGeom prst="rect">
+            <a:avLst/>
+          </a:prstGeom>
+          <a:noFill/>
+          <a:extLst>
+            <a:ext uri="{909E8E84-426E-40DD-AFC4-6F175D3DCCD1}">
+              <a14:hiddenFill xmlns:a14="http://schemas.microsoft.com/office/drawing/2010/main">
+                <a:solidFill>
+                  <a:srgbClr val="FFFFFF"/>
+                </a:solidFill>
+              </a14:hiddenFill>
+            </a:ext>
+          </a:extLst>
+        </p:spPr>
+      </p:pic>
+      <p:pic>
+        <p:nvPicPr>
+          <p:cNvPr id="21" name="Graphic 20">
+            <a:extLst>
+              <a:ext uri="{FF2B5EF4-FFF2-40B4-BE49-F238E27FC236}">
+                <a16:creationId xmlns:a16="http://schemas.microsoft.com/office/drawing/2014/main" id="{4DCAAB39-A56E-0DEE-C6B4-7E5D07F0EEB0}"/>
+              </a:ext>
+            </a:extLst>
+          </p:cNvPr>
+          <p:cNvPicPr>
+            <a:picLocks noChangeAspect="1"/>
+          </p:cNvPicPr>
+          <p:nvPr/>
+        </p:nvPicPr>
+        <p:blipFill>
+          <a:blip r:embed="rId7">
+            <a:extLst>
+              <a:ext uri="{96DAC541-7B7A-43D3-8B79-37D633B846F1}">
+                <asvg:svgBlip xmlns:asvg="http://schemas.microsoft.com/office/drawing/2016/SVG/main" r:embed="rId8"/>
+              </a:ext>
+            </a:extLst>
+          </a:blip>
+          <a:stretch>
+            <a:fillRect/>
+          </a:stretch>
+        </p:blipFill>
+        <p:spPr>
+          <a:xfrm>
+            <a:off x="5005387" y="3107749"/>
+            <a:ext cx="457200" cy="457200"/>
+          </a:xfrm>
+          <a:prstGeom prst="rect">
+            <a:avLst/>
+          </a:prstGeom>
+        </p:spPr>
+      </p:pic>
+      <p:pic>
+        <p:nvPicPr>
+          <p:cNvPr id="23" name="Graphic 22">
+            <a:extLst>
+              <a:ext uri="{FF2B5EF4-FFF2-40B4-BE49-F238E27FC236}">
+                <a16:creationId xmlns:a16="http://schemas.microsoft.com/office/drawing/2014/main" id="{9F45F68D-2016-AE28-5FB4-29299FA72985}"/>
+              </a:ext>
+            </a:extLst>
+          </p:cNvPr>
+          <p:cNvPicPr>
+            <a:picLocks noChangeAspect="1"/>
+          </p:cNvPicPr>
+          <p:nvPr/>
+        </p:nvPicPr>
+        <p:blipFill>
+          <a:blip r:embed="rId9">
+            <a:extLst>
+              <a:ext uri="{96DAC541-7B7A-43D3-8B79-37D633B846F1}">
+                <asvg:svgBlip xmlns:asvg="http://schemas.microsoft.com/office/drawing/2016/SVG/main" r:embed="rId10"/>
+              </a:ext>
+            </a:extLst>
+          </a:blip>
+          <a:stretch>
+            <a:fillRect/>
+          </a:stretch>
+        </p:blipFill>
+        <p:spPr>
+          <a:xfrm>
+            <a:off x="4039776" y="1698160"/>
+            <a:ext cx="685800" cy="685800"/>
+          </a:xfrm>
+          <a:prstGeom prst="rect">
+            <a:avLst/>
+          </a:prstGeom>
+        </p:spPr>
+      </p:pic>
+      <p:grpSp>
+        <p:nvGrpSpPr>
+          <p:cNvPr id="27" name="Group 26">
+            <a:extLst>
+              <a:ext uri="{FF2B5EF4-FFF2-40B4-BE49-F238E27FC236}">
+                <a16:creationId xmlns:a16="http://schemas.microsoft.com/office/drawing/2014/main" id="{220717FD-C295-A74B-1DD9-B84C288BFAF5}"/>
+              </a:ext>
+            </a:extLst>
+          </p:cNvPr>
+          <p:cNvGrpSpPr/>
+          <p:nvPr/>
+        </p:nvGrpSpPr>
+        <p:grpSpPr>
+          <a:xfrm>
+            <a:off x="4468860" y="550330"/>
+            <a:ext cx="3254280" cy="685800"/>
+            <a:chOff x="4558421" y="553105"/>
+            <a:chExt cx="3254280" cy="685800"/>
+          </a:xfrm>
+        </p:grpSpPr>
+        <p:pic>
+          <p:nvPicPr>
+            <p:cNvPr id="25" name="Picture 24">
+              <a:extLst>
+                <a:ext uri="{FF2B5EF4-FFF2-40B4-BE49-F238E27FC236}">
+                  <a16:creationId xmlns:a16="http://schemas.microsoft.com/office/drawing/2014/main" id="{637A2444-6EF1-C6ED-5009-47471D8E1AFB}"/>
+                </a:ext>
+              </a:extLst>
+            </p:cNvPr>
+            <p:cNvPicPr>
+              <a:picLocks noChangeAspect="1"/>
+            </p:cNvPicPr>
+            <p:nvPr/>
+          </p:nvPicPr>
+          <p:blipFill>
+            <a:blip r:embed="rId11">
+              <a:extLst>
+                <a:ext uri="{28A0092B-C50C-407E-A947-70E740481C1C}">
+                  <a14:useLocalDpi xmlns:a14="http://schemas.microsoft.com/office/drawing/2010/main" val="0"/>
+                </a:ext>
+              </a:extLst>
+            </a:blip>
+            <a:stretch>
+              <a:fillRect/>
+            </a:stretch>
+          </p:blipFill>
+          <p:spPr>
+            <a:xfrm>
+              <a:off x="4558421" y="553105"/>
+              <a:ext cx="750646" cy="685800"/>
+            </a:xfrm>
+            <a:prstGeom prst="rect">
+              <a:avLst/>
+            </a:prstGeom>
+          </p:spPr>
+        </p:pic>
+        <p:sp>
+          <p:nvSpPr>
+            <p:cNvPr id="26" name="TextBox 25">
+              <a:extLst>
+                <a:ext uri="{FF2B5EF4-FFF2-40B4-BE49-F238E27FC236}">
+                  <a16:creationId xmlns:a16="http://schemas.microsoft.com/office/drawing/2014/main" id="{AF52B155-53E9-CC0C-9CB8-93574EE705D4}"/>
+                </a:ext>
+              </a:extLst>
+            </p:cNvPr>
+            <p:cNvSpPr txBox="1"/>
+            <p:nvPr/>
+          </p:nvSpPr>
+          <p:spPr>
+            <a:xfrm>
+              <a:off x="5309067" y="634395"/>
+              <a:ext cx="2503634" cy="523220"/>
+            </a:xfrm>
+            <a:prstGeom prst="rect">
+              <a:avLst/>
+            </a:prstGeom>
+            <a:noFill/>
+          </p:spPr>
+          <p:txBody>
+            <a:bodyPr wrap="none" rtlCol="0">
+              <a:spAutoFit/>
+            </a:bodyPr>
+            <a:lstStyle/>
+            <a:p>
+              <a:r>
+                <a:rPr lang="en-US" sz="2800" dirty="0"/>
+                <a:t>Microsoft Foundry</a:t>
+              </a:r>
+            </a:p>
+          </p:txBody>
+        </p:sp>
+      </p:grpSp>
+    </p:spTree>
+    <p:extLst>
+      <p:ext uri="{BB962C8B-B14F-4D97-AF65-F5344CB8AC3E}">
+        <p14:creationId xmlns:p14="http://schemas.microsoft.com/office/powerpoint/2010/main" val="71902365"/>
+      </p:ext>
+    </p:extLst>
+  </p:cSld>
+  <p:clrMapOvr>
+    <a:masterClrMapping/>
+  </p:clrMapOvr>
+</p:sld>
+</file>
+
+<file path=ppt/slides/slide5.xml><?xml version="1.0" encoding="utf-8"?>
+<p:sld xmlns:a="http://schemas.openxmlformats.org/drawingml/2006/main" xmlns:r="http://schemas.openxmlformats.org/officeDocument/2006/relationships" xmlns:p="http://schemas.openxmlformats.org/presentationml/2006/main">
+  <p:cSld>
+    <p:spTree>
+      <p:nvGrpSpPr>
+        <p:cNvPr id="1" name=""/>
+        <p:cNvGrpSpPr/>
+        <p:nvPr/>
+      </p:nvGrpSpPr>
+      <p:grpSpPr>
+        <a:xfrm>
+          <a:off x="0" y="0"/>
+          <a:ext cx="0" cy="0"/>
+          <a:chOff x="0" y="0"/>
+          <a:chExt cx="0" cy="0"/>
+        </a:xfrm>
+      </p:grpSpPr>
+      <p:sp>
+        <p:nvSpPr>
+          <p:cNvPr id="2" name="Rectangle: Rounded Corners 1">
+            <a:extLst>
+              <a:ext uri="{FF2B5EF4-FFF2-40B4-BE49-F238E27FC236}">
+                <a16:creationId xmlns:a16="http://schemas.microsoft.com/office/drawing/2014/main" id="{ED732446-F0F6-0ACF-647A-3BC33E7C3D60}"/>
+              </a:ext>
+            </a:extLst>
+          </p:cNvPr>
+          <p:cNvSpPr/>
+          <p:nvPr/>
+        </p:nvSpPr>
+        <p:spPr>
+          <a:xfrm>
+            <a:off x="962567" y="281940"/>
+            <a:ext cx="10552099" cy="6187439"/>
+          </a:xfrm>
+          <a:prstGeom prst="roundRect">
+            <a:avLst>
+              <a:gd name="adj" fmla="val 5234"/>
+            </a:avLst>
+          </a:prstGeom>
+          <a:solidFill>
+            <a:schemeClr val="bg1"/>
+          </a:solidFill>
+          <a:ln>
+            <a:solidFill>
+              <a:schemeClr val="tx1"/>
+            </a:solidFill>
+          </a:ln>
+        </p:spPr>
+        <p:style>
+          <a:lnRef idx="2">
+            <a:schemeClr val="accent1">
+              <a:shade val="15000"/>
+            </a:schemeClr>
+          </a:lnRef>
+          <a:fillRef idx="1">
+            <a:schemeClr val="accent1"/>
+          </a:fillRef>
+          <a:effectRef idx="0">
+            <a:schemeClr val="accent1"/>
+          </a:effectRef>
+          <a:fontRef idx="minor">
+            <a:schemeClr val="lt1"/>
+          </a:fontRef>
+        </p:style>
+        <p:txBody>
+          <a:bodyPr rtlCol="0" anchor="t"/>
+          <a:lstStyle/>
+          <a:p>
+            <a:pPr algn="ctr"/>
+            <a:r>
+              <a:rPr lang="en-US" dirty="0">
+                <a:solidFill>
+                  <a:schemeClr val="tx1"/>
+                </a:solidFill>
+              </a:rPr>
+              <a:t>Example Models</a:t>
+            </a:r>
+          </a:p>
+        </p:txBody>
+      </p:sp>
+      <p:sp>
+        <p:nvSpPr>
+          <p:cNvPr id="3" name="Rectangle: Rounded Corners 2">
+            <a:extLst>
+              <a:ext uri="{FF2B5EF4-FFF2-40B4-BE49-F238E27FC236}">
+                <a16:creationId xmlns:a16="http://schemas.microsoft.com/office/drawing/2014/main" id="{5574ED1F-143F-F0C3-860B-D1D1A94B8038}"/>
+              </a:ext>
+            </a:extLst>
+          </p:cNvPr>
+          <p:cNvSpPr/>
+          <p:nvPr/>
+        </p:nvSpPr>
+        <p:spPr>
+          <a:xfrm>
+            <a:off x="4778916" y="1188720"/>
+            <a:ext cx="2634168" cy="2335531"/>
+          </a:xfrm>
+          <a:prstGeom prst="roundRect">
+            <a:avLst/>
+          </a:prstGeom>
+          <a:solidFill>
+            <a:srgbClr val="E5F1F8"/>
+          </a:solidFill>
+          <a:ln>
+            <a:solidFill>
+              <a:schemeClr val="tx1"/>
+            </a:solidFill>
+          </a:ln>
+        </p:spPr>
+        <p:style>
+          <a:lnRef idx="2">
+            <a:schemeClr val="accent1">
+              <a:shade val="15000"/>
+            </a:schemeClr>
+          </a:lnRef>
+          <a:fillRef idx="1">
+            <a:schemeClr val="accent1"/>
+          </a:fillRef>
+          <a:effectRef idx="0">
+            <a:schemeClr val="accent1"/>
+          </a:effectRef>
+          <a:fontRef idx="minor">
+            <a:schemeClr val="lt1"/>
+          </a:fontRef>
+        </p:style>
+        <p:txBody>
+          <a:bodyPr rtlCol="0" anchor="t"/>
+          <a:lstStyle/>
+          <a:p>
+            <a:pPr algn="ctr"/>
+            <a:r>
+              <a:rPr lang="en-US" dirty="0">
+                <a:solidFill>
+                  <a:schemeClr val="tx1"/>
+                </a:solidFill>
+              </a:rPr>
+              <a:t>Anthropic</a:t>
+            </a:r>
+          </a:p>
+        </p:txBody>
+      </p:sp>
+      <p:sp>
+        <p:nvSpPr>
+          <p:cNvPr id="4" name="Rectangle: Rounded Corners 3">
+            <a:extLst>
+              <a:ext uri="{FF2B5EF4-FFF2-40B4-BE49-F238E27FC236}">
+                <a16:creationId xmlns:a16="http://schemas.microsoft.com/office/drawing/2014/main" id="{CB92B3E5-A0FB-4F52-03FE-A3994B4A676E}"/>
+              </a:ext>
+            </a:extLst>
+          </p:cNvPr>
+          <p:cNvSpPr/>
+          <p:nvPr/>
+        </p:nvSpPr>
+        <p:spPr>
+          <a:xfrm>
+            <a:off x="1553658" y="1188720"/>
+            <a:ext cx="2634168" cy="2335531"/>
+          </a:xfrm>
+          <a:prstGeom prst="roundRect">
+            <a:avLst/>
+          </a:prstGeom>
+          <a:solidFill>
+            <a:srgbClr val="E5F1F8"/>
+          </a:solidFill>
+          <a:ln>
+            <a:solidFill>
+              <a:schemeClr val="tx1"/>
+            </a:solidFill>
+          </a:ln>
+        </p:spPr>
+        <p:style>
+          <a:lnRef idx="2">
+            <a:schemeClr val="accent1">
+              <a:shade val="15000"/>
+            </a:schemeClr>
+          </a:lnRef>
+          <a:fillRef idx="1">
+            <a:schemeClr val="accent1"/>
+          </a:fillRef>
+          <a:effectRef idx="0">
+            <a:schemeClr val="accent1"/>
+          </a:effectRef>
+          <a:fontRef idx="minor">
+            <a:schemeClr val="lt1"/>
+          </a:fontRef>
+        </p:style>
+        <p:txBody>
+          <a:bodyPr rtlCol="0" anchor="t"/>
+          <a:lstStyle/>
+          <a:p>
+            <a:pPr algn="ctr"/>
+            <a:r>
+              <a:rPr lang="en-US" dirty="0">
+                <a:solidFill>
+                  <a:schemeClr val="tx1"/>
+                </a:solidFill>
+              </a:rPr>
+              <a:t>Azure OpenAI</a:t>
+            </a:r>
+          </a:p>
+        </p:txBody>
+      </p:sp>
+      <p:sp>
+        <p:nvSpPr>
+          <p:cNvPr id="5" name="Rectangle: Rounded Corners 4">
+            <a:extLst>
+              <a:ext uri="{FF2B5EF4-FFF2-40B4-BE49-F238E27FC236}">
+                <a16:creationId xmlns:a16="http://schemas.microsoft.com/office/drawing/2014/main" id="{ACE8A258-9DE7-F4AF-1449-211286E0D11E}"/>
+              </a:ext>
+            </a:extLst>
+          </p:cNvPr>
+          <p:cNvSpPr/>
+          <p:nvPr/>
+        </p:nvSpPr>
+        <p:spPr>
+          <a:xfrm>
+            <a:off x="8004174" y="1188720"/>
+            <a:ext cx="2634168" cy="2335531"/>
+          </a:xfrm>
+          <a:prstGeom prst="roundRect">
+            <a:avLst/>
+          </a:prstGeom>
+          <a:solidFill>
+            <a:srgbClr val="E5F1F8"/>
+          </a:solidFill>
+          <a:ln>
+            <a:solidFill>
+              <a:schemeClr val="tx1"/>
+            </a:solidFill>
+          </a:ln>
+        </p:spPr>
+        <p:style>
+          <a:lnRef idx="2">
+            <a:schemeClr val="accent1">
+              <a:shade val="15000"/>
+            </a:schemeClr>
+          </a:lnRef>
+          <a:fillRef idx="1">
+            <a:schemeClr val="accent1"/>
+          </a:fillRef>
+          <a:effectRef idx="0">
+            <a:schemeClr val="accent1"/>
+          </a:effectRef>
+          <a:fontRef idx="minor">
+            <a:schemeClr val="lt1"/>
+          </a:fontRef>
+        </p:style>
+        <p:txBody>
+          <a:bodyPr rtlCol="0" anchor="t"/>
+          <a:lstStyle/>
+          <a:p>
+            <a:pPr algn="ctr"/>
+            <a:r>
+              <a:rPr lang="en-US" dirty="0">
+                <a:solidFill>
+                  <a:schemeClr val="tx1"/>
+                </a:solidFill>
+              </a:rPr>
+              <a:t>Microsoft</a:t>
+            </a:r>
+          </a:p>
+        </p:txBody>
+      </p:sp>
+      <p:sp>
+        <p:nvSpPr>
+          <p:cNvPr id="6" name="Rectangle: Rounded Corners 5">
+            <a:extLst>
+              <a:ext uri="{FF2B5EF4-FFF2-40B4-BE49-F238E27FC236}">
+                <a16:creationId xmlns:a16="http://schemas.microsoft.com/office/drawing/2014/main" id="{417ADCD0-E7DE-9B18-898C-7D55B783F694}"/>
+              </a:ext>
+            </a:extLst>
+          </p:cNvPr>
+          <p:cNvSpPr/>
+          <p:nvPr/>
+        </p:nvSpPr>
+        <p:spPr>
+          <a:xfrm>
+            <a:off x="4778916" y="3653789"/>
+            <a:ext cx="2634168" cy="2335531"/>
+          </a:xfrm>
+          <a:prstGeom prst="roundRect">
+            <a:avLst/>
+          </a:prstGeom>
+          <a:solidFill>
+            <a:srgbClr val="E5F1F8"/>
+          </a:solidFill>
+          <a:ln>
+            <a:solidFill>
+              <a:schemeClr val="tx1"/>
+            </a:solidFill>
+          </a:ln>
+        </p:spPr>
+        <p:style>
+          <a:lnRef idx="2">
+            <a:schemeClr val="accent1">
+              <a:shade val="15000"/>
+            </a:schemeClr>
+          </a:lnRef>
+          <a:fillRef idx="1">
+            <a:schemeClr val="accent1"/>
+          </a:fillRef>
+          <a:effectRef idx="0">
+            <a:schemeClr val="accent1"/>
+          </a:effectRef>
+          <a:fontRef idx="minor">
+            <a:schemeClr val="lt1"/>
+          </a:fontRef>
+        </p:style>
+        <p:txBody>
+          <a:bodyPr rtlCol="0" anchor="t"/>
+          <a:lstStyle/>
+          <a:p>
+            <a:pPr algn="ctr"/>
+            <a:r>
+              <a:rPr lang="en-US" dirty="0">
+                <a:solidFill>
+                  <a:schemeClr val="tx1"/>
+                </a:solidFill>
+              </a:rPr>
+              <a:t>Mistral AI</a:t>
+            </a:r>
+          </a:p>
+        </p:txBody>
+      </p:sp>
+      <p:sp>
+        <p:nvSpPr>
+          <p:cNvPr id="7" name="Rectangle: Rounded Corners 6">
+            <a:extLst>
+              <a:ext uri="{FF2B5EF4-FFF2-40B4-BE49-F238E27FC236}">
+                <a16:creationId xmlns:a16="http://schemas.microsoft.com/office/drawing/2014/main" id="{A55125DD-7A11-66B1-DDF5-ECD5D6C1F69B}"/>
+              </a:ext>
+            </a:extLst>
+          </p:cNvPr>
+          <p:cNvSpPr/>
+          <p:nvPr/>
+        </p:nvSpPr>
+        <p:spPr>
+          <a:xfrm>
+            <a:off x="1553658" y="3653789"/>
+            <a:ext cx="2634168" cy="2335531"/>
+          </a:xfrm>
+          <a:prstGeom prst="roundRect">
+            <a:avLst/>
+          </a:prstGeom>
+          <a:solidFill>
+            <a:srgbClr val="E5F1F8"/>
+          </a:solidFill>
+          <a:ln>
+            <a:solidFill>
+              <a:schemeClr val="tx1"/>
+            </a:solidFill>
+          </a:ln>
+        </p:spPr>
+        <p:style>
+          <a:lnRef idx="2">
+            <a:schemeClr val="accent1">
+              <a:shade val="15000"/>
+            </a:schemeClr>
+          </a:lnRef>
+          <a:fillRef idx="1">
+            <a:schemeClr val="accent1"/>
+          </a:fillRef>
+          <a:effectRef idx="0">
+            <a:schemeClr val="accent1"/>
+          </a:effectRef>
+          <a:fontRef idx="minor">
+            <a:schemeClr val="lt1"/>
+          </a:fontRef>
+        </p:style>
+        <p:txBody>
+          <a:bodyPr rtlCol="0" anchor="t"/>
+          <a:lstStyle/>
+          <a:p>
+            <a:pPr algn="ctr"/>
+            <a:r>
+              <a:rPr lang="en-US" dirty="0">
+                <a:solidFill>
+                  <a:schemeClr val="tx1"/>
+                </a:solidFill>
+              </a:rPr>
+              <a:t>Meta</a:t>
+            </a:r>
+          </a:p>
+        </p:txBody>
+      </p:sp>
+      <p:sp>
+        <p:nvSpPr>
+          <p:cNvPr id="8" name="Rectangle: Rounded Corners 7">
+            <a:extLst>
+              <a:ext uri="{FF2B5EF4-FFF2-40B4-BE49-F238E27FC236}">
+                <a16:creationId xmlns:a16="http://schemas.microsoft.com/office/drawing/2014/main" id="{4D8433B6-E222-52DE-3420-6BC81E4D9945}"/>
+              </a:ext>
+            </a:extLst>
+          </p:cNvPr>
+          <p:cNvSpPr/>
+          <p:nvPr/>
+        </p:nvSpPr>
+        <p:spPr>
+          <a:xfrm>
+            <a:off x="8004174" y="3653789"/>
+            <a:ext cx="2634168" cy="2335531"/>
+          </a:xfrm>
+          <a:prstGeom prst="roundRect">
+            <a:avLst/>
+          </a:prstGeom>
+          <a:solidFill>
+            <a:srgbClr val="E5F1F8"/>
+          </a:solidFill>
+          <a:ln>
+            <a:solidFill>
+              <a:schemeClr val="tx1"/>
+            </a:solidFill>
+          </a:ln>
+        </p:spPr>
+        <p:style>
+          <a:lnRef idx="2">
+            <a:schemeClr val="accent1">
+              <a:shade val="15000"/>
+            </a:schemeClr>
+          </a:lnRef>
+          <a:fillRef idx="1">
+            <a:schemeClr val="accent1"/>
+          </a:fillRef>
+          <a:effectRef idx="0">
+            <a:schemeClr val="accent1"/>
+          </a:effectRef>
+          <a:fontRef idx="minor">
+            <a:schemeClr val="lt1"/>
+          </a:fontRef>
+        </p:style>
+        <p:txBody>
+          <a:bodyPr rtlCol="0" anchor="t"/>
+          <a:lstStyle/>
+          <a:p>
+            <a:pPr algn="ctr"/>
+            <a:r>
+              <a:rPr lang="en-US" dirty="0">
+                <a:solidFill>
+                  <a:schemeClr val="tx1"/>
+                </a:solidFill>
+              </a:rPr>
+              <a:t>DeepSeek</a:t>
+            </a:r>
+          </a:p>
+        </p:txBody>
+      </p:sp>
+      <p:sp>
+        <p:nvSpPr>
+          <p:cNvPr id="10" name="Rectangle: Rounded Corners 9">
+            <a:extLst>
+              <a:ext uri="{FF2B5EF4-FFF2-40B4-BE49-F238E27FC236}">
+                <a16:creationId xmlns:a16="http://schemas.microsoft.com/office/drawing/2014/main" id="{02E5EA1C-587E-4A45-E606-F67DF515B407}"/>
+              </a:ext>
+            </a:extLst>
+          </p:cNvPr>
+          <p:cNvSpPr/>
+          <p:nvPr/>
+        </p:nvSpPr>
+        <p:spPr>
+          <a:xfrm>
+            <a:off x="1790700" y="1882140"/>
+            <a:ext cx="2111892" cy="322508"/>
+          </a:xfrm>
+          <a:prstGeom prst="roundRect">
+            <a:avLst>
+              <a:gd name="adj" fmla="val 50000"/>
+            </a:avLst>
+          </a:prstGeom>
+          <a:solidFill>
+            <a:srgbClr val="B2D4EB"/>
+          </a:solidFill>
+          <a:ln>
+            <a:solidFill>
+              <a:schemeClr val="tx1"/>
+            </a:solidFill>
+          </a:ln>
+        </p:spPr>
+        <p:style>
+          <a:lnRef idx="2">
+            <a:schemeClr val="accent1">
+              <a:shade val="15000"/>
+            </a:schemeClr>
+          </a:lnRef>
+          <a:fillRef idx="1">
+            <a:schemeClr val="accent1"/>
+          </a:fillRef>
+          <a:effectRef idx="0">
+            <a:schemeClr val="accent1"/>
+          </a:effectRef>
+          <a:fontRef idx="minor">
+            <a:schemeClr val="lt1"/>
+          </a:fontRef>
+        </p:style>
+        <p:txBody>
+          <a:bodyPr rtlCol="0" anchor="ctr"/>
+          <a:lstStyle/>
+          <a:p>
+            <a:pPr algn="ctr"/>
+            <a:r>
+              <a:rPr lang="en-US" dirty="0" err="1">
+                <a:solidFill>
+                  <a:schemeClr val="tx1"/>
+                </a:solidFill>
+              </a:rPr>
+              <a:t>gpt</a:t>
+            </a:r>
+            <a:endParaRPr lang="en-US" i="1" dirty="0">
+              <a:solidFill>
+                <a:schemeClr val="tx1"/>
+              </a:solidFill>
+            </a:endParaRPr>
+          </a:p>
+        </p:txBody>
+      </p:sp>
+      <p:sp>
+        <p:nvSpPr>
+          <p:cNvPr id="11" name="Rectangle: Rounded Corners 10">
+            <a:extLst>
+              <a:ext uri="{FF2B5EF4-FFF2-40B4-BE49-F238E27FC236}">
+                <a16:creationId xmlns:a16="http://schemas.microsoft.com/office/drawing/2014/main" id="{E11D9861-1EDA-793B-0AA0-18BFA52ACCE4}"/>
+              </a:ext>
+            </a:extLst>
+          </p:cNvPr>
+          <p:cNvSpPr/>
+          <p:nvPr/>
+        </p:nvSpPr>
+        <p:spPr>
+          <a:xfrm>
+            <a:off x="1790700" y="2380687"/>
+            <a:ext cx="2111892" cy="322508"/>
+          </a:xfrm>
+          <a:prstGeom prst="roundRect">
+            <a:avLst>
+              <a:gd name="adj" fmla="val 50000"/>
+            </a:avLst>
+          </a:prstGeom>
+          <a:solidFill>
+            <a:srgbClr val="B2D4EB"/>
+          </a:solidFill>
+          <a:ln>
+            <a:solidFill>
+              <a:schemeClr val="tx1"/>
+            </a:solidFill>
+          </a:ln>
+        </p:spPr>
+        <p:style>
+          <a:lnRef idx="2">
+            <a:schemeClr val="accent1">
+              <a:shade val="15000"/>
+            </a:schemeClr>
+          </a:lnRef>
+          <a:fillRef idx="1">
+            <a:schemeClr val="accent1"/>
+          </a:fillRef>
+          <a:effectRef idx="0">
+            <a:schemeClr val="accent1"/>
+          </a:effectRef>
+          <a:fontRef idx="minor">
+            <a:schemeClr val="lt1"/>
+          </a:fontRef>
+        </p:style>
+        <p:txBody>
+          <a:bodyPr rtlCol="0" anchor="ctr"/>
+          <a:lstStyle/>
+          <a:p>
+            <a:pPr algn="ctr"/>
+            <a:r>
+              <a:rPr lang="en-US" dirty="0">
+                <a:solidFill>
+                  <a:schemeClr val="tx1"/>
+                </a:solidFill>
+              </a:rPr>
+              <a:t>o</a:t>
+            </a:r>
+          </a:p>
+        </p:txBody>
+      </p:sp>
+      <p:sp>
+        <p:nvSpPr>
+          <p:cNvPr id="12" name="Rectangle: Rounded Corners 11">
+            <a:extLst>
+              <a:ext uri="{FF2B5EF4-FFF2-40B4-BE49-F238E27FC236}">
+                <a16:creationId xmlns:a16="http://schemas.microsoft.com/office/drawing/2014/main" id="{46BFDC7A-CED3-C375-66E6-683B9E52EDD1}"/>
+              </a:ext>
+            </a:extLst>
+          </p:cNvPr>
+          <p:cNvSpPr/>
+          <p:nvPr/>
+        </p:nvSpPr>
+        <p:spPr>
+          <a:xfrm>
+            <a:off x="1790700" y="2879234"/>
+            <a:ext cx="2111892" cy="322508"/>
+          </a:xfrm>
+          <a:prstGeom prst="roundRect">
+            <a:avLst>
+              <a:gd name="adj" fmla="val 50000"/>
+            </a:avLst>
+          </a:prstGeom>
+          <a:solidFill>
+            <a:srgbClr val="B2D4EB"/>
+          </a:solidFill>
+          <a:ln>
+            <a:solidFill>
+              <a:schemeClr val="tx1"/>
+            </a:solidFill>
+          </a:ln>
+        </p:spPr>
+        <p:style>
+          <a:lnRef idx="2">
+            <a:schemeClr val="accent1">
+              <a:shade val="15000"/>
+            </a:schemeClr>
+          </a:lnRef>
+          <a:fillRef idx="1">
+            <a:schemeClr val="accent1"/>
+          </a:fillRef>
+          <a:effectRef idx="0">
+            <a:schemeClr val="accent1"/>
+          </a:effectRef>
+          <a:fontRef idx="minor">
+            <a:schemeClr val="lt1"/>
+          </a:fontRef>
+        </p:style>
+        <p:txBody>
+          <a:bodyPr rtlCol="0" anchor="ctr"/>
+          <a:lstStyle/>
+          <a:p>
+            <a:pPr algn="ctr"/>
+            <a:r>
+              <a:rPr lang="en-US" dirty="0">
+                <a:solidFill>
+                  <a:schemeClr val="tx1"/>
+                </a:solidFill>
+              </a:rPr>
+              <a:t>sora</a:t>
+            </a:r>
+          </a:p>
+        </p:txBody>
+      </p:sp>
+    </p:spTree>
+    <p:extLst>
+      <p:ext uri="{BB962C8B-B14F-4D97-AF65-F5344CB8AC3E}">
+        <p14:creationId xmlns:p14="http://schemas.microsoft.com/office/powerpoint/2010/main" val="2145715379"/>
+      </p:ext>
+    </p:extLst>
+  </p:cSld>
+  <p:clrMapOvr>
+    <a:masterClrMapping/>
+  </p:clrMapOvr>
+</p:sld>
+</file>
+
+<file path=ppt/slides/slide6.xml><?xml version="1.0" encoding="utf-8"?>
+<p:sld xmlns:a="http://schemas.openxmlformats.org/drawingml/2006/main" xmlns:r="http://schemas.openxmlformats.org/officeDocument/2006/relationships" xmlns:p="http://schemas.openxmlformats.org/presentationml/2006/main">
+  <p:cSld>
+    <p:spTree>
+      <p:nvGrpSpPr>
+        <p:cNvPr id="1" name=""/>
+        <p:cNvGrpSpPr/>
+        <p:nvPr/>
+      </p:nvGrpSpPr>
+      <p:grpSpPr>
+        <a:xfrm>
+          <a:off x="0" y="0"/>
+          <a:ext cx="0" cy="0"/>
+          <a:chOff x="0" y="0"/>
+          <a:chExt cx="0" cy="0"/>
+        </a:xfrm>
+      </p:grpSpPr>
+      <p:sp>
+        <p:nvSpPr>
           <p:cNvPr id="5" name="TextBox 4">
             <a:extLst>
               <a:ext uri="{FF2B5EF4-FFF2-40B4-BE49-F238E27FC236}">
@@ -5133,7 +7421,7 @@
 </p:sld>
 </file>
 
-<file path=ppt/slides/slide5.xml><?xml version="1.0" encoding="utf-8"?>
+<file path=ppt/slides/slide7.xml><?xml version="1.0" encoding="utf-8"?>
 <p:sld xmlns:a="http://schemas.openxmlformats.org/drawingml/2006/main" xmlns:r="http://schemas.openxmlformats.org/officeDocument/2006/relationships" xmlns:p="http://schemas.openxmlformats.org/presentationml/2006/main">
   <p:cSld>
     <p:spTree>
@@ -5867,7 +8155,7 @@
 </p:sld>
 </file>
 
-<file path=ppt/slides/slide6.xml><?xml version="1.0" encoding="utf-8"?>
+<file path=ppt/slides/slide8.xml><?xml version="1.0" encoding="utf-8"?>
 <p:sld xmlns:a="http://schemas.openxmlformats.org/drawingml/2006/main" xmlns:r="http://schemas.openxmlformats.org/officeDocument/2006/relationships" xmlns:p="http://schemas.openxmlformats.org/presentationml/2006/main">
   <p:cSld>
     <p:spTree>

</xml_diff>

<commit_message>
Update Ch03 based on MC 20260225 comments
</commit_message>
<xml_diff>
--- a/figures/figures.pptx
+++ b/figures/figures.pptx
@@ -5,7 +5,7 @@
     <p:sldMasterId id="2147483660" r:id="rId1"/>
   </p:sldMasterIdLst>
   <p:notesMasterIdLst>
-    <p:notesMasterId r:id="rId20"/>
+    <p:notesMasterId r:id="rId21"/>
   </p:notesMasterIdLst>
   <p:sldIdLst>
     <p:sldId id="258" r:id="rId2"/>
@@ -15,17 +15,18 @@
     <p:sldId id="259" r:id="rId6"/>
     <p:sldId id="261" r:id="rId7"/>
     <p:sldId id="268" r:id="rId8"/>
-    <p:sldId id="262" r:id="rId9"/>
-    <p:sldId id="264" r:id="rId10"/>
-    <p:sldId id="265" r:id="rId11"/>
-    <p:sldId id="267" r:id="rId12"/>
-    <p:sldId id="269" r:id="rId13"/>
-    <p:sldId id="274" r:id="rId14"/>
-    <p:sldId id="270" r:id="rId15"/>
-    <p:sldId id="271" r:id="rId16"/>
-    <p:sldId id="272" r:id="rId17"/>
-    <p:sldId id="273" r:id="rId18"/>
-    <p:sldId id="257" r:id="rId19"/>
+    <p:sldId id="275" r:id="rId9"/>
+    <p:sldId id="262" r:id="rId10"/>
+    <p:sldId id="264" r:id="rId11"/>
+    <p:sldId id="265" r:id="rId12"/>
+    <p:sldId id="267" r:id="rId13"/>
+    <p:sldId id="269" r:id="rId14"/>
+    <p:sldId id="274" r:id="rId15"/>
+    <p:sldId id="270" r:id="rId16"/>
+    <p:sldId id="271" r:id="rId17"/>
+    <p:sldId id="272" r:id="rId18"/>
+    <p:sldId id="273" r:id="rId19"/>
+    <p:sldId id="257" r:id="rId20"/>
   </p:sldIdLst>
   <p:sldSz cx="12192000" cy="6858000"/>
   <p:notesSz cx="6858000" cy="9144000"/>
@@ -148,6 +149,7 @@
           <p14:sldIdLst>
             <p14:sldId id="261"/>
             <p14:sldId id="268"/>
+            <p14:sldId id="275"/>
           </p14:sldIdLst>
         </p14:section>
         <p14:section name="Knowledge Bases" id="{06E034E2-AFC7-4A28-B1B0-B4E2903C9A55}">
@@ -268,7 +270,7 @@
           <a:p>
             <a:fld id="{DAABB0E5-6D8D-4DEE-B75F-67010CF2307C}" type="datetimeFigureOut">
               <a:rPr lang="en-US" smtClean="0"/>
-              <a:t>2/19/2026</a:t>
+              <a:t>2/26/2026</a:t>
             </a:fld>
             <a:endParaRPr lang="en-US"/>
           </a:p>
@@ -953,7 +955,7 @@
           <a:p>
             <a:fld id="{B84C5C40-2055-49AF-9028-5DA79E75E391}" type="datetimeFigureOut">
               <a:rPr lang="en-US" smtClean="0"/>
-              <a:t>2/19/2026</a:t>
+              <a:t>2/26/2026</a:t>
             </a:fld>
             <a:endParaRPr lang="en-US"/>
           </a:p>
@@ -1123,7 +1125,7 @@
           <a:p>
             <a:fld id="{B84C5C40-2055-49AF-9028-5DA79E75E391}" type="datetimeFigureOut">
               <a:rPr lang="en-US" smtClean="0"/>
-              <a:t>2/19/2026</a:t>
+              <a:t>2/26/2026</a:t>
             </a:fld>
             <a:endParaRPr lang="en-US"/>
           </a:p>
@@ -1303,7 +1305,7 @@
           <a:p>
             <a:fld id="{B84C5C40-2055-49AF-9028-5DA79E75E391}" type="datetimeFigureOut">
               <a:rPr lang="en-US" smtClean="0"/>
-              <a:t>2/19/2026</a:t>
+              <a:t>2/26/2026</a:t>
             </a:fld>
             <a:endParaRPr lang="en-US"/>
           </a:p>
@@ -1473,7 +1475,7 @@
           <a:p>
             <a:fld id="{B84C5C40-2055-49AF-9028-5DA79E75E391}" type="datetimeFigureOut">
               <a:rPr lang="en-US" smtClean="0"/>
-              <a:t>2/19/2026</a:t>
+              <a:t>2/26/2026</a:t>
             </a:fld>
             <a:endParaRPr lang="en-US"/>
           </a:p>
@@ -1719,7 +1721,7 @@
           <a:p>
             <a:fld id="{B84C5C40-2055-49AF-9028-5DA79E75E391}" type="datetimeFigureOut">
               <a:rPr lang="en-US" smtClean="0"/>
-              <a:t>2/19/2026</a:t>
+              <a:t>2/26/2026</a:t>
             </a:fld>
             <a:endParaRPr lang="en-US"/>
           </a:p>
@@ -1951,7 +1953,7 @@
           <a:p>
             <a:fld id="{B84C5C40-2055-49AF-9028-5DA79E75E391}" type="datetimeFigureOut">
               <a:rPr lang="en-US" smtClean="0"/>
-              <a:t>2/19/2026</a:t>
+              <a:t>2/26/2026</a:t>
             </a:fld>
             <a:endParaRPr lang="en-US"/>
           </a:p>
@@ -2318,7 +2320,7 @@
           <a:p>
             <a:fld id="{B84C5C40-2055-49AF-9028-5DA79E75E391}" type="datetimeFigureOut">
               <a:rPr lang="en-US" smtClean="0"/>
-              <a:t>2/19/2026</a:t>
+              <a:t>2/26/2026</a:t>
             </a:fld>
             <a:endParaRPr lang="en-US"/>
           </a:p>
@@ -2436,7 +2438,7 @@
           <a:p>
             <a:fld id="{B84C5C40-2055-49AF-9028-5DA79E75E391}" type="datetimeFigureOut">
               <a:rPr lang="en-US" smtClean="0"/>
-              <a:t>2/19/2026</a:t>
+              <a:t>2/26/2026</a:t>
             </a:fld>
             <a:endParaRPr lang="en-US"/>
           </a:p>
@@ -2531,7 +2533,7 @@
           <a:p>
             <a:fld id="{B84C5C40-2055-49AF-9028-5DA79E75E391}" type="datetimeFigureOut">
               <a:rPr lang="en-US" smtClean="0"/>
-              <a:t>2/19/2026</a:t>
+              <a:t>2/26/2026</a:t>
             </a:fld>
             <a:endParaRPr lang="en-US"/>
           </a:p>
@@ -2808,7 +2810,7 @@
           <a:p>
             <a:fld id="{B84C5C40-2055-49AF-9028-5DA79E75E391}" type="datetimeFigureOut">
               <a:rPr lang="en-US" smtClean="0"/>
-              <a:t>2/19/2026</a:t>
+              <a:t>2/26/2026</a:t>
             </a:fld>
             <a:endParaRPr lang="en-US"/>
           </a:p>
@@ -3065,7 +3067,7 @@
           <a:p>
             <a:fld id="{B84C5C40-2055-49AF-9028-5DA79E75E391}" type="datetimeFigureOut">
               <a:rPr lang="en-US" smtClean="0"/>
-              <a:t>2/19/2026</a:t>
+              <a:t>2/26/2026</a:t>
             </a:fld>
             <a:endParaRPr lang="en-US"/>
           </a:p>
@@ -3278,7 +3280,7 @@
           <a:p>
             <a:fld id="{B84C5C40-2055-49AF-9028-5DA79E75E391}" type="datetimeFigureOut">
               <a:rPr lang="en-US" smtClean="0"/>
-              <a:t>2/19/2026</a:t>
+              <a:t>2/26/2026</a:t>
             </a:fld>
             <a:endParaRPr lang="en-US"/>
           </a:p>
@@ -3771,12 +3773,1067 @@
           <a:chExt cx="0" cy="0"/>
         </a:xfrm>
       </p:grpSpPr>
+      <p:sp>
+        <p:nvSpPr>
+          <p:cNvPr id="2" name="Rectangle: Rounded Corners 1">
+            <a:extLst>
+              <a:ext uri="{FF2B5EF4-FFF2-40B4-BE49-F238E27FC236}">
+                <a16:creationId xmlns:a16="http://schemas.microsoft.com/office/drawing/2014/main" id="{F09FDC59-6067-4502-1360-F42554AD87D3}"/>
+              </a:ext>
+            </a:extLst>
+          </p:cNvPr>
+          <p:cNvSpPr/>
+          <p:nvPr/>
+        </p:nvSpPr>
+        <p:spPr>
+          <a:xfrm>
+            <a:off x="4046220" y="3398520"/>
+            <a:ext cx="4282440" cy="457200"/>
+          </a:xfrm>
+          <a:prstGeom prst="roundRect">
+            <a:avLst/>
+          </a:prstGeom>
+          <a:solidFill>
+            <a:srgbClr val="B2D4EB"/>
+          </a:solidFill>
+          <a:ln>
+            <a:solidFill>
+              <a:schemeClr val="tx1"/>
+            </a:solidFill>
+          </a:ln>
+        </p:spPr>
+        <p:style>
+          <a:lnRef idx="2">
+            <a:schemeClr val="accent1">
+              <a:shade val="15000"/>
+            </a:schemeClr>
+          </a:lnRef>
+          <a:fillRef idx="1">
+            <a:schemeClr val="accent1"/>
+          </a:fillRef>
+          <a:effectRef idx="0">
+            <a:schemeClr val="accent1"/>
+          </a:effectRef>
+          <a:fontRef idx="minor">
+            <a:schemeClr val="lt1"/>
+          </a:fontRef>
+        </p:style>
+        <p:txBody>
+          <a:bodyPr rtlCol="0" anchor="ctr"/>
+          <a:lstStyle/>
+          <a:p>
+            <a:pPr algn="ctr"/>
+            <a:r>
+              <a:rPr lang="en-US" dirty="0">
+                <a:solidFill>
+                  <a:schemeClr val="tx1"/>
+                </a:solidFill>
+              </a:rPr>
+              <a:t>Search Public Information on the Web</a:t>
+            </a:r>
+            <a:endParaRPr lang="en-US" i="1" dirty="0">
+              <a:solidFill>
+                <a:schemeClr val="tx1"/>
+              </a:solidFill>
+            </a:endParaRPr>
+          </a:p>
+        </p:txBody>
+      </p:sp>
+      <p:sp>
+        <p:nvSpPr>
+          <p:cNvPr id="3" name="Rectangle: Rounded Corners 2">
+            <a:extLst>
+              <a:ext uri="{FF2B5EF4-FFF2-40B4-BE49-F238E27FC236}">
+                <a16:creationId xmlns:a16="http://schemas.microsoft.com/office/drawing/2014/main" id="{9800FF13-E208-2C00-EB7C-BCBA48F554BD}"/>
+              </a:ext>
+            </a:extLst>
+          </p:cNvPr>
+          <p:cNvSpPr/>
+          <p:nvPr/>
+        </p:nvSpPr>
+        <p:spPr>
+          <a:xfrm>
+            <a:off x="4046220" y="2625554"/>
+            <a:ext cx="4282440" cy="457200"/>
+          </a:xfrm>
+          <a:prstGeom prst="roundRect">
+            <a:avLst/>
+          </a:prstGeom>
+          <a:solidFill>
+            <a:srgbClr val="B2D4EB"/>
+          </a:solidFill>
+          <a:ln>
+            <a:solidFill>
+              <a:schemeClr val="tx1"/>
+            </a:solidFill>
+          </a:ln>
+        </p:spPr>
+        <p:style>
+          <a:lnRef idx="2">
+            <a:schemeClr val="accent1">
+              <a:shade val="15000"/>
+            </a:schemeClr>
+          </a:lnRef>
+          <a:fillRef idx="1">
+            <a:schemeClr val="accent1"/>
+          </a:fillRef>
+          <a:effectRef idx="0">
+            <a:schemeClr val="accent1"/>
+          </a:effectRef>
+          <a:fontRef idx="minor">
+            <a:schemeClr val="lt1"/>
+          </a:fontRef>
+        </p:style>
+        <p:txBody>
+          <a:bodyPr rtlCol="0" anchor="ctr"/>
+          <a:lstStyle/>
+          <a:p>
+            <a:pPr algn="ctr"/>
+            <a:r>
+              <a:rPr lang="en-US" dirty="0">
+                <a:solidFill>
+                  <a:schemeClr val="tx1"/>
+                </a:solidFill>
+              </a:rPr>
+              <a:t>Retrieve Stock Quotes from an API</a:t>
+            </a:r>
+            <a:endParaRPr lang="en-US" i="1" dirty="0">
+              <a:solidFill>
+                <a:schemeClr val="tx1"/>
+              </a:solidFill>
+            </a:endParaRPr>
+          </a:p>
+        </p:txBody>
+      </p:sp>
+      <p:sp>
+        <p:nvSpPr>
+          <p:cNvPr id="4" name="Rectangle: Rounded Corners 3">
+            <a:extLst>
+              <a:ext uri="{FF2B5EF4-FFF2-40B4-BE49-F238E27FC236}">
+                <a16:creationId xmlns:a16="http://schemas.microsoft.com/office/drawing/2014/main" id="{CD952C55-0F41-C8E8-4833-F5F86239B3AD}"/>
+              </a:ext>
+            </a:extLst>
+          </p:cNvPr>
+          <p:cNvSpPr/>
+          <p:nvPr/>
+        </p:nvSpPr>
+        <p:spPr>
+          <a:xfrm>
+            <a:off x="4046220" y="1855003"/>
+            <a:ext cx="4282440" cy="457200"/>
+          </a:xfrm>
+          <a:prstGeom prst="roundRect">
+            <a:avLst/>
+          </a:prstGeom>
+          <a:solidFill>
+            <a:srgbClr val="B2D4EB"/>
+          </a:solidFill>
+          <a:ln>
+            <a:solidFill>
+              <a:schemeClr val="tx1"/>
+            </a:solidFill>
+          </a:ln>
+        </p:spPr>
+        <p:style>
+          <a:lnRef idx="2">
+            <a:schemeClr val="accent1">
+              <a:shade val="15000"/>
+            </a:schemeClr>
+          </a:lnRef>
+          <a:fillRef idx="1">
+            <a:schemeClr val="accent1"/>
+          </a:fillRef>
+          <a:effectRef idx="0">
+            <a:schemeClr val="accent1"/>
+          </a:effectRef>
+          <a:fontRef idx="minor">
+            <a:schemeClr val="lt1"/>
+          </a:fontRef>
+        </p:style>
+        <p:txBody>
+          <a:bodyPr rtlCol="0" anchor="ctr"/>
+          <a:lstStyle/>
+          <a:p>
+            <a:pPr algn="ctr"/>
+            <a:r>
+              <a:rPr lang="en-US" dirty="0">
+                <a:solidFill>
+                  <a:schemeClr val="tx1"/>
+                </a:solidFill>
+              </a:rPr>
+              <a:t>Reference Internal Report Files</a:t>
+            </a:r>
+            <a:endParaRPr lang="en-US" i="1" dirty="0">
+              <a:solidFill>
+                <a:schemeClr val="tx1"/>
+              </a:solidFill>
+            </a:endParaRPr>
+          </a:p>
+        </p:txBody>
+      </p:sp>
+      <p:sp>
+        <p:nvSpPr>
+          <p:cNvPr id="5" name="Rectangle: Rounded Corners 4">
+            <a:extLst>
+              <a:ext uri="{FF2B5EF4-FFF2-40B4-BE49-F238E27FC236}">
+                <a16:creationId xmlns:a16="http://schemas.microsoft.com/office/drawing/2014/main" id="{600226F7-C833-1B1C-B967-7291F64244CC}"/>
+              </a:ext>
+            </a:extLst>
+          </p:cNvPr>
+          <p:cNvSpPr/>
+          <p:nvPr/>
+        </p:nvSpPr>
+        <p:spPr>
+          <a:xfrm>
+            <a:off x="1507938" y="2374095"/>
+            <a:ext cx="1913442" cy="960119"/>
+          </a:xfrm>
+          <a:prstGeom prst="roundRect">
+            <a:avLst/>
+          </a:prstGeom>
+          <a:solidFill>
+            <a:srgbClr val="E5F1F8"/>
+          </a:solidFill>
+          <a:ln>
+            <a:solidFill>
+              <a:schemeClr val="tx1"/>
+            </a:solidFill>
+          </a:ln>
+        </p:spPr>
+        <p:style>
+          <a:lnRef idx="2">
+            <a:schemeClr val="accent1">
+              <a:shade val="15000"/>
+            </a:schemeClr>
+          </a:lnRef>
+          <a:fillRef idx="1">
+            <a:schemeClr val="accent1"/>
+          </a:fillRef>
+          <a:effectRef idx="0">
+            <a:schemeClr val="accent1"/>
+          </a:effectRef>
+          <a:fontRef idx="minor">
+            <a:schemeClr val="lt1"/>
+          </a:fontRef>
+        </p:style>
+        <p:txBody>
+          <a:bodyPr rtlCol="0" anchor="ctr"/>
+          <a:lstStyle/>
+          <a:p>
+            <a:pPr algn="ctr"/>
+            <a:r>
+              <a:rPr lang="en-US" dirty="0">
+                <a:solidFill>
+                  <a:schemeClr val="tx1"/>
+                </a:solidFill>
+              </a:rPr>
+              <a:t>Query</a:t>
+            </a:r>
+          </a:p>
+          <a:p>
+            <a:pPr algn="ctr"/>
+            <a:r>
+              <a:rPr lang="en-US" dirty="0">
+                <a:solidFill>
+                  <a:schemeClr val="tx1"/>
+                </a:solidFill>
+              </a:rPr>
+              <a:t>Planning</a:t>
+            </a:r>
+          </a:p>
+        </p:txBody>
+      </p:sp>
+      <p:sp>
+        <p:nvSpPr>
+          <p:cNvPr id="6" name="Rectangle: Rounded Corners 5">
+            <a:extLst>
+              <a:ext uri="{FF2B5EF4-FFF2-40B4-BE49-F238E27FC236}">
+                <a16:creationId xmlns:a16="http://schemas.microsoft.com/office/drawing/2014/main" id="{C93C6EBF-0FE7-EC6E-5B5C-7AA41F6606DD}"/>
+              </a:ext>
+            </a:extLst>
+          </p:cNvPr>
+          <p:cNvSpPr/>
+          <p:nvPr/>
+        </p:nvSpPr>
+        <p:spPr>
+          <a:xfrm>
+            <a:off x="9837420" y="2374095"/>
+            <a:ext cx="1913442" cy="960119"/>
+          </a:xfrm>
+          <a:prstGeom prst="roundRect">
+            <a:avLst/>
+          </a:prstGeom>
+          <a:solidFill>
+            <a:srgbClr val="E5F1F8"/>
+          </a:solidFill>
+          <a:ln>
+            <a:solidFill>
+              <a:schemeClr val="tx1"/>
+            </a:solidFill>
+          </a:ln>
+        </p:spPr>
+        <p:style>
+          <a:lnRef idx="2">
+            <a:schemeClr val="accent1">
+              <a:shade val="15000"/>
+            </a:schemeClr>
+          </a:lnRef>
+          <a:fillRef idx="1">
+            <a:schemeClr val="accent1"/>
+          </a:fillRef>
+          <a:effectRef idx="0">
+            <a:schemeClr val="accent1"/>
+          </a:effectRef>
+          <a:fontRef idx="minor">
+            <a:schemeClr val="lt1"/>
+          </a:fontRef>
+        </p:style>
+        <p:txBody>
+          <a:bodyPr rtlCol="0" anchor="ctr"/>
+          <a:lstStyle/>
+          <a:p>
+            <a:pPr algn="ctr"/>
+            <a:r>
+              <a:rPr lang="en-US" dirty="0">
+                <a:solidFill>
+                  <a:schemeClr val="tx1"/>
+                </a:solidFill>
+              </a:rPr>
+              <a:t>Language</a:t>
+            </a:r>
+          </a:p>
+          <a:p>
+            <a:pPr algn="ctr"/>
+            <a:r>
+              <a:rPr lang="en-US" dirty="0">
+                <a:solidFill>
+                  <a:schemeClr val="tx1"/>
+                </a:solidFill>
+              </a:rPr>
+              <a:t>Model</a:t>
+            </a:r>
+          </a:p>
+        </p:txBody>
+      </p:sp>
+      <p:cxnSp>
+        <p:nvCxnSpPr>
+          <p:cNvPr id="7" name="Straight Arrow Connector 6">
+            <a:extLst>
+              <a:ext uri="{FF2B5EF4-FFF2-40B4-BE49-F238E27FC236}">
+                <a16:creationId xmlns:a16="http://schemas.microsoft.com/office/drawing/2014/main" id="{70FF9049-A038-5CD7-B5B6-A7A955E2687C}"/>
+              </a:ext>
+            </a:extLst>
+          </p:cNvPr>
+          <p:cNvCxnSpPr>
+            <a:cxnSpLocks/>
+            <a:stCxn id="5" idx="3"/>
+            <a:endCxn id="3" idx="1"/>
+          </p:cNvCxnSpPr>
+          <p:nvPr/>
+        </p:nvCxnSpPr>
+        <p:spPr>
+          <a:xfrm flipV="1">
+            <a:off x="3421380" y="2854154"/>
+            <a:ext cx="624840" cy="1"/>
+          </a:xfrm>
+          <a:prstGeom prst="straightConnector1">
+            <a:avLst/>
+          </a:prstGeom>
+          <a:ln>
+            <a:solidFill>
+              <a:schemeClr val="tx1"/>
+            </a:solidFill>
+            <a:prstDash val="solid"/>
+            <a:tailEnd type="triangle" w="lg" len="lg"/>
+          </a:ln>
+        </p:spPr>
+        <p:style>
+          <a:lnRef idx="2">
+            <a:schemeClr val="accent1"/>
+          </a:lnRef>
+          <a:fillRef idx="0">
+            <a:schemeClr val="accent1"/>
+          </a:fillRef>
+          <a:effectRef idx="1">
+            <a:schemeClr val="accent1"/>
+          </a:effectRef>
+          <a:fontRef idx="minor">
+            <a:schemeClr val="tx1"/>
+          </a:fontRef>
+        </p:style>
+      </p:cxnSp>
+      <p:cxnSp>
+        <p:nvCxnSpPr>
+          <p:cNvPr id="10" name="Straight Arrow Connector 9">
+            <a:extLst>
+              <a:ext uri="{FF2B5EF4-FFF2-40B4-BE49-F238E27FC236}">
+                <a16:creationId xmlns:a16="http://schemas.microsoft.com/office/drawing/2014/main" id="{2C10FC99-8029-AE13-0A3B-1F87064360AB}"/>
+              </a:ext>
+            </a:extLst>
+          </p:cNvPr>
+          <p:cNvCxnSpPr>
+            <a:cxnSpLocks/>
+            <a:stCxn id="44" idx="3"/>
+            <a:endCxn id="6" idx="1"/>
+          </p:cNvCxnSpPr>
+          <p:nvPr/>
+        </p:nvCxnSpPr>
+        <p:spPr>
+          <a:xfrm>
+            <a:off x="9189720" y="2854155"/>
+            <a:ext cx="647700" cy="0"/>
+          </a:xfrm>
+          <a:prstGeom prst="straightConnector1">
+            <a:avLst/>
+          </a:prstGeom>
+          <a:ln>
+            <a:solidFill>
+              <a:schemeClr val="tx1"/>
+            </a:solidFill>
+            <a:prstDash val="solid"/>
+            <a:tailEnd type="triangle" w="lg" len="lg"/>
+          </a:ln>
+        </p:spPr>
+        <p:style>
+          <a:lnRef idx="2">
+            <a:schemeClr val="accent1"/>
+          </a:lnRef>
+          <a:fillRef idx="0">
+            <a:schemeClr val="accent1"/>
+          </a:fillRef>
+          <a:effectRef idx="1">
+            <a:schemeClr val="accent1"/>
+          </a:effectRef>
+          <a:fontRef idx="minor">
+            <a:schemeClr val="tx1"/>
+          </a:fontRef>
+        </p:style>
+      </p:cxnSp>
+      <p:sp>
+        <p:nvSpPr>
+          <p:cNvPr id="15" name="Rectangle: Rounded Corners 14">
+            <a:extLst>
+              <a:ext uri="{FF2B5EF4-FFF2-40B4-BE49-F238E27FC236}">
+                <a16:creationId xmlns:a16="http://schemas.microsoft.com/office/drawing/2014/main" id="{C23DA4FB-7AE1-4EE4-8DD5-321F7F7C7F33}"/>
+              </a:ext>
+            </a:extLst>
+          </p:cNvPr>
+          <p:cNvSpPr/>
+          <p:nvPr/>
+        </p:nvSpPr>
+        <p:spPr>
+          <a:xfrm>
+            <a:off x="189267" y="2619607"/>
+            <a:ext cx="915222" cy="469096"/>
+          </a:xfrm>
+          <a:prstGeom prst="roundRect">
+            <a:avLst/>
+          </a:prstGeom>
+          <a:solidFill>
+            <a:srgbClr val="E5F1F8"/>
+          </a:solidFill>
+          <a:ln>
+            <a:solidFill>
+              <a:schemeClr val="tx1"/>
+            </a:solidFill>
+          </a:ln>
+        </p:spPr>
+        <p:style>
+          <a:lnRef idx="2">
+            <a:schemeClr val="accent1">
+              <a:shade val="15000"/>
+            </a:schemeClr>
+          </a:lnRef>
+          <a:fillRef idx="1">
+            <a:schemeClr val="accent1"/>
+          </a:fillRef>
+          <a:effectRef idx="0">
+            <a:schemeClr val="accent1"/>
+          </a:effectRef>
+          <a:fontRef idx="minor">
+            <a:schemeClr val="lt1"/>
+          </a:fontRef>
+        </p:style>
+        <p:txBody>
+          <a:bodyPr rtlCol="0" anchor="ctr"/>
+          <a:lstStyle/>
+          <a:p>
+            <a:pPr algn="ctr"/>
+            <a:r>
+              <a:rPr lang="en-US" dirty="0">
+                <a:solidFill>
+                  <a:schemeClr val="tx1"/>
+                </a:solidFill>
+              </a:rPr>
+              <a:t>Prompt</a:t>
+            </a:r>
+          </a:p>
+        </p:txBody>
+      </p:sp>
+      <p:cxnSp>
+        <p:nvCxnSpPr>
+          <p:cNvPr id="16" name="Straight Arrow Connector 15">
+            <a:extLst>
+              <a:ext uri="{FF2B5EF4-FFF2-40B4-BE49-F238E27FC236}">
+                <a16:creationId xmlns:a16="http://schemas.microsoft.com/office/drawing/2014/main" id="{942D3144-4FA8-07EA-6898-D7B2C45E010A}"/>
+              </a:ext>
+            </a:extLst>
+          </p:cNvPr>
+          <p:cNvCxnSpPr>
+            <a:cxnSpLocks/>
+            <a:stCxn id="15" idx="3"/>
+            <a:endCxn id="5" idx="1"/>
+          </p:cNvCxnSpPr>
+          <p:nvPr/>
+        </p:nvCxnSpPr>
+        <p:spPr>
+          <a:xfrm>
+            <a:off x="1104489" y="2854155"/>
+            <a:ext cx="403449" cy="0"/>
+          </a:xfrm>
+          <a:prstGeom prst="straightConnector1">
+            <a:avLst/>
+          </a:prstGeom>
+          <a:ln>
+            <a:solidFill>
+              <a:schemeClr val="tx1"/>
+            </a:solidFill>
+            <a:prstDash val="sysDash"/>
+            <a:tailEnd type="triangle" w="lg" len="lg"/>
+          </a:ln>
+        </p:spPr>
+        <p:style>
+          <a:lnRef idx="2">
+            <a:schemeClr val="accent1"/>
+          </a:lnRef>
+          <a:fillRef idx="0">
+            <a:schemeClr val="accent1"/>
+          </a:fillRef>
+          <a:effectRef idx="1">
+            <a:schemeClr val="accent1"/>
+          </a:effectRef>
+          <a:fontRef idx="minor">
+            <a:schemeClr val="tx1"/>
+          </a:fontRef>
+        </p:style>
+      </p:cxnSp>
+      <p:cxnSp>
+        <p:nvCxnSpPr>
+          <p:cNvPr id="19" name="Connector: Elbow 18">
+            <a:extLst>
+              <a:ext uri="{FF2B5EF4-FFF2-40B4-BE49-F238E27FC236}">
+                <a16:creationId xmlns:a16="http://schemas.microsoft.com/office/drawing/2014/main" id="{BF48D9D9-8BAB-3118-5B91-13BAA46C2349}"/>
+              </a:ext>
+            </a:extLst>
+          </p:cNvPr>
+          <p:cNvCxnSpPr>
+            <a:cxnSpLocks/>
+            <a:stCxn id="5" idx="3"/>
+            <a:endCxn id="4" idx="1"/>
+          </p:cNvCxnSpPr>
+          <p:nvPr/>
+        </p:nvCxnSpPr>
+        <p:spPr>
+          <a:xfrm flipV="1">
+            <a:off x="3421380" y="2083603"/>
+            <a:ext cx="624840" cy="770552"/>
+          </a:xfrm>
+          <a:prstGeom prst="bentConnector3">
+            <a:avLst>
+              <a:gd name="adj1" fmla="val 50000"/>
+            </a:avLst>
+          </a:prstGeom>
+          <a:ln>
+            <a:solidFill>
+              <a:schemeClr val="tx1"/>
+            </a:solidFill>
+            <a:prstDash val="solid"/>
+            <a:tailEnd type="triangle" w="lg" len="lg"/>
+          </a:ln>
+        </p:spPr>
+        <p:style>
+          <a:lnRef idx="2">
+            <a:schemeClr val="accent1"/>
+          </a:lnRef>
+          <a:fillRef idx="0">
+            <a:schemeClr val="accent1"/>
+          </a:fillRef>
+          <a:effectRef idx="1">
+            <a:schemeClr val="accent1"/>
+          </a:effectRef>
+          <a:fontRef idx="minor">
+            <a:schemeClr val="tx1"/>
+          </a:fontRef>
+        </p:style>
+      </p:cxnSp>
+      <p:cxnSp>
+        <p:nvCxnSpPr>
+          <p:cNvPr id="22" name="Connector: Elbow 21">
+            <a:extLst>
+              <a:ext uri="{FF2B5EF4-FFF2-40B4-BE49-F238E27FC236}">
+                <a16:creationId xmlns:a16="http://schemas.microsoft.com/office/drawing/2014/main" id="{217AA7E3-1E41-FB8C-7F66-A5758B29A028}"/>
+              </a:ext>
+            </a:extLst>
+          </p:cNvPr>
+          <p:cNvCxnSpPr>
+            <a:cxnSpLocks/>
+            <a:stCxn id="5" idx="3"/>
+            <a:endCxn id="2" idx="1"/>
+          </p:cNvCxnSpPr>
+          <p:nvPr/>
+        </p:nvCxnSpPr>
+        <p:spPr>
+          <a:xfrm>
+            <a:off x="3421380" y="2854155"/>
+            <a:ext cx="624840" cy="772965"/>
+          </a:xfrm>
+          <a:prstGeom prst="bentConnector3">
+            <a:avLst>
+              <a:gd name="adj1" fmla="val 50000"/>
+            </a:avLst>
+          </a:prstGeom>
+          <a:ln>
+            <a:solidFill>
+              <a:schemeClr val="tx1"/>
+            </a:solidFill>
+            <a:prstDash val="solid"/>
+            <a:tailEnd type="triangle" w="lg" len="lg"/>
+          </a:ln>
+        </p:spPr>
+        <p:style>
+          <a:lnRef idx="2">
+            <a:schemeClr val="accent1"/>
+          </a:lnRef>
+          <a:fillRef idx="0">
+            <a:schemeClr val="accent1"/>
+          </a:fillRef>
+          <a:effectRef idx="1">
+            <a:schemeClr val="accent1"/>
+          </a:effectRef>
+          <a:fontRef idx="minor">
+            <a:schemeClr val="tx1"/>
+          </a:fontRef>
+        </p:style>
+      </p:cxnSp>
+      <p:sp>
+        <p:nvSpPr>
+          <p:cNvPr id="25" name="Rectangle: Rounded Corners 24">
+            <a:extLst>
+              <a:ext uri="{FF2B5EF4-FFF2-40B4-BE49-F238E27FC236}">
+                <a16:creationId xmlns:a16="http://schemas.microsoft.com/office/drawing/2014/main" id="{98E95763-BD68-DEF9-F942-CCC8B336544E}"/>
+              </a:ext>
+            </a:extLst>
+          </p:cNvPr>
+          <p:cNvSpPr/>
+          <p:nvPr/>
+        </p:nvSpPr>
+        <p:spPr>
+          <a:xfrm>
+            <a:off x="8732520" y="1852591"/>
+            <a:ext cx="457200" cy="457200"/>
+          </a:xfrm>
+          <a:prstGeom prst="roundRect">
+            <a:avLst/>
+          </a:prstGeom>
+          <a:solidFill>
+            <a:srgbClr val="E5F1F8"/>
+          </a:solidFill>
+          <a:ln>
+            <a:solidFill>
+              <a:schemeClr val="tx1"/>
+            </a:solidFill>
+          </a:ln>
+        </p:spPr>
+        <p:style>
+          <a:lnRef idx="2">
+            <a:schemeClr val="accent1">
+              <a:shade val="15000"/>
+            </a:schemeClr>
+          </a:lnRef>
+          <a:fillRef idx="1">
+            <a:schemeClr val="accent1"/>
+          </a:fillRef>
+          <a:effectRef idx="0">
+            <a:schemeClr val="accent1"/>
+          </a:effectRef>
+          <a:fontRef idx="minor">
+            <a:schemeClr val="lt1"/>
+          </a:fontRef>
+        </p:style>
+        <p:txBody>
+          <a:bodyPr rtlCol="0" anchor="ctr"/>
+          <a:lstStyle/>
+          <a:p>
+            <a:pPr algn="ctr"/>
+            <a:endParaRPr lang="en-US" dirty="0">
+              <a:solidFill>
+                <a:schemeClr val="tx1"/>
+              </a:solidFill>
+            </a:endParaRPr>
+          </a:p>
+        </p:txBody>
+      </p:sp>
+      <p:cxnSp>
+        <p:nvCxnSpPr>
+          <p:cNvPr id="40" name="Straight Arrow Connector 39">
+            <a:extLst>
+              <a:ext uri="{FF2B5EF4-FFF2-40B4-BE49-F238E27FC236}">
+                <a16:creationId xmlns:a16="http://schemas.microsoft.com/office/drawing/2014/main" id="{B899F5AF-E80C-3452-008E-8E821AEFA864}"/>
+              </a:ext>
+            </a:extLst>
+          </p:cNvPr>
+          <p:cNvCxnSpPr>
+            <a:cxnSpLocks/>
+            <a:stCxn id="4" idx="3"/>
+            <a:endCxn id="25" idx="1"/>
+          </p:cNvCxnSpPr>
+          <p:nvPr/>
+        </p:nvCxnSpPr>
+        <p:spPr>
+          <a:xfrm flipV="1">
+            <a:off x="8328660" y="2081191"/>
+            <a:ext cx="403860" cy="2412"/>
+          </a:xfrm>
+          <a:prstGeom prst="straightConnector1">
+            <a:avLst/>
+          </a:prstGeom>
+          <a:ln>
+            <a:solidFill>
+              <a:schemeClr val="tx1"/>
+            </a:solidFill>
+            <a:prstDash val="solid"/>
+            <a:tailEnd type="triangle" w="lg" len="lg"/>
+          </a:ln>
+        </p:spPr>
+        <p:style>
+          <a:lnRef idx="2">
+            <a:schemeClr val="accent1"/>
+          </a:lnRef>
+          <a:fillRef idx="0">
+            <a:schemeClr val="accent1"/>
+          </a:fillRef>
+          <a:effectRef idx="1">
+            <a:schemeClr val="accent1"/>
+          </a:effectRef>
+          <a:fontRef idx="minor">
+            <a:schemeClr val="tx1"/>
+          </a:fontRef>
+        </p:style>
+      </p:cxnSp>
+      <p:sp>
+        <p:nvSpPr>
+          <p:cNvPr id="44" name="Rectangle: Rounded Corners 43">
+            <a:extLst>
+              <a:ext uri="{FF2B5EF4-FFF2-40B4-BE49-F238E27FC236}">
+                <a16:creationId xmlns:a16="http://schemas.microsoft.com/office/drawing/2014/main" id="{3F66FD98-C347-7EA9-DC36-7FDBB97B4248}"/>
+              </a:ext>
+            </a:extLst>
+          </p:cNvPr>
+          <p:cNvSpPr/>
+          <p:nvPr/>
+        </p:nvSpPr>
+        <p:spPr>
+          <a:xfrm>
+            <a:off x="8732520" y="2625555"/>
+            <a:ext cx="457200" cy="457200"/>
+          </a:xfrm>
+          <a:prstGeom prst="roundRect">
+            <a:avLst/>
+          </a:prstGeom>
+          <a:solidFill>
+            <a:srgbClr val="E5F1F8"/>
+          </a:solidFill>
+          <a:ln>
+            <a:solidFill>
+              <a:schemeClr val="tx1"/>
+            </a:solidFill>
+          </a:ln>
+        </p:spPr>
+        <p:style>
+          <a:lnRef idx="2">
+            <a:schemeClr val="accent1">
+              <a:shade val="15000"/>
+            </a:schemeClr>
+          </a:lnRef>
+          <a:fillRef idx="1">
+            <a:schemeClr val="accent1"/>
+          </a:fillRef>
+          <a:effectRef idx="0">
+            <a:schemeClr val="accent1"/>
+          </a:effectRef>
+          <a:fontRef idx="minor">
+            <a:schemeClr val="lt1"/>
+          </a:fontRef>
+        </p:style>
+        <p:txBody>
+          <a:bodyPr rtlCol="0" anchor="ctr"/>
+          <a:lstStyle/>
+          <a:p>
+            <a:pPr algn="ctr"/>
+            <a:endParaRPr lang="en-US" dirty="0">
+              <a:solidFill>
+                <a:schemeClr val="tx1"/>
+              </a:solidFill>
+            </a:endParaRPr>
+          </a:p>
+        </p:txBody>
+      </p:sp>
+      <p:sp>
+        <p:nvSpPr>
+          <p:cNvPr id="46" name="Rectangle: Rounded Corners 45">
+            <a:extLst>
+              <a:ext uri="{FF2B5EF4-FFF2-40B4-BE49-F238E27FC236}">
+                <a16:creationId xmlns:a16="http://schemas.microsoft.com/office/drawing/2014/main" id="{A791A27B-2AA1-8E05-2231-C99FE09DCBEB}"/>
+              </a:ext>
+            </a:extLst>
+          </p:cNvPr>
+          <p:cNvSpPr/>
+          <p:nvPr/>
+        </p:nvSpPr>
+        <p:spPr>
+          <a:xfrm>
+            <a:off x="8732520" y="3398519"/>
+            <a:ext cx="457200" cy="457200"/>
+          </a:xfrm>
+          <a:prstGeom prst="roundRect">
+            <a:avLst/>
+          </a:prstGeom>
+          <a:solidFill>
+            <a:srgbClr val="E5F1F8"/>
+          </a:solidFill>
+          <a:ln>
+            <a:solidFill>
+              <a:schemeClr val="tx1"/>
+            </a:solidFill>
+          </a:ln>
+        </p:spPr>
+        <p:style>
+          <a:lnRef idx="2">
+            <a:schemeClr val="accent1">
+              <a:shade val="15000"/>
+            </a:schemeClr>
+          </a:lnRef>
+          <a:fillRef idx="1">
+            <a:schemeClr val="accent1"/>
+          </a:fillRef>
+          <a:effectRef idx="0">
+            <a:schemeClr val="accent1"/>
+          </a:effectRef>
+          <a:fontRef idx="minor">
+            <a:schemeClr val="lt1"/>
+          </a:fontRef>
+        </p:style>
+        <p:txBody>
+          <a:bodyPr rtlCol="0" anchor="ctr"/>
+          <a:lstStyle/>
+          <a:p>
+            <a:pPr algn="ctr"/>
+            <a:endParaRPr lang="en-US" dirty="0">
+              <a:solidFill>
+                <a:schemeClr val="tx1"/>
+              </a:solidFill>
+            </a:endParaRPr>
+          </a:p>
+        </p:txBody>
+      </p:sp>
+      <p:cxnSp>
+        <p:nvCxnSpPr>
+          <p:cNvPr id="47" name="Straight Arrow Connector 46">
+            <a:extLst>
+              <a:ext uri="{FF2B5EF4-FFF2-40B4-BE49-F238E27FC236}">
+                <a16:creationId xmlns:a16="http://schemas.microsoft.com/office/drawing/2014/main" id="{42D77B26-2C1F-3022-9B0B-3736BC5CF8AA}"/>
+              </a:ext>
+            </a:extLst>
+          </p:cNvPr>
+          <p:cNvCxnSpPr>
+            <a:cxnSpLocks/>
+            <a:stCxn id="3" idx="3"/>
+            <a:endCxn id="44" idx="1"/>
+          </p:cNvCxnSpPr>
+          <p:nvPr/>
+        </p:nvCxnSpPr>
+        <p:spPr>
+          <a:xfrm>
+            <a:off x="8328660" y="2854154"/>
+            <a:ext cx="403860" cy="1"/>
+          </a:xfrm>
+          <a:prstGeom prst="straightConnector1">
+            <a:avLst/>
+          </a:prstGeom>
+          <a:ln>
+            <a:solidFill>
+              <a:schemeClr val="tx1"/>
+            </a:solidFill>
+            <a:prstDash val="solid"/>
+            <a:tailEnd type="triangle" w="lg" len="lg"/>
+          </a:ln>
+        </p:spPr>
+        <p:style>
+          <a:lnRef idx="2">
+            <a:schemeClr val="accent1"/>
+          </a:lnRef>
+          <a:fillRef idx="0">
+            <a:schemeClr val="accent1"/>
+          </a:fillRef>
+          <a:effectRef idx="1">
+            <a:schemeClr val="accent1"/>
+          </a:effectRef>
+          <a:fontRef idx="minor">
+            <a:schemeClr val="tx1"/>
+          </a:fontRef>
+        </p:style>
+      </p:cxnSp>
+      <p:cxnSp>
+        <p:nvCxnSpPr>
+          <p:cNvPr id="55" name="Straight Arrow Connector 54">
+            <a:extLst>
+              <a:ext uri="{FF2B5EF4-FFF2-40B4-BE49-F238E27FC236}">
+                <a16:creationId xmlns:a16="http://schemas.microsoft.com/office/drawing/2014/main" id="{A99ECFB6-8E63-4F62-C5D3-37BC5BB43934}"/>
+              </a:ext>
+            </a:extLst>
+          </p:cNvPr>
+          <p:cNvCxnSpPr>
+            <a:cxnSpLocks/>
+            <a:stCxn id="2" idx="3"/>
+            <a:endCxn id="46" idx="1"/>
+          </p:cNvCxnSpPr>
+          <p:nvPr/>
+        </p:nvCxnSpPr>
+        <p:spPr>
+          <a:xfrm flipV="1">
+            <a:off x="8328660" y="3627119"/>
+            <a:ext cx="403860" cy="1"/>
+          </a:xfrm>
+          <a:prstGeom prst="straightConnector1">
+            <a:avLst/>
+          </a:prstGeom>
+          <a:ln>
+            <a:solidFill>
+              <a:schemeClr val="tx1"/>
+            </a:solidFill>
+            <a:prstDash val="solid"/>
+            <a:tailEnd type="triangle" w="lg" len="lg"/>
+          </a:ln>
+        </p:spPr>
+        <p:style>
+          <a:lnRef idx="2">
+            <a:schemeClr val="accent1"/>
+          </a:lnRef>
+          <a:fillRef idx="0">
+            <a:schemeClr val="accent1"/>
+          </a:fillRef>
+          <a:effectRef idx="1">
+            <a:schemeClr val="accent1"/>
+          </a:effectRef>
+          <a:fontRef idx="minor">
+            <a:schemeClr val="tx1"/>
+          </a:fontRef>
+        </p:style>
+      </p:cxnSp>
+      <p:cxnSp>
+        <p:nvCxnSpPr>
+          <p:cNvPr id="58" name="Connector: Elbow 57">
+            <a:extLst>
+              <a:ext uri="{FF2B5EF4-FFF2-40B4-BE49-F238E27FC236}">
+                <a16:creationId xmlns:a16="http://schemas.microsoft.com/office/drawing/2014/main" id="{DDB500F1-F165-AABE-6725-11E4ED79023E}"/>
+              </a:ext>
+            </a:extLst>
+          </p:cNvPr>
+          <p:cNvCxnSpPr>
+            <a:cxnSpLocks/>
+            <a:stCxn id="25" idx="3"/>
+            <a:endCxn id="6" idx="1"/>
+          </p:cNvCxnSpPr>
+          <p:nvPr/>
+        </p:nvCxnSpPr>
+        <p:spPr>
+          <a:xfrm>
+            <a:off x="9189720" y="2081191"/>
+            <a:ext cx="647700" cy="772964"/>
+          </a:xfrm>
+          <a:prstGeom prst="bentConnector3">
+            <a:avLst>
+              <a:gd name="adj1" fmla="val 50000"/>
+            </a:avLst>
+          </a:prstGeom>
+          <a:ln>
+            <a:solidFill>
+              <a:schemeClr val="tx1"/>
+            </a:solidFill>
+            <a:prstDash val="solid"/>
+            <a:tailEnd type="triangle" w="lg" len="lg"/>
+          </a:ln>
+        </p:spPr>
+        <p:style>
+          <a:lnRef idx="2">
+            <a:schemeClr val="accent1"/>
+          </a:lnRef>
+          <a:fillRef idx="0">
+            <a:schemeClr val="accent1"/>
+          </a:fillRef>
+          <a:effectRef idx="1">
+            <a:schemeClr val="accent1"/>
+          </a:effectRef>
+          <a:fontRef idx="minor">
+            <a:schemeClr val="tx1"/>
+          </a:fontRef>
+        </p:style>
+      </p:cxnSp>
+      <p:cxnSp>
+        <p:nvCxnSpPr>
+          <p:cNvPr id="61" name="Connector: Elbow 60">
+            <a:extLst>
+              <a:ext uri="{FF2B5EF4-FFF2-40B4-BE49-F238E27FC236}">
+                <a16:creationId xmlns:a16="http://schemas.microsoft.com/office/drawing/2014/main" id="{28AC6A5D-0A01-5370-996D-AF8698A1082D}"/>
+              </a:ext>
+            </a:extLst>
+          </p:cNvPr>
+          <p:cNvCxnSpPr>
+            <a:cxnSpLocks/>
+            <a:stCxn id="46" idx="3"/>
+            <a:endCxn id="6" idx="1"/>
+          </p:cNvCxnSpPr>
+          <p:nvPr/>
+        </p:nvCxnSpPr>
+        <p:spPr>
+          <a:xfrm flipV="1">
+            <a:off x="9189720" y="2854155"/>
+            <a:ext cx="647700" cy="772964"/>
+          </a:xfrm>
+          <a:prstGeom prst="bentConnector3">
+            <a:avLst>
+              <a:gd name="adj1" fmla="val 50000"/>
+            </a:avLst>
+          </a:prstGeom>
+          <a:ln>
+            <a:solidFill>
+              <a:schemeClr val="tx1"/>
+            </a:solidFill>
+            <a:prstDash val="solid"/>
+            <a:tailEnd type="triangle" w="lg" len="lg"/>
+          </a:ln>
+        </p:spPr>
+        <p:style>
+          <a:lnRef idx="2">
+            <a:schemeClr val="accent1"/>
+          </a:lnRef>
+          <a:fillRef idx="0">
+            <a:schemeClr val="accent1"/>
+          </a:fillRef>
+          <a:effectRef idx="1">
+            <a:schemeClr val="accent1"/>
+          </a:effectRef>
+          <a:fontRef idx="minor">
+            <a:schemeClr val="tx1"/>
+          </a:fontRef>
+        </p:style>
+      </p:cxnSp>
       <p:pic>
         <p:nvPicPr>
-          <p:cNvPr id="3" name="Picture 2">
-            <a:extLst>
-              <a:ext uri="{FF2B5EF4-FFF2-40B4-BE49-F238E27FC236}">
-                <a16:creationId xmlns:a16="http://schemas.microsoft.com/office/drawing/2014/main" id="{FD8E52CD-5961-A7C1-3607-A00CDD4774AD}"/>
+          <p:cNvPr id="67" name="Graphic 66" descr="Web design with solid fill">
+            <a:extLst>
+              <a:ext uri="{FF2B5EF4-FFF2-40B4-BE49-F238E27FC236}">
+                <a16:creationId xmlns:a16="http://schemas.microsoft.com/office/drawing/2014/main" id="{5D8BB564-5BA8-868D-2AB7-35E0D3AE65F9}"/>
               </a:ext>
             </a:extLst>
           </p:cNvPr>
@@ -3786,25 +4843,294 @@
           <p:nvPr/>
         </p:nvPicPr>
         <p:blipFill>
-          <a:blip r:embed="rId2"/>
+          <a:blip r:embed="rId2">
+            <a:extLst>
+              <a:ext uri="{96DAC541-7B7A-43D3-8B79-37D633B846F1}">
+                <asvg:svgBlip xmlns:asvg="http://schemas.microsoft.com/office/drawing/2016/SVG/main" r:embed="rId3"/>
+              </a:ext>
+            </a:extLst>
+          </a:blip>
           <a:stretch>
             <a:fillRect/>
           </a:stretch>
         </p:blipFill>
         <p:spPr>
           <a:xfrm>
-            <a:off x="0" y="23812"/>
-            <a:ext cx="12192000" cy="6810375"/>
+            <a:off x="8755380" y="2648413"/>
+            <a:ext cx="411480" cy="411480"/>
           </a:xfrm>
           <a:prstGeom prst="rect">
             <a:avLst/>
           </a:prstGeom>
         </p:spPr>
       </p:pic>
+      <p:pic>
+        <p:nvPicPr>
+          <p:cNvPr id="71" name="Graphic 70" descr="World with solid fill">
+            <a:extLst>
+              <a:ext uri="{FF2B5EF4-FFF2-40B4-BE49-F238E27FC236}">
+                <a16:creationId xmlns:a16="http://schemas.microsoft.com/office/drawing/2014/main" id="{0EF50C39-FA5F-96A6-2DE6-53C76B029FDB}"/>
+              </a:ext>
+            </a:extLst>
+          </p:cNvPr>
+          <p:cNvPicPr>
+            <a:picLocks noChangeAspect="1"/>
+          </p:cNvPicPr>
+          <p:nvPr/>
+        </p:nvPicPr>
+        <p:blipFill>
+          <a:blip r:embed="rId4">
+            <a:extLst>
+              <a:ext uri="{96DAC541-7B7A-43D3-8B79-37D633B846F1}">
+                <asvg:svgBlip xmlns:asvg="http://schemas.microsoft.com/office/drawing/2016/SVG/main" r:embed="rId5"/>
+              </a:ext>
+            </a:extLst>
+          </a:blip>
+          <a:stretch>
+            <a:fillRect/>
+          </a:stretch>
+        </p:blipFill>
+        <p:spPr>
+          <a:xfrm>
+            <a:off x="8755380" y="3421379"/>
+            <a:ext cx="411480" cy="411480"/>
+          </a:xfrm>
+          <a:prstGeom prst="rect">
+            <a:avLst/>
+          </a:prstGeom>
+        </p:spPr>
+      </p:pic>
+      <p:pic>
+        <p:nvPicPr>
+          <p:cNvPr id="73" name="Graphic 72" descr="Database with solid fill">
+            <a:extLst>
+              <a:ext uri="{FF2B5EF4-FFF2-40B4-BE49-F238E27FC236}">
+                <a16:creationId xmlns:a16="http://schemas.microsoft.com/office/drawing/2014/main" id="{20B0889E-3ACA-9DCA-25FE-C1F9B73F7329}"/>
+              </a:ext>
+            </a:extLst>
+          </p:cNvPr>
+          <p:cNvPicPr>
+            <a:picLocks noChangeAspect="1"/>
+          </p:cNvPicPr>
+          <p:nvPr/>
+        </p:nvPicPr>
+        <p:blipFill>
+          <a:blip r:embed="rId6">
+            <a:extLst>
+              <a:ext uri="{96DAC541-7B7A-43D3-8B79-37D633B846F1}">
+                <asvg:svgBlip xmlns:asvg="http://schemas.microsoft.com/office/drawing/2016/SVG/main" r:embed="rId7"/>
+              </a:ext>
+            </a:extLst>
+          </a:blip>
+          <a:stretch>
+            <a:fillRect/>
+          </a:stretch>
+        </p:blipFill>
+        <p:spPr>
+          <a:xfrm>
+            <a:off x="8755380" y="1875451"/>
+            <a:ext cx="411480" cy="411480"/>
+          </a:xfrm>
+          <a:prstGeom prst="rect">
+            <a:avLst/>
+          </a:prstGeom>
+        </p:spPr>
+      </p:pic>
+      <p:pic>
+        <p:nvPicPr>
+          <p:cNvPr id="75" name="Graphic 74" descr="Gears with solid fill">
+            <a:extLst>
+              <a:ext uri="{FF2B5EF4-FFF2-40B4-BE49-F238E27FC236}">
+                <a16:creationId xmlns:a16="http://schemas.microsoft.com/office/drawing/2014/main" id="{AFA7CC75-0D4E-9273-3BC2-179536E5EC20}"/>
+              </a:ext>
+            </a:extLst>
+          </p:cNvPr>
+          <p:cNvPicPr>
+            <a:picLocks noChangeAspect="1"/>
+          </p:cNvPicPr>
+          <p:nvPr/>
+        </p:nvPicPr>
+        <p:blipFill>
+          <a:blip r:embed="rId8">
+            <a:extLst>
+              <a:ext uri="{96DAC541-7B7A-43D3-8B79-37D633B846F1}">
+                <asvg:svgBlip xmlns:asvg="http://schemas.microsoft.com/office/drawing/2016/SVG/main" r:embed="rId9"/>
+              </a:ext>
+            </a:extLst>
+          </a:blip>
+          <a:stretch>
+            <a:fillRect/>
+          </a:stretch>
+        </p:blipFill>
+        <p:spPr>
+          <a:xfrm>
+            <a:off x="1626048" y="2648413"/>
+            <a:ext cx="411480" cy="411480"/>
+          </a:xfrm>
+          <a:prstGeom prst="rect">
+            <a:avLst/>
+          </a:prstGeom>
+        </p:spPr>
+      </p:pic>
+      <p:sp>
+        <p:nvSpPr>
+          <p:cNvPr id="76" name="Rectangle: Rounded Corners 75">
+            <a:extLst>
+              <a:ext uri="{FF2B5EF4-FFF2-40B4-BE49-F238E27FC236}">
+                <a16:creationId xmlns:a16="http://schemas.microsoft.com/office/drawing/2014/main" id="{3492D89A-8D12-E69E-613E-246E45DCD83F}"/>
+              </a:ext>
+            </a:extLst>
+          </p:cNvPr>
+          <p:cNvSpPr/>
+          <p:nvPr/>
+        </p:nvSpPr>
+        <p:spPr>
+          <a:xfrm>
+            <a:off x="10545258" y="3627118"/>
+            <a:ext cx="1205604" cy="469096"/>
+          </a:xfrm>
+          <a:prstGeom prst="roundRect">
+            <a:avLst/>
+          </a:prstGeom>
+          <a:solidFill>
+            <a:srgbClr val="E5F1F8"/>
+          </a:solidFill>
+          <a:ln>
+            <a:solidFill>
+              <a:schemeClr val="tx1"/>
+            </a:solidFill>
+          </a:ln>
+        </p:spPr>
+        <p:style>
+          <a:lnRef idx="2">
+            <a:schemeClr val="accent1">
+              <a:shade val="15000"/>
+            </a:schemeClr>
+          </a:lnRef>
+          <a:fillRef idx="1">
+            <a:schemeClr val="accent1"/>
+          </a:fillRef>
+          <a:effectRef idx="0">
+            <a:schemeClr val="accent1"/>
+          </a:effectRef>
+          <a:fontRef idx="minor">
+            <a:schemeClr val="lt1"/>
+          </a:fontRef>
+        </p:style>
+        <p:txBody>
+          <a:bodyPr rtlCol="0" anchor="ctr"/>
+          <a:lstStyle/>
+          <a:p>
+            <a:pPr algn="ctr"/>
+            <a:r>
+              <a:rPr lang="en-US" dirty="0">
+                <a:solidFill>
+                  <a:schemeClr val="tx1"/>
+                </a:solidFill>
+              </a:rPr>
+              <a:t>Response</a:t>
+            </a:r>
+          </a:p>
+        </p:txBody>
+      </p:sp>
+      <p:cxnSp>
+        <p:nvCxnSpPr>
+          <p:cNvPr id="77" name="Straight Arrow Connector 76">
+            <a:extLst>
+              <a:ext uri="{FF2B5EF4-FFF2-40B4-BE49-F238E27FC236}">
+                <a16:creationId xmlns:a16="http://schemas.microsoft.com/office/drawing/2014/main" id="{1A734903-BE53-2153-B1BE-7817395A6ACC}"/>
+              </a:ext>
+            </a:extLst>
+          </p:cNvPr>
+          <p:cNvCxnSpPr>
+            <a:cxnSpLocks/>
+            <a:endCxn id="76" idx="0"/>
+          </p:cNvCxnSpPr>
+          <p:nvPr/>
+        </p:nvCxnSpPr>
+        <p:spPr>
+          <a:xfrm>
+            <a:off x="11148060" y="3334214"/>
+            <a:ext cx="0" cy="292904"/>
+          </a:xfrm>
+          <a:prstGeom prst="straightConnector1">
+            <a:avLst/>
+          </a:prstGeom>
+          <a:ln>
+            <a:solidFill>
+              <a:schemeClr val="tx1"/>
+            </a:solidFill>
+            <a:prstDash val="sysDash"/>
+            <a:tailEnd type="triangle" w="lg" len="lg"/>
+          </a:ln>
+        </p:spPr>
+        <p:style>
+          <a:lnRef idx="2">
+            <a:schemeClr val="accent1"/>
+          </a:lnRef>
+          <a:fillRef idx="0">
+            <a:schemeClr val="accent1"/>
+          </a:fillRef>
+          <a:effectRef idx="1">
+            <a:schemeClr val="accent1"/>
+          </a:effectRef>
+          <a:fontRef idx="minor">
+            <a:schemeClr val="tx1"/>
+          </a:fontRef>
+        </p:style>
+      </p:cxnSp>
+      <p:cxnSp>
+        <p:nvCxnSpPr>
+          <p:cNvPr id="14" name="Connector: Elbow 13">
+            <a:extLst>
+              <a:ext uri="{FF2B5EF4-FFF2-40B4-BE49-F238E27FC236}">
+                <a16:creationId xmlns:a16="http://schemas.microsoft.com/office/drawing/2014/main" id="{4D371B40-23D5-3632-64F0-3A5DAC685C2C}"/>
+              </a:ext>
+            </a:extLst>
+          </p:cNvPr>
+          <p:cNvCxnSpPr>
+            <a:cxnSpLocks/>
+            <a:endCxn id="5" idx="2"/>
+          </p:cNvCxnSpPr>
+          <p:nvPr/>
+        </p:nvCxnSpPr>
+        <p:spPr>
+          <a:xfrm rot="5400000">
+            <a:off x="6337265" y="-538391"/>
+            <a:ext cx="12700" cy="7745211"/>
+          </a:xfrm>
+          <a:prstGeom prst="bentConnector3">
+            <a:avLst>
+              <a:gd name="adj1" fmla="val 6060000"/>
+            </a:avLst>
+          </a:prstGeom>
+          <a:ln>
+            <a:solidFill>
+              <a:schemeClr val="tx1"/>
+            </a:solidFill>
+            <a:prstDash val="sysDash"/>
+            <a:tailEnd type="triangle" w="lg" len="lg"/>
+          </a:ln>
+        </p:spPr>
+        <p:style>
+          <a:lnRef idx="2">
+            <a:schemeClr val="accent1"/>
+          </a:lnRef>
+          <a:fillRef idx="0">
+            <a:schemeClr val="accent1"/>
+          </a:fillRef>
+          <a:effectRef idx="1">
+            <a:schemeClr val="accent1"/>
+          </a:effectRef>
+          <a:fontRef idx="minor">
+            <a:schemeClr val="tx1"/>
+          </a:fontRef>
+        </p:style>
+      </p:cxnSp>
     </p:spTree>
     <p:extLst>
       <p:ext uri="{BB962C8B-B14F-4D97-AF65-F5344CB8AC3E}">
-        <p14:creationId xmlns:p14="http://schemas.microsoft.com/office/powerpoint/2010/main" val="3564074342"/>
+        <p14:creationId xmlns:p14="http://schemas.microsoft.com/office/powerpoint/2010/main" val="2560175498"/>
       </p:ext>
     </p:extLst>
   </p:cSld>
@@ -3836,7 +5162,7 @@
           <p:cNvPr id="3" name="Picture 2">
             <a:extLst>
               <a:ext uri="{FF2B5EF4-FFF2-40B4-BE49-F238E27FC236}">
-                <a16:creationId xmlns:a16="http://schemas.microsoft.com/office/drawing/2014/main" id="{D6A42420-8E3C-777D-C41A-540741D913CD}"/>
+                <a16:creationId xmlns:a16="http://schemas.microsoft.com/office/drawing/2014/main" id="{FD8E52CD-5961-A7C1-3607-A00CDD4774AD}"/>
               </a:ext>
             </a:extLst>
           </p:cNvPr>
@@ -3853,8 +5179,8 @@
         </p:blipFill>
         <p:spPr>
           <a:xfrm>
-            <a:off x="0" y="7451"/>
-            <a:ext cx="12192000" cy="6843098"/>
+            <a:off x="0" y="23812"/>
+            <a:ext cx="12192000" cy="6810375"/>
           </a:xfrm>
           <a:prstGeom prst="rect">
             <a:avLst/>
@@ -3864,7 +5190,7 @@
     </p:spTree>
     <p:extLst>
       <p:ext uri="{BB962C8B-B14F-4D97-AF65-F5344CB8AC3E}">
-        <p14:creationId xmlns:p14="http://schemas.microsoft.com/office/powerpoint/2010/main" val="3996994306"/>
+        <p14:creationId xmlns:p14="http://schemas.microsoft.com/office/powerpoint/2010/main" val="3564074342"/>
       </p:ext>
     </p:extLst>
   </p:cSld>
@@ -3896,6 +5222,66 @@
           <p:cNvPr id="3" name="Picture 2">
             <a:extLst>
               <a:ext uri="{FF2B5EF4-FFF2-40B4-BE49-F238E27FC236}">
+                <a16:creationId xmlns:a16="http://schemas.microsoft.com/office/drawing/2014/main" id="{D6A42420-8E3C-777D-C41A-540741D913CD}"/>
+              </a:ext>
+            </a:extLst>
+          </p:cNvPr>
+          <p:cNvPicPr>
+            <a:picLocks noChangeAspect="1"/>
+          </p:cNvPicPr>
+          <p:nvPr/>
+        </p:nvPicPr>
+        <p:blipFill>
+          <a:blip r:embed="rId2"/>
+          <a:stretch>
+            <a:fillRect/>
+          </a:stretch>
+        </p:blipFill>
+        <p:spPr>
+          <a:xfrm>
+            <a:off x="0" y="7451"/>
+            <a:ext cx="12192000" cy="6843098"/>
+          </a:xfrm>
+          <a:prstGeom prst="rect">
+            <a:avLst/>
+          </a:prstGeom>
+        </p:spPr>
+      </p:pic>
+    </p:spTree>
+    <p:extLst>
+      <p:ext uri="{BB962C8B-B14F-4D97-AF65-F5344CB8AC3E}">
+        <p14:creationId xmlns:p14="http://schemas.microsoft.com/office/powerpoint/2010/main" val="3996994306"/>
+      </p:ext>
+    </p:extLst>
+  </p:cSld>
+  <p:clrMapOvr>
+    <a:masterClrMapping/>
+  </p:clrMapOvr>
+</p:sld>
+</file>
+
+<file path=ppt/slides/slide13.xml><?xml version="1.0" encoding="utf-8"?>
+<p:sld xmlns:a="http://schemas.openxmlformats.org/drawingml/2006/main" xmlns:r="http://schemas.openxmlformats.org/officeDocument/2006/relationships" xmlns:p="http://schemas.openxmlformats.org/presentationml/2006/main">
+  <p:cSld>
+    <p:spTree>
+      <p:nvGrpSpPr>
+        <p:cNvPr id="1" name=""/>
+        <p:cNvGrpSpPr/>
+        <p:nvPr/>
+      </p:nvGrpSpPr>
+      <p:grpSpPr>
+        <a:xfrm>
+          <a:off x="0" y="0"/>
+          <a:ext cx="0" cy="0"/>
+          <a:chOff x="0" y="0"/>
+          <a:chExt cx="0" cy="0"/>
+        </a:xfrm>
+      </p:grpSpPr>
+      <p:pic>
+        <p:nvPicPr>
+          <p:cNvPr id="3" name="Picture 2">
+            <a:extLst>
+              <a:ext uri="{FF2B5EF4-FFF2-40B4-BE49-F238E27FC236}">
                 <a16:creationId xmlns:a16="http://schemas.microsoft.com/office/drawing/2014/main" id="{EE4867BA-66DD-B140-5528-856BCA343CD6}"/>
               </a:ext>
             </a:extLst>
@@ -3934,7 +5320,7 @@
 </p:sld>
 </file>
 
-<file path=ppt/slides/slide13.xml><?xml version="1.0" encoding="utf-8"?>
+<file path=ppt/slides/slide14.xml><?xml version="1.0" encoding="utf-8"?>
 <p:sld xmlns:a="http://schemas.openxmlformats.org/drawingml/2006/main" xmlns:r="http://schemas.openxmlformats.org/officeDocument/2006/relationships" xmlns:p="http://schemas.openxmlformats.org/presentationml/2006/main">
   <p:cSld>
     <p:spTree>
@@ -4000,7 +5386,7 @@
 </p:sld>
 </file>
 
-<file path=ppt/slides/slide14.xml><?xml version="1.0" encoding="utf-8"?>
+<file path=ppt/slides/slide15.xml><?xml version="1.0" encoding="utf-8"?>
 <p:sld xmlns:a="http://schemas.openxmlformats.org/drawingml/2006/main" xmlns:r="http://schemas.openxmlformats.org/officeDocument/2006/relationships" xmlns:p="http://schemas.openxmlformats.org/presentationml/2006/main">
   <p:cSld>
     <p:spTree>
@@ -4090,7 +5476,7 @@
 </p:sld>
 </file>
 
-<file path=ppt/slides/slide15.xml><?xml version="1.0" encoding="utf-8"?>
+<file path=ppt/slides/slide16.xml><?xml version="1.0" encoding="utf-8"?>
 <p:sld xmlns:a="http://schemas.openxmlformats.org/drawingml/2006/main" xmlns:r="http://schemas.openxmlformats.org/officeDocument/2006/relationships" xmlns:p="http://schemas.openxmlformats.org/presentationml/2006/main">
   <p:cSld>
     <p:spTree>
@@ -4126,7 +5512,7 @@
 </p:sld>
 </file>
 
-<file path=ppt/slides/slide16.xml><?xml version="1.0" encoding="utf-8"?>
+<file path=ppt/slides/slide17.xml><?xml version="1.0" encoding="utf-8"?>
 <p:sld xmlns:a="http://schemas.openxmlformats.org/drawingml/2006/main" xmlns:r="http://schemas.openxmlformats.org/officeDocument/2006/relationships" xmlns:p="http://schemas.openxmlformats.org/presentationml/2006/main">
   <p:cSld>
     <p:spTree>
@@ -4162,7 +5548,7 @@
 </p:sld>
 </file>
 
-<file path=ppt/slides/slide17.xml><?xml version="1.0" encoding="utf-8"?>
+<file path=ppt/slides/slide18.xml><?xml version="1.0" encoding="utf-8"?>
 <p:sld xmlns:a="http://schemas.openxmlformats.org/drawingml/2006/main" xmlns:r="http://schemas.openxmlformats.org/officeDocument/2006/relationships" xmlns:p="http://schemas.openxmlformats.org/presentationml/2006/main">
   <p:cSld>
     <p:spTree>
@@ -4198,7 +5584,7 @@
 </p:sld>
 </file>
 
-<file path=ppt/slides/slide18.xml><?xml version="1.0" encoding="utf-8"?>
+<file path=ppt/slides/slide19.xml><?xml version="1.0" encoding="utf-8"?>
 <p:sld xmlns:a="http://schemas.openxmlformats.org/drawingml/2006/main" xmlns:r="http://schemas.openxmlformats.org/officeDocument/2006/relationships" xmlns:p="http://schemas.openxmlformats.org/presentationml/2006/main">
   <p:cSld>
     <p:spTree>
@@ -9065,6 +10451,1255 @@
 </file>
 
 <file path=ppt/slides/slide8.xml><?xml version="1.0" encoding="utf-8"?>
+<p:sld xmlns:a="http://schemas.openxmlformats.org/drawingml/2006/main" xmlns:r="http://schemas.openxmlformats.org/officeDocument/2006/relationships" xmlns:p="http://schemas.openxmlformats.org/presentationml/2006/main">
+  <p:cSld>
+    <p:spTree>
+      <p:nvGrpSpPr>
+        <p:cNvPr id="1" name=""/>
+        <p:cNvGrpSpPr/>
+        <p:nvPr/>
+      </p:nvGrpSpPr>
+      <p:grpSpPr>
+        <a:xfrm>
+          <a:off x="0" y="0"/>
+          <a:ext cx="0" cy="0"/>
+          <a:chOff x="0" y="0"/>
+          <a:chExt cx="0" cy="0"/>
+        </a:xfrm>
+      </p:grpSpPr>
+      <p:sp>
+        <p:nvSpPr>
+          <p:cNvPr id="2" name="Rectangle: Rounded Corners 1">
+            <a:extLst>
+              <a:ext uri="{FF2B5EF4-FFF2-40B4-BE49-F238E27FC236}">
+                <a16:creationId xmlns:a16="http://schemas.microsoft.com/office/drawing/2014/main" id="{FCEAC593-D8CD-61FE-1EC9-C96369134D92}"/>
+              </a:ext>
+            </a:extLst>
+          </p:cNvPr>
+          <p:cNvSpPr/>
+          <p:nvPr/>
+        </p:nvSpPr>
+        <p:spPr>
+          <a:xfrm>
+            <a:off x="182881" y="1961989"/>
+            <a:ext cx="3841894" cy="1790701"/>
+          </a:xfrm>
+          <a:prstGeom prst="roundRect">
+            <a:avLst>
+              <a:gd name="adj" fmla="val 5234"/>
+            </a:avLst>
+          </a:prstGeom>
+          <a:solidFill>
+            <a:schemeClr val="bg1"/>
+          </a:solidFill>
+          <a:ln>
+            <a:solidFill>
+              <a:schemeClr val="tx1"/>
+            </a:solidFill>
+          </a:ln>
+        </p:spPr>
+        <p:style>
+          <a:lnRef idx="2">
+            <a:schemeClr val="accent1">
+              <a:shade val="15000"/>
+            </a:schemeClr>
+          </a:lnRef>
+          <a:fillRef idx="1">
+            <a:schemeClr val="accent1"/>
+          </a:fillRef>
+          <a:effectRef idx="0">
+            <a:schemeClr val="accent1"/>
+          </a:effectRef>
+          <a:fontRef idx="minor">
+            <a:schemeClr val="lt1"/>
+          </a:fontRef>
+        </p:style>
+        <p:txBody>
+          <a:bodyPr rtlCol="0" anchor="t"/>
+          <a:lstStyle/>
+          <a:p>
+            <a:pPr algn="ctr"/>
+            <a:r>
+              <a:rPr lang="en-US" dirty="0">
+                <a:solidFill>
+                  <a:schemeClr val="tx1"/>
+                </a:solidFill>
+              </a:rPr>
+              <a:t>Microsoft Foundry</a:t>
+            </a:r>
+          </a:p>
+        </p:txBody>
+      </p:sp>
+      <p:grpSp>
+        <p:nvGrpSpPr>
+          <p:cNvPr id="20" name="Group 19">
+            <a:extLst>
+              <a:ext uri="{FF2B5EF4-FFF2-40B4-BE49-F238E27FC236}">
+                <a16:creationId xmlns:a16="http://schemas.microsoft.com/office/drawing/2014/main" id="{3C8D5DE6-7408-3D08-510F-FAA473A61DAF}"/>
+              </a:ext>
+            </a:extLst>
+          </p:cNvPr>
+          <p:cNvGrpSpPr/>
+          <p:nvPr/>
+        </p:nvGrpSpPr>
+        <p:grpSpPr>
+          <a:xfrm>
+            <a:off x="492634" y="2520363"/>
+            <a:ext cx="3213551" cy="870652"/>
+            <a:chOff x="1094614" y="2520363"/>
+            <a:chExt cx="3213551" cy="870652"/>
+          </a:xfrm>
+        </p:grpSpPr>
+        <p:sp>
+          <p:nvSpPr>
+            <p:cNvPr id="3" name="Rectangle: Rounded Corners 2">
+              <a:extLst>
+                <a:ext uri="{FF2B5EF4-FFF2-40B4-BE49-F238E27FC236}">
+                  <a16:creationId xmlns:a16="http://schemas.microsoft.com/office/drawing/2014/main" id="{A912725C-460A-B2C6-B45E-AFDA16950EF5}"/>
+                </a:ext>
+              </a:extLst>
+            </p:cNvPr>
+            <p:cNvSpPr/>
+            <p:nvPr/>
+          </p:nvSpPr>
+          <p:spPr>
+            <a:xfrm>
+              <a:off x="1094614" y="2520363"/>
+              <a:ext cx="1340237" cy="870652"/>
+            </a:xfrm>
+            <a:prstGeom prst="roundRect">
+              <a:avLst/>
+            </a:prstGeom>
+            <a:solidFill>
+              <a:srgbClr val="E5F1F8"/>
+            </a:solidFill>
+            <a:ln>
+              <a:solidFill>
+                <a:schemeClr val="tx1"/>
+              </a:solidFill>
+            </a:ln>
+          </p:spPr>
+          <p:style>
+            <a:lnRef idx="2">
+              <a:schemeClr val="accent1">
+                <a:shade val="15000"/>
+              </a:schemeClr>
+            </a:lnRef>
+            <a:fillRef idx="1">
+              <a:schemeClr val="accent1"/>
+            </a:fillRef>
+            <a:effectRef idx="0">
+              <a:schemeClr val="accent1"/>
+            </a:effectRef>
+            <a:fontRef idx="minor">
+              <a:schemeClr val="lt1"/>
+            </a:fontRef>
+          </p:style>
+          <p:txBody>
+            <a:bodyPr rtlCol="0" anchor="ctr"/>
+            <a:lstStyle/>
+            <a:p>
+              <a:pPr algn="ctr"/>
+              <a:r>
+                <a:rPr lang="en-US" dirty="0">
+                  <a:solidFill>
+                    <a:schemeClr val="tx1"/>
+                  </a:solidFill>
+                </a:rPr>
+                <a:t>Agent</a:t>
+              </a:r>
+            </a:p>
+          </p:txBody>
+        </p:sp>
+        <p:sp>
+          <p:nvSpPr>
+            <p:cNvPr id="4" name="Rectangle: Rounded Corners 3">
+              <a:extLst>
+                <a:ext uri="{FF2B5EF4-FFF2-40B4-BE49-F238E27FC236}">
+                  <a16:creationId xmlns:a16="http://schemas.microsoft.com/office/drawing/2014/main" id="{E5663406-1A83-EB63-FD18-62122032389D}"/>
+                </a:ext>
+              </a:extLst>
+            </p:cNvPr>
+            <p:cNvSpPr/>
+            <p:nvPr/>
+          </p:nvSpPr>
+          <p:spPr>
+            <a:xfrm>
+              <a:off x="2967928" y="2520363"/>
+              <a:ext cx="1340237" cy="870652"/>
+            </a:xfrm>
+            <a:prstGeom prst="roundRect">
+              <a:avLst/>
+            </a:prstGeom>
+            <a:solidFill>
+              <a:srgbClr val="E5F1F8"/>
+            </a:solidFill>
+            <a:ln>
+              <a:solidFill>
+                <a:schemeClr val="tx1"/>
+              </a:solidFill>
+            </a:ln>
+          </p:spPr>
+          <p:style>
+            <a:lnRef idx="2">
+              <a:schemeClr val="accent1">
+                <a:shade val="15000"/>
+              </a:schemeClr>
+            </a:lnRef>
+            <a:fillRef idx="1">
+              <a:schemeClr val="accent1"/>
+            </a:fillRef>
+            <a:effectRef idx="0">
+              <a:schemeClr val="accent1"/>
+            </a:effectRef>
+            <a:fontRef idx="minor">
+              <a:schemeClr val="lt1"/>
+            </a:fontRef>
+          </p:style>
+          <p:txBody>
+            <a:bodyPr rtlCol="0" anchor="ctr"/>
+            <a:lstStyle/>
+            <a:p>
+              <a:pPr algn="ctr"/>
+              <a:r>
+                <a:rPr lang="en-US" dirty="0">
+                  <a:solidFill>
+                    <a:schemeClr val="tx1"/>
+                  </a:solidFill>
+                </a:rPr>
+                <a:t>MCP Client</a:t>
+              </a:r>
+            </a:p>
+          </p:txBody>
+        </p:sp>
+      </p:grpSp>
+      <p:sp>
+        <p:nvSpPr>
+          <p:cNvPr id="5" name="Rectangle: Rounded Corners 4">
+            <a:extLst>
+              <a:ext uri="{FF2B5EF4-FFF2-40B4-BE49-F238E27FC236}">
+                <a16:creationId xmlns:a16="http://schemas.microsoft.com/office/drawing/2014/main" id="{7A06BC94-073A-00F0-7B7A-53ABD805A1C4}"/>
+              </a:ext>
+            </a:extLst>
+          </p:cNvPr>
+          <p:cNvSpPr/>
+          <p:nvPr/>
+        </p:nvSpPr>
+        <p:spPr>
+          <a:xfrm>
+            <a:off x="5159832" y="804800"/>
+            <a:ext cx="2406383" cy="4059193"/>
+          </a:xfrm>
+          <a:prstGeom prst="roundRect">
+            <a:avLst>
+              <a:gd name="adj" fmla="val 5234"/>
+            </a:avLst>
+          </a:prstGeom>
+          <a:solidFill>
+            <a:schemeClr val="bg1"/>
+          </a:solidFill>
+          <a:ln>
+            <a:solidFill>
+              <a:schemeClr val="tx1"/>
+            </a:solidFill>
+          </a:ln>
+        </p:spPr>
+        <p:style>
+          <a:lnRef idx="2">
+            <a:schemeClr val="accent1">
+              <a:shade val="15000"/>
+            </a:schemeClr>
+          </a:lnRef>
+          <a:fillRef idx="1">
+            <a:schemeClr val="accent1"/>
+          </a:fillRef>
+          <a:effectRef idx="0">
+            <a:schemeClr val="accent1"/>
+          </a:effectRef>
+          <a:fontRef idx="minor">
+            <a:schemeClr val="lt1"/>
+          </a:fontRef>
+        </p:style>
+        <p:txBody>
+          <a:bodyPr rtlCol="0" anchor="t"/>
+          <a:lstStyle/>
+          <a:p>
+            <a:pPr algn="ctr"/>
+            <a:r>
+              <a:rPr lang="en-US" dirty="0">
+                <a:solidFill>
+                  <a:schemeClr val="tx1"/>
+                </a:solidFill>
+              </a:rPr>
+              <a:t>MCP Servers</a:t>
+            </a:r>
+          </a:p>
+        </p:txBody>
+      </p:sp>
+      <p:sp>
+        <p:nvSpPr>
+          <p:cNvPr id="6" name="Rectangle: Rounded Corners 5">
+            <a:extLst>
+              <a:ext uri="{FF2B5EF4-FFF2-40B4-BE49-F238E27FC236}">
+                <a16:creationId xmlns:a16="http://schemas.microsoft.com/office/drawing/2014/main" id="{B66DD466-80C6-ABEA-A847-87533B9DAE34}"/>
+              </a:ext>
+            </a:extLst>
+          </p:cNvPr>
+          <p:cNvSpPr/>
+          <p:nvPr/>
+        </p:nvSpPr>
+        <p:spPr>
+          <a:xfrm>
+            <a:off x="5692902" y="2520363"/>
+            <a:ext cx="1340237" cy="870652"/>
+          </a:xfrm>
+          <a:prstGeom prst="roundRect">
+            <a:avLst/>
+          </a:prstGeom>
+          <a:solidFill>
+            <a:srgbClr val="E5F1F8"/>
+          </a:solidFill>
+          <a:ln>
+            <a:solidFill>
+              <a:schemeClr val="tx1"/>
+            </a:solidFill>
+          </a:ln>
+        </p:spPr>
+        <p:style>
+          <a:lnRef idx="2">
+            <a:schemeClr val="accent1">
+              <a:shade val="15000"/>
+            </a:schemeClr>
+          </a:lnRef>
+          <a:fillRef idx="1">
+            <a:schemeClr val="accent1"/>
+          </a:fillRef>
+          <a:effectRef idx="0">
+            <a:schemeClr val="accent1"/>
+          </a:effectRef>
+          <a:fontRef idx="minor">
+            <a:schemeClr val="lt1"/>
+          </a:fontRef>
+        </p:style>
+        <p:txBody>
+          <a:bodyPr rtlCol="0" anchor="ctr"/>
+          <a:lstStyle/>
+          <a:p>
+            <a:pPr algn="ctr"/>
+            <a:r>
+              <a:rPr lang="en-US" dirty="0">
+                <a:solidFill>
+                  <a:schemeClr val="tx1"/>
+                </a:solidFill>
+              </a:rPr>
+              <a:t>File Storage MCP Server</a:t>
+            </a:r>
+          </a:p>
+        </p:txBody>
+      </p:sp>
+      <p:sp>
+        <p:nvSpPr>
+          <p:cNvPr id="7" name="Rectangle: Rounded Corners 6">
+            <a:extLst>
+              <a:ext uri="{FF2B5EF4-FFF2-40B4-BE49-F238E27FC236}">
+                <a16:creationId xmlns:a16="http://schemas.microsoft.com/office/drawing/2014/main" id="{93581B78-846C-5C2B-AD8B-2A27DE6133B0}"/>
+              </a:ext>
+            </a:extLst>
+          </p:cNvPr>
+          <p:cNvSpPr/>
+          <p:nvPr/>
+        </p:nvSpPr>
+        <p:spPr>
+          <a:xfrm>
+            <a:off x="5692901" y="1412582"/>
+            <a:ext cx="1340237" cy="870652"/>
+          </a:xfrm>
+          <a:prstGeom prst="roundRect">
+            <a:avLst/>
+          </a:prstGeom>
+          <a:solidFill>
+            <a:srgbClr val="E5F1F8"/>
+          </a:solidFill>
+          <a:ln>
+            <a:solidFill>
+              <a:schemeClr val="tx1"/>
+            </a:solidFill>
+          </a:ln>
+        </p:spPr>
+        <p:style>
+          <a:lnRef idx="2">
+            <a:schemeClr val="accent1">
+              <a:shade val="15000"/>
+            </a:schemeClr>
+          </a:lnRef>
+          <a:fillRef idx="1">
+            <a:schemeClr val="accent1"/>
+          </a:fillRef>
+          <a:effectRef idx="0">
+            <a:schemeClr val="accent1"/>
+          </a:effectRef>
+          <a:fontRef idx="minor">
+            <a:schemeClr val="lt1"/>
+          </a:fontRef>
+        </p:style>
+        <p:txBody>
+          <a:bodyPr rtlCol="0" anchor="ctr"/>
+          <a:lstStyle/>
+          <a:p>
+            <a:pPr algn="ctr"/>
+            <a:r>
+              <a:rPr lang="en-US" dirty="0">
+                <a:solidFill>
+                  <a:schemeClr val="tx1"/>
+                </a:solidFill>
+              </a:rPr>
+              <a:t>Third-Party MCP Server</a:t>
+            </a:r>
+          </a:p>
+        </p:txBody>
+      </p:sp>
+      <p:sp>
+        <p:nvSpPr>
+          <p:cNvPr id="8" name="Rectangle: Rounded Corners 7">
+            <a:extLst>
+              <a:ext uri="{FF2B5EF4-FFF2-40B4-BE49-F238E27FC236}">
+                <a16:creationId xmlns:a16="http://schemas.microsoft.com/office/drawing/2014/main" id="{4CA2D4C7-E2C9-BE70-32B0-9E817B3AD4C5}"/>
+              </a:ext>
+            </a:extLst>
+          </p:cNvPr>
+          <p:cNvSpPr/>
+          <p:nvPr/>
+        </p:nvSpPr>
+        <p:spPr>
+          <a:xfrm>
+            <a:off x="5692900" y="3628144"/>
+            <a:ext cx="1340237" cy="870652"/>
+          </a:xfrm>
+          <a:prstGeom prst="roundRect">
+            <a:avLst/>
+          </a:prstGeom>
+          <a:solidFill>
+            <a:srgbClr val="E5F1F8"/>
+          </a:solidFill>
+          <a:ln>
+            <a:solidFill>
+              <a:schemeClr val="tx1"/>
+            </a:solidFill>
+          </a:ln>
+        </p:spPr>
+        <p:style>
+          <a:lnRef idx="2">
+            <a:schemeClr val="accent1">
+              <a:shade val="15000"/>
+            </a:schemeClr>
+          </a:lnRef>
+          <a:fillRef idx="1">
+            <a:schemeClr val="accent1"/>
+          </a:fillRef>
+          <a:effectRef idx="0">
+            <a:schemeClr val="accent1"/>
+          </a:effectRef>
+          <a:fontRef idx="minor">
+            <a:schemeClr val="lt1"/>
+          </a:fontRef>
+        </p:style>
+        <p:txBody>
+          <a:bodyPr rtlCol="0" anchor="ctr"/>
+          <a:lstStyle/>
+          <a:p>
+            <a:pPr algn="ctr"/>
+            <a:r>
+              <a:rPr lang="en-US" dirty="0">
+                <a:solidFill>
+                  <a:schemeClr val="tx1"/>
+                </a:solidFill>
+              </a:rPr>
+              <a:t>Database</a:t>
+            </a:r>
+          </a:p>
+          <a:p>
+            <a:pPr algn="ctr"/>
+            <a:r>
+              <a:rPr lang="en-US" dirty="0">
+                <a:solidFill>
+                  <a:schemeClr val="tx1"/>
+                </a:solidFill>
+              </a:rPr>
+              <a:t>MCP Server</a:t>
+            </a:r>
+          </a:p>
+        </p:txBody>
+      </p:sp>
+      <p:sp>
+        <p:nvSpPr>
+          <p:cNvPr id="10" name="Rectangle: Rounded Corners 9">
+            <a:extLst>
+              <a:ext uri="{FF2B5EF4-FFF2-40B4-BE49-F238E27FC236}">
+                <a16:creationId xmlns:a16="http://schemas.microsoft.com/office/drawing/2014/main" id="{E9A04995-C98F-AF75-E6DC-AFDAD76B392B}"/>
+              </a:ext>
+            </a:extLst>
+          </p:cNvPr>
+          <p:cNvSpPr/>
+          <p:nvPr/>
+        </p:nvSpPr>
+        <p:spPr>
+          <a:xfrm>
+            <a:off x="9067023" y="804800"/>
+            <a:ext cx="2406383" cy="4059193"/>
+          </a:xfrm>
+          <a:prstGeom prst="roundRect">
+            <a:avLst>
+              <a:gd name="adj" fmla="val 5234"/>
+            </a:avLst>
+          </a:prstGeom>
+          <a:solidFill>
+            <a:schemeClr val="bg1"/>
+          </a:solidFill>
+          <a:ln>
+            <a:solidFill>
+              <a:schemeClr val="tx1"/>
+            </a:solidFill>
+          </a:ln>
+        </p:spPr>
+        <p:style>
+          <a:lnRef idx="2">
+            <a:schemeClr val="accent1">
+              <a:shade val="15000"/>
+            </a:schemeClr>
+          </a:lnRef>
+          <a:fillRef idx="1">
+            <a:schemeClr val="accent1"/>
+          </a:fillRef>
+          <a:effectRef idx="0">
+            <a:schemeClr val="accent1"/>
+          </a:effectRef>
+          <a:fontRef idx="minor">
+            <a:schemeClr val="lt1"/>
+          </a:fontRef>
+        </p:style>
+        <p:txBody>
+          <a:bodyPr rtlCol="0" anchor="t"/>
+          <a:lstStyle/>
+          <a:p>
+            <a:pPr algn="ctr"/>
+            <a:r>
+              <a:rPr lang="en-US" dirty="0">
+                <a:solidFill>
+                  <a:schemeClr val="tx1"/>
+                </a:solidFill>
+              </a:rPr>
+              <a:t>External Services</a:t>
+            </a:r>
+          </a:p>
+        </p:txBody>
+      </p:sp>
+      <p:sp>
+        <p:nvSpPr>
+          <p:cNvPr id="11" name="Rectangle: Rounded Corners 10">
+            <a:extLst>
+              <a:ext uri="{FF2B5EF4-FFF2-40B4-BE49-F238E27FC236}">
+                <a16:creationId xmlns:a16="http://schemas.microsoft.com/office/drawing/2014/main" id="{B5A15264-2CA2-94CF-802C-8F148D56ECAF}"/>
+              </a:ext>
+            </a:extLst>
+          </p:cNvPr>
+          <p:cNvSpPr/>
+          <p:nvPr/>
+        </p:nvSpPr>
+        <p:spPr>
+          <a:xfrm>
+            <a:off x="9600093" y="2520363"/>
+            <a:ext cx="1340237" cy="870652"/>
+          </a:xfrm>
+          <a:prstGeom prst="roundRect">
+            <a:avLst/>
+          </a:prstGeom>
+          <a:solidFill>
+            <a:srgbClr val="E5F1F8"/>
+          </a:solidFill>
+          <a:ln>
+            <a:solidFill>
+              <a:schemeClr val="tx1"/>
+            </a:solidFill>
+          </a:ln>
+        </p:spPr>
+        <p:style>
+          <a:lnRef idx="2">
+            <a:schemeClr val="accent1">
+              <a:shade val="15000"/>
+            </a:schemeClr>
+          </a:lnRef>
+          <a:fillRef idx="1">
+            <a:schemeClr val="accent1"/>
+          </a:fillRef>
+          <a:effectRef idx="0">
+            <a:schemeClr val="accent1"/>
+          </a:effectRef>
+          <a:fontRef idx="minor">
+            <a:schemeClr val="lt1"/>
+          </a:fontRef>
+        </p:style>
+        <p:txBody>
+          <a:bodyPr rtlCol="0" anchor="ctr"/>
+          <a:lstStyle/>
+          <a:p>
+            <a:pPr algn="ctr"/>
+            <a:r>
+              <a:rPr lang="en-US" dirty="0">
+                <a:solidFill>
+                  <a:schemeClr val="tx1"/>
+                </a:solidFill>
+              </a:rPr>
+              <a:t>Blob Storage</a:t>
+            </a:r>
+          </a:p>
+        </p:txBody>
+      </p:sp>
+      <p:sp>
+        <p:nvSpPr>
+          <p:cNvPr id="12" name="Rectangle: Rounded Corners 11">
+            <a:extLst>
+              <a:ext uri="{FF2B5EF4-FFF2-40B4-BE49-F238E27FC236}">
+                <a16:creationId xmlns:a16="http://schemas.microsoft.com/office/drawing/2014/main" id="{F9FB5A06-89C1-2865-4EBC-BFD77D31C7E0}"/>
+              </a:ext>
+            </a:extLst>
+          </p:cNvPr>
+          <p:cNvSpPr/>
+          <p:nvPr/>
+        </p:nvSpPr>
+        <p:spPr>
+          <a:xfrm>
+            <a:off x="9600092" y="1412582"/>
+            <a:ext cx="1340237" cy="870652"/>
+          </a:xfrm>
+          <a:prstGeom prst="roundRect">
+            <a:avLst/>
+          </a:prstGeom>
+          <a:solidFill>
+            <a:srgbClr val="E5F1F8"/>
+          </a:solidFill>
+          <a:ln>
+            <a:solidFill>
+              <a:schemeClr val="tx1"/>
+            </a:solidFill>
+          </a:ln>
+        </p:spPr>
+        <p:style>
+          <a:lnRef idx="2">
+            <a:schemeClr val="accent1">
+              <a:shade val="15000"/>
+            </a:schemeClr>
+          </a:lnRef>
+          <a:fillRef idx="1">
+            <a:schemeClr val="accent1"/>
+          </a:fillRef>
+          <a:effectRef idx="0">
+            <a:schemeClr val="accent1"/>
+          </a:effectRef>
+          <a:fontRef idx="minor">
+            <a:schemeClr val="lt1"/>
+          </a:fontRef>
+        </p:style>
+        <p:txBody>
+          <a:bodyPr rtlCol="0" anchor="ctr"/>
+          <a:lstStyle/>
+          <a:p>
+            <a:pPr algn="ctr"/>
+            <a:r>
+              <a:rPr lang="en-US" dirty="0">
+                <a:solidFill>
+                  <a:schemeClr val="tx1"/>
+                </a:solidFill>
+              </a:rPr>
+              <a:t>SaaS App</a:t>
+            </a:r>
+          </a:p>
+        </p:txBody>
+      </p:sp>
+      <p:sp>
+        <p:nvSpPr>
+          <p:cNvPr id="13" name="Rectangle: Rounded Corners 12">
+            <a:extLst>
+              <a:ext uri="{FF2B5EF4-FFF2-40B4-BE49-F238E27FC236}">
+                <a16:creationId xmlns:a16="http://schemas.microsoft.com/office/drawing/2014/main" id="{22A69AFF-6121-37F3-566A-DE1AA9EF9D38}"/>
+              </a:ext>
+            </a:extLst>
+          </p:cNvPr>
+          <p:cNvSpPr/>
+          <p:nvPr/>
+        </p:nvSpPr>
+        <p:spPr>
+          <a:xfrm>
+            <a:off x="9600091" y="3628144"/>
+            <a:ext cx="1340237" cy="870652"/>
+          </a:xfrm>
+          <a:prstGeom prst="roundRect">
+            <a:avLst/>
+          </a:prstGeom>
+          <a:solidFill>
+            <a:srgbClr val="E5F1F8"/>
+          </a:solidFill>
+          <a:ln>
+            <a:solidFill>
+              <a:schemeClr val="tx1"/>
+            </a:solidFill>
+          </a:ln>
+        </p:spPr>
+        <p:style>
+          <a:lnRef idx="2">
+            <a:schemeClr val="accent1">
+              <a:shade val="15000"/>
+            </a:schemeClr>
+          </a:lnRef>
+          <a:fillRef idx="1">
+            <a:schemeClr val="accent1"/>
+          </a:fillRef>
+          <a:effectRef idx="0">
+            <a:schemeClr val="accent1"/>
+          </a:effectRef>
+          <a:fontRef idx="minor">
+            <a:schemeClr val="lt1"/>
+          </a:fontRef>
+        </p:style>
+        <p:txBody>
+          <a:bodyPr rtlCol="0" anchor="ctr"/>
+          <a:lstStyle/>
+          <a:p>
+            <a:pPr algn="ctr"/>
+            <a:r>
+              <a:rPr lang="en-US" dirty="0">
+                <a:solidFill>
+                  <a:schemeClr val="tx1"/>
+                </a:solidFill>
+              </a:rPr>
+              <a:t>Database</a:t>
+            </a:r>
+          </a:p>
+        </p:txBody>
+      </p:sp>
+      <p:cxnSp>
+        <p:nvCxnSpPr>
+          <p:cNvPr id="15" name="Straight Arrow Connector 14">
+            <a:extLst>
+              <a:ext uri="{FF2B5EF4-FFF2-40B4-BE49-F238E27FC236}">
+                <a16:creationId xmlns:a16="http://schemas.microsoft.com/office/drawing/2014/main" id="{6A8B2231-37D8-6CF7-3B6C-0CA623A3A208}"/>
+              </a:ext>
+            </a:extLst>
+          </p:cNvPr>
+          <p:cNvCxnSpPr>
+            <a:cxnSpLocks/>
+            <a:stCxn id="3" idx="3"/>
+            <a:endCxn id="4" idx="1"/>
+          </p:cNvCxnSpPr>
+          <p:nvPr/>
+        </p:nvCxnSpPr>
+        <p:spPr>
+          <a:xfrm>
+            <a:off x="1832871" y="2955689"/>
+            <a:ext cx="533077" cy="0"/>
+          </a:xfrm>
+          <a:prstGeom prst="straightConnector1">
+            <a:avLst/>
+          </a:prstGeom>
+          <a:ln>
+            <a:solidFill>
+              <a:schemeClr val="tx1"/>
+            </a:solidFill>
+            <a:prstDash val="solid"/>
+            <a:headEnd type="triangle" w="lg" len="lg"/>
+            <a:tailEnd type="triangle" w="lg" len="lg"/>
+          </a:ln>
+        </p:spPr>
+        <p:style>
+          <a:lnRef idx="2">
+            <a:schemeClr val="accent1"/>
+          </a:lnRef>
+          <a:fillRef idx="0">
+            <a:schemeClr val="accent1"/>
+          </a:fillRef>
+          <a:effectRef idx="1">
+            <a:schemeClr val="accent1"/>
+          </a:effectRef>
+          <a:fontRef idx="minor">
+            <a:schemeClr val="tx1"/>
+          </a:fontRef>
+        </p:style>
+      </p:cxnSp>
+      <p:cxnSp>
+        <p:nvCxnSpPr>
+          <p:cNvPr id="22" name="Straight Arrow Connector 21">
+            <a:extLst>
+              <a:ext uri="{FF2B5EF4-FFF2-40B4-BE49-F238E27FC236}">
+                <a16:creationId xmlns:a16="http://schemas.microsoft.com/office/drawing/2014/main" id="{B6AF12AA-901C-45D0-7A07-FC55AAB45F61}"/>
+              </a:ext>
+            </a:extLst>
+          </p:cNvPr>
+          <p:cNvCxnSpPr>
+            <a:cxnSpLocks/>
+            <a:stCxn id="7" idx="3"/>
+            <a:endCxn id="12" idx="1"/>
+          </p:cNvCxnSpPr>
+          <p:nvPr/>
+        </p:nvCxnSpPr>
+        <p:spPr>
+          <a:xfrm>
+            <a:off x="7033138" y="1847908"/>
+            <a:ext cx="2566954" cy="0"/>
+          </a:xfrm>
+          <a:prstGeom prst="straightConnector1">
+            <a:avLst/>
+          </a:prstGeom>
+          <a:ln>
+            <a:solidFill>
+              <a:schemeClr val="tx1"/>
+            </a:solidFill>
+            <a:prstDash val="sysDash"/>
+            <a:tailEnd type="triangle" w="lg" len="lg"/>
+          </a:ln>
+        </p:spPr>
+        <p:style>
+          <a:lnRef idx="2">
+            <a:schemeClr val="accent1"/>
+          </a:lnRef>
+          <a:fillRef idx="0">
+            <a:schemeClr val="accent1"/>
+          </a:fillRef>
+          <a:effectRef idx="1">
+            <a:schemeClr val="accent1"/>
+          </a:effectRef>
+          <a:fontRef idx="minor">
+            <a:schemeClr val="tx1"/>
+          </a:fontRef>
+        </p:style>
+      </p:cxnSp>
+      <p:cxnSp>
+        <p:nvCxnSpPr>
+          <p:cNvPr id="25" name="Straight Arrow Connector 24">
+            <a:extLst>
+              <a:ext uri="{FF2B5EF4-FFF2-40B4-BE49-F238E27FC236}">
+                <a16:creationId xmlns:a16="http://schemas.microsoft.com/office/drawing/2014/main" id="{B39D667D-0422-43D5-28F2-605AE5941F22}"/>
+              </a:ext>
+            </a:extLst>
+          </p:cNvPr>
+          <p:cNvCxnSpPr>
+            <a:cxnSpLocks/>
+            <a:stCxn id="6" idx="3"/>
+            <a:endCxn id="11" idx="1"/>
+          </p:cNvCxnSpPr>
+          <p:nvPr/>
+        </p:nvCxnSpPr>
+        <p:spPr>
+          <a:xfrm>
+            <a:off x="7033139" y="2955689"/>
+            <a:ext cx="2566954" cy="0"/>
+          </a:xfrm>
+          <a:prstGeom prst="straightConnector1">
+            <a:avLst/>
+          </a:prstGeom>
+          <a:ln>
+            <a:solidFill>
+              <a:schemeClr val="tx1"/>
+            </a:solidFill>
+            <a:prstDash val="sysDash"/>
+            <a:tailEnd type="triangle" w="lg" len="lg"/>
+          </a:ln>
+        </p:spPr>
+        <p:style>
+          <a:lnRef idx="2">
+            <a:schemeClr val="accent1"/>
+          </a:lnRef>
+          <a:fillRef idx="0">
+            <a:schemeClr val="accent1"/>
+          </a:fillRef>
+          <a:effectRef idx="1">
+            <a:schemeClr val="accent1"/>
+          </a:effectRef>
+          <a:fontRef idx="minor">
+            <a:schemeClr val="tx1"/>
+          </a:fontRef>
+        </p:style>
+      </p:cxnSp>
+      <p:cxnSp>
+        <p:nvCxnSpPr>
+          <p:cNvPr id="28" name="Straight Arrow Connector 27">
+            <a:extLst>
+              <a:ext uri="{FF2B5EF4-FFF2-40B4-BE49-F238E27FC236}">
+                <a16:creationId xmlns:a16="http://schemas.microsoft.com/office/drawing/2014/main" id="{8A2CC6C4-B8F4-865E-18AE-A24BC6F4AF3A}"/>
+              </a:ext>
+            </a:extLst>
+          </p:cNvPr>
+          <p:cNvCxnSpPr>
+            <a:cxnSpLocks/>
+            <a:stCxn id="8" idx="3"/>
+            <a:endCxn id="13" idx="1"/>
+          </p:cNvCxnSpPr>
+          <p:nvPr/>
+        </p:nvCxnSpPr>
+        <p:spPr>
+          <a:xfrm>
+            <a:off x="7033137" y="4063470"/>
+            <a:ext cx="2566954" cy="0"/>
+          </a:xfrm>
+          <a:prstGeom prst="straightConnector1">
+            <a:avLst/>
+          </a:prstGeom>
+          <a:ln>
+            <a:solidFill>
+              <a:schemeClr val="tx1"/>
+            </a:solidFill>
+            <a:prstDash val="sysDash"/>
+            <a:tailEnd type="triangle" w="lg" len="lg"/>
+          </a:ln>
+        </p:spPr>
+        <p:style>
+          <a:lnRef idx="2">
+            <a:schemeClr val="accent1"/>
+          </a:lnRef>
+          <a:fillRef idx="0">
+            <a:schemeClr val="accent1"/>
+          </a:fillRef>
+          <a:effectRef idx="1">
+            <a:schemeClr val="accent1"/>
+          </a:effectRef>
+          <a:fontRef idx="minor">
+            <a:schemeClr val="tx1"/>
+          </a:fontRef>
+        </p:style>
+      </p:cxnSp>
+      <p:cxnSp>
+        <p:nvCxnSpPr>
+          <p:cNvPr id="31" name="Connector: Elbow 30">
+            <a:extLst>
+              <a:ext uri="{FF2B5EF4-FFF2-40B4-BE49-F238E27FC236}">
+                <a16:creationId xmlns:a16="http://schemas.microsoft.com/office/drawing/2014/main" id="{B97CD07A-2870-7437-2F7C-3F75E24EB5CF}"/>
+              </a:ext>
+            </a:extLst>
+          </p:cNvPr>
+          <p:cNvCxnSpPr>
+            <a:cxnSpLocks/>
+            <a:stCxn id="4" idx="3"/>
+            <a:endCxn id="7" idx="1"/>
+          </p:cNvCxnSpPr>
+          <p:nvPr/>
+        </p:nvCxnSpPr>
+        <p:spPr>
+          <a:xfrm flipV="1">
+            <a:off x="3706185" y="1847908"/>
+            <a:ext cx="1986716" cy="1107781"/>
+          </a:xfrm>
+          <a:prstGeom prst="bentConnector3">
+            <a:avLst>
+              <a:gd name="adj1" fmla="val 50000"/>
+            </a:avLst>
+          </a:prstGeom>
+          <a:ln>
+            <a:solidFill>
+              <a:schemeClr val="tx1"/>
+            </a:solidFill>
+            <a:prstDash val="solid"/>
+            <a:headEnd type="triangle" w="lg" len="lg"/>
+            <a:tailEnd type="triangle" w="lg" len="lg"/>
+          </a:ln>
+        </p:spPr>
+        <p:style>
+          <a:lnRef idx="2">
+            <a:schemeClr val="accent1"/>
+          </a:lnRef>
+          <a:fillRef idx="0">
+            <a:schemeClr val="accent1"/>
+          </a:fillRef>
+          <a:effectRef idx="1">
+            <a:schemeClr val="accent1"/>
+          </a:effectRef>
+          <a:fontRef idx="minor">
+            <a:schemeClr val="tx1"/>
+          </a:fontRef>
+        </p:style>
+      </p:cxnSp>
+      <p:cxnSp>
+        <p:nvCxnSpPr>
+          <p:cNvPr id="34" name="Connector: Elbow 33">
+            <a:extLst>
+              <a:ext uri="{FF2B5EF4-FFF2-40B4-BE49-F238E27FC236}">
+                <a16:creationId xmlns:a16="http://schemas.microsoft.com/office/drawing/2014/main" id="{18C5FA9F-3761-6651-D33F-2C24793118A2}"/>
+              </a:ext>
+            </a:extLst>
+          </p:cNvPr>
+          <p:cNvCxnSpPr>
+            <a:cxnSpLocks/>
+            <a:stCxn id="4" idx="3"/>
+            <a:endCxn id="8" idx="1"/>
+          </p:cNvCxnSpPr>
+          <p:nvPr/>
+        </p:nvCxnSpPr>
+        <p:spPr>
+          <a:xfrm>
+            <a:off x="3706185" y="2955689"/>
+            <a:ext cx="1986715" cy="1107781"/>
+          </a:xfrm>
+          <a:prstGeom prst="bentConnector3">
+            <a:avLst>
+              <a:gd name="adj1" fmla="val 50000"/>
+            </a:avLst>
+          </a:prstGeom>
+          <a:ln>
+            <a:solidFill>
+              <a:schemeClr val="tx1"/>
+            </a:solidFill>
+            <a:prstDash val="solid"/>
+            <a:headEnd type="triangle" w="lg" len="lg"/>
+            <a:tailEnd type="triangle" w="lg" len="lg"/>
+          </a:ln>
+        </p:spPr>
+        <p:style>
+          <a:lnRef idx="2">
+            <a:schemeClr val="accent1"/>
+          </a:lnRef>
+          <a:fillRef idx="0">
+            <a:schemeClr val="accent1"/>
+          </a:fillRef>
+          <a:effectRef idx="1">
+            <a:schemeClr val="accent1"/>
+          </a:effectRef>
+          <a:fontRef idx="minor">
+            <a:schemeClr val="tx1"/>
+          </a:fontRef>
+        </p:style>
+      </p:cxnSp>
+      <p:cxnSp>
+        <p:nvCxnSpPr>
+          <p:cNvPr id="37" name="Straight Arrow Connector 36">
+            <a:extLst>
+              <a:ext uri="{FF2B5EF4-FFF2-40B4-BE49-F238E27FC236}">
+                <a16:creationId xmlns:a16="http://schemas.microsoft.com/office/drawing/2014/main" id="{43E6F43D-CF04-FED6-7F22-B3883E121EF8}"/>
+              </a:ext>
+            </a:extLst>
+          </p:cNvPr>
+          <p:cNvCxnSpPr>
+            <a:cxnSpLocks/>
+            <a:stCxn id="4" idx="3"/>
+            <a:endCxn id="6" idx="1"/>
+          </p:cNvCxnSpPr>
+          <p:nvPr/>
+        </p:nvCxnSpPr>
+        <p:spPr>
+          <a:xfrm>
+            <a:off x="3706185" y="2955689"/>
+            <a:ext cx="1986717" cy="0"/>
+          </a:xfrm>
+          <a:prstGeom prst="straightConnector1">
+            <a:avLst/>
+          </a:prstGeom>
+          <a:ln>
+            <a:solidFill>
+              <a:schemeClr val="tx1"/>
+            </a:solidFill>
+            <a:prstDash val="solid"/>
+            <a:headEnd type="triangle" w="lg" len="lg"/>
+            <a:tailEnd type="triangle" w="lg" len="lg"/>
+          </a:ln>
+        </p:spPr>
+        <p:style>
+          <a:lnRef idx="2">
+            <a:schemeClr val="accent1"/>
+          </a:lnRef>
+          <a:fillRef idx="0">
+            <a:schemeClr val="accent1"/>
+          </a:fillRef>
+          <a:effectRef idx="1">
+            <a:schemeClr val="accent1"/>
+          </a:effectRef>
+          <a:fontRef idx="minor">
+            <a:schemeClr val="tx1"/>
+          </a:fontRef>
+        </p:style>
+      </p:cxnSp>
+      <p:sp>
+        <p:nvSpPr>
+          <p:cNvPr id="40" name="TextBox 39">
+            <a:extLst>
+              <a:ext uri="{FF2B5EF4-FFF2-40B4-BE49-F238E27FC236}">
+                <a16:creationId xmlns:a16="http://schemas.microsoft.com/office/drawing/2014/main" id="{50545247-9B5D-B18C-25FF-A2F607D94783}"/>
+              </a:ext>
+            </a:extLst>
+          </p:cNvPr>
+          <p:cNvSpPr txBox="1"/>
+          <p:nvPr/>
+        </p:nvSpPr>
+        <p:spPr>
+          <a:xfrm>
+            <a:off x="7920517" y="1478522"/>
+            <a:ext cx="792204" cy="369332"/>
+          </a:xfrm>
+          <a:prstGeom prst="rect">
+            <a:avLst/>
+          </a:prstGeom>
+          <a:noFill/>
+        </p:spPr>
+        <p:txBody>
+          <a:bodyPr wrap="none" rtlCol="0">
+            <a:spAutoFit/>
+          </a:bodyPr>
+          <a:lstStyle/>
+          <a:p>
+            <a:pPr algn="ctr"/>
+            <a:r>
+              <a:rPr lang="en-US" dirty="0"/>
+              <a:t>API Call</a:t>
+            </a:r>
+          </a:p>
+        </p:txBody>
+      </p:sp>
+      <p:sp>
+        <p:nvSpPr>
+          <p:cNvPr id="41" name="TextBox 40">
+            <a:extLst>
+              <a:ext uri="{FF2B5EF4-FFF2-40B4-BE49-F238E27FC236}">
+                <a16:creationId xmlns:a16="http://schemas.microsoft.com/office/drawing/2014/main" id="{0F2CCF29-E962-3B49-3A2F-5B7C8B1E62E0}"/>
+              </a:ext>
+            </a:extLst>
+          </p:cNvPr>
+          <p:cNvSpPr txBox="1"/>
+          <p:nvPr/>
+        </p:nvSpPr>
+        <p:spPr>
+          <a:xfrm>
+            <a:off x="7739820" y="2586250"/>
+            <a:ext cx="1153586" cy="369332"/>
+          </a:xfrm>
+          <a:prstGeom prst="rect">
+            <a:avLst/>
+          </a:prstGeom>
+          <a:noFill/>
+        </p:spPr>
+        <p:txBody>
+          <a:bodyPr wrap="none" rtlCol="0">
+            <a:spAutoFit/>
+          </a:bodyPr>
+          <a:lstStyle/>
+          <a:p>
+            <a:pPr algn="ctr"/>
+            <a:r>
+              <a:rPr lang="en-US" dirty="0"/>
+              <a:t>Python SDK</a:t>
+            </a:r>
+          </a:p>
+        </p:txBody>
+      </p:sp>
+      <p:sp>
+        <p:nvSpPr>
+          <p:cNvPr id="42" name="TextBox 41">
+            <a:extLst>
+              <a:ext uri="{FF2B5EF4-FFF2-40B4-BE49-F238E27FC236}">
+                <a16:creationId xmlns:a16="http://schemas.microsoft.com/office/drawing/2014/main" id="{683BC4EA-D032-66AD-9B5E-0313282962E7}"/>
+              </a:ext>
+            </a:extLst>
+          </p:cNvPr>
+          <p:cNvSpPr txBox="1"/>
+          <p:nvPr/>
+        </p:nvSpPr>
+        <p:spPr>
+          <a:xfrm>
+            <a:off x="7794098" y="3694030"/>
+            <a:ext cx="1045030" cy="369332"/>
+          </a:xfrm>
+          <a:prstGeom prst="rect">
+            <a:avLst/>
+          </a:prstGeom>
+          <a:noFill/>
+        </p:spPr>
+        <p:txBody>
+          <a:bodyPr wrap="none" rtlCol="0">
+            <a:spAutoFit/>
+          </a:bodyPr>
+          <a:lstStyle/>
+          <a:p>
+            <a:r>
+              <a:rPr lang="en-US" dirty="0"/>
+              <a:t>SQL Query</a:t>
+            </a:r>
+          </a:p>
+        </p:txBody>
+      </p:sp>
+      <p:sp>
+        <p:nvSpPr>
+          <p:cNvPr id="45" name="Rectangle: Rounded Corners 44">
+            <a:extLst>
+              <a:ext uri="{FF2B5EF4-FFF2-40B4-BE49-F238E27FC236}">
+                <a16:creationId xmlns:a16="http://schemas.microsoft.com/office/drawing/2014/main" id="{F84FB3F3-23CB-15B6-FD3C-E0EC33E4649A}"/>
+              </a:ext>
+            </a:extLst>
+          </p:cNvPr>
+          <p:cNvSpPr/>
+          <p:nvPr/>
+        </p:nvSpPr>
+        <p:spPr>
+          <a:xfrm rot="16200000">
+            <a:off x="4167506" y="2771023"/>
+            <a:ext cx="1054775" cy="369332"/>
+          </a:xfrm>
+          <a:prstGeom prst="roundRect">
+            <a:avLst/>
+          </a:prstGeom>
+          <a:solidFill>
+            <a:srgbClr val="B2D4EB"/>
+          </a:solidFill>
+          <a:ln>
+            <a:solidFill>
+              <a:schemeClr val="tx1"/>
+            </a:solidFill>
+          </a:ln>
+        </p:spPr>
+        <p:style>
+          <a:lnRef idx="2">
+            <a:schemeClr val="accent1">
+              <a:shade val="15000"/>
+            </a:schemeClr>
+          </a:lnRef>
+          <a:fillRef idx="1">
+            <a:schemeClr val="accent1"/>
+          </a:fillRef>
+          <a:effectRef idx="0">
+            <a:schemeClr val="accent1"/>
+          </a:effectRef>
+          <a:fontRef idx="minor">
+            <a:schemeClr val="lt1"/>
+          </a:fontRef>
+        </p:style>
+        <p:txBody>
+          <a:bodyPr rtlCol="0" anchor="ctr"/>
+          <a:lstStyle/>
+          <a:p>
+            <a:pPr algn="ctr"/>
+            <a:r>
+              <a:rPr lang="en-US" dirty="0">
+                <a:solidFill>
+                  <a:schemeClr val="tx1"/>
+                </a:solidFill>
+              </a:rPr>
+              <a:t>JSON-RPC</a:t>
+            </a:r>
+            <a:endParaRPr lang="en-US" i="1" dirty="0">
+              <a:solidFill>
+                <a:schemeClr val="tx1"/>
+              </a:solidFill>
+            </a:endParaRPr>
+          </a:p>
+        </p:txBody>
+      </p:sp>
+    </p:spTree>
+    <p:extLst>
+      <p:ext uri="{BB962C8B-B14F-4D97-AF65-F5344CB8AC3E}">
+        <p14:creationId xmlns:p14="http://schemas.microsoft.com/office/powerpoint/2010/main" val="566489712"/>
+      </p:ext>
+    </p:extLst>
+  </p:cSld>
+  <p:clrMapOvr>
+    <a:masterClrMapping/>
+  </p:clrMapOvr>
+</p:sld>
+</file>
+
+<file path=ppt/slides/slide9.xml><?xml version="1.0" encoding="utf-8"?>
 <p:sld xmlns:a="http://schemas.openxmlformats.org/drawingml/2006/main" xmlns:r="http://schemas.openxmlformats.org/officeDocument/2006/relationships" xmlns:p="http://schemas.openxmlformats.org/presentationml/2006/main">
   <p:cSld>
     <p:spTree>
@@ -10243,1390 +12878,6 @@
     <p:extLst>
       <p:ext uri="{BB962C8B-B14F-4D97-AF65-F5344CB8AC3E}">
         <p14:creationId xmlns:p14="http://schemas.microsoft.com/office/powerpoint/2010/main" val="3488000674"/>
-      </p:ext>
-    </p:extLst>
-  </p:cSld>
-  <p:clrMapOvr>
-    <a:masterClrMapping/>
-  </p:clrMapOvr>
-</p:sld>
-</file>
-
-<file path=ppt/slides/slide9.xml><?xml version="1.0" encoding="utf-8"?>
-<p:sld xmlns:a="http://schemas.openxmlformats.org/drawingml/2006/main" xmlns:r="http://schemas.openxmlformats.org/officeDocument/2006/relationships" xmlns:p="http://schemas.openxmlformats.org/presentationml/2006/main">
-  <p:cSld>
-    <p:spTree>
-      <p:nvGrpSpPr>
-        <p:cNvPr id="1" name=""/>
-        <p:cNvGrpSpPr/>
-        <p:nvPr/>
-      </p:nvGrpSpPr>
-      <p:grpSpPr>
-        <a:xfrm>
-          <a:off x="0" y="0"/>
-          <a:ext cx="0" cy="0"/>
-          <a:chOff x="0" y="0"/>
-          <a:chExt cx="0" cy="0"/>
-        </a:xfrm>
-      </p:grpSpPr>
-      <p:sp>
-        <p:nvSpPr>
-          <p:cNvPr id="2" name="Rectangle: Rounded Corners 1">
-            <a:extLst>
-              <a:ext uri="{FF2B5EF4-FFF2-40B4-BE49-F238E27FC236}">
-                <a16:creationId xmlns:a16="http://schemas.microsoft.com/office/drawing/2014/main" id="{F09FDC59-6067-4502-1360-F42554AD87D3}"/>
-              </a:ext>
-            </a:extLst>
-          </p:cNvPr>
-          <p:cNvSpPr/>
-          <p:nvPr/>
-        </p:nvSpPr>
-        <p:spPr>
-          <a:xfrm>
-            <a:off x="4046220" y="3398520"/>
-            <a:ext cx="4282440" cy="457200"/>
-          </a:xfrm>
-          <a:prstGeom prst="roundRect">
-            <a:avLst/>
-          </a:prstGeom>
-          <a:solidFill>
-            <a:srgbClr val="B2D4EB"/>
-          </a:solidFill>
-          <a:ln>
-            <a:solidFill>
-              <a:schemeClr val="tx1"/>
-            </a:solidFill>
-          </a:ln>
-        </p:spPr>
-        <p:style>
-          <a:lnRef idx="2">
-            <a:schemeClr val="accent1">
-              <a:shade val="15000"/>
-            </a:schemeClr>
-          </a:lnRef>
-          <a:fillRef idx="1">
-            <a:schemeClr val="accent1"/>
-          </a:fillRef>
-          <a:effectRef idx="0">
-            <a:schemeClr val="accent1"/>
-          </a:effectRef>
-          <a:fontRef idx="minor">
-            <a:schemeClr val="lt1"/>
-          </a:fontRef>
-        </p:style>
-        <p:txBody>
-          <a:bodyPr rtlCol="0" anchor="ctr"/>
-          <a:lstStyle/>
-          <a:p>
-            <a:pPr algn="ctr"/>
-            <a:r>
-              <a:rPr lang="en-US" dirty="0">
-                <a:solidFill>
-                  <a:schemeClr val="tx1"/>
-                </a:solidFill>
-              </a:rPr>
-              <a:t>Search Public Information on the Web</a:t>
-            </a:r>
-            <a:endParaRPr lang="en-US" i="1" dirty="0">
-              <a:solidFill>
-                <a:schemeClr val="tx1"/>
-              </a:solidFill>
-            </a:endParaRPr>
-          </a:p>
-        </p:txBody>
-      </p:sp>
-      <p:sp>
-        <p:nvSpPr>
-          <p:cNvPr id="3" name="Rectangle: Rounded Corners 2">
-            <a:extLst>
-              <a:ext uri="{FF2B5EF4-FFF2-40B4-BE49-F238E27FC236}">
-                <a16:creationId xmlns:a16="http://schemas.microsoft.com/office/drawing/2014/main" id="{9800FF13-E208-2C00-EB7C-BCBA48F554BD}"/>
-              </a:ext>
-            </a:extLst>
-          </p:cNvPr>
-          <p:cNvSpPr/>
-          <p:nvPr/>
-        </p:nvSpPr>
-        <p:spPr>
-          <a:xfrm>
-            <a:off x="4046220" y="2625554"/>
-            <a:ext cx="4282440" cy="457200"/>
-          </a:xfrm>
-          <a:prstGeom prst="roundRect">
-            <a:avLst/>
-          </a:prstGeom>
-          <a:solidFill>
-            <a:srgbClr val="B2D4EB"/>
-          </a:solidFill>
-          <a:ln>
-            <a:solidFill>
-              <a:schemeClr val="tx1"/>
-            </a:solidFill>
-          </a:ln>
-        </p:spPr>
-        <p:style>
-          <a:lnRef idx="2">
-            <a:schemeClr val="accent1">
-              <a:shade val="15000"/>
-            </a:schemeClr>
-          </a:lnRef>
-          <a:fillRef idx="1">
-            <a:schemeClr val="accent1"/>
-          </a:fillRef>
-          <a:effectRef idx="0">
-            <a:schemeClr val="accent1"/>
-          </a:effectRef>
-          <a:fontRef idx="minor">
-            <a:schemeClr val="lt1"/>
-          </a:fontRef>
-        </p:style>
-        <p:txBody>
-          <a:bodyPr rtlCol="0" anchor="ctr"/>
-          <a:lstStyle/>
-          <a:p>
-            <a:pPr algn="ctr"/>
-            <a:r>
-              <a:rPr lang="en-US" dirty="0">
-                <a:solidFill>
-                  <a:schemeClr val="tx1"/>
-                </a:solidFill>
-              </a:rPr>
-              <a:t>Retrieve Stock Quotes from an API</a:t>
-            </a:r>
-            <a:endParaRPr lang="en-US" i="1" dirty="0">
-              <a:solidFill>
-                <a:schemeClr val="tx1"/>
-              </a:solidFill>
-            </a:endParaRPr>
-          </a:p>
-        </p:txBody>
-      </p:sp>
-      <p:sp>
-        <p:nvSpPr>
-          <p:cNvPr id="4" name="Rectangle: Rounded Corners 3">
-            <a:extLst>
-              <a:ext uri="{FF2B5EF4-FFF2-40B4-BE49-F238E27FC236}">
-                <a16:creationId xmlns:a16="http://schemas.microsoft.com/office/drawing/2014/main" id="{CD952C55-0F41-C8E8-4833-F5F86239B3AD}"/>
-              </a:ext>
-            </a:extLst>
-          </p:cNvPr>
-          <p:cNvSpPr/>
-          <p:nvPr/>
-        </p:nvSpPr>
-        <p:spPr>
-          <a:xfrm>
-            <a:off x="4046220" y="1855003"/>
-            <a:ext cx="4282440" cy="457200"/>
-          </a:xfrm>
-          <a:prstGeom prst="roundRect">
-            <a:avLst/>
-          </a:prstGeom>
-          <a:solidFill>
-            <a:srgbClr val="B2D4EB"/>
-          </a:solidFill>
-          <a:ln>
-            <a:solidFill>
-              <a:schemeClr val="tx1"/>
-            </a:solidFill>
-          </a:ln>
-        </p:spPr>
-        <p:style>
-          <a:lnRef idx="2">
-            <a:schemeClr val="accent1">
-              <a:shade val="15000"/>
-            </a:schemeClr>
-          </a:lnRef>
-          <a:fillRef idx="1">
-            <a:schemeClr val="accent1"/>
-          </a:fillRef>
-          <a:effectRef idx="0">
-            <a:schemeClr val="accent1"/>
-          </a:effectRef>
-          <a:fontRef idx="minor">
-            <a:schemeClr val="lt1"/>
-          </a:fontRef>
-        </p:style>
-        <p:txBody>
-          <a:bodyPr rtlCol="0" anchor="ctr"/>
-          <a:lstStyle/>
-          <a:p>
-            <a:pPr algn="ctr"/>
-            <a:r>
-              <a:rPr lang="en-US" dirty="0">
-                <a:solidFill>
-                  <a:schemeClr val="tx1"/>
-                </a:solidFill>
-              </a:rPr>
-              <a:t>Reference Internal Report Files</a:t>
-            </a:r>
-            <a:endParaRPr lang="en-US" i="1" dirty="0">
-              <a:solidFill>
-                <a:schemeClr val="tx1"/>
-              </a:solidFill>
-            </a:endParaRPr>
-          </a:p>
-        </p:txBody>
-      </p:sp>
-      <p:sp>
-        <p:nvSpPr>
-          <p:cNvPr id="5" name="Rectangle: Rounded Corners 4">
-            <a:extLst>
-              <a:ext uri="{FF2B5EF4-FFF2-40B4-BE49-F238E27FC236}">
-                <a16:creationId xmlns:a16="http://schemas.microsoft.com/office/drawing/2014/main" id="{600226F7-C833-1B1C-B967-7291F64244CC}"/>
-              </a:ext>
-            </a:extLst>
-          </p:cNvPr>
-          <p:cNvSpPr/>
-          <p:nvPr/>
-        </p:nvSpPr>
-        <p:spPr>
-          <a:xfrm>
-            <a:off x="1507938" y="2374095"/>
-            <a:ext cx="1913442" cy="960119"/>
-          </a:xfrm>
-          <a:prstGeom prst="roundRect">
-            <a:avLst/>
-          </a:prstGeom>
-          <a:solidFill>
-            <a:srgbClr val="E5F1F8"/>
-          </a:solidFill>
-          <a:ln>
-            <a:solidFill>
-              <a:schemeClr val="tx1"/>
-            </a:solidFill>
-          </a:ln>
-        </p:spPr>
-        <p:style>
-          <a:lnRef idx="2">
-            <a:schemeClr val="accent1">
-              <a:shade val="15000"/>
-            </a:schemeClr>
-          </a:lnRef>
-          <a:fillRef idx="1">
-            <a:schemeClr val="accent1"/>
-          </a:fillRef>
-          <a:effectRef idx="0">
-            <a:schemeClr val="accent1"/>
-          </a:effectRef>
-          <a:fontRef idx="minor">
-            <a:schemeClr val="lt1"/>
-          </a:fontRef>
-        </p:style>
-        <p:txBody>
-          <a:bodyPr rtlCol="0" anchor="ctr"/>
-          <a:lstStyle/>
-          <a:p>
-            <a:pPr algn="ctr"/>
-            <a:r>
-              <a:rPr lang="en-US" dirty="0">
-                <a:solidFill>
-                  <a:schemeClr val="tx1"/>
-                </a:solidFill>
-              </a:rPr>
-              <a:t>Query</a:t>
-            </a:r>
-          </a:p>
-          <a:p>
-            <a:pPr algn="ctr"/>
-            <a:r>
-              <a:rPr lang="en-US" dirty="0">
-                <a:solidFill>
-                  <a:schemeClr val="tx1"/>
-                </a:solidFill>
-              </a:rPr>
-              <a:t>Planning</a:t>
-            </a:r>
-          </a:p>
-        </p:txBody>
-      </p:sp>
-      <p:sp>
-        <p:nvSpPr>
-          <p:cNvPr id="6" name="Rectangle: Rounded Corners 5">
-            <a:extLst>
-              <a:ext uri="{FF2B5EF4-FFF2-40B4-BE49-F238E27FC236}">
-                <a16:creationId xmlns:a16="http://schemas.microsoft.com/office/drawing/2014/main" id="{C93C6EBF-0FE7-EC6E-5B5C-7AA41F6606DD}"/>
-              </a:ext>
-            </a:extLst>
-          </p:cNvPr>
-          <p:cNvSpPr/>
-          <p:nvPr/>
-        </p:nvSpPr>
-        <p:spPr>
-          <a:xfrm>
-            <a:off x="9837420" y="2374095"/>
-            <a:ext cx="1913442" cy="960119"/>
-          </a:xfrm>
-          <a:prstGeom prst="roundRect">
-            <a:avLst/>
-          </a:prstGeom>
-          <a:solidFill>
-            <a:srgbClr val="E5F1F8"/>
-          </a:solidFill>
-          <a:ln>
-            <a:solidFill>
-              <a:schemeClr val="tx1"/>
-            </a:solidFill>
-          </a:ln>
-        </p:spPr>
-        <p:style>
-          <a:lnRef idx="2">
-            <a:schemeClr val="accent1">
-              <a:shade val="15000"/>
-            </a:schemeClr>
-          </a:lnRef>
-          <a:fillRef idx="1">
-            <a:schemeClr val="accent1"/>
-          </a:fillRef>
-          <a:effectRef idx="0">
-            <a:schemeClr val="accent1"/>
-          </a:effectRef>
-          <a:fontRef idx="minor">
-            <a:schemeClr val="lt1"/>
-          </a:fontRef>
-        </p:style>
-        <p:txBody>
-          <a:bodyPr rtlCol="0" anchor="ctr"/>
-          <a:lstStyle/>
-          <a:p>
-            <a:pPr algn="ctr"/>
-            <a:r>
-              <a:rPr lang="en-US" dirty="0">
-                <a:solidFill>
-                  <a:schemeClr val="tx1"/>
-                </a:solidFill>
-              </a:rPr>
-              <a:t>Language</a:t>
-            </a:r>
-          </a:p>
-          <a:p>
-            <a:pPr algn="ctr"/>
-            <a:r>
-              <a:rPr lang="en-US" dirty="0">
-                <a:solidFill>
-                  <a:schemeClr val="tx1"/>
-                </a:solidFill>
-              </a:rPr>
-              <a:t>Model</a:t>
-            </a:r>
-          </a:p>
-        </p:txBody>
-      </p:sp>
-      <p:cxnSp>
-        <p:nvCxnSpPr>
-          <p:cNvPr id="7" name="Straight Arrow Connector 6">
-            <a:extLst>
-              <a:ext uri="{FF2B5EF4-FFF2-40B4-BE49-F238E27FC236}">
-                <a16:creationId xmlns:a16="http://schemas.microsoft.com/office/drawing/2014/main" id="{70FF9049-A038-5CD7-B5B6-A7A955E2687C}"/>
-              </a:ext>
-            </a:extLst>
-          </p:cNvPr>
-          <p:cNvCxnSpPr>
-            <a:cxnSpLocks/>
-            <a:stCxn id="5" idx="3"/>
-            <a:endCxn id="3" idx="1"/>
-          </p:cNvCxnSpPr>
-          <p:nvPr/>
-        </p:nvCxnSpPr>
-        <p:spPr>
-          <a:xfrm flipV="1">
-            <a:off x="3421380" y="2854154"/>
-            <a:ext cx="624840" cy="1"/>
-          </a:xfrm>
-          <a:prstGeom prst="straightConnector1">
-            <a:avLst/>
-          </a:prstGeom>
-          <a:ln>
-            <a:solidFill>
-              <a:schemeClr val="tx1"/>
-            </a:solidFill>
-            <a:prstDash val="solid"/>
-            <a:tailEnd type="triangle" w="lg" len="lg"/>
-          </a:ln>
-        </p:spPr>
-        <p:style>
-          <a:lnRef idx="2">
-            <a:schemeClr val="accent1"/>
-          </a:lnRef>
-          <a:fillRef idx="0">
-            <a:schemeClr val="accent1"/>
-          </a:fillRef>
-          <a:effectRef idx="1">
-            <a:schemeClr val="accent1"/>
-          </a:effectRef>
-          <a:fontRef idx="minor">
-            <a:schemeClr val="tx1"/>
-          </a:fontRef>
-        </p:style>
-      </p:cxnSp>
-      <p:cxnSp>
-        <p:nvCxnSpPr>
-          <p:cNvPr id="10" name="Straight Arrow Connector 9">
-            <a:extLst>
-              <a:ext uri="{FF2B5EF4-FFF2-40B4-BE49-F238E27FC236}">
-                <a16:creationId xmlns:a16="http://schemas.microsoft.com/office/drawing/2014/main" id="{2C10FC99-8029-AE13-0A3B-1F87064360AB}"/>
-              </a:ext>
-            </a:extLst>
-          </p:cNvPr>
-          <p:cNvCxnSpPr>
-            <a:cxnSpLocks/>
-            <a:stCxn id="44" idx="3"/>
-            <a:endCxn id="6" idx="1"/>
-          </p:cNvCxnSpPr>
-          <p:nvPr/>
-        </p:nvCxnSpPr>
-        <p:spPr>
-          <a:xfrm>
-            <a:off x="9189720" y="2854155"/>
-            <a:ext cx="647700" cy="0"/>
-          </a:xfrm>
-          <a:prstGeom prst="straightConnector1">
-            <a:avLst/>
-          </a:prstGeom>
-          <a:ln>
-            <a:solidFill>
-              <a:schemeClr val="tx1"/>
-            </a:solidFill>
-            <a:prstDash val="solid"/>
-            <a:tailEnd type="triangle" w="lg" len="lg"/>
-          </a:ln>
-        </p:spPr>
-        <p:style>
-          <a:lnRef idx="2">
-            <a:schemeClr val="accent1"/>
-          </a:lnRef>
-          <a:fillRef idx="0">
-            <a:schemeClr val="accent1"/>
-          </a:fillRef>
-          <a:effectRef idx="1">
-            <a:schemeClr val="accent1"/>
-          </a:effectRef>
-          <a:fontRef idx="minor">
-            <a:schemeClr val="tx1"/>
-          </a:fontRef>
-        </p:style>
-      </p:cxnSp>
-      <p:sp>
-        <p:nvSpPr>
-          <p:cNvPr id="15" name="Rectangle: Rounded Corners 14">
-            <a:extLst>
-              <a:ext uri="{FF2B5EF4-FFF2-40B4-BE49-F238E27FC236}">
-                <a16:creationId xmlns:a16="http://schemas.microsoft.com/office/drawing/2014/main" id="{C23DA4FB-7AE1-4EE4-8DD5-321F7F7C7F33}"/>
-              </a:ext>
-            </a:extLst>
-          </p:cNvPr>
-          <p:cNvSpPr/>
-          <p:nvPr/>
-        </p:nvSpPr>
-        <p:spPr>
-          <a:xfrm>
-            <a:off x="189267" y="2619607"/>
-            <a:ext cx="915222" cy="469096"/>
-          </a:xfrm>
-          <a:prstGeom prst="roundRect">
-            <a:avLst/>
-          </a:prstGeom>
-          <a:solidFill>
-            <a:srgbClr val="E5F1F8"/>
-          </a:solidFill>
-          <a:ln>
-            <a:solidFill>
-              <a:schemeClr val="tx1"/>
-            </a:solidFill>
-          </a:ln>
-        </p:spPr>
-        <p:style>
-          <a:lnRef idx="2">
-            <a:schemeClr val="accent1">
-              <a:shade val="15000"/>
-            </a:schemeClr>
-          </a:lnRef>
-          <a:fillRef idx="1">
-            <a:schemeClr val="accent1"/>
-          </a:fillRef>
-          <a:effectRef idx="0">
-            <a:schemeClr val="accent1"/>
-          </a:effectRef>
-          <a:fontRef idx="minor">
-            <a:schemeClr val="lt1"/>
-          </a:fontRef>
-        </p:style>
-        <p:txBody>
-          <a:bodyPr rtlCol="0" anchor="ctr"/>
-          <a:lstStyle/>
-          <a:p>
-            <a:pPr algn="ctr"/>
-            <a:r>
-              <a:rPr lang="en-US" dirty="0">
-                <a:solidFill>
-                  <a:schemeClr val="tx1"/>
-                </a:solidFill>
-              </a:rPr>
-              <a:t>Prompt</a:t>
-            </a:r>
-          </a:p>
-        </p:txBody>
-      </p:sp>
-      <p:cxnSp>
-        <p:nvCxnSpPr>
-          <p:cNvPr id="16" name="Straight Arrow Connector 15">
-            <a:extLst>
-              <a:ext uri="{FF2B5EF4-FFF2-40B4-BE49-F238E27FC236}">
-                <a16:creationId xmlns:a16="http://schemas.microsoft.com/office/drawing/2014/main" id="{942D3144-4FA8-07EA-6898-D7B2C45E010A}"/>
-              </a:ext>
-            </a:extLst>
-          </p:cNvPr>
-          <p:cNvCxnSpPr>
-            <a:cxnSpLocks/>
-            <a:stCxn id="15" idx="3"/>
-            <a:endCxn id="5" idx="1"/>
-          </p:cNvCxnSpPr>
-          <p:nvPr/>
-        </p:nvCxnSpPr>
-        <p:spPr>
-          <a:xfrm>
-            <a:off x="1104489" y="2854155"/>
-            <a:ext cx="403449" cy="0"/>
-          </a:xfrm>
-          <a:prstGeom prst="straightConnector1">
-            <a:avLst/>
-          </a:prstGeom>
-          <a:ln>
-            <a:solidFill>
-              <a:schemeClr val="tx1"/>
-            </a:solidFill>
-            <a:prstDash val="sysDash"/>
-            <a:tailEnd type="triangle" w="lg" len="lg"/>
-          </a:ln>
-        </p:spPr>
-        <p:style>
-          <a:lnRef idx="2">
-            <a:schemeClr val="accent1"/>
-          </a:lnRef>
-          <a:fillRef idx="0">
-            <a:schemeClr val="accent1"/>
-          </a:fillRef>
-          <a:effectRef idx="1">
-            <a:schemeClr val="accent1"/>
-          </a:effectRef>
-          <a:fontRef idx="minor">
-            <a:schemeClr val="tx1"/>
-          </a:fontRef>
-        </p:style>
-      </p:cxnSp>
-      <p:cxnSp>
-        <p:nvCxnSpPr>
-          <p:cNvPr id="19" name="Connector: Elbow 18">
-            <a:extLst>
-              <a:ext uri="{FF2B5EF4-FFF2-40B4-BE49-F238E27FC236}">
-                <a16:creationId xmlns:a16="http://schemas.microsoft.com/office/drawing/2014/main" id="{BF48D9D9-8BAB-3118-5B91-13BAA46C2349}"/>
-              </a:ext>
-            </a:extLst>
-          </p:cNvPr>
-          <p:cNvCxnSpPr>
-            <a:cxnSpLocks/>
-            <a:stCxn id="5" idx="3"/>
-            <a:endCxn id="4" idx="1"/>
-          </p:cNvCxnSpPr>
-          <p:nvPr/>
-        </p:nvCxnSpPr>
-        <p:spPr>
-          <a:xfrm flipV="1">
-            <a:off x="3421380" y="2083603"/>
-            <a:ext cx="624840" cy="770552"/>
-          </a:xfrm>
-          <a:prstGeom prst="bentConnector3">
-            <a:avLst>
-              <a:gd name="adj1" fmla="val 50000"/>
-            </a:avLst>
-          </a:prstGeom>
-          <a:ln>
-            <a:solidFill>
-              <a:schemeClr val="tx1"/>
-            </a:solidFill>
-            <a:prstDash val="solid"/>
-            <a:tailEnd type="triangle" w="lg" len="lg"/>
-          </a:ln>
-        </p:spPr>
-        <p:style>
-          <a:lnRef idx="2">
-            <a:schemeClr val="accent1"/>
-          </a:lnRef>
-          <a:fillRef idx="0">
-            <a:schemeClr val="accent1"/>
-          </a:fillRef>
-          <a:effectRef idx="1">
-            <a:schemeClr val="accent1"/>
-          </a:effectRef>
-          <a:fontRef idx="minor">
-            <a:schemeClr val="tx1"/>
-          </a:fontRef>
-        </p:style>
-      </p:cxnSp>
-      <p:cxnSp>
-        <p:nvCxnSpPr>
-          <p:cNvPr id="22" name="Connector: Elbow 21">
-            <a:extLst>
-              <a:ext uri="{FF2B5EF4-FFF2-40B4-BE49-F238E27FC236}">
-                <a16:creationId xmlns:a16="http://schemas.microsoft.com/office/drawing/2014/main" id="{217AA7E3-1E41-FB8C-7F66-A5758B29A028}"/>
-              </a:ext>
-            </a:extLst>
-          </p:cNvPr>
-          <p:cNvCxnSpPr>
-            <a:cxnSpLocks/>
-            <a:stCxn id="5" idx="3"/>
-            <a:endCxn id="2" idx="1"/>
-          </p:cNvCxnSpPr>
-          <p:nvPr/>
-        </p:nvCxnSpPr>
-        <p:spPr>
-          <a:xfrm>
-            <a:off x="3421380" y="2854155"/>
-            <a:ext cx="624840" cy="772965"/>
-          </a:xfrm>
-          <a:prstGeom prst="bentConnector3">
-            <a:avLst>
-              <a:gd name="adj1" fmla="val 50000"/>
-            </a:avLst>
-          </a:prstGeom>
-          <a:ln>
-            <a:solidFill>
-              <a:schemeClr val="tx1"/>
-            </a:solidFill>
-            <a:prstDash val="solid"/>
-            <a:tailEnd type="triangle" w="lg" len="lg"/>
-          </a:ln>
-        </p:spPr>
-        <p:style>
-          <a:lnRef idx="2">
-            <a:schemeClr val="accent1"/>
-          </a:lnRef>
-          <a:fillRef idx="0">
-            <a:schemeClr val="accent1"/>
-          </a:fillRef>
-          <a:effectRef idx="1">
-            <a:schemeClr val="accent1"/>
-          </a:effectRef>
-          <a:fontRef idx="minor">
-            <a:schemeClr val="tx1"/>
-          </a:fontRef>
-        </p:style>
-      </p:cxnSp>
-      <p:sp>
-        <p:nvSpPr>
-          <p:cNvPr id="25" name="Rectangle: Rounded Corners 24">
-            <a:extLst>
-              <a:ext uri="{FF2B5EF4-FFF2-40B4-BE49-F238E27FC236}">
-                <a16:creationId xmlns:a16="http://schemas.microsoft.com/office/drawing/2014/main" id="{98E95763-BD68-DEF9-F942-CCC8B336544E}"/>
-              </a:ext>
-            </a:extLst>
-          </p:cNvPr>
-          <p:cNvSpPr/>
-          <p:nvPr/>
-        </p:nvSpPr>
-        <p:spPr>
-          <a:xfrm>
-            <a:off x="8732520" y="1852591"/>
-            <a:ext cx="457200" cy="457200"/>
-          </a:xfrm>
-          <a:prstGeom prst="roundRect">
-            <a:avLst/>
-          </a:prstGeom>
-          <a:solidFill>
-            <a:srgbClr val="E5F1F8"/>
-          </a:solidFill>
-          <a:ln>
-            <a:solidFill>
-              <a:schemeClr val="tx1"/>
-            </a:solidFill>
-          </a:ln>
-        </p:spPr>
-        <p:style>
-          <a:lnRef idx="2">
-            <a:schemeClr val="accent1">
-              <a:shade val="15000"/>
-            </a:schemeClr>
-          </a:lnRef>
-          <a:fillRef idx="1">
-            <a:schemeClr val="accent1"/>
-          </a:fillRef>
-          <a:effectRef idx="0">
-            <a:schemeClr val="accent1"/>
-          </a:effectRef>
-          <a:fontRef idx="minor">
-            <a:schemeClr val="lt1"/>
-          </a:fontRef>
-        </p:style>
-        <p:txBody>
-          <a:bodyPr rtlCol="0" anchor="ctr"/>
-          <a:lstStyle/>
-          <a:p>
-            <a:pPr algn="ctr"/>
-            <a:endParaRPr lang="en-US" dirty="0">
-              <a:solidFill>
-                <a:schemeClr val="tx1"/>
-              </a:solidFill>
-            </a:endParaRPr>
-          </a:p>
-        </p:txBody>
-      </p:sp>
-      <p:cxnSp>
-        <p:nvCxnSpPr>
-          <p:cNvPr id="40" name="Straight Arrow Connector 39">
-            <a:extLst>
-              <a:ext uri="{FF2B5EF4-FFF2-40B4-BE49-F238E27FC236}">
-                <a16:creationId xmlns:a16="http://schemas.microsoft.com/office/drawing/2014/main" id="{B899F5AF-E80C-3452-008E-8E821AEFA864}"/>
-              </a:ext>
-            </a:extLst>
-          </p:cNvPr>
-          <p:cNvCxnSpPr>
-            <a:cxnSpLocks/>
-            <a:stCxn id="4" idx="3"/>
-            <a:endCxn id="25" idx="1"/>
-          </p:cNvCxnSpPr>
-          <p:nvPr/>
-        </p:nvCxnSpPr>
-        <p:spPr>
-          <a:xfrm flipV="1">
-            <a:off x="8328660" y="2081191"/>
-            <a:ext cx="403860" cy="2412"/>
-          </a:xfrm>
-          <a:prstGeom prst="straightConnector1">
-            <a:avLst/>
-          </a:prstGeom>
-          <a:ln>
-            <a:solidFill>
-              <a:schemeClr val="tx1"/>
-            </a:solidFill>
-            <a:prstDash val="solid"/>
-            <a:tailEnd type="triangle" w="lg" len="lg"/>
-          </a:ln>
-        </p:spPr>
-        <p:style>
-          <a:lnRef idx="2">
-            <a:schemeClr val="accent1"/>
-          </a:lnRef>
-          <a:fillRef idx="0">
-            <a:schemeClr val="accent1"/>
-          </a:fillRef>
-          <a:effectRef idx="1">
-            <a:schemeClr val="accent1"/>
-          </a:effectRef>
-          <a:fontRef idx="minor">
-            <a:schemeClr val="tx1"/>
-          </a:fontRef>
-        </p:style>
-      </p:cxnSp>
-      <p:sp>
-        <p:nvSpPr>
-          <p:cNvPr id="44" name="Rectangle: Rounded Corners 43">
-            <a:extLst>
-              <a:ext uri="{FF2B5EF4-FFF2-40B4-BE49-F238E27FC236}">
-                <a16:creationId xmlns:a16="http://schemas.microsoft.com/office/drawing/2014/main" id="{3F66FD98-C347-7EA9-DC36-7FDBB97B4248}"/>
-              </a:ext>
-            </a:extLst>
-          </p:cNvPr>
-          <p:cNvSpPr/>
-          <p:nvPr/>
-        </p:nvSpPr>
-        <p:spPr>
-          <a:xfrm>
-            <a:off x="8732520" y="2625555"/>
-            <a:ext cx="457200" cy="457200"/>
-          </a:xfrm>
-          <a:prstGeom prst="roundRect">
-            <a:avLst/>
-          </a:prstGeom>
-          <a:solidFill>
-            <a:srgbClr val="E5F1F8"/>
-          </a:solidFill>
-          <a:ln>
-            <a:solidFill>
-              <a:schemeClr val="tx1"/>
-            </a:solidFill>
-          </a:ln>
-        </p:spPr>
-        <p:style>
-          <a:lnRef idx="2">
-            <a:schemeClr val="accent1">
-              <a:shade val="15000"/>
-            </a:schemeClr>
-          </a:lnRef>
-          <a:fillRef idx="1">
-            <a:schemeClr val="accent1"/>
-          </a:fillRef>
-          <a:effectRef idx="0">
-            <a:schemeClr val="accent1"/>
-          </a:effectRef>
-          <a:fontRef idx="minor">
-            <a:schemeClr val="lt1"/>
-          </a:fontRef>
-        </p:style>
-        <p:txBody>
-          <a:bodyPr rtlCol="0" anchor="ctr"/>
-          <a:lstStyle/>
-          <a:p>
-            <a:pPr algn="ctr"/>
-            <a:endParaRPr lang="en-US" dirty="0">
-              <a:solidFill>
-                <a:schemeClr val="tx1"/>
-              </a:solidFill>
-            </a:endParaRPr>
-          </a:p>
-        </p:txBody>
-      </p:sp>
-      <p:sp>
-        <p:nvSpPr>
-          <p:cNvPr id="46" name="Rectangle: Rounded Corners 45">
-            <a:extLst>
-              <a:ext uri="{FF2B5EF4-FFF2-40B4-BE49-F238E27FC236}">
-                <a16:creationId xmlns:a16="http://schemas.microsoft.com/office/drawing/2014/main" id="{A791A27B-2AA1-8E05-2231-C99FE09DCBEB}"/>
-              </a:ext>
-            </a:extLst>
-          </p:cNvPr>
-          <p:cNvSpPr/>
-          <p:nvPr/>
-        </p:nvSpPr>
-        <p:spPr>
-          <a:xfrm>
-            <a:off x="8732520" y="3398519"/>
-            <a:ext cx="457200" cy="457200"/>
-          </a:xfrm>
-          <a:prstGeom prst="roundRect">
-            <a:avLst/>
-          </a:prstGeom>
-          <a:solidFill>
-            <a:srgbClr val="E5F1F8"/>
-          </a:solidFill>
-          <a:ln>
-            <a:solidFill>
-              <a:schemeClr val="tx1"/>
-            </a:solidFill>
-          </a:ln>
-        </p:spPr>
-        <p:style>
-          <a:lnRef idx="2">
-            <a:schemeClr val="accent1">
-              <a:shade val="15000"/>
-            </a:schemeClr>
-          </a:lnRef>
-          <a:fillRef idx="1">
-            <a:schemeClr val="accent1"/>
-          </a:fillRef>
-          <a:effectRef idx="0">
-            <a:schemeClr val="accent1"/>
-          </a:effectRef>
-          <a:fontRef idx="minor">
-            <a:schemeClr val="lt1"/>
-          </a:fontRef>
-        </p:style>
-        <p:txBody>
-          <a:bodyPr rtlCol="0" anchor="ctr"/>
-          <a:lstStyle/>
-          <a:p>
-            <a:pPr algn="ctr"/>
-            <a:endParaRPr lang="en-US" dirty="0">
-              <a:solidFill>
-                <a:schemeClr val="tx1"/>
-              </a:solidFill>
-            </a:endParaRPr>
-          </a:p>
-        </p:txBody>
-      </p:sp>
-      <p:cxnSp>
-        <p:nvCxnSpPr>
-          <p:cNvPr id="47" name="Straight Arrow Connector 46">
-            <a:extLst>
-              <a:ext uri="{FF2B5EF4-FFF2-40B4-BE49-F238E27FC236}">
-                <a16:creationId xmlns:a16="http://schemas.microsoft.com/office/drawing/2014/main" id="{42D77B26-2C1F-3022-9B0B-3736BC5CF8AA}"/>
-              </a:ext>
-            </a:extLst>
-          </p:cNvPr>
-          <p:cNvCxnSpPr>
-            <a:cxnSpLocks/>
-            <a:stCxn id="3" idx="3"/>
-            <a:endCxn id="44" idx="1"/>
-          </p:cNvCxnSpPr>
-          <p:nvPr/>
-        </p:nvCxnSpPr>
-        <p:spPr>
-          <a:xfrm>
-            <a:off x="8328660" y="2854154"/>
-            <a:ext cx="403860" cy="1"/>
-          </a:xfrm>
-          <a:prstGeom prst="straightConnector1">
-            <a:avLst/>
-          </a:prstGeom>
-          <a:ln>
-            <a:solidFill>
-              <a:schemeClr val="tx1"/>
-            </a:solidFill>
-            <a:prstDash val="solid"/>
-            <a:tailEnd type="triangle" w="lg" len="lg"/>
-          </a:ln>
-        </p:spPr>
-        <p:style>
-          <a:lnRef idx="2">
-            <a:schemeClr val="accent1"/>
-          </a:lnRef>
-          <a:fillRef idx="0">
-            <a:schemeClr val="accent1"/>
-          </a:fillRef>
-          <a:effectRef idx="1">
-            <a:schemeClr val="accent1"/>
-          </a:effectRef>
-          <a:fontRef idx="minor">
-            <a:schemeClr val="tx1"/>
-          </a:fontRef>
-        </p:style>
-      </p:cxnSp>
-      <p:cxnSp>
-        <p:nvCxnSpPr>
-          <p:cNvPr id="55" name="Straight Arrow Connector 54">
-            <a:extLst>
-              <a:ext uri="{FF2B5EF4-FFF2-40B4-BE49-F238E27FC236}">
-                <a16:creationId xmlns:a16="http://schemas.microsoft.com/office/drawing/2014/main" id="{A99ECFB6-8E63-4F62-C5D3-37BC5BB43934}"/>
-              </a:ext>
-            </a:extLst>
-          </p:cNvPr>
-          <p:cNvCxnSpPr>
-            <a:cxnSpLocks/>
-            <a:stCxn id="2" idx="3"/>
-            <a:endCxn id="46" idx="1"/>
-          </p:cNvCxnSpPr>
-          <p:nvPr/>
-        </p:nvCxnSpPr>
-        <p:spPr>
-          <a:xfrm flipV="1">
-            <a:off x="8328660" y="3627119"/>
-            <a:ext cx="403860" cy="1"/>
-          </a:xfrm>
-          <a:prstGeom prst="straightConnector1">
-            <a:avLst/>
-          </a:prstGeom>
-          <a:ln>
-            <a:solidFill>
-              <a:schemeClr val="tx1"/>
-            </a:solidFill>
-            <a:prstDash val="solid"/>
-            <a:tailEnd type="triangle" w="lg" len="lg"/>
-          </a:ln>
-        </p:spPr>
-        <p:style>
-          <a:lnRef idx="2">
-            <a:schemeClr val="accent1"/>
-          </a:lnRef>
-          <a:fillRef idx="0">
-            <a:schemeClr val="accent1"/>
-          </a:fillRef>
-          <a:effectRef idx="1">
-            <a:schemeClr val="accent1"/>
-          </a:effectRef>
-          <a:fontRef idx="minor">
-            <a:schemeClr val="tx1"/>
-          </a:fontRef>
-        </p:style>
-      </p:cxnSp>
-      <p:cxnSp>
-        <p:nvCxnSpPr>
-          <p:cNvPr id="58" name="Connector: Elbow 57">
-            <a:extLst>
-              <a:ext uri="{FF2B5EF4-FFF2-40B4-BE49-F238E27FC236}">
-                <a16:creationId xmlns:a16="http://schemas.microsoft.com/office/drawing/2014/main" id="{DDB500F1-F165-AABE-6725-11E4ED79023E}"/>
-              </a:ext>
-            </a:extLst>
-          </p:cNvPr>
-          <p:cNvCxnSpPr>
-            <a:cxnSpLocks/>
-            <a:stCxn id="25" idx="3"/>
-            <a:endCxn id="6" idx="1"/>
-          </p:cNvCxnSpPr>
-          <p:nvPr/>
-        </p:nvCxnSpPr>
-        <p:spPr>
-          <a:xfrm>
-            <a:off x="9189720" y="2081191"/>
-            <a:ext cx="647700" cy="772964"/>
-          </a:xfrm>
-          <a:prstGeom prst="bentConnector3">
-            <a:avLst>
-              <a:gd name="adj1" fmla="val 50000"/>
-            </a:avLst>
-          </a:prstGeom>
-          <a:ln>
-            <a:solidFill>
-              <a:schemeClr val="tx1"/>
-            </a:solidFill>
-            <a:prstDash val="solid"/>
-            <a:tailEnd type="triangle" w="lg" len="lg"/>
-          </a:ln>
-        </p:spPr>
-        <p:style>
-          <a:lnRef idx="2">
-            <a:schemeClr val="accent1"/>
-          </a:lnRef>
-          <a:fillRef idx="0">
-            <a:schemeClr val="accent1"/>
-          </a:fillRef>
-          <a:effectRef idx="1">
-            <a:schemeClr val="accent1"/>
-          </a:effectRef>
-          <a:fontRef idx="minor">
-            <a:schemeClr val="tx1"/>
-          </a:fontRef>
-        </p:style>
-      </p:cxnSp>
-      <p:cxnSp>
-        <p:nvCxnSpPr>
-          <p:cNvPr id="61" name="Connector: Elbow 60">
-            <a:extLst>
-              <a:ext uri="{FF2B5EF4-FFF2-40B4-BE49-F238E27FC236}">
-                <a16:creationId xmlns:a16="http://schemas.microsoft.com/office/drawing/2014/main" id="{28AC6A5D-0A01-5370-996D-AF8698A1082D}"/>
-              </a:ext>
-            </a:extLst>
-          </p:cNvPr>
-          <p:cNvCxnSpPr>
-            <a:cxnSpLocks/>
-            <a:stCxn id="46" idx="3"/>
-            <a:endCxn id="6" idx="1"/>
-          </p:cNvCxnSpPr>
-          <p:nvPr/>
-        </p:nvCxnSpPr>
-        <p:spPr>
-          <a:xfrm flipV="1">
-            <a:off x="9189720" y="2854155"/>
-            <a:ext cx="647700" cy="772964"/>
-          </a:xfrm>
-          <a:prstGeom prst="bentConnector3">
-            <a:avLst>
-              <a:gd name="adj1" fmla="val 50000"/>
-            </a:avLst>
-          </a:prstGeom>
-          <a:ln>
-            <a:solidFill>
-              <a:schemeClr val="tx1"/>
-            </a:solidFill>
-            <a:prstDash val="solid"/>
-            <a:tailEnd type="triangle" w="lg" len="lg"/>
-          </a:ln>
-        </p:spPr>
-        <p:style>
-          <a:lnRef idx="2">
-            <a:schemeClr val="accent1"/>
-          </a:lnRef>
-          <a:fillRef idx="0">
-            <a:schemeClr val="accent1"/>
-          </a:fillRef>
-          <a:effectRef idx="1">
-            <a:schemeClr val="accent1"/>
-          </a:effectRef>
-          <a:fontRef idx="minor">
-            <a:schemeClr val="tx1"/>
-          </a:fontRef>
-        </p:style>
-      </p:cxnSp>
-      <p:pic>
-        <p:nvPicPr>
-          <p:cNvPr id="67" name="Graphic 66" descr="Web design with solid fill">
-            <a:extLst>
-              <a:ext uri="{FF2B5EF4-FFF2-40B4-BE49-F238E27FC236}">
-                <a16:creationId xmlns:a16="http://schemas.microsoft.com/office/drawing/2014/main" id="{5D8BB564-5BA8-868D-2AB7-35E0D3AE65F9}"/>
-              </a:ext>
-            </a:extLst>
-          </p:cNvPr>
-          <p:cNvPicPr>
-            <a:picLocks noChangeAspect="1"/>
-          </p:cNvPicPr>
-          <p:nvPr/>
-        </p:nvPicPr>
-        <p:blipFill>
-          <a:blip r:embed="rId2">
-            <a:extLst>
-              <a:ext uri="{96DAC541-7B7A-43D3-8B79-37D633B846F1}">
-                <asvg:svgBlip xmlns:asvg="http://schemas.microsoft.com/office/drawing/2016/SVG/main" r:embed="rId3"/>
-              </a:ext>
-            </a:extLst>
-          </a:blip>
-          <a:stretch>
-            <a:fillRect/>
-          </a:stretch>
-        </p:blipFill>
-        <p:spPr>
-          <a:xfrm>
-            <a:off x="8755380" y="2648413"/>
-            <a:ext cx="411480" cy="411480"/>
-          </a:xfrm>
-          <a:prstGeom prst="rect">
-            <a:avLst/>
-          </a:prstGeom>
-        </p:spPr>
-      </p:pic>
-      <p:pic>
-        <p:nvPicPr>
-          <p:cNvPr id="71" name="Graphic 70" descr="World with solid fill">
-            <a:extLst>
-              <a:ext uri="{FF2B5EF4-FFF2-40B4-BE49-F238E27FC236}">
-                <a16:creationId xmlns:a16="http://schemas.microsoft.com/office/drawing/2014/main" id="{0EF50C39-FA5F-96A6-2DE6-53C76B029FDB}"/>
-              </a:ext>
-            </a:extLst>
-          </p:cNvPr>
-          <p:cNvPicPr>
-            <a:picLocks noChangeAspect="1"/>
-          </p:cNvPicPr>
-          <p:nvPr/>
-        </p:nvPicPr>
-        <p:blipFill>
-          <a:blip r:embed="rId4">
-            <a:extLst>
-              <a:ext uri="{96DAC541-7B7A-43D3-8B79-37D633B846F1}">
-                <asvg:svgBlip xmlns:asvg="http://schemas.microsoft.com/office/drawing/2016/SVG/main" r:embed="rId5"/>
-              </a:ext>
-            </a:extLst>
-          </a:blip>
-          <a:stretch>
-            <a:fillRect/>
-          </a:stretch>
-        </p:blipFill>
-        <p:spPr>
-          <a:xfrm>
-            <a:off x="8755380" y="3421379"/>
-            <a:ext cx="411480" cy="411480"/>
-          </a:xfrm>
-          <a:prstGeom prst="rect">
-            <a:avLst/>
-          </a:prstGeom>
-        </p:spPr>
-      </p:pic>
-      <p:pic>
-        <p:nvPicPr>
-          <p:cNvPr id="73" name="Graphic 72" descr="Database with solid fill">
-            <a:extLst>
-              <a:ext uri="{FF2B5EF4-FFF2-40B4-BE49-F238E27FC236}">
-                <a16:creationId xmlns:a16="http://schemas.microsoft.com/office/drawing/2014/main" id="{20B0889E-3ACA-9DCA-25FE-C1F9B73F7329}"/>
-              </a:ext>
-            </a:extLst>
-          </p:cNvPr>
-          <p:cNvPicPr>
-            <a:picLocks noChangeAspect="1"/>
-          </p:cNvPicPr>
-          <p:nvPr/>
-        </p:nvPicPr>
-        <p:blipFill>
-          <a:blip r:embed="rId6">
-            <a:extLst>
-              <a:ext uri="{96DAC541-7B7A-43D3-8B79-37D633B846F1}">
-                <asvg:svgBlip xmlns:asvg="http://schemas.microsoft.com/office/drawing/2016/SVG/main" r:embed="rId7"/>
-              </a:ext>
-            </a:extLst>
-          </a:blip>
-          <a:stretch>
-            <a:fillRect/>
-          </a:stretch>
-        </p:blipFill>
-        <p:spPr>
-          <a:xfrm>
-            <a:off x="8755380" y="1875451"/>
-            <a:ext cx="411480" cy="411480"/>
-          </a:xfrm>
-          <a:prstGeom prst="rect">
-            <a:avLst/>
-          </a:prstGeom>
-        </p:spPr>
-      </p:pic>
-      <p:pic>
-        <p:nvPicPr>
-          <p:cNvPr id="75" name="Graphic 74" descr="Gears with solid fill">
-            <a:extLst>
-              <a:ext uri="{FF2B5EF4-FFF2-40B4-BE49-F238E27FC236}">
-                <a16:creationId xmlns:a16="http://schemas.microsoft.com/office/drawing/2014/main" id="{AFA7CC75-0D4E-9273-3BC2-179536E5EC20}"/>
-              </a:ext>
-            </a:extLst>
-          </p:cNvPr>
-          <p:cNvPicPr>
-            <a:picLocks noChangeAspect="1"/>
-          </p:cNvPicPr>
-          <p:nvPr/>
-        </p:nvPicPr>
-        <p:blipFill>
-          <a:blip r:embed="rId8">
-            <a:extLst>
-              <a:ext uri="{96DAC541-7B7A-43D3-8B79-37D633B846F1}">
-                <asvg:svgBlip xmlns:asvg="http://schemas.microsoft.com/office/drawing/2016/SVG/main" r:embed="rId9"/>
-              </a:ext>
-            </a:extLst>
-          </a:blip>
-          <a:stretch>
-            <a:fillRect/>
-          </a:stretch>
-        </p:blipFill>
-        <p:spPr>
-          <a:xfrm>
-            <a:off x="1626048" y="2648413"/>
-            <a:ext cx="411480" cy="411480"/>
-          </a:xfrm>
-          <a:prstGeom prst="rect">
-            <a:avLst/>
-          </a:prstGeom>
-        </p:spPr>
-      </p:pic>
-      <p:sp>
-        <p:nvSpPr>
-          <p:cNvPr id="76" name="Rectangle: Rounded Corners 75">
-            <a:extLst>
-              <a:ext uri="{FF2B5EF4-FFF2-40B4-BE49-F238E27FC236}">
-                <a16:creationId xmlns:a16="http://schemas.microsoft.com/office/drawing/2014/main" id="{3492D89A-8D12-E69E-613E-246E45DCD83F}"/>
-              </a:ext>
-            </a:extLst>
-          </p:cNvPr>
-          <p:cNvSpPr/>
-          <p:nvPr/>
-        </p:nvSpPr>
-        <p:spPr>
-          <a:xfrm>
-            <a:off x="10545258" y="3627118"/>
-            <a:ext cx="1205604" cy="469096"/>
-          </a:xfrm>
-          <a:prstGeom prst="roundRect">
-            <a:avLst/>
-          </a:prstGeom>
-          <a:solidFill>
-            <a:srgbClr val="E5F1F8"/>
-          </a:solidFill>
-          <a:ln>
-            <a:solidFill>
-              <a:schemeClr val="tx1"/>
-            </a:solidFill>
-          </a:ln>
-        </p:spPr>
-        <p:style>
-          <a:lnRef idx="2">
-            <a:schemeClr val="accent1">
-              <a:shade val="15000"/>
-            </a:schemeClr>
-          </a:lnRef>
-          <a:fillRef idx="1">
-            <a:schemeClr val="accent1"/>
-          </a:fillRef>
-          <a:effectRef idx="0">
-            <a:schemeClr val="accent1"/>
-          </a:effectRef>
-          <a:fontRef idx="minor">
-            <a:schemeClr val="lt1"/>
-          </a:fontRef>
-        </p:style>
-        <p:txBody>
-          <a:bodyPr rtlCol="0" anchor="ctr"/>
-          <a:lstStyle/>
-          <a:p>
-            <a:pPr algn="ctr"/>
-            <a:r>
-              <a:rPr lang="en-US" dirty="0">
-                <a:solidFill>
-                  <a:schemeClr val="tx1"/>
-                </a:solidFill>
-              </a:rPr>
-              <a:t>Response</a:t>
-            </a:r>
-          </a:p>
-        </p:txBody>
-      </p:sp>
-      <p:cxnSp>
-        <p:nvCxnSpPr>
-          <p:cNvPr id="77" name="Straight Arrow Connector 76">
-            <a:extLst>
-              <a:ext uri="{FF2B5EF4-FFF2-40B4-BE49-F238E27FC236}">
-                <a16:creationId xmlns:a16="http://schemas.microsoft.com/office/drawing/2014/main" id="{1A734903-BE53-2153-B1BE-7817395A6ACC}"/>
-              </a:ext>
-            </a:extLst>
-          </p:cNvPr>
-          <p:cNvCxnSpPr>
-            <a:cxnSpLocks/>
-            <a:endCxn id="76" idx="0"/>
-          </p:cNvCxnSpPr>
-          <p:nvPr/>
-        </p:nvCxnSpPr>
-        <p:spPr>
-          <a:xfrm>
-            <a:off x="11148060" y="3334214"/>
-            <a:ext cx="0" cy="292904"/>
-          </a:xfrm>
-          <a:prstGeom prst="straightConnector1">
-            <a:avLst/>
-          </a:prstGeom>
-          <a:ln>
-            <a:solidFill>
-              <a:schemeClr val="tx1"/>
-            </a:solidFill>
-            <a:prstDash val="sysDash"/>
-            <a:tailEnd type="triangle" w="lg" len="lg"/>
-          </a:ln>
-        </p:spPr>
-        <p:style>
-          <a:lnRef idx="2">
-            <a:schemeClr val="accent1"/>
-          </a:lnRef>
-          <a:fillRef idx="0">
-            <a:schemeClr val="accent1"/>
-          </a:fillRef>
-          <a:effectRef idx="1">
-            <a:schemeClr val="accent1"/>
-          </a:effectRef>
-          <a:fontRef idx="minor">
-            <a:schemeClr val="tx1"/>
-          </a:fontRef>
-        </p:style>
-      </p:cxnSp>
-      <p:cxnSp>
-        <p:nvCxnSpPr>
-          <p:cNvPr id="14" name="Connector: Elbow 13">
-            <a:extLst>
-              <a:ext uri="{FF2B5EF4-FFF2-40B4-BE49-F238E27FC236}">
-                <a16:creationId xmlns:a16="http://schemas.microsoft.com/office/drawing/2014/main" id="{4D371B40-23D5-3632-64F0-3A5DAC685C2C}"/>
-              </a:ext>
-            </a:extLst>
-          </p:cNvPr>
-          <p:cNvCxnSpPr>
-            <a:cxnSpLocks/>
-            <a:endCxn id="5" idx="2"/>
-          </p:cNvCxnSpPr>
-          <p:nvPr/>
-        </p:nvCxnSpPr>
-        <p:spPr>
-          <a:xfrm rot="5400000">
-            <a:off x="6337265" y="-538391"/>
-            <a:ext cx="12700" cy="7745211"/>
-          </a:xfrm>
-          <a:prstGeom prst="bentConnector3">
-            <a:avLst>
-              <a:gd name="adj1" fmla="val 6060000"/>
-            </a:avLst>
-          </a:prstGeom>
-          <a:ln>
-            <a:solidFill>
-              <a:schemeClr val="tx1"/>
-            </a:solidFill>
-            <a:prstDash val="sysDash"/>
-            <a:tailEnd type="triangle" w="lg" len="lg"/>
-          </a:ln>
-        </p:spPr>
-        <p:style>
-          <a:lnRef idx="2">
-            <a:schemeClr val="accent1"/>
-          </a:lnRef>
-          <a:fillRef idx="0">
-            <a:schemeClr val="accent1"/>
-          </a:fillRef>
-          <a:effectRef idx="1">
-            <a:schemeClr val="accent1"/>
-          </a:effectRef>
-          <a:fontRef idx="minor">
-            <a:schemeClr val="tx1"/>
-          </a:fontRef>
-        </p:style>
-      </p:cxnSp>
-    </p:spTree>
-    <p:extLst>
-      <p:ext uri="{BB962C8B-B14F-4D97-AF65-F5344CB8AC3E}">
-        <p14:creationId xmlns:p14="http://schemas.microsoft.com/office/powerpoint/2010/main" val="2560175498"/>
       </p:ext>
     </p:extLst>
   </p:cSld>

</xml_diff>

<commit_message>
Update illustrations for Ch08
</commit_message>
<xml_diff>
--- a/figures/figures.pptx
+++ b/figures/figures.pptx
@@ -175,6 +175,10 @@
             <p14:sldId id="269"/>
             <p14:sldId id="274"/>
             <p14:sldId id="270"/>
+          </p14:sldIdLst>
+        </p14:section>
+        <p14:section name="Edge Deployment" id="{751363D7-BD1F-4E68-8906-25A659F6AF95}">
+          <p14:sldIdLst>
             <p14:sldId id="271"/>
             <p14:sldId id="272"/>
             <p14:sldId id="273"/>
@@ -276,7 +280,7 @@
           <a:p>
             <a:fld id="{DAABB0E5-6D8D-4DEE-B75F-67010CF2307C}" type="datetimeFigureOut">
               <a:rPr lang="en-US" smtClean="0"/>
-              <a:t>3/26/2026</a:t>
+              <a:t>4/5/2026</a:t>
             </a:fld>
             <a:endParaRPr lang="en-US"/>
           </a:p>
@@ -961,7 +965,7 @@
           <a:p>
             <a:fld id="{B84C5C40-2055-49AF-9028-5DA79E75E391}" type="datetimeFigureOut">
               <a:rPr lang="en-US" smtClean="0"/>
-              <a:t>3/26/2026</a:t>
+              <a:t>4/5/2026</a:t>
             </a:fld>
             <a:endParaRPr lang="en-US"/>
           </a:p>
@@ -1131,7 +1135,7 @@
           <a:p>
             <a:fld id="{B84C5C40-2055-49AF-9028-5DA79E75E391}" type="datetimeFigureOut">
               <a:rPr lang="en-US" smtClean="0"/>
-              <a:t>3/26/2026</a:t>
+              <a:t>4/5/2026</a:t>
             </a:fld>
             <a:endParaRPr lang="en-US"/>
           </a:p>
@@ -1311,7 +1315,7 @@
           <a:p>
             <a:fld id="{B84C5C40-2055-49AF-9028-5DA79E75E391}" type="datetimeFigureOut">
               <a:rPr lang="en-US" smtClean="0"/>
-              <a:t>3/26/2026</a:t>
+              <a:t>4/5/2026</a:t>
             </a:fld>
             <a:endParaRPr lang="en-US"/>
           </a:p>
@@ -1481,7 +1485,7 @@
           <a:p>
             <a:fld id="{B84C5C40-2055-49AF-9028-5DA79E75E391}" type="datetimeFigureOut">
               <a:rPr lang="en-US" smtClean="0"/>
-              <a:t>3/26/2026</a:t>
+              <a:t>4/5/2026</a:t>
             </a:fld>
             <a:endParaRPr lang="en-US"/>
           </a:p>
@@ -1727,7 +1731,7 @@
           <a:p>
             <a:fld id="{B84C5C40-2055-49AF-9028-5DA79E75E391}" type="datetimeFigureOut">
               <a:rPr lang="en-US" smtClean="0"/>
-              <a:t>3/26/2026</a:t>
+              <a:t>4/5/2026</a:t>
             </a:fld>
             <a:endParaRPr lang="en-US"/>
           </a:p>
@@ -1959,7 +1963,7 @@
           <a:p>
             <a:fld id="{B84C5C40-2055-49AF-9028-5DA79E75E391}" type="datetimeFigureOut">
               <a:rPr lang="en-US" smtClean="0"/>
-              <a:t>3/26/2026</a:t>
+              <a:t>4/5/2026</a:t>
             </a:fld>
             <a:endParaRPr lang="en-US"/>
           </a:p>
@@ -2326,7 +2330,7 @@
           <a:p>
             <a:fld id="{B84C5C40-2055-49AF-9028-5DA79E75E391}" type="datetimeFigureOut">
               <a:rPr lang="en-US" smtClean="0"/>
-              <a:t>3/26/2026</a:t>
+              <a:t>4/5/2026</a:t>
             </a:fld>
             <a:endParaRPr lang="en-US"/>
           </a:p>
@@ -2444,7 +2448,7 @@
           <a:p>
             <a:fld id="{B84C5C40-2055-49AF-9028-5DA79E75E391}" type="datetimeFigureOut">
               <a:rPr lang="en-US" smtClean="0"/>
-              <a:t>3/26/2026</a:t>
+              <a:t>4/5/2026</a:t>
             </a:fld>
             <a:endParaRPr lang="en-US"/>
           </a:p>
@@ -2539,7 +2543,7 @@
           <a:p>
             <a:fld id="{B84C5C40-2055-49AF-9028-5DA79E75E391}" type="datetimeFigureOut">
               <a:rPr lang="en-US" smtClean="0"/>
-              <a:t>3/26/2026</a:t>
+              <a:t>4/5/2026</a:t>
             </a:fld>
             <a:endParaRPr lang="en-US"/>
           </a:p>
@@ -2816,7 +2820,7 @@
           <a:p>
             <a:fld id="{B84C5C40-2055-49AF-9028-5DA79E75E391}" type="datetimeFigureOut">
               <a:rPr lang="en-US" smtClean="0"/>
-              <a:t>3/26/2026</a:t>
+              <a:t>4/5/2026</a:t>
             </a:fld>
             <a:endParaRPr lang="en-US"/>
           </a:p>
@@ -3073,7 +3077,7 @@
           <a:p>
             <a:fld id="{B84C5C40-2055-49AF-9028-5DA79E75E391}" type="datetimeFigureOut">
               <a:rPr lang="en-US" smtClean="0"/>
-              <a:t>3/26/2026</a:t>
+              <a:t>4/5/2026</a:t>
             </a:fld>
             <a:endParaRPr lang="en-US"/>
           </a:p>
@@ -3286,7 +3290,7 @@
           <a:p>
             <a:fld id="{B84C5C40-2055-49AF-9028-5DA79E75E391}" type="datetimeFigureOut">
               <a:rPr lang="en-US" smtClean="0"/>
-              <a:t>3/26/2026</a:t>
+              <a:t>4/5/2026</a:t>
             </a:fld>
             <a:endParaRPr lang="en-US"/>
           </a:p>
@@ -8860,6 +8864,963 @@
           <a:chExt cx="0" cy="0"/>
         </a:xfrm>
       </p:grpSpPr>
+      <p:sp>
+        <p:nvSpPr>
+          <p:cNvPr id="2" name="Rectangle: Rounded Corners 1">
+            <a:extLst>
+              <a:ext uri="{FF2B5EF4-FFF2-40B4-BE49-F238E27FC236}">
+                <a16:creationId xmlns:a16="http://schemas.microsoft.com/office/drawing/2014/main" id="{B5CB0691-4F4F-B36F-1292-BDF4D6F64E6F}"/>
+              </a:ext>
+            </a:extLst>
+          </p:cNvPr>
+          <p:cNvSpPr/>
+          <p:nvPr/>
+        </p:nvSpPr>
+        <p:spPr>
+          <a:xfrm>
+            <a:off x="2933281" y="1839992"/>
+            <a:ext cx="6325438" cy="974563"/>
+          </a:xfrm>
+          <a:prstGeom prst="roundRect">
+            <a:avLst>
+              <a:gd name="adj" fmla="val 5234"/>
+            </a:avLst>
+          </a:prstGeom>
+          <a:solidFill>
+            <a:schemeClr val="bg1"/>
+          </a:solidFill>
+          <a:ln>
+            <a:solidFill>
+              <a:schemeClr val="tx1"/>
+            </a:solidFill>
+          </a:ln>
+        </p:spPr>
+        <p:style>
+          <a:lnRef idx="2">
+            <a:schemeClr val="accent1">
+              <a:shade val="15000"/>
+            </a:schemeClr>
+          </a:lnRef>
+          <a:fillRef idx="1">
+            <a:schemeClr val="accent1"/>
+          </a:fillRef>
+          <a:effectRef idx="0">
+            <a:schemeClr val="accent1"/>
+          </a:effectRef>
+          <a:fontRef idx="minor">
+            <a:schemeClr val="lt1"/>
+          </a:fontRef>
+        </p:style>
+        <p:txBody>
+          <a:bodyPr rtlCol="0" anchor="ctr"/>
+          <a:lstStyle/>
+          <a:p>
+            <a:pPr algn="ctr"/>
+            <a:endParaRPr lang="en-US" dirty="0">
+              <a:solidFill>
+                <a:schemeClr val="tx1"/>
+              </a:solidFill>
+            </a:endParaRPr>
+          </a:p>
+        </p:txBody>
+      </p:sp>
+      <p:sp>
+        <p:nvSpPr>
+          <p:cNvPr id="3" name="Rectangle: Rounded Corners 2">
+            <a:extLst>
+              <a:ext uri="{FF2B5EF4-FFF2-40B4-BE49-F238E27FC236}">
+                <a16:creationId xmlns:a16="http://schemas.microsoft.com/office/drawing/2014/main" id="{3CC2B664-F030-F1F9-F28B-DCC5EEC01A16}"/>
+              </a:ext>
+            </a:extLst>
+          </p:cNvPr>
+          <p:cNvSpPr/>
+          <p:nvPr/>
+        </p:nvSpPr>
+        <p:spPr>
+          <a:xfrm>
+            <a:off x="4805537" y="1655326"/>
+            <a:ext cx="2580925" cy="369332"/>
+          </a:xfrm>
+          <a:prstGeom prst="roundRect">
+            <a:avLst/>
+          </a:prstGeom>
+          <a:solidFill>
+            <a:srgbClr val="B2D4EB"/>
+          </a:solidFill>
+          <a:ln>
+            <a:solidFill>
+              <a:schemeClr val="tx1"/>
+            </a:solidFill>
+          </a:ln>
+        </p:spPr>
+        <p:style>
+          <a:lnRef idx="2">
+            <a:schemeClr val="accent1">
+              <a:shade val="15000"/>
+            </a:schemeClr>
+          </a:lnRef>
+          <a:fillRef idx="1">
+            <a:schemeClr val="accent1"/>
+          </a:fillRef>
+          <a:effectRef idx="0">
+            <a:schemeClr val="accent1"/>
+          </a:effectRef>
+          <a:fontRef idx="minor">
+            <a:schemeClr val="lt1"/>
+          </a:fontRef>
+        </p:style>
+        <p:txBody>
+          <a:bodyPr rtlCol="0" anchor="ctr"/>
+          <a:lstStyle/>
+          <a:p>
+            <a:pPr algn="ctr"/>
+            <a:r>
+              <a:rPr lang="en-US" dirty="0">
+                <a:solidFill>
+                  <a:schemeClr val="tx1"/>
+                </a:solidFill>
+              </a:rPr>
+              <a:t>On-Device Inference</a:t>
+            </a:r>
+            <a:endParaRPr lang="en-US" i="1" dirty="0">
+              <a:solidFill>
+                <a:schemeClr val="tx1"/>
+              </a:solidFill>
+            </a:endParaRPr>
+          </a:p>
+        </p:txBody>
+      </p:sp>
+      <p:graphicFrame>
+        <p:nvGraphicFramePr>
+          <p:cNvPr id="4" name="Table 3">
+            <a:extLst>
+              <a:ext uri="{FF2B5EF4-FFF2-40B4-BE49-F238E27FC236}">
+                <a16:creationId xmlns:a16="http://schemas.microsoft.com/office/drawing/2014/main" id="{DF53C473-9B29-E37D-A715-ED5C1E1CE73A}"/>
+              </a:ext>
+            </a:extLst>
+          </p:cNvPr>
+          <p:cNvGraphicFramePr>
+            <a:graphicFrameLocks noGrp="1"/>
+          </p:cNvGraphicFramePr>
+          <p:nvPr>
+            <p:extLst>
+              <p:ext uri="{D42A27DB-BD31-4B8C-83A1-F6EECF244321}">
+                <p14:modId xmlns:p14="http://schemas.microsoft.com/office/powerpoint/2010/main" val="2686571618"/>
+              </p:ext>
+            </p:extLst>
+          </p:nvPr>
+        </p:nvGraphicFramePr>
+        <p:xfrm>
+          <a:off x="3122928" y="2208569"/>
+          <a:ext cx="5946141" cy="370840"/>
+        </p:xfrm>
+        <a:graphic>
+          <a:graphicData uri="http://schemas.openxmlformats.org/drawingml/2006/table">
+            <a:tbl>
+              <a:tblPr firstRow="1" bandRow="1">
+                <a:tableStyleId>{5C22544A-7EE6-4342-B048-85BDC9FD1C3A}</a:tableStyleId>
+              </a:tblPr>
+              <a:tblGrid>
+                <a:gridCol w="1982047">
+                  <a:extLst>
+                    <a:ext uri="{9D8B030D-6E8A-4147-A177-3AD203B41FA5}">
+                      <a16:colId xmlns:a16="http://schemas.microsoft.com/office/drawing/2014/main" val="3167127258"/>
+                    </a:ext>
+                  </a:extLst>
+                </a:gridCol>
+                <a:gridCol w="1982047">
+                  <a:extLst>
+                    <a:ext uri="{9D8B030D-6E8A-4147-A177-3AD203B41FA5}">
+                      <a16:colId xmlns:a16="http://schemas.microsoft.com/office/drawing/2014/main" val="1913894467"/>
+                    </a:ext>
+                  </a:extLst>
+                </a:gridCol>
+                <a:gridCol w="1982047">
+                  <a:extLst>
+                    <a:ext uri="{9D8B030D-6E8A-4147-A177-3AD203B41FA5}">
+                      <a16:colId xmlns:a16="http://schemas.microsoft.com/office/drawing/2014/main" val="304178738"/>
+                    </a:ext>
+                  </a:extLst>
+                </a:gridCol>
+              </a:tblGrid>
+              <a:tr h="370840">
+                <a:tc>
+                  <a:txBody>
+                    <a:bodyPr/>
+                    <a:lstStyle/>
+                    <a:p>
+                      <a:pPr algn="ctr"/>
+                      <a:r>
+                        <a:rPr lang="en-US" b="0" dirty="0">
+                          <a:solidFill>
+                            <a:sysClr val="windowText" lastClr="000000"/>
+                          </a:solidFill>
+                        </a:rPr>
+                        <a:t>No per-token costs</a:t>
+                      </a:r>
+                    </a:p>
+                  </a:txBody>
+                  <a:tcPr anchor="ctr">
+                    <a:lnL w="12700" cmpd="sng">
+                      <a:noFill/>
+                    </a:lnL>
+                    <a:lnR w="12700" cmpd="sng">
+                      <a:noFill/>
+                    </a:lnR>
+                    <a:lnT w="12700" cmpd="sng">
+                      <a:noFill/>
+                    </a:lnT>
+                    <a:lnB w="38100" cmpd="sng">
+                      <a:noFill/>
+                    </a:lnB>
+                    <a:lnTlToBr w="12700" cmpd="sng">
+                      <a:noFill/>
+                      <a:prstDash val="solid"/>
+                    </a:lnTlToBr>
+                    <a:lnBlToTr w="12700" cmpd="sng">
+                      <a:noFill/>
+                      <a:prstDash val="solid"/>
+                    </a:lnBlToTr>
+                    <a:noFill/>
+                  </a:tcPr>
+                </a:tc>
+                <a:tc>
+                  <a:txBody>
+                    <a:bodyPr/>
+                    <a:lstStyle/>
+                    <a:p>
+                      <a:pPr algn="ctr"/>
+                      <a:r>
+                        <a:rPr lang="en-US" b="0" dirty="0">
+                          <a:solidFill>
+                            <a:sysClr val="windowText" lastClr="000000"/>
+                          </a:solidFill>
+                        </a:rPr>
+                        <a:t>Low latency</a:t>
+                      </a:r>
+                    </a:p>
+                  </a:txBody>
+                  <a:tcPr anchor="ctr">
+                    <a:lnL w="12700" cmpd="sng">
+                      <a:noFill/>
+                    </a:lnL>
+                    <a:lnR w="12700" cmpd="sng">
+                      <a:noFill/>
+                    </a:lnR>
+                    <a:lnT w="12700" cmpd="sng">
+                      <a:noFill/>
+                    </a:lnT>
+                    <a:lnB w="38100" cmpd="sng">
+                      <a:noFill/>
+                    </a:lnB>
+                    <a:lnTlToBr w="12700" cmpd="sng">
+                      <a:noFill/>
+                      <a:prstDash val="solid"/>
+                    </a:lnTlToBr>
+                    <a:lnBlToTr w="12700" cmpd="sng">
+                      <a:noFill/>
+                      <a:prstDash val="solid"/>
+                    </a:lnBlToTr>
+                    <a:noFill/>
+                  </a:tcPr>
+                </a:tc>
+                <a:tc>
+                  <a:txBody>
+                    <a:bodyPr/>
+                    <a:lstStyle/>
+                    <a:p>
+                      <a:pPr algn="ctr"/>
+                      <a:r>
+                        <a:rPr lang="en-US" b="0" dirty="0">
+                          <a:solidFill>
+                            <a:sysClr val="windowText" lastClr="000000"/>
+                          </a:solidFill>
+                        </a:rPr>
+                        <a:t>Works Offline</a:t>
+                      </a:r>
+                    </a:p>
+                  </a:txBody>
+                  <a:tcPr anchor="ctr">
+                    <a:lnL w="12700" cmpd="sng">
+                      <a:noFill/>
+                    </a:lnL>
+                    <a:lnR w="12700" cmpd="sng">
+                      <a:noFill/>
+                    </a:lnR>
+                    <a:lnT w="12700" cmpd="sng">
+                      <a:noFill/>
+                    </a:lnT>
+                    <a:lnB w="38100" cmpd="sng">
+                      <a:noFill/>
+                    </a:lnB>
+                    <a:lnTlToBr w="12700" cmpd="sng">
+                      <a:noFill/>
+                      <a:prstDash val="solid"/>
+                    </a:lnTlToBr>
+                    <a:lnBlToTr w="12700" cmpd="sng">
+                      <a:noFill/>
+                      <a:prstDash val="solid"/>
+                    </a:lnBlToTr>
+                    <a:noFill/>
+                  </a:tcPr>
+                </a:tc>
+                <a:extLst>
+                  <a:ext uri="{0D108BD9-81ED-4DB2-BD59-A6C34878D82A}">
+                    <a16:rowId xmlns:a16="http://schemas.microsoft.com/office/drawing/2014/main" val="2068122310"/>
+                  </a:ext>
+                </a:extLst>
+              </a:tr>
+            </a:tbl>
+          </a:graphicData>
+        </a:graphic>
+      </p:graphicFrame>
+      <p:sp>
+        <p:nvSpPr>
+          <p:cNvPr id="5" name="Rectangle: Rounded Corners 4">
+            <a:extLst>
+              <a:ext uri="{FF2B5EF4-FFF2-40B4-BE49-F238E27FC236}">
+                <a16:creationId xmlns:a16="http://schemas.microsoft.com/office/drawing/2014/main" id="{E2F5A509-0B8F-7811-0487-C9575E6398F1}"/>
+              </a:ext>
+            </a:extLst>
+          </p:cNvPr>
+          <p:cNvSpPr/>
+          <p:nvPr/>
+        </p:nvSpPr>
+        <p:spPr>
+          <a:xfrm>
+            <a:off x="2933281" y="3183887"/>
+            <a:ext cx="6325438" cy="974563"/>
+          </a:xfrm>
+          <a:prstGeom prst="roundRect">
+            <a:avLst>
+              <a:gd name="adj" fmla="val 5234"/>
+            </a:avLst>
+          </a:prstGeom>
+          <a:solidFill>
+            <a:schemeClr val="bg1"/>
+          </a:solidFill>
+          <a:ln>
+            <a:solidFill>
+              <a:schemeClr val="tx1"/>
+            </a:solidFill>
+          </a:ln>
+        </p:spPr>
+        <p:style>
+          <a:lnRef idx="2">
+            <a:schemeClr val="accent1">
+              <a:shade val="15000"/>
+            </a:schemeClr>
+          </a:lnRef>
+          <a:fillRef idx="1">
+            <a:schemeClr val="accent1"/>
+          </a:fillRef>
+          <a:effectRef idx="0">
+            <a:schemeClr val="accent1"/>
+          </a:effectRef>
+          <a:fontRef idx="minor">
+            <a:schemeClr val="lt1"/>
+          </a:fontRef>
+        </p:style>
+        <p:txBody>
+          <a:bodyPr rtlCol="0" anchor="ctr"/>
+          <a:lstStyle/>
+          <a:p>
+            <a:pPr algn="ctr"/>
+            <a:endParaRPr lang="en-US" dirty="0">
+              <a:solidFill>
+                <a:schemeClr val="tx1"/>
+              </a:solidFill>
+            </a:endParaRPr>
+          </a:p>
+        </p:txBody>
+      </p:sp>
+      <p:sp>
+        <p:nvSpPr>
+          <p:cNvPr id="6" name="Rectangle: Rounded Corners 5">
+            <a:extLst>
+              <a:ext uri="{FF2B5EF4-FFF2-40B4-BE49-F238E27FC236}">
+                <a16:creationId xmlns:a16="http://schemas.microsoft.com/office/drawing/2014/main" id="{D4965C37-35DD-9952-1CFD-D128D2081A33}"/>
+              </a:ext>
+            </a:extLst>
+          </p:cNvPr>
+          <p:cNvSpPr/>
+          <p:nvPr/>
+        </p:nvSpPr>
+        <p:spPr>
+          <a:xfrm>
+            <a:off x="4805537" y="2999221"/>
+            <a:ext cx="2580925" cy="369332"/>
+          </a:xfrm>
+          <a:prstGeom prst="roundRect">
+            <a:avLst/>
+          </a:prstGeom>
+          <a:solidFill>
+            <a:srgbClr val="B2D4EB"/>
+          </a:solidFill>
+          <a:ln>
+            <a:solidFill>
+              <a:schemeClr val="tx1"/>
+            </a:solidFill>
+          </a:ln>
+        </p:spPr>
+        <p:style>
+          <a:lnRef idx="2">
+            <a:schemeClr val="accent1">
+              <a:shade val="15000"/>
+            </a:schemeClr>
+          </a:lnRef>
+          <a:fillRef idx="1">
+            <a:schemeClr val="accent1"/>
+          </a:fillRef>
+          <a:effectRef idx="0">
+            <a:schemeClr val="accent1"/>
+          </a:effectRef>
+          <a:fontRef idx="minor">
+            <a:schemeClr val="lt1"/>
+          </a:fontRef>
+        </p:style>
+        <p:txBody>
+          <a:bodyPr rtlCol="0" anchor="ctr"/>
+          <a:lstStyle/>
+          <a:p>
+            <a:pPr algn="ctr"/>
+            <a:r>
+              <a:rPr lang="en-US" dirty="0">
+                <a:solidFill>
+                  <a:schemeClr val="tx1"/>
+                </a:solidFill>
+              </a:rPr>
+              <a:t>Model Customization</a:t>
+            </a:r>
+            <a:endParaRPr lang="en-US" i="1" dirty="0">
+              <a:solidFill>
+                <a:schemeClr val="tx1"/>
+              </a:solidFill>
+            </a:endParaRPr>
+          </a:p>
+        </p:txBody>
+      </p:sp>
+      <p:graphicFrame>
+        <p:nvGraphicFramePr>
+          <p:cNvPr id="7" name="Table 6">
+            <a:extLst>
+              <a:ext uri="{FF2B5EF4-FFF2-40B4-BE49-F238E27FC236}">
+                <a16:creationId xmlns:a16="http://schemas.microsoft.com/office/drawing/2014/main" id="{43E63C08-E18D-B389-2582-B89833A5B651}"/>
+              </a:ext>
+            </a:extLst>
+          </p:cNvPr>
+          <p:cNvGraphicFramePr>
+            <a:graphicFrameLocks noGrp="1"/>
+          </p:cNvGraphicFramePr>
+          <p:nvPr>
+            <p:extLst>
+              <p:ext uri="{D42A27DB-BD31-4B8C-83A1-F6EECF244321}">
+                <p14:modId xmlns:p14="http://schemas.microsoft.com/office/powerpoint/2010/main" val="3340926545"/>
+              </p:ext>
+            </p:extLst>
+          </p:nvPr>
+        </p:nvGraphicFramePr>
+        <p:xfrm>
+          <a:off x="3122928" y="3443461"/>
+          <a:ext cx="5946141" cy="640080"/>
+        </p:xfrm>
+        <a:graphic>
+          <a:graphicData uri="http://schemas.openxmlformats.org/drawingml/2006/table">
+            <a:tbl>
+              <a:tblPr firstRow="1" bandRow="1">
+                <a:tableStyleId>{5C22544A-7EE6-4342-B048-85BDC9FD1C3A}</a:tableStyleId>
+              </a:tblPr>
+              <a:tblGrid>
+                <a:gridCol w="1982047">
+                  <a:extLst>
+                    <a:ext uri="{9D8B030D-6E8A-4147-A177-3AD203B41FA5}">
+                      <a16:colId xmlns:a16="http://schemas.microsoft.com/office/drawing/2014/main" val="3167127258"/>
+                    </a:ext>
+                  </a:extLst>
+                </a:gridCol>
+                <a:gridCol w="1982047">
+                  <a:extLst>
+                    <a:ext uri="{9D8B030D-6E8A-4147-A177-3AD203B41FA5}">
+                      <a16:colId xmlns:a16="http://schemas.microsoft.com/office/drawing/2014/main" val="1913894467"/>
+                    </a:ext>
+                  </a:extLst>
+                </a:gridCol>
+                <a:gridCol w="1982047">
+                  <a:extLst>
+                    <a:ext uri="{9D8B030D-6E8A-4147-A177-3AD203B41FA5}">
+                      <a16:colId xmlns:a16="http://schemas.microsoft.com/office/drawing/2014/main" val="304178738"/>
+                    </a:ext>
+                  </a:extLst>
+                </a:gridCol>
+              </a:tblGrid>
+              <a:tr h="370840">
+                <a:tc>
+                  <a:txBody>
+                    <a:bodyPr/>
+                    <a:lstStyle/>
+                    <a:p>
+                      <a:pPr algn="ctr"/>
+                      <a:r>
+                        <a:rPr lang="en-US" b="0" dirty="0">
+                          <a:solidFill>
+                            <a:sysClr val="windowText" lastClr="000000"/>
+                          </a:solidFill>
+                        </a:rPr>
+                        <a:t>Download from Foundry models</a:t>
+                      </a:r>
+                    </a:p>
+                  </a:txBody>
+                  <a:tcPr anchor="ctr">
+                    <a:lnL w="12700" cmpd="sng">
+                      <a:noFill/>
+                    </a:lnL>
+                    <a:lnR w="12700" cmpd="sng">
+                      <a:noFill/>
+                    </a:lnR>
+                    <a:lnT w="12700" cmpd="sng">
+                      <a:noFill/>
+                    </a:lnT>
+                    <a:lnB w="38100" cmpd="sng">
+                      <a:noFill/>
+                    </a:lnB>
+                    <a:lnTlToBr w="12700" cmpd="sng">
+                      <a:noFill/>
+                      <a:prstDash val="solid"/>
+                    </a:lnTlToBr>
+                    <a:lnBlToTr w="12700" cmpd="sng">
+                      <a:noFill/>
+                      <a:prstDash val="solid"/>
+                    </a:lnBlToTr>
+                    <a:noFill/>
+                  </a:tcPr>
+                </a:tc>
+                <a:tc>
+                  <a:txBody>
+                    <a:bodyPr/>
+                    <a:lstStyle/>
+                    <a:p>
+                      <a:pPr algn="ctr"/>
+                      <a:r>
+                        <a:rPr lang="en-US" b="0" dirty="0">
+                          <a:solidFill>
+                            <a:sysClr val="windowText" lastClr="000000"/>
+                          </a:solidFill>
+                        </a:rPr>
+                        <a:t>Pull other models from Hugging Face</a:t>
+                      </a:r>
+                    </a:p>
+                  </a:txBody>
+                  <a:tcPr anchor="ctr">
+                    <a:lnL w="12700" cmpd="sng">
+                      <a:noFill/>
+                    </a:lnL>
+                    <a:lnR w="12700" cmpd="sng">
+                      <a:noFill/>
+                    </a:lnR>
+                    <a:lnT w="12700" cmpd="sng">
+                      <a:noFill/>
+                    </a:lnT>
+                    <a:lnB w="38100" cmpd="sng">
+                      <a:noFill/>
+                    </a:lnB>
+                    <a:lnTlToBr w="12700" cmpd="sng">
+                      <a:noFill/>
+                      <a:prstDash val="solid"/>
+                    </a:lnTlToBr>
+                    <a:lnBlToTr w="12700" cmpd="sng">
+                      <a:noFill/>
+                      <a:prstDash val="solid"/>
+                    </a:lnBlToTr>
+                    <a:noFill/>
+                  </a:tcPr>
+                </a:tc>
+                <a:tc>
+                  <a:txBody>
+                    <a:bodyPr/>
+                    <a:lstStyle/>
+                    <a:p>
+                      <a:pPr algn="ctr"/>
+                      <a:r>
+                        <a:rPr lang="en-US" b="0" dirty="0">
+                          <a:solidFill>
+                            <a:sysClr val="windowText" lastClr="000000"/>
+                          </a:solidFill>
+                        </a:rPr>
+                        <a:t>Optimize for your machine</a:t>
+                      </a:r>
+                    </a:p>
+                  </a:txBody>
+                  <a:tcPr anchor="ctr">
+                    <a:lnL w="12700" cmpd="sng">
+                      <a:noFill/>
+                    </a:lnL>
+                    <a:lnR w="12700" cmpd="sng">
+                      <a:noFill/>
+                    </a:lnR>
+                    <a:lnT w="12700" cmpd="sng">
+                      <a:noFill/>
+                    </a:lnT>
+                    <a:lnB w="38100" cmpd="sng">
+                      <a:noFill/>
+                    </a:lnB>
+                    <a:lnTlToBr w="12700" cmpd="sng">
+                      <a:noFill/>
+                      <a:prstDash val="solid"/>
+                    </a:lnTlToBr>
+                    <a:lnBlToTr w="12700" cmpd="sng">
+                      <a:noFill/>
+                      <a:prstDash val="solid"/>
+                    </a:lnBlToTr>
+                    <a:noFill/>
+                  </a:tcPr>
+                </a:tc>
+                <a:extLst>
+                  <a:ext uri="{0D108BD9-81ED-4DB2-BD59-A6C34878D82A}">
+                    <a16:rowId xmlns:a16="http://schemas.microsoft.com/office/drawing/2014/main" val="2068122310"/>
+                  </a:ext>
+                </a:extLst>
+              </a:tr>
+            </a:tbl>
+          </a:graphicData>
+        </a:graphic>
+      </p:graphicFrame>
+      <p:sp>
+        <p:nvSpPr>
+          <p:cNvPr id="8" name="Rectangle: Rounded Corners 7">
+            <a:extLst>
+              <a:ext uri="{FF2B5EF4-FFF2-40B4-BE49-F238E27FC236}">
+                <a16:creationId xmlns:a16="http://schemas.microsoft.com/office/drawing/2014/main" id="{807007C4-3061-A8D2-7F2E-AC6DBB9E5633}"/>
+              </a:ext>
+            </a:extLst>
+          </p:cNvPr>
+          <p:cNvSpPr/>
+          <p:nvPr/>
+        </p:nvSpPr>
+        <p:spPr>
+          <a:xfrm>
+            <a:off x="2933282" y="4527781"/>
+            <a:ext cx="6325438" cy="974563"/>
+          </a:xfrm>
+          <a:prstGeom prst="roundRect">
+            <a:avLst>
+              <a:gd name="adj" fmla="val 5234"/>
+            </a:avLst>
+          </a:prstGeom>
+          <a:solidFill>
+            <a:schemeClr val="bg1"/>
+          </a:solidFill>
+          <a:ln>
+            <a:solidFill>
+              <a:schemeClr val="tx1"/>
+            </a:solidFill>
+          </a:ln>
+        </p:spPr>
+        <p:style>
+          <a:lnRef idx="2">
+            <a:schemeClr val="accent1">
+              <a:shade val="15000"/>
+            </a:schemeClr>
+          </a:lnRef>
+          <a:fillRef idx="1">
+            <a:schemeClr val="accent1"/>
+          </a:fillRef>
+          <a:effectRef idx="0">
+            <a:schemeClr val="accent1"/>
+          </a:effectRef>
+          <a:fontRef idx="minor">
+            <a:schemeClr val="lt1"/>
+          </a:fontRef>
+        </p:style>
+        <p:txBody>
+          <a:bodyPr rtlCol="0" anchor="ctr"/>
+          <a:lstStyle/>
+          <a:p>
+            <a:pPr algn="ctr"/>
+            <a:endParaRPr lang="en-US" dirty="0">
+              <a:solidFill>
+                <a:schemeClr val="tx1"/>
+              </a:solidFill>
+            </a:endParaRPr>
+          </a:p>
+        </p:txBody>
+      </p:sp>
+      <p:sp>
+        <p:nvSpPr>
+          <p:cNvPr id="9" name="Rectangle: Rounded Corners 8">
+            <a:extLst>
+              <a:ext uri="{FF2B5EF4-FFF2-40B4-BE49-F238E27FC236}">
+                <a16:creationId xmlns:a16="http://schemas.microsoft.com/office/drawing/2014/main" id="{40E10519-9789-FE60-F956-7F35469179EF}"/>
+              </a:ext>
+            </a:extLst>
+          </p:cNvPr>
+          <p:cNvSpPr/>
+          <p:nvPr/>
+        </p:nvSpPr>
+        <p:spPr>
+          <a:xfrm>
+            <a:off x="4805538" y="4343115"/>
+            <a:ext cx="2580925" cy="369332"/>
+          </a:xfrm>
+          <a:prstGeom prst="roundRect">
+            <a:avLst/>
+          </a:prstGeom>
+          <a:solidFill>
+            <a:srgbClr val="B2D4EB"/>
+          </a:solidFill>
+          <a:ln>
+            <a:solidFill>
+              <a:schemeClr val="tx1"/>
+            </a:solidFill>
+          </a:ln>
+        </p:spPr>
+        <p:style>
+          <a:lnRef idx="2">
+            <a:schemeClr val="accent1">
+              <a:shade val="15000"/>
+            </a:schemeClr>
+          </a:lnRef>
+          <a:fillRef idx="1">
+            <a:schemeClr val="accent1"/>
+          </a:fillRef>
+          <a:effectRef idx="0">
+            <a:schemeClr val="accent1"/>
+          </a:effectRef>
+          <a:fontRef idx="minor">
+            <a:schemeClr val="lt1"/>
+          </a:fontRef>
+        </p:style>
+        <p:txBody>
+          <a:bodyPr rtlCol="0" anchor="ctr"/>
+          <a:lstStyle/>
+          <a:p>
+            <a:pPr algn="ctr"/>
+            <a:r>
+              <a:rPr lang="en-US" dirty="0">
+                <a:solidFill>
+                  <a:schemeClr val="tx1"/>
+                </a:solidFill>
+              </a:rPr>
+              <a:t>App Integration</a:t>
+            </a:r>
+            <a:endParaRPr lang="en-US" i="1" dirty="0">
+              <a:solidFill>
+                <a:schemeClr val="tx1"/>
+              </a:solidFill>
+            </a:endParaRPr>
+          </a:p>
+        </p:txBody>
+      </p:sp>
+      <p:graphicFrame>
+        <p:nvGraphicFramePr>
+          <p:cNvPr id="10" name="Table 9">
+            <a:extLst>
+              <a:ext uri="{FF2B5EF4-FFF2-40B4-BE49-F238E27FC236}">
+                <a16:creationId xmlns:a16="http://schemas.microsoft.com/office/drawing/2014/main" id="{5B679DA3-8983-1774-D4AD-BD0BA5945F8A}"/>
+              </a:ext>
+            </a:extLst>
+          </p:cNvPr>
+          <p:cNvGraphicFramePr>
+            <a:graphicFrameLocks noGrp="1"/>
+          </p:cNvGraphicFramePr>
+          <p:nvPr>
+            <p:extLst>
+              <p:ext uri="{D42A27DB-BD31-4B8C-83A1-F6EECF244321}">
+                <p14:modId xmlns:p14="http://schemas.microsoft.com/office/powerpoint/2010/main" val="1308394595"/>
+              </p:ext>
+            </p:extLst>
+          </p:nvPr>
+        </p:nvGraphicFramePr>
+        <p:xfrm>
+          <a:off x="3122929" y="4787355"/>
+          <a:ext cx="5946141" cy="640080"/>
+        </p:xfrm>
+        <a:graphic>
+          <a:graphicData uri="http://schemas.openxmlformats.org/drawingml/2006/table">
+            <a:tbl>
+              <a:tblPr firstRow="1" bandRow="1">
+                <a:tableStyleId>{5C22544A-7EE6-4342-B048-85BDC9FD1C3A}</a:tableStyleId>
+              </a:tblPr>
+              <a:tblGrid>
+                <a:gridCol w="1982047">
+                  <a:extLst>
+                    <a:ext uri="{9D8B030D-6E8A-4147-A177-3AD203B41FA5}">
+                      <a16:colId xmlns:a16="http://schemas.microsoft.com/office/drawing/2014/main" val="3167127258"/>
+                    </a:ext>
+                  </a:extLst>
+                </a:gridCol>
+                <a:gridCol w="1982047">
+                  <a:extLst>
+                    <a:ext uri="{9D8B030D-6E8A-4147-A177-3AD203B41FA5}">
+                      <a16:colId xmlns:a16="http://schemas.microsoft.com/office/drawing/2014/main" val="1913894467"/>
+                    </a:ext>
+                  </a:extLst>
+                </a:gridCol>
+                <a:gridCol w="1982047">
+                  <a:extLst>
+                    <a:ext uri="{9D8B030D-6E8A-4147-A177-3AD203B41FA5}">
+                      <a16:colId xmlns:a16="http://schemas.microsoft.com/office/drawing/2014/main" val="304178738"/>
+                    </a:ext>
+                  </a:extLst>
+                </a:gridCol>
+              </a:tblGrid>
+              <a:tr h="370840">
+                <a:tc>
+                  <a:txBody>
+                    <a:bodyPr/>
+                    <a:lstStyle/>
+                    <a:p>
+                      <a:pPr algn="ctr"/>
+                      <a:r>
+                        <a:rPr lang="en-US" b="0" dirty="0">
+                          <a:solidFill>
+                            <a:sysClr val="windowText" lastClr="000000"/>
+                          </a:solidFill>
+                        </a:rPr>
+                        <a:t>SDKs for </a:t>
+                      </a:r>
+                      <a:r>
+                        <a:rPr lang="en-US" b="0" dirty="0" err="1">
+                          <a:solidFill>
+                            <a:sysClr val="windowText" lastClr="000000"/>
+                          </a:solidFill>
+                        </a:rPr>
+                        <a:t>Javascript</a:t>
+                      </a:r>
+                      <a:r>
+                        <a:rPr lang="en-US" b="0" dirty="0">
+                          <a:solidFill>
+                            <a:sysClr val="windowText" lastClr="000000"/>
+                          </a:solidFill>
+                        </a:rPr>
+                        <a:t>, Python, &amp; C#</a:t>
+                      </a:r>
+                    </a:p>
+                  </a:txBody>
+                  <a:tcPr anchor="ctr">
+                    <a:lnL w="12700" cmpd="sng">
+                      <a:noFill/>
+                    </a:lnL>
+                    <a:lnR w="12700" cmpd="sng">
+                      <a:noFill/>
+                    </a:lnR>
+                    <a:lnT w="12700" cmpd="sng">
+                      <a:noFill/>
+                    </a:lnT>
+                    <a:lnB w="38100" cmpd="sng">
+                      <a:noFill/>
+                    </a:lnB>
+                    <a:lnTlToBr w="12700" cmpd="sng">
+                      <a:noFill/>
+                      <a:prstDash val="solid"/>
+                    </a:lnTlToBr>
+                    <a:lnBlToTr w="12700" cmpd="sng">
+                      <a:noFill/>
+                      <a:prstDash val="solid"/>
+                    </a:lnBlToTr>
+                    <a:noFill/>
+                  </a:tcPr>
+                </a:tc>
+                <a:tc>
+                  <a:txBody>
+                    <a:bodyPr/>
+                    <a:lstStyle/>
+                    <a:p>
+                      <a:pPr algn="ctr"/>
+                      <a:r>
+                        <a:rPr lang="en-US" b="0" dirty="0">
+                          <a:solidFill>
+                            <a:sysClr val="windowText" lastClr="000000"/>
+                          </a:solidFill>
+                        </a:rPr>
+                        <a:t>OpenAI-compatible API format</a:t>
+                      </a:r>
+                    </a:p>
+                  </a:txBody>
+                  <a:tcPr anchor="ctr">
+                    <a:lnL w="12700" cmpd="sng">
+                      <a:noFill/>
+                    </a:lnL>
+                    <a:lnR w="12700" cmpd="sng">
+                      <a:noFill/>
+                    </a:lnR>
+                    <a:lnT w="12700" cmpd="sng">
+                      <a:noFill/>
+                    </a:lnT>
+                    <a:lnB w="38100" cmpd="sng">
+                      <a:noFill/>
+                    </a:lnB>
+                    <a:lnTlToBr w="12700" cmpd="sng">
+                      <a:noFill/>
+                      <a:prstDash val="solid"/>
+                    </a:lnTlToBr>
+                    <a:lnBlToTr w="12700" cmpd="sng">
+                      <a:noFill/>
+                      <a:prstDash val="solid"/>
+                    </a:lnBlToTr>
+                    <a:noFill/>
+                  </a:tcPr>
+                </a:tc>
+                <a:tc>
+                  <a:txBody>
+                    <a:bodyPr/>
+                    <a:lstStyle/>
+                    <a:p>
+                      <a:pPr algn="ctr"/>
+                      <a:r>
+                        <a:rPr lang="en-US" b="0" dirty="0">
+                          <a:solidFill>
+                            <a:sysClr val="windowText" lastClr="000000"/>
+                          </a:solidFill>
+                        </a:rPr>
+                        <a:t>Interactive chat</a:t>
+                      </a:r>
+                    </a:p>
+                    <a:p>
+                      <a:pPr algn="ctr"/>
+                      <a:r>
+                        <a:rPr lang="en-US" b="0" dirty="0">
+                          <a:solidFill>
+                            <a:sysClr val="windowText" lastClr="000000"/>
+                          </a:solidFill>
+                        </a:rPr>
+                        <a:t>via the CLI</a:t>
+                      </a:r>
+                    </a:p>
+                  </a:txBody>
+                  <a:tcPr anchor="ctr">
+                    <a:lnL w="12700" cmpd="sng">
+                      <a:noFill/>
+                    </a:lnL>
+                    <a:lnR w="12700" cmpd="sng">
+                      <a:noFill/>
+                    </a:lnR>
+                    <a:lnT w="12700" cmpd="sng">
+                      <a:noFill/>
+                    </a:lnT>
+                    <a:lnB w="38100" cmpd="sng">
+                      <a:noFill/>
+                    </a:lnB>
+                    <a:lnTlToBr w="12700" cmpd="sng">
+                      <a:noFill/>
+                      <a:prstDash val="solid"/>
+                    </a:lnTlToBr>
+                    <a:lnBlToTr w="12700" cmpd="sng">
+                      <a:noFill/>
+                      <a:prstDash val="solid"/>
+                    </a:lnBlToTr>
+                    <a:noFill/>
+                  </a:tcPr>
+                </a:tc>
+                <a:extLst>
+                  <a:ext uri="{0D108BD9-81ED-4DB2-BD59-A6C34878D82A}">
+                    <a16:rowId xmlns:a16="http://schemas.microsoft.com/office/drawing/2014/main" val="2068122310"/>
+                  </a:ext>
+                </a:extLst>
+              </a:tr>
+            </a:tbl>
+          </a:graphicData>
+        </a:graphic>
+      </p:graphicFrame>
     </p:spTree>
     <p:extLst>
       <p:ext uri="{BB962C8B-B14F-4D97-AF65-F5344CB8AC3E}">
@@ -9526,6 +10487,1226 @@
           <a:chExt cx="0" cy="0"/>
         </a:xfrm>
       </p:grpSpPr>
+      <p:sp>
+        <p:nvSpPr>
+          <p:cNvPr id="2" name="Rectangle: Rounded Corners 1">
+            <a:extLst>
+              <a:ext uri="{FF2B5EF4-FFF2-40B4-BE49-F238E27FC236}">
+                <a16:creationId xmlns:a16="http://schemas.microsoft.com/office/drawing/2014/main" id="{9DABD033-95C1-DE14-1371-DDB65914500E}"/>
+              </a:ext>
+            </a:extLst>
+          </p:cNvPr>
+          <p:cNvSpPr/>
+          <p:nvPr/>
+        </p:nvSpPr>
+        <p:spPr>
+          <a:xfrm>
+            <a:off x="2584694" y="2174798"/>
+            <a:ext cx="4982297" cy="2468643"/>
+          </a:xfrm>
+          <a:prstGeom prst="roundRect">
+            <a:avLst>
+              <a:gd name="adj" fmla="val 5234"/>
+            </a:avLst>
+          </a:prstGeom>
+          <a:solidFill>
+            <a:schemeClr val="bg1"/>
+          </a:solidFill>
+          <a:ln>
+            <a:solidFill>
+              <a:schemeClr val="tx1"/>
+            </a:solidFill>
+          </a:ln>
+        </p:spPr>
+        <p:style>
+          <a:lnRef idx="2">
+            <a:schemeClr val="accent1">
+              <a:shade val="15000"/>
+            </a:schemeClr>
+          </a:lnRef>
+          <a:fillRef idx="1">
+            <a:schemeClr val="accent1"/>
+          </a:fillRef>
+          <a:effectRef idx="0">
+            <a:schemeClr val="accent1"/>
+          </a:effectRef>
+          <a:fontRef idx="minor">
+            <a:schemeClr val="lt1"/>
+          </a:fontRef>
+        </p:style>
+        <p:txBody>
+          <a:bodyPr rtlCol="0" anchor="ctr"/>
+          <a:lstStyle/>
+          <a:p>
+            <a:pPr algn="ctr"/>
+            <a:endParaRPr lang="en-US" dirty="0">
+              <a:solidFill>
+                <a:schemeClr val="tx1"/>
+              </a:solidFill>
+            </a:endParaRPr>
+          </a:p>
+        </p:txBody>
+      </p:sp>
+      <p:cxnSp>
+        <p:nvCxnSpPr>
+          <p:cNvPr id="8" name="Straight Arrow Connector 7">
+            <a:extLst>
+              <a:ext uri="{FF2B5EF4-FFF2-40B4-BE49-F238E27FC236}">
+                <a16:creationId xmlns:a16="http://schemas.microsoft.com/office/drawing/2014/main" id="{81F47915-E3BB-FBA3-7676-86FE48083972}"/>
+              </a:ext>
+            </a:extLst>
+          </p:cNvPr>
+          <p:cNvCxnSpPr>
+            <a:cxnSpLocks/>
+            <a:stCxn id="20" idx="1"/>
+            <a:endCxn id="12" idx="3"/>
+          </p:cNvCxnSpPr>
+          <p:nvPr/>
+        </p:nvCxnSpPr>
+        <p:spPr>
+          <a:xfrm flipH="1">
+            <a:off x="7281103" y="2888337"/>
+            <a:ext cx="795151" cy="0"/>
+          </a:xfrm>
+          <a:prstGeom prst="straightConnector1">
+            <a:avLst/>
+          </a:prstGeom>
+          <a:ln>
+            <a:solidFill>
+              <a:schemeClr val="tx1"/>
+            </a:solidFill>
+            <a:prstDash val="solid"/>
+            <a:headEnd type="none" w="lg" len="lg"/>
+            <a:tailEnd type="triangle" w="lg" len="lg"/>
+          </a:ln>
+        </p:spPr>
+        <p:style>
+          <a:lnRef idx="2">
+            <a:schemeClr val="accent1"/>
+          </a:lnRef>
+          <a:fillRef idx="0">
+            <a:schemeClr val="accent1"/>
+          </a:fillRef>
+          <a:effectRef idx="1">
+            <a:schemeClr val="accent1"/>
+          </a:effectRef>
+          <a:fontRef idx="minor">
+            <a:schemeClr val="tx1"/>
+          </a:fontRef>
+        </p:style>
+      </p:cxnSp>
+      <p:grpSp>
+        <p:nvGrpSpPr>
+          <p:cNvPr id="26" name="Group 25">
+            <a:extLst>
+              <a:ext uri="{FF2B5EF4-FFF2-40B4-BE49-F238E27FC236}">
+                <a16:creationId xmlns:a16="http://schemas.microsoft.com/office/drawing/2014/main" id="{D9DEEFD6-4A89-56D2-D306-6B0F392F03A2}"/>
+              </a:ext>
+            </a:extLst>
+          </p:cNvPr>
+          <p:cNvGrpSpPr/>
+          <p:nvPr/>
+        </p:nvGrpSpPr>
+        <p:grpSpPr>
+          <a:xfrm>
+            <a:off x="2870578" y="2444894"/>
+            <a:ext cx="4410525" cy="1928450"/>
+            <a:chOff x="4432935" y="2463266"/>
+            <a:chExt cx="4410525" cy="1928450"/>
+          </a:xfrm>
+        </p:grpSpPr>
+        <p:sp>
+          <p:nvSpPr>
+            <p:cNvPr id="4" name="Rectangle: Rounded Corners 3">
+              <a:extLst>
+                <a:ext uri="{FF2B5EF4-FFF2-40B4-BE49-F238E27FC236}">
+                  <a16:creationId xmlns:a16="http://schemas.microsoft.com/office/drawing/2014/main" id="{7D235446-172F-6EEA-DCA9-68B84AE458F0}"/>
+                </a:ext>
+              </a:extLst>
+            </p:cNvPr>
+            <p:cNvSpPr/>
+            <p:nvPr/>
+          </p:nvSpPr>
+          <p:spPr>
+            <a:xfrm>
+              <a:off x="4432936" y="2466285"/>
+              <a:ext cx="1344168" cy="866894"/>
+            </a:xfrm>
+            <a:prstGeom prst="roundRect">
+              <a:avLst/>
+            </a:prstGeom>
+            <a:solidFill>
+              <a:srgbClr val="E5F1F8"/>
+            </a:solidFill>
+            <a:ln>
+              <a:solidFill>
+                <a:schemeClr val="tx1"/>
+              </a:solidFill>
+            </a:ln>
+          </p:spPr>
+          <p:style>
+            <a:lnRef idx="2">
+              <a:schemeClr val="accent1">
+                <a:shade val="15000"/>
+              </a:schemeClr>
+            </a:lnRef>
+            <a:fillRef idx="1">
+              <a:schemeClr val="accent1"/>
+            </a:fillRef>
+            <a:effectRef idx="0">
+              <a:schemeClr val="accent1"/>
+            </a:effectRef>
+            <a:fontRef idx="minor">
+              <a:schemeClr val="lt1"/>
+            </a:fontRef>
+          </p:style>
+          <p:txBody>
+            <a:bodyPr rtlCol="0" anchor="ctr"/>
+            <a:lstStyle/>
+            <a:p>
+              <a:pPr algn="ctr"/>
+              <a:r>
+                <a:rPr lang="en-US" dirty="0">
+                  <a:solidFill>
+                    <a:schemeClr val="tx1"/>
+                  </a:solidFill>
+                </a:rPr>
+                <a:t>Local Service</a:t>
+              </a:r>
+            </a:p>
+            <a:p>
+              <a:pPr algn="ctr"/>
+              <a:r>
+                <a:rPr lang="en-US" dirty="0">
+                  <a:solidFill>
+                    <a:schemeClr val="tx1"/>
+                  </a:solidFill>
+                </a:rPr>
+                <a:t>(Core C API)</a:t>
+              </a:r>
+            </a:p>
+          </p:txBody>
+        </p:sp>
+        <p:sp>
+          <p:nvSpPr>
+            <p:cNvPr id="6" name="Rectangle: Rounded Corners 5">
+              <a:extLst>
+                <a:ext uri="{FF2B5EF4-FFF2-40B4-BE49-F238E27FC236}">
+                  <a16:creationId xmlns:a16="http://schemas.microsoft.com/office/drawing/2014/main" id="{EC6BE8AC-19F7-DD20-EE5B-659AF29F464A}"/>
+                </a:ext>
+              </a:extLst>
+            </p:cNvPr>
+            <p:cNvSpPr/>
+            <p:nvPr/>
+          </p:nvSpPr>
+          <p:spPr>
+            <a:xfrm>
+              <a:off x="5966114" y="2463266"/>
+              <a:ext cx="1344168" cy="866894"/>
+            </a:xfrm>
+            <a:prstGeom prst="roundRect">
+              <a:avLst/>
+            </a:prstGeom>
+            <a:solidFill>
+              <a:srgbClr val="E5F1F8"/>
+            </a:solidFill>
+            <a:ln>
+              <a:solidFill>
+                <a:schemeClr val="tx1"/>
+              </a:solidFill>
+            </a:ln>
+          </p:spPr>
+          <p:style>
+            <a:lnRef idx="2">
+              <a:schemeClr val="accent1">
+                <a:shade val="15000"/>
+              </a:schemeClr>
+            </a:lnRef>
+            <a:fillRef idx="1">
+              <a:schemeClr val="accent1"/>
+            </a:fillRef>
+            <a:effectRef idx="0">
+              <a:schemeClr val="accent1"/>
+            </a:effectRef>
+            <a:fontRef idx="minor">
+              <a:schemeClr val="lt1"/>
+            </a:fontRef>
+          </p:style>
+          <p:txBody>
+            <a:bodyPr rtlCol="0" anchor="ctr"/>
+            <a:lstStyle/>
+            <a:p>
+              <a:pPr algn="ctr"/>
+              <a:r>
+                <a:rPr lang="en-US" dirty="0">
+                  <a:solidFill>
+                    <a:schemeClr val="tx1"/>
+                  </a:solidFill>
+                </a:rPr>
+                <a:t>ONNX Runtime</a:t>
+              </a:r>
+            </a:p>
+          </p:txBody>
+        </p:sp>
+        <p:sp>
+          <p:nvSpPr>
+            <p:cNvPr id="7" name="Rectangle: Rounded Corners 6">
+              <a:extLst>
+                <a:ext uri="{FF2B5EF4-FFF2-40B4-BE49-F238E27FC236}">
+                  <a16:creationId xmlns:a16="http://schemas.microsoft.com/office/drawing/2014/main" id="{8197549C-A069-ABFE-9697-3B84E0F4C460}"/>
+                </a:ext>
+              </a:extLst>
+            </p:cNvPr>
+            <p:cNvSpPr/>
+            <p:nvPr/>
+          </p:nvSpPr>
+          <p:spPr>
+            <a:xfrm>
+              <a:off x="4432935" y="3524822"/>
+              <a:ext cx="4410525" cy="866894"/>
+            </a:xfrm>
+            <a:prstGeom prst="roundRect">
+              <a:avLst/>
+            </a:prstGeom>
+            <a:solidFill>
+              <a:srgbClr val="E5F1F8"/>
+            </a:solidFill>
+            <a:ln>
+              <a:solidFill>
+                <a:schemeClr val="tx1"/>
+              </a:solidFill>
+            </a:ln>
+          </p:spPr>
+          <p:style>
+            <a:lnRef idx="2">
+              <a:schemeClr val="accent1">
+                <a:shade val="15000"/>
+              </a:schemeClr>
+            </a:lnRef>
+            <a:fillRef idx="1">
+              <a:schemeClr val="accent1"/>
+            </a:fillRef>
+            <a:effectRef idx="0">
+              <a:schemeClr val="accent1"/>
+            </a:effectRef>
+            <a:fontRef idx="minor">
+              <a:schemeClr val="lt1"/>
+            </a:fontRef>
+          </p:style>
+          <p:txBody>
+            <a:bodyPr rtlCol="0" anchor="t"/>
+            <a:lstStyle/>
+            <a:p>
+              <a:pPr algn="ctr"/>
+              <a:r>
+                <a:rPr lang="en-US" dirty="0">
+                  <a:solidFill>
+                    <a:schemeClr val="tx1"/>
+                  </a:solidFill>
+                </a:rPr>
+                <a:t>Model Cache</a:t>
+              </a:r>
+            </a:p>
+          </p:txBody>
+        </p:sp>
+        <p:sp>
+          <p:nvSpPr>
+            <p:cNvPr id="12" name="Rectangle: Rounded Corners 11">
+              <a:extLst>
+                <a:ext uri="{FF2B5EF4-FFF2-40B4-BE49-F238E27FC236}">
+                  <a16:creationId xmlns:a16="http://schemas.microsoft.com/office/drawing/2014/main" id="{3EAD17B7-C4B2-FCB0-6649-6E63B0A81515}"/>
+                </a:ext>
+              </a:extLst>
+            </p:cNvPr>
+            <p:cNvSpPr/>
+            <p:nvPr/>
+          </p:nvSpPr>
+          <p:spPr>
+            <a:xfrm>
+              <a:off x="7499292" y="2473262"/>
+              <a:ext cx="1344168" cy="866894"/>
+            </a:xfrm>
+            <a:prstGeom prst="roundRect">
+              <a:avLst/>
+            </a:prstGeom>
+            <a:solidFill>
+              <a:srgbClr val="E5F1F8"/>
+            </a:solidFill>
+            <a:ln>
+              <a:solidFill>
+                <a:schemeClr val="tx1"/>
+              </a:solidFill>
+            </a:ln>
+          </p:spPr>
+          <p:style>
+            <a:lnRef idx="2">
+              <a:schemeClr val="accent1">
+                <a:shade val="15000"/>
+              </a:schemeClr>
+            </a:lnRef>
+            <a:fillRef idx="1">
+              <a:schemeClr val="accent1"/>
+            </a:fillRef>
+            <a:effectRef idx="0">
+              <a:schemeClr val="accent1"/>
+            </a:effectRef>
+            <a:fontRef idx="minor">
+              <a:schemeClr val="lt1"/>
+            </a:fontRef>
+          </p:style>
+          <p:txBody>
+            <a:bodyPr rtlCol="0" anchor="ctr"/>
+            <a:lstStyle/>
+            <a:p>
+              <a:pPr algn="ctr"/>
+              <a:r>
+                <a:rPr lang="en-US" dirty="0">
+                  <a:solidFill>
+                    <a:schemeClr val="tx1"/>
+                  </a:solidFill>
+                </a:rPr>
+                <a:t>Model Management</a:t>
+              </a:r>
+            </a:p>
+          </p:txBody>
+        </p:sp>
+        <p:sp>
+          <p:nvSpPr>
+            <p:cNvPr id="13" name="Rectangle: Rounded Corners 12">
+              <a:extLst>
+                <a:ext uri="{FF2B5EF4-FFF2-40B4-BE49-F238E27FC236}">
+                  <a16:creationId xmlns:a16="http://schemas.microsoft.com/office/drawing/2014/main" id="{2120D170-1949-EC3F-DB51-93C17FCF7505}"/>
+                </a:ext>
+              </a:extLst>
+            </p:cNvPr>
+            <p:cNvSpPr/>
+            <p:nvPr/>
+          </p:nvSpPr>
+          <p:spPr>
+            <a:xfrm>
+              <a:off x="6102328" y="3955654"/>
+              <a:ext cx="1071738" cy="322014"/>
+            </a:xfrm>
+            <a:prstGeom prst="roundRect">
+              <a:avLst/>
+            </a:prstGeom>
+            <a:solidFill>
+              <a:srgbClr val="B2D4EB"/>
+            </a:solidFill>
+            <a:ln>
+              <a:solidFill>
+                <a:schemeClr val="tx1"/>
+              </a:solidFill>
+            </a:ln>
+          </p:spPr>
+          <p:style>
+            <a:lnRef idx="2">
+              <a:schemeClr val="accent1">
+                <a:shade val="15000"/>
+              </a:schemeClr>
+            </a:lnRef>
+            <a:fillRef idx="1">
+              <a:schemeClr val="accent1"/>
+            </a:fillRef>
+            <a:effectRef idx="0">
+              <a:schemeClr val="accent1"/>
+            </a:effectRef>
+            <a:fontRef idx="minor">
+              <a:schemeClr val="lt1"/>
+            </a:fontRef>
+          </p:style>
+          <p:txBody>
+            <a:bodyPr rtlCol="0" anchor="ctr"/>
+            <a:lstStyle/>
+            <a:p>
+              <a:pPr algn="ctr"/>
+              <a:r>
+                <a:rPr lang="en-US" sz="1400" i="1" dirty="0">
+                  <a:solidFill>
+                    <a:schemeClr val="tx1"/>
+                  </a:solidFill>
+                </a:rPr>
+                <a:t>Model 2</a:t>
+              </a:r>
+            </a:p>
+          </p:txBody>
+        </p:sp>
+        <p:sp>
+          <p:nvSpPr>
+            <p:cNvPr id="14" name="Rectangle: Rounded Corners 13">
+              <a:extLst>
+                <a:ext uri="{FF2B5EF4-FFF2-40B4-BE49-F238E27FC236}">
+                  <a16:creationId xmlns:a16="http://schemas.microsoft.com/office/drawing/2014/main" id="{30451BAB-C34E-4650-515B-63F461663ED0}"/>
+                </a:ext>
+              </a:extLst>
+            </p:cNvPr>
+            <p:cNvSpPr/>
+            <p:nvPr/>
+          </p:nvSpPr>
+          <p:spPr>
+            <a:xfrm>
+              <a:off x="7635507" y="3955654"/>
+              <a:ext cx="1071738" cy="322014"/>
+            </a:xfrm>
+            <a:prstGeom prst="roundRect">
+              <a:avLst/>
+            </a:prstGeom>
+            <a:solidFill>
+              <a:srgbClr val="B2D4EB"/>
+            </a:solidFill>
+            <a:ln>
+              <a:solidFill>
+                <a:schemeClr val="tx1"/>
+              </a:solidFill>
+            </a:ln>
+          </p:spPr>
+          <p:style>
+            <a:lnRef idx="2">
+              <a:schemeClr val="accent1">
+                <a:shade val="15000"/>
+              </a:schemeClr>
+            </a:lnRef>
+            <a:fillRef idx="1">
+              <a:schemeClr val="accent1"/>
+            </a:fillRef>
+            <a:effectRef idx="0">
+              <a:schemeClr val="accent1"/>
+            </a:effectRef>
+            <a:fontRef idx="minor">
+              <a:schemeClr val="lt1"/>
+            </a:fontRef>
+          </p:style>
+          <p:txBody>
+            <a:bodyPr rtlCol="0" anchor="ctr"/>
+            <a:lstStyle/>
+            <a:p>
+              <a:pPr algn="ctr"/>
+              <a:r>
+                <a:rPr lang="en-US" sz="1400" i="1" dirty="0">
+                  <a:solidFill>
+                    <a:schemeClr val="tx1"/>
+                  </a:solidFill>
+                </a:rPr>
+                <a:t>Model 3</a:t>
+              </a:r>
+            </a:p>
+          </p:txBody>
+        </p:sp>
+        <p:sp>
+          <p:nvSpPr>
+            <p:cNvPr id="15" name="Rectangle: Rounded Corners 14">
+              <a:extLst>
+                <a:ext uri="{FF2B5EF4-FFF2-40B4-BE49-F238E27FC236}">
+                  <a16:creationId xmlns:a16="http://schemas.microsoft.com/office/drawing/2014/main" id="{55626C3B-43F8-65F9-6D86-F7B15D95C526}"/>
+                </a:ext>
+              </a:extLst>
+            </p:cNvPr>
+            <p:cNvSpPr/>
+            <p:nvPr/>
+          </p:nvSpPr>
+          <p:spPr>
+            <a:xfrm>
+              <a:off x="4569151" y="3945117"/>
+              <a:ext cx="1071738" cy="322014"/>
+            </a:xfrm>
+            <a:prstGeom prst="roundRect">
+              <a:avLst/>
+            </a:prstGeom>
+            <a:solidFill>
+              <a:srgbClr val="B2D4EB"/>
+            </a:solidFill>
+            <a:ln>
+              <a:solidFill>
+                <a:schemeClr val="tx1"/>
+              </a:solidFill>
+            </a:ln>
+          </p:spPr>
+          <p:style>
+            <a:lnRef idx="2">
+              <a:schemeClr val="accent1">
+                <a:shade val="15000"/>
+              </a:schemeClr>
+            </a:lnRef>
+            <a:fillRef idx="1">
+              <a:schemeClr val="accent1"/>
+            </a:fillRef>
+            <a:effectRef idx="0">
+              <a:schemeClr val="accent1"/>
+            </a:effectRef>
+            <a:fontRef idx="minor">
+              <a:schemeClr val="lt1"/>
+            </a:fontRef>
+          </p:style>
+          <p:txBody>
+            <a:bodyPr rtlCol="0" anchor="ctr"/>
+            <a:lstStyle/>
+            <a:p>
+              <a:pPr algn="ctr"/>
+              <a:r>
+                <a:rPr lang="en-US" sz="1400" i="1" dirty="0">
+                  <a:solidFill>
+                    <a:schemeClr val="tx1"/>
+                  </a:solidFill>
+                </a:rPr>
+                <a:t>Model 1</a:t>
+              </a:r>
+            </a:p>
+          </p:txBody>
+        </p:sp>
+      </p:grpSp>
+      <p:sp>
+        <p:nvSpPr>
+          <p:cNvPr id="16" name="Rectangle: Rounded Corners 15">
+            <a:extLst>
+              <a:ext uri="{FF2B5EF4-FFF2-40B4-BE49-F238E27FC236}">
+                <a16:creationId xmlns:a16="http://schemas.microsoft.com/office/drawing/2014/main" id="{03CFB2EF-0BF7-6736-3257-3868777206B9}"/>
+              </a:ext>
+            </a:extLst>
+          </p:cNvPr>
+          <p:cNvSpPr/>
+          <p:nvPr/>
+        </p:nvSpPr>
+        <p:spPr>
+          <a:xfrm>
+            <a:off x="3785379" y="4465752"/>
+            <a:ext cx="2580925" cy="369332"/>
+          </a:xfrm>
+          <a:prstGeom prst="roundRect">
+            <a:avLst/>
+          </a:prstGeom>
+          <a:solidFill>
+            <a:srgbClr val="B2D4EB"/>
+          </a:solidFill>
+          <a:ln>
+            <a:solidFill>
+              <a:schemeClr val="tx1"/>
+            </a:solidFill>
+          </a:ln>
+        </p:spPr>
+        <p:style>
+          <a:lnRef idx="2">
+            <a:schemeClr val="accent1">
+              <a:shade val="15000"/>
+            </a:schemeClr>
+          </a:lnRef>
+          <a:fillRef idx="1">
+            <a:schemeClr val="accent1"/>
+          </a:fillRef>
+          <a:effectRef idx="0">
+            <a:schemeClr val="accent1"/>
+          </a:effectRef>
+          <a:fontRef idx="minor">
+            <a:schemeClr val="lt1"/>
+          </a:fontRef>
+        </p:style>
+        <p:txBody>
+          <a:bodyPr rtlCol="0" anchor="ctr"/>
+          <a:lstStyle/>
+          <a:p>
+            <a:pPr algn="ctr"/>
+            <a:r>
+              <a:rPr lang="en-US" dirty="0">
+                <a:solidFill>
+                  <a:schemeClr val="tx1"/>
+                </a:solidFill>
+              </a:rPr>
+              <a:t>Foundry Local</a:t>
+            </a:r>
+            <a:endParaRPr lang="en-US" i="1" dirty="0">
+              <a:solidFill>
+                <a:schemeClr val="tx1"/>
+              </a:solidFill>
+            </a:endParaRPr>
+          </a:p>
+        </p:txBody>
+      </p:sp>
+      <p:pic>
+        <p:nvPicPr>
+          <p:cNvPr id="18" name="Picture 17">
+            <a:extLst>
+              <a:ext uri="{FF2B5EF4-FFF2-40B4-BE49-F238E27FC236}">
+                <a16:creationId xmlns:a16="http://schemas.microsoft.com/office/drawing/2014/main" id="{740EC0C0-D10C-CDBC-F226-4707993BAD76}"/>
+              </a:ext>
+            </a:extLst>
+          </p:cNvPr>
+          <p:cNvPicPr>
+            <a:picLocks noChangeAspect="1"/>
+          </p:cNvPicPr>
+          <p:nvPr/>
+        </p:nvPicPr>
+        <p:blipFill>
+          <a:blip r:embed="rId2">
+            <a:extLst>
+              <a:ext uri="{28A0092B-C50C-407E-A947-70E740481C1C}">
+                <a14:useLocalDpi xmlns:a14="http://schemas.microsoft.com/office/drawing/2010/main" val="0"/>
+              </a:ext>
+            </a:extLst>
+          </a:blip>
+          <a:stretch>
+            <a:fillRect/>
+          </a:stretch>
+        </p:blipFill>
+        <p:spPr>
+          <a:xfrm>
+            <a:off x="3858140" y="4444678"/>
+            <a:ext cx="411480" cy="411480"/>
+          </a:xfrm>
+          <a:prstGeom prst="rect">
+            <a:avLst/>
+          </a:prstGeom>
+        </p:spPr>
+      </p:pic>
+      <p:pic>
+        <p:nvPicPr>
+          <p:cNvPr id="20" name="Picture 19">
+            <a:extLst>
+              <a:ext uri="{FF2B5EF4-FFF2-40B4-BE49-F238E27FC236}">
+                <a16:creationId xmlns:a16="http://schemas.microsoft.com/office/drawing/2014/main" id="{08B03222-4598-AD0F-7004-E5BF69B439B1}"/>
+              </a:ext>
+            </a:extLst>
+          </p:cNvPr>
+          <p:cNvPicPr>
+            <a:picLocks noChangeAspect="1"/>
+          </p:cNvPicPr>
+          <p:nvPr/>
+        </p:nvPicPr>
+        <p:blipFill>
+          <a:blip r:embed="rId3">
+            <a:extLst>
+              <a:ext uri="{28A0092B-C50C-407E-A947-70E740481C1C}">
+                <a14:useLocalDpi xmlns:a14="http://schemas.microsoft.com/office/drawing/2010/main" val="0"/>
+              </a:ext>
+            </a:extLst>
+          </a:blip>
+          <a:stretch>
+            <a:fillRect/>
+          </a:stretch>
+        </p:blipFill>
+        <p:spPr>
+          <a:xfrm>
+            <a:off x="8076254" y="2545437"/>
+            <a:ext cx="750647" cy="685800"/>
+          </a:xfrm>
+          <a:prstGeom prst="rect">
+            <a:avLst/>
+          </a:prstGeom>
+        </p:spPr>
+      </p:pic>
+      <p:sp>
+        <p:nvSpPr>
+          <p:cNvPr id="21" name="TextBox 20">
+            <a:extLst>
+              <a:ext uri="{FF2B5EF4-FFF2-40B4-BE49-F238E27FC236}">
+                <a16:creationId xmlns:a16="http://schemas.microsoft.com/office/drawing/2014/main" id="{61ACAD34-655D-6D96-E9CE-9A30055341BD}"/>
+              </a:ext>
+            </a:extLst>
+          </p:cNvPr>
+          <p:cNvSpPr txBox="1"/>
+          <p:nvPr/>
+        </p:nvSpPr>
+        <p:spPr>
+          <a:xfrm>
+            <a:off x="7613977" y="3183284"/>
+            <a:ext cx="1675202" cy="646331"/>
+          </a:xfrm>
+          <a:prstGeom prst="rect">
+            <a:avLst/>
+          </a:prstGeom>
+          <a:noFill/>
+        </p:spPr>
+        <p:txBody>
+          <a:bodyPr wrap="none" rtlCol="0">
+            <a:spAutoFit/>
+          </a:bodyPr>
+          <a:lstStyle/>
+          <a:p>
+            <a:pPr algn="ctr"/>
+            <a:r>
+              <a:rPr lang="en-US" dirty="0"/>
+              <a:t>Microsoft Foundry</a:t>
+            </a:r>
+          </a:p>
+          <a:p>
+            <a:pPr algn="ctr"/>
+            <a:r>
+              <a:rPr lang="en-US" dirty="0"/>
+              <a:t>Model Catalog</a:t>
+            </a:r>
+          </a:p>
+        </p:txBody>
+      </p:sp>
+      <p:sp>
+        <p:nvSpPr>
+          <p:cNvPr id="29" name="Rectangle: Rounded Corners 28">
+            <a:extLst>
+              <a:ext uri="{FF2B5EF4-FFF2-40B4-BE49-F238E27FC236}">
+                <a16:creationId xmlns:a16="http://schemas.microsoft.com/office/drawing/2014/main" id="{8D49B3AD-DB92-B552-129E-23875F3C5E8A}"/>
+              </a:ext>
+            </a:extLst>
+          </p:cNvPr>
+          <p:cNvSpPr/>
+          <p:nvPr/>
+        </p:nvSpPr>
+        <p:spPr>
+          <a:xfrm>
+            <a:off x="2584694" y="800167"/>
+            <a:ext cx="4982297" cy="941185"/>
+          </a:xfrm>
+          <a:prstGeom prst="roundRect">
+            <a:avLst>
+              <a:gd name="adj" fmla="val 5234"/>
+            </a:avLst>
+          </a:prstGeom>
+          <a:solidFill>
+            <a:schemeClr val="bg1"/>
+          </a:solidFill>
+          <a:ln>
+            <a:solidFill>
+              <a:schemeClr val="tx1"/>
+            </a:solidFill>
+          </a:ln>
+        </p:spPr>
+        <p:style>
+          <a:lnRef idx="2">
+            <a:schemeClr val="accent1">
+              <a:shade val="15000"/>
+            </a:schemeClr>
+          </a:lnRef>
+          <a:fillRef idx="1">
+            <a:schemeClr val="accent1"/>
+          </a:fillRef>
+          <a:effectRef idx="0">
+            <a:schemeClr val="accent1"/>
+          </a:effectRef>
+          <a:fontRef idx="minor">
+            <a:schemeClr val="lt1"/>
+          </a:fontRef>
+        </p:style>
+        <p:txBody>
+          <a:bodyPr rtlCol="0" anchor="ctr"/>
+          <a:lstStyle/>
+          <a:p>
+            <a:pPr algn="ctr"/>
+            <a:endParaRPr lang="en-US" dirty="0">
+              <a:solidFill>
+                <a:schemeClr val="tx1"/>
+              </a:solidFill>
+            </a:endParaRPr>
+          </a:p>
+        </p:txBody>
+      </p:sp>
+      <p:sp>
+        <p:nvSpPr>
+          <p:cNvPr id="30" name="Rectangle: Rounded Corners 29">
+            <a:extLst>
+              <a:ext uri="{FF2B5EF4-FFF2-40B4-BE49-F238E27FC236}">
+                <a16:creationId xmlns:a16="http://schemas.microsoft.com/office/drawing/2014/main" id="{FE1E4223-18B0-0270-B46F-77DE56377983}"/>
+              </a:ext>
+            </a:extLst>
+          </p:cNvPr>
+          <p:cNvSpPr/>
+          <p:nvPr/>
+        </p:nvSpPr>
+        <p:spPr>
+          <a:xfrm>
+            <a:off x="3785377" y="615501"/>
+            <a:ext cx="2580925" cy="369332"/>
+          </a:xfrm>
+          <a:prstGeom prst="roundRect">
+            <a:avLst/>
+          </a:prstGeom>
+          <a:solidFill>
+            <a:srgbClr val="B2D4EB"/>
+          </a:solidFill>
+          <a:ln>
+            <a:solidFill>
+              <a:schemeClr val="tx1"/>
+            </a:solidFill>
+          </a:ln>
+        </p:spPr>
+        <p:style>
+          <a:lnRef idx="2">
+            <a:schemeClr val="accent1">
+              <a:shade val="15000"/>
+            </a:schemeClr>
+          </a:lnRef>
+          <a:fillRef idx="1">
+            <a:schemeClr val="accent1"/>
+          </a:fillRef>
+          <a:effectRef idx="0">
+            <a:schemeClr val="accent1"/>
+          </a:effectRef>
+          <a:fontRef idx="minor">
+            <a:schemeClr val="lt1"/>
+          </a:fontRef>
+        </p:style>
+        <p:txBody>
+          <a:bodyPr rtlCol="0" anchor="ctr"/>
+          <a:lstStyle/>
+          <a:p>
+            <a:pPr algn="ctr"/>
+            <a:r>
+              <a:rPr lang="en-US" dirty="0">
+                <a:solidFill>
+                  <a:schemeClr val="tx1"/>
+                </a:solidFill>
+              </a:rPr>
+              <a:t>Developer Experience</a:t>
+            </a:r>
+            <a:endParaRPr lang="en-US" i="1" dirty="0">
+              <a:solidFill>
+                <a:schemeClr val="tx1"/>
+              </a:solidFill>
+            </a:endParaRPr>
+          </a:p>
+        </p:txBody>
+      </p:sp>
+      <p:sp>
+        <p:nvSpPr>
+          <p:cNvPr id="32" name="Rectangle: Rounded Corners 31">
+            <a:extLst>
+              <a:ext uri="{FF2B5EF4-FFF2-40B4-BE49-F238E27FC236}">
+                <a16:creationId xmlns:a16="http://schemas.microsoft.com/office/drawing/2014/main" id="{D047E8E3-E96F-F9CC-2C1A-9F31EC67F570}"/>
+              </a:ext>
+            </a:extLst>
+          </p:cNvPr>
+          <p:cNvSpPr/>
+          <p:nvPr/>
+        </p:nvSpPr>
+        <p:spPr>
+          <a:xfrm>
+            <a:off x="4403757" y="1064612"/>
+            <a:ext cx="1344168" cy="553989"/>
+          </a:xfrm>
+          <a:prstGeom prst="roundRect">
+            <a:avLst/>
+          </a:prstGeom>
+          <a:solidFill>
+            <a:srgbClr val="E5F1F8"/>
+          </a:solidFill>
+          <a:ln>
+            <a:solidFill>
+              <a:schemeClr val="tx1"/>
+            </a:solidFill>
+          </a:ln>
+        </p:spPr>
+        <p:style>
+          <a:lnRef idx="2">
+            <a:schemeClr val="accent1">
+              <a:shade val="15000"/>
+            </a:schemeClr>
+          </a:lnRef>
+          <a:fillRef idx="1">
+            <a:schemeClr val="accent1"/>
+          </a:fillRef>
+          <a:effectRef idx="0">
+            <a:schemeClr val="accent1"/>
+          </a:effectRef>
+          <a:fontRef idx="minor">
+            <a:schemeClr val="lt1"/>
+          </a:fontRef>
+        </p:style>
+        <p:txBody>
+          <a:bodyPr rtlCol="0" anchor="ctr"/>
+          <a:lstStyle/>
+          <a:p>
+            <a:pPr algn="ctr"/>
+            <a:r>
+              <a:rPr lang="en-US" dirty="0">
+                <a:solidFill>
+                  <a:schemeClr val="tx1"/>
+                </a:solidFill>
+              </a:rPr>
+              <a:t>SDKs</a:t>
+            </a:r>
+          </a:p>
+        </p:txBody>
+      </p:sp>
+      <p:sp>
+        <p:nvSpPr>
+          <p:cNvPr id="33" name="Rectangle: Rounded Corners 32">
+            <a:extLst>
+              <a:ext uri="{FF2B5EF4-FFF2-40B4-BE49-F238E27FC236}">
+                <a16:creationId xmlns:a16="http://schemas.microsoft.com/office/drawing/2014/main" id="{1549E190-6268-5A77-8C6B-DAEBDEFAD43C}"/>
+              </a:ext>
+            </a:extLst>
+          </p:cNvPr>
+          <p:cNvSpPr/>
+          <p:nvPr/>
+        </p:nvSpPr>
+        <p:spPr>
+          <a:xfrm>
+            <a:off x="5985374" y="1064611"/>
+            <a:ext cx="1344168" cy="553989"/>
+          </a:xfrm>
+          <a:prstGeom prst="roundRect">
+            <a:avLst/>
+          </a:prstGeom>
+          <a:solidFill>
+            <a:srgbClr val="E5F1F8"/>
+          </a:solidFill>
+          <a:ln>
+            <a:solidFill>
+              <a:schemeClr val="tx1"/>
+            </a:solidFill>
+          </a:ln>
+        </p:spPr>
+        <p:style>
+          <a:lnRef idx="2">
+            <a:schemeClr val="accent1">
+              <a:shade val="15000"/>
+            </a:schemeClr>
+          </a:lnRef>
+          <a:fillRef idx="1">
+            <a:schemeClr val="accent1"/>
+          </a:fillRef>
+          <a:effectRef idx="0">
+            <a:schemeClr val="accent1"/>
+          </a:effectRef>
+          <a:fontRef idx="minor">
+            <a:schemeClr val="lt1"/>
+          </a:fontRef>
+        </p:style>
+        <p:txBody>
+          <a:bodyPr rtlCol="0" anchor="ctr"/>
+          <a:lstStyle/>
+          <a:p>
+            <a:pPr algn="ctr"/>
+            <a:r>
+              <a:rPr lang="en-US" dirty="0">
+                <a:solidFill>
+                  <a:schemeClr val="tx1"/>
+                </a:solidFill>
+              </a:rPr>
+              <a:t>CLI</a:t>
+            </a:r>
+          </a:p>
+        </p:txBody>
+      </p:sp>
+      <p:sp>
+        <p:nvSpPr>
+          <p:cNvPr id="34" name="Rectangle: Rounded Corners 33">
+            <a:extLst>
+              <a:ext uri="{FF2B5EF4-FFF2-40B4-BE49-F238E27FC236}">
+                <a16:creationId xmlns:a16="http://schemas.microsoft.com/office/drawing/2014/main" id="{20DFE1C6-902A-9B22-61A5-FE9656C8C7D0}"/>
+              </a:ext>
+            </a:extLst>
+          </p:cNvPr>
+          <p:cNvSpPr/>
+          <p:nvPr/>
+        </p:nvSpPr>
+        <p:spPr>
+          <a:xfrm>
+            <a:off x="2822140" y="1062776"/>
+            <a:ext cx="1344168" cy="553989"/>
+          </a:xfrm>
+          <a:prstGeom prst="roundRect">
+            <a:avLst/>
+          </a:prstGeom>
+          <a:solidFill>
+            <a:srgbClr val="E5F1F8"/>
+          </a:solidFill>
+          <a:ln>
+            <a:solidFill>
+              <a:schemeClr val="tx1"/>
+            </a:solidFill>
+          </a:ln>
+        </p:spPr>
+        <p:style>
+          <a:lnRef idx="2">
+            <a:schemeClr val="accent1">
+              <a:shade val="15000"/>
+            </a:schemeClr>
+          </a:lnRef>
+          <a:fillRef idx="1">
+            <a:schemeClr val="accent1"/>
+          </a:fillRef>
+          <a:effectRef idx="0">
+            <a:schemeClr val="accent1"/>
+          </a:effectRef>
+          <a:fontRef idx="minor">
+            <a:schemeClr val="lt1"/>
+          </a:fontRef>
+        </p:style>
+        <p:txBody>
+          <a:bodyPr rtlCol="0" anchor="ctr"/>
+          <a:lstStyle/>
+          <a:p>
+            <a:pPr algn="ctr"/>
+            <a:r>
+              <a:rPr lang="en-US" dirty="0">
+                <a:solidFill>
+                  <a:schemeClr val="tx1"/>
+                </a:solidFill>
+              </a:rPr>
+              <a:t>REST Web Server</a:t>
+            </a:r>
+          </a:p>
+        </p:txBody>
+      </p:sp>
+      <p:cxnSp>
+        <p:nvCxnSpPr>
+          <p:cNvPr id="35" name="Straight Arrow Connector 34">
+            <a:extLst>
+              <a:ext uri="{FF2B5EF4-FFF2-40B4-BE49-F238E27FC236}">
+                <a16:creationId xmlns:a16="http://schemas.microsoft.com/office/drawing/2014/main" id="{C78B64DB-9DDF-AAC1-D30D-EC498B479ED1}"/>
+              </a:ext>
+            </a:extLst>
+          </p:cNvPr>
+          <p:cNvCxnSpPr>
+            <a:cxnSpLocks/>
+          </p:cNvCxnSpPr>
+          <p:nvPr/>
+        </p:nvCxnSpPr>
+        <p:spPr>
+          <a:xfrm flipV="1">
+            <a:off x="4282872" y="1741352"/>
+            <a:ext cx="0" cy="433446"/>
+          </a:xfrm>
+          <a:prstGeom prst="straightConnector1">
+            <a:avLst/>
+          </a:prstGeom>
+          <a:ln>
+            <a:solidFill>
+              <a:schemeClr val="tx1"/>
+            </a:solidFill>
+            <a:prstDash val="solid"/>
+            <a:headEnd type="triangle" w="lg" len="lg"/>
+            <a:tailEnd type="triangle" w="lg" len="lg"/>
+          </a:ln>
+        </p:spPr>
+        <p:style>
+          <a:lnRef idx="2">
+            <a:schemeClr val="accent1"/>
+          </a:lnRef>
+          <a:fillRef idx="0">
+            <a:schemeClr val="accent1"/>
+          </a:fillRef>
+          <a:effectRef idx="1">
+            <a:schemeClr val="accent1"/>
+          </a:effectRef>
+          <a:fontRef idx="minor">
+            <a:schemeClr val="tx1"/>
+          </a:fontRef>
+        </p:style>
+      </p:cxnSp>
+      <p:cxnSp>
+        <p:nvCxnSpPr>
+          <p:cNvPr id="39" name="Straight Arrow Connector 38">
+            <a:extLst>
+              <a:ext uri="{FF2B5EF4-FFF2-40B4-BE49-F238E27FC236}">
+                <a16:creationId xmlns:a16="http://schemas.microsoft.com/office/drawing/2014/main" id="{6DC56010-06B3-9647-A302-F7EA6C749369}"/>
+              </a:ext>
+            </a:extLst>
+          </p:cNvPr>
+          <p:cNvCxnSpPr>
+            <a:cxnSpLocks/>
+          </p:cNvCxnSpPr>
+          <p:nvPr/>
+        </p:nvCxnSpPr>
+        <p:spPr>
+          <a:xfrm flipV="1">
+            <a:off x="5853254" y="1741352"/>
+            <a:ext cx="0" cy="433446"/>
+          </a:xfrm>
+          <a:prstGeom prst="straightConnector1">
+            <a:avLst/>
+          </a:prstGeom>
+          <a:ln>
+            <a:solidFill>
+              <a:schemeClr val="tx1"/>
+            </a:solidFill>
+            <a:prstDash val="solid"/>
+            <a:headEnd type="triangle" w="lg" len="lg"/>
+            <a:tailEnd type="triangle" w="lg" len="lg"/>
+          </a:ln>
+        </p:spPr>
+        <p:style>
+          <a:lnRef idx="2">
+            <a:schemeClr val="accent1"/>
+          </a:lnRef>
+          <a:fillRef idx="0">
+            <a:schemeClr val="accent1"/>
+          </a:fillRef>
+          <a:effectRef idx="1">
+            <a:schemeClr val="accent1"/>
+          </a:effectRef>
+          <a:fontRef idx="minor">
+            <a:schemeClr val="tx1"/>
+          </a:fontRef>
+        </p:style>
+      </p:cxnSp>
+      <p:sp>
+        <p:nvSpPr>
+          <p:cNvPr id="40" name="TextBox 39">
+            <a:extLst>
+              <a:ext uri="{FF2B5EF4-FFF2-40B4-BE49-F238E27FC236}">
+                <a16:creationId xmlns:a16="http://schemas.microsoft.com/office/drawing/2014/main" id="{6B841E0E-9A0C-0AF0-73DC-3D01CB1B600C}"/>
+              </a:ext>
+            </a:extLst>
+          </p:cNvPr>
+          <p:cNvSpPr txBox="1"/>
+          <p:nvPr/>
+        </p:nvSpPr>
+        <p:spPr>
+          <a:xfrm>
+            <a:off x="5985374" y="1795687"/>
+            <a:ext cx="1015920" cy="307777"/>
+          </a:xfrm>
+          <a:prstGeom prst="rect">
+            <a:avLst/>
+          </a:prstGeom>
+          <a:noFill/>
+        </p:spPr>
+        <p:txBody>
+          <a:bodyPr wrap="none" rtlCol="0">
+            <a:spAutoFit/>
+          </a:bodyPr>
+          <a:lstStyle/>
+          <a:p>
+            <a:r>
+              <a:rPr lang="en-US" sz="1400" i="1" dirty="0"/>
+              <a:t>Named Pipes</a:t>
+            </a:r>
+          </a:p>
+        </p:txBody>
+      </p:sp>
+      <p:sp>
+        <p:nvSpPr>
+          <p:cNvPr id="41" name="TextBox 40">
+            <a:extLst>
+              <a:ext uri="{FF2B5EF4-FFF2-40B4-BE49-F238E27FC236}">
+                <a16:creationId xmlns:a16="http://schemas.microsoft.com/office/drawing/2014/main" id="{5B935555-E192-F7FA-B5DB-71FBC3D6CE7B}"/>
+              </a:ext>
+            </a:extLst>
+          </p:cNvPr>
+          <p:cNvSpPr txBox="1"/>
+          <p:nvPr/>
+        </p:nvSpPr>
+        <p:spPr>
+          <a:xfrm>
+            <a:off x="3328515" y="1801431"/>
+            <a:ext cx="837793" cy="307777"/>
+          </a:xfrm>
+          <a:prstGeom prst="rect">
+            <a:avLst/>
+          </a:prstGeom>
+          <a:noFill/>
+        </p:spPr>
+        <p:txBody>
+          <a:bodyPr wrap="none" rtlCol="0">
+            <a:spAutoFit/>
+          </a:bodyPr>
+          <a:lstStyle/>
+          <a:p>
+            <a:pPr algn="ctr"/>
+            <a:r>
+              <a:rPr lang="en-US" sz="1400" i="1" dirty="0"/>
+              <a:t>HTTP Calls</a:t>
+            </a:r>
+          </a:p>
+        </p:txBody>
+      </p:sp>
     </p:spTree>
     <p:extLst>
       <p:ext uri="{BB962C8B-B14F-4D97-AF65-F5344CB8AC3E}">
@@ -9562,6 +11743,2264 @@
           <a:chExt cx="0" cy="0"/>
         </a:xfrm>
       </p:grpSpPr>
+      <p:grpSp>
+        <p:nvGrpSpPr>
+          <p:cNvPr id="3" name="Group 2">
+            <a:extLst>
+              <a:ext uri="{FF2B5EF4-FFF2-40B4-BE49-F238E27FC236}">
+                <a16:creationId xmlns:a16="http://schemas.microsoft.com/office/drawing/2014/main" id="{1CA1E36B-6F8B-78EC-D1DA-00A7BA890F0C}"/>
+              </a:ext>
+            </a:extLst>
+          </p:cNvPr>
+          <p:cNvGrpSpPr/>
+          <p:nvPr/>
+        </p:nvGrpSpPr>
+        <p:grpSpPr>
+          <a:xfrm>
+            <a:off x="573747" y="1716157"/>
+            <a:ext cx="10253279" cy="3589047"/>
+            <a:chOff x="112514" y="1046426"/>
+            <a:chExt cx="8240279" cy="3542588"/>
+          </a:xfrm>
+        </p:grpSpPr>
+        <p:sp>
+          <p:nvSpPr>
+            <p:cNvPr id="4" name="Rectangle 3">
+              <a:extLst>
+                <a:ext uri="{FF2B5EF4-FFF2-40B4-BE49-F238E27FC236}">
+                  <a16:creationId xmlns:a16="http://schemas.microsoft.com/office/drawing/2014/main" id="{2E48D362-580F-42C1-3153-EC52D854BB7E}"/>
+                </a:ext>
+              </a:extLst>
+            </p:cNvPr>
+            <p:cNvSpPr/>
+            <p:nvPr/>
+          </p:nvSpPr>
+          <p:spPr>
+            <a:xfrm>
+              <a:off x="542776" y="1046427"/>
+              <a:ext cx="1525630" cy="273831"/>
+            </a:xfrm>
+            <a:prstGeom prst="rect">
+              <a:avLst/>
+            </a:prstGeom>
+            <a:solidFill>
+              <a:srgbClr val="B2D4EB"/>
+            </a:solidFill>
+          </p:spPr>
+          <p:style>
+            <a:lnRef idx="2">
+              <a:schemeClr val="dk1">
+                <a:shade val="15000"/>
+              </a:schemeClr>
+            </a:lnRef>
+            <a:fillRef idx="1">
+              <a:schemeClr val="dk1"/>
+            </a:fillRef>
+            <a:effectRef idx="0">
+              <a:schemeClr val="dk1"/>
+            </a:effectRef>
+            <a:fontRef idx="minor">
+              <a:schemeClr val="lt1"/>
+            </a:fontRef>
+          </p:style>
+          <p:txBody>
+            <a:bodyPr rtlCol="0" anchor="ctr"/>
+            <a:lstStyle/>
+            <a:p>
+              <a:pPr algn="ctr"/>
+              <a:r>
+                <a:rPr lang="en-US" dirty="0">
+                  <a:solidFill>
+                    <a:schemeClr val="tx1"/>
+                  </a:solidFill>
+                </a:rPr>
+                <a:t>Model Weight</a:t>
+              </a:r>
+            </a:p>
+          </p:txBody>
+        </p:sp>
+        <mc:AlternateContent xmlns:mc="http://schemas.openxmlformats.org/markup-compatibility/2006">
+          <mc:Choice xmlns:a14="http://schemas.microsoft.com/office/drawing/2010/main" Requires="a14">
+            <p:sp>
+              <p:nvSpPr>
+                <p:cNvPr id="5" name="Rectangle 4">
+                  <a:extLst>
+                    <a:ext uri="{FF2B5EF4-FFF2-40B4-BE49-F238E27FC236}">
+                      <a16:creationId xmlns:a16="http://schemas.microsoft.com/office/drawing/2014/main" id="{6BE5B6E0-B039-FB4B-FEBD-88B3EACEBF59}"/>
+                    </a:ext>
+                  </a:extLst>
+                </p:cNvPr>
+                <p:cNvSpPr/>
+                <p:nvPr/>
+              </p:nvSpPr>
+              <p:spPr>
+                <a:xfrm>
+                  <a:off x="542776" y="1320258"/>
+                  <a:ext cx="1525630" cy="289315"/>
+                </a:xfrm>
+                <a:prstGeom prst="rect">
+                  <a:avLst/>
+                </a:prstGeom>
+                <a:solidFill>
+                  <a:schemeClr val="bg1"/>
+                </a:solidFill>
+              </p:spPr>
+              <p:style>
+                <a:lnRef idx="2">
+                  <a:schemeClr val="accent5">
+                    <a:shade val="15000"/>
+                  </a:schemeClr>
+                </a:lnRef>
+                <a:fillRef idx="1">
+                  <a:schemeClr val="accent5"/>
+                </a:fillRef>
+                <a:effectRef idx="0">
+                  <a:schemeClr val="accent5"/>
+                </a:effectRef>
+                <a:fontRef idx="minor">
+                  <a:schemeClr val="lt1"/>
+                </a:fontRef>
+              </p:style>
+              <p:txBody>
+                <a:bodyPr rtlCol="0" anchor="ctr"/>
+                <a:lstStyle/>
+                <a:p>
+                  <a:pPr algn="ctr"/>
+                  <a14:m>
+                    <m:oMathPara xmlns:m="http://schemas.openxmlformats.org/officeDocument/2006/math">
+                      <m:oMathParaPr>
+                        <m:jc m:val="centerGroup"/>
+                      </m:oMathParaPr>
+                      <m:oMath xmlns:m="http://schemas.openxmlformats.org/officeDocument/2006/math">
+                        <m:r>
+                          <a:rPr lang="en-US" b="0" i="1" smtClean="0">
+                            <a:solidFill>
+                              <a:sysClr val="windowText" lastClr="000000"/>
+                            </a:solidFill>
+                            <a:latin typeface="Cambria Math" panose="02040503050406030204" pitchFamily="18" charset="0"/>
+                          </a:rPr>
+                          <m:t>𝑤</m:t>
+                        </m:r>
+                        <m:r>
+                          <a:rPr lang="en-US" b="0" i="1" smtClean="0">
+                            <a:solidFill>
+                              <a:sysClr val="windowText" lastClr="000000"/>
+                            </a:solidFill>
+                            <a:latin typeface="Cambria Math" panose="02040503050406030204" pitchFamily="18" charset="0"/>
+                          </a:rPr>
+                          <m:t>=0.37</m:t>
+                        </m:r>
+                      </m:oMath>
+                    </m:oMathPara>
+                  </a14:m>
+                  <a:endParaRPr lang="en-US" dirty="0">
+                    <a:solidFill>
+                      <a:sysClr val="windowText" lastClr="000000"/>
+                    </a:solidFill>
+                  </a:endParaRPr>
+                </a:p>
+              </p:txBody>
+            </p:sp>
+          </mc:Choice>
+          <mc:Fallback>
+            <p:sp>
+              <p:nvSpPr>
+                <p:cNvPr id="5" name="Rectangle 4">
+                  <a:extLst>
+                    <a:ext uri="{FF2B5EF4-FFF2-40B4-BE49-F238E27FC236}">
+                      <a16:creationId xmlns:a16="http://schemas.microsoft.com/office/drawing/2014/main" id="{6BE5B6E0-B039-FB4B-FEBD-88B3EACEBF59}"/>
+                    </a:ext>
+                  </a:extLst>
+                </p:cNvPr>
+                <p:cNvSpPr>
+                  <a:spLocks noRot="1" noChangeAspect="1" noMove="1" noResize="1" noEditPoints="1" noAdjustHandles="1" noChangeArrowheads="1" noChangeShapeType="1" noTextEdit="1"/>
+                </p:cNvSpPr>
+                <p:nvPr/>
+              </p:nvSpPr>
+              <p:spPr>
+                <a:xfrm>
+                  <a:off x="542776" y="1320258"/>
+                  <a:ext cx="1525630" cy="289315"/>
+                </a:xfrm>
+                <a:prstGeom prst="rect">
+                  <a:avLst/>
+                </a:prstGeom>
+                <a:blipFill>
+                  <a:blip r:embed="rId2"/>
+                  <a:stretch>
+                    <a:fillRect b="-3922"/>
+                  </a:stretch>
+                </a:blipFill>
+              </p:spPr>
+              <p:txBody>
+                <a:bodyPr/>
+                <a:lstStyle/>
+                <a:p>
+                  <a:r>
+                    <a:rPr lang="en-US">
+                      <a:noFill/>
+                    </a:rPr>
+                    <a:t> </a:t>
+                  </a:r>
+                </a:p>
+              </p:txBody>
+            </p:sp>
+          </mc:Fallback>
+        </mc:AlternateContent>
+        <p:sp>
+          <p:nvSpPr>
+            <p:cNvPr id="6" name="TextBox 5">
+              <a:extLst>
+                <a:ext uri="{FF2B5EF4-FFF2-40B4-BE49-F238E27FC236}">
+                  <a16:creationId xmlns:a16="http://schemas.microsoft.com/office/drawing/2014/main" id="{51D7E328-0589-1816-BDBA-AD0FE42F5688}"/>
+                </a:ext>
+              </a:extLst>
+            </p:cNvPr>
+            <p:cNvSpPr txBox="1"/>
+            <p:nvPr/>
+          </p:nvSpPr>
+          <p:spPr>
+            <a:xfrm>
+              <a:off x="549126" y="1639593"/>
+              <a:ext cx="1525630" cy="430887"/>
+            </a:xfrm>
+            <a:prstGeom prst="rect">
+              <a:avLst/>
+            </a:prstGeom>
+            <a:noFill/>
+          </p:spPr>
+          <p:txBody>
+            <a:bodyPr wrap="square" rtlCol="0">
+              <a:spAutoFit/>
+            </a:bodyPr>
+            <a:lstStyle/>
+            <a:p>
+              <a:pPr algn="ctr"/>
+              <a:r>
+                <a:rPr lang="en-US" sz="1100" dirty="0"/>
+                <a:t>Stored as a 32-bit number (FP32)*</a:t>
+              </a:r>
+            </a:p>
+          </p:txBody>
+        </p:sp>
+        <p:sp>
+          <p:nvSpPr>
+            <p:cNvPr id="7" name="Rectangle 6">
+              <a:extLst>
+                <a:ext uri="{FF2B5EF4-FFF2-40B4-BE49-F238E27FC236}">
+                  <a16:creationId xmlns:a16="http://schemas.microsoft.com/office/drawing/2014/main" id="{D0E40183-A35F-5E76-740F-108817A55AEF}"/>
+                </a:ext>
+              </a:extLst>
+            </p:cNvPr>
+            <p:cNvSpPr/>
+            <p:nvPr/>
+          </p:nvSpPr>
+          <p:spPr>
+            <a:xfrm>
+              <a:off x="278148" y="2328864"/>
+              <a:ext cx="2067587" cy="273831"/>
+            </a:xfrm>
+            <a:prstGeom prst="rect">
+              <a:avLst/>
+            </a:prstGeom>
+            <a:solidFill>
+              <a:srgbClr val="B2D4EB"/>
+            </a:solidFill>
+          </p:spPr>
+          <p:style>
+            <a:lnRef idx="2">
+              <a:schemeClr val="dk1">
+                <a:shade val="15000"/>
+              </a:schemeClr>
+            </a:lnRef>
+            <a:fillRef idx="1">
+              <a:schemeClr val="dk1"/>
+            </a:fillRef>
+            <a:effectRef idx="0">
+              <a:schemeClr val="dk1"/>
+            </a:effectRef>
+            <a:fontRef idx="minor">
+              <a:schemeClr val="lt1"/>
+            </a:fontRef>
+          </p:style>
+          <p:txBody>
+            <a:bodyPr rtlCol="0" anchor="ctr"/>
+            <a:lstStyle/>
+            <a:p>
+              <a:pPr algn="ctr"/>
+              <a:r>
+                <a:rPr lang="en-US" dirty="0">
+                  <a:solidFill>
+                    <a:schemeClr val="tx1"/>
+                  </a:solidFill>
+                </a:rPr>
+                <a:t>4-bit Quantization</a:t>
+              </a:r>
+            </a:p>
+          </p:txBody>
+        </p:sp>
+        <mc:AlternateContent xmlns:mc="http://schemas.openxmlformats.org/markup-compatibility/2006">
+          <mc:Choice xmlns:a14="http://schemas.microsoft.com/office/drawing/2010/main" Requires="a14">
+            <p:sp>
+              <p:nvSpPr>
+                <p:cNvPr id="8" name="Rectangle 7">
+                  <a:extLst>
+                    <a:ext uri="{FF2B5EF4-FFF2-40B4-BE49-F238E27FC236}">
+                      <a16:creationId xmlns:a16="http://schemas.microsoft.com/office/drawing/2014/main" id="{27C0CFB8-487E-1AB4-9407-F3EA9F0EF059}"/>
+                    </a:ext>
+                  </a:extLst>
+                </p:cNvPr>
+                <p:cNvSpPr/>
+                <p:nvPr/>
+              </p:nvSpPr>
+              <p:spPr>
+                <a:xfrm>
+                  <a:off x="278149" y="2602695"/>
+                  <a:ext cx="2067586" cy="577001"/>
+                </a:xfrm>
+                <a:prstGeom prst="rect">
+                  <a:avLst/>
+                </a:prstGeom>
+                <a:solidFill>
+                  <a:schemeClr val="bg1"/>
+                </a:solidFill>
+              </p:spPr>
+              <p:style>
+                <a:lnRef idx="2">
+                  <a:schemeClr val="accent5">
+                    <a:shade val="15000"/>
+                  </a:schemeClr>
+                </a:lnRef>
+                <a:fillRef idx="1">
+                  <a:schemeClr val="accent5"/>
+                </a:fillRef>
+                <a:effectRef idx="0">
+                  <a:schemeClr val="accent5"/>
+                </a:effectRef>
+                <a:fontRef idx="minor">
+                  <a:schemeClr val="lt1"/>
+                </a:fontRef>
+              </p:style>
+              <p:txBody>
+                <a:bodyPr rtlCol="0" anchor="ctr"/>
+                <a:lstStyle/>
+                <a:p>
+                  <a:pPr algn="ctr"/>
+                  <a14:m>
+                    <m:oMathPara xmlns:m="http://schemas.openxmlformats.org/officeDocument/2006/math">
+                      <m:oMathParaPr>
+                        <m:jc m:val="centerGroup"/>
+                      </m:oMathParaPr>
+                      <m:oMath xmlns:m="http://schemas.openxmlformats.org/officeDocument/2006/math">
+                        <m:r>
+                          <a:rPr lang="en-US" b="0" i="1" smtClean="0">
+                            <a:solidFill>
+                              <a:sysClr val="windowText" lastClr="000000"/>
+                            </a:solidFill>
+                            <a:latin typeface="Cambria Math" panose="02040503050406030204" pitchFamily="18" charset="0"/>
+                          </a:rPr>
+                          <m:t>𝑄</m:t>
+                        </m:r>
+                        <m:d>
+                          <m:dPr>
+                            <m:ctrlPr>
+                              <a:rPr lang="en-US" b="0" i="1" smtClean="0">
+                                <a:solidFill>
+                                  <a:sysClr val="windowText" lastClr="000000"/>
+                                </a:solidFill>
+                                <a:latin typeface="Cambria Math" panose="02040503050406030204" pitchFamily="18" charset="0"/>
+                              </a:rPr>
+                            </m:ctrlPr>
+                          </m:dPr>
+                          <m:e>
+                            <m:r>
+                              <a:rPr lang="en-US" b="0" i="1" smtClean="0">
+                                <a:solidFill>
+                                  <a:sysClr val="windowText" lastClr="000000"/>
+                                </a:solidFill>
+                                <a:latin typeface="Cambria Math" panose="02040503050406030204" pitchFamily="18" charset="0"/>
+                              </a:rPr>
+                              <m:t>𝑤</m:t>
+                            </m:r>
+                          </m:e>
+                        </m:d>
+                        <m:r>
+                          <a:rPr lang="en-US" b="0" i="1" smtClean="0">
+                            <a:solidFill>
+                              <a:sysClr val="windowText" lastClr="000000"/>
+                            </a:solidFill>
+                            <a:latin typeface="Cambria Math" panose="02040503050406030204" pitchFamily="18" charset="0"/>
+                          </a:rPr>
+                          <m:t>=</m:t>
+                        </m:r>
+                        <m:r>
+                          <m:rPr>
+                            <m:nor/>
+                          </m:rPr>
+                          <a:rPr lang="en-US" b="0" i="0" smtClean="0">
+                            <a:solidFill>
+                              <a:sysClr val="windowText" lastClr="000000"/>
+                            </a:solidFill>
+                            <a:latin typeface="Cambria Math" panose="02040503050406030204" pitchFamily="18" charset="0"/>
+                          </a:rPr>
+                          <m:t>round</m:t>
+                        </m:r>
+                        <m:d>
+                          <m:dPr>
+                            <m:ctrlPr>
+                              <a:rPr lang="en-US" b="0" i="1" smtClean="0">
+                                <a:solidFill>
+                                  <a:sysClr val="windowText" lastClr="000000"/>
+                                </a:solidFill>
+                                <a:latin typeface="Cambria Math" panose="02040503050406030204" pitchFamily="18" charset="0"/>
+                              </a:rPr>
+                            </m:ctrlPr>
+                          </m:dPr>
+                          <m:e>
+                            <m:f>
+                              <m:fPr>
+                                <m:ctrlPr>
+                                  <a:rPr lang="en-US" b="0" i="1" smtClean="0">
+                                    <a:solidFill>
+                                      <a:sysClr val="windowText" lastClr="000000"/>
+                                    </a:solidFill>
+                                    <a:latin typeface="Cambria Math" panose="02040503050406030204" pitchFamily="18" charset="0"/>
+                                  </a:rPr>
+                                </m:ctrlPr>
+                              </m:fPr>
+                              <m:num>
+                                <m:r>
+                                  <a:rPr lang="en-US" b="0" i="1" smtClean="0">
+                                    <a:solidFill>
+                                      <a:sysClr val="windowText" lastClr="000000"/>
+                                    </a:solidFill>
+                                    <a:latin typeface="Cambria Math" panose="02040503050406030204" pitchFamily="18" charset="0"/>
+                                  </a:rPr>
+                                  <m:t>𝑤</m:t>
+                                </m:r>
+                              </m:num>
+                              <m:den>
+                                <m:r>
+                                  <a:rPr lang="en-US" b="0" i="1" smtClean="0">
+                                    <a:solidFill>
+                                      <a:sysClr val="windowText" lastClr="000000"/>
+                                    </a:solidFill>
+                                    <a:latin typeface="Cambria Math" panose="02040503050406030204" pitchFamily="18" charset="0"/>
+                                  </a:rPr>
+                                  <m:t>𝑆</m:t>
+                                </m:r>
+                              </m:den>
+                            </m:f>
+                          </m:e>
+                        </m:d>
+                      </m:oMath>
+                    </m:oMathPara>
+                  </a14:m>
+                  <a:endParaRPr lang="en-US" dirty="0">
+                    <a:solidFill>
+                      <a:sysClr val="windowText" lastClr="000000"/>
+                    </a:solidFill>
+                  </a:endParaRPr>
+                </a:p>
+              </p:txBody>
+            </p:sp>
+          </mc:Choice>
+          <mc:Fallback>
+            <p:sp>
+              <p:nvSpPr>
+                <p:cNvPr id="8" name="Rectangle 7">
+                  <a:extLst>
+                    <a:ext uri="{FF2B5EF4-FFF2-40B4-BE49-F238E27FC236}">
+                      <a16:creationId xmlns:a16="http://schemas.microsoft.com/office/drawing/2014/main" id="{27C0CFB8-487E-1AB4-9407-F3EA9F0EF059}"/>
+                    </a:ext>
+                  </a:extLst>
+                </p:cNvPr>
+                <p:cNvSpPr>
+                  <a:spLocks noRot="1" noChangeAspect="1" noMove="1" noResize="1" noEditPoints="1" noAdjustHandles="1" noChangeArrowheads="1" noChangeShapeType="1" noTextEdit="1"/>
+                </p:cNvSpPr>
+                <p:nvPr/>
+              </p:nvSpPr>
+              <p:spPr>
+                <a:xfrm>
+                  <a:off x="278149" y="2602695"/>
+                  <a:ext cx="2067586" cy="577001"/>
+                </a:xfrm>
+                <a:prstGeom prst="rect">
+                  <a:avLst/>
+                </a:prstGeom>
+                <a:blipFill>
+                  <a:blip r:embed="rId3"/>
+                  <a:stretch>
+                    <a:fillRect/>
+                  </a:stretch>
+                </a:blipFill>
+              </p:spPr>
+              <p:txBody>
+                <a:bodyPr/>
+                <a:lstStyle/>
+                <a:p>
+                  <a:r>
+                    <a:rPr lang="en-US">
+                      <a:noFill/>
+                    </a:rPr>
+                    <a:t> </a:t>
+                  </a:r>
+                </a:p>
+              </p:txBody>
+            </p:sp>
+          </mc:Fallback>
+        </mc:AlternateContent>
+        <mc:AlternateContent xmlns:mc="http://schemas.openxmlformats.org/markup-compatibility/2006">
+          <mc:Choice xmlns:a14="http://schemas.microsoft.com/office/drawing/2010/main" Requires="a14">
+            <p:sp>
+              <p:nvSpPr>
+                <p:cNvPr id="9" name="TextBox 8">
+                  <a:extLst>
+                    <a:ext uri="{FF2B5EF4-FFF2-40B4-BE49-F238E27FC236}">
+                      <a16:creationId xmlns:a16="http://schemas.microsoft.com/office/drawing/2014/main" id="{CEA2197A-6B30-EDA9-B710-11ED19E1A2EA}"/>
+                    </a:ext>
+                  </a:extLst>
+                </p:cNvPr>
+                <p:cNvSpPr txBox="1"/>
+                <p:nvPr/>
+              </p:nvSpPr>
+              <p:spPr>
+                <a:xfrm>
+                  <a:off x="112514" y="3180683"/>
+                  <a:ext cx="2398855" cy="1260739"/>
+                </a:xfrm>
+                <a:prstGeom prst="rect">
+                  <a:avLst/>
+                </a:prstGeom>
+                <a:noFill/>
+              </p:spPr>
+              <p:txBody>
+                <a:bodyPr wrap="square" rtlCol="0">
+                  <a:spAutoFit/>
+                </a:bodyPr>
+                <a:lstStyle/>
+                <a:p>
+                  <a:pPr algn="ctr"/>
+                  <a:r>
+                    <a:rPr lang="en-US" sz="1100" dirty="0"/>
+                    <a:t>A 4-bit quantized value can represent 2</a:t>
+                  </a:r>
+                  <a:r>
+                    <a:rPr lang="en-US" sz="1100" baseline="30000" dirty="0"/>
+                    <a:t>4</a:t>
+                  </a:r>
+                  <a:r>
+                    <a:rPr lang="en-US" sz="1100" dirty="0"/>
+                    <a:t>=16 discrete levels.</a:t>
+                  </a:r>
+                </a:p>
+                <a:p>
+                  <a:r>
+                    <a:rPr lang="en-US" sz="1100" dirty="0"/>
+                    <a:t>Where:</a:t>
+                  </a:r>
+                </a:p>
+                <a:p>
+                  <a:pPr marL="171450" indent="-171450">
+                    <a:buFont typeface="Arial" panose="020B0604020202020204" pitchFamily="34" charset="0"/>
+                    <a:buChar char="•"/>
+                  </a:pPr>
+                  <a14:m>
+                    <m:oMath xmlns:m="http://schemas.openxmlformats.org/officeDocument/2006/math">
+                      <m:r>
+                        <a:rPr lang="en-US" sz="1100" i="1" dirty="0" smtClean="0">
+                          <a:latin typeface="Cambria Math" panose="02040503050406030204" pitchFamily="18" charset="0"/>
+                        </a:rPr>
+                        <m:t>𝑆</m:t>
+                      </m:r>
+                    </m:oMath>
+                  </a14:m>
+                  <a:r>
+                    <a:rPr lang="en-US" sz="1100" dirty="0"/>
+                    <a:t> is the scale factor (how much one quantization level represents)</a:t>
+                  </a:r>
+                </a:p>
+                <a:p>
+                  <a:pPr marL="171450" indent="-171450">
+                    <a:buFont typeface="Arial" panose="020B0604020202020204" pitchFamily="34" charset="0"/>
+                    <a:buChar char="•"/>
+                  </a:pPr>
+                  <a14:m>
+                    <m:oMath xmlns:m="http://schemas.openxmlformats.org/officeDocument/2006/math">
+                      <m:r>
+                        <a:rPr lang="en-US" sz="1100" i="1" dirty="0" smtClean="0">
+                          <a:latin typeface="Cambria Math" panose="02040503050406030204" pitchFamily="18" charset="0"/>
+                        </a:rPr>
+                        <m:t>𝑄</m:t>
+                      </m:r>
+                      <m:r>
+                        <a:rPr lang="en-US" sz="1100" i="1" dirty="0" smtClean="0">
+                          <a:latin typeface="Cambria Math" panose="02040503050406030204" pitchFamily="18" charset="0"/>
+                        </a:rPr>
+                        <m:t>(</m:t>
+                      </m:r>
+                      <m:r>
+                        <a:rPr lang="en-US" sz="1100" i="1" dirty="0" smtClean="0">
+                          <a:latin typeface="Cambria Math" panose="02040503050406030204" pitchFamily="18" charset="0"/>
+                        </a:rPr>
+                        <m:t>𝑤</m:t>
+                      </m:r>
+                      <m:r>
+                        <a:rPr lang="en-US" sz="1100" i="1" dirty="0" smtClean="0">
+                          <a:latin typeface="Cambria Math" panose="02040503050406030204" pitchFamily="18" charset="0"/>
+                        </a:rPr>
+                        <m:t>) </m:t>
+                      </m:r>
+                    </m:oMath>
+                  </a14:m>
+                  <a:r>
+                    <a:rPr lang="en-US" sz="1100" dirty="0"/>
+                    <a:t>is an integer between [-8,+7] (16 levels total).</a:t>
+                  </a:r>
+                </a:p>
+                <a:p>
+                  <a:pPr marL="171450" indent="-171450">
+                    <a:buFont typeface="Arial" panose="020B0604020202020204" pitchFamily="34" charset="0"/>
+                    <a:buChar char="•"/>
+                  </a:pPr>
+                  <a14:m>
+                    <m:oMath xmlns:m="http://schemas.openxmlformats.org/officeDocument/2006/math">
+                      <m:r>
+                        <a:rPr lang="en-US" sz="1100" i="1" dirty="0" smtClean="0">
+                          <a:latin typeface="Cambria Math" panose="02040503050406030204" pitchFamily="18" charset="0"/>
+                        </a:rPr>
+                        <m:t>𝑄</m:t>
+                      </m:r>
+                      <m:r>
+                        <a:rPr lang="en-US" sz="1100" i="1" dirty="0" smtClean="0">
+                          <a:latin typeface="Cambria Math" panose="02040503050406030204" pitchFamily="18" charset="0"/>
+                        </a:rPr>
+                        <m:t>(</m:t>
+                      </m:r>
+                      <m:r>
+                        <a:rPr lang="en-US" sz="1100" i="1" dirty="0" smtClean="0">
+                          <a:latin typeface="Cambria Math" panose="02040503050406030204" pitchFamily="18" charset="0"/>
+                        </a:rPr>
+                        <m:t>𝑤</m:t>
+                      </m:r>
+                      <m:r>
+                        <a:rPr lang="en-US" sz="1100" i="1" dirty="0" smtClean="0">
+                          <a:latin typeface="Cambria Math" panose="02040503050406030204" pitchFamily="18" charset="0"/>
+                        </a:rPr>
+                        <m:t>)∈{−8,−7,−6,…,6,7}</m:t>
+                      </m:r>
+                    </m:oMath>
+                  </a14:m>
+                  <a:endParaRPr lang="en-US" sz="1100" dirty="0"/>
+                </a:p>
+              </p:txBody>
+            </p:sp>
+          </mc:Choice>
+          <mc:Fallback>
+            <p:sp>
+              <p:nvSpPr>
+                <p:cNvPr id="9" name="TextBox 8">
+                  <a:extLst>
+                    <a:ext uri="{FF2B5EF4-FFF2-40B4-BE49-F238E27FC236}">
+                      <a16:creationId xmlns:a16="http://schemas.microsoft.com/office/drawing/2014/main" id="{CEA2197A-6B30-EDA9-B710-11ED19E1A2EA}"/>
+                    </a:ext>
+                  </a:extLst>
+                </p:cNvPr>
+                <p:cNvSpPr txBox="1">
+                  <a:spLocks noRot="1" noChangeAspect="1" noMove="1" noResize="1" noEditPoints="1" noAdjustHandles="1" noChangeArrowheads="1" noChangeShapeType="1" noTextEdit="1"/>
+                </p:cNvSpPr>
+                <p:nvPr/>
+              </p:nvSpPr>
+              <p:spPr>
+                <a:xfrm>
+                  <a:off x="112514" y="3180683"/>
+                  <a:ext cx="2398855" cy="1260739"/>
+                </a:xfrm>
+                <a:prstGeom prst="rect">
+                  <a:avLst/>
+                </a:prstGeom>
+                <a:blipFill>
+                  <a:blip r:embed="rId4"/>
+                  <a:stretch>
+                    <a:fillRect b="-1429"/>
+                  </a:stretch>
+                </a:blipFill>
+              </p:spPr>
+              <p:txBody>
+                <a:bodyPr/>
+                <a:lstStyle/>
+                <a:p>
+                  <a:r>
+                    <a:rPr lang="en-US">
+                      <a:noFill/>
+                    </a:rPr>
+                    <a:t> </a:t>
+                  </a:r>
+                </a:p>
+              </p:txBody>
+            </p:sp>
+          </mc:Fallback>
+        </mc:AlternateContent>
+        <p:sp>
+          <p:nvSpPr>
+            <p:cNvPr id="10" name="Rectangle 9">
+              <a:extLst>
+                <a:ext uri="{FF2B5EF4-FFF2-40B4-BE49-F238E27FC236}">
+                  <a16:creationId xmlns:a16="http://schemas.microsoft.com/office/drawing/2014/main" id="{F8000436-35AE-15BA-7C56-0E053A1C98DD}"/>
+                </a:ext>
+              </a:extLst>
+            </p:cNvPr>
+            <p:cNvSpPr/>
+            <p:nvPr/>
+          </p:nvSpPr>
+          <p:spPr>
+            <a:xfrm>
+              <a:off x="2886939" y="1046426"/>
+              <a:ext cx="2757871" cy="273831"/>
+            </a:xfrm>
+            <a:prstGeom prst="rect">
+              <a:avLst/>
+            </a:prstGeom>
+            <a:solidFill>
+              <a:srgbClr val="B2D4EB"/>
+            </a:solidFill>
+          </p:spPr>
+          <p:style>
+            <a:lnRef idx="2">
+              <a:schemeClr val="dk1">
+                <a:shade val="15000"/>
+              </a:schemeClr>
+            </a:lnRef>
+            <a:fillRef idx="1">
+              <a:schemeClr val="dk1"/>
+            </a:fillRef>
+            <a:effectRef idx="0">
+              <a:schemeClr val="dk1"/>
+            </a:effectRef>
+            <a:fontRef idx="minor">
+              <a:schemeClr val="lt1"/>
+            </a:fontRef>
+          </p:style>
+          <p:txBody>
+            <a:bodyPr rtlCol="0" anchor="ctr"/>
+            <a:lstStyle/>
+            <a:p>
+              <a:pPr algn="ctr"/>
+              <a:r>
+                <a:rPr lang="en-US" dirty="0">
+                  <a:solidFill>
+                    <a:schemeClr val="tx1"/>
+                  </a:solidFill>
+                </a:rPr>
+                <a:t>Map the Scale</a:t>
+              </a:r>
+            </a:p>
+          </p:txBody>
+        </p:sp>
+        <mc:AlternateContent xmlns:mc="http://schemas.openxmlformats.org/markup-compatibility/2006">
+          <mc:Choice xmlns:a14="http://schemas.microsoft.com/office/drawing/2010/main" Requires="a14">
+            <p:sp>
+              <p:nvSpPr>
+                <p:cNvPr id="11" name="Rectangle 10">
+                  <a:extLst>
+                    <a:ext uri="{FF2B5EF4-FFF2-40B4-BE49-F238E27FC236}">
+                      <a16:creationId xmlns:a16="http://schemas.microsoft.com/office/drawing/2014/main" id="{46CEBABB-5713-12A3-0F3D-6E24FAB414B1}"/>
+                    </a:ext>
+                  </a:extLst>
+                </p:cNvPr>
+                <p:cNvSpPr/>
+                <p:nvPr/>
+              </p:nvSpPr>
+              <p:spPr>
+                <a:xfrm>
+                  <a:off x="2886939" y="1315484"/>
+                  <a:ext cx="2757871" cy="577001"/>
+                </a:xfrm>
+                <a:prstGeom prst="rect">
+                  <a:avLst/>
+                </a:prstGeom>
+                <a:solidFill>
+                  <a:schemeClr val="bg1"/>
+                </a:solidFill>
+              </p:spPr>
+              <p:style>
+                <a:lnRef idx="2">
+                  <a:schemeClr val="accent5">
+                    <a:shade val="15000"/>
+                  </a:schemeClr>
+                </a:lnRef>
+                <a:fillRef idx="1">
+                  <a:schemeClr val="accent5"/>
+                </a:fillRef>
+                <a:effectRef idx="0">
+                  <a:schemeClr val="accent5"/>
+                </a:effectRef>
+                <a:fontRef idx="minor">
+                  <a:schemeClr val="lt1"/>
+                </a:fontRef>
+              </p:style>
+              <p:txBody>
+                <a:bodyPr rtlCol="0" anchor="ctr"/>
+                <a:lstStyle/>
+                <a:p>
+                  <a:pPr algn="ctr"/>
+                  <a14:m>
+                    <m:oMathPara xmlns:m="http://schemas.openxmlformats.org/officeDocument/2006/math">
+                      <m:oMathParaPr>
+                        <m:jc m:val="centerGroup"/>
+                      </m:oMathParaPr>
+                      <m:oMath xmlns:m="http://schemas.openxmlformats.org/officeDocument/2006/math">
+                        <m:r>
+                          <m:rPr>
+                            <m:sty m:val="p"/>
+                          </m:rPr>
+                          <a:rPr lang="en-US" b="0" i="0" smtClean="0">
+                            <a:solidFill>
+                              <a:sysClr val="windowText" lastClr="000000"/>
+                            </a:solidFill>
+                            <a:latin typeface="Cambria Math" panose="02040503050406030204" pitchFamily="18" charset="0"/>
+                          </a:rPr>
+                          <m:t>S</m:t>
+                        </m:r>
+                        <m:r>
+                          <a:rPr lang="en-US" b="0" i="0" smtClean="0">
+                            <a:solidFill>
+                              <a:sysClr val="windowText" lastClr="000000"/>
+                            </a:solidFill>
+                            <a:latin typeface="Cambria Math" panose="02040503050406030204" pitchFamily="18" charset="0"/>
+                          </a:rPr>
+                          <m:t>=</m:t>
+                        </m:r>
+                        <m:f>
+                          <m:fPr>
+                            <m:ctrlPr>
+                              <a:rPr lang="en-US" b="0" i="1" smtClean="0">
+                                <a:solidFill>
+                                  <a:sysClr val="windowText" lastClr="000000"/>
+                                </a:solidFill>
+                                <a:latin typeface="Cambria Math" panose="02040503050406030204" pitchFamily="18" charset="0"/>
+                              </a:rPr>
+                            </m:ctrlPr>
+                          </m:fPr>
+                          <m:num>
+                            <m:r>
+                              <m:rPr>
+                                <m:sty m:val="p"/>
+                              </m:rPr>
+                              <a:rPr lang="en-US" b="0" i="0" smtClean="0">
+                                <a:solidFill>
+                                  <a:sysClr val="windowText" lastClr="000000"/>
+                                </a:solidFill>
+                                <a:latin typeface="Cambria Math" panose="02040503050406030204" pitchFamily="18" charset="0"/>
+                              </a:rPr>
+                              <m:t>max</m:t>
+                            </m:r>
+                            <m:r>
+                              <a:rPr lang="en-US" b="0" i="1" smtClean="0">
+                                <a:solidFill>
+                                  <a:sysClr val="windowText" lastClr="000000"/>
+                                </a:solidFill>
+                                <a:latin typeface="Cambria Math" panose="02040503050406030204" pitchFamily="18" charset="0"/>
+                              </a:rPr>
+                              <m:t>⁡(</m:t>
+                            </m:r>
+                            <m:d>
+                              <m:dPr>
+                                <m:begChr m:val="|"/>
+                                <m:endChr m:val="|"/>
+                                <m:ctrlPr>
+                                  <a:rPr lang="en-US" b="0" i="1" smtClean="0">
+                                    <a:solidFill>
+                                      <a:sysClr val="windowText" lastClr="000000"/>
+                                    </a:solidFill>
+                                    <a:latin typeface="Cambria Math" panose="02040503050406030204" pitchFamily="18" charset="0"/>
+                                  </a:rPr>
+                                </m:ctrlPr>
+                              </m:dPr>
+                              <m:e>
+                                <m:r>
+                                  <a:rPr lang="en-US" b="0" i="1" smtClean="0">
+                                    <a:solidFill>
+                                      <a:sysClr val="windowText" lastClr="000000"/>
+                                    </a:solidFill>
+                                    <a:latin typeface="Cambria Math" panose="02040503050406030204" pitchFamily="18" charset="0"/>
+                                  </a:rPr>
+                                  <m:t>𝑤</m:t>
+                                </m:r>
+                              </m:e>
+                            </m:d>
+                            <m:r>
+                              <a:rPr lang="en-US" b="0" i="1" smtClean="0">
+                                <a:solidFill>
+                                  <a:sysClr val="windowText" lastClr="000000"/>
+                                </a:solidFill>
+                                <a:latin typeface="Cambria Math" panose="02040503050406030204" pitchFamily="18" charset="0"/>
+                              </a:rPr>
+                              <m:t>)</m:t>
+                            </m:r>
+                          </m:num>
+                          <m:den>
+                            <m:r>
+                              <a:rPr lang="en-US" b="0" i="1" smtClean="0">
+                                <a:solidFill>
+                                  <a:sysClr val="windowText" lastClr="000000"/>
+                                </a:solidFill>
+                                <a:latin typeface="Cambria Math" panose="02040503050406030204" pitchFamily="18" charset="0"/>
+                              </a:rPr>
+                              <m:t>7</m:t>
+                            </m:r>
+                          </m:den>
+                        </m:f>
+                        <m:r>
+                          <a:rPr lang="en-US" b="0" i="1" smtClean="0">
+                            <a:solidFill>
+                              <a:sysClr val="windowText" lastClr="000000"/>
+                            </a:solidFill>
+                            <a:latin typeface="Cambria Math" panose="02040503050406030204" pitchFamily="18" charset="0"/>
+                          </a:rPr>
+                          <m:t>=</m:t>
+                        </m:r>
+                        <m:f>
+                          <m:fPr>
+                            <m:ctrlPr>
+                              <a:rPr lang="en-US" b="0" i="1" smtClean="0">
+                                <a:solidFill>
+                                  <a:sysClr val="windowText" lastClr="000000"/>
+                                </a:solidFill>
+                                <a:latin typeface="Cambria Math" panose="02040503050406030204" pitchFamily="18" charset="0"/>
+                              </a:rPr>
+                            </m:ctrlPr>
+                          </m:fPr>
+                          <m:num>
+                            <m:r>
+                              <a:rPr lang="en-US" b="0" i="1" smtClean="0">
+                                <a:solidFill>
+                                  <a:sysClr val="windowText" lastClr="000000"/>
+                                </a:solidFill>
+                                <a:latin typeface="Cambria Math" panose="02040503050406030204" pitchFamily="18" charset="0"/>
+                              </a:rPr>
+                              <m:t>1.0</m:t>
+                            </m:r>
+                          </m:num>
+                          <m:den>
+                            <m:r>
+                              <a:rPr lang="en-US" b="0" i="1" smtClean="0">
+                                <a:solidFill>
+                                  <a:sysClr val="windowText" lastClr="000000"/>
+                                </a:solidFill>
+                                <a:latin typeface="Cambria Math" panose="02040503050406030204" pitchFamily="18" charset="0"/>
+                              </a:rPr>
+                              <m:t>7</m:t>
+                            </m:r>
+                          </m:den>
+                        </m:f>
+                        <m:r>
+                          <a:rPr lang="en-US" b="0" i="1" smtClean="0">
+                            <a:solidFill>
+                              <a:sysClr val="windowText" lastClr="000000"/>
+                            </a:solidFill>
+                            <a:latin typeface="Cambria Math" panose="02040503050406030204" pitchFamily="18" charset="0"/>
+                            <a:ea typeface="Cambria Math" panose="02040503050406030204" pitchFamily="18" charset="0"/>
+                          </a:rPr>
+                          <m:t>≈0.1429</m:t>
+                        </m:r>
+                      </m:oMath>
+                    </m:oMathPara>
+                  </a14:m>
+                  <a:endParaRPr lang="en-US" dirty="0">
+                    <a:solidFill>
+                      <a:sysClr val="windowText" lastClr="000000"/>
+                    </a:solidFill>
+                  </a:endParaRPr>
+                </a:p>
+              </p:txBody>
+            </p:sp>
+          </mc:Choice>
+          <mc:Fallback>
+            <p:sp>
+              <p:nvSpPr>
+                <p:cNvPr id="11" name="Rectangle 10">
+                  <a:extLst>
+                    <a:ext uri="{FF2B5EF4-FFF2-40B4-BE49-F238E27FC236}">
+                      <a16:creationId xmlns:a16="http://schemas.microsoft.com/office/drawing/2014/main" id="{46CEBABB-5713-12A3-0F3D-6E24FAB414B1}"/>
+                    </a:ext>
+                  </a:extLst>
+                </p:cNvPr>
+                <p:cNvSpPr>
+                  <a:spLocks noRot="1" noChangeAspect="1" noMove="1" noResize="1" noEditPoints="1" noAdjustHandles="1" noChangeArrowheads="1" noChangeShapeType="1" noTextEdit="1"/>
+                </p:cNvSpPr>
+                <p:nvPr/>
+              </p:nvSpPr>
+              <p:spPr>
+                <a:xfrm>
+                  <a:off x="2886939" y="1315484"/>
+                  <a:ext cx="2757871" cy="577001"/>
+                </a:xfrm>
+                <a:prstGeom prst="rect">
+                  <a:avLst/>
+                </a:prstGeom>
+                <a:blipFill>
+                  <a:blip r:embed="rId5"/>
+                  <a:stretch>
+                    <a:fillRect/>
+                  </a:stretch>
+                </a:blipFill>
+              </p:spPr>
+              <p:txBody>
+                <a:bodyPr/>
+                <a:lstStyle/>
+                <a:p>
+                  <a:r>
+                    <a:rPr lang="en-US">
+                      <a:noFill/>
+                    </a:rPr>
+                    <a:t> </a:t>
+                  </a:r>
+                </a:p>
+              </p:txBody>
+            </p:sp>
+          </mc:Fallback>
+        </mc:AlternateContent>
+        <p:sp>
+          <p:nvSpPr>
+            <p:cNvPr id="12" name="TextBox 11">
+              <a:extLst>
+                <a:ext uri="{FF2B5EF4-FFF2-40B4-BE49-F238E27FC236}">
+                  <a16:creationId xmlns:a16="http://schemas.microsoft.com/office/drawing/2014/main" id="{B747FC42-5EAE-C0DF-2B08-6B125B6DB5B2}"/>
+                </a:ext>
+              </a:extLst>
+            </p:cNvPr>
+            <p:cNvSpPr txBox="1"/>
+            <p:nvPr/>
+          </p:nvSpPr>
+          <p:spPr>
+            <a:xfrm>
+              <a:off x="2886938" y="1930258"/>
+              <a:ext cx="2757871" cy="600164"/>
+            </a:xfrm>
+            <a:prstGeom prst="rect">
+              <a:avLst/>
+            </a:prstGeom>
+            <a:noFill/>
+          </p:spPr>
+          <p:txBody>
+            <a:bodyPr wrap="square">
+              <a:spAutoFit/>
+            </a:bodyPr>
+            <a:lstStyle/>
+            <a:p>
+              <a:pPr algn="ctr"/>
+              <a:r>
+                <a:rPr lang="en-US" sz="1100" dirty="0"/>
+                <a:t>Let’s say the weights in this tensor range from [-1.0,+1.0]. Denominator is the max weight in the [-8,+7] quant range (so, 7).</a:t>
+              </a:r>
+            </a:p>
+          </p:txBody>
+        </p:sp>
+        <p:sp>
+          <p:nvSpPr>
+            <p:cNvPr id="13" name="Rectangle 12">
+              <a:extLst>
+                <a:ext uri="{FF2B5EF4-FFF2-40B4-BE49-F238E27FC236}">
+                  <a16:creationId xmlns:a16="http://schemas.microsoft.com/office/drawing/2014/main" id="{05AF1B14-4056-FBF2-F6CB-B18A101C05C6}"/>
+                </a:ext>
+              </a:extLst>
+            </p:cNvPr>
+            <p:cNvSpPr/>
+            <p:nvPr/>
+          </p:nvSpPr>
+          <p:spPr>
+            <a:xfrm>
+              <a:off x="2886937" y="2967524"/>
+              <a:ext cx="2757871" cy="273831"/>
+            </a:xfrm>
+            <a:prstGeom prst="rect">
+              <a:avLst/>
+            </a:prstGeom>
+            <a:solidFill>
+              <a:srgbClr val="B2D4EB"/>
+            </a:solidFill>
+          </p:spPr>
+          <p:style>
+            <a:lnRef idx="2">
+              <a:schemeClr val="dk1">
+                <a:shade val="15000"/>
+              </a:schemeClr>
+            </a:lnRef>
+            <a:fillRef idx="1">
+              <a:schemeClr val="dk1"/>
+            </a:fillRef>
+            <a:effectRef idx="0">
+              <a:schemeClr val="dk1"/>
+            </a:effectRef>
+            <a:fontRef idx="minor">
+              <a:schemeClr val="lt1"/>
+            </a:fontRef>
+          </p:style>
+          <p:txBody>
+            <a:bodyPr rtlCol="0" anchor="ctr"/>
+            <a:lstStyle/>
+            <a:p>
+              <a:pPr algn="ctr"/>
+              <a:r>
+                <a:rPr lang="en-US" dirty="0">
+                  <a:solidFill>
+                    <a:schemeClr val="tx1"/>
+                  </a:solidFill>
+                </a:rPr>
+                <a:t>Quantize the Value</a:t>
+              </a:r>
+            </a:p>
+          </p:txBody>
+        </p:sp>
+        <mc:AlternateContent xmlns:mc="http://schemas.openxmlformats.org/markup-compatibility/2006">
+          <mc:Choice xmlns:a14="http://schemas.microsoft.com/office/drawing/2010/main" Requires="a14">
+            <p:sp>
+              <p:nvSpPr>
+                <p:cNvPr id="14" name="Rectangle 13">
+                  <a:extLst>
+                    <a:ext uri="{FF2B5EF4-FFF2-40B4-BE49-F238E27FC236}">
+                      <a16:creationId xmlns:a16="http://schemas.microsoft.com/office/drawing/2014/main" id="{1A52E72A-5693-49F9-8BB0-4E7AC881649A}"/>
+                    </a:ext>
+                  </a:extLst>
+                </p:cNvPr>
+                <p:cNvSpPr/>
+                <p:nvPr/>
+              </p:nvSpPr>
+              <p:spPr>
+                <a:xfrm>
+                  <a:off x="2886939" y="3247400"/>
+                  <a:ext cx="2757871" cy="869576"/>
+                </a:xfrm>
+                <a:prstGeom prst="rect">
+                  <a:avLst/>
+                </a:prstGeom>
+                <a:solidFill>
+                  <a:schemeClr val="bg1"/>
+                </a:solidFill>
+              </p:spPr>
+              <p:style>
+                <a:lnRef idx="2">
+                  <a:schemeClr val="accent5">
+                    <a:shade val="15000"/>
+                  </a:schemeClr>
+                </a:lnRef>
+                <a:fillRef idx="1">
+                  <a:schemeClr val="accent5"/>
+                </a:fillRef>
+                <a:effectRef idx="0">
+                  <a:schemeClr val="accent5"/>
+                </a:effectRef>
+                <a:fontRef idx="minor">
+                  <a:schemeClr val="lt1"/>
+                </a:fontRef>
+              </p:style>
+              <p:txBody>
+                <a:bodyPr rtlCol="0" anchor="ctr"/>
+                <a:lstStyle/>
+                <a:p>
+                  <a:pPr algn="ctr"/>
+                  <a14:m>
+                    <m:oMathPara xmlns:m="http://schemas.openxmlformats.org/officeDocument/2006/math">
+                      <m:oMathParaPr>
+                        <m:jc m:val="centerGroup"/>
+                      </m:oMathParaPr>
+                      <m:oMath xmlns:m="http://schemas.openxmlformats.org/officeDocument/2006/math">
+                        <m:r>
+                          <a:rPr lang="en-US" i="1" smtClean="0">
+                            <a:solidFill>
+                              <a:sysClr val="windowText" lastClr="000000"/>
+                            </a:solidFill>
+                            <a:latin typeface="Cambria Math" panose="02040503050406030204" pitchFamily="18" charset="0"/>
+                          </a:rPr>
+                          <m:t>𝑄</m:t>
+                        </m:r>
+                        <m:d>
+                          <m:dPr>
+                            <m:ctrlPr>
+                              <a:rPr lang="en-US" i="1">
+                                <a:solidFill>
+                                  <a:sysClr val="windowText" lastClr="000000"/>
+                                </a:solidFill>
+                                <a:latin typeface="Cambria Math" panose="02040503050406030204" pitchFamily="18" charset="0"/>
+                              </a:rPr>
+                            </m:ctrlPr>
+                          </m:dPr>
+                          <m:e>
+                            <m:r>
+                              <a:rPr lang="en-US" b="0" i="1" smtClean="0">
+                                <a:solidFill>
+                                  <a:sysClr val="windowText" lastClr="000000"/>
+                                </a:solidFill>
+                                <a:latin typeface="Cambria Math" panose="02040503050406030204" pitchFamily="18" charset="0"/>
+                              </a:rPr>
+                              <m:t>0.37</m:t>
+                            </m:r>
+                          </m:e>
+                        </m:d>
+                        <m:r>
+                          <a:rPr lang="en-US" i="1">
+                            <a:solidFill>
+                              <a:sysClr val="windowText" lastClr="000000"/>
+                            </a:solidFill>
+                            <a:latin typeface="Cambria Math" panose="02040503050406030204" pitchFamily="18" charset="0"/>
+                          </a:rPr>
+                          <m:t>=</m:t>
+                        </m:r>
+                        <m:r>
+                          <m:rPr>
+                            <m:nor/>
+                          </m:rPr>
+                          <a:rPr lang="en-US">
+                            <a:solidFill>
+                              <a:sysClr val="windowText" lastClr="000000"/>
+                            </a:solidFill>
+                            <a:latin typeface="Cambria Math" panose="02040503050406030204" pitchFamily="18" charset="0"/>
+                          </a:rPr>
+                          <m:t>round</m:t>
+                        </m:r>
+                        <m:d>
+                          <m:dPr>
+                            <m:ctrlPr>
+                              <a:rPr lang="en-US" i="1">
+                                <a:solidFill>
+                                  <a:sysClr val="windowText" lastClr="000000"/>
+                                </a:solidFill>
+                                <a:latin typeface="Cambria Math" panose="02040503050406030204" pitchFamily="18" charset="0"/>
+                              </a:rPr>
+                            </m:ctrlPr>
+                          </m:dPr>
+                          <m:e>
+                            <m:f>
+                              <m:fPr>
+                                <m:ctrlPr>
+                                  <a:rPr lang="en-US" i="1">
+                                    <a:solidFill>
+                                      <a:sysClr val="windowText" lastClr="000000"/>
+                                    </a:solidFill>
+                                    <a:latin typeface="Cambria Math" panose="02040503050406030204" pitchFamily="18" charset="0"/>
+                                  </a:rPr>
+                                </m:ctrlPr>
+                              </m:fPr>
+                              <m:num>
+                                <m:r>
+                                  <a:rPr lang="en-US" b="0" i="1" smtClean="0">
+                                    <a:solidFill>
+                                      <a:sysClr val="windowText" lastClr="000000"/>
+                                    </a:solidFill>
+                                    <a:latin typeface="Cambria Math" panose="02040503050406030204" pitchFamily="18" charset="0"/>
+                                  </a:rPr>
+                                  <m:t>0.37</m:t>
+                                </m:r>
+                              </m:num>
+                              <m:den>
+                                <m:r>
+                                  <a:rPr lang="en-US" b="0" i="1" smtClean="0">
+                                    <a:solidFill>
+                                      <a:sysClr val="windowText" lastClr="000000"/>
+                                    </a:solidFill>
+                                    <a:latin typeface="Cambria Math" panose="02040503050406030204" pitchFamily="18" charset="0"/>
+                                  </a:rPr>
+                                  <m:t>0.1429</m:t>
+                                </m:r>
+                              </m:den>
+                            </m:f>
+                          </m:e>
+                        </m:d>
+                      </m:oMath>
+                    </m:oMathPara>
+                  </a14:m>
+                  <a:endParaRPr lang="en-US" i="1" dirty="0">
+                    <a:solidFill>
+                      <a:sysClr val="windowText" lastClr="000000"/>
+                    </a:solidFill>
+                    <a:latin typeface="Cambria Math" panose="02040503050406030204" pitchFamily="18" charset="0"/>
+                  </a:endParaRPr>
+                </a:p>
+                <a:p>
+                  <a:pPr algn="ctr"/>
+                  <a14:m>
+                    <m:oMathPara xmlns:m="http://schemas.openxmlformats.org/officeDocument/2006/math">
+                      <m:oMathParaPr>
+                        <m:jc m:val="centerGroup"/>
+                      </m:oMathParaPr>
+                      <m:oMath xmlns:m="http://schemas.openxmlformats.org/officeDocument/2006/math">
+                        <m:r>
+                          <a:rPr lang="en-US" b="0" i="1" smtClean="0">
+                            <a:solidFill>
+                              <a:sysClr val="windowText" lastClr="000000"/>
+                            </a:solidFill>
+                            <a:latin typeface="Cambria Math" panose="02040503050406030204" pitchFamily="18" charset="0"/>
+                          </a:rPr>
+                          <m:t>=</m:t>
+                        </m:r>
+                        <m:r>
+                          <m:rPr>
+                            <m:nor/>
+                          </m:rPr>
+                          <a:rPr lang="en-US">
+                            <a:solidFill>
+                              <a:sysClr val="windowText" lastClr="000000"/>
+                            </a:solidFill>
+                            <a:latin typeface="Cambria Math" panose="02040503050406030204" pitchFamily="18" charset="0"/>
+                          </a:rPr>
+                          <m:t>round</m:t>
+                        </m:r>
+                        <m:d>
+                          <m:dPr>
+                            <m:ctrlPr>
+                              <a:rPr lang="en-US" i="1" smtClean="0">
+                                <a:solidFill>
+                                  <a:sysClr val="windowText" lastClr="000000"/>
+                                </a:solidFill>
+                                <a:latin typeface="Cambria Math" panose="02040503050406030204" pitchFamily="18" charset="0"/>
+                              </a:rPr>
+                            </m:ctrlPr>
+                          </m:dPr>
+                          <m:e>
+                            <m:r>
+                              <a:rPr lang="en-US" b="0" i="1" smtClean="0">
+                                <a:solidFill>
+                                  <a:sysClr val="windowText" lastClr="000000"/>
+                                </a:solidFill>
+                                <a:latin typeface="Cambria Math" panose="02040503050406030204" pitchFamily="18" charset="0"/>
+                              </a:rPr>
+                              <m:t>2.59</m:t>
+                            </m:r>
+                          </m:e>
+                        </m:d>
+                        <m:r>
+                          <a:rPr lang="en-US" b="0" i="1" smtClean="0">
+                            <a:solidFill>
+                              <a:sysClr val="windowText" lastClr="000000"/>
+                            </a:solidFill>
+                            <a:latin typeface="Cambria Math" panose="02040503050406030204" pitchFamily="18" charset="0"/>
+                          </a:rPr>
+                          <m:t>=3</m:t>
+                        </m:r>
+                      </m:oMath>
+                    </m:oMathPara>
+                  </a14:m>
+                  <a:endParaRPr lang="en-US" dirty="0">
+                    <a:solidFill>
+                      <a:sysClr val="windowText" lastClr="000000"/>
+                    </a:solidFill>
+                  </a:endParaRPr>
+                </a:p>
+              </p:txBody>
+            </p:sp>
+          </mc:Choice>
+          <mc:Fallback>
+            <p:sp>
+              <p:nvSpPr>
+                <p:cNvPr id="14" name="Rectangle 13">
+                  <a:extLst>
+                    <a:ext uri="{FF2B5EF4-FFF2-40B4-BE49-F238E27FC236}">
+                      <a16:creationId xmlns:a16="http://schemas.microsoft.com/office/drawing/2014/main" id="{1A52E72A-5693-49F9-8BB0-4E7AC881649A}"/>
+                    </a:ext>
+                  </a:extLst>
+                </p:cNvPr>
+                <p:cNvSpPr>
+                  <a:spLocks noRot="1" noChangeAspect="1" noMove="1" noResize="1" noEditPoints="1" noAdjustHandles="1" noChangeArrowheads="1" noChangeShapeType="1" noTextEdit="1"/>
+                </p:cNvSpPr>
+                <p:nvPr/>
+              </p:nvSpPr>
+              <p:spPr>
+                <a:xfrm>
+                  <a:off x="2886939" y="3247400"/>
+                  <a:ext cx="2757871" cy="869576"/>
+                </a:xfrm>
+                <a:prstGeom prst="rect">
+                  <a:avLst/>
+                </a:prstGeom>
+                <a:blipFill>
+                  <a:blip r:embed="rId6"/>
+                  <a:stretch>
+                    <a:fillRect b="-3378"/>
+                  </a:stretch>
+                </a:blipFill>
+              </p:spPr>
+              <p:txBody>
+                <a:bodyPr/>
+                <a:lstStyle/>
+                <a:p>
+                  <a:r>
+                    <a:rPr lang="en-US">
+                      <a:noFill/>
+                    </a:rPr>
+                    <a:t> </a:t>
+                  </a:r>
+                </a:p>
+              </p:txBody>
+            </p:sp>
+          </mc:Fallback>
+        </mc:AlternateContent>
+        <p:sp>
+          <p:nvSpPr>
+            <p:cNvPr id="15" name="TextBox 14">
+              <a:extLst>
+                <a:ext uri="{FF2B5EF4-FFF2-40B4-BE49-F238E27FC236}">
+                  <a16:creationId xmlns:a16="http://schemas.microsoft.com/office/drawing/2014/main" id="{46F26E49-C806-D5AE-946D-FC847BA33CA6}"/>
+                </a:ext>
+              </a:extLst>
+            </p:cNvPr>
+            <p:cNvSpPr txBox="1"/>
+            <p:nvPr/>
+          </p:nvSpPr>
+          <p:spPr>
+            <a:xfrm>
+              <a:off x="2886939" y="4158127"/>
+              <a:ext cx="2757871" cy="430887"/>
+            </a:xfrm>
+            <a:prstGeom prst="rect">
+              <a:avLst/>
+            </a:prstGeom>
+            <a:noFill/>
+          </p:spPr>
+          <p:txBody>
+            <a:bodyPr wrap="square">
+              <a:spAutoFit/>
+            </a:bodyPr>
+            <a:lstStyle/>
+            <a:p>
+              <a:pPr algn="ctr"/>
+              <a:r>
+                <a:rPr lang="en-US" sz="1100" dirty="0"/>
+                <a:t>Integer representation (4-bit) is: 3</a:t>
+              </a:r>
+            </a:p>
+            <a:p>
+              <a:pPr algn="ctr"/>
+              <a:r>
+                <a:rPr lang="en-US" sz="1100" dirty="0"/>
+                <a:t>(binary: 0011)</a:t>
+              </a:r>
+            </a:p>
+          </p:txBody>
+        </p:sp>
+        <p:cxnSp>
+          <p:nvCxnSpPr>
+            <p:cNvPr id="16" name="Connector: Elbow 15">
+              <a:extLst>
+                <a:ext uri="{FF2B5EF4-FFF2-40B4-BE49-F238E27FC236}">
+                  <a16:creationId xmlns:a16="http://schemas.microsoft.com/office/drawing/2014/main" id="{A08310A7-EEE8-F6F6-64C4-407BEAE69530}"/>
+                </a:ext>
+              </a:extLst>
+            </p:cNvPr>
+            <p:cNvCxnSpPr>
+              <a:cxnSpLocks/>
+              <a:stCxn id="13" idx="3"/>
+              <a:endCxn id="18" idx="1"/>
+            </p:cNvCxnSpPr>
+            <p:nvPr/>
+          </p:nvCxnSpPr>
+          <p:spPr>
+            <a:xfrm flipV="1">
+              <a:off x="5644808" y="1183343"/>
+              <a:ext cx="818539" cy="1921097"/>
+            </a:xfrm>
+            <a:prstGeom prst="bentConnector3">
+              <a:avLst>
+                <a:gd name="adj1" fmla="val 50000"/>
+              </a:avLst>
+            </a:prstGeom>
+            <a:ln w="38100">
+              <a:solidFill>
+                <a:schemeClr val="tx1"/>
+              </a:solidFill>
+              <a:tailEnd type="triangle"/>
+            </a:ln>
+          </p:spPr>
+          <p:style>
+            <a:lnRef idx="1">
+              <a:schemeClr val="accent1"/>
+            </a:lnRef>
+            <a:fillRef idx="0">
+              <a:schemeClr val="accent1"/>
+            </a:fillRef>
+            <a:effectRef idx="0">
+              <a:schemeClr val="accent1"/>
+            </a:effectRef>
+            <a:fontRef idx="minor">
+              <a:schemeClr val="tx1"/>
+            </a:fontRef>
+          </p:style>
+        </p:cxnSp>
+        <p:cxnSp>
+          <p:nvCxnSpPr>
+            <p:cNvPr id="17" name="Connector: Elbow 16">
+              <a:extLst>
+                <a:ext uri="{FF2B5EF4-FFF2-40B4-BE49-F238E27FC236}">
+                  <a16:creationId xmlns:a16="http://schemas.microsoft.com/office/drawing/2014/main" id="{20F04CE8-49AC-5CFE-206A-9C293D4CF620}"/>
+                </a:ext>
+              </a:extLst>
+            </p:cNvPr>
+            <p:cNvCxnSpPr>
+              <a:cxnSpLocks/>
+              <a:stCxn id="7" idx="3"/>
+              <a:endCxn id="10" idx="1"/>
+            </p:cNvCxnSpPr>
+            <p:nvPr/>
+          </p:nvCxnSpPr>
+          <p:spPr>
+            <a:xfrm flipV="1">
+              <a:off x="2345735" y="1183342"/>
+              <a:ext cx="541204" cy="1282438"/>
+            </a:xfrm>
+            <a:prstGeom prst="bentConnector3">
+              <a:avLst>
+                <a:gd name="adj1" fmla="val 50000"/>
+              </a:avLst>
+            </a:prstGeom>
+            <a:ln w="38100">
+              <a:solidFill>
+                <a:schemeClr val="tx1"/>
+              </a:solidFill>
+              <a:tailEnd type="triangle"/>
+            </a:ln>
+          </p:spPr>
+          <p:style>
+            <a:lnRef idx="1">
+              <a:schemeClr val="accent1"/>
+            </a:lnRef>
+            <a:fillRef idx="0">
+              <a:schemeClr val="accent1"/>
+            </a:fillRef>
+            <a:effectRef idx="0">
+              <a:schemeClr val="accent1"/>
+            </a:effectRef>
+            <a:fontRef idx="minor">
+              <a:schemeClr val="tx1"/>
+            </a:fontRef>
+          </p:style>
+        </p:cxnSp>
+        <p:sp>
+          <p:nvSpPr>
+            <p:cNvPr id="18" name="Rectangle 17">
+              <a:extLst>
+                <a:ext uri="{FF2B5EF4-FFF2-40B4-BE49-F238E27FC236}">
+                  <a16:creationId xmlns:a16="http://schemas.microsoft.com/office/drawing/2014/main" id="{597FF09C-A29A-A499-A2B3-672C34E3A06E}"/>
+                </a:ext>
+              </a:extLst>
+            </p:cNvPr>
+            <p:cNvSpPr/>
+            <p:nvPr/>
+          </p:nvSpPr>
+          <p:spPr>
+            <a:xfrm>
+              <a:off x="6463347" y="1046427"/>
+              <a:ext cx="1711303" cy="273831"/>
+            </a:xfrm>
+            <a:prstGeom prst="rect">
+              <a:avLst/>
+            </a:prstGeom>
+            <a:solidFill>
+              <a:srgbClr val="B2D4EB"/>
+            </a:solidFill>
+          </p:spPr>
+          <p:style>
+            <a:lnRef idx="2">
+              <a:schemeClr val="dk1">
+                <a:shade val="15000"/>
+              </a:schemeClr>
+            </a:lnRef>
+            <a:fillRef idx="1">
+              <a:schemeClr val="dk1"/>
+            </a:fillRef>
+            <a:effectRef idx="0">
+              <a:schemeClr val="dk1"/>
+            </a:effectRef>
+            <a:fontRef idx="minor">
+              <a:schemeClr val="lt1"/>
+            </a:fontRef>
+          </p:style>
+          <p:txBody>
+            <a:bodyPr rtlCol="0" anchor="ctr"/>
+            <a:lstStyle/>
+            <a:p>
+              <a:pPr algn="ctr"/>
+              <a:r>
+                <a:rPr lang="en-US" dirty="0">
+                  <a:solidFill>
+                    <a:schemeClr val="tx1"/>
+                  </a:solidFill>
+                </a:rPr>
+                <a:t>De-Quantize</a:t>
+              </a:r>
+            </a:p>
+          </p:txBody>
+        </p:sp>
+        <mc:AlternateContent xmlns:mc="http://schemas.openxmlformats.org/markup-compatibility/2006">
+          <mc:Choice xmlns:a14="http://schemas.microsoft.com/office/drawing/2010/main" Requires="a14">
+            <p:sp>
+              <p:nvSpPr>
+                <p:cNvPr id="19" name="Rectangle 18">
+                  <a:extLst>
+                    <a:ext uri="{FF2B5EF4-FFF2-40B4-BE49-F238E27FC236}">
+                      <a16:creationId xmlns:a16="http://schemas.microsoft.com/office/drawing/2014/main" id="{18328F5A-70D5-58BA-1577-8D30F865B26C}"/>
+                    </a:ext>
+                  </a:extLst>
+                </p:cNvPr>
+                <p:cNvSpPr/>
+                <p:nvPr/>
+              </p:nvSpPr>
+              <p:spPr>
+                <a:xfrm>
+                  <a:off x="6463345" y="1315484"/>
+                  <a:ext cx="1711304" cy="855718"/>
+                </a:xfrm>
+                <a:prstGeom prst="rect">
+                  <a:avLst/>
+                </a:prstGeom>
+                <a:solidFill>
+                  <a:schemeClr val="bg1"/>
+                </a:solidFill>
+              </p:spPr>
+              <p:style>
+                <a:lnRef idx="2">
+                  <a:schemeClr val="accent5">
+                    <a:shade val="15000"/>
+                  </a:schemeClr>
+                </a:lnRef>
+                <a:fillRef idx="1">
+                  <a:schemeClr val="accent5"/>
+                </a:fillRef>
+                <a:effectRef idx="0">
+                  <a:schemeClr val="accent5"/>
+                </a:effectRef>
+                <a:fontRef idx="minor">
+                  <a:schemeClr val="lt1"/>
+                </a:fontRef>
+              </p:style>
+              <p:txBody>
+                <a:bodyPr rtlCol="0" anchor="ctr"/>
+                <a:lstStyle/>
+                <a:p>
+                  <a:pPr algn="ctr"/>
+                  <a14:m>
+                    <m:oMathPara xmlns:m="http://schemas.openxmlformats.org/officeDocument/2006/math">
+                      <m:oMathParaPr>
+                        <m:jc m:val="centerGroup"/>
+                      </m:oMathParaPr>
+                      <m:oMath xmlns:m="http://schemas.openxmlformats.org/officeDocument/2006/math">
+                        <m:acc>
+                          <m:accPr>
+                            <m:chr m:val="̂"/>
+                            <m:ctrlPr>
+                              <a:rPr lang="pl-PL" b="0" i="1" smtClean="0">
+                                <a:solidFill>
+                                  <a:sysClr val="windowText" lastClr="000000"/>
+                                </a:solidFill>
+                                <a:latin typeface="Cambria Math" panose="02040503050406030204" pitchFamily="18" charset="0"/>
+                              </a:rPr>
+                            </m:ctrlPr>
+                          </m:accPr>
+                          <m:e>
+                            <m:r>
+                              <a:rPr lang="en-US" b="0" i="1" smtClean="0">
+                                <a:solidFill>
+                                  <a:sysClr val="windowText" lastClr="000000"/>
+                                </a:solidFill>
+                                <a:latin typeface="Cambria Math" panose="02040503050406030204" pitchFamily="18" charset="0"/>
+                              </a:rPr>
+                              <m:t>𝑤</m:t>
+                            </m:r>
+                          </m:e>
+                        </m:acc>
+                        <m:r>
+                          <a:rPr lang="pl-PL" i="1">
+                            <a:solidFill>
+                              <a:sysClr val="windowText" lastClr="000000"/>
+                            </a:solidFill>
+                            <a:latin typeface="Cambria Math" panose="02040503050406030204" pitchFamily="18" charset="0"/>
+                          </a:rPr>
+                          <m:t>=</m:t>
+                        </m:r>
+                        <m:r>
+                          <a:rPr lang="pl-PL" i="1">
+                            <a:solidFill>
+                              <a:sysClr val="windowText" lastClr="000000"/>
+                            </a:solidFill>
+                            <a:latin typeface="Cambria Math" panose="02040503050406030204" pitchFamily="18" charset="0"/>
+                          </a:rPr>
+                          <m:t>𝑆</m:t>
+                        </m:r>
+                        <m:r>
+                          <a:rPr lang="pl-PL" i="1">
+                            <a:solidFill>
+                              <a:sysClr val="windowText" lastClr="000000"/>
+                            </a:solidFill>
+                            <a:latin typeface="Cambria Math" panose="02040503050406030204" pitchFamily="18" charset="0"/>
+                          </a:rPr>
+                          <m:t>×</m:t>
+                        </m:r>
+                        <m:r>
+                          <a:rPr lang="pl-PL" i="1">
+                            <a:solidFill>
+                              <a:sysClr val="windowText" lastClr="000000"/>
+                            </a:solidFill>
+                            <a:latin typeface="Cambria Math" panose="02040503050406030204" pitchFamily="18" charset="0"/>
+                          </a:rPr>
+                          <m:t>𝑄</m:t>
+                        </m:r>
+                        <m:r>
+                          <a:rPr lang="pl-PL" i="1">
+                            <a:solidFill>
+                              <a:sysClr val="windowText" lastClr="000000"/>
+                            </a:solidFill>
+                            <a:latin typeface="Cambria Math" panose="02040503050406030204" pitchFamily="18" charset="0"/>
+                          </a:rPr>
+                          <m:t>(</m:t>
+                        </m:r>
+                        <m:r>
+                          <a:rPr lang="pl-PL" i="1">
+                            <a:solidFill>
+                              <a:sysClr val="windowText" lastClr="000000"/>
+                            </a:solidFill>
+                            <a:latin typeface="Cambria Math" panose="02040503050406030204" pitchFamily="18" charset="0"/>
+                          </a:rPr>
+                          <m:t>𝑤</m:t>
+                        </m:r>
+                        <m:r>
+                          <a:rPr lang="pl-PL" i="1">
+                            <a:solidFill>
+                              <a:sysClr val="windowText" lastClr="000000"/>
+                            </a:solidFill>
+                            <a:latin typeface="Cambria Math" panose="02040503050406030204" pitchFamily="18" charset="0"/>
+                          </a:rPr>
+                          <m:t>)=0.1429×3=0.4287</m:t>
+                        </m:r>
+                      </m:oMath>
+                    </m:oMathPara>
+                  </a14:m>
+                  <a:endParaRPr lang="en-US" dirty="0">
+                    <a:solidFill>
+                      <a:sysClr val="windowText" lastClr="000000"/>
+                    </a:solidFill>
+                  </a:endParaRPr>
+                </a:p>
+              </p:txBody>
+            </p:sp>
+          </mc:Choice>
+          <mc:Fallback>
+            <p:sp>
+              <p:nvSpPr>
+                <p:cNvPr id="19" name="Rectangle 18">
+                  <a:extLst>
+                    <a:ext uri="{FF2B5EF4-FFF2-40B4-BE49-F238E27FC236}">
+                      <a16:creationId xmlns:a16="http://schemas.microsoft.com/office/drawing/2014/main" id="{18328F5A-70D5-58BA-1577-8D30F865B26C}"/>
+                    </a:ext>
+                  </a:extLst>
+                </p:cNvPr>
+                <p:cNvSpPr>
+                  <a:spLocks noRot="1" noChangeAspect="1" noMove="1" noResize="1" noEditPoints="1" noAdjustHandles="1" noChangeArrowheads="1" noChangeShapeType="1" noTextEdit="1"/>
+                </p:cNvSpPr>
+                <p:nvPr/>
+              </p:nvSpPr>
+              <p:spPr>
+                <a:xfrm>
+                  <a:off x="6463345" y="1315484"/>
+                  <a:ext cx="1711304" cy="855718"/>
+                </a:xfrm>
+                <a:prstGeom prst="rect">
+                  <a:avLst/>
+                </a:prstGeom>
+                <a:blipFill>
+                  <a:blip r:embed="rId7"/>
+                  <a:stretch>
+                    <a:fillRect t="-3448"/>
+                  </a:stretch>
+                </a:blipFill>
+              </p:spPr>
+              <p:txBody>
+                <a:bodyPr/>
+                <a:lstStyle/>
+                <a:p>
+                  <a:r>
+                    <a:rPr lang="en-US">
+                      <a:noFill/>
+                    </a:rPr>
+                    <a:t> </a:t>
+                  </a:r>
+                </a:p>
+              </p:txBody>
+            </p:sp>
+          </mc:Fallback>
+        </mc:AlternateContent>
+        <p:sp>
+          <p:nvSpPr>
+            <p:cNvPr id="20" name="TextBox 19">
+              <a:extLst>
+                <a:ext uri="{FF2B5EF4-FFF2-40B4-BE49-F238E27FC236}">
+                  <a16:creationId xmlns:a16="http://schemas.microsoft.com/office/drawing/2014/main" id="{539C600D-70A1-925D-4FF1-E2B23D5A1F91}"/>
+                </a:ext>
+              </a:extLst>
+            </p:cNvPr>
+            <p:cNvSpPr txBox="1"/>
+            <p:nvPr/>
+          </p:nvSpPr>
+          <p:spPr>
+            <a:xfrm>
+              <a:off x="6463345" y="2227691"/>
+              <a:ext cx="1711304" cy="430887"/>
+            </a:xfrm>
+            <a:prstGeom prst="rect">
+              <a:avLst/>
+            </a:prstGeom>
+            <a:noFill/>
+          </p:spPr>
+          <p:txBody>
+            <a:bodyPr wrap="square" rtlCol="0">
+              <a:spAutoFit/>
+            </a:bodyPr>
+            <a:lstStyle/>
+            <a:p>
+              <a:pPr algn="ctr"/>
+              <a:r>
+                <a:rPr lang="en-US" sz="1100" dirty="0"/>
+                <a:t>Reconstruct the original model weight</a:t>
+              </a:r>
+            </a:p>
+          </p:txBody>
+        </p:sp>
+        <p:sp>
+          <p:nvSpPr>
+            <p:cNvPr id="21" name="Rectangle 20">
+              <a:extLst>
+                <a:ext uri="{FF2B5EF4-FFF2-40B4-BE49-F238E27FC236}">
+                  <a16:creationId xmlns:a16="http://schemas.microsoft.com/office/drawing/2014/main" id="{60E68490-F7D3-8A4D-DB15-5F77430143DC}"/>
+                </a:ext>
+              </a:extLst>
+            </p:cNvPr>
+            <p:cNvSpPr/>
+            <p:nvPr/>
+          </p:nvSpPr>
+          <p:spPr>
+            <a:xfrm>
+              <a:off x="6285205" y="2967525"/>
+              <a:ext cx="2067587" cy="273831"/>
+            </a:xfrm>
+            <a:prstGeom prst="rect">
+              <a:avLst/>
+            </a:prstGeom>
+            <a:solidFill>
+              <a:srgbClr val="B2D4EB"/>
+            </a:solidFill>
+          </p:spPr>
+          <p:style>
+            <a:lnRef idx="2">
+              <a:schemeClr val="dk1">
+                <a:shade val="15000"/>
+              </a:schemeClr>
+            </a:lnRef>
+            <a:fillRef idx="1">
+              <a:schemeClr val="dk1"/>
+            </a:fillRef>
+            <a:effectRef idx="0">
+              <a:schemeClr val="dk1"/>
+            </a:effectRef>
+            <a:fontRef idx="minor">
+              <a:schemeClr val="lt1"/>
+            </a:fontRef>
+          </p:style>
+          <p:txBody>
+            <a:bodyPr rtlCol="0" anchor="ctr"/>
+            <a:lstStyle/>
+            <a:p>
+              <a:pPr algn="ctr"/>
+              <a:r>
+                <a:rPr lang="en-US" dirty="0">
+                  <a:solidFill>
+                    <a:schemeClr val="tx1"/>
+                  </a:solidFill>
+                </a:rPr>
+                <a:t>Error</a:t>
+              </a:r>
+            </a:p>
+          </p:txBody>
+        </p:sp>
+        <mc:AlternateContent xmlns:mc="http://schemas.openxmlformats.org/markup-compatibility/2006">
+          <mc:Choice xmlns:a14="http://schemas.microsoft.com/office/drawing/2010/main" Requires="a14">
+            <p:sp>
+              <p:nvSpPr>
+                <p:cNvPr id="22" name="Rectangle 21">
+                  <a:extLst>
+                    <a:ext uri="{FF2B5EF4-FFF2-40B4-BE49-F238E27FC236}">
+                      <a16:creationId xmlns:a16="http://schemas.microsoft.com/office/drawing/2014/main" id="{85A267A4-5AA5-3125-5651-EB5175AD87BD}"/>
+                    </a:ext>
+                  </a:extLst>
+                </p:cNvPr>
+                <p:cNvSpPr/>
+                <p:nvPr/>
+              </p:nvSpPr>
+              <p:spPr>
+                <a:xfrm>
+                  <a:off x="6285206" y="3241356"/>
+                  <a:ext cx="2067586" cy="875620"/>
+                </a:xfrm>
+                <a:prstGeom prst="rect">
+                  <a:avLst/>
+                </a:prstGeom>
+                <a:solidFill>
+                  <a:schemeClr val="bg1"/>
+                </a:solidFill>
+              </p:spPr>
+              <p:style>
+                <a:lnRef idx="2">
+                  <a:schemeClr val="accent5">
+                    <a:shade val="15000"/>
+                  </a:schemeClr>
+                </a:lnRef>
+                <a:fillRef idx="1">
+                  <a:schemeClr val="accent5"/>
+                </a:fillRef>
+                <a:effectRef idx="0">
+                  <a:schemeClr val="accent5"/>
+                </a:effectRef>
+                <a:fontRef idx="minor">
+                  <a:schemeClr val="lt1"/>
+                </a:fontRef>
+              </p:style>
+              <p:txBody>
+                <a:bodyPr rtlCol="0" anchor="ctr"/>
+                <a:lstStyle/>
+                <a:p>
+                  <a:pPr algn="ctr"/>
+                  <a14:m>
+                    <m:oMathPara xmlns:m="http://schemas.openxmlformats.org/officeDocument/2006/math">
+                      <m:oMathParaPr>
+                        <m:jc m:val="centerGroup"/>
+                      </m:oMathParaPr>
+                      <m:oMath xmlns:m="http://schemas.openxmlformats.org/officeDocument/2006/math">
+                        <m:r>
+                          <m:rPr>
+                            <m:nor/>
+                          </m:rPr>
+                          <a:rPr lang="en-US" b="0" i="0" smtClean="0">
+                            <a:solidFill>
+                              <a:sysClr val="windowText" lastClr="000000"/>
+                            </a:solidFill>
+                            <a:latin typeface="Cambria Math" panose="02040503050406030204" pitchFamily="18" charset="0"/>
+                          </a:rPr>
+                          <m:t>error</m:t>
+                        </m:r>
+                        <m:r>
+                          <a:rPr lang="en-US" b="0" i="1" smtClean="0">
+                            <a:solidFill>
+                              <a:sysClr val="windowText" lastClr="000000"/>
+                            </a:solidFill>
+                            <a:latin typeface="Cambria Math" panose="02040503050406030204" pitchFamily="18" charset="0"/>
+                          </a:rPr>
+                          <m:t>=</m:t>
+                        </m:r>
+                        <m:r>
+                          <a:rPr lang="pl-PL" i="1" smtClean="0">
+                            <a:solidFill>
+                              <a:sysClr val="windowText" lastClr="000000"/>
+                            </a:solidFill>
+                            <a:latin typeface="Cambria Math" panose="02040503050406030204" pitchFamily="18" charset="0"/>
+                          </a:rPr>
+                          <m:t>𝑤</m:t>
+                        </m:r>
+                        <m:r>
+                          <a:rPr lang="pl-PL" i="1" smtClean="0">
+                            <a:solidFill>
+                              <a:sysClr val="windowText" lastClr="000000"/>
+                            </a:solidFill>
+                            <a:latin typeface="Cambria Math" panose="02040503050406030204" pitchFamily="18" charset="0"/>
+                          </a:rPr>
+                          <m:t>−</m:t>
+                        </m:r>
+                        <m:acc>
+                          <m:accPr>
+                            <m:chr m:val="̂"/>
+                            <m:ctrlPr>
+                              <a:rPr lang="pl-PL" i="1" smtClean="0">
+                                <a:solidFill>
+                                  <a:sysClr val="windowText" lastClr="000000"/>
+                                </a:solidFill>
+                                <a:latin typeface="Cambria Math" panose="02040503050406030204" pitchFamily="18" charset="0"/>
+                              </a:rPr>
+                            </m:ctrlPr>
+                          </m:accPr>
+                          <m:e>
+                            <m:r>
+                              <a:rPr lang="en-US" b="0" i="1" smtClean="0">
+                                <a:solidFill>
+                                  <a:sysClr val="windowText" lastClr="000000"/>
+                                </a:solidFill>
+                                <a:latin typeface="Cambria Math" panose="02040503050406030204" pitchFamily="18" charset="0"/>
+                              </a:rPr>
+                              <m:t>𝑤</m:t>
+                            </m:r>
+                          </m:e>
+                        </m:acc>
+                      </m:oMath>
+                    </m:oMathPara>
+                  </a14:m>
+                  <a:endParaRPr lang="en-US" i="1" dirty="0">
+                    <a:solidFill>
+                      <a:sysClr val="windowText" lastClr="000000"/>
+                    </a:solidFill>
+                    <a:latin typeface="Cambria Math" panose="02040503050406030204" pitchFamily="18" charset="0"/>
+                  </a:endParaRPr>
+                </a:p>
+                <a:p>
+                  <a:pPr algn="ctr"/>
+                  <a14:m>
+                    <m:oMathPara xmlns:m="http://schemas.openxmlformats.org/officeDocument/2006/math">
+                      <m:oMathParaPr>
+                        <m:jc m:val="centerGroup"/>
+                      </m:oMathParaPr>
+                      <m:oMath xmlns:m="http://schemas.openxmlformats.org/officeDocument/2006/math">
+                        <m:r>
+                          <a:rPr lang="pl-PL" i="1">
+                            <a:solidFill>
+                              <a:sysClr val="windowText" lastClr="000000"/>
+                            </a:solidFill>
+                            <a:latin typeface="Cambria Math" panose="02040503050406030204" pitchFamily="18" charset="0"/>
+                          </a:rPr>
+                          <m:t>=0.37−0.4287=−0.0587</m:t>
+                        </m:r>
+                      </m:oMath>
+                    </m:oMathPara>
+                  </a14:m>
+                  <a:endParaRPr lang="en-US" dirty="0">
+                    <a:solidFill>
+                      <a:sysClr val="windowText" lastClr="000000"/>
+                    </a:solidFill>
+                  </a:endParaRPr>
+                </a:p>
+              </p:txBody>
+            </p:sp>
+          </mc:Choice>
+          <mc:Fallback>
+            <p:sp>
+              <p:nvSpPr>
+                <p:cNvPr id="22" name="Rectangle 21">
+                  <a:extLst>
+                    <a:ext uri="{FF2B5EF4-FFF2-40B4-BE49-F238E27FC236}">
+                      <a16:creationId xmlns:a16="http://schemas.microsoft.com/office/drawing/2014/main" id="{85A267A4-5AA5-3125-5651-EB5175AD87BD}"/>
+                    </a:ext>
+                  </a:extLst>
+                </p:cNvPr>
+                <p:cNvSpPr>
+                  <a:spLocks noRot="1" noChangeAspect="1" noMove="1" noResize="1" noEditPoints="1" noAdjustHandles="1" noChangeArrowheads="1" noChangeShapeType="1" noTextEdit="1"/>
+                </p:cNvSpPr>
+                <p:nvPr/>
+              </p:nvSpPr>
+              <p:spPr>
+                <a:xfrm>
+                  <a:off x="6285206" y="3241356"/>
+                  <a:ext cx="2067586" cy="875620"/>
+                </a:xfrm>
+                <a:prstGeom prst="rect">
+                  <a:avLst/>
+                </a:prstGeom>
+                <a:blipFill>
+                  <a:blip r:embed="rId8"/>
+                  <a:stretch>
+                    <a:fillRect t="-2013"/>
+                  </a:stretch>
+                </a:blipFill>
+              </p:spPr>
+              <p:txBody>
+                <a:bodyPr/>
+                <a:lstStyle/>
+                <a:p>
+                  <a:r>
+                    <a:rPr lang="en-US">
+                      <a:noFill/>
+                    </a:rPr>
+                    <a:t> </a:t>
+                  </a:r>
+                </a:p>
+              </p:txBody>
+            </p:sp>
+          </mc:Fallback>
+        </mc:AlternateContent>
+        <p:sp>
+          <p:nvSpPr>
+            <p:cNvPr id="23" name="TextBox 22">
+              <a:extLst>
+                <a:ext uri="{FF2B5EF4-FFF2-40B4-BE49-F238E27FC236}">
+                  <a16:creationId xmlns:a16="http://schemas.microsoft.com/office/drawing/2014/main" id="{C6E99888-98F6-40AA-8A60-0DCC4BFB49C2}"/>
+                </a:ext>
+              </a:extLst>
+            </p:cNvPr>
+            <p:cNvSpPr txBox="1"/>
+            <p:nvPr/>
+          </p:nvSpPr>
+          <p:spPr>
+            <a:xfrm>
+              <a:off x="6285206" y="4090401"/>
+              <a:ext cx="2067587" cy="430887"/>
+            </a:xfrm>
+            <a:prstGeom prst="rect">
+              <a:avLst/>
+            </a:prstGeom>
+            <a:noFill/>
+          </p:spPr>
+          <p:txBody>
+            <a:bodyPr wrap="square" rtlCol="0">
+              <a:spAutoFit/>
+            </a:bodyPr>
+            <a:lstStyle/>
+            <a:p>
+              <a:pPr algn="ctr"/>
+              <a:r>
+                <a:rPr lang="en-US" sz="1100" dirty="0"/>
+                <a:t>The reconstructed model weight is</a:t>
+              </a:r>
+            </a:p>
+            <a:p>
+              <a:pPr algn="ctr"/>
+              <a:r>
+                <a:rPr lang="en-US" sz="1100" dirty="0"/>
+                <a:t>off by -0.0587</a:t>
+              </a:r>
+            </a:p>
+          </p:txBody>
+        </p:sp>
+        <p:cxnSp>
+          <p:nvCxnSpPr>
+            <p:cNvPr id="24" name="Straight Arrow Connector 23">
+              <a:extLst>
+                <a:ext uri="{FF2B5EF4-FFF2-40B4-BE49-F238E27FC236}">
+                  <a16:creationId xmlns:a16="http://schemas.microsoft.com/office/drawing/2014/main" id="{CD7909FA-F299-55CF-6779-574736906812}"/>
+                </a:ext>
+              </a:extLst>
+            </p:cNvPr>
+            <p:cNvCxnSpPr>
+              <a:cxnSpLocks/>
+              <a:stCxn id="6" idx="2"/>
+              <a:endCxn id="7" idx="0"/>
+            </p:cNvCxnSpPr>
+            <p:nvPr/>
+          </p:nvCxnSpPr>
+          <p:spPr>
+            <a:xfrm>
+              <a:off x="1311942" y="1928908"/>
+              <a:ext cx="0" cy="399956"/>
+            </a:xfrm>
+            <a:prstGeom prst="straightConnector1">
+              <a:avLst/>
+            </a:prstGeom>
+            <a:ln w="38100">
+              <a:solidFill>
+                <a:schemeClr val="tx1"/>
+              </a:solidFill>
+              <a:tailEnd type="triangle"/>
+            </a:ln>
+          </p:spPr>
+          <p:style>
+            <a:lnRef idx="1">
+              <a:schemeClr val="accent1"/>
+            </a:lnRef>
+            <a:fillRef idx="0">
+              <a:schemeClr val="accent1"/>
+            </a:fillRef>
+            <a:effectRef idx="0">
+              <a:schemeClr val="accent1"/>
+            </a:effectRef>
+            <a:fontRef idx="minor">
+              <a:schemeClr val="tx1"/>
+            </a:fontRef>
+          </p:style>
+        </p:cxnSp>
+        <p:cxnSp>
+          <p:nvCxnSpPr>
+            <p:cNvPr id="25" name="Straight Arrow Connector 24">
+              <a:extLst>
+                <a:ext uri="{FF2B5EF4-FFF2-40B4-BE49-F238E27FC236}">
+                  <a16:creationId xmlns:a16="http://schemas.microsoft.com/office/drawing/2014/main" id="{CF8213CC-FC4F-80C2-D898-9041F2C3C40F}"/>
+                </a:ext>
+              </a:extLst>
+            </p:cNvPr>
+            <p:cNvCxnSpPr>
+              <a:cxnSpLocks/>
+              <a:stCxn id="12" idx="2"/>
+              <a:endCxn id="13" idx="0"/>
+            </p:cNvCxnSpPr>
+            <p:nvPr/>
+          </p:nvCxnSpPr>
+          <p:spPr>
+            <a:xfrm flipH="1">
+              <a:off x="4265873" y="2361146"/>
+              <a:ext cx="1" cy="606378"/>
+            </a:xfrm>
+            <a:prstGeom prst="straightConnector1">
+              <a:avLst/>
+            </a:prstGeom>
+            <a:ln w="38100">
+              <a:solidFill>
+                <a:schemeClr val="tx1"/>
+              </a:solidFill>
+              <a:tailEnd type="triangle"/>
+            </a:ln>
+          </p:spPr>
+          <p:style>
+            <a:lnRef idx="1">
+              <a:schemeClr val="accent1"/>
+            </a:lnRef>
+            <a:fillRef idx="0">
+              <a:schemeClr val="accent1"/>
+            </a:fillRef>
+            <a:effectRef idx="0">
+              <a:schemeClr val="accent1"/>
+            </a:effectRef>
+            <a:fontRef idx="minor">
+              <a:schemeClr val="tx1"/>
+            </a:fontRef>
+          </p:style>
+        </p:cxnSp>
+        <p:cxnSp>
+          <p:nvCxnSpPr>
+            <p:cNvPr id="26" name="Straight Arrow Connector 25">
+              <a:extLst>
+                <a:ext uri="{FF2B5EF4-FFF2-40B4-BE49-F238E27FC236}">
+                  <a16:creationId xmlns:a16="http://schemas.microsoft.com/office/drawing/2014/main" id="{7F869889-41FC-A3CD-DF46-A7147E3D45EB}"/>
+                </a:ext>
+              </a:extLst>
+            </p:cNvPr>
+            <p:cNvCxnSpPr>
+              <a:cxnSpLocks/>
+              <a:stCxn id="20" idx="2"/>
+              <a:endCxn id="21" idx="0"/>
+            </p:cNvCxnSpPr>
+            <p:nvPr/>
+          </p:nvCxnSpPr>
+          <p:spPr>
+            <a:xfrm>
+              <a:off x="7318998" y="2501521"/>
+              <a:ext cx="1" cy="466004"/>
+            </a:xfrm>
+            <a:prstGeom prst="straightConnector1">
+              <a:avLst/>
+            </a:prstGeom>
+            <a:ln w="38100">
+              <a:solidFill>
+                <a:schemeClr val="tx1"/>
+              </a:solidFill>
+              <a:tailEnd type="triangle"/>
+            </a:ln>
+          </p:spPr>
+          <p:style>
+            <a:lnRef idx="1">
+              <a:schemeClr val="accent1"/>
+            </a:lnRef>
+            <a:fillRef idx="0">
+              <a:schemeClr val="accent1"/>
+            </a:fillRef>
+            <a:effectRef idx="0">
+              <a:schemeClr val="accent1"/>
+            </a:effectRef>
+            <a:fontRef idx="minor">
+              <a:schemeClr val="tx1"/>
+            </a:fontRef>
+          </p:style>
+        </p:cxnSp>
+      </p:grpSp>
     </p:spTree>
     <p:extLst>
       <p:ext uri="{BB962C8B-B14F-4D97-AF65-F5344CB8AC3E}">

</xml_diff>

<commit_message>
Add Ch06 illustration figure
</commit_message>
<xml_diff>
--- a/figures/figures.pptx
+++ b/figures/figures.pptx
@@ -5,7 +5,7 @@
     <p:sldMasterId id="2147483660" r:id="rId1"/>
   </p:sldMasterIdLst>
   <p:notesMasterIdLst>
-    <p:notesMasterId r:id="rId24"/>
+    <p:notesMasterId r:id="rId25"/>
   </p:notesMasterIdLst>
   <p:sldIdLst>
     <p:sldId id="258" r:id="rId2"/>
@@ -23,13 +23,14 @@
     <p:sldId id="264" r:id="rId14"/>
     <p:sldId id="265" r:id="rId15"/>
     <p:sldId id="267" r:id="rId16"/>
-    <p:sldId id="269" r:id="rId17"/>
-    <p:sldId id="274" r:id="rId18"/>
-    <p:sldId id="270" r:id="rId19"/>
-    <p:sldId id="271" r:id="rId20"/>
-    <p:sldId id="272" r:id="rId21"/>
-    <p:sldId id="273" r:id="rId22"/>
-    <p:sldId id="257" r:id="rId23"/>
+    <p:sldId id="280" r:id="rId17"/>
+    <p:sldId id="271" r:id="rId18"/>
+    <p:sldId id="272" r:id="rId19"/>
+    <p:sldId id="273" r:id="rId20"/>
+    <p:sldId id="269" r:id="rId21"/>
+    <p:sldId id="274" r:id="rId22"/>
+    <p:sldId id="270" r:id="rId23"/>
+    <p:sldId id="257" r:id="rId24"/>
   </p:sldIdLst>
   <p:sldSz cx="12192000" cy="6858000"/>
   <p:notesSz cx="6858000" cy="9144000"/>
@@ -170,11 +171,9 @@
             <p14:sldId id="267"/>
           </p14:sldIdLst>
         </p14:section>
-        <p14:section name="Governance" id="{038CE4AA-62CD-47A2-8E40-F6F0DFCCB854}">
+        <p14:section name="Workflows" id="{F124E500-37B7-4919-B26F-2DBCF3957E81}">
           <p14:sldIdLst>
-            <p14:sldId id="269"/>
-            <p14:sldId id="274"/>
-            <p14:sldId id="270"/>
+            <p14:sldId id="280"/>
           </p14:sldIdLst>
         </p14:section>
         <p14:section name="Edge Deployment" id="{751363D7-BD1F-4E68-8906-25A659F6AF95}">
@@ -182,6 +181,13 @@
             <p14:sldId id="271"/>
             <p14:sldId id="272"/>
             <p14:sldId id="273"/>
+          </p14:sldIdLst>
+        </p14:section>
+        <p14:section name="Governance" id="{038CE4AA-62CD-47A2-8E40-F6F0DFCCB854}">
+          <p14:sldIdLst>
+            <p14:sldId id="269"/>
+            <p14:sldId id="274"/>
+            <p14:sldId id="270"/>
           </p14:sldIdLst>
         </p14:section>
         <p14:section name="Examples" id="{2CEADF37-2C1D-4DE6-BB08-5D838E707A13}">
@@ -280,7 +286,7 @@
           <a:p>
             <a:fld id="{DAABB0E5-6D8D-4DEE-B75F-67010CF2307C}" type="datetimeFigureOut">
               <a:rPr lang="en-US" smtClean="0"/>
-              <a:t>4/5/2026</a:t>
+              <a:t>4/11/2026</a:t>
             </a:fld>
             <a:endParaRPr lang="en-US"/>
           </a:p>
@@ -965,7 +971,7 @@
           <a:p>
             <a:fld id="{B84C5C40-2055-49AF-9028-5DA79E75E391}" type="datetimeFigureOut">
               <a:rPr lang="en-US" smtClean="0"/>
-              <a:t>4/5/2026</a:t>
+              <a:t>4/11/2026</a:t>
             </a:fld>
             <a:endParaRPr lang="en-US"/>
           </a:p>
@@ -1135,7 +1141,7 @@
           <a:p>
             <a:fld id="{B84C5C40-2055-49AF-9028-5DA79E75E391}" type="datetimeFigureOut">
               <a:rPr lang="en-US" smtClean="0"/>
-              <a:t>4/5/2026</a:t>
+              <a:t>4/11/2026</a:t>
             </a:fld>
             <a:endParaRPr lang="en-US"/>
           </a:p>
@@ -1315,7 +1321,7 @@
           <a:p>
             <a:fld id="{B84C5C40-2055-49AF-9028-5DA79E75E391}" type="datetimeFigureOut">
               <a:rPr lang="en-US" smtClean="0"/>
-              <a:t>4/5/2026</a:t>
+              <a:t>4/11/2026</a:t>
             </a:fld>
             <a:endParaRPr lang="en-US"/>
           </a:p>
@@ -1485,7 +1491,7 @@
           <a:p>
             <a:fld id="{B84C5C40-2055-49AF-9028-5DA79E75E391}" type="datetimeFigureOut">
               <a:rPr lang="en-US" smtClean="0"/>
-              <a:t>4/5/2026</a:t>
+              <a:t>4/11/2026</a:t>
             </a:fld>
             <a:endParaRPr lang="en-US"/>
           </a:p>
@@ -1731,7 +1737,7 @@
           <a:p>
             <a:fld id="{B84C5C40-2055-49AF-9028-5DA79E75E391}" type="datetimeFigureOut">
               <a:rPr lang="en-US" smtClean="0"/>
-              <a:t>4/5/2026</a:t>
+              <a:t>4/11/2026</a:t>
             </a:fld>
             <a:endParaRPr lang="en-US"/>
           </a:p>
@@ -1963,7 +1969,7 @@
           <a:p>
             <a:fld id="{B84C5C40-2055-49AF-9028-5DA79E75E391}" type="datetimeFigureOut">
               <a:rPr lang="en-US" smtClean="0"/>
-              <a:t>4/5/2026</a:t>
+              <a:t>4/11/2026</a:t>
             </a:fld>
             <a:endParaRPr lang="en-US"/>
           </a:p>
@@ -2330,7 +2336,7 @@
           <a:p>
             <a:fld id="{B84C5C40-2055-49AF-9028-5DA79E75E391}" type="datetimeFigureOut">
               <a:rPr lang="en-US" smtClean="0"/>
-              <a:t>4/5/2026</a:t>
+              <a:t>4/11/2026</a:t>
             </a:fld>
             <a:endParaRPr lang="en-US"/>
           </a:p>
@@ -2448,7 +2454,7 @@
           <a:p>
             <a:fld id="{B84C5C40-2055-49AF-9028-5DA79E75E391}" type="datetimeFigureOut">
               <a:rPr lang="en-US" smtClean="0"/>
-              <a:t>4/5/2026</a:t>
+              <a:t>4/11/2026</a:t>
             </a:fld>
             <a:endParaRPr lang="en-US"/>
           </a:p>
@@ -2543,7 +2549,7 @@
           <a:p>
             <a:fld id="{B84C5C40-2055-49AF-9028-5DA79E75E391}" type="datetimeFigureOut">
               <a:rPr lang="en-US" smtClean="0"/>
-              <a:t>4/5/2026</a:t>
+              <a:t>4/11/2026</a:t>
             </a:fld>
             <a:endParaRPr lang="en-US"/>
           </a:p>
@@ -2820,7 +2826,7 @@
           <a:p>
             <a:fld id="{B84C5C40-2055-49AF-9028-5DA79E75E391}" type="datetimeFigureOut">
               <a:rPr lang="en-US" smtClean="0"/>
-              <a:t>4/5/2026</a:t>
+              <a:t>4/11/2026</a:t>
             </a:fld>
             <a:endParaRPr lang="en-US"/>
           </a:p>
@@ -3077,7 +3083,7 @@
           <a:p>
             <a:fld id="{B84C5C40-2055-49AF-9028-5DA79E75E391}" type="datetimeFigureOut">
               <a:rPr lang="en-US" smtClean="0"/>
-              <a:t>4/5/2026</a:t>
+              <a:t>4/11/2026</a:t>
             </a:fld>
             <a:endParaRPr lang="en-US"/>
           </a:p>
@@ -3290,7 +3296,7 @@
           <a:p>
             <a:fld id="{B84C5C40-2055-49AF-9028-5DA79E75E391}" type="datetimeFigureOut">
               <a:rPr lang="en-US" smtClean="0"/>
-              <a:t>4/5/2026</a:t>
+              <a:t>4/11/2026</a:t>
             </a:fld>
             <a:endParaRPr lang="en-US"/>
           </a:p>
@@ -8642,12 +8648,832 @@
           <a:chExt cx="0" cy="0"/>
         </a:xfrm>
       </p:grpSpPr>
+      <p:sp>
+        <p:nvSpPr>
+          <p:cNvPr id="2" name="Rectangle: Rounded Corners 1">
+            <a:extLst>
+              <a:ext uri="{FF2B5EF4-FFF2-40B4-BE49-F238E27FC236}">
+                <a16:creationId xmlns:a16="http://schemas.microsoft.com/office/drawing/2014/main" id="{08AFB654-7A06-C3A4-7E7E-0CD359D6C0E5}"/>
+              </a:ext>
+            </a:extLst>
+          </p:cNvPr>
+          <p:cNvSpPr/>
+          <p:nvPr/>
+        </p:nvSpPr>
+        <p:spPr>
+          <a:xfrm>
+            <a:off x="1293967" y="880545"/>
+            <a:ext cx="2580925" cy="369332"/>
+          </a:xfrm>
+          <a:prstGeom prst="roundRect">
+            <a:avLst/>
+          </a:prstGeom>
+          <a:solidFill>
+            <a:srgbClr val="B2D4EB"/>
+          </a:solidFill>
+          <a:ln>
+            <a:solidFill>
+              <a:schemeClr val="tx1"/>
+            </a:solidFill>
+          </a:ln>
+        </p:spPr>
+        <p:style>
+          <a:lnRef idx="2">
+            <a:schemeClr val="accent1">
+              <a:shade val="15000"/>
+            </a:schemeClr>
+          </a:lnRef>
+          <a:fillRef idx="1">
+            <a:schemeClr val="accent1"/>
+          </a:fillRef>
+          <a:effectRef idx="0">
+            <a:schemeClr val="accent1"/>
+          </a:effectRef>
+          <a:fontRef idx="minor">
+            <a:schemeClr val="lt1"/>
+          </a:fontRef>
+        </p:style>
+        <p:txBody>
+          <a:bodyPr rtlCol="0" anchor="ctr"/>
+          <a:lstStyle/>
+          <a:p>
+            <a:pPr algn="ctr"/>
+            <a:r>
+              <a:rPr lang="en-US" dirty="0">
+                <a:solidFill>
+                  <a:schemeClr val="tx1"/>
+                </a:solidFill>
+              </a:rPr>
+              <a:t>User Input</a:t>
+            </a:r>
+            <a:endParaRPr lang="en-US" i="1" dirty="0">
+              <a:solidFill>
+                <a:schemeClr val="tx1"/>
+              </a:solidFill>
+            </a:endParaRPr>
+          </a:p>
+        </p:txBody>
+      </p:sp>
+      <p:sp>
+        <p:nvSpPr>
+          <p:cNvPr id="3" name="Rectangle: Rounded Corners 2">
+            <a:extLst>
+              <a:ext uri="{FF2B5EF4-FFF2-40B4-BE49-F238E27FC236}">
+                <a16:creationId xmlns:a16="http://schemas.microsoft.com/office/drawing/2014/main" id="{E86E8FED-E7D9-C8F7-A2EF-4BE21234B54B}"/>
+              </a:ext>
+            </a:extLst>
+          </p:cNvPr>
+          <p:cNvSpPr/>
+          <p:nvPr/>
+        </p:nvSpPr>
+        <p:spPr>
+          <a:xfrm>
+            <a:off x="1293967" y="5160997"/>
+            <a:ext cx="2580925" cy="369332"/>
+          </a:xfrm>
+          <a:prstGeom prst="roundRect">
+            <a:avLst/>
+          </a:prstGeom>
+          <a:solidFill>
+            <a:srgbClr val="B2D4EB"/>
+          </a:solidFill>
+          <a:ln>
+            <a:solidFill>
+              <a:schemeClr val="tx1"/>
+            </a:solidFill>
+          </a:ln>
+        </p:spPr>
+        <p:style>
+          <a:lnRef idx="2">
+            <a:schemeClr val="accent1">
+              <a:shade val="15000"/>
+            </a:schemeClr>
+          </a:lnRef>
+          <a:fillRef idx="1">
+            <a:schemeClr val="accent1"/>
+          </a:fillRef>
+          <a:effectRef idx="0">
+            <a:schemeClr val="accent1"/>
+          </a:effectRef>
+          <a:fontRef idx="minor">
+            <a:schemeClr val="lt1"/>
+          </a:fontRef>
+        </p:style>
+        <p:txBody>
+          <a:bodyPr rtlCol="0" anchor="ctr"/>
+          <a:lstStyle/>
+          <a:p>
+            <a:pPr algn="ctr"/>
+            <a:r>
+              <a:rPr lang="en-US" dirty="0">
+                <a:solidFill>
+                  <a:schemeClr val="tx1"/>
+                </a:solidFill>
+              </a:rPr>
+              <a:t>Output</a:t>
+            </a:r>
+            <a:endParaRPr lang="en-US" i="1" dirty="0">
+              <a:solidFill>
+                <a:schemeClr val="tx1"/>
+              </a:solidFill>
+            </a:endParaRPr>
+          </a:p>
+        </p:txBody>
+      </p:sp>
+      <p:sp>
+        <p:nvSpPr>
+          <p:cNvPr id="4" name="Rectangle: Rounded Corners 3">
+            <a:extLst>
+              <a:ext uri="{FF2B5EF4-FFF2-40B4-BE49-F238E27FC236}">
+                <a16:creationId xmlns:a16="http://schemas.microsoft.com/office/drawing/2014/main" id="{77C06C5B-8FC5-D569-2AE0-03636CF0CCD1}"/>
+              </a:ext>
+            </a:extLst>
+          </p:cNvPr>
+          <p:cNvSpPr/>
+          <p:nvPr/>
+        </p:nvSpPr>
+        <p:spPr>
+          <a:xfrm>
+            <a:off x="4805537" y="5160997"/>
+            <a:ext cx="2580925" cy="369332"/>
+          </a:xfrm>
+          <a:prstGeom prst="roundRect">
+            <a:avLst/>
+          </a:prstGeom>
+          <a:solidFill>
+            <a:srgbClr val="B2D4EB"/>
+          </a:solidFill>
+          <a:ln>
+            <a:solidFill>
+              <a:schemeClr val="tx1"/>
+            </a:solidFill>
+          </a:ln>
+        </p:spPr>
+        <p:style>
+          <a:lnRef idx="2">
+            <a:schemeClr val="accent1">
+              <a:shade val="15000"/>
+            </a:schemeClr>
+          </a:lnRef>
+          <a:fillRef idx="1">
+            <a:schemeClr val="accent1"/>
+          </a:fillRef>
+          <a:effectRef idx="0">
+            <a:schemeClr val="accent1"/>
+          </a:effectRef>
+          <a:fontRef idx="minor">
+            <a:schemeClr val="lt1"/>
+          </a:fontRef>
+        </p:style>
+        <p:txBody>
+          <a:bodyPr rtlCol="0" anchor="ctr"/>
+          <a:lstStyle/>
+          <a:p>
+            <a:pPr algn="ctr"/>
+            <a:r>
+              <a:rPr lang="en-US" dirty="0">
+                <a:solidFill>
+                  <a:schemeClr val="tx1"/>
+                </a:solidFill>
+              </a:rPr>
+              <a:t>Output</a:t>
+            </a:r>
+            <a:endParaRPr lang="en-US" i="1" dirty="0">
+              <a:solidFill>
+                <a:schemeClr val="tx1"/>
+              </a:solidFill>
+            </a:endParaRPr>
+          </a:p>
+        </p:txBody>
+      </p:sp>
+      <p:sp>
+        <p:nvSpPr>
+          <p:cNvPr id="5" name="Rectangle: Rounded Corners 4">
+            <a:extLst>
+              <a:ext uri="{FF2B5EF4-FFF2-40B4-BE49-F238E27FC236}">
+                <a16:creationId xmlns:a16="http://schemas.microsoft.com/office/drawing/2014/main" id="{44341166-D50F-198F-0E6D-17DCEC0EA317}"/>
+              </a:ext>
+            </a:extLst>
+          </p:cNvPr>
+          <p:cNvSpPr/>
+          <p:nvPr/>
+        </p:nvSpPr>
+        <p:spPr>
+          <a:xfrm>
+            <a:off x="4805536" y="880545"/>
+            <a:ext cx="2580925" cy="369332"/>
+          </a:xfrm>
+          <a:prstGeom prst="roundRect">
+            <a:avLst/>
+          </a:prstGeom>
+          <a:solidFill>
+            <a:srgbClr val="B2D4EB"/>
+          </a:solidFill>
+          <a:ln>
+            <a:solidFill>
+              <a:schemeClr val="tx1"/>
+            </a:solidFill>
+          </a:ln>
+        </p:spPr>
+        <p:style>
+          <a:lnRef idx="2">
+            <a:schemeClr val="accent1">
+              <a:shade val="15000"/>
+            </a:schemeClr>
+          </a:lnRef>
+          <a:fillRef idx="1">
+            <a:schemeClr val="accent1"/>
+          </a:fillRef>
+          <a:effectRef idx="0">
+            <a:schemeClr val="accent1"/>
+          </a:effectRef>
+          <a:fontRef idx="minor">
+            <a:schemeClr val="lt1"/>
+          </a:fontRef>
+        </p:style>
+        <p:txBody>
+          <a:bodyPr rtlCol="0" anchor="ctr"/>
+          <a:lstStyle/>
+          <a:p>
+            <a:pPr algn="ctr"/>
+            <a:r>
+              <a:rPr lang="en-US" dirty="0">
+                <a:solidFill>
+                  <a:schemeClr val="tx1"/>
+                </a:solidFill>
+              </a:rPr>
+              <a:t>User Input</a:t>
+            </a:r>
+            <a:endParaRPr lang="en-US" i="1" dirty="0">
+              <a:solidFill>
+                <a:schemeClr val="tx1"/>
+              </a:solidFill>
+            </a:endParaRPr>
+          </a:p>
+        </p:txBody>
+      </p:sp>
+      <p:sp>
+        <p:nvSpPr>
+          <p:cNvPr id="6" name="Rectangle: Rounded Corners 5">
+            <a:extLst>
+              <a:ext uri="{FF2B5EF4-FFF2-40B4-BE49-F238E27FC236}">
+                <a16:creationId xmlns:a16="http://schemas.microsoft.com/office/drawing/2014/main" id="{782E7744-3205-3D14-6BE9-883217B14999}"/>
+              </a:ext>
+            </a:extLst>
+          </p:cNvPr>
+          <p:cNvSpPr/>
+          <p:nvPr/>
+        </p:nvSpPr>
+        <p:spPr>
+          <a:xfrm>
+            <a:off x="8317108" y="878092"/>
+            <a:ext cx="2580925" cy="369332"/>
+          </a:xfrm>
+          <a:prstGeom prst="roundRect">
+            <a:avLst/>
+          </a:prstGeom>
+          <a:solidFill>
+            <a:srgbClr val="B2D4EB"/>
+          </a:solidFill>
+          <a:ln>
+            <a:solidFill>
+              <a:schemeClr val="tx1"/>
+            </a:solidFill>
+          </a:ln>
+        </p:spPr>
+        <p:style>
+          <a:lnRef idx="2">
+            <a:schemeClr val="accent1">
+              <a:shade val="15000"/>
+            </a:schemeClr>
+          </a:lnRef>
+          <a:fillRef idx="1">
+            <a:schemeClr val="accent1"/>
+          </a:fillRef>
+          <a:effectRef idx="0">
+            <a:schemeClr val="accent1"/>
+          </a:effectRef>
+          <a:fontRef idx="minor">
+            <a:schemeClr val="lt1"/>
+          </a:fontRef>
+        </p:style>
+        <p:txBody>
+          <a:bodyPr rtlCol="0" anchor="ctr"/>
+          <a:lstStyle/>
+          <a:p>
+            <a:pPr algn="ctr"/>
+            <a:r>
+              <a:rPr lang="en-US" dirty="0">
+                <a:solidFill>
+                  <a:schemeClr val="tx1"/>
+                </a:solidFill>
+              </a:rPr>
+              <a:t>User Input</a:t>
+            </a:r>
+            <a:endParaRPr lang="en-US" i="1" dirty="0">
+              <a:solidFill>
+                <a:schemeClr val="tx1"/>
+              </a:solidFill>
+            </a:endParaRPr>
+          </a:p>
+        </p:txBody>
+      </p:sp>
+      <p:sp>
+        <p:nvSpPr>
+          <p:cNvPr id="7" name="Rectangle: Rounded Corners 6">
+            <a:extLst>
+              <a:ext uri="{FF2B5EF4-FFF2-40B4-BE49-F238E27FC236}">
+                <a16:creationId xmlns:a16="http://schemas.microsoft.com/office/drawing/2014/main" id="{27A39C3D-9111-F29C-AB9D-1E650F4C0C60}"/>
+              </a:ext>
+            </a:extLst>
+          </p:cNvPr>
+          <p:cNvSpPr/>
+          <p:nvPr/>
+        </p:nvSpPr>
+        <p:spPr>
+          <a:xfrm>
+            <a:off x="8317108" y="5160997"/>
+            <a:ext cx="2580925" cy="369332"/>
+          </a:xfrm>
+          <a:prstGeom prst="roundRect">
+            <a:avLst/>
+          </a:prstGeom>
+          <a:solidFill>
+            <a:srgbClr val="B2D4EB"/>
+          </a:solidFill>
+          <a:ln>
+            <a:solidFill>
+              <a:schemeClr val="tx1"/>
+            </a:solidFill>
+          </a:ln>
+        </p:spPr>
+        <p:style>
+          <a:lnRef idx="2">
+            <a:schemeClr val="accent1">
+              <a:shade val="15000"/>
+            </a:schemeClr>
+          </a:lnRef>
+          <a:fillRef idx="1">
+            <a:schemeClr val="accent1"/>
+          </a:fillRef>
+          <a:effectRef idx="0">
+            <a:schemeClr val="accent1"/>
+          </a:effectRef>
+          <a:fontRef idx="minor">
+            <a:schemeClr val="lt1"/>
+          </a:fontRef>
+        </p:style>
+        <p:txBody>
+          <a:bodyPr rtlCol="0" anchor="ctr"/>
+          <a:lstStyle/>
+          <a:p>
+            <a:pPr algn="ctr"/>
+            <a:r>
+              <a:rPr lang="en-US" dirty="0">
+                <a:solidFill>
+                  <a:schemeClr val="tx1"/>
+                </a:solidFill>
+              </a:rPr>
+              <a:t>Output</a:t>
+            </a:r>
+            <a:endParaRPr lang="en-US" i="1" dirty="0">
+              <a:solidFill>
+                <a:schemeClr val="tx1"/>
+              </a:solidFill>
+            </a:endParaRPr>
+          </a:p>
+        </p:txBody>
+      </p:sp>
+      <p:sp>
+        <p:nvSpPr>
+          <p:cNvPr id="8" name="TextBox 7">
+            <a:extLst>
+              <a:ext uri="{FF2B5EF4-FFF2-40B4-BE49-F238E27FC236}">
+                <a16:creationId xmlns:a16="http://schemas.microsoft.com/office/drawing/2014/main" id="{5D035EDB-7D42-FD80-A64D-1B444CF1F6E4}"/>
+              </a:ext>
+            </a:extLst>
+          </p:cNvPr>
+          <p:cNvSpPr txBox="1"/>
+          <p:nvPr/>
+        </p:nvSpPr>
+        <p:spPr>
+          <a:xfrm>
+            <a:off x="2059509" y="397565"/>
+            <a:ext cx="1049839" cy="369332"/>
+          </a:xfrm>
+          <a:prstGeom prst="rect">
+            <a:avLst/>
+          </a:prstGeom>
+          <a:noFill/>
+        </p:spPr>
+        <p:txBody>
+          <a:bodyPr wrap="none" rtlCol="0">
+            <a:spAutoFit/>
+          </a:bodyPr>
+          <a:lstStyle/>
+          <a:p>
+            <a:pPr algn="ctr"/>
+            <a:r>
+              <a:rPr lang="en-US" dirty="0"/>
+              <a:t>Sequential</a:t>
+            </a:r>
+          </a:p>
+        </p:txBody>
+      </p:sp>
+      <p:sp>
+        <p:nvSpPr>
+          <p:cNvPr id="9" name="TextBox 8">
+            <a:extLst>
+              <a:ext uri="{FF2B5EF4-FFF2-40B4-BE49-F238E27FC236}">
+                <a16:creationId xmlns:a16="http://schemas.microsoft.com/office/drawing/2014/main" id="{0DCBC3F8-8300-3DAD-0BC5-425AB5841CE3}"/>
+              </a:ext>
+            </a:extLst>
+          </p:cNvPr>
+          <p:cNvSpPr txBox="1"/>
+          <p:nvPr/>
+        </p:nvSpPr>
+        <p:spPr>
+          <a:xfrm>
+            <a:off x="9054373" y="397565"/>
+            <a:ext cx="1106393" cy="369332"/>
+          </a:xfrm>
+          <a:prstGeom prst="rect">
+            <a:avLst/>
+          </a:prstGeom>
+          <a:noFill/>
+        </p:spPr>
+        <p:txBody>
+          <a:bodyPr wrap="none" rtlCol="0">
+            <a:spAutoFit/>
+          </a:bodyPr>
+          <a:lstStyle/>
+          <a:p>
+            <a:pPr algn="ctr"/>
+            <a:r>
+              <a:rPr lang="en-US" dirty="0"/>
+              <a:t>Group Chat</a:t>
+            </a:r>
+          </a:p>
+        </p:txBody>
+      </p:sp>
+      <p:sp>
+        <p:nvSpPr>
+          <p:cNvPr id="10" name="TextBox 9">
+            <a:extLst>
+              <a:ext uri="{FF2B5EF4-FFF2-40B4-BE49-F238E27FC236}">
+                <a16:creationId xmlns:a16="http://schemas.microsoft.com/office/drawing/2014/main" id="{8D0CDE82-B9BA-575A-4838-57123640C602}"/>
+              </a:ext>
+            </a:extLst>
+          </p:cNvPr>
+          <p:cNvSpPr txBox="1"/>
+          <p:nvPr/>
+        </p:nvSpPr>
+        <p:spPr>
+          <a:xfrm>
+            <a:off x="5386865" y="397565"/>
+            <a:ext cx="1418273" cy="369332"/>
+          </a:xfrm>
+          <a:prstGeom prst="rect">
+            <a:avLst/>
+          </a:prstGeom>
+          <a:noFill/>
+        </p:spPr>
+        <p:txBody>
+          <a:bodyPr wrap="none" rtlCol="0">
+            <a:spAutoFit/>
+          </a:bodyPr>
+          <a:lstStyle/>
+          <a:p>
+            <a:pPr algn="ctr"/>
+            <a:r>
+              <a:rPr lang="en-US" dirty="0"/>
+              <a:t>Human in Loop</a:t>
+            </a:r>
+          </a:p>
+        </p:txBody>
+      </p:sp>
+      <p:sp>
+        <p:nvSpPr>
+          <p:cNvPr id="11" name="Rectangle: Rounded Corners 10">
+            <a:extLst>
+              <a:ext uri="{FF2B5EF4-FFF2-40B4-BE49-F238E27FC236}">
+                <a16:creationId xmlns:a16="http://schemas.microsoft.com/office/drawing/2014/main" id="{03C72ADD-5624-A5AF-C90C-8D288A445042}"/>
+              </a:ext>
+            </a:extLst>
+          </p:cNvPr>
+          <p:cNvSpPr/>
+          <p:nvPr/>
+        </p:nvSpPr>
+        <p:spPr>
+          <a:xfrm>
+            <a:off x="1907431" y="1577486"/>
+            <a:ext cx="1344168" cy="866894"/>
+          </a:xfrm>
+          <a:prstGeom prst="roundRect">
+            <a:avLst/>
+          </a:prstGeom>
+          <a:solidFill>
+            <a:srgbClr val="E5F1F8"/>
+          </a:solidFill>
+          <a:ln>
+            <a:solidFill>
+              <a:schemeClr val="tx1"/>
+            </a:solidFill>
+          </a:ln>
+        </p:spPr>
+        <p:style>
+          <a:lnRef idx="2">
+            <a:schemeClr val="accent1">
+              <a:shade val="15000"/>
+            </a:schemeClr>
+          </a:lnRef>
+          <a:fillRef idx="1">
+            <a:schemeClr val="accent1"/>
+          </a:fillRef>
+          <a:effectRef idx="0">
+            <a:schemeClr val="accent1"/>
+          </a:effectRef>
+          <a:fontRef idx="minor">
+            <a:schemeClr val="lt1"/>
+          </a:fontRef>
+        </p:style>
+        <p:txBody>
+          <a:bodyPr rtlCol="0" anchor="ctr"/>
+          <a:lstStyle/>
+          <a:p>
+            <a:pPr algn="ctr"/>
+            <a:r>
+              <a:rPr lang="en-US" dirty="0">
+                <a:solidFill>
+                  <a:schemeClr val="tx1"/>
+                </a:solidFill>
+              </a:rPr>
+              <a:t>Agent 1</a:t>
+            </a:r>
+          </a:p>
+        </p:txBody>
+      </p:sp>
+      <p:sp>
+        <p:nvSpPr>
+          <p:cNvPr id="12" name="Rectangle: Rounded Corners 11">
+            <a:extLst>
+              <a:ext uri="{FF2B5EF4-FFF2-40B4-BE49-F238E27FC236}">
+                <a16:creationId xmlns:a16="http://schemas.microsoft.com/office/drawing/2014/main" id="{00E24462-6792-9F65-B196-3AAC33E7B93E}"/>
+              </a:ext>
+            </a:extLst>
+          </p:cNvPr>
+          <p:cNvSpPr/>
+          <p:nvPr/>
+        </p:nvSpPr>
+        <p:spPr>
+          <a:xfrm>
+            <a:off x="1907431" y="3966493"/>
+            <a:ext cx="1344168" cy="866894"/>
+          </a:xfrm>
+          <a:prstGeom prst="roundRect">
+            <a:avLst/>
+          </a:prstGeom>
+          <a:solidFill>
+            <a:srgbClr val="E5F1F8"/>
+          </a:solidFill>
+          <a:ln>
+            <a:solidFill>
+              <a:schemeClr val="tx1"/>
+            </a:solidFill>
+          </a:ln>
+        </p:spPr>
+        <p:style>
+          <a:lnRef idx="2">
+            <a:schemeClr val="accent1">
+              <a:shade val="15000"/>
+            </a:schemeClr>
+          </a:lnRef>
+          <a:fillRef idx="1">
+            <a:schemeClr val="accent1"/>
+          </a:fillRef>
+          <a:effectRef idx="0">
+            <a:schemeClr val="accent1"/>
+          </a:effectRef>
+          <a:fontRef idx="minor">
+            <a:schemeClr val="lt1"/>
+          </a:fontRef>
+        </p:style>
+        <p:txBody>
+          <a:bodyPr rtlCol="0" anchor="ctr"/>
+          <a:lstStyle/>
+          <a:p>
+            <a:pPr algn="ctr"/>
+            <a:r>
+              <a:rPr lang="en-US" dirty="0">
+                <a:solidFill>
+                  <a:schemeClr val="tx1"/>
+                </a:solidFill>
+              </a:rPr>
+              <a:t>Agent 3</a:t>
+            </a:r>
+          </a:p>
+        </p:txBody>
+      </p:sp>
+      <p:sp>
+        <p:nvSpPr>
+          <p:cNvPr id="13" name="Rectangle: Rounded Corners 12">
+            <a:extLst>
+              <a:ext uri="{FF2B5EF4-FFF2-40B4-BE49-F238E27FC236}">
+                <a16:creationId xmlns:a16="http://schemas.microsoft.com/office/drawing/2014/main" id="{127113AE-C3C2-85C7-0E3A-0BAF3433488F}"/>
+              </a:ext>
+            </a:extLst>
+          </p:cNvPr>
+          <p:cNvSpPr/>
+          <p:nvPr/>
+        </p:nvSpPr>
+        <p:spPr>
+          <a:xfrm>
+            <a:off x="1907431" y="2771990"/>
+            <a:ext cx="1344168" cy="866894"/>
+          </a:xfrm>
+          <a:prstGeom prst="roundRect">
+            <a:avLst/>
+          </a:prstGeom>
+          <a:solidFill>
+            <a:srgbClr val="E5F1F8"/>
+          </a:solidFill>
+          <a:ln>
+            <a:solidFill>
+              <a:schemeClr val="tx1"/>
+            </a:solidFill>
+          </a:ln>
+        </p:spPr>
+        <p:style>
+          <a:lnRef idx="2">
+            <a:schemeClr val="accent1">
+              <a:shade val="15000"/>
+            </a:schemeClr>
+          </a:lnRef>
+          <a:fillRef idx="1">
+            <a:schemeClr val="accent1"/>
+          </a:fillRef>
+          <a:effectRef idx="0">
+            <a:schemeClr val="accent1"/>
+          </a:effectRef>
+          <a:fontRef idx="minor">
+            <a:schemeClr val="lt1"/>
+          </a:fontRef>
+        </p:style>
+        <p:txBody>
+          <a:bodyPr rtlCol="0" anchor="ctr"/>
+          <a:lstStyle/>
+          <a:p>
+            <a:pPr algn="ctr"/>
+            <a:r>
+              <a:rPr lang="en-US" dirty="0">
+                <a:solidFill>
+                  <a:schemeClr val="tx1"/>
+                </a:solidFill>
+              </a:rPr>
+              <a:t>Agent 2</a:t>
+            </a:r>
+          </a:p>
+        </p:txBody>
+      </p:sp>
+      <p:sp>
+        <p:nvSpPr>
+          <p:cNvPr id="14" name="Rectangle: Rounded Corners 13">
+            <a:extLst>
+              <a:ext uri="{FF2B5EF4-FFF2-40B4-BE49-F238E27FC236}">
+                <a16:creationId xmlns:a16="http://schemas.microsoft.com/office/drawing/2014/main" id="{50CB94AA-C467-6DED-59A5-34F72F9BE893}"/>
+              </a:ext>
+            </a:extLst>
+          </p:cNvPr>
+          <p:cNvSpPr/>
+          <p:nvPr/>
+        </p:nvSpPr>
+        <p:spPr>
+          <a:xfrm>
+            <a:off x="8935485" y="1577486"/>
+            <a:ext cx="1344168" cy="866894"/>
+          </a:xfrm>
+          <a:prstGeom prst="roundRect">
+            <a:avLst/>
+          </a:prstGeom>
+          <a:solidFill>
+            <a:srgbClr val="E5F1F8"/>
+          </a:solidFill>
+          <a:ln>
+            <a:solidFill>
+              <a:schemeClr val="tx1"/>
+            </a:solidFill>
+          </a:ln>
+        </p:spPr>
+        <p:style>
+          <a:lnRef idx="2">
+            <a:schemeClr val="accent1">
+              <a:shade val="15000"/>
+            </a:schemeClr>
+          </a:lnRef>
+          <a:fillRef idx="1">
+            <a:schemeClr val="accent1"/>
+          </a:fillRef>
+          <a:effectRef idx="0">
+            <a:schemeClr val="accent1"/>
+          </a:effectRef>
+          <a:fontRef idx="minor">
+            <a:schemeClr val="lt1"/>
+          </a:fontRef>
+        </p:style>
+        <p:txBody>
+          <a:bodyPr rtlCol="0" anchor="ctr"/>
+          <a:lstStyle/>
+          <a:p>
+            <a:pPr algn="ctr"/>
+            <a:r>
+              <a:rPr lang="en-US" dirty="0">
+                <a:solidFill>
+                  <a:schemeClr val="tx1"/>
+                </a:solidFill>
+              </a:rPr>
+              <a:t>Orchestrator</a:t>
+            </a:r>
+          </a:p>
+          <a:p>
+            <a:pPr algn="ctr"/>
+            <a:r>
+              <a:rPr lang="en-US" sz="1200" dirty="0">
+                <a:solidFill>
+                  <a:schemeClr val="tx1"/>
+                </a:solidFill>
+              </a:rPr>
+              <a:t>(Route by Context)</a:t>
+            </a:r>
+          </a:p>
+        </p:txBody>
+      </p:sp>
+      <p:sp>
+        <p:nvSpPr>
+          <p:cNvPr id="16" name="Rectangle: Rounded Corners 15">
+            <a:extLst>
+              <a:ext uri="{FF2B5EF4-FFF2-40B4-BE49-F238E27FC236}">
+                <a16:creationId xmlns:a16="http://schemas.microsoft.com/office/drawing/2014/main" id="{A6050253-1AB3-63EB-84EB-ACEE2400BBF8}"/>
+              </a:ext>
+            </a:extLst>
+          </p:cNvPr>
+          <p:cNvSpPr/>
+          <p:nvPr/>
+        </p:nvSpPr>
+        <p:spPr>
+          <a:xfrm>
+            <a:off x="5421458" y="1577486"/>
+            <a:ext cx="1344168" cy="866894"/>
+          </a:xfrm>
+          <a:prstGeom prst="roundRect">
+            <a:avLst/>
+          </a:prstGeom>
+          <a:solidFill>
+            <a:srgbClr val="E5F1F8"/>
+          </a:solidFill>
+          <a:ln>
+            <a:solidFill>
+              <a:schemeClr val="tx1"/>
+            </a:solidFill>
+          </a:ln>
+        </p:spPr>
+        <p:style>
+          <a:lnRef idx="2">
+            <a:schemeClr val="accent1">
+              <a:shade val="15000"/>
+            </a:schemeClr>
+          </a:lnRef>
+          <a:fillRef idx="1">
+            <a:schemeClr val="accent1"/>
+          </a:fillRef>
+          <a:effectRef idx="0">
+            <a:schemeClr val="accent1"/>
+          </a:effectRef>
+          <a:fontRef idx="minor">
+            <a:schemeClr val="lt1"/>
+          </a:fontRef>
+        </p:style>
+        <p:txBody>
+          <a:bodyPr rtlCol="0" anchor="ctr"/>
+          <a:lstStyle/>
+          <a:p>
+            <a:pPr algn="ctr"/>
+            <a:r>
+              <a:rPr lang="en-US" dirty="0">
+                <a:solidFill>
+                  <a:schemeClr val="tx1"/>
+                </a:solidFill>
+              </a:rPr>
+              <a:t>Agent 1</a:t>
+            </a:r>
+          </a:p>
+        </p:txBody>
+      </p:sp>
       <p:pic>
         <p:nvPicPr>
-          <p:cNvPr id="3" name="Picture 2">
-            <a:extLst>
-              <a:ext uri="{FF2B5EF4-FFF2-40B4-BE49-F238E27FC236}">
-                <a16:creationId xmlns:a16="http://schemas.microsoft.com/office/drawing/2014/main" id="{EE4867BA-66DD-B140-5528-856BCA343CD6}"/>
+          <p:cNvPr id="18" name="Graphic 17" descr="User with solid fill">
+            <a:extLst>
+              <a:ext uri="{FF2B5EF4-FFF2-40B4-BE49-F238E27FC236}">
+                <a16:creationId xmlns:a16="http://schemas.microsoft.com/office/drawing/2014/main" id="{1B9F9BDD-1142-BCE0-EDD8-ADD84DF93974}"/>
               </a:ext>
             </a:extLst>
           </p:cNvPr>
@@ -8657,25 +9483,1179 @@
           <p:nvPr/>
         </p:nvPicPr>
         <p:blipFill>
-          <a:blip r:embed="rId2"/>
+          <a:blip r:embed="rId2">
+            <a:extLst>
+              <a:ext uri="{96DAC541-7B7A-43D3-8B79-37D633B846F1}">
+                <asvg:svgBlip xmlns:asvg="http://schemas.microsoft.com/office/drawing/2016/SVG/main" r:embed="rId3"/>
+              </a:ext>
+            </a:extLst>
+          </a:blip>
           <a:stretch>
             <a:fillRect/>
           </a:stretch>
         </p:blipFill>
         <p:spPr>
           <a:xfrm>
-            <a:off x="0" y="99063"/>
-            <a:ext cx="12192000" cy="6659873"/>
+            <a:off x="6422726" y="3841197"/>
+            <a:ext cx="685800" cy="685800"/>
           </a:xfrm>
           <a:prstGeom prst="rect">
             <a:avLst/>
           </a:prstGeom>
         </p:spPr>
       </p:pic>
+      <p:cxnSp>
+        <p:nvCxnSpPr>
+          <p:cNvPr id="19" name="Straight Arrow Connector 18">
+            <a:extLst>
+              <a:ext uri="{FF2B5EF4-FFF2-40B4-BE49-F238E27FC236}">
+                <a16:creationId xmlns:a16="http://schemas.microsoft.com/office/drawing/2014/main" id="{3BEF4AA4-B888-18BB-6FB5-C6F9288B2265}"/>
+              </a:ext>
+            </a:extLst>
+          </p:cNvPr>
+          <p:cNvCxnSpPr>
+            <a:cxnSpLocks/>
+            <a:stCxn id="5" idx="2"/>
+            <a:endCxn id="16" idx="0"/>
+          </p:cNvCxnSpPr>
+          <p:nvPr/>
+        </p:nvCxnSpPr>
+        <p:spPr>
+          <a:xfrm flipH="1">
+            <a:off x="6093542" y="1249877"/>
+            <a:ext cx="2457" cy="327609"/>
+          </a:xfrm>
+          <a:prstGeom prst="straightConnector1">
+            <a:avLst/>
+          </a:prstGeom>
+          <a:ln>
+            <a:solidFill>
+              <a:schemeClr val="tx1"/>
+            </a:solidFill>
+            <a:prstDash val="solid"/>
+            <a:headEnd type="none" w="lg" len="lg"/>
+            <a:tailEnd type="triangle" w="lg" len="lg"/>
+          </a:ln>
+        </p:spPr>
+        <p:style>
+          <a:lnRef idx="2">
+            <a:schemeClr val="accent1"/>
+          </a:lnRef>
+          <a:fillRef idx="0">
+            <a:schemeClr val="accent1"/>
+          </a:fillRef>
+          <a:effectRef idx="1">
+            <a:schemeClr val="accent1"/>
+          </a:effectRef>
+          <a:fontRef idx="minor">
+            <a:schemeClr val="tx1"/>
+          </a:fontRef>
+        </p:style>
+      </p:cxnSp>
+      <p:cxnSp>
+        <p:nvCxnSpPr>
+          <p:cNvPr id="22" name="Straight Arrow Connector 21">
+            <a:extLst>
+              <a:ext uri="{FF2B5EF4-FFF2-40B4-BE49-F238E27FC236}">
+                <a16:creationId xmlns:a16="http://schemas.microsoft.com/office/drawing/2014/main" id="{F476B6AE-D465-4915-3E1B-D83CE01572FB}"/>
+              </a:ext>
+            </a:extLst>
+          </p:cNvPr>
+          <p:cNvCxnSpPr>
+            <a:cxnSpLocks/>
+            <a:stCxn id="16" idx="2"/>
+            <a:endCxn id="15" idx="0"/>
+          </p:cNvCxnSpPr>
+          <p:nvPr/>
+        </p:nvCxnSpPr>
+        <p:spPr>
+          <a:xfrm>
+            <a:off x="6093542" y="2444380"/>
+            <a:ext cx="0" cy="327610"/>
+          </a:xfrm>
+          <a:prstGeom prst="straightConnector1">
+            <a:avLst/>
+          </a:prstGeom>
+          <a:ln>
+            <a:solidFill>
+              <a:schemeClr val="tx1"/>
+            </a:solidFill>
+            <a:prstDash val="solid"/>
+            <a:headEnd type="none" w="lg" len="lg"/>
+            <a:tailEnd type="triangle" w="lg" len="lg"/>
+          </a:ln>
+        </p:spPr>
+        <p:style>
+          <a:lnRef idx="2">
+            <a:schemeClr val="accent1"/>
+          </a:lnRef>
+          <a:fillRef idx="0">
+            <a:schemeClr val="accent1"/>
+          </a:fillRef>
+          <a:effectRef idx="1">
+            <a:schemeClr val="accent1"/>
+          </a:effectRef>
+          <a:fontRef idx="minor">
+            <a:schemeClr val="tx1"/>
+          </a:fontRef>
+        </p:style>
+      </p:cxnSp>
+      <p:cxnSp>
+        <p:nvCxnSpPr>
+          <p:cNvPr id="25" name="Straight Arrow Connector 24">
+            <a:extLst>
+              <a:ext uri="{FF2B5EF4-FFF2-40B4-BE49-F238E27FC236}">
+                <a16:creationId xmlns:a16="http://schemas.microsoft.com/office/drawing/2014/main" id="{6211E7CA-0A5C-9A5B-E02F-FE87A8E49E61}"/>
+              </a:ext>
+            </a:extLst>
+          </p:cNvPr>
+          <p:cNvCxnSpPr>
+            <a:cxnSpLocks/>
+            <a:stCxn id="2" idx="2"/>
+            <a:endCxn id="11" idx="0"/>
+          </p:cNvCxnSpPr>
+          <p:nvPr/>
+        </p:nvCxnSpPr>
+        <p:spPr>
+          <a:xfrm flipH="1">
+            <a:off x="2579515" y="1249877"/>
+            <a:ext cx="4915" cy="327609"/>
+          </a:xfrm>
+          <a:prstGeom prst="straightConnector1">
+            <a:avLst/>
+          </a:prstGeom>
+          <a:ln>
+            <a:solidFill>
+              <a:schemeClr val="tx1"/>
+            </a:solidFill>
+            <a:prstDash val="solid"/>
+            <a:headEnd type="none" w="lg" len="lg"/>
+            <a:tailEnd type="triangle" w="lg" len="lg"/>
+          </a:ln>
+        </p:spPr>
+        <p:style>
+          <a:lnRef idx="2">
+            <a:schemeClr val="accent1"/>
+          </a:lnRef>
+          <a:fillRef idx="0">
+            <a:schemeClr val="accent1"/>
+          </a:fillRef>
+          <a:effectRef idx="1">
+            <a:schemeClr val="accent1"/>
+          </a:effectRef>
+          <a:fontRef idx="minor">
+            <a:schemeClr val="tx1"/>
+          </a:fontRef>
+        </p:style>
+      </p:cxnSp>
+      <p:sp>
+        <p:nvSpPr>
+          <p:cNvPr id="28" name="TextBox 27">
+            <a:extLst>
+              <a:ext uri="{FF2B5EF4-FFF2-40B4-BE49-F238E27FC236}">
+                <a16:creationId xmlns:a16="http://schemas.microsoft.com/office/drawing/2014/main" id="{65BE0972-B87A-4DA1-1F47-7D690864B492}"/>
+              </a:ext>
+            </a:extLst>
+          </p:cNvPr>
+          <p:cNvSpPr txBox="1"/>
+          <p:nvPr/>
+        </p:nvSpPr>
+        <p:spPr>
+          <a:xfrm>
+            <a:off x="6344228" y="4416172"/>
+            <a:ext cx="842795" cy="461665"/>
+          </a:xfrm>
+          <a:prstGeom prst="rect">
+            <a:avLst/>
+          </a:prstGeom>
+          <a:noFill/>
+        </p:spPr>
+        <p:txBody>
+          <a:bodyPr wrap="none" rtlCol="0">
+            <a:spAutoFit/>
+          </a:bodyPr>
+          <a:lstStyle/>
+          <a:p>
+            <a:pPr algn="ctr"/>
+            <a:r>
+              <a:rPr lang="en-US" sz="1200" dirty="0"/>
+              <a:t>Approves or</a:t>
+            </a:r>
+          </a:p>
+          <a:p>
+            <a:pPr algn="ctr"/>
+            <a:r>
+              <a:rPr lang="en-US" sz="1200" dirty="0"/>
+              <a:t>Clarifies</a:t>
+            </a:r>
+          </a:p>
+        </p:txBody>
+      </p:sp>
+      <p:cxnSp>
+        <p:nvCxnSpPr>
+          <p:cNvPr id="30" name="Connector: Elbow 29">
+            <a:extLst>
+              <a:ext uri="{FF2B5EF4-FFF2-40B4-BE49-F238E27FC236}">
+                <a16:creationId xmlns:a16="http://schemas.microsoft.com/office/drawing/2014/main" id="{F9C84E05-C87E-751E-D39B-0EB80D386D6F}"/>
+              </a:ext>
+            </a:extLst>
+          </p:cNvPr>
+          <p:cNvCxnSpPr>
+            <a:cxnSpLocks/>
+            <a:endCxn id="18" idx="0"/>
+          </p:cNvCxnSpPr>
+          <p:nvPr/>
+        </p:nvCxnSpPr>
+        <p:spPr>
+          <a:xfrm rot="16200000" flipH="1">
+            <a:off x="6422641" y="3498212"/>
+            <a:ext cx="412200" cy="273770"/>
+          </a:xfrm>
+          <a:prstGeom prst="bentConnector3">
+            <a:avLst>
+              <a:gd name="adj1" fmla="val 50000"/>
+            </a:avLst>
+          </a:prstGeom>
+          <a:ln>
+            <a:solidFill>
+              <a:schemeClr val="tx1"/>
+            </a:solidFill>
+            <a:prstDash val="solid"/>
+            <a:headEnd type="none" w="lg" len="lg"/>
+            <a:tailEnd type="triangle" w="lg" len="lg"/>
+          </a:ln>
+        </p:spPr>
+        <p:style>
+          <a:lnRef idx="2">
+            <a:schemeClr val="accent1"/>
+          </a:lnRef>
+          <a:fillRef idx="0">
+            <a:schemeClr val="accent1"/>
+          </a:fillRef>
+          <a:effectRef idx="1">
+            <a:schemeClr val="accent1"/>
+          </a:effectRef>
+          <a:fontRef idx="minor">
+            <a:schemeClr val="tx1"/>
+          </a:fontRef>
+        </p:style>
+      </p:cxnSp>
+      <p:cxnSp>
+        <p:nvCxnSpPr>
+          <p:cNvPr id="39" name="Straight Arrow Connector 38">
+            <a:extLst>
+              <a:ext uri="{FF2B5EF4-FFF2-40B4-BE49-F238E27FC236}">
+                <a16:creationId xmlns:a16="http://schemas.microsoft.com/office/drawing/2014/main" id="{EFC9E4D5-9A27-41B0-A6B7-325376A8EEA9}"/>
+              </a:ext>
+            </a:extLst>
+          </p:cNvPr>
+          <p:cNvCxnSpPr>
+            <a:cxnSpLocks/>
+            <a:stCxn id="11" idx="2"/>
+            <a:endCxn id="13" idx="0"/>
+          </p:cNvCxnSpPr>
+          <p:nvPr/>
+        </p:nvCxnSpPr>
+        <p:spPr>
+          <a:xfrm>
+            <a:off x="2579515" y="2444380"/>
+            <a:ext cx="0" cy="327610"/>
+          </a:xfrm>
+          <a:prstGeom prst="straightConnector1">
+            <a:avLst/>
+          </a:prstGeom>
+          <a:ln>
+            <a:solidFill>
+              <a:schemeClr val="tx1"/>
+            </a:solidFill>
+            <a:prstDash val="solid"/>
+            <a:headEnd type="none" w="lg" len="lg"/>
+            <a:tailEnd type="triangle" w="lg" len="lg"/>
+          </a:ln>
+        </p:spPr>
+        <p:style>
+          <a:lnRef idx="2">
+            <a:schemeClr val="accent1"/>
+          </a:lnRef>
+          <a:fillRef idx="0">
+            <a:schemeClr val="accent1"/>
+          </a:fillRef>
+          <a:effectRef idx="1">
+            <a:schemeClr val="accent1"/>
+          </a:effectRef>
+          <a:fontRef idx="minor">
+            <a:schemeClr val="tx1"/>
+          </a:fontRef>
+        </p:style>
+      </p:cxnSp>
+      <p:cxnSp>
+        <p:nvCxnSpPr>
+          <p:cNvPr id="42" name="Straight Arrow Connector 41">
+            <a:extLst>
+              <a:ext uri="{FF2B5EF4-FFF2-40B4-BE49-F238E27FC236}">
+                <a16:creationId xmlns:a16="http://schemas.microsoft.com/office/drawing/2014/main" id="{B5EE7C03-9562-EF4D-00EA-CB265A4C9AB9}"/>
+              </a:ext>
+            </a:extLst>
+          </p:cNvPr>
+          <p:cNvCxnSpPr>
+            <a:cxnSpLocks/>
+            <a:stCxn id="13" idx="2"/>
+            <a:endCxn id="12" idx="0"/>
+          </p:cNvCxnSpPr>
+          <p:nvPr/>
+        </p:nvCxnSpPr>
+        <p:spPr>
+          <a:xfrm>
+            <a:off x="2579515" y="3638884"/>
+            <a:ext cx="0" cy="327609"/>
+          </a:xfrm>
+          <a:prstGeom prst="straightConnector1">
+            <a:avLst/>
+          </a:prstGeom>
+          <a:ln>
+            <a:solidFill>
+              <a:schemeClr val="tx1"/>
+            </a:solidFill>
+            <a:prstDash val="solid"/>
+            <a:headEnd type="none" w="lg" len="lg"/>
+            <a:tailEnd type="triangle" w="lg" len="lg"/>
+          </a:ln>
+        </p:spPr>
+        <p:style>
+          <a:lnRef idx="2">
+            <a:schemeClr val="accent1"/>
+          </a:lnRef>
+          <a:fillRef idx="0">
+            <a:schemeClr val="accent1"/>
+          </a:fillRef>
+          <a:effectRef idx="1">
+            <a:schemeClr val="accent1"/>
+          </a:effectRef>
+          <a:fontRef idx="minor">
+            <a:schemeClr val="tx1"/>
+          </a:fontRef>
+        </p:style>
+      </p:cxnSp>
+      <p:cxnSp>
+        <p:nvCxnSpPr>
+          <p:cNvPr id="45" name="Straight Arrow Connector 44">
+            <a:extLst>
+              <a:ext uri="{FF2B5EF4-FFF2-40B4-BE49-F238E27FC236}">
+                <a16:creationId xmlns:a16="http://schemas.microsoft.com/office/drawing/2014/main" id="{4025382F-8D45-D2AE-35A9-8B1AFA651182}"/>
+              </a:ext>
+            </a:extLst>
+          </p:cNvPr>
+          <p:cNvCxnSpPr>
+            <a:cxnSpLocks/>
+            <a:stCxn id="12" idx="2"/>
+            <a:endCxn id="3" idx="0"/>
+          </p:cNvCxnSpPr>
+          <p:nvPr/>
+        </p:nvCxnSpPr>
+        <p:spPr>
+          <a:xfrm>
+            <a:off x="2579515" y="4833387"/>
+            <a:ext cx="4915" cy="327610"/>
+          </a:xfrm>
+          <a:prstGeom prst="straightConnector1">
+            <a:avLst/>
+          </a:prstGeom>
+          <a:ln>
+            <a:solidFill>
+              <a:schemeClr val="tx1"/>
+            </a:solidFill>
+            <a:prstDash val="solid"/>
+            <a:headEnd type="none" w="lg" len="lg"/>
+            <a:tailEnd type="triangle" w="lg" len="lg"/>
+          </a:ln>
+        </p:spPr>
+        <p:style>
+          <a:lnRef idx="2">
+            <a:schemeClr val="accent1"/>
+          </a:lnRef>
+          <a:fillRef idx="0">
+            <a:schemeClr val="accent1"/>
+          </a:fillRef>
+          <a:effectRef idx="1">
+            <a:schemeClr val="accent1"/>
+          </a:effectRef>
+          <a:fontRef idx="minor">
+            <a:schemeClr val="tx1"/>
+          </a:fontRef>
+        </p:style>
+      </p:cxnSp>
+      <p:sp>
+        <p:nvSpPr>
+          <p:cNvPr id="48" name="TextBox 47">
+            <a:extLst>
+              <a:ext uri="{FF2B5EF4-FFF2-40B4-BE49-F238E27FC236}">
+                <a16:creationId xmlns:a16="http://schemas.microsoft.com/office/drawing/2014/main" id="{FD068019-47A3-33D3-84C8-9F7C60B24399}"/>
+              </a:ext>
+            </a:extLst>
+          </p:cNvPr>
+          <p:cNvSpPr txBox="1"/>
+          <p:nvPr/>
+        </p:nvSpPr>
+        <p:spPr>
+          <a:xfrm>
+            <a:off x="6479406" y="3355943"/>
+            <a:ext cx="366639" cy="276999"/>
+          </a:xfrm>
+          <a:prstGeom prst="rect">
+            <a:avLst/>
+          </a:prstGeom>
+          <a:noFill/>
+        </p:spPr>
+        <p:txBody>
+          <a:bodyPr wrap="none" rtlCol="0">
+            <a:spAutoFit/>
+          </a:bodyPr>
+          <a:lstStyle/>
+          <a:p>
+            <a:pPr algn="ctr"/>
+            <a:r>
+              <a:rPr lang="en-US" sz="1200" dirty="0"/>
+              <a:t>yes</a:t>
+            </a:r>
+          </a:p>
+        </p:txBody>
+      </p:sp>
+      <p:sp>
+        <p:nvSpPr>
+          <p:cNvPr id="49" name="TextBox 48">
+            <a:extLst>
+              <a:ext uri="{FF2B5EF4-FFF2-40B4-BE49-F238E27FC236}">
+                <a16:creationId xmlns:a16="http://schemas.microsoft.com/office/drawing/2014/main" id="{CD2AEDFC-0FEB-1CDF-3F9F-2B7FB5A2FC99}"/>
+              </a:ext>
+            </a:extLst>
+          </p:cNvPr>
+          <p:cNvSpPr txBox="1"/>
+          <p:nvPr/>
+        </p:nvSpPr>
+        <p:spPr>
+          <a:xfrm>
+            <a:off x="5386865" y="3355943"/>
+            <a:ext cx="325731" cy="276999"/>
+          </a:xfrm>
+          <a:prstGeom prst="rect">
+            <a:avLst/>
+          </a:prstGeom>
+          <a:noFill/>
+        </p:spPr>
+        <p:txBody>
+          <a:bodyPr wrap="none" rtlCol="0">
+            <a:spAutoFit/>
+          </a:bodyPr>
+          <a:lstStyle/>
+          <a:p>
+            <a:pPr algn="ctr"/>
+            <a:r>
+              <a:rPr lang="en-US" sz="1200" dirty="0"/>
+              <a:t>no</a:t>
+            </a:r>
+          </a:p>
+        </p:txBody>
+      </p:sp>
+      <p:cxnSp>
+        <p:nvCxnSpPr>
+          <p:cNvPr id="53" name="Straight Arrow Connector 52">
+            <a:extLst>
+              <a:ext uri="{FF2B5EF4-FFF2-40B4-BE49-F238E27FC236}">
+                <a16:creationId xmlns:a16="http://schemas.microsoft.com/office/drawing/2014/main" id="{7294098A-677B-10E2-34C5-5C1BE2219448}"/>
+              </a:ext>
+            </a:extLst>
+          </p:cNvPr>
+          <p:cNvCxnSpPr>
+            <a:cxnSpLocks/>
+          </p:cNvCxnSpPr>
+          <p:nvPr/>
+        </p:nvCxnSpPr>
+        <p:spPr>
+          <a:xfrm>
+            <a:off x="5700145" y="3428997"/>
+            <a:ext cx="0" cy="1726058"/>
+          </a:xfrm>
+          <a:prstGeom prst="straightConnector1">
+            <a:avLst/>
+          </a:prstGeom>
+          <a:ln>
+            <a:solidFill>
+              <a:schemeClr val="tx1"/>
+            </a:solidFill>
+            <a:prstDash val="solid"/>
+            <a:headEnd type="none" w="lg" len="lg"/>
+            <a:tailEnd type="triangle" w="lg" len="lg"/>
+          </a:ln>
+        </p:spPr>
+        <p:style>
+          <a:lnRef idx="2">
+            <a:schemeClr val="accent1"/>
+          </a:lnRef>
+          <a:fillRef idx="0">
+            <a:schemeClr val="accent1"/>
+          </a:fillRef>
+          <a:effectRef idx="1">
+            <a:schemeClr val="accent1"/>
+          </a:effectRef>
+          <a:fontRef idx="minor">
+            <a:schemeClr val="tx1"/>
+          </a:fontRef>
+        </p:style>
+      </p:cxnSp>
+      <p:cxnSp>
+        <p:nvCxnSpPr>
+          <p:cNvPr id="55" name="Straight Arrow Connector 54">
+            <a:extLst>
+              <a:ext uri="{FF2B5EF4-FFF2-40B4-BE49-F238E27FC236}">
+                <a16:creationId xmlns:a16="http://schemas.microsoft.com/office/drawing/2014/main" id="{E89C40B7-FA41-0814-7C87-B0B00357906E}"/>
+              </a:ext>
+            </a:extLst>
+          </p:cNvPr>
+          <p:cNvCxnSpPr>
+            <a:cxnSpLocks/>
+            <a:stCxn id="28" idx="2"/>
+          </p:cNvCxnSpPr>
+          <p:nvPr/>
+        </p:nvCxnSpPr>
+        <p:spPr>
+          <a:xfrm flipH="1">
+            <a:off x="6765625" y="4877837"/>
+            <a:ext cx="1" cy="277218"/>
+          </a:xfrm>
+          <a:prstGeom prst="straightConnector1">
+            <a:avLst/>
+          </a:prstGeom>
+          <a:ln>
+            <a:solidFill>
+              <a:schemeClr val="tx1"/>
+            </a:solidFill>
+            <a:prstDash val="solid"/>
+            <a:headEnd type="none" w="lg" len="lg"/>
+            <a:tailEnd type="triangle" w="lg" len="lg"/>
+          </a:ln>
+        </p:spPr>
+        <p:style>
+          <a:lnRef idx="2">
+            <a:schemeClr val="accent1"/>
+          </a:lnRef>
+          <a:fillRef idx="0">
+            <a:schemeClr val="accent1"/>
+          </a:fillRef>
+          <a:effectRef idx="1">
+            <a:schemeClr val="accent1"/>
+          </a:effectRef>
+          <a:fontRef idx="minor">
+            <a:schemeClr val="tx1"/>
+          </a:fontRef>
+        </p:style>
+      </p:cxnSp>
+      <p:sp>
+        <p:nvSpPr>
+          <p:cNvPr id="15" name="Flowchart: Decision 14">
+            <a:extLst>
+              <a:ext uri="{FF2B5EF4-FFF2-40B4-BE49-F238E27FC236}">
+                <a16:creationId xmlns:a16="http://schemas.microsoft.com/office/drawing/2014/main" id="{9F808D75-E976-70B5-1E8C-92954997F27F}"/>
+              </a:ext>
+            </a:extLst>
+          </p:cNvPr>
+          <p:cNvSpPr/>
+          <p:nvPr/>
+        </p:nvSpPr>
+        <p:spPr>
+          <a:xfrm>
+            <a:off x="5231894" y="2771990"/>
+            <a:ext cx="1723296" cy="866894"/>
+          </a:xfrm>
+          <a:prstGeom prst="flowChartDecision">
+            <a:avLst/>
+          </a:prstGeom>
+          <a:solidFill>
+            <a:srgbClr val="E5F1F8"/>
+          </a:solidFill>
+          <a:ln>
+            <a:solidFill>
+              <a:schemeClr val="tx1"/>
+            </a:solidFill>
+          </a:ln>
+        </p:spPr>
+        <p:style>
+          <a:lnRef idx="2">
+            <a:schemeClr val="accent1">
+              <a:shade val="15000"/>
+            </a:schemeClr>
+          </a:lnRef>
+          <a:fillRef idx="1">
+            <a:schemeClr val="accent1"/>
+          </a:fillRef>
+          <a:effectRef idx="0">
+            <a:schemeClr val="accent1"/>
+          </a:effectRef>
+          <a:fontRef idx="minor">
+            <a:schemeClr val="lt1"/>
+          </a:fontRef>
+        </p:style>
+        <p:txBody>
+          <a:bodyPr rtlCol="0" anchor="ctr"/>
+          <a:lstStyle/>
+          <a:p>
+            <a:pPr algn="ctr"/>
+            <a:r>
+              <a:rPr lang="en-US" dirty="0">
+                <a:solidFill>
+                  <a:schemeClr val="tx1"/>
+                </a:solidFill>
+              </a:rPr>
+              <a:t>Review?</a:t>
+            </a:r>
+          </a:p>
+        </p:txBody>
+      </p:sp>
+      <p:sp>
+        <p:nvSpPr>
+          <p:cNvPr id="60" name="Rectangle: Rounded Corners 59">
+            <a:extLst>
+              <a:ext uri="{FF2B5EF4-FFF2-40B4-BE49-F238E27FC236}">
+                <a16:creationId xmlns:a16="http://schemas.microsoft.com/office/drawing/2014/main" id="{C0F91184-A0B5-338B-04D3-73E6BC57562B}"/>
+              </a:ext>
+            </a:extLst>
+          </p:cNvPr>
+          <p:cNvSpPr/>
+          <p:nvPr/>
+        </p:nvSpPr>
+        <p:spPr>
+          <a:xfrm>
+            <a:off x="8317107" y="2947785"/>
+            <a:ext cx="792503" cy="685157"/>
+          </a:xfrm>
+          <a:prstGeom prst="roundRect">
+            <a:avLst/>
+          </a:prstGeom>
+          <a:solidFill>
+            <a:srgbClr val="E5F1F8"/>
+          </a:solidFill>
+          <a:ln>
+            <a:solidFill>
+              <a:schemeClr val="tx1"/>
+            </a:solidFill>
+          </a:ln>
+        </p:spPr>
+        <p:style>
+          <a:lnRef idx="2">
+            <a:schemeClr val="accent1">
+              <a:shade val="15000"/>
+            </a:schemeClr>
+          </a:lnRef>
+          <a:fillRef idx="1">
+            <a:schemeClr val="accent1"/>
+          </a:fillRef>
+          <a:effectRef idx="0">
+            <a:schemeClr val="accent1"/>
+          </a:effectRef>
+          <a:fontRef idx="minor">
+            <a:schemeClr val="lt1"/>
+          </a:fontRef>
+        </p:style>
+        <p:txBody>
+          <a:bodyPr rtlCol="0" anchor="ctr"/>
+          <a:lstStyle/>
+          <a:p>
+            <a:pPr algn="ctr"/>
+            <a:r>
+              <a:rPr lang="en-US" dirty="0">
+                <a:solidFill>
+                  <a:schemeClr val="tx1"/>
+                </a:solidFill>
+              </a:rPr>
+              <a:t>Expert A</a:t>
+            </a:r>
+            <a:endParaRPr lang="en-US" sz="1200" dirty="0">
+              <a:solidFill>
+                <a:schemeClr val="tx1"/>
+              </a:solidFill>
+            </a:endParaRPr>
+          </a:p>
+        </p:txBody>
+      </p:sp>
+      <p:sp>
+        <p:nvSpPr>
+          <p:cNvPr id="61" name="Rectangle: Rounded Corners 60">
+            <a:extLst>
+              <a:ext uri="{FF2B5EF4-FFF2-40B4-BE49-F238E27FC236}">
+                <a16:creationId xmlns:a16="http://schemas.microsoft.com/office/drawing/2014/main" id="{AB01557F-ABD2-BE16-968B-EB3184C63AF1}"/>
+              </a:ext>
+            </a:extLst>
+          </p:cNvPr>
+          <p:cNvSpPr/>
+          <p:nvPr/>
+        </p:nvSpPr>
+        <p:spPr>
+          <a:xfrm>
+            <a:off x="9211317" y="2947785"/>
+            <a:ext cx="792503" cy="685157"/>
+          </a:xfrm>
+          <a:prstGeom prst="roundRect">
+            <a:avLst/>
+          </a:prstGeom>
+          <a:solidFill>
+            <a:srgbClr val="E5F1F8"/>
+          </a:solidFill>
+          <a:ln>
+            <a:solidFill>
+              <a:schemeClr val="tx1"/>
+            </a:solidFill>
+          </a:ln>
+        </p:spPr>
+        <p:style>
+          <a:lnRef idx="2">
+            <a:schemeClr val="accent1">
+              <a:shade val="15000"/>
+            </a:schemeClr>
+          </a:lnRef>
+          <a:fillRef idx="1">
+            <a:schemeClr val="accent1"/>
+          </a:fillRef>
+          <a:effectRef idx="0">
+            <a:schemeClr val="accent1"/>
+          </a:effectRef>
+          <a:fontRef idx="minor">
+            <a:schemeClr val="lt1"/>
+          </a:fontRef>
+        </p:style>
+        <p:txBody>
+          <a:bodyPr rtlCol="0" anchor="ctr"/>
+          <a:lstStyle/>
+          <a:p>
+            <a:pPr algn="ctr"/>
+            <a:r>
+              <a:rPr lang="en-US" dirty="0">
+                <a:solidFill>
+                  <a:schemeClr val="tx1"/>
+                </a:solidFill>
+              </a:rPr>
+              <a:t>Expert B</a:t>
+            </a:r>
+            <a:endParaRPr lang="en-US" sz="1200" dirty="0">
+              <a:solidFill>
+                <a:schemeClr val="tx1"/>
+              </a:solidFill>
+            </a:endParaRPr>
+          </a:p>
+        </p:txBody>
+      </p:sp>
+      <p:sp>
+        <p:nvSpPr>
+          <p:cNvPr id="62" name="Rectangle: Rounded Corners 61">
+            <a:extLst>
+              <a:ext uri="{FF2B5EF4-FFF2-40B4-BE49-F238E27FC236}">
+                <a16:creationId xmlns:a16="http://schemas.microsoft.com/office/drawing/2014/main" id="{88F63535-DF4C-4B17-E76D-AF2692CD0174}"/>
+              </a:ext>
+            </a:extLst>
+          </p:cNvPr>
+          <p:cNvSpPr/>
+          <p:nvPr/>
+        </p:nvSpPr>
+        <p:spPr>
+          <a:xfrm>
+            <a:off x="10105530" y="2947785"/>
+            <a:ext cx="792503" cy="685157"/>
+          </a:xfrm>
+          <a:prstGeom prst="roundRect">
+            <a:avLst/>
+          </a:prstGeom>
+          <a:solidFill>
+            <a:srgbClr val="E5F1F8"/>
+          </a:solidFill>
+          <a:ln>
+            <a:solidFill>
+              <a:schemeClr val="tx1"/>
+            </a:solidFill>
+          </a:ln>
+        </p:spPr>
+        <p:style>
+          <a:lnRef idx="2">
+            <a:schemeClr val="accent1">
+              <a:shade val="15000"/>
+            </a:schemeClr>
+          </a:lnRef>
+          <a:fillRef idx="1">
+            <a:schemeClr val="accent1"/>
+          </a:fillRef>
+          <a:effectRef idx="0">
+            <a:schemeClr val="accent1"/>
+          </a:effectRef>
+          <a:fontRef idx="minor">
+            <a:schemeClr val="lt1"/>
+          </a:fontRef>
+        </p:style>
+        <p:txBody>
+          <a:bodyPr rtlCol="0" anchor="ctr"/>
+          <a:lstStyle/>
+          <a:p>
+            <a:pPr algn="ctr"/>
+            <a:r>
+              <a:rPr lang="en-US" dirty="0">
+                <a:solidFill>
+                  <a:schemeClr val="tx1"/>
+                </a:solidFill>
+              </a:rPr>
+              <a:t>Expert C</a:t>
+            </a:r>
+            <a:endParaRPr lang="en-US" sz="1200" dirty="0">
+              <a:solidFill>
+                <a:schemeClr val="tx1"/>
+              </a:solidFill>
+            </a:endParaRPr>
+          </a:p>
+        </p:txBody>
+      </p:sp>
+      <p:cxnSp>
+        <p:nvCxnSpPr>
+          <p:cNvPr id="63" name="Straight Arrow Connector 62">
+            <a:extLst>
+              <a:ext uri="{FF2B5EF4-FFF2-40B4-BE49-F238E27FC236}">
+                <a16:creationId xmlns:a16="http://schemas.microsoft.com/office/drawing/2014/main" id="{C1F33F15-6730-7F83-7184-1EFFB0E840B2}"/>
+              </a:ext>
+            </a:extLst>
+          </p:cNvPr>
+          <p:cNvCxnSpPr>
+            <a:cxnSpLocks/>
+            <a:stCxn id="14" idx="2"/>
+            <a:endCxn id="61" idx="0"/>
+          </p:cNvCxnSpPr>
+          <p:nvPr/>
+        </p:nvCxnSpPr>
+        <p:spPr>
+          <a:xfrm>
+            <a:off x="9607569" y="2444380"/>
+            <a:ext cx="0" cy="503405"/>
+          </a:xfrm>
+          <a:prstGeom prst="straightConnector1">
+            <a:avLst/>
+          </a:prstGeom>
+          <a:ln>
+            <a:solidFill>
+              <a:schemeClr val="tx1"/>
+            </a:solidFill>
+            <a:prstDash val="solid"/>
+            <a:headEnd type="none" w="lg" len="lg"/>
+            <a:tailEnd type="triangle" w="lg" len="lg"/>
+          </a:ln>
+        </p:spPr>
+        <p:style>
+          <a:lnRef idx="2">
+            <a:schemeClr val="accent1"/>
+          </a:lnRef>
+          <a:fillRef idx="0">
+            <a:schemeClr val="accent1"/>
+          </a:fillRef>
+          <a:effectRef idx="1">
+            <a:schemeClr val="accent1"/>
+          </a:effectRef>
+          <a:fontRef idx="minor">
+            <a:schemeClr val="tx1"/>
+          </a:fontRef>
+        </p:style>
+      </p:cxnSp>
+      <p:cxnSp>
+        <p:nvCxnSpPr>
+          <p:cNvPr id="66" name="Straight Arrow Connector 65">
+            <a:extLst>
+              <a:ext uri="{FF2B5EF4-FFF2-40B4-BE49-F238E27FC236}">
+                <a16:creationId xmlns:a16="http://schemas.microsoft.com/office/drawing/2014/main" id="{A4BA7FA0-175B-997D-9DFD-C48975209D2D}"/>
+              </a:ext>
+            </a:extLst>
+          </p:cNvPr>
+          <p:cNvCxnSpPr>
+            <a:cxnSpLocks/>
+            <a:stCxn id="6" idx="2"/>
+            <a:endCxn id="14" idx="0"/>
+          </p:cNvCxnSpPr>
+          <p:nvPr/>
+        </p:nvCxnSpPr>
+        <p:spPr>
+          <a:xfrm flipH="1">
+            <a:off x="9607569" y="1247424"/>
+            <a:ext cx="2" cy="330062"/>
+          </a:xfrm>
+          <a:prstGeom prst="straightConnector1">
+            <a:avLst/>
+          </a:prstGeom>
+          <a:ln>
+            <a:solidFill>
+              <a:schemeClr val="tx1"/>
+            </a:solidFill>
+            <a:prstDash val="solid"/>
+            <a:headEnd type="none" w="lg" len="lg"/>
+            <a:tailEnd type="triangle" w="lg" len="lg"/>
+          </a:ln>
+        </p:spPr>
+        <p:style>
+          <a:lnRef idx="2">
+            <a:schemeClr val="accent1"/>
+          </a:lnRef>
+          <a:fillRef idx="0">
+            <a:schemeClr val="accent1"/>
+          </a:fillRef>
+          <a:effectRef idx="1">
+            <a:schemeClr val="accent1"/>
+          </a:effectRef>
+          <a:fontRef idx="minor">
+            <a:schemeClr val="tx1"/>
+          </a:fontRef>
+        </p:style>
+      </p:cxnSp>
+      <p:cxnSp>
+        <p:nvCxnSpPr>
+          <p:cNvPr id="69" name="Connector: Elbow 68">
+            <a:extLst>
+              <a:ext uri="{FF2B5EF4-FFF2-40B4-BE49-F238E27FC236}">
+                <a16:creationId xmlns:a16="http://schemas.microsoft.com/office/drawing/2014/main" id="{C712FCF4-FA2C-A1B7-F6E3-C494DB41694C}"/>
+              </a:ext>
+            </a:extLst>
+          </p:cNvPr>
+          <p:cNvCxnSpPr>
+            <a:cxnSpLocks/>
+            <a:stCxn id="14" idx="2"/>
+            <a:endCxn id="60" idx="0"/>
+          </p:cNvCxnSpPr>
+          <p:nvPr/>
+        </p:nvCxnSpPr>
+        <p:spPr>
+          <a:xfrm rot="5400000">
+            <a:off x="8908762" y="2248977"/>
+            <a:ext cx="503405" cy="894210"/>
+          </a:xfrm>
+          <a:prstGeom prst="bentConnector3">
+            <a:avLst>
+              <a:gd name="adj1" fmla="val 50000"/>
+            </a:avLst>
+          </a:prstGeom>
+          <a:ln>
+            <a:solidFill>
+              <a:schemeClr val="tx1"/>
+            </a:solidFill>
+            <a:prstDash val="solid"/>
+            <a:headEnd type="none" w="lg" len="lg"/>
+            <a:tailEnd type="triangle" w="lg" len="lg"/>
+          </a:ln>
+        </p:spPr>
+        <p:style>
+          <a:lnRef idx="2">
+            <a:schemeClr val="accent1"/>
+          </a:lnRef>
+          <a:fillRef idx="0">
+            <a:schemeClr val="accent1"/>
+          </a:fillRef>
+          <a:effectRef idx="1">
+            <a:schemeClr val="accent1"/>
+          </a:effectRef>
+          <a:fontRef idx="minor">
+            <a:schemeClr val="tx1"/>
+          </a:fontRef>
+        </p:style>
+      </p:cxnSp>
+      <p:cxnSp>
+        <p:nvCxnSpPr>
+          <p:cNvPr id="72" name="Connector: Elbow 71">
+            <a:extLst>
+              <a:ext uri="{FF2B5EF4-FFF2-40B4-BE49-F238E27FC236}">
+                <a16:creationId xmlns:a16="http://schemas.microsoft.com/office/drawing/2014/main" id="{B6BE40E8-80D9-F923-B31B-4EB673E02EF8}"/>
+              </a:ext>
+            </a:extLst>
+          </p:cNvPr>
+          <p:cNvCxnSpPr>
+            <a:cxnSpLocks/>
+            <a:stCxn id="14" idx="2"/>
+            <a:endCxn id="62" idx="0"/>
+          </p:cNvCxnSpPr>
+          <p:nvPr/>
+        </p:nvCxnSpPr>
+        <p:spPr>
+          <a:xfrm rot="16200000" flipH="1">
+            <a:off x="9802973" y="2248975"/>
+            <a:ext cx="503405" cy="894213"/>
+          </a:xfrm>
+          <a:prstGeom prst="bentConnector3">
+            <a:avLst>
+              <a:gd name="adj1" fmla="val 50000"/>
+            </a:avLst>
+          </a:prstGeom>
+          <a:ln>
+            <a:solidFill>
+              <a:schemeClr val="tx1"/>
+            </a:solidFill>
+            <a:prstDash val="solid"/>
+            <a:headEnd type="none" w="lg" len="lg"/>
+            <a:tailEnd type="triangle" w="lg" len="lg"/>
+          </a:ln>
+        </p:spPr>
+        <p:style>
+          <a:lnRef idx="2">
+            <a:schemeClr val="accent1"/>
+          </a:lnRef>
+          <a:fillRef idx="0">
+            <a:schemeClr val="accent1"/>
+          </a:fillRef>
+          <a:effectRef idx="1">
+            <a:schemeClr val="accent1"/>
+          </a:effectRef>
+          <a:fontRef idx="minor">
+            <a:schemeClr val="tx1"/>
+          </a:fontRef>
+        </p:style>
+      </p:cxnSp>
+      <p:cxnSp>
+        <p:nvCxnSpPr>
+          <p:cNvPr id="75" name="Connector: Elbow 74">
+            <a:extLst>
+              <a:ext uri="{FF2B5EF4-FFF2-40B4-BE49-F238E27FC236}">
+                <a16:creationId xmlns:a16="http://schemas.microsoft.com/office/drawing/2014/main" id="{3F73E562-451E-ACE6-539E-D86109028F4E}"/>
+              </a:ext>
+            </a:extLst>
+          </p:cNvPr>
+          <p:cNvCxnSpPr>
+            <a:cxnSpLocks/>
+            <a:stCxn id="60" idx="2"/>
+            <a:endCxn id="7" idx="0"/>
+          </p:cNvCxnSpPr>
+          <p:nvPr/>
+        </p:nvCxnSpPr>
+        <p:spPr>
+          <a:xfrm rot="16200000" flipH="1">
+            <a:off x="8396438" y="3949863"/>
+            <a:ext cx="1528055" cy="894212"/>
+          </a:xfrm>
+          <a:prstGeom prst="bentConnector3">
+            <a:avLst>
+              <a:gd name="adj1" fmla="val 50000"/>
+            </a:avLst>
+          </a:prstGeom>
+          <a:ln>
+            <a:solidFill>
+              <a:schemeClr val="tx1"/>
+            </a:solidFill>
+            <a:prstDash val="solid"/>
+            <a:headEnd type="none" w="lg" len="lg"/>
+            <a:tailEnd type="triangle" w="lg" len="lg"/>
+          </a:ln>
+        </p:spPr>
+        <p:style>
+          <a:lnRef idx="2">
+            <a:schemeClr val="accent1"/>
+          </a:lnRef>
+          <a:fillRef idx="0">
+            <a:schemeClr val="accent1"/>
+          </a:fillRef>
+          <a:effectRef idx="1">
+            <a:schemeClr val="accent1"/>
+          </a:effectRef>
+          <a:fontRef idx="minor">
+            <a:schemeClr val="tx1"/>
+          </a:fontRef>
+        </p:style>
+      </p:cxnSp>
+      <p:cxnSp>
+        <p:nvCxnSpPr>
+          <p:cNvPr id="78" name="Connector: Elbow 77">
+            <a:extLst>
+              <a:ext uri="{FF2B5EF4-FFF2-40B4-BE49-F238E27FC236}">
+                <a16:creationId xmlns:a16="http://schemas.microsoft.com/office/drawing/2014/main" id="{DE881DF3-FDE1-E2F0-A9A6-2EF92D0A6A22}"/>
+              </a:ext>
+            </a:extLst>
+          </p:cNvPr>
+          <p:cNvCxnSpPr>
+            <a:cxnSpLocks/>
+            <a:stCxn id="62" idx="2"/>
+            <a:endCxn id="7" idx="0"/>
+          </p:cNvCxnSpPr>
+          <p:nvPr/>
+        </p:nvCxnSpPr>
+        <p:spPr>
+          <a:xfrm rot="5400000">
+            <a:off x="9290650" y="3949864"/>
+            <a:ext cx="1528055" cy="894211"/>
+          </a:xfrm>
+          <a:prstGeom prst="bentConnector3">
+            <a:avLst>
+              <a:gd name="adj1" fmla="val 50000"/>
+            </a:avLst>
+          </a:prstGeom>
+          <a:ln>
+            <a:solidFill>
+              <a:schemeClr val="tx1"/>
+            </a:solidFill>
+            <a:prstDash val="solid"/>
+            <a:headEnd type="none" w="lg" len="lg"/>
+            <a:tailEnd type="triangle" w="lg" len="lg"/>
+          </a:ln>
+        </p:spPr>
+        <p:style>
+          <a:lnRef idx="2">
+            <a:schemeClr val="accent1"/>
+          </a:lnRef>
+          <a:fillRef idx="0">
+            <a:schemeClr val="accent1"/>
+          </a:fillRef>
+          <a:effectRef idx="1">
+            <a:schemeClr val="accent1"/>
+          </a:effectRef>
+          <a:fontRef idx="minor">
+            <a:schemeClr val="tx1"/>
+          </a:fontRef>
+        </p:style>
+      </p:cxnSp>
+      <p:cxnSp>
+        <p:nvCxnSpPr>
+          <p:cNvPr id="81" name="Straight Arrow Connector 80">
+            <a:extLst>
+              <a:ext uri="{FF2B5EF4-FFF2-40B4-BE49-F238E27FC236}">
+                <a16:creationId xmlns:a16="http://schemas.microsoft.com/office/drawing/2014/main" id="{457C5348-A8B7-BB09-4C4A-BB5E1799E7CD}"/>
+              </a:ext>
+            </a:extLst>
+          </p:cNvPr>
+          <p:cNvCxnSpPr>
+            <a:cxnSpLocks/>
+            <a:stCxn id="61" idx="2"/>
+            <a:endCxn id="7" idx="0"/>
+          </p:cNvCxnSpPr>
+          <p:nvPr/>
+        </p:nvCxnSpPr>
+        <p:spPr>
+          <a:xfrm>
+            <a:off x="9607569" y="3632942"/>
+            <a:ext cx="2" cy="1528055"/>
+          </a:xfrm>
+          <a:prstGeom prst="straightConnector1">
+            <a:avLst/>
+          </a:prstGeom>
+          <a:ln>
+            <a:solidFill>
+              <a:schemeClr val="tx1"/>
+            </a:solidFill>
+            <a:prstDash val="solid"/>
+            <a:headEnd type="none" w="lg" len="lg"/>
+            <a:tailEnd type="triangle" w="lg" len="lg"/>
+          </a:ln>
+        </p:spPr>
+        <p:style>
+          <a:lnRef idx="2">
+            <a:schemeClr val="accent1"/>
+          </a:lnRef>
+          <a:fillRef idx="0">
+            <a:schemeClr val="accent1"/>
+          </a:fillRef>
+          <a:effectRef idx="1">
+            <a:schemeClr val="accent1"/>
+          </a:effectRef>
+          <a:fontRef idx="minor">
+            <a:schemeClr val="tx1"/>
+          </a:fontRef>
+        </p:style>
+      </p:cxnSp>
     </p:spTree>
     <p:extLst>
       <p:ext uri="{BB962C8B-B14F-4D97-AF65-F5344CB8AC3E}">
-        <p14:creationId xmlns:p14="http://schemas.microsoft.com/office/powerpoint/2010/main" val="276189202"/>
+        <p14:creationId xmlns:p14="http://schemas.microsoft.com/office/powerpoint/2010/main" val="996512096"/>
       </p:ext>
     </p:extLst>
   </p:cSld>
@@ -8686,162 +10666,6 @@
 </file>
 
 <file path=ppt/slides/slide17.xml><?xml version="1.0" encoding="utf-8"?>
-<p:sld xmlns:a="http://schemas.openxmlformats.org/drawingml/2006/main" xmlns:r="http://schemas.openxmlformats.org/officeDocument/2006/relationships" xmlns:p="http://schemas.openxmlformats.org/presentationml/2006/main">
-  <p:cSld>
-    <p:spTree>
-      <p:nvGrpSpPr>
-        <p:cNvPr id="1" name="">
-          <a:extLst>
-            <a:ext uri="{FF2B5EF4-FFF2-40B4-BE49-F238E27FC236}">
-              <a16:creationId xmlns:a16="http://schemas.microsoft.com/office/drawing/2014/main" id="{677E65E1-5DF3-2FE1-BF1F-36B02D0FEC76}"/>
-            </a:ext>
-          </a:extLst>
-        </p:cNvPr>
-        <p:cNvGrpSpPr/>
-        <p:nvPr/>
-      </p:nvGrpSpPr>
-      <p:grpSpPr>
-        <a:xfrm>
-          <a:off x="0" y="0"/>
-          <a:ext cx="0" cy="0"/>
-          <a:chOff x="0" y="0"/>
-          <a:chExt cx="0" cy="0"/>
-        </a:xfrm>
-      </p:grpSpPr>
-      <p:pic>
-        <p:nvPicPr>
-          <p:cNvPr id="3" name="Picture 2">
-            <a:extLst>
-              <a:ext uri="{FF2B5EF4-FFF2-40B4-BE49-F238E27FC236}">
-                <a16:creationId xmlns:a16="http://schemas.microsoft.com/office/drawing/2014/main" id="{8F0F888E-6C37-17E1-670D-996346E71810}"/>
-              </a:ext>
-            </a:extLst>
-          </p:cNvPr>
-          <p:cNvPicPr>
-            <a:picLocks noChangeAspect="1"/>
-          </p:cNvPicPr>
-          <p:nvPr/>
-        </p:nvPicPr>
-        <p:blipFill>
-          <a:blip r:embed="rId2"/>
-          <a:stretch>
-            <a:fillRect/>
-          </a:stretch>
-        </p:blipFill>
-        <p:spPr>
-          <a:xfrm>
-            <a:off x="0" y="1214427"/>
-            <a:ext cx="12192000" cy="4429145"/>
-          </a:xfrm>
-          <a:prstGeom prst="rect">
-            <a:avLst/>
-          </a:prstGeom>
-        </p:spPr>
-      </p:pic>
-    </p:spTree>
-    <p:extLst>
-      <p:ext uri="{BB962C8B-B14F-4D97-AF65-F5344CB8AC3E}">
-        <p14:creationId xmlns:p14="http://schemas.microsoft.com/office/powerpoint/2010/main" val="3483502725"/>
-      </p:ext>
-    </p:extLst>
-  </p:cSld>
-  <p:clrMapOvr>
-    <a:masterClrMapping/>
-  </p:clrMapOvr>
-</p:sld>
-</file>
-
-<file path=ppt/slides/slide18.xml><?xml version="1.0" encoding="utf-8"?>
-<p:sld xmlns:a="http://schemas.openxmlformats.org/drawingml/2006/main" xmlns:r="http://schemas.openxmlformats.org/officeDocument/2006/relationships" xmlns:p="http://schemas.openxmlformats.org/presentationml/2006/main">
-  <p:cSld>
-    <p:spTree>
-      <p:nvGrpSpPr>
-        <p:cNvPr id="1" name=""/>
-        <p:cNvGrpSpPr/>
-        <p:nvPr/>
-      </p:nvGrpSpPr>
-      <p:grpSpPr>
-        <a:xfrm>
-          <a:off x="0" y="0"/>
-          <a:ext cx="0" cy="0"/>
-          <a:chOff x="0" y="0"/>
-          <a:chExt cx="0" cy="0"/>
-        </a:xfrm>
-      </p:grpSpPr>
-      <p:pic>
-        <p:nvPicPr>
-          <p:cNvPr id="3" name="Picture 2">
-            <a:extLst>
-              <a:ext uri="{FF2B5EF4-FFF2-40B4-BE49-F238E27FC236}">
-                <a16:creationId xmlns:a16="http://schemas.microsoft.com/office/drawing/2014/main" id="{5A667DA2-6815-DE2B-768E-FDE43E3CE7EB}"/>
-              </a:ext>
-            </a:extLst>
-          </p:cNvPr>
-          <p:cNvPicPr>
-            <a:picLocks noChangeAspect="1"/>
-          </p:cNvPicPr>
-          <p:nvPr/>
-        </p:nvPicPr>
-        <p:blipFill>
-          <a:blip r:embed="rId2"/>
-          <a:stretch>
-            <a:fillRect/>
-          </a:stretch>
-        </p:blipFill>
-        <p:spPr>
-          <a:xfrm>
-            <a:off x="0" y="0"/>
-            <a:ext cx="7078980" cy="3865170"/>
-          </a:xfrm>
-          <a:prstGeom prst="rect">
-            <a:avLst/>
-          </a:prstGeom>
-        </p:spPr>
-      </p:pic>
-      <p:pic>
-        <p:nvPicPr>
-          <p:cNvPr id="5" name="Picture 4">
-            <a:extLst>
-              <a:ext uri="{FF2B5EF4-FFF2-40B4-BE49-F238E27FC236}">
-                <a16:creationId xmlns:a16="http://schemas.microsoft.com/office/drawing/2014/main" id="{3B15023E-4451-73EF-7EF8-DE3379C381B6}"/>
-              </a:ext>
-            </a:extLst>
-          </p:cNvPr>
-          <p:cNvPicPr>
-            <a:picLocks noChangeAspect="1"/>
-          </p:cNvPicPr>
-          <p:nvPr/>
-        </p:nvPicPr>
-        <p:blipFill>
-          <a:blip r:embed="rId3"/>
-          <a:stretch>
-            <a:fillRect/>
-          </a:stretch>
-        </p:blipFill>
-        <p:spPr>
-          <a:xfrm>
-            <a:off x="2834640" y="3493186"/>
-            <a:ext cx="9357360" cy="3292055"/>
-          </a:xfrm>
-          <a:prstGeom prst="rect">
-            <a:avLst/>
-          </a:prstGeom>
-        </p:spPr>
-      </p:pic>
-    </p:spTree>
-    <p:extLst>
-      <p:ext uri="{BB962C8B-B14F-4D97-AF65-F5344CB8AC3E}">
-        <p14:creationId xmlns:p14="http://schemas.microsoft.com/office/powerpoint/2010/main" val="1990716002"/>
-      </p:ext>
-    </p:extLst>
-  </p:cSld>
-  <p:clrMapOvr>
-    <a:masterClrMapping/>
-  </p:clrMapOvr>
-</p:sld>
-</file>
-
-<file path=ppt/slides/slide19.xml><?xml version="1.0" encoding="utf-8"?>
 <p:sld xmlns:a="http://schemas.openxmlformats.org/drawingml/2006/main" xmlns:r="http://schemas.openxmlformats.org/officeDocument/2006/relationships" xmlns:p="http://schemas.openxmlformats.org/presentationml/2006/main">
   <p:cSld>
     <p:spTree>
@@ -9834,637 +11658,7 @@
 </p:sld>
 </file>
 
-<file path=ppt/slides/slide2.xml><?xml version="1.0" encoding="utf-8"?>
-<p:sld xmlns:a="http://schemas.openxmlformats.org/drawingml/2006/main" xmlns:r="http://schemas.openxmlformats.org/officeDocument/2006/relationships" xmlns:p="http://schemas.openxmlformats.org/presentationml/2006/main">
-  <p:cSld>
-    <p:spTree>
-      <p:nvGrpSpPr>
-        <p:cNvPr id="1" name=""/>
-        <p:cNvGrpSpPr/>
-        <p:nvPr/>
-      </p:nvGrpSpPr>
-      <p:grpSpPr>
-        <a:xfrm>
-          <a:off x="0" y="0"/>
-          <a:ext cx="0" cy="0"/>
-          <a:chOff x="0" y="0"/>
-          <a:chExt cx="0" cy="0"/>
-        </a:xfrm>
-      </p:grpSpPr>
-      <p:pic>
-        <p:nvPicPr>
-          <p:cNvPr id="2050" name="Picture 2" descr="Diagram showing Foundry resource containing multiple projects, each with deployments and connections.">
-            <a:extLst>
-              <a:ext uri="{FF2B5EF4-FFF2-40B4-BE49-F238E27FC236}">
-                <a16:creationId xmlns:a16="http://schemas.microsoft.com/office/drawing/2014/main" id="{12EEA84E-8776-00EF-5D97-05E8737B61E3}"/>
-              </a:ext>
-            </a:extLst>
-          </p:cNvPr>
-          <p:cNvPicPr>
-            <a:picLocks noChangeAspect="1" noChangeArrowheads="1"/>
-          </p:cNvPicPr>
-          <p:nvPr/>
-        </p:nvPicPr>
-        <p:blipFill>
-          <a:blip r:embed="rId3">
-            <a:clrChange>
-              <a:clrFrom>
-                <a:srgbClr val="FFFFFF"/>
-              </a:clrFrom>
-              <a:clrTo>
-                <a:srgbClr val="FFFFFF">
-                  <a:alpha val="0"/>
-                </a:srgbClr>
-              </a:clrTo>
-            </a:clrChange>
-            <a:extLst>
-              <a:ext uri="{28A0092B-C50C-407E-A947-70E740481C1C}">
-                <a14:useLocalDpi xmlns:a14="http://schemas.microsoft.com/office/drawing/2010/main" val="0"/>
-              </a:ext>
-            </a:extLst>
-          </a:blip>
-          <a:srcRect/>
-          <a:stretch>
-            <a:fillRect/>
-          </a:stretch>
-        </p:blipFill>
-        <p:spPr bwMode="auto">
-          <a:xfrm>
-            <a:off x="6607866" y="3166424"/>
-            <a:ext cx="5524500" cy="3667125"/>
-          </a:xfrm>
-          <a:prstGeom prst="rect">
-            <a:avLst/>
-          </a:prstGeom>
-          <a:noFill/>
-          <a:extLst>
-            <a:ext uri="{909E8E84-426E-40DD-AFC4-6F175D3DCCD1}">
-              <a14:hiddenFill xmlns:a14="http://schemas.microsoft.com/office/drawing/2010/main">
-                <a:solidFill>
-                  <a:srgbClr val="FFFFFF"/>
-                </a:solidFill>
-              </a14:hiddenFill>
-            </a:ext>
-          </a:extLst>
-        </p:spPr>
-      </p:pic>
-      <p:sp>
-        <p:nvSpPr>
-          <p:cNvPr id="4" name="Rectangle: Rounded Corners 3">
-            <a:extLst>
-              <a:ext uri="{FF2B5EF4-FFF2-40B4-BE49-F238E27FC236}">
-                <a16:creationId xmlns:a16="http://schemas.microsoft.com/office/drawing/2014/main" id="{F839DD77-409D-94ED-8A62-6F53CBB88ADD}"/>
-              </a:ext>
-            </a:extLst>
-          </p:cNvPr>
-          <p:cNvSpPr/>
-          <p:nvPr/>
-        </p:nvSpPr>
-        <p:spPr>
-          <a:xfrm>
-            <a:off x="962568" y="732317"/>
-            <a:ext cx="4456090" cy="2434107"/>
-          </a:xfrm>
-          <a:prstGeom prst="roundRect">
-            <a:avLst>
-              <a:gd name="adj" fmla="val 5234"/>
-            </a:avLst>
-          </a:prstGeom>
-          <a:solidFill>
-            <a:schemeClr val="bg1"/>
-          </a:solidFill>
-          <a:ln>
-            <a:solidFill>
-              <a:schemeClr val="tx1"/>
-            </a:solidFill>
-          </a:ln>
-        </p:spPr>
-        <p:style>
-          <a:lnRef idx="2">
-            <a:schemeClr val="accent1">
-              <a:shade val="15000"/>
-            </a:schemeClr>
-          </a:lnRef>
-          <a:fillRef idx="1">
-            <a:schemeClr val="accent1"/>
-          </a:fillRef>
-          <a:effectRef idx="0">
-            <a:schemeClr val="accent1"/>
-          </a:effectRef>
-          <a:fontRef idx="minor">
-            <a:schemeClr val="lt1"/>
-          </a:fontRef>
-        </p:style>
-        <p:txBody>
-          <a:bodyPr rtlCol="0" anchor="t"/>
-          <a:lstStyle/>
-          <a:p>
-            <a:pPr algn="ctr"/>
-            <a:r>
-              <a:rPr lang="en-US" dirty="0">
-                <a:solidFill>
-                  <a:schemeClr val="tx1"/>
-                </a:solidFill>
-              </a:rPr>
-              <a:t>Foundry Resource</a:t>
-            </a:r>
-          </a:p>
-        </p:txBody>
-      </p:sp>
-      <p:sp>
-        <p:nvSpPr>
-          <p:cNvPr id="5" name="Rectangle: Rounded Corners 4">
-            <a:extLst>
-              <a:ext uri="{FF2B5EF4-FFF2-40B4-BE49-F238E27FC236}">
-                <a16:creationId xmlns:a16="http://schemas.microsoft.com/office/drawing/2014/main" id="{CFAF0893-8AEC-1DBB-B036-2949BA0795A0}"/>
-              </a:ext>
-            </a:extLst>
-          </p:cNvPr>
-          <p:cNvSpPr/>
-          <p:nvPr/>
-        </p:nvSpPr>
-        <p:spPr>
-          <a:xfrm>
-            <a:off x="2410311" y="1494888"/>
-            <a:ext cx="1080042" cy="694520"/>
-          </a:xfrm>
-          <a:prstGeom prst="roundRect">
-            <a:avLst/>
-          </a:prstGeom>
-          <a:solidFill>
-            <a:srgbClr val="E5F1F8"/>
-          </a:solidFill>
-          <a:ln>
-            <a:solidFill>
-              <a:schemeClr val="tx1"/>
-            </a:solidFill>
-          </a:ln>
-        </p:spPr>
-        <p:style>
-          <a:lnRef idx="2">
-            <a:schemeClr val="accent1">
-              <a:shade val="15000"/>
-            </a:schemeClr>
-          </a:lnRef>
-          <a:fillRef idx="1">
-            <a:schemeClr val="accent1"/>
-          </a:fillRef>
-          <a:effectRef idx="0">
-            <a:schemeClr val="accent1"/>
-          </a:effectRef>
-          <a:fontRef idx="minor">
-            <a:schemeClr val="lt1"/>
-          </a:fontRef>
-        </p:style>
-        <p:txBody>
-          <a:bodyPr rtlCol="0" anchor="ctr"/>
-          <a:lstStyle/>
-          <a:p>
-            <a:pPr algn="ctr"/>
-            <a:r>
-              <a:rPr lang="en-US" dirty="0">
-                <a:solidFill>
-                  <a:schemeClr val="tx1"/>
-                </a:solidFill>
-              </a:rPr>
-              <a:t>Project</a:t>
-            </a:r>
-          </a:p>
-          <a:p>
-            <a:pPr algn="ctr"/>
-            <a:r>
-              <a:rPr lang="en-US" dirty="0">
-                <a:solidFill>
-                  <a:schemeClr val="tx1"/>
-                </a:solidFill>
-              </a:rPr>
-              <a:t>2</a:t>
-            </a:r>
-          </a:p>
-        </p:txBody>
-      </p:sp>
-      <p:sp>
-        <p:nvSpPr>
-          <p:cNvPr id="6" name="Rectangle: Rounded Corners 5">
-            <a:extLst>
-              <a:ext uri="{FF2B5EF4-FFF2-40B4-BE49-F238E27FC236}">
-                <a16:creationId xmlns:a16="http://schemas.microsoft.com/office/drawing/2014/main" id="{A7E630FB-2D59-D6DB-B847-29F7E0317AFA}"/>
-              </a:ext>
-            </a:extLst>
-          </p:cNvPr>
-          <p:cNvSpPr/>
-          <p:nvPr/>
-        </p:nvSpPr>
-        <p:spPr>
-          <a:xfrm>
-            <a:off x="1183452" y="1494888"/>
-            <a:ext cx="1080042" cy="694520"/>
-          </a:xfrm>
-          <a:prstGeom prst="roundRect">
-            <a:avLst/>
-          </a:prstGeom>
-          <a:solidFill>
-            <a:srgbClr val="E5F1F8"/>
-          </a:solidFill>
-          <a:ln>
-            <a:solidFill>
-              <a:schemeClr val="tx1"/>
-            </a:solidFill>
-          </a:ln>
-        </p:spPr>
-        <p:style>
-          <a:lnRef idx="2">
-            <a:schemeClr val="accent1">
-              <a:shade val="15000"/>
-            </a:schemeClr>
-          </a:lnRef>
-          <a:fillRef idx="1">
-            <a:schemeClr val="accent1"/>
-          </a:fillRef>
-          <a:effectRef idx="0">
-            <a:schemeClr val="accent1"/>
-          </a:effectRef>
-          <a:fontRef idx="minor">
-            <a:schemeClr val="lt1"/>
-          </a:fontRef>
-        </p:style>
-        <p:txBody>
-          <a:bodyPr rtlCol="0" anchor="ctr"/>
-          <a:lstStyle/>
-          <a:p>
-            <a:pPr algn="ctr"/>
-            <a:r>
-              <a:rPr lang="en-US" dirty="0">
-                <a:solidFill>
-                  <a:schemeClr val="tx1"/>
-                </a:solidFill>
-              </a:rPr>
-              <a:t>Project</a:t>
-            </a:r>
-          </a:p>
-          <a:p>
-            <a:pPr algn="ctr"/>
-            <a:r>
-              <a:rPr lang="en-US" dirty="0">
-                <a:solidFill>
-                  <a:schemeClr val="tx1"/>
-                </a:solidFill>
-              </a:rPr>
-              <a:t>1</a:t>
-            </a:r>
-          </a:p>
-        </p:txBody>
-      </p:sp>
-      <p:sp>
-        <p:nvSpPr>
-          <p:cNvPr id="8" name="Rectangle: Rounded Corners 7">
-            <a:extLst>
-              <a:ext uri="{FF2B5EF4-FFF2-40B4-BE49-F238E27FC236}">
-                <a16:creationId xmlns:a16="http://schemas.microsoft.com/office/drawing/2014/main" id="{5E9103F9-368F-E4D0-C17C-BF0F1C74D31A}"/>
-              </a:ext>
-            </a:extLst>
-          </p:cNvPr>
-          <p:cNvSpPr/>
-          <p:nvPr/>
-        </p:nvSpPr>
-        <p:spPr>
-          <a:xfrm>
-            <a:off x="4117733" y="1494888"/>
-            <a:ext cx="1080042" cy="694520"/>
-          </a:xfrm>
-          <a:prstGeom prst="roundRect">
-            <a:avLst/>
-          </a:prstGeom>
-          <a:solidFill>
-            <a:srgbClr val="B2D4EB"/>
-          </a:solidFill>
-          <a:ln>
-            <a:solidFill>
-              <a:schemeClr val="tx1"/>
-            </a:solidFill>
-          </a:ln>
-        </p:spPr>
-        <p:style>
-          <a:lnRef idx="2">
-            <a:schemeClr val="accent1">
-              <a:shade val="15000"/>
-            </a:schemeClr>
-          </a:lnRef>
-          <a:fillRef idx="1">
-            <a:schemeClr val="accent1"/>
-          </a:fillRef>
-          <a:effectRef idx="0">
-            <a:schemeClr val="accent1"/>
-          </a:effectRef>
-          <a:fontRef idx="minor">
-            <a:schemeClr val="lt1"/>
-          </a:fontRef>
-        </p:style>
-        <p:txBody>
-          <a:bodyPr rtlCol="0" anchor="ctr"/>
-          <a:lstStyle/>
-          <a:p>
-            <a:pPr algn="ctr"/>
-            <a:r>
-              <a:rPr lang="en-US" dirty="0">
-                <a:solidFill>
-                  <a:schemeClr val="tx1"/>
-                </a:solidFill>
-              </a:rPr>
-              <a:t>Project</a:t>
-            </a:r>
-          </a:p>
-          <a:p>
-            <a:pPr algn="ctr"/>
-            <a:r>
-              <a:rPr lang="en-US" i="1" dirty="0">
-                <a:solidFill>
-                  <a:schemeClr val="tx1"/>
-                </a:solidFill>
-              </a:rPr>
-              <a:t>n</a:t>
-            </a:r>
-          </a:p>
-        </p:txBody>
-      </p:sp>
-      <p:sp>
-        <p:nvSpPr>
-          <p:cNvPr id="9" name="TextBox 8">
-            <a:extLst>
-              <a:ext uri="{FF2B5EF4-FFF2-40B4-BE49-F238E27FC236}">
-                <a16:creationId xmlns:a16="http://schemas.microsoft.com/office/drawing/2014/main" id="{C992B776-2029-F35D-E69F-FB22F1454014}"/>
-              </a:ext>
-            </a:extLst>
-          </p:cNvPr>
-          <p:cNvSpPr txBox="1"/>
-          <p:nvPr/>
-        </p:nvSpPr>
-        <p:spPr>
-          <a:xfrm>
-            <a:off x="3637170" y="1657482"/>
-            <a:ext cx="333746" cy="369332"/>
-          </a:xfrm>
-          <a:prstGeom prst="rect">
-            <a:avLst/>
-          </a:prstGeom>
-          <a:noFill/>
-        </p:spPr>
-        <p:txBody>
-          <a:bodyPr wrap="none" rtlCol="0" anchor="ctr">
-            <a:spAutoFit/>
-          </a:bodyPr>
-          <a:lstStyle/>
-          <a:p>
-            <a:r>
-              <a:rPr lang="en-US" dirty="0"/>
-              <a:t>…</a:t>
-            </a:r>
-          </a:p>
-        </p:txBody>
-      </p:sp>
-      <p:sp>
-        <p:nvSpPr>
-          <p:cNvPr id="10" name="Rectangle: Rounded Corners 9">
-            <a:extLst>
-              <a:ext uri="{FF2B5EF4-FFF2-40B4-BE49-F238E27FC236}">
-                <a16:creationId xmlns:a16="http://schemas.microsoft.com/office/drawing/2014/main" id="{B3CF4078-AF58-188A-DF99-E08A01A42DFE}"/>
-              </a:ext>
-            </a:extLst>
-          </p:cNvPr>
-          <p:cNvSpPr/>
-          <p:nvPr/>
-        </p:nvSpPr>
-        <p:spPr>
-          <a:xfrm>
-            <a:off x="1183452" y="2534516"/>
-            <a:ext cx="4014323" cy="369332"/>
-          </a:xfrm>
-          <a:prstGeom prst="roundRect">
-            <a:avLst/>
-          </a:prstGeom>
-          <a:solidFill>
-            <a:srgbClr val="B2D4EB"/>
-          </a:solidFill>
-          <a:ln>
-            <a:solidFill>
-              <a:schemeClr val="tx1"/>
-            </a:solidFill>
-          </a:ln>
-        </p:spPr>
-        <p:style>
-          <a:lnRef idx="2">
-            <a:schemeClr val="accent1">
-              <a:shade val="15000"/>
-            </a:schemeClr>
-          </a:lnRef>
-          <a:fillRef idx="1">
-            <a:schemeClr val="accent1"/>
-          </a:fillRef>
-          <a:effectRef idx="0">
-            <a:schemeClr val="accent1"/>
-          </a:effectRef>
-          <a:fontRef idx="minor">
-            <a:schemeClr val="lt1"/>
-          </a:fontRef>
-        </p:style>
-        <p:txBody>
-          <a:bodyPr rtlCol="0" anchor="ctr"/>
-          <a:lstStyle/>
-          <a:p>
-            <a:pPr algn="ctr"/>
-            <a:r>
-              <a:rPr lang="en-US" dirty="0">
-                <a:solidFill>
-                  <a:schemeClr val="tx1"/>
-                </a:solidFill>
-              </a:rPr>
-              <a:t>Security + Governance</a:t>
-            </a:r>
-            <a:endParaRPr lang="en-US" i="1" dirty="0">
-              <a:solidFill>
-                <a:schemeClr val="tx1"/>
-              </a:solidFill>
-            </a:endParaRPr>
-          </a:p>
-        </p:txBody>
-      </p:sp>
-      <p:cxnSp>
-        <p:nvCxnSpPr>
-          <p:cNvPr id="13" name="Straight Arrow Connector 12">
-            <a:extLst>
-              <a:ext uri="{FF2B5EF4-FFF2-40B4-BE49-F238E27FC236}">
-                <a16:creationId xmlns:a16="http://schemas.microsoft.com/office/drawing/2014/main" id="{B3C89E23-8123-0234-D0F1-F39C80D61B78}"/>
-              </a:ext>
-            </a:extLst>
-          </p:cNvPr>
-          <p:cNvCxnSpPr>
-            <a:stCxn id="8" idx="3"/>
-          </p:cNvCxnSpPr>
-          <p:nvPr/>
-        </p:nvCxnSpPr>
-        <p:spPr>
-          <a:xfrm>
-            <a:off x="5197775" y="1842148"/>
-            <a:ext cx="591279" cy="0"/>
-          </a:xfrm>
-          <a:prstGeom prst="straightConnector1">
-            <a:avLst/>
-          </a:prstGeom>
-          <a:ln>
-            <a:solidFill>
-              <a:schemeClr val="tx1"/>
-            </a:solidFill>
-            <a:prstDash val="sysDash"/>
-            <a:tailEnd type="triangle" w="lg" len="lg"/>
-          </a:ln>
-        </p:spPr>
-        <p:style>
-          <a:lnRef idx="2">
-            <a:schemeClr val="accent1"/>
-          </a:lnRef>
-          <a:fillRef idx="0">
-            <a:schemeClr val="accent1"/>
-          </a:fillRef>
-          <a:effectRef idx="1">
-            <a:schemeClr val="accent1"/>
-          </a:effectRef>
-          <a:fontRef idx="minor">
-            <a:schemeClr val="tx1"/>
-          </a:fontRef>
-        </p:style>
-      </p:cxnSp>
-      <p:sp>
-        <p:nvSpPr>
-          <p:cNvPr id="14" name="TextBox 13">
-            <a:extLst>
-              <a:ext uri="{FF2B5EF4-FFF2-40B4-BE49-F238E27FC236}">
-                <a16:creationId xmlns:a16="http://schemas.microsoft.com/office/drawing/2014/main" id="{DA373EA2-E891-EE8A-A28C-9322032A5F17}"/>
-              </a:ext>
-            </a:extLst>
-          </p:cNvPr>
-          <p:cNvSpPr txBox="1"/>
-          <p:nvPr/>
-        </p:nvSpPr>
-        <p:spPr>
-          <a:xfrm>
-            <a:off x="5825155" y="1518982"/>
-            <a:ext cx="2013506" cy="646331"/>
-          </a:xfrm>
-          <a:prstGeom prst="rect">
-            <a:avLst/>
-          </a:prstGeom>
-          <a:noFill/>
-        </p:spPr>
-        <p:txBody>
-          <a:bodyPr wrap="square" rtlCol="0" anchor="ctr">
-            <a:spAutoFit/>
-          </a:bodyPr>
-          <a:lstStyle/>
-          <a:p>
-            <a:r>
-              <a:rPr lang="en-US" dirty="0"/>
-              <a:t>Configure Identities, RBAC, Monitoring, etc.</a:t>
-            </a:r>
-          </a:p>
-        </p:txBody>
-      </p:sp>
-      <p:sp>
-        <p:nvSpPr>
-          <p:cNvPr id="15" name="TextBox 14">
-            <a:extLst>
-              <a:ext uri="{FF2B5EF4-FFF2-40B4-BE49-F238E27FC236}">
-                <a16:creationId xmlns:a16="http://schemas.microsoft.com/office/drawing/2014/main" id="{0121F8B3-1DDB-194B-0435-0F2F79CBA773}"/>
-              </a:ext>
-            </a:extLst>
-          </p:cNvPr>
-          <p:cNvSpPr txBox="1"/>
-          <p:nvPr/>
-        </p:nvSpPr>
-        <p:spPr>
-          <a:xfrm>
-            <a:off x="2183860" y="3429000"/>
-            <a:ext cx="2013506" cy="646331"/>
-          </a:xfrm>
-          <a:prstGeom prst="rect">
-            <a:avLst/>
-          </a:prstGeom>
-          <a:noFill/>
-        </p:spPr>
-        <p:txBody>
-          <a:bodyPr wrap="square" rtlCol="0" anchor="ctr">
-            <a:spAutoFit/>
-          </a:bodyPr>
-          <a:lstStyle/>
-          <a:p>
-            <a:pPr algn="ctr"/>
-            <a:r>
-              <a:rPr lang="en-US" dirty="0"/>
-              <a:t>Connect to Tools and Knowledge bases</a:t>
-            </a:r>
-          </a:p>
-        </p:txBody>
-      </p:sp>
-      <p:cxnSp>
-        <p:nvCxnSpPr>
-          <p:cNvPr id="16" name="Straight Arrow Connector 15">
-            <a:extLst>
-              <a:ext uri="{FF2B5EF4-FFF2-40B4-BE49-F238E27FC236}">
-                <a16:creationId xmlns:a16="http://schemas.microsoft.com/office/drawing/2014/main" id="{753FAC2D-AAEE-099D-6EBF-C4AE11D1CF5E}"/>
-              </a:ext>
-            </a:extLst>
-          </p:cNvPr>
-          <p:cNvCxnSpPr>
-            <a:cxnSpLocks/>
-            <a:stCxn id="10" idx="2"/>
-            <a:endCxn id="15" idx="0"/>
-          </p:cNvCxnSpPr>
-          <p:nvPr/>
-        </p:nvCxnSpPr>
-        <p:spPr>
-          <a:xfrm flipH="1">
-            <a:off x="3190613" y="2903848"/>
-            <a:ext cx="1" cy="525152"/>
-          </a:xfrm>
-          <a:prstGeom prst="straightConnector1">
-            <a:avLst/>
-          </a:prstGeom>
-          <a:ln>
-            <a:solidFill>
-              <a:schemeClr val="tx1"/>
-            </a:solidFill>
-            <a:prstDash val="sysDash"/>
-            <a:tailEnd type="triangle" w="lg" len="lg"/>
-          </a:ln>
-        </p:spPr>
-        <p:style>
-          <a:lnRef idx="2">
-            <a:schemeClr val="accent1"/>
-          </a:lnRef>
-          <a:fillRef idx="0">
-            <a:schemeClr val="accent1"/>
-          </a:fillRef>
-          <a:effectRef idx="1">
-            <a:schemeClr val="accent1"/>
-          </a:effectRef>
-          <a:fontRef idx="minor">
-            <a:schemeClr val="tx1"/>
-          </a:fontRef>
-        </p:style>
-      </p:cxnSp>
-    </p:spTree>
-    <p:extLst>
-      <p:ext uri="{BB962C8B-B14F-4D97-AF65-F5344CB8AC3E}">
-        <p14:creationId xmlns:p14="http://schemas.microsoft.com/office/powerpoint/2010/main" val="1065807327"/>
-      </p:ext>
-    </p:extLst>
-  </p:cSld>
-  <p:clrMapOvr>
-    <a:masterClrMapping/>
-  </p:clrMapOvr>
-</p:sld>
-</file>
-
-<file path=ppt/slides/slide20.xml><?xml version="1.0" encoding="utf-8"?>
+<file path=ppt/slides/slide18.xml><?xml version="1.0" encoding="utf-8"?>
 <p:sld xmlns:a="http://schemas.openxmlformats.org/drawingml/2006/main" xmlns:r="http://schemas.openxmlformats.org/officeDocument/2006/relationships" xmlns:p="http://schemas.openxmlformats.org/presentationml/2006/main">
   <p:cSld>
     <p:spTree>
@@ -11720,7 +12914,7 @@
 </p:sld>
 </file>
 
-<file path=ppt/slides/slide21.xml><?xml version="1.0" encoding="utf-8"?>
+<file path=ppt/slides/slide19.xml><?xml version="1.0" encoding="utf-8"?>
 <p:sld xmlns:a="http://schemas.openxmlformats.org/drawingml/2006/main" xmlns:r="http://schemas.openxmlformats.org/officeDocument/2006/relationships" xmlns:p="http://schemas.openxmlformats.org/presentationml/2006/main">
   <p:cSld>
     <p:spTree>
@@ -11819,8 +13013,8 @@
             </a:p>
           </p:txBody>
         </p:sp>
-        <mc:AlternateContent xmlns:mc="http://schemas.openxmlformats.org/markup-compatibility/2006">
-          <mc:Choice xmlns:a14="http://schemas.microsoft.com/office/drawing/2010/main" Requires="a14">
+        <mc:AlternateContent xmlns:mc="http://schemas.openxmlformats.org/markup-compatibility/2006" xmlns:a14="http://schemas.microsoft.com/office/drawing/2010/main">
+          <mc:Choice Requires="a14">
             <p:sp>
               <p:nvSpPr>
                 <p:cNvPr id="5" name="Rectangle 4">
@@ -11902,7 +13096,7 @@
               </p:txBody>
             </p:sp>
           </mc:Choice>
-          <mc:Fallback>
+          <mc:Fallback xmlns="">
             <p:sp>
               <p:nvSpPr>
                 <p:cNvPr id="5" name="Rectangle 4">
@@ -12039,8 +13233,8 @@
             </a:p>
           </p:txBody>
         </p:sp>
-        <mc:AlternateContent xmlns:mc="http://schemas.openxmlformats.org/markup-compatibility/2006">
-          <mc:Choice xmlns:a14="http://schemas.microsoft.com/office/drawing/2010/main" Requires="a14">
+        <mc:AlternateContent xmlns:mc="http://schemas.openxmlformats.org/markup-compatibility/2006" xmlns:a14="http://schemas.microsoft.com/office/drawing/2010/main">
+          <mc:Choice Requires="a14">
             <p:sp>
               <p:nvSpPr>
                 <p:cNvPr id="8" name="Rectangle 7">
@@ -12205,7 +13399,7 @@
               </p:txBody>
             </p:sp>
           </mc:Choice>
-          <mc:Fallback>
+          <mc:Fallback xmlns="">
             <p:sp>
               <p:nvSpPr>
                 <p:cNvPr id="8" name="Rectangle 7">
@@ -12250,8 +13444,8 @@
             </p:sp>
           </mc:Fallback>
         </mc:AlternateContent>
-        <mc:AlternateContent xmlns:mc="http://schemas.openxmlformats.org/markup-compatibility/2006">
-          <mc:Choice xmlns:a14="http://schemas.microsoft.com/office/drawing/2010/main" Requires="a14">
+        <mc:AlternateContent xmlns:mc="http://schemas.openxmlformats.org/markup-compatibility/2006" xmlns:a14="http://schemas.microsoft.com/office/drawing/2010/main">
+          <mc:Choice Requires="a14">
             <p:sp>
               <p:nvSpPr>
                 <p:cNvPr id="9" name="TextBox 8">
@@ -12396,7 +13590,7 @@
               </p:txBody>
             </p:sp>
           </mc:Choice>
-          <mc:Fallback>
+          <mc:Fallback xmlns="">
             <p:sp>
               <p:nvSpPr>
                 <p:cNvPr id="9" name="TextBox 8">
@@ -12497,8 +13691,8 @@
             </a:p>
           </p:txBody>
         </p:sp>
-        <mc:AlternateContent xmlns:mc="http://schemas.openxmlformats.org/markup-compatibility/2006">
-          <mc:Choice xmlns:a14="http://schemas.microsoft.com/office/drawing/2010/main" Requires="a14">
+        <mc:AlternateContent xmlns:mc="http://schemas.openxmlformats.org/markup-compatibility/2006" xmlns:a14="http://schemas.microsoft.com/office/drawing/2010/main">
+          <mc:Choice Requires="a14">
             <p:sp>
               <p:nvSpPr>
                 <p:cNvPr id="11" name="Rectangle 10">
@@ -12716,7 +13910,7 @@
               </p:txBody>
             </p:sp>
           </mc:Choice>
-          <mc:Fallback>
+          <mc:Fallback xmlns="">
             <p:sp>
               <p:nvSpPr>
                 <p:cNvPr id="11" name="Rectangle 10">
@@ -12853,8 +14047,8 @@
             </a:p>
           </p:txBody>
         </p:sp>
-        <mc:AlternateContent xmlns:mc="http://schemas.openxmlformats.org/markup-compatibility/2006">
-          <mc:Choice xmlns:a14="http://schemas.microsoft.com/office/drawing/2010/main" Requires="a14">
+        <mc:AlternateContent xmlns:mc="http://schemas.openxmlformats.org/markup-compatibility/2006" xmlns:a14="http://schemas.microsoft.com/office/drawing/2010/main">
+          <mc:Choice Requires="a14">
             <p:sp>
               <p:nvSpPr>
                 <p:cNvPr id="14" name="Rectangle 13">
@@ -13090,7 +14284,7 @@
               </p:txBody>
             </p:sp>
           </mc:Choice>
-          <mc:Fallback>
+          <mc:Fallback xmlns="">
             <p:sp>
               <p:nvSpPr>
                 <p:cNvPr id="14" name="Rectangle 13">
@@ -13330,8 +14524,8 @@
             </a:p>
           </p:txBody>
         </p:sp>
-        <mc:AlternateContent xmlns:mc="http://schemas.openxmlformats.org/markup-compatibility/2006">
-          <mc:Choice xmlns:a14="http://schemas.microsoft.com/office/drawing/2010/main" Requires="a14">
+        <mc:AlternateContent xmlns:mc="http://schemas.openxmlformats.org/markup-compatibility/2006" xmlns:a14="http://schemas.microsoft.com/office/drawing/2010/main">
+          <mc:Choice Requires="a14">
             <p:sp>
               <p:nvSpPr>
                 <p:cNvPr id="19" name="Rectangle 18">
@@ -13482,7 +14676,7 @@
               </p:txBody>
             </p:sp>
           </mc:Choice>
-          <mc:Fallback>
+          <mc:Fallback xmlns="">
             <p:sp>
               <p:nvSpPr>
                 <p:cNvPr id="19" name="Rectangle 18">
@@ -13619,8 +14813,8 @@
             </a:p>
           </p:txBody>
         </p:sp>
-        <mc:AlternateContent xmlns:mc="http://schemas.openxmlformats.org/markup-compatibility/2006">
-          <mc:Choice xmlns:a14="http://schemas.microsoft.com/office/drawing/2010/main" Requires="a14">
+        <mc:AlternateContent xmlns:mc="http://schemas.openxmlformats.org/markup-compatibility/2006" xmlns:a14="http://schemas.microsoft.com/office/drawing/2010/main">
+          <mc:Choice Requires="a14">
             <p:sp>
               <p:nvSpPr>
                 <p:cNvPr id="22" name="Rectangle 21">
@@ -13774,7 +14968,7 @@
               </p:txBody>
             </p:sp>
           </mc:Choice>
-          <mc:Fallback>
+          <mc:Fallback xmlns="">
             <p:sp>
               <p:nvSpPr>
                 <p:cNvPr id="22" name="Rectangle 21">
@@ -14014,7 +15208,853 @@
 </p:sld>
 </file>
 
+<file path=ppt/slides/slide2.xml><?xml version="1.0" encoding="utf-8"?>
+<p:sld xmlns:a="http://schemas.openxmlformats.org/drawingml/2006/main" xmlns:r="http://schemas.openxmlformats.org/officeDocument/2006/relationships" xmlns:p="http://schemas.openxmlformats.org/presentationml/2006/main">
+  <p:cSld>
+    <p:spTree>
+      <p:nvGrpSpPr>
+        <p:cNvPr id="1" name=""/>
+        <p:cNvGrpSpPr/>
+        <p:nvPr/>
+      </p:nvGrpSpPr>
+      <p:grpSpPr>
+        <a:xfrm>
+          <a:off x="0" y="0"/>
+          <a:ext cx="0" cy="0"/>
+          <a:chOff x="0" y="0"/>
+          <a:chExt cx="0" cy="0"/>
+        </a:xfrm>
+      </p:grpSpPr>
+      <p:pic>
+        <p:nvPicPr>
+          <p:cNvPr id="2050" name="Picture 2" descr="Diagram showing Foundry resource containing multiple projects, each with deployments and connections.">
+            <a:extLst>
+              <a:ext uri="{FF2B5EF4-FFF2-40B4-BE49-F238E27FC236}">
+                <a16:creationId xmlns:a16="http://schemas.microsoft.com/office/drawing/2014/main" id="{12EEA84E-8776-00EF-5D97-05E8737B61E3}"/>
+              </a:ext>
+            </a:extLst>
+          </p:cNvPr>
+          <p:cNvPicPr>
+            <a:picLocks noChangeAspect="1" noChangeArrowheads="1"/>
+          </p:cNvPicPr>
+          <p:nvPr/>
+        </p:nvPicPr>
+        <p:blipFill>
+          <a:blip r:embed="rId3">
+            <a:clrChange>
+              <a:clrFrom>
+                <a:srgbClr val="FFFFFF"/>
+              </a:clrFrom>
+              <a:clrTo>
+                <a:srgbClr val="FFFFFF">
+                  <a:alpha val="0"/>
+                </a:srgbClr>
+              </a:clrTo>
+            </a:clrChange>
+            <a:extLst>
+              <a:ext uri="{28A0092B-C50C-407E-A947-70E740481C1C}">
+                <a14:useLocalDpi xmlns:a14="http://schemas.microsoft.com/office/drawing/2010/main" val="0"/>
+              </a:ext>
+            </a:extLst>
+          </a:blip>
+          <a:srcRect/>
+          <a:stretch>
+            <a:fillRect/>
+          </a:stretch>
+        </p:blipFill>
+        <p:spPr bwMode="auto">
+          <a:xfrm>
+            <a:off x="6607866" y="3166424"/>
+            <a:ext cx="5524500" cy="3667125"/>
+          </a:xfrm>
+          <a:prstGeom prst="rect">
+            <a:avLst/>
+          </a:prstGeom>
+          <a:noFill/>
+          <a:extLst>
+            <a:ext uri="{909E8E84-426E-40DD-AFC4-6F175D3DCCD1}">
+              <a14:hiddenFill xmlns:a14="http://schemas.microsoft.com/office/drawing/2010/main">
+                <a:solidFill>
+                  <a:srgbClr val="FFFFFF"/>
+                </a:solidFill>
+              </a14:hiddenFill>
+            </a:ext>
+          </a:extLst>
+        </p:spPr>
+      </p:pic>
+      <p:sp>
+        <p:nvSpPr>
+          <p:cNvPr id="4" name="Rectangle: Rounded Corners 3">
+            <a:extLst>
+              <a:ext uri="{FF2B5EF4-FFF2-40B4-BE49-F238E27FC236}">
+                <a16:creationId xmlns:a16="http://schemas.microsoft.com/office/drawing/2014/main" id="{F839DD77-409D-94ED-8A62-6F53CBB88ADD}"/>
+              </a:ext>
+            </a:extLst>
+          </p:cNvPr>
+          <p:cNvSpPr/>
+          <p:nvPr/>
+        </p:nvSpPr>
+        <p:spPr>
+          <a:xfrm>
+            <a:off x="962568" y="732317"/>
+            <a:ext cx="4456090" cy="2434107"/>
+          </a:xfrm>
+          <a:prstGeom prst="roundRect">
+            <a:avLst>
+              <a:gd name="adj" fmla="val 5234"/>
+            </a:avLst>
+          </a:prstGeom>
+          <a:solidFill>
+            <a:schemeClr val="bg1"/>
+          </a:solidFill>
+          <a:ln>
+            <a:solidFill>
+              <a:schemeClr val="tx1"/>
+            </a:solidFill>
+          </a:ln>
+        </p:spPr>
+        <p:style>
+          <a:lnRef idx="2">
+            <a:schemeClr val="accent1">
+              <a:shade val="15000"/>
+            </a:schemeClr>
+          </a:lnRef>
+          <a:fillRef idx="1">
+            <a:schemeClr val="accent1"/>
+          </a:fillRef>
+          <a:effectRef idx="0">
+            <a:schemeClr val="accent1"/>
+          </a:effectRef>
+          <a:fontRef idx="minor">
+            <a:schemeClr val="lt1"/>
+          </a:fontRef>
+        </p:style>
+        <p:txBody>
+          <a:bodyPr rtlCol="0" anchor="t"/>
+          <a:lstStyle/>
+          <a:p>
+            <a:pPr algn="ctr"/>
+            <a:r>
+              <a:rPr lang="en-US" dirty="0">
+                <a:solidFill>
+                  <a:schemeClr val="tx1"/>
+                </a:solidFill>
+              </a:rPr>
+              <a:t>Foundry Resource</a:t>
+            </a:r>
+          </a:p>
+        </p:txBody>
+      </p:sp>
+      <p:sp>
+        <p:nvSpPr>
+          <p:cNvPr id="5" name="Rectangle: Rounded Corners 4">
+            <a:extLst>
+              <a:ext uri="{FF2B5EF4-FFF2-40B4-BE49-F238E27FC236}">
+                <a16:creationId xmlns:a16="http://schemas.microsoft.com/office/drawing/2014/main" id="{CFAF0893-8AEC-1DBB-B036-2949BA0795A0}"/>
+              </a:ext>
+            </a:extLst>
+          </p:cNvPr>
+          <p:cNvSpPr/>
+          <p:nvPr/>
+        </p:nvSpPr>
+        <p:spPr>
+          <a:xfrm>
+            <a:off x="2410311" y="1494888"/>
+            <a:ext cx="1080042" cy="694520"/>
+          </a:xfrm>
+          <a:prstGeom prst="roundRect">
+            <a:avLst/>
+          </a:prstGeom>
+          <a:solidFill>
+            <a:srgbClr val="E5F1F8"/>
+          </a:solidFill>
+          <a:ln>
+            <a:solidFill>
+              <a:schemeClr val="tx1"/>
+            </a:solidFill>
+          </a:ln>
+        </p:spPr>
+        <p:style>
+          <a:lnRef idx="2">
+            <a:schemeClr val="accent1">
+              <a:shade val="15000"/>
+            </a:schemeClr>
+          </a:lnRef>
+          <a:fillRef idx="1">
+            <a:schemeClr val="accent1"/>
+          </a:fillRef>
+          <a:effectRef idx="0">
+            <a:schemeClr val="accent1"/>
+          </a:effectRef>
+          <a:fontRef idx="minor">
+            <a:schemeClr val="lt1"/>
+          </a:fontRef>
+        </p:style>
+        <p:txBody>
+          <a:bodyPr rtlCol="0" anchor="ctr"/>
+          <a:lstStyle/>
+          <a:p>
+            <a:pPr algn="ctr"/>
+            <a:r>
+              <a:rPr lang="en-US" dirty="0">
+                <a:solidFill>
+                  <a:schemeClr val="tx1"/>
+                </a:solidFill>
+              </a:rPr>
+              <a:t>Project</a:t>
+            </a:r>
+          </a:p>
+          <a:p>
+            <a:pPr algn="ctr"/>
+            <a:r>
+              <a:rPr lang="en-US" dirty="0">
+                <a:solidFill>
+                  <a:schemeClr val="tx1"/>
+                </a:solidFill>
+              </a:rPr>
+              <a:t>2</a:t>
+            </a:r>
+          </a:p>
+        </p:txBody>
+      </p:sp>
+      <p:sp>
+        <p:nvSpPr>
+          <p:cNvPr id="6" name="Rectangle: Rounded Corners 5">
+            <a:extLst>
+              <a:ext uri="{FF2B5EF4-FFF2-40B4-BE49-F238E27FC236}">
+                <a16:creationId xmlns:a16="http://schemas.microsoft.com/office/drawing/2014/main" id="{A7E630FB-2D59-D6DB-B847-29F7E0317AFA}"/>
+              </a:ext>
+            </a:extLst>
+          </p:cNvPr>
+          <p:cNvSpPr/>
+          <p:nvPr/>
+        </p:nvSpPr>
+        <p:spPr>
+          <a:xfrm>
+            <a:off x="1183452" y="1494888"/>
+            <a:ext cx="1080042" cy="694520"/>
+          </a:xfrm>
+          <a:prstGeom prst="roundRect">
+            <a:avLst/>
+          </a:prstGeom>
+          <a:solidFill>
+            <a:srgbClr val="E5F1F8"/>
+          </a:solidFill>
+          <a:ln>
+            <a:solidFill>
+              <a:schemeClr val="tx1"/>
+            </a:solidFill>
+          </a:ln>
+        </p:spPr>
+        <p:style>
+          <a:lnRef idx="2">
+            <a:schemeClr val="accent1">
+              <a:shade val="15000"/>
+            </a:schemeClr>
+          </a:lnRef>
+          <a:fillRef idx="1">
+            <a:schemeClr val="accent1"/>
+          </a:fillRef>
+          <a:effectRef idx="0">
+            <a:schemeClr val="accent1"/>
+          </a:effectRef>
+          <a:fontRef idx="minor">
+            <a:schemeClr val="lt1"/>
+          </a:fontRef>
+        </p:style>
+        <p:txBody>
+          <a:bodyPr rtlCol="0" anchor="ctr"/>
+          <a:lstStyle/>
+          <a:p>
+            <a:pPr algn="ctr"/>
+            <a:r>
+              <a:rPr lang="en-US" dirty="0">
+                <a:solidFill>
+                  <a:schemeClr val="tx1"/>
+                </a:solidFill>
+              </a:rPr>
+              <a:t>Project</a:t>
+            </a:r>
+          </a:p>
+          <a:p>
+            <a:pPr algn="ctr"/>
+            <a:r>
+              <a:rPr lang="en-US" dirty="0">
+                <a:solidFill>
+                  <a:schemeClr val="tx1"/>
+                </a:solidFill>
+              </a:rPr>
+              <a:t>1</a:t>
+            </a:r>
+          </a:p>
+        </p:txBody>
+      </p:sp>
+      <p:sp>
+        <p:nvSpPr>
+          <p:cNvPr id="8" name="Rectangle: Rounded Corners 7">
+            <a:extLst>
+              <a:ext uri="{FF2B5EF4-FFF2-40B4-BE49-F238E27FC236}">
+                <a16:creationId xmlns:a16="http://schemas.microsoft.com/office/drawing/2014/main" id="{5E9103F9-368F-E4D0-C17C-BF0F1C74D31A}"/>
+              </a:ext>
+            </a:extLst>
+          </p:cNvPr>
+          <p:cNvSpPr/>
+          <p:nvPr/>
+        </p:nvSpPr>
+        <p:spPr>
+          <a:xfrm>
+            <a:off x="4117733" y="1494888"/>
+            <a:ext cx="1080042" cy="694520"/>
+          </a:xfrm>
+          <a:prstGeom prst="roundRect">
+            <a:avLst/>
+          </a:prstGeom>
+          <a:solidFill>
+            <a:srgbClr val="B2D4EB"/>
+          </a:solidFill>
+          <a:ln>
+            <a:solidFill>
+              <a:schemeClr val="tx1"/>
+            </a:solidFill>
+          </a:ln>
+        </p:spPr>
+        <p:style>
+          <a:lnRef idx="2">
+            <a:schemeClr val="accent1">
+              <a:shade val="15000"/>
+            </a:schemeClr>
+          </a:lnRef>
+          <a:fillRef idx="1">
+            <a:schemeClr val="accent1"/>
+          </a:fillRef>
+          <a:effectRef idx="0">
+            <a:schemeClr val="accent1"/>
+          </a:effectRef>
+          <a:fontRef idx="minor">
+            <a:schemeClr val="lt1"/>
+          </a:fontRef>
+        </p:style>
+        <p:txBody>
+          <a:bodyPr rtlCol="0" anchor="ctr"/>
+          <a:lstStyle/>
+          <a:p>
+            <a:pPr algn="ctr"/>
+            <a:r>
+              <a:rPr lang="en-US" dirty="0">
+                <a:solidFill>
+                  <a:schemeClr val="tx1"/>
+                </a:solidFill>
+              </a:rPr>
+              <a:t>Project</a:t>
+            </a:r>
+          </a:p>
+          <a:p>
+            <a:pPr algn="ctr"/>
+            <a:r>
+              <a:rPr lang="en-US" i="1" dirty="0">
+                <a:solidFill>
+                  <a:schemeClr val="tx1"/>
+                </a:solidFill>
+              </a:rPr>
+              <a:t>n</a:t>
+            </a:r>
+          </a:p>
+        </p:txBody>
+      </p:sp>
+      <p:sp>
+        <p:nvSpPr>
+          <p:cNvPr id="9" name="TextBox 8">
+            <a:extLst>
+              <a:ext uri="{FF2B5EF4-FFF2-40B4-BE49-F238E27FC236}">
+                <a16:creationId xmlns:a16="http://schemas.microsoft.com/office/drawing/2014/main" id="{C992B776-2029-F35D-E69F-FB22F1454014}"/>
+              </a:ext>
+            </a:extLst>
+          </p:cNvPr>
+          <p:cNvSpPr txBox="1"/>
+          <p:nvPr/>
+        </p:nvSpPr>
+        <p:spPr>
+          <a:xfrm>
+            <a:off x="3637170" y="1657482"/>
+            <a:ext cx="333746" cy="369332"/>
+          </a:xfrm>
+          <a:prstGeom prst="rect">
+            <a:avLst/>
+          </a:prstGeom>
+          <a:noFill/>
+        </p:spPr>
+        <p:txBody>
+          <a:bodyPr wrap="none" rtlCol="0" anchor="ctr">
+            <a:spAutoFit/>
+          </a:bodyPr>
+          <a:lstStyle/>
+          <a:p>
+            <a:r>
+              <a:rPr lang="en-US" dirty="0"/>
+              <a:t>…</a:t>
+            </a:r>
+          </a:p>
+        </p:txBody>
+      </p:sp>
+      <p:sp>
+        <p:nvSpPr>
+          <p:cNvPr id="10" name="Rectangle: Rounded Corners 9">
+            <a:extLst>
+              <a:ext uri="{FF2B5EF4-FFF2-40B4-BE49-F238E27FC236}">
+                <a16:creationId xmlns:a16="http://schemas.microsoft.com/office/drawing/2014/main" id="{B3CF4078-AF58-188A-DF99-E08A01A42DFE}"/>
+              </a:ext>
+            </a:extLst>
+          </p:cNvPr>
+          <p:cNvSpPr/>
+          <p:nvPr/>
+        </p:nvSpPr>
+        <p:spPr>
+          <a:xfrm>
+            <a:off x="1183452" y="2534516"/>
+            <a:ext cx="4014323" cy="369332"/>
+          </a:xfrm>
+          <a:prstGeom prst="roundRect">
+            <a:avLst/>
+          </a:prstGeom>
+          <a:solidFill>
+            <a:srgbClr val="B2D4EB"/>
+          </a:solidFill>
+          <a:ln>
+            <a:solidFill>
+              <a:schemeClr val="tx1"/>
+            </a:solidFill>
+          </a:ln>
+        </p:spPr>
+        <p:style>
+          <a:lnRef idx="2">
+            <a:schemeClr val="accent1">
+              <a:shade val="15000"/>
+            </a:schemeClr>
+          </a:lnRef>
+          <a:fillRef idx="1">
+            <a:schemeClr val="accent1"/>
+          </a:fillRef>
+          <a:effectRef idx="0">
+            <a:schemeClr val="accent1"/>
+          </a:effectRef>
+          <a:fontRef idx="minor">
+            <a:schemeClr val="lt1"/>
+          </a:fontRef>
+        </p:style>
+        <p:txBody>
+          <a:bodyPr rtlCol="0" anchor="ctr"/>
+          <a:lstStyle/>
+          <a:p>
+            <a:pPr algn="ctr"/>
+            <a:r>
+              <a:rPr lang="en-US" dirty="0">
+                <a:solidFill>
+                  <a:schemeClr val="tx1"/>
+                </a:solidFill>
+              </a:rPr>
+              <a:t>Security + Governance</a:t>
+            </a:r>
+            <a:endParaRPr lang="en-US" i="1" dirty="0">
+              <a:solidFill>
+                <a:schemeClr val="tx1"/>
+              </a:solidFill>
+            </a:endParaRPr>
+          </a:p>
+        </p:txBody>
+      </p:sp>
+      <p:cxnSp>
+        <p:nvCxnSpPr>
+          <p:cNvPr id="13" name="Straight Arrow Connector 12">
+            <a:extLst>
+              <a:ext uri="{FF2B5EF4-FFF2-40B4-BE49-F238E27FC236}">
+                <a16:creationId xmlns:a16="http://schemas.microsoft.com/office/drawing/2014/main" id="{B3C89E23-8123-0234-D0F1-F39C80D61B78}"/>
+              </a:ext>
+            </a:extLst>
+          </p:cNvPr>
+          <p:cNvCxnSpPr>
+            <a:stCxn id="8" idx="3"/>
+          </p:cNvCxnSpPr>
+          <p:nvPr/>
+        </p:nvCxnSpPr>
+        <p:spPr>
+          <a:xfrm>
+            <a:off x="5197775" y="1842148"/>
+            <a:ext cx="591279" cy="0"/>
+          </a:xfrm>
+          <a:prstGeom prst="straightConnector1">
+            <a:avLst/>
+          </a:prstGeom>
+          <a:ln>
+            <a:solidFill>
+              <a:schemeClr val="tx1"/>
+            </a:solidFill>
+            <a:prstDash val="sysDash"/>
+            <a:tailEnd type="triangle" w="lg" len="lg"/>
+          </a:ln>
+        </p:spPr>
+        <p:style>
+          <a:lnRef idx="2">
+            <a:schemeClr val="accent1"/>
+          </a:lnRef>
+          <a:fillRef idx="0">
+            <a:schemeClr val="accent1"/>
+          </a:fillRef>
+          <a:effectRef idx="1">
+            <a:schemeClr val="accent1"/>
+          </a:effectRef>
+          <a:fontRef idx="minor">
+            <a:schemeClr val="tx1"/>
+          </a:fontRef>
+        </p:style>
+      </p:cxnSp>
+      <p:sp>
+        <p:nvSpPr>
+          <p:cNvPr id="14" name="TextBox 13">
+            <a:extLst>
+              <a:ext uri="{FF2B5EF4-FFF2-40B4-BE49-F238E27FC236}">
+                <a16:creationId xmlns:a16="http://schemas.microsoft.com/office/drawing/2014/main" id="{DA373EA2-E891-EE8A-A28C-9322032A5F17}"/>
+              </a:ext>
+            </a:extLst>
+          </p:cNvPr>
+          <p:cNvSpPr txBox="1"/>
+          <p:nvPr/>
+        </p:nvSpPr>
+        <p:spPr>
+          <a:xfrm>
+            <a:off x="5825155" y="1518982"/>
+            <a:ext cx="2013506" cy="646331"/>
+          </a:xfrm>
+          <a:prstGeom prst="rect">
+            <a:avLst/>
+          </a:prstGeom>
+          <a:noFill/>
+        </p:spPr>
+        <p:txBody>
+          <a:bodyPr wrap="square" rtlCol="0" anchor="ctr">
+            <a:spAutoFit/>
+          </a:bodyPr>
+          <a:lstStyle/>
+          <a:p>
+            <a:r>
+              <a:rPr lang="en-US" dirty="0"/>
+              <a:t>Configure Identities, RBAC, Monitoring, etc.</a:t>
+            </a:r>
+          </a:p>
+        </p:txBody>
+      </p:sp>
+      <p:sp>
+        <p:nvSpPr>
+          <p:cNvPr id="15" name="TextBox 14">
+            <a:extLst>
+              <a:ext uri="{FF2B5EF4-FFF2-40B4-BE49-F238E27FC236}">
+                <a16:creationId xmlns:a16="http://schemas.microsoft.com/office/drawing/2014/main" id="{0121F8B3-1DDB-194B-0435-0F2F79CBA773}"/>
+              </a:ext>
+            </a:extLst>
+          </p:cNvPr>
+          <p:cNvSpPr txBox="1"/>
+          <p:nvPr/>
+        </p:nvSpPr>
+        <p:spPr>
+          <a:xfrm>
+            <a:off x="2183860" y="3429000"/>
+            <a:ext cx="2013506" cy="646331"/>
+          </a:xfrm>
+          <a:prstGeom prst="rect">
+            <a:avLst/>
+          </a:prstGeom>
+          <a:noFill/>
+        </p:spPr>
+        <p:txBody>
+          <a:bodyPr wrap="square" rtlCol="0" anchor="ctr">
+            <a:spAutoFit/>
+          </a:bodyPr>
+          <a:lstStyle/>
+          <a:p>
+            <a:pPr algn="ctr"/>
+            <a:r>
+              <a:rPr lang="en-US" dirty="0"/>
+              <a:t>Connect to Tools and Knowledge bases</a:t>
+            </a:r>
+          </a:p>
+        </p:txBody>
+      </p:sp>
+      <p:cxnSp>
+        <p:nvCxnSpPr>
+          <p:cNvPr id="16" name="Straight Arrow Connector 15">
+            <a:extLst>
+              <a:ext uri="{FF2B5EF4-FFF2-40B4-BE49-F238E27FC236}">
+                <a16:creationId xmlns:a16="http://schemas.microsoft.com/office/drawing/2014/main" id="{753FAC2D-AAEE-099D-6EBF-C4AE11D1CF5E}"/>
+              </a:ext>
+            </a:extLst>
+          </p:cNvPr>
+          <p:cNvCxnSpPr>
+            <a:cxnSpLocks/>
+            <a:stCxn id="10" idx="2"/>
+            <a:endCxn id="15" idx="0"/>
+          </p:cNvCxnSpPr>
+          <p:nvPr/>
+        </p:nvCxnSpPr>
+        <p:spPr>
+          <a:xfrm flipH="1">
+            <a:off x="3190613" y="2903848"/>
+            <a:ext cx="1" cy="525152"/>
+          </a:xfrm>
+          <a:prstGeom prst="straightConnector1">
+            <a:avLst/>
+          </a:prstGeom>
+          <a:ln>
+            <a:solidFill>
+              <a:schemeClr val="tx1"/>
+            </a:solidFill>
+            <a:prstDash val="sysDash"/>
+            <a:tailEnd type="triangle" w="lg" len="lg"/>
+          </a:ln>
+        </p:spPr>
+        <p:style>
+          <a:lnRef idx="2">
+            <a:schemeClr val="accent1"/>
+          </a:lnRef>
+          <a:fillRef idx="0">
+            <a:schemeClr val="accent1"/>
+          </a:fillRef>
+          <a:effectRef idx="1">
+            <a:schemeClr val="accent1"/>
+          </a:effectRef>
+          <a:fontRef idx="minor">
+            <a:schemeClr val="tx1"/>
+          </a:fontRef>
+        </p:style>
+      </p:cxnSp>
+    </p:spTree>
+    <p:extLst>
+      <p:ext uri="{BB962C8B-B14F-4D97-AF65-F5344CB8AC3E}">
+        <p14:creationId xmlns:p14="http://schemas.microsoft.com/office/powerpoint/2010/main" val="1065807327"/>
+      </p:ext>
+    </p:extLst>
+  </p:cSld>
+  <p:clrMapOvr>
+    <a:masterClrMapping/>
+  </p:clrMapOvr>
+</p:sld>
+</file>
+
+<file path=ppt/slides/slide20.xml><?xml version="1.0" encoding="utf-8"?>
+<p:sld xmlns:a="http://schemas.openxmlformats.org/drawingml/2006/main" xmlns:r="http://schemas.openxmlformats.org/officeDocument/2006/relationships" xmlns:p="http://schemas.openxmlformats.org/presentationml/2006/main">
+  <p:cSld>
+    <p:spTree>
+      <p:nvGrpSpPr>
+        <p:cNvPr id="1" name=""/>
+        <p:cNvGrpSpPr/>
+        <p:nvPr/>
+      </p:nvGrpSpPr>
+      <p:grpSpPr>
+        <a:xfrm>
+          <a:off x="0" y="0"/>
+          <a:ext cx="0" cy="0"/>
+          <a:chOff x="0" y="0"/>
+          <a:chExt cx="0" cy="0"/>
+        </a:xfrm>
+      </p:grpSpPr>
+      <p:pic>
+        <p:nvPicPr>
+          <p:cNvPr id="3" name="Picture 2">
+            <a:extLst>
+              <a:ext uri="{FF2B5EF4-FFF2-40B4-BE49-F238E27FC236}">
+                <a16:creationId xmlns:a16="http://schemas.microsoft.com/office/drawing/2014/main" id="{EE4867BA-66DD-B140-5528-856BCA343CD6}"/>
+              </a:ext>
+            </a:extLst>
+          </p:cNvPr>
+          <p:cNvPicPr>
+            <a:picLocks noChangeAspect="1"/>
+          </p:cNvPicPr>
+          <p:nvPr/>
+        </p:nvPicPr>
+        <p:blipFill>
+          <a:blip r:embed="rId2"/>
+          <a:stretch>
+            <a:fillRect/>
+          </a:stretch>
+        </p:blipFill>
+        <p:spPr>
+          <a:xfrm>
+            <a:off x="0" y="99063"/>
+            <a:ext cx="12192000" cy="6659873"/>
+          </a:xfrm>
+          <a:prstGeom prst="rect">
+            <a:avLst/>
+          </a:prstGeom>
+        </p:spPr>
+      </p:pic>
+    </p:spTree>
+    <p:extLst>
+      <p:ext uri="{BB962C8B-B14F-4D97-AF65-F5344CB8AC3E}">
+        <p14:creationId xmlns:p14="http://schemas.microsoft.com/office/powerpoint/2010/main" val="276189202"/>
+      </p:ext>
+    </p:extLst>
+  </p:cSld>
+  <p:clrMapOvr>
+    <a:masterClrMapping/>
+  </p:clrMapOvr>
+</p:sld>
+</file>
+
+<file path=ppt/slides/slide21.xml><?xml version="1.0" encoding="utf-8"?>
+<p:sld xmlns:a="http://schemas.openxmlformats.org/drawingml/2006/main" xmlns:r="http://schemas.openxmlformats.org/officeDocument/2006/relationships" xmlns:p="http://schemas.openxmlformats.org/presentationml/2006/main">
+  <p:cSld>
+    <p:spTree>
+      <p:nvGrpSpPr>
+        <p:cNvPr id="1" name="">
+          <a:extLst>
+            <a:ext uri="{FF2B5EF4-FFF2-40B4-BE49-F238E27FC236}">
+              <a16:creationId xmlns:a16="http://schemas.microsoft.com/office/drawing/2014/main" id="{677E65E1-5DF3-2FE1-BF1F-36B02D0FEC76}"/>
+            </a:ext>
+          </a:extLst>
+        </p:cNvPr>
+        <p:cNvGrpSpPr/>
+        <p:nvPr/>
+      </p:nvGrpSpPr>
+      <p:grpSpPr>
+        <a:xfrm>
+          <a:off x="0" y="0"/>
+          <a:ext cx="0" cy="0"/>
+          <a:chOff x="0" y="0"/>
+          <a:chExt cx="0" cy="0"/>
+        </a:xfrm>
+      </p:grpSpPr>
+      <p:pic>
+        <p:nvPicPr>
+          <p:cNvPr id="3" name="Picture 2">
+            <a:extLst>
+              <a:ext uri="{FF2B5EF4-FFF2-40B4-BE49-F238E27FC236}">
+                <a16:creationId xmlns:a16="http://schemas.microsoft.com/office/drawing/2014/main" id="{8F0F888E-6C37-17E1-670D-996346E71810}"/>
+              </a:ext>
+            </a:extLst>
+          </p:cNvPr>
+          <p:cNvPicPr>
+            <a:picLocks noChangeAspect="1"/>
+          </p:cNvPicPr>
+          <p:nvPr/>
+        </p:nvPicPr>
+        <p:blipFill>
+          <a:blip r:embed="rId2"/>
+          <a:stretch>
+            <a:fillRect/>
+          </a:stretch>
+        </p:blipFill>
+        <p:spPr>
+          <a:xfrm>
+            <a:off x="0" y="1214427"/>
+            <a:ext cx="12192000" cy="4429145"/>
+          </a:xfrm>
+          <a:prstGeom prst="rect">
+            <a:avLst/>
+          </a:prstGeom>
+        </p:spPr>
+      </p:pic>
+    </p:spTree>
+    <p:extLst>
+      <p:ext uri="{BB962C8B-B14F-4D97-AF65-F5344CB8AC3E}">
+        <p14:creationId xmlns:p14="http://schemas.microsoft.com/office/powerpoint/2010/main" val="3483502725"/>
+      </p:ext>
+    </p:extLst>
+  </p:cSld>
+  <p:clrMapOvr>
+    <a:masterClrMapping/>
+  </p:clrMapOvr>
+</p:sld>
+</file>
+
 <file path=ppt/slides/slide22.xml><?xml version="1.0" encoding="utf-8"?>
+<p:sld xmlns:a="http://schemas.openxmlformats.org/drawingml/2006/main" xmlns:r="http://schemas.openxmlformats.org/officeDocument/2006/relationships" xmlns:p="http://schemas.openxmlformats.org/presentationml/2006/main">
+  <p:cSld>
+    <p:spTree>
+      <p:nvGrpSpPr>
+        <p:cNvPr id="1" name=""/>
+        <p:cNvGrpSpPr/>
+        <p:nvPr/>
+      </p:nvGrpSpPr>
+      <p:grpSpPr>
+        <a:xfrm>
+          <a:off x="0" y="0"/>
+          <a:ext cx="0" cy="0"/>
+          <a:chOff x="0" y="0"/>
+          <a:chExt cx="0" cy="0"/>
+        </a:xfrm>
+      </p:grpSpPr>
+      <p:pic>
+        <p:nvPicPr>
+          <p:cNvPr id="3" name="Picture 2">
+            <a:extLst>
+              <a:ext uri="{FF2B5EF4-FFF2-40B4-BE49-F238E27FC236}">
+                <a16:creationId xmlns:a16="http://schemas.microsoft.com/office/drawing/2014/main" id="{5A667DA2-6815-DE2B-768E-FDE43E3CE7EB}"/>
+              </a:ext>
+            </a:extLst>
+          </p:cNvPr>
+          <p:cNvPicPr>
+            <a:picLocks noChangeAspect="1"/>
+          </p:cNvPicPr>
+          <p:nvPr/>
+        </p:nvPicPr>
+        <p:blipFill>
+          <a:blip r:embed="rId2"/>
+          <a:stretch>
+            <a:fillRect/>
+          </a:stretch>
+        </p:blipFill>
+        <p:spPr>
+          <a:xfrm>
+            <a:off x="0" y="0"/>
+            <a:ext cx="7078980" cy="3865170"/>
+          </a:xfrm>
+          <a:prstGeom prst="rect">
+            <a:avLst/>
+          </a:prstGeom>
+        </p:spPr>
+      </p:pic>
+      <p:pic>
+        <p:nvPicPr>
+          <p:cNvPr id="5" name="Picture 4">
+            <a:extLst>
+              <a:ext uri="{FF2B5EF4-FFF2-40B4-BE49-F238E27FC236}">
+                <a16:creationId xmlns:a16="http://schemas.microsoft.com/office/drawing/2014/main" id="{3B15023E-4451-73EF-7EF8-DE3379C381B6}"/>
+              </a:ext>
+            </a:extLst>
+          </p:cNvPr>
+          <p:cNvPicPr>
+            <a:picLocks noChangeAspect="1"/>
+          </p:cNvPicPr>
+          <p:nvPr/>
+        </p:nvPicPr>
+        <p:blipFill>
+          <a:blip r:embed="rId3"/>
+          <a:stretch>
+            <a:fillRect/>
+          </a:stretch>
+        </p:blipFill>
+        <p:spPr>
+          <a:xfrm>
+            <a:off x="2834640" y="3493186"/>
+            <a:ext cx="9357360" cy="3292055"/>
+          </a:xfrm>
+          <a:prstGeom prst="rect">
+            <a:avLst/>
+          </a:prstGeom>
+        </p:spPr>
+      </p:pic>
+    </p:spTree>
+    <p:extLst>
+      <p:ext uri="{BB962C8B-B14F-4D97-AF65-F5344CB8AC3E}">
+        <p14:creationId xmlns:p14="http://schemas.microsoft.com/office/powerpoint/2010/main" val="1990716002"/>
+      </p:ext>
+    </p:extLst>
+  </p:cSld>
+  <p:clrMapOvr>
+    <a:masterClrMapping/>
+  </p:clrMapOvr>
+</p:sld>
+</file>
+
+<file path=ppt/slides/slide23.xml><?xml version="1.0" encoding="utf-8"?>
 <p:sld xmlns:a="http://schemas.openxmlformats.org/drawingml/2006/main" xmlns:r="http://schemas.openxmlformats.org/officeDocument/2006/relationships" xmlns:p="http://schemas.openxmlformats.org/presentationml/2006/main">
   <p:cSld>
     <p:spTree>

</xml_diff>

<commit_message>
Update Ch07 per MC's recommendations
</commit_message>
<xml_diff>
--- a/figures/figures.pptx
+++ b/figures/figures.pptx
@@ -5,7 +5,7 @@
     <p:sldMasterId id="2147483660" r:id="rId1"/>
   </p:sldMasterIdLst>
   <p:notesMasterIdLst>
-    <p:notesMasterId r:id="rId25"/>
+    <p:notesMasterId r:id="rId26"/>
   </p:notesMasterIdLst>
   <p:sldIdLst>
     <p:sldId id="258" r:id="rId2"/>
@@ -27,10 +27,11 @@
     <p:sldId id="271" r:id="rId18"/>
     <p:sldId id="272" r:id="rId19"/>
     <p:sldId id="273" r:id="rId20"/>
-    <p:sldId id="269" r:id="rId21"/>
-    <p:sldId id="274" r:id="rId22"/>
-    <p:sldId id="270" r:id="rId23"/>
-    <p:sldId id="257" r:id="rId24"/>
+    <p:sldId id="281" r:id="rId21"/>
+    <p:sldId id="269" r:id="rId22"/>
+    <p:sldId id="274" r:id="rId23"/>
+    <p:sldId id="270" r:id="rId24"/>
+    <p:sldId id="257" r:id="rId25"/>
   </p:sldIdLst>
   <p:sldSz cx="12192000" cy="6858000"/>
   <p:notesSz cx="6858000" cy="9144000"/>
@@ -185,6 +186,7 @@
         </p14:section>
         <p14:section name="Governance" id="{038CE4AA-62CD-47A2-8E40-F6F0DFCCB854}">
           <p14:sldIdLst>
+            <p14:sldId id="281"/>
             <p14:sldId id="269"/>
             <p14:sldId id="274"/>
             <p14:sldId id="270"/>
@@ -286,7 +288,7 @@
           <a:p>
             <a:fld id="{DAABB0E5-6D8D-4DEE-B75F-67010CF2307C}" type="datetimeFigureOut">
               <a:rPr lang="en-US" smtClean="0"/>
-              <a:t>4/11/2026</a:t>
+              <a:t>4/23/2026</a:t>
             </a:fld>
             <a:endParaRPr lang="en-US"/>
           </a:p>
@@ -971,7 +973,7 @@
           <a:p>
             <a:fld id="{B84C5C40-2055-49AF-9028-5DA79E75E391}" type="datetimeFigureOut">
               <a:rPr lang="en-US" smtClean="0"/>
-              <a:t>4/11/2026</a:t>
+              <a:t>4/23/2026</a:t>
             </a:fld>
             <a:endParaRPr lang="en-US"/>
           </a:p>
@@ -1141,7 +1143,7 @@
           <a:p>
             <a:fld id="{B84C5C40-2055-49AF-9028-5DA79E75E391}" type="datetimeFigureOut">
               <a:rPr lang="en-US" smtClean="0"/>
-              <a:t>4/11/2026</a:t>
+              <a:t>4/23/2026</a:t>
             </a:fld>
             <a:endParaRPr lang="en-US"/>
           </a:p>
@@ -1321,7 +1323,7 @@
           <a:p>
             <a:fld id="{B84C5C40-2055-49AF-9028-5DA79E75E391}" type="datetimeFigureOut">
               <a:rPr lang="en-US" smtClean="0"/>
-              <a:t>4/11/2026</a:t>
+              <a:t>4/23/2026</a:t>
             </a:fld>
             <a:endParaRPr lang="en-US"/>
           </a:p>
@@ -1491,7 +1493,7 @@
           <a:p>
             <a:fld id="{B84C5C40-2055-49AF-9028-5DA79E75E391}" type="datetimeFigureOut">
               <a:rPr lang="en-US" smtClean="0"/>
-              <a:t>4/11/2026</a:t>
+              <a:t>4/23/2026</a:t>
             </a:fld>
             <a:endParaRPr lang="en-US"/>
           </a:p>
@@ -1737,7 +1739,7 @@
           <a:p>
             <a:fld id="{B84C5C40-2055-49AF-9028-5DA79E75E391}" type="datetimeFigureOut">
               <a:rPr lang="en-US" smtClean="0"/>
-              <a:t>4/11/2026</a:t>
+              <a:t>4/23/2026</a:t>
             </a:fld>
             <a:endParaRPr lang="en-US"/>
           </a:p>
@@ -1969,7 +1971,7 @@
           <a:p>
             <a:fld id="{B84C5C40-2055-49AF-9028-5DA79E75E391}" type="datetimeFigureOut">
               <a:rPr lang="en-US" smtClean="0"/>
-              <a:t>4/11/2026</a:t>
+              <a:t>4/23/2026</a:t>
             </a:fld>
             <a:endParaRPr lang="en-US"/>
           </a:p>
@@ -2336,7 +2338,7 @@
           <a:p>
             <a:fld id="{B84C5C40-2055-49AF-9028-5DA79E75E391}" type="datetimeFigureOut">
               <a:rPr lang="en-US" smtClean="0"/>
-              <a:t>4/11/2026</a:t>
+              <a:t>4/23/2026</a:t>
             </a:fld>
             <a:endParaRPr lang="en-US"/>
           </a:p>
@@ -2454,7 +2456,7 @@
           <a:p>
             <a:fld id="{B84C5C40-2055-49AF-9028-5DA79E75E391}" type="datetimeFigureOut">
               <a:rPr lang="en-US" smtClean="0"/>
-              <a:t>4/11/2026</a:t>
+              <a:t>4/23/2026</a:t>
             </a:fld>
             <a:endParaRPr lang="en-US"/>
           </a:p>
@@ -2549,7 +2551,7 @@
           <a:p>
             <a:fld id="{B84C5C40-2055-49AF-9028-5DA79E75E391}" type="datetimeFigureOut">
               <a:rPr lang="en-US" smtClean="0"/>
-              <a:t>4/11/2026</a:t>
+              <a:t>4/23/2026</a:t>
             </a:fld>
             <a:endParaRPr lang="en-US"/>
           </a:p>
@@ -2826,7 +2828,7 @@
           <a:p>
             <a:fld id="{B84C5C40-2055-49AF-9028-5DA79E75E391}" type="datetimeFigureOut">
               <a:rPr lang="en-US" smtClean="0"/>
-              <a:t>4/11/2026</a:t>
+              <a:t>4/23/2026</a:t>
             </a:fld>
             <a:endParaRPr lang="en-US"/>
           </a:p>
@@ -3083,7 +3085,7 @@
           <a:p>
             <a:fld id="{B84C5C40-2055-49AF-9028-5DA79E75E391}" type="datetimeFigureOut">
               <a:rPr lang="en-US" smtClean="0"/>
-              <a:t>4/11/2026</a:t>
+              <a:t>4/23/2026</a:t>
             </a:fld>
             <a:endParaRPr lang="en-US"/>
           </a:p>
@@ -3296,7 +3298,7 @@
           <a:p>
             <a:fld id="{B84C5C40-2055-49AF-9028-5DA79E75E391}" type="datetimeFigureOut">
               <a:rPr lang="en-US" smtClean="0"/>
-              <a:t>4/11/2026</a:t>
+              <a:t>4/23/2026</a:t>
             </a:fld>
             <a:endParaRPr lang="en-US"/>
           </a:p>
@@ -4052,10 +4054,10 @@
           <p:nvPr/>
         </p:nvPicPr>
         <p:blipFill>
-          <a:blip r:embed="rId2">
+          <a:blip>
             <a:extLst>
               <a:ext uri="{96DAC541-7B7A-43D3-8B79-37D633B846F1}">
-                <asvg:svgBlip xmlns:asvg="http://schemas.microsoft.com/office/drawing/2016/SVG/main" r:embed="rId3"/>
+                <asvg:svgBlip xmlns:asvg="http://schemas.microsoft.com/office/drawing/2016/SVG/main" r:embed="rId2"/>
               </a:ext>
             </a:extLst>
           </a:blip>
@@ -4088,10 +4090,10 @@
           <p:nvPr/>
         </p:nvPicPr>
         <p:blipFill>
-          <a:blip r:embed="rId4">
+          <a:blip>
             <a:extLst>
               <a:ext uri="{96DAC541-7B7A-43D3-8B79-37D633B846F1}">
-                <asvg:svgBlip xmlns:asvg="http://schemas.microsoft.com/office/drawing/2016/SVG/main" r:embed="rId5"/>
+                <asvg:svgBlip xmlns:asvg="http://schemas.microsoft.com/office/drawing/2016/SVG/main" r:embed="rId3"/>
               </a:ext>
             </a:extLst>
           </a:blip>
@@ -4123,10 +4125,10 @@
           <p:nvPr/>
         </p:nvPicPr>
         <p:blipFill>
-          <a:blip r:embed="rId6">
+          <a:blip>
             <a:extLst>
               <a:ext uri="{96DAC541-7B7A-43D3-8B79-37D633B846F1}">
-                <asvg:svgBlip xmlns:asvg="http://schemas.microsoft.com/office/drawing/2016/SVG/main" r:embed="rId7"/>
+                <asvg:svgBlip xmlns:asvg="http://schemas.microsoft.com/office/drawing/2016/SVG/main" r:embed="rId4"/>
               </a:ext>
             </a:extLst>
           </a:blip>
@@ -4266,10 +4268,10 @@
           <p:nvPr/>
         </p:nvPicPr>
         <p:blipFill>
-          <a:blip r:embed="rId8">
+          <a:blip>
             <a:extLst>
               <a:ext uri="{96DAC541-7B7A-43D3-8B79-37D633B846F1}">
-                <asvg:svgBlip xmlns:asvg="http://schemas.microsoft.com/office/drawing/2016/SVG/main" r:embed="rId9"/>
+                <asvg:svgBlip xmlns:asvg="http://schemas.microsoft.com/office/drawing/2016/SVG/main" r:embed="rId5"/>
               </a:ext>
             </a:extLst>
           </a:blip>
@@ -5178,10 +5180,10 @@
           <p:nvPr/>
         </p:nvPicPr>
         <p:blipFill>
-          <a:blip r:embed="rId3">
+          <a:blip>
             <a:extLst>
               <a:ext uri="{96DAC541-7B7A-43D3-8B79-37D633B846F1}">
-                <asvg:svgBlip xmlns:asvg="http://schemas.microsoft.com/office/drawing/2016/SVG/main" r:embed="rId4"/>
+                <asvg:svgBlip xmlns:asvg="http://schemas.microsoft.com/office/drawing/2016/SVG/main" r:embed="rId3"/>
               </a:ext>
             </a:extLst>
           </a:blip>
@@ -6071,10 +6073,10 @@
             <p:nvPr/>
           </p:nvPicPr>
           <p:blipFill>
-            <a:blip r:embed="rId5">
+            <a:blip>
               <a:extLst>
                 <a:ext uri="{96DAC541-7B7A-43D3-8B79-37D633B846F1}">
-                  <asvg:svgBlip xmlns:asvg="http://schemas.microsoft.com/office/drawing/2016/SVG/main" r:embed="rId6"/>
+                  <asvg:svgBlip xmlns:asvg="http://schemas.microsoft.com/office/drawing/2016/SVG/main" r:embed="rId4"/>
                 </a:ext>
               </a:extLst>
             </a:blip>
@@ -6714,10 +6716,10 @@
           <p:nvPr/>
         </p:nvPicPr>
         <p:blipFill>
-          <a:blip r:embed="rId2">
+          <a:blip>
             <a:extLst>
               <a:ext uri="{96DAC541-7B7A-43D3-8B79-37D633B846F1}">
-                <asvg:svgBlip xmlns:asvg="http://schemas.microsoft.com/office/drawing/2016/SVG/main" r:embed="rId3"/>
+                <asvg:svgBlip xmlns:asvg="http://schemas.microsoft.com/office/drawing/2016/SVG/main" r:embed="rId2"/>
               </a:ext>
             </a:extLst>
           </a:blip>
@@ -8214,10 +8216,10 @@
           <p:nvPr/>
         </p:nvPicPr>
         <p:blipFill>
-          <a:blip r:embed="rId2">
+          <a:blip>
             <a:extLst>
               <a:ext uri="{96DAC541-7B7A-43D3-8B79-37D633B846F1}">
-                <asvg:svgBlip xmlns:asvg="http://schemas.microsoft.com/office/drawing/2016/SVG/main" r:embed="rId3"/>
+                <asvg:svgBlip xmlns:asvg="http://schemas.microsoft.com/office/drawing/2016/SVG/main" r:embed="rId2"/>
               </a:ext>
             </a:extLst>
           </a:blip>
@@ -8250,10 +8252,10 @@
           <p:nvPr/>
         </p:nvPicPr>
         <p:blipFill>
-          <a:blip r:embed="rId4">
+          <a:blip>
             <a:extLst>
               <a:ext uri="{96DAC541-7B7A-43D3-8B79-37D633B846F1}">
-                <asvg:svgBlip xmlns:asvg="http://schemas.microsoft.com/office/drawing/2016/SVG/main" r:embed="rId5"/>
+                <asvg:svgBlip xmlns:asvg="http://schemas.microsoft.com/office/drawing/2016/SVG/main" r:embed="rId3"/>
               </a:ext>
             </a:extLst>
           </a:blip>
@@ -8286,10 +8288,10 @@
           <p:nvPr/>
         </p:nvPicPr>
         <p:blipFill>
-          <a:blip r:embed="rId6">
+          <a:blip>
             <a:extLst>
               <a:ext uri="{96DAC541-7B7A-43D3-8B79-37D633B846F1}">
-                <asvg:svgBlip xmlns:asvg="http://schemas.microsoft.com/office/drawing/2016/SVG/main" r:embed="rId7"/>
+                <asvg:svgBlip xmlns:asvg="http://schemas.microsoft.com/office/drawing/2016/SVG/main" r:embed="rId4"/>
               </a:ext>
             </a:extLst>
           </a:blip>
@@ -8322,10 +8324,10 @@
           <p:nvPr/>
         </p:nvPicPr>
         <p:blipFill>
-          <a:blip r:embed="rId8">
+          <a:blip>
             <a:extLst>
               <a:ext uri="{96DAC541-7B7A-43D3-8B79-37D633B846F1}">
-                <asvg:svgBlip xmlns:asvg="http://schemas.microsoft.com/office/drawing/2016/SVG/main" r:embed="rId9"/>
+                <asvg:svgBlip xmlns:asvg="http://schemas.microsoft.com/office/drawing/2016/SVG/main" r:embed="rId5"/>
               </a:ext>
             </a:extLst>
           </a:blip>
@@ -9483,10 +9485,10 @@
           <p:nvPr/>
         </p:nvPicPr>
         <p:blipFill>
-          <a:blip r:embed="rId2">
+          <a:blip>
             <a:extLst>
               <a:ext uri="{96DAC541-7B7A-43D3-8B79-37D633B846F1}">
-                <asvg:svgBlip xmlns:asvg="http://schemas.microsoft.com/office/drawing/2016/SVG/main" r:embed="rId3"/>
+                <asvg:svgBlip xmlns:asvg="http://schemas.microsoft.com/office/drawing/2016/SVG/main" r:embed="rId2"/>
               </a:ext>
             </a:extLst>
           </a:blip>
@@ -15855,6 +15857,976 @@
           <a:chExt cx="0" cy="0"/>
         </a:xfrm>
       </p:grpSpPr>
+      <p:grpSp>
+        <p:nvGrpSpPr>
+          <p:cNvPr id="57" name="Group 56">
+            <a:extLst>
+              <a:ext uri="{FF2B5EF4-FFF2-40B4-BE49-F238E27FC236}">
+                <a16:creationId xmlns:a16="http://schemas.microsoft.com/office/drawing/2014/main" id="{94D3DA75-530C-7F8C-9F2D-5A7A12B26CC8}"/>
+              </a:ext>
+            </a:extLst>
+          </p:cNvPr>
+          <p:cNvGrpSpPr/>
+          <p:nvPr/>
+        </p:nvGrpSpPr>
+        <p:grpSpPr>
+          <a:xfrm>
+            <a:off x="2742318" y="1761898"/>
+            <a:ext cx="6707363" cy="3334204"/>
+            <a:chOff x="2626805" y="1138961"/>
+            <a:chExt cx="6707363" cy="3334204"/>
+          </a:xfrm>
+        </p:grpSpPr>
+        <p:sp>
+          <p:nvSpPr>
+            <p:cNvPr id="2" name="Rectangle: Rounded Corners 1">
+              <a:extLst>
+                <a:ext uri="{FF2B5EF4-FFF2-40B4-BE49-F238E27FC236}">
+                  <a16:creationId xmlns:a16="http://schemas.microsoft.com/office/drawing/2014/main" id="{42E1BAB5-E274-763D-6C88-4CAF97E3D6C2}"/>
+                </a:ext>
+              </a:extLst>
+            </p:cNvPr>
+            <p:cNvSpPr/>
+            <p:nvPr/>
+          </p:nvSpPr>
+          <p:spPr>
+            <a:xfrm>
+              <a:off x="2626805" y="2444034"/>
+              <a:ext cx="1438743" cy="724060"/>
+            </a:xfrm>
+            <a:prstGeom prst="roundRect">
+              <a:avLst/>
+            </a:prstGeom>
+            <a:solidFill>
+              <a:srgbClr val="E5F1F8"/>
+            </a:solidFill>
+            <a:ln>
+              <a:solidFill>
+                <a:schemeClr val="tx1"/>
+              </a:solidFill>
+            </a:ln>
+          </p:spPr>
+          <p:style>
+            <a:lnRef idx="2">
+              <a:schemeClr val="accent1">
+                <a:shade val="15000"/>
+              </a:schemeClr>
+            </a:lnRef>
+            <a:fillRef idx="1">
+              <a:schemeClr val="accent1"/>
+            </a:fillRef>
+            <a:effectRef idx="0">
+              <a:schemeClr val="accent1"/>
+            </a:effectRef>
+            <a:fontRef idx="minor">
+              <a:schemeClr val="lt1"/>
+            </a:fontRef>
+          </p:style>
+          <p:txBody>
+            <a:bodyPr rtlCol="0" anchor="ctr"/>
+            <a:lstStyle/>
+            <a:p>
+              <a:pPr algn="ctr"/>
+              <a:r>
+                <a:rPr lang="en-US" dirty="0">
+                  <a:solidFill>
+                    <a:schemeClr val="tx1"/>
+                  </a:solidFill>
+                </a:rPr>
+                <a:t>User Input</a:t>
+              </a:r>
+            </a:p>
+          </p:txBody>
+        </p:sp>
+        <p:sp>
+          <p:nvSpPr>
+            <p:cNvPr id="3" name="Rectangle: Rounded Corners 2">
+              <a:extLst>
+                <a:ext uri="{FF2B5EF4-FFF2-40B4-BE49-F238E27FC236}">
+                  <a16:creationId xmlns:a16="http://schemas.microsoft.com/office/drawing/2014/main" id="{32354587-DCA6-E904-8F29-6F6BFBBEFBD3}"/>
+                </a:ext>
+              </a:extLst>
+            </p:cNvPr>
+            <p:cNvSpPr/>
+            <p:nvPr/>
+          </p:nvSpPr>
+          <p:spPr>
+            <a:xfrm>
+              <a:off x="5261115" y="2444034"/>
+              <a:ext cx="1438743" cy="724060"/>
+            </a:xfrm>
+            <a:prstGeom prst="roundRect">
+              <a:avLst/>
+            </a:prstGeom>
+            <a:solidFill>
+              <a:srgbClr val="E5F1F8"/>
+            </a:solidFill>
+            <a:ln>
+              <a:solidFill>
+                <a:schemeClr val="tx1"/>
+              </a:solidFill>
+            </a:ln>
+          </p:spPr>
+          <p:style>
+            <a:lnRef idx="2">
+              <a:schemeClr val="accent1">
+                <a:shade val="15000"/>
+              </a:schemeClr>
+            </a:lnRef>
+            <a:fillRef idx="1">
+              <a:schemeClr val="accent1"/>
+            </a:fillRef>
+            <a:effectRef idx="0">
+              <a:schemeClr val="accent1"/>
+            </a:effectRef>
+            <a:fontRef idx="minor">
+              <a:schemeClr val="lt1"/>
+            </a:fontRef>
+          </p:style>
+          <p:txBody>
+            <a:bodyPr rtlCol="0" anchor="ctr"/>
+            <a:lstStyle/>
+            <a:p>
+              <a:pPr algn="ctr"/>
+              <a:r>
+                <a:rPr lang="en-US" dirty="0">
+                  <a:solidFill>
+                    <a:schemeClr val="tx1"/>
+                  </a:solidFill>
+                </a:rPr>
+                <a:t>Tool Call &amp; Response</a:t>
+              </a:r>
+            </a:p>
+          </p:txBody>
+        </p:sp>
+        <p:sp>
+          <p:nvSpPr>
+            <p:cNvPr id="5" name="Rectangle: Rounded Corners 4">
+              <a:extLst>
+                <a:ext uri="{FF2B5EF4-FFF2-40B4-BE49-F238E27FC236}">
+                  <a16:creationId xmlns:a16="http://schemas.microsoft.com/office/drawing/2014/main" id="{C88989B2-FAE5-E38B-FFE5-3D8A1AFD67E2}"/>
+                </a:ext>
+              </a:extLst>
+            </p:cNvPr>
+            <p:cNvSpPr/>
+            <p:nvPr/>
+          </p:nvSpPr>
+          <p:spPr>
+            <a:xfrm>
+              <a:off x="7895425" y="2444034"/>
+              <a:ext cx="1438743" cy="724060"/>
+            </a:xfrm>
+            <a:prstGeom prst="roundRect">
+              <a:avLst/>
+            </a:prstGeom>
+            <a:solidFill>
+              <a:srgbClr val="E5F1F8"/>
+            </a:solidFill>
+            <a:ln>
+              <a:solidFill>
+                <a:schemeClr val="tx1"/>
+              </a:solidFill>
+            </a:ln>
+          </p:spPr>
+          <p:style>
+            <a:lnRef idx="2">
+              <a:schemeClr val="accent1">
+                <a:shade val="15000"/>
+              </a:schemeClr>
+            </a:lnRef>
+            <a:fillRef idx="1">
+              <a:schemeClr val="accent1"/>
+            </a:fillRef>
+            <a:effectRef idx="0">
+              <a:schemeClr val="accent1"/>
+            </a:effectRef>
+            <a:fontRef idx="minor">
+              <a:schemeClr val="lt1"/>
+            </a:fontRef>
+          </p:style>
+          <p:txBody>
+            <a:bodyPr rtlCol="0" anchor="ctr"/>
+            <a:lstStyle/>
+            <a:p>
+              <a:pPr algn="ctr"/>
+              <a:r>
+                <a:rPr lang="en-US" dirty="0">
+                  <a:solidFill>
+                    <a:schemeClr val="tx1"/>
+                  </a:solidFill>
+                </a:rPr>
+                <a:t>Agent Output</a:t>
+              </a:r>
+            </a:p>
+          </p:txBody>
+        </p:sp>
+        <p:cxnSp>
+          <p:nvCxnSpPr>
+            <p:cNvPr id="6" name="Straight Arrow Connector 5">
+              <a:extLst>
+                <a:ext uri="{FF2B5EF4-FFF2-40B4-BE49-F238E27FC236}">
+                  <a16:creationId xmlns:a16="http://schemas.microsoft.com/office/drawing/2014/main" id="{AF1DA7FB-B4E6-70FC-E344-8A1F141B58BC}"/>
+                </a:ext>
+              </a:extLst>
+            </p:cNvPr>
+            <p:cNvCxnSpPr>
+              <a:cxnSpLocks/>
+              <a:stCxn id="2" idx="3"/>
+              <a:endCxn id="3" idx="1"/>
+            </p:cNvCxnSpPr>
+            <p:nvPr/>
+          </p:nvCxnSpPr>
+          <p:spPr>
+            <a:xfrm>
+              <a:off x="4065548" y="2806064"/>
+              <a:ext cx="1195567" cy="0"/>
+            </a:xfrm>
+            <a:prstGeom prst="straightConnector1">
+              <a:avLst/>
+            </a:prstGeom>
+            <a:ln>
+              <a:solidFill>
+                <a:schemeClr val="tx1"/>
+              </a:solidFill>
+              <a:prstDash val="solid"/>
+              <a:headEnd type="none" w="lg" len="lg"/>
+              <a:tailEnd type="triangle" w="lg" len="lg"/>
+            </a:ln>
+          </p:spPr>
+          <p:style>
+            <a:lnRef idx="2">
+              <a:schemeClr val="accent1"/>
+            </a:lnRef>
+            <a:fillRef idx="0">
+              <a:schemeClr val="accent1"/>
+            </a:fillRef>
+            <a:effectRef idx="1">
+              <a:schemeClr val="accent1"/>
+            </a:effectRef>
+            <a:fontRef idx="minor">
+              <a:schemeClr val="tx1"/>
+            </a:fontRef>
+          </p:style>
+        </p:cxnSp>
+        <p:sp>
+          <p:nvSpPr>
+            <p:cNvPr id="16" name="Rectangle: Rounded Corners 15">
+              <a:extLst>
+                <a:ext uri="{FF2B5EF4-FFF2-40B4-BE49-F238E27FC236}">
+                  <a16:creationId xmlns:a16="http://schemas.microsoft.com/office/drawing/2014/main" id="{76E5D172-00CA-4800-2437-6E2B4EBDF04D}"/>
+                </a:ext>
+              </a:extLst>
+            </p:cNvPr>
+            <p:cNvSpPr/>
+            <p:nvPr/>
+          </p:nvSpPr>
+          <p:spPr>
+            <a:xfrm>
+              <a:off x="3460475" y="1138963"/>
+              <a:ext cx="1914939" cy="928378"/>
+            </a:xfrm>
+            <a:prstGeom prst="roundRect">
+              <a:avLst/>
+            </a:prstGeom>
+            <a:solidFill>
+              <a:srgbClr val="B2D4EB"/>
+            </a:solidFill>
+            <a:ln>
+              <a:solidFill>
+                <a:schemeClr val="tx1"/>
+              </a:solidFill>
+            </a:ln>
+          </p:spPr>
+          <p:style>
+            <a:lnRef idx="2">
+              <a:schemeClr val="accent1">
+                <a:shade val="15000"/>
+              </a:schemeClr>
+            </a:lnRef>
+            <a:fillRef idx="1">
+              <a:schemeClr val="accent1"/>
+            </a:fillRef>
+            <a:effectRef idx="0">
+              <a:schemeClr val="accent1"/>
+            </a:effectRef>
+            <a:fontRef idx="minor">
+              <a:schemeClr val="lt1"/>
+            </a:fontRef>
+          </p:style>
+          <p:txBody>
+            <a:bodyPr rtlCol="0" anchor="ctr"/>
+            <a:lstStyle/>
+            <a:p>
+              <a:pPr algn="ctr"/>
+              <a:r>
+                <a:rPr lang="en-US" dirty="0">
+                  <a:solidFill>
+                    <a:schemeClr val="tx1"/>
+                  </a:solidFill>
+                </a:rPr>
+                <a:t>Check for harmful requests</a:t>
+              </a:r>
+              <a:endParaRPr lang="en-US" i="1" dirty="0">
+                <a:solidFill>
+                  <a:schemeClr val="tx1"/>
+                </a:solidFill>
+              </a:endParaRPr>
+            </a:p>
+          </p:txBody>
+        </p:sp>
+        <p:cxnSp>
+          <p:nvCxnSpPr>
+            <p:cNvPr id="18" name="Straight Connector 17">
+              <a:extLst>
+                <a:ext uri="{FF2B5EF4-FFF2-40B4-BE49-F238E27FC236}">
+                  <a16:creationId xmlns:a16="http://schemas.microsoft.com/office/drawing/2014/main" id="{B5E30DE5-D8B0-6032-35C8-AA4A209F9440}"/>
+                </a:ext>
+              </a:extLst>
+            </p:cNvPr>
+            <p:cNvCxnSpPr>
+              <a:cxnSpLocks/>
+              <a:stCxn id="16" idx="2"/>
+              <a:endCxn id="25" idx="0"/>
+            </p:cNvCxnSpPr>
+            <p:nvPr/>
+          </p:nvCxnSpPr>
+          <p:spPr>
+            <a:xfrm>
+              <a:off x="4417945" y="2067341"/>
+              <a:ext cx="1215" cy="670142"/>
+            </a:xfrm>
+            <a:prstGeom prst="line">
+              <a:avLst/>
+            </a:prstGeom>
+            <a:ln>
+              <a:solidFill>
+                <a:schemeClr val="tx1"/>
+              </a:solidFill>
+              <a:prstDash val="sysDash"/>
+              <a:headEnd type="none" w="med" len="med"/>
+              <a:tailEnd type="none" w="med" len="med"/>
+            </a:ln>
+          </p:spPr>
+          <p:style>
+            <a:lnRef idx="2">
+              <a:schemeClr val="accent1"/>
+            </a:lnRef>
+            <a:fillRef idx="0">
+              <a:schemeClr val="accent1"/>
+            </a:fillRef>
+            <a:effectRef idx="1">
+              <a:schemeClr val="accent1"/>
+            </a:effectRef>
+            <a:fontRef idx="minor">
+              <a:schemeClr val="tx1"/>
+            </a:fontRef>
+          </p:style>
+        </p:cxnSp>
+        <p:sp>
+          <p:nvSpPr>
+            <p:cNvPr id="20" name="Rectangle: Rounded Corners 19">
+              <a:extLst>
+                <a:ext uri="{FF2B5EF4-FFF2-40B4-BE49-F238E27FC236}">
+                  <a16:creationId xmlns:a16="http://schemas.microsoft.com/office/drawing/2014/main" id="{9C640152-4738-174F-FD99-7D55FC76F495}"/>
+                </a:ext>
+              </a:extLst>
+            </p:cNvPr>
+            <p:cNvSpPr/>
+            <p:nvPr/>
+          </p:nvSpPr>
+          <p:spPr>
+            <a:xfrm>
+              <a:off x="3836948" y="3544787"/>
+              <a:ext cx="1914939" cy="928378"/>
+            </a:xfrm>
+            <a:prstGeom prst="roundRect">
+              <a:avLst/>
+            </a:prstGeom>
+            <a:solidFill>
+              <a:srgbClr val="B2D4EB"/>
+            </a:solidFill>
+            <a:ln>
+              <a:solidFill>
+                <a:schemeClr val="tx1"/>
+              </a:solidFill>
+            </a:ln>
+          </p:spPr>
+          <p:style>
+            <a:lnRef idx="2">
+              <a:schemeClr val="accent1">
+                <a:shade val="15000"/>
+              </a:schemeClr>
+            </a:lnRef>
+            <a:fillRef idx="1">
+              <a:schemeClr val="accent1"/>
+            </a:fillRef>
+            <a:effectRef idx="0">
+              <a:schemeClr val="accent1"/>
+            </a:effectRef>
+            <a:fontRef idx="minor">
+              <a:schemeClr val="lt1"/>
+            </a:fontRef>
+          </p:style>
+          <p:txBody>
+            <a:bodyPr rtlCol="0" anchor="ctr"/>
+            <a:lstStyle/>
+            <a:p>
+              <a:pPr algn="ctr"/>
+              <a:r>
+                <a:rPr lang="en-US" dirty="0">
+                  <a:solidFill>
+                    <a:schemeClr val="tx1"/>
+                  </a:solidFill>
+                </a:rPr>
+                <a:t>Limit off-task or malicious tool requests</a:t>
+              </a:r>
+              <a:endParaRPr lang="en-US" i="1" dirty="0">
+                <a:solidFill>
+                  <a:schemeClr val="tx1"/>
+                </a:solidFill>
+              </a:endParaRPr>
+            </a:p>
+          </p:txBody>
+        </p:sp>
+        <p:sp>
+          <p:nvSpPr>
+            <p:cNvPr id="21" name="Rectangle: Rounded Corners 20">
+              <a:extLst>
+                <a:ext uri="{FF2B5EF4-FFF2-40B4-BE49-F238E27FC236}">
+                  <a16:creationId xmlns:a16="http://schemas.microsoft.com/office/drawing/2014/main" id="{CE8A49B1-D71B-5EA0-3F20-96427E390C88}"/>
+                </a:ext>
+              </a:extLst>
+            </p:cNvPr>
+            <p:cNvSpPr/>
+            <p:nvPr/>
+          </p:nvSpPr>
+          <p:spPr>
+            <a:xfrm>
+              <a:off x="6096000" y="3544787"/>
+              <a:ext cx="1914939" cy="928378"/>
+            </a:xfrm>
+            <a:prstGeom prst="roundRect">
+              <a:avLst/>
+            </a:prstGeom>
+            <a:solidFill>
+              <a:srgbClr val="B2D4EB"/>
+            </a:solidFill>
+            <a:ln>
+              <a:solidFill>
+                <a:schemeClr val="tx1"/>
+              </a:solidFill>
+            </a:ln>
+          </p:spPr>
+          <p:style>
+            <a:lnRef idx="2">
+              <a:schemeClr val="accent1">
+                <a:shade val="15000"/>
+              </a:schemeClr>
+            </a:lnRef>
+            <a:fillRef idx="1">
+              <a:schemeClr val="accent1"/>
+            </a:fillRef>
+            <a:effectRef idx="0">
+              <a:schemeClr val="accent1"/>
+            </a:effectRef>
+            <a:fontRef idx="minor">
+              <a:schemeClr val="lt1"/>
+            </a:fontRef>
+          </p:style>
+          <p:txBody>
+            <a:bodyPr rtlCol="0" anchor="ctr"/>
+            <a:lstStyle/>
+            <a:p>
+              <a:pPr algn="ctr"/>
+              <a:r>
+                <a:rPr lang="en-US" dirty="0">
+                  <a:solidFill>
+                    <a:schemeClr val="tx1"/>
+                  </a:solidFill>
+                </a:rPr>
+                <a:t>Remove sensitive info from reasoning</a:t>
+              </a:r>
+              <a:endParaRPr lang="en-US" i="1" dirty="0">
+                <a:solidFill>
+                  <a:schemeClr val="tx1"/>
+                </a:solidFill>
+              </a:endParaRPr>
+            </a:p>
+          </p:txBody>
+        </p:sp>
+        <p:sp>
+          <p:nvSpPr>
+            <p:cNvPr id="25" name="Oval 24">
+              <a:extLst>
+                <a:ext uri="{FF2B5EF4-FFF2-40B4-BE49-F238E27FC236}">
+                  <a16:creationId xmlns:a16="http://schemas.microsoft.com/office/drawing/2014/main" id="{E4AFC691-A3D6-2FFA-81BA-8C7DE54F75B0}"/>
+                </a:ext>
+              </a:extLst>
+            </p:cNvPr>
+            <p:cNvSpPr/>
+            <p:nvPr/>
+          </p:nvSpPr>
+          <p:spPr>
+            <a:xfrm>
+              <a:off x="4350580" y="2737483"/>
+              <a:ext cx="137160" cy="137160"/>
+            </a:xfrm>
+            <a:prstGeom prst="ellipse">
+              <a:avLst/>
+            </a:prstGeom>
+          </p:spPr>
+          <p:style>
+            <a:lnRef idx="2">
+              <a:schemeClr val="dk1">
+                <a:shade val="15000"/>
+              </a:schemeClr>
+            </a:lnRef>
+            <a:fillRef idx="1">
+              <a:schemeClr val="dk1"/>
+            </a:fillRef>
+            <a:effectRef idx="0">
+              <a:schemeClr val="dk1"/>
+            </a:effectRef>
+            <a:fontRef idx="minor">
+              <a:schemeClr val="lt1"/>
+            </a:fontRef>
+          </p:style>
+          <p:txBody>
+            <a:bodyPr rtlCol="0" anchor="ctr"/>
+            <a:lstStyle/>
+            <a:p>
+              <a:pPr algn="ctr"/>
+              <a:endParaRPr lang="en-US"/>
+            </a:p>
+          </p:txBody>
+        </p:sp>
+        <p:sp>
+          <p:nvSpPr>
+            <p:cNvPr id="28" name="Oval 27">
+              <a:extLst>
+                <a:ext uri="{FF2B5EF4-FFF2-40B4-BE49-F238E27FC236}">
+                  <a16:creationId xmlns:a16="http://schemas.microsoft.com/office/drawing/2014/main" id="{50B510AA-FF5C-95FD-3DCF-B2FFD06A3D55}"/>
+                </a:ext>
+              </a:extLst>
+            </p:cNvPr>
+            <p:cNvSpPr/>
+            <p:nvPr/>
+          </p:nvSpPr>
+          <p:spPr>
+            <a:xfrm>
+              <a:off x="4725838" y="2737483"/>
+              <a:ext cx="137160" cy="137160"/>
+            </a:xfrm>
+            <a:prstGeom prst="ellipse">
+              <a:avLst/>
+            </a:prstGeom>
+          </p:spPr>
+          <p:style>
+            <a:lnRef idx="2">
+              <a:schemeClr val="dk1">
+                <a:shade val="15000"/>
+              </a:schemeClr>
+            </a:lnRef>
+            <a:fillRef idx="1">
+              <a:schemeClr val="dk1"/>
+            </a:fillRef>
+            <a:effectRef idx="0">
+              <a:schemeClr val="dk1"/>
+            </a:effectRef>
+            <a:fontRef idx="minor">
+              <a:schemeClr val="lt1"/>
+            </a:fontRef>
+          </p:style>
+          <p:txBody>
+            <a:bodyPr rtlCol="0" anchor="ctr"/>
+            <a:lstStyle/>
+            <a:p>
+              <a:pPr algn="ctr"/>
+              <a:endParaRPr lang="en-US"/>
+            </a:p>
+          </p:txBody>
+        </p:sp>
+        <p:cxnSp>
+          <p:nvCxnSpPr>
+            <p:cNvPr id="29" name="Straight Connector 28">
+              <a:extLst>
+                <a:ext uri="{FF2B5EF4-FFF2-40B4-BE49-F238E27FC236}">
+                  <a16:creationId xmlns:a16="http://schemas.microsoft.com/office/drawing/2014/main" id="{A3BF217B-83BA-289D-E5E5-4473C0B1D346}"/>
+                </a:ext>
+              </a:extLst>
+            </p:cNvPr>
+            <p:cNvCxnSpPr>
+              <a:cxnSpLocks/>
+              <a:stCxn id="28" idx="4"/>
+              <a:endCxn id="20" idx="0"/>
+            </p:cNvCxnSpPr>
+            <p:nvPr/>
+          </p:nvCxnSpPr>
+          <p:spPr>
+            <a:xfrm>
+              <a:off x="4794418" y="2874643"/>
+              <a:ext cx="0" cy="670144"/>
+            </a:xfrm>
+            <a:prstGeom prst="line">
+              <a:avLst/>
+            </a:prstGeom>
+            <a:ln>
+              <a:solidFill>
+                <a:schemeClr val="tx1"/>
+              </a:solidFill>
+              <a:prstDash val="sysDash"/>
+              <a:headEnd type="none" w="med" len="med"/>
+              <a:tailEnd type="none" w="med" len="med"/>
+            </a:ln>
+          </p:spPr>
+          <p:style>
+            <a:lnRef idx="2">
+              <a:schemeClr val="accent1"/>
+            </a:lnRef>
+            <a:fillRef idx="0">
+              <a:schemeClr val="accent1"/>
+            </a:fillRef>
+            <a:effectRef idx="1">
+              <a:schemeClr val="accent1"/>
+            </a:effectRef>
+            <a:fontRef idx="minor">
+              <a:schemeClr val="tx1"/>
+            </a:fontRef>
+          </p:style>
+        </p:cxnSp>
+        <p:cxnSp>
+          <p:nvCxnSpPr>
+            <p:cNvPr id="40" name="Straight Connector 39">
+              <a:extLst>
+                <a:ext uri="{FF2B5EF4-FFF2-40B4-BE49-F238E27FC236}">
+                  <a16:creationId xmlns:a16="http://schemas.microsoft.com/office/drawing/2014/main" id="{D0973632-01B6-A0BB-7642-2574628EF338}"/>
+                </a:ext>
+              </a:extLst>
+            </p:cNvPr>
+            <p:cNvCxnSpPr>
+              <a:cxnSpLocks/>
+              <a:stCxn id="21" idx="0"/>
+              <a:endCxn id="48" idx="4"/>
+            </p:cNvCxnSpPr>
+            <p:nvPr/>
+          </p:nvCxnSpPr>
+          <p:spPr>
+            <a:xfrm flipV="1">
+              <a:off x="7053470" y="2874643"/>
+              <a:ext cx="0" cy="670144"/>
+            </a:xfrm>
+            <a:prstGeom prst="line">
+              <a:avLst/>
+            </a:prstGeom>
+            <a:ln>
+              <a:solidFill>
+                <a:schemeClr val="tx1"/>
+              </a:solidFill>
+              <a:prstDash val="sysDash"/>
+              <a:headEnd type="none" w="med" len="med"/>
+              <a:tailEnd type="none" w="med" len="med"/>
+            </a:ln>
+          </p:spPr>
+          <p:style>
+            <a:lnRef idx="2">
+              <a:schemeClr val="accent1"/>
+            </a:lnRef>
+            <a:fillRef idx="0">
+              <a:schemeClr val="accent1"/>
+            </a:fillRef>
+            <a:effectRef idx="1">
+              <a:schemeClr val="accent1"/>
+            </a:effectRef>
+            <a:fontRef idx="minor">
+              <a:schemeClr val="tx1"/>
+            </a:fontRef>
+          </p:style>
+        </p:cxnSp>
+        <p:sp>
+          <p:nvSpPr>
+            <p:cNvPr id="46" name="Rectangle: Rounded Corners 45">
+              <a:extLst>
+                <a:ext uri="{FF2B5EF4-FFF2-40B4-BE49-F238E27FC236}">
+                  <a16:creationId xmlns:a16="http://schemas.microsoft.com/office/drawing/2014/main" id="{79F8E829-F3C4-30FE-28E1-43304C61F284}"/>
+                </a:ext>
+              </a:extLst>
+            </p:cNvPr>
+            <p:cNvSpPr/>
+            <p:nvPr/>
+          </p:nvSpPr>
+          <p:spPr>
+            <a:xfrm>
+              <a:off x="6471258" y="1138961"/>
+              <a:ext cx="1914939" cy="928378"/>
+            </a:xfrm>
+            <a:prstGeom prst="roundRect">
+              <a:avLst/>
+            </a:prstGeom>
+            <a:solidFill>
+              <a:srgbClr val="B2D4EB"/>
+            </a:solidFill>
+            <a:ln>
+              <a:solidFill>
+                <a:schemeClr val="tx1"/>
+              </a:solidFill>
+            </a:ln>
+          </p:spPr>
+          <p:style>
+            <a:lnRef idx="2">
+              <a:schemeClr val="accent1">
+                <a:shade val="15000"/>
+              </a:schemeClr>
+            </a:lnRef>
+            <a:fillRef idx="1">
+              <a:schemeClr val="accent1"/>
+            </a:fillRef>
+            <a:effectRef idx="0">
+              <a:schemeClr val="accent1"/>
+            </a:effectRef>
+            <a:fontRef idx="minor">
+              <a:schemeClr val="lt1"/>
+            </a:fontRef>
+          </p:style>
+          <p:txBody>
+            <a:bodyPr rtlCol="0" anchor="ctr"/>
+            <a:lstStyle/>
+            <a:p>
+              <a:pPr algn="ctr"/>
+              <a:r>
+                <a:rPr lang="en-US" dirty="0">
+                  <a:solidFill>
+                    <a:schemeClr val="tx1"/>
+                  </a:solidFill>
+                </a:rPr>
+                <a:t>Last checks &amp; annotations before response</a:t>
+              </a:r>
+              <a:endParaRPr lang="en-US" i="1" dirty="0">
+                <a:solidFill>
+                  <a:schemeClr val="tx1"/>
+                </a:solidFill>
+              </a:endParaRPr>
+            </a:p>
+          </p:txBody>
+        </p:sp>
+        <p:cxnSp>
+          <p:nvCxnSpPr>
+            <p:cNvPr id="47" name="Straight Arrow Connector 46">
+              <a:extLst>
+                <a:ext uri="{FF2B5EF4-FFF2-40B4-BE49-F238E27FC236}">
+                  <a16:creationId xmlns:a16="http://schemas.microsoft.com/office/drawing/2014/main" id="{FB411845-759C-7B36-5B9F-4D89DD0FB430}"/>
+                </a:ext>
+              </a:extLst>
+            </p:cNvPr>
+            <p:cNvCxnSpPr>
+              <a:cxnSpLocks/>
+              <a:stCxn id="3" idx="3"/>
+              <a:endCxn id="5" idx="1"/>
+            </p:cNvCxnSpPr>
+            <p:nvPr/>
+          </p:nvCxnSpPr>
+          <p:spPr>
+            <a:xfrm>
+              <a:off x="6699858" y="2806064"/>
+              <a:ext cx="1195567" cy="0"/>
+            </a:xfrm>
+            <a:prstGeom prst="straightConnector1">
+              <a:avLst/>
+            </a:prstGeom>
+            <a:ln>
+              <a:solidFill>
+                <a:schemeClr val="tx1"/>
+              </a:solidFill>
+              <a:prstDash val="solid"/>
+              <a:headEnd type="none" w="lg" len="lg"/>
+              <a:tailEnd type="triangle" w="lg" len="lg"/>
+            </a:ln>
+          </p:spPr>
+          <p:style>
+            <a:lnRef idx="2">
+              <a:schemeClr val="accent1"/>
+            </a:lnRef>
+            <a:fillRef idx="0">
+              <a:schemeClr val="accent1"/>
+            </a:fillRef>
+            <a:effectRef idx="1">
+              <a:schemeClr val="accent1"/>
+            </a:effectRef>
+            <a:fontRef idx="minor">
+              <a:schemeClr val="tx1"/>
+            </a:fontRef>
+          </p:style>
+        </p:cxnSp>
+        <p:sp>
+          <p:nvSpPr>
+            <p:cNvPr id="48" name="Oval 47">
+              <a:extLst>
+                <a:ext uri="{FF2B5EF4-FFF2-40B4-BE49-F238E27FC236}">
+                  <a16:creationId xmlns:a16="http://schemas.microsoft.com/office/drawing/2014/main" id="{15A50184-1911-57A0-BC51-2E2FCC6E2FB1}"/>
+                </a:ext>
+              </a:extLst>
+            </p:cNvPr>
+            <p:cNvSpPr/>
+            <p:nvPr/>
+          </p:nvSpPr>
+          <p:spPr>
+            <a:xfrm>
+              <a:off x="6984890" y="2737483"/>
+              <a:ext cx="137160" cy="137160"/>
+            </a:xfrm>
+            <a:prstGeom prst="ellipse">
+              <a:avLst/>
+            </a:prstGeom>
+          </p:spPr>
+          <p:style>
+            <a:lnRef idx="2">
+              <a:schemeClr val="dk1">
+                <a:shade val="15000"/>
+              </a:schemeClr>
+            </a:lnRef>
+            <a:fillRef idx="1">
+              <a:schemeClr val="dk1"/>
+            </a:fillRef>
+            <a:effectRef idx="0">
+              <a:schemeClr val="dk1"/>
+            </a:effectRef>
+            <a:fontRef idx="minor">
+              <a:schemeClr val="lt1"/>
+            </a:fontRef>
+          </p:style>
+          <p:txBody>
+            <a:bodyPr rtlCol="0" anchor="ctr"/>
+            <a:lstStyle/>
+            <a:p>
+              <a:pPr algn="ctr"/>
+              <a:endParaRPr lang="en-US"/>
+            </a:p>
+          </p:txBody>
+        </p:sp>
+        <p:sp>
+          <p:nvSpPr>
+            <p:cNvPr id="49" name="Oval 48">
+              <a:extLst>
+                <a:ext uri="{FF2B5EF4-FFF2-40B4-BE49-F238E27FC236}">
+                  <a16:creationId xmlns:a16="http://schemas.microsoft.com/office/drawing/2014/main" id="{4DBFB7B5-4EF5-73EA-6169-E38F3155B0DA}"/>
+                </a:ext>
+              </a:extLst>
+            </p:cNvPr>
+            <p:cNvSpPr/>
+            <p:nvPr/>
+          </p:nvSpPr>
+          <p:spPr>
+            <a:xfrm>
+              <a:off x="7360148" y="2737483"/>
+              <a:ext cx="137160" cy="137160"/>
+            </a:xfrm>
+            <a:prstGeom prst="ellipse">
+              <a:avLst/>
+            </a:prstGeom>
+          </p:spPr>
+          <p:style>
+            <a:lnRef idx="2">
+              <a:schemeClr val="dk1">
+                <a:shade val="15000"/>
+              </a:schemeClr>
+            </a:lnRef>
+            <a:fillRef idx="1">
+              <a:schemeClr val="dk1"/>
+            </a:fillRef>
+            <a:effectRef idx="0">
+              <a:schemeClr val="dk1"/>
+            </a:effectRef>
+            <a:fontRef idx="minor">
+              <a:schemeClr val="lt1"/>
+            </a:fontRef>
+          </p:style>
+          <p:txBody>
+            <a:bodyPr rtlCol="0" anchor="ctr"/>
+            <a:lstStyle/>
+            <a:p>
+              <a:pPr algn="ctr"/>
+              <a:endParaRPr lang="en-US"/>
+            </a:p>
+          </p:txBody>
+        </p:sp>
+        <p:cxnSp>
+          <p:nvCxnSpPr>
+            <p:cNvPr id="54" name="Straight Connector 53">
+              <a:extLst>
+                <a:ext uri="{FF2B5EF4-FFF2-40B4-BE49-F238E27FC236}">
+                  <a16:creationId xmlns:a16="http://schemas.microsoft.com/office/drawing/2014/main" id="{915D2FED-027D-2E87-5FF7-B06AF88F9EE2}"/>
+                </a:ext>
+              </a:extLst>
+            </p:cNvPr>
+            <p:cNvCxnSpPr>
+              <a:cxnSpLocks/>
+              <a:stCxn id="49" idx="0"/>
+              <a:endCxn id="46" idx="2"/>
+            </p:cNvCxnSpPr>
+            <p:nvPr/>
+          </p:nvCxnSpPr>
+          <p:spPr>
+            <a:xfrm flipV="1">
+              <a:off x="7428728" y="2067339"/>
+              <a:ext cx="0" cy="670144"/>
+            </a:xfrm>
+            <a:prstGeom prst="line">
+              <a:avLst/>
+            </a:prstGeom>
+            <a:ln>
+              <a:solidFill>
+                <a:schemeClr val="tx1"/>
+              </a:solidFill>
+              <a:prstDash val="sysDash"/>
+              <a:headEnd type="none" w="med" len="med"/>
+              <a:tailEnd type="none" w="med" len="med"/>
+            </a:ln>
+          </p:spPr>
+          <p:style>
+            <a:lnRef idx="2">
+              <a:schemeClr val="accent1"/>
+            </a:lnRef>
+            <a:fillRef idx="0">
+              <a:schemeClr val="accent1"/>
+            </a:fillRef>
+            <a:effectRef idx="1">
+              <a:schemeClr val="accent1"/>
+            </a:effectRef>
+            <a:fontRef idx="minor">
+              <a:schemeClr val="tx1"/>
+            </a:fontRef>
+          </p:style>
+        </p:cxnSp>
+      </p:grpSp>
+    </p:spTree>
+    <p:extLst>
+      <p:ext uri="{BB962C8B-B14F-4D97-AF65-F5344CB8AC3E}">
+        <p14:creationId xmlns:p14="http://schemas.microsoft.com/office/powerpoint/2010/main" val="793143649"/>
+      </p:ext>
+    </p:extLst>
+  </p:cSld>
+  <p:clrMapOvr>
+    <a:masterClrMapping/>
+  </p:clrMapOvr>
+</p:sld>
+</file>
+
+<file path=ppt/slides/slide21.xml><?xml version="1.0" encoding="utf-8"?>
+<p:sld xmlns:a="http://schemas.openxmlformats.org/drawingml/2006/main" xmlns:r="http://schemas.openxmlformats.org/officeDocument/2006/relationships" xmlns:p="http://schemas.openxmlformats.org/presentationml/2006/main">
+  <p:cSld>
+    <p:spTree>
+      <p:nvGrpSpPr>
+        <p:cNvPr id="1" name=""/>
+        <p:cNvGrpSpPr/>
+        <p:nvPr/>
+      </p:nvGrpSpPr>
+      <p:grpSpPr>
+        <a:xfrm>
+          <a:off x="0" y="0"/>
+          <a:ext cx="0" cy="0"/>
+          <a:chOff x="0" y="0"/>
+          <a:chExt cx="0" cy="0"/>
+        </a:xfrm>
+      </p:grpSpPr>
       <p:pic>
         <p:nvPicPr>
           <p:cNvPr id="3" name="Picture 2">
@@ -15898,7 +16870,7 @@
 </p:sld>
 </file>
 
-<file path=ppt/slides/slide21.xml><?xml version="1.0" encoding="utf-8"?>
+<file path=ppt/slides/slide22.xml><?xml version="1.0" encoding="utf-8"?>
 <p:sld xmlns:a="http://schemas.openxmlformats.org/drawingml/2006/main" xmlns:r="http://schemas.openxmlformats.org/officeDocument/2006/relationships" xmlns:p="http://schemas.openxmlformats.org/presentationml/2006/main">
   <p:cSld>
     <p:spTree>
@@ -15964,7 +16936,7 @@
 </p:sld>
 </file>
 
-<file path=ppt/slides/slide22.xml><?xml version="1.0" encoding="utf-8"?>
+<file path=ppt/slides/slide23.xml><?xml version="1.0" encoding="utf-8"?>
 <p:sld xmlns:a="http://schemas.openxmlformats.org/drawingml/2006/main" xmlns:r="http://schemas.openxmlformats.org/officeDocument/2006/relationships" xmlns:p="http://schemas.openxmlformats.org/presentationml/2006/main">
   <p:cSld>
     <p:spTree>
@@ -16054,7 +17026,7 @@
 </p:sld>
 </file>
 
-<file path=ppt/slides/slide23.xml><?xml version="1.0" encoding="utf-8"?>
+<file path=ppt/slides/slide24.xml><?xml version="1.0" encoding="utf-8"?>
 <p:sld xmlns:a="http://schemas.openxmlformats.org/drawingml/2006/main" xmlns:r="http://schemas.openxmlformats.org/officeDocument/2006/relationships" xmlns:p="http://schemas.openxmlformats.org/presentationml/2006/main">
   <p:cSld>
     <p:spTree>
@@ -17147,10 +18119,10 @@
           <p:nvPr/>
         </p:nvPicPr>
         <p:blipFill>
-          <a:blip r:embed="rId7">
+          <a:blip>
             <a:extLst>
               <a:ext uri="{96DAC541-7B7A-43D3-8B79-37D633B846F1}">
-                <asvg:svgBlip xmlns:asvg="http://schemas.microsoft.com/office/drawing/2016/SVG/main" r:embed="rId8"/>
+                <asvg:svgBlip xmlns:asvg="http://schemas.microsoft.com/office/drawing/2016/SVG/main" r:embed="rId7"/>
               </a:ext>
             </a:extLst>
           </a:blip>
@@ -17183,10 +18155,10 @@
           <p:nvPr/>
         </p:nvPicPr>
         <p:blipFill>
-          <a:blip r:embed="rId9">
+          <a:blip>
             <a:extLst>
               <a:ext uri="{96DAC541-7B7A-43D3-8B79-37D633B846F1}">
-                <asvg:svgBlip xmlns:asvg="http://schemas.microsoft.com/office/drawing/2016/SVG/main" r:embed="rId10"/>
+                <asvg:svgBlip xmlns:asvg="http://schemas.microsoft.com/office/drawing/2016/SVG/main" r:embed="rId8"/>
               </a:ext>
             </a:extLst>
           </a:blip>
@@ -17239,7 +18211,7 @@
             <p:nvPr/>
           </p:nvPicPr>
           <p:blipFill>
-            <a:blip r:embed="rId11">
+            <a:blip r:embed="rId9">
               <a:extLst>
                 <a:ext uri="{28A0092B-C50C-407E-A947-70E740481C1C}">
                   <a14:useLocalDpi xmlns:a14="http://schemas.microsoft.com/office/drawing/2010/main" val="0"/>
@@ -19346,10 +20318,10 @@
           <p:nvPr/>
         </p:nvPicPr>
         <p:blipFill>
-          <a:blip r:embed="rId3">
+          <a:blip>
             <a:extLst>
               <a:ext uri="{96DAC541-7B7A-43D3-8B79-37D633B846F1}">
-                <asvg:svgBlip xmlns:asvg="http://schemas.microsoft.com/office/drawing/2016/SVG/main" r:embed="rId4"/>
+                <asvg:svgBlip xmlns:asvg="http://schemas.microsoft.com/office/drawing/2016/SVG/main" r:embed="rId3"/>
               </a:ext>
             </a:extLst>
           </a:blip>
@@ -19382,10 +20354,10 @@
           <p:nvPr/>
         </p:nvPicPr>
         <p:blipFill>
-          <a:blip r:embed="rId5">
+          <a:blip>
             <a:extLst>
               <a:ext uri="{96DAC541-7B7A-43D3-8B79-37D633B846F1}">
-                <asvg:svgBlip xmlns:asvg="http://schemas.microsoft.com/office/drawing/2016/SVG/main" r:embed="rId6"/>
+                <asvg:svgBlip xmlns:asvg="http://schemas.microsoft.com/office/drawing/2016/SVG/main" r:embed="rId4"/>
               </a:ext>
             </a:extLst>
           </a:blip>
@@ -19418,10 +20390,10 @@
           <p:nvPr/>
         </p:nvPicPr>
         <p:blipFill>
-          <a:blip r:embed="rId7">
+          <a:blip>
             <a:extLst>
               <a:ext uri="{96DAC541-7B7A-43D3-8B79-37D633B846F1}">
-                <asvg:svgBlip xmlns:asvg="http://schemas.microsoft.com/office/drawing/2016/SVG/main" r:embed="rId8"/>
+                <asvg:svgBlip xmlns:asvg="http://schemas.microsoft.com/office/drawing/2016/SVG/main" r:embed="rId5"/>
               </a:ext>
             </a:extLst>
           </a:blip>
@@ -19454,10 +20426,10 @@
           <p:nvPr/>
         </p:nvPicPr>
         <p:blipFill>
-          <a:blip r:embed="rId9">
+          <a:blip>
             <a:extLst>
               <a:ext uri="{96DAC541-7B7A-43D3-8B79-37D633B846F1}">
-                <asvg:svgBlip xmlns:asvg="http://schemas.microsoft.com/office/drawing/2016/SVG/main" r:embed="rId10"/>
+                <asvg:svgBlip xmlns:asvg="http://schemas.microsoft.com/office/drawing/2016/SVG/main" r:embed="rId6"/>
               </a:ext>
             </a:extLst>
           </a:blip>
@@ -19490,10 +20462,10 @@
           <p:nvPr/>
         </p:nvPicPr>
         <p:blipFill>
-          <a:blip r:embed="rId11">
+          <a:blip>
             <a:extLst>
               <a:ext uri="{96DAC541-7B7A-43D3-8B79-37D633B846F1}">
-                <asvg:svgBlip xmlns:asvg="http://schemas.microsoft.com/office/drawing/2016/SVG/main" r:embed="rId12"/>
+                <asvg:svgBlip xmlns:asvg="http://schemas.microsoft.com/office/drawing/2016/SVG/main" r:embed="rId7"/>
               </a:ext>
             </a:extLst>
           </a:blip>
@@ -19526,10 +20498,10 @@
           <p:nvPr/>
         </p:nvPicPr>
         <p:blipFill>
-          <a:blip r:embed="rId13">
+          <a:blip>
             <a:extLst>
               <a:ext uri="{96DAC541-7B7A-43D3-8B79-37D633B846F1}">
-                <asvg:svgBlip xmlns:asvg="http://schemas.microsoft.com/office/drawing/2016/SVG/main" r:embed="rId14"/>
+                <asvg:svgBlip xmlns:asvg="http://schemas.microsoft.com/office/drawing/2016/SVG/main" r:embed="rId8"/>
               </a:ext>
             </a:extLst>
           </a:blip>
@@ -19562,10 +20534,10 @@
           <p:nvPr/>
         </p:nvPicPr>
         <p:blipFill>
-          <a:blip r:embed="rId15">
+          <a:blip>
             <a:extLst>
               <a:ext uri="{96DAC541-7B7A-43D3-8B79-37D633B846F1}">
-                <asvg:svgBlip xmlns:asvg="http://schemas.microsoft.com/office/drawing/2016/SVG/main" r:embed="rId16"/>
+                <asvg:svgBlip xmlns:asvg="http://schemas.microsoft.com/office/drawing/2016/SVG/main" r:embed="rId9"/>
               </a:ext>
             </a:extLst>
           </a:blip>
@@ -20208,10 +21180,10 @@
           <p:nvPr/>
         </p:nvPicPr>
         <p:blipFill>
-          <a:blip r:embed="rId11">
+          <a:blip>
             <a:extLst>
               <a:ext uri="{96DAC541-7B7A-43D3-8B79-37D633B846F1}">
-                <asvg:svgBlip xmlns:asvg="http://schemas.microsoft.com/office/drawing/2016/SVG/main" r:embed="rId12"/>
+                <asvg:svgBlip xmlns:asvg="http://schemas.microsoft.com/office/drawing/2016/SVG/main" r:embed="rId7"/>
               </a:ext>
             </a:extLst>
           </a:blip>

</xml_diff>

<commit_message>
Add figures for Ch09
</commit_message>
<xml_diff>
--- a/figures/figures.pptx
+++ b/figures/figures.pptx
@@ -5,7 +5,7 @@
     <p:sldMasterId id="2147483660" r:id="rId1"/>
   </p:sldMasterIdLst>
   <p:notesMasterIdLst>
-    <p:notesMasterId r:id="rId26"/>
+    <p:notesMasterId r:id="rId29"/>
   </p:notesMasterIdLst>
   <p:sldIdLst>
     <p:sldId id="258" r:id="rId2"/>
@@ -31,7 +31,10 @@
     <p:sldId id="269" r:id="rId22"/>
     <p:sldId id="274" r:id="rId23"/>
     <p:sldId id="270" r:id="rId24"/>
-    <p:sldId id="257" r:id="rId25"/>
+    <p:sldId id="284" r:id="rId25"/>
+    <p:sldId id="282" r:id="rId26"/>
+    <p:sldId id="283" r:id="rId27"/>
+    <p:sldId id="257" r:id="rId28"/>
   </p:sldIdLst>
   <p:sldSz cx="12192000" cy="6858000"/>
   <p:notesSz cx="6858000" cy="9144000"/>
@@ -190,6 +193,13 @@
             <p14:sldId id="269"/>
             <p14:sldId id="274"/>
             <p14:sldId id="270"/>
+          </p14:sldIdLst>
+        </p14:section>
+        <p14:section name="Conclusion" id="{02F95322-1659-4331-9A74-3CC42BA10F6A}">
+          <p14:sldIdLst>
+            <p14:sldId id="284"/>
+            <p14:sldId id="282"/>
+            <p14:sldId id="283"/>
           </p14:sldIdLst>
         </p14:section>
         <p14:section name="Examples" id="{2CEADF37-2C1D-4DE6-BB08-5D838E707A13}">
@@ -17043,6 +17053,3904 @@
           <a:chExt cx="0" cy="0"/>
         </a:xfrm>
       </p:grpSpPr>
+      <p:sp>
+        <p:nvSpPr>
+          <p:cNvPr id="44" name="Rectangle: Rounded Corners 43">
+            <a:extLst>
+              <a:ext uri="{FF2B5EF4-FFF2-40B4-BE49-F238E27FC236}">
+                <a16:creationId xmlns:a16="http://schemas.microsoft.com/office/drawing/2014/main" id="{D2CE8B92-0FBB-60F0-A0EE-D6AFE5D15B09}"/>
+              </a:ext>
+            </a:extLst>
+          </p:cNvPr>
+          <p:cNvSpPr/>
+          <p:nvPr/>
+        </p:nvSpPr>
+        <p:spPr>
+          <a:xfrm>
+            <a:off x="358855" y="3658434"/>
+            <a:ext cx="8891162" cy="2923341"/>
+          </a:xfrm>
+          <a:prstGeom prst="roundRect">
+            <a:avLst>
+              <a:gd name="adj" fmla="val 5234"/>
+            </a:avLst>
+          </a:prstGeom>
+          <a:solidFill>
+            <a:schemeClr val="bg1"/>
+          </a:solidFill>
+          <a:ln>
+            <a:solidFill>
+              <a:schemeClr val="tx1"/>
+            </a:solidFill>
+          </a:ln>
+        </p:spPr>
+        <p:style>
+          <a:lnRef idx="2">
+            <a:schemeClr val="accent1">
+              <a:shade val="15000"/>
+            </a:schemeClr>
+          </a:lnRef>
+          <a:fillRef idx="1">
+            <a:schemeClr val="accent1"/>
+          </a:fillRef>
+          <a:effectRef idx="0">
+            <a:schemeClr val="accent1"/>
+          </a:effectRef>
+          <a:fontRef idx="minor">
+            <a:schemeClr val="lt1"/>
+          </a:fontRef>
+        </p:style>
+        <p:txBody>
+          <a:bodyPr rtlCol="0" anchor="ctr"/>
+          <a:lstStyle/>
+          <a:p>
+            <a:pPr algn="ctr"/>
+            <a:endParaRPr lang="en-US" dirty="0">
+              <a:solidFill>
+                <a:schemeClr val="tx1"/>
+              </a:solidFill>
+            </a:endParaRPr>
+          </a:p>
+        </p:txBody>
+      </p:sp>
+      <p:sp>
+        <p:nvSpPr>
+          <p:cNvPr id="43" name="Rectangle: Rounded Corners 42">
+            <a:extLst>
+              <a:ext uri="{FF2B5EF4-FFF2-40B4-BE49-F238E27FC236}">
+                <a16:creationId xmlns:a16="http://schemas.microsoft.com/office/drawing/2014/main" id="{E8230BA4-DB8E-C294-E0A5-63D3EE9E71FE}"/>
+              </a:ext>
+            </a:extLst>
+          </p:cNvPr>
+          <p:cNvSpPr/>
+          <p:nvPr/>
+        </p:nvSpPr>
+        <p:spPr>
+          <a:xfrm>
+            <a:off x="358855" y="153614"/>
+            <a:ext cx="8891162" cy="3433513"/>
+          </a:xfrm>
+          <a:prstGeom prst="roundRect">
+            <a:avLst>
+              <a:gd name="adj" fmla="val 5234"/>
+            </a:avLst>
+          </a:prstGeom>
+          <a:solidFill>
+            <a:schemeClr val="bg1"/>
+          </a:solidFill>
+          <a:ln>
+            <a:solidFill>
+              <a:schemeClr val="tx1"/>
+            </a:solidFill>
+          </a:ln>
+        </p:spPr>
+        <p:style>
+          <a:lnRef idx="2">
+            <a:schemeClr val="accent1">
+              <a:shade val="15000"/>
+            </a:schemeClr>
+          </a:lnRef>
+          <a:fillRef idx="1">
+            <a:schemeClr val="accent1"/>
+          </a:fillRef>
+          <a:effectRef idx="0">
+            <a:schemeClr val="accent1"/>
+          </a:effectRef>
+          <a:fontRef idx="minor">
+            <a:schemeClr val="lt1"/>
+          </a:fontRef>
+        </p:style>
+        <p:txBody>
+          <a:bodyPr rtlCol="0" anchor="ctr"/>
+          <a:lstStyle/>
+          <a:p>
+            <a:pPr algn="ctr"/>
+            <a:endParaRPr lang="en-US" dirty="0">
+              <a:solidFill>
+                <a:schemeClr val="tx1"/>
+              </a:solidFill>
+            </a:endParaRPr>
+          </a:p>
+        </p:txBody>
+      </p:sp>
+      <p:pic>
+        <p:nvPicPr>
+          <p:cNvPr id="5" name="Graphic 4">
+            <a:extLst>
+              <a:ext uri="{FF2B5EF4-FFF2-40B4-BE49-F238E27FC236}">
+                <a16:creationId xmlns:a16="http://schemas.microsoft.com/office/drawing/2014/main" id="{71F33519-CE18-B69F-489D-3645A1E07D4E}"/>
+              </a:ext>
+            </a:extLst>
+          </p:cNvPr>
+          <p:cNvPicPr>
+            <a:picLocks noChangeAspect="1"/>
+          </p:cNvPicPr>
+          <p:nvPr/>
+        </p:nvPicPr>
+        <p:blipFill>
+          <a:blip>
+            <a:extLst>
+              <a:ext uri="{96DAC541-7B7A-43D3-8B79-37D633B846F1}">
+                <asvg:svgBlip xmlns:asvg="http://schemas.microsoft.com/office/drawing/2016/SVG/main" r:embed="rId2"/>
+              </a:ext>
+            </a:extLst>
+          </a:blip>
+          <a:stretch>
+            <a:fillRect/>
+          </a:stretch>
+        </p:blipFill>
+        <p:spPr>
+          <a:xfrm>
+            <a:off x="6328300" y="1598778"/>
+            <a:ext cx="685800" cy="685800"/>
+          </a:xfrm>
+          <a:prstGeom prst="rect">
+            <a:avLst/>
+          </a:prstGeom>
+        </p:spPr>
+      </p:pic>
+      <p:pic>
+        <p:nvPicPr>
+          <p:cNvPr id="7" name="Graphic 6">
+            <a:extLst>
+              <a:ext uri="{FF2B5EF4-FFF2-40B4-BE49-F238E27FC236}">
+                <a16:creationId xmlns:a16="http://schemas.microsoft.com/office/drawing/2014/main" id="{ED25F84F-12D9-933D-383D-DF47935E14D8}"/>
+              </a:ext>
+            </a:extLst>
+          </p:cNvPr>
+          <p:cNvPicPr>
+            <a:picLocks noChangeAspect="1"/>
+          </p:cNvPicPr>
+          <p:nvPr/>
+        </p:nvPicPr>
+        <p:blipFill>
+          <a:blip>
+            <a:extLst>
+              <a:ext uri="{96DAC541-7B7A-43D3-8B79-37D633B846F1}">
+                <asvg:svgBlip xmlns:asvg="http://schemas.microsoft.com/office/drawing/2016/SVG/main" r:embed="rId3"/>
+              </a:ext>
+            </a:extLst>
+          </a:blip>
+          <a:stretch>
+            <a:fillRect/>
+          </a:stretch>
+        </p:blipFill>
+        <p:spPr>
+          <a:xfrm>
+            <a:off x="4144061" y="1598778"/>
+            <a:ext cx="685800" cy="685800"/>
+          </a:xfrm>
+          <a:prstGeom prst="rect">
+            <a:avLst/>
+          </a:prstGeom>
+        </p:spPr>
+      </p:pic>
+      <p:pic>
+        <p:nvPicPr>
+          <p:cNvPr id="8" name="Graphic 7" descr="User with solid fill">
+            <a:extLst>
+              <a:ext uri="{FF2B5EF4-FFF2-40B4-BE49-F238E27FC236}">
+                <a16:creationId xmlns:a16="http://schemas.microsoft.com/office/drawing/2014/main" id="{45C5B597-FDA1-220F-DA15-C4996706619A}"/>
+              </a:ext>
+            </a:extLst>
+          </p:cNvPr>
+          <p:cNvPicPr>
+            <a:picLocks noChangeAspect="1"/>
+          </p:cNvPicPr>
+          <p:nvPr/>
+        </p:nvPicPr>
+        <p:blipFill>
+          <a:blip>
+            <a:extLst>
+              <a:ext uri="{96DAC541-7B7A-43D3-8B79-37D633B846F1}">
+                <asvg:svgBlip xmlns:asvg="http://schemas.microsoft.com/office/drawing/2016/SVG/main" r:embed="rId4"/>
+              </a:ext>
+            </a:extLst>
+          </a:blip>
+          <a:stretch>
+            <a:fillRect/>
+          </a:stretch>
+        </p:blipFill>
+        <p:spPr>
+          <a:xfrm>
+            <a:off x="1966732" y="1598778"/>
+            <a:ext cx="685800" cy="685800"/>
+          </a:xfrm>
+          <a:prstGeom prst="rect">
+            <a:avLst/>
+          </a:prstGeom>
+        </p:spPr>
+      </p:pic>
+      <p:sp>
+        <p:nvSpPr>
+          <p:cNvPr id="9" name="TextBox 8">
+            <a:extLst>
+              <a:ext uri="{FF2B5EF4-FFF2-40B4-BE49-F238E27FC236}">
+                <a16:creationId xmlns:a16="http://schemas.microsoft.com/office/drawing/2014/main" id="{4085A3F3-6DF2-4004-4A04-AFA22E2C0073}"/>
+              </a:ext>
+            </a:extLst>
+          </p:cNvPr>
+          <p:cNvSpPr txBox="1"/>
+          <p:nvPr/>
+        </p:nvSpPr>
+        <p:spPr>
+          <a:xfrm>
+            <a:off x="2032152" y="2183544"/>
+            <a:ext cx="554960" cy="369332"/>
+          </a:xfrm>
+          <a:prstGeom prst="rect">
+            <a:avLst/>
+          </a:prstGeom>
+          <a:noFill/>
+        </p:spPr>
+        <p:txBody>
+          <a:bodyPr wrap="none" rtlCol="0">
+            <a:spAutoFit/>
+          </a:bodyPr>
+          <a:lstStyle/>
+          <a:p>
+            <a:pPr algn="ctr"/>
+            <a:r>
+              <a:rPr lang="en-US" dirty="0"/>
+              <a:t>User</a:t>
+            </a:r>
+          </a:p>
+        </p:txBody>
+      </p:sp>
+      <p:sp>
+        <p:nvSpPr>
+          <p:cNvPr id="12" name="Rectangle: Rounded Corners 11">
+            <a:extLst>
+              <a:ext uri="{FF2B5EF4-FFF2-40B4-BE49-F238E27FC236}">
+                <a16:creationId xmlns:a16="http://schemas.microsoft.com/office/drawing/2014/main" id="{C68BB52E-7BF9-9935-FCC4-98115B42BF97}"/>
+              </a:ext>
+            </a:extLst>
+          </p:cNvPr>
+          <p:cNvSpPr/>
+          <p:nvPr/>
+        </p:nvSpPr>
+        <p:spPr>
+          <a:xfrm>
+            <a:off x="533713" y="1685704"/>
+            <a:ext cx="1078685" cy="369332"/>
+          </a:xfrm>
+          <a:prstGeom prst="roundRect">
+            <a:avLst/>
+          </a:prstGeom>
+          <a:solidFill>
+            <a:srgbClr val="B2D4EB"/>
+          </a:solidFill>
+          <a:ln>
+            <a:solidFill>
+              <a:schemeClr val="tx1"/>
+            </a:solidFill>
+          </a:ln>
+        </p:spPr>
+        <p:style>
+          <a:lnRef idx="2">
+            <a:schemeClr val="accent1">
+              <a:shade val="15000"/>
+            </a:schemeClr>
+          </a:lnRef>
+          <a:fillRef idx="1">
+            <a:schemeClr val="accent1"/>
+          </a:fillRef>
+          <a:effectRef idx="0">
+            <a:schemeClr val="accent1"/>
+          </a:effectRef>
+          <a:fontRef idx="minor">
+            <a:schemeClr val="lt1"/>
+          </a:fontRef>
+        </p:style>
+        <p:txBody>
+          <a:bodyPr rtlCol="0" anchor="ctr"/>
+          <a:lstStyle/>
+          <a:p>
+            <a:pPr algn="ctr"/>
+            <a:r>
+              <a:rPr lang="en-US" dirty="0">
+                <a:solidFill>
+                  <a:schemeClr val="tx1"/>
+                </a:solidFill>
+              </a:rPr>
+              <a:t>Now…</a:t>
+            </a:r>
+            <a:endParaRPr lang="en-US" i="1" dirty="0">
+              <a:solidFill>
+                <a:schemeClr val="tx1"/>
+              </a:solidFill>
+            </a:endParaRPr>
+          </a:p>
+        </p:txBody>
+      </p:sp>
+      <p:sp>
+        <p:nvSpPr>
+          <p:cNvPr id="14" name="TextBox 13">
+            <a:extLst>
+              <a:ext uri="{FF2B5EF4-FFF2-40B4-BE49-F238E27FC236}">
+                <a16:creationId xmlns:a16="http://schemas.microsoft.com/office/drawing/2014/main" id="{131DAF99-B97C-87DD-26D0-B8648A52F7C4}"/>
+              </a:ext>
+            </a:extLst>
+          </p:cNvPr>
+          <p:cNvSpPr txBox="1"/>
+          <p:nvPr/>
+        </p:nvSpPr>
+        <p:spPr>
+          <a:xfrm>
+            <a:off x="4150971" y="2183544"/>
+            <a:ext cx="671980" cy="369332"/>
+          </a:xfrm>
+          <a:prstGeom prst="rect">
+            <a:avLst/>
+          </a:prstGeom>
+          <a:noFill/>
+        </p:spPr>
+        <p:txBody>
+          <a:bodyPr wrap="none" rtlCol="0">
+            <a:spAutoFit/>
+          </a:bodyPr>
+          <a:lstStyle/>
+          <a:p>
+            <a:pPr algn="ctr"/>
+            <a:r>
+              <a:rPr lang="en-US" dirty="0"/>
+              <a:t>Agent</a:t>
+            </a:r>
+          </a:p>
+        </p:txBody>
+      </p:sp>
+      <p:sp>
+        <p:nvSpPr>
+          <p:cNvPr id="15" name="TextBox 14">
+            <a:extLst>
+              <a:ext uri="{FF2B5EF4-FFF2-40B4-BE49-F238E27FC236}">
+                <a16:creationId xmlns:a16="http://schemas.microsoft.com/office/drawing/2014/main" id="{1163E150-DB3F-44DE-67E4-D87E6220AC23}"/>
+              </a:ext>
+            </a:extLst>
+          </p:cNvPr>
+          <p:cNvSpPr txBox="1"/>
+          <p:nvPr/>
+        </p:nvSpPr>
+        <p:spPr>
+          <a:xfrm>
+            <a:off x="6002012" y="2183544"/>
+            <a:ext cx="1338380" cy="369332"/>
+          </a:xfrm>
+          <a:prstGeom prst="rect">
+            <a:avLst/>
+          </a:prstGeom>
+          <a:noFill/>
+        </p:spPr>
+        <p:txBody>
+          <a:bodyPr wrap="none" rtlCol="0">
+            <a:spAutoFit/>
+          </a:bodyPr>
+          <a:lstStyle/>
+          <a:p>
+            <a:pPr algn="ctr"/>
+            <a:r>
+              <a:rPr lang="en-US" dirty="0"/>
+              <a:t>Memory Store</a:t>
+            </a:r>
+          </a:p>
+        </p:txBody>
+      </p:sp>
+      <p:sp>
+        <p:nvSpPr>
+          <p:cNvPr id="16" name="Speech Bubble: Rectangle with Corners Rounded 15">
+            <a:extLst>
+              <a:ext uri="{FF2B5EF4-FFF2-40B4-BE49-F238E27FC236}">
+                <a16:creationId xmlns:a16="http://schemas.microsoft.com/office/drawing/2014/main" id="{62598B43-CEC1-5766-C927-CEC15C1A0AAE}"/>
+              </a:ext>
+            </a:extLst>
+          </p:cNvPr>
+          <p:cNvSpPr/>
+          <p:nvPr/>
+        </p:nvSpPr>
+        <p:spPr>
+          <a:xfrm>
+            <a:off x="1770288" y="366015"/>
+            <a:ext cx="2885222" cy="1012578"/>
+          </a:xfrm>
+          <a:prstGeom prst="wedgeRoundRectCallout">
+            <a:avLst>
+              <a:gd name="adj1" fmla="val -29100"/>
+              <a:gd name="adj2" fmla="val 75797"/>
+              <a:gd name="adj3" fmla="val 16667"/>
+            </a:avLst>
+          </a:prstGeom>
+          <a:solidFill>
+            <a:srgbClr val="E5F1F8"/>
+          </a:solidFill>
+        </p:spPr>
+        <p:style>
+          <a:lnRef idx="2">
+            <a:schemeClr val="dk1">
+              <a:shade val="15000"/>
+            </a:schemeClr>
+          </a:lnRef>
+          <a:fillRef idx="1">
+            <a:schemeClr val="dk1"/>
+          </a:fillRef>
+          <a:effectRef idx="0">
+            <a:schemeClr val="dk1"/>
+          </a:effectRef>
+          <a:fontRef idx="minor">
+            <a:schemeClr val="lt1"/>
+          </a:fontRef>
+        </p:style>
+        <p:txBody>
+          <a:bodyPr rtlCol="0" anchor="ctr"/>
+          <a:lstStyle/>
+          <a:p>
+            <a:pPr algn="ctr"/>
+            <a:r>
+              <a:rPr lang="en-US" dirty="0">
+                <a:solidFill>
+                  <a:schemeClr val="tx1"/>
+                </a:solidFill>
+              </a:rPr>
+              <a:t>Write some code to train a machine learning model.</a:t>
+            </a:r>
+          </a:p>
+          <a:p>
+            <a:pPr algn="ctr"/>
+            <a:r>
+              <a:rPr lang="en-US" dirty="0">
+                <a:solidFill>
+                  <a:schemeClr val="tx1"/>
+                </a:solidFill>
+              </a:rPr>
+              <a:t>I only know Python. </a:t>
+            </a:r>
+          </a:p>
+        </p:txBody>
+      </p:sp>
+      <p:cxnSp>
+        <p:nvCxnSpPr>
+          <p:cNvPr id="19" name="Straight Arrow Connector 18">
+            <a:extLst>
+              <a:ext uri="{FF2B5EF4-FFF2-40B4-BE49-F238E27FC236}">
+                <a16:creationId xmlns:a16="http://schemas.microsoft.com/office/drawing/2014/main" id="{511CB169-6E50-27F5-F297-9515C4A19049}"/>
+              </a:ext>
+            </a:extLst>
+          </p:cNvPr>
+          <p:cNvCxnSpPr>
+            <a:cxnSpLocks/>
+            <a:stCxn id="8" idx="3"/>
+            <a:endCxn id="7" idx="1"/>
+          </p:cNvCxnSpPr>
+          <p:nvPr/>
+        </p:nvCxnSpPr>
+        <p:spPr>
+          <a:xfrm>
+            <a:off x="2652532" y="1941678"/>
+            <a:ext cx="1491529" cy="0"/>
+          </a:xfrm>
+          <a:prstGeom prst="straightConnector1">
+            <a:avLst/>
+          </a:prstGeom>
+          <a:ln>
+            <a:solidFill>
+              <a:schemeClr val="tx1"/>
+            </a:solidFill>
+            <a:prstDash val="solid"/>
+            <a:headEnd type="none" w="lg" len="lg"/>
+            <a:tailEnd type="triangle" w="lg" len="lg"/>
+          </a:ln>
+        </p:spPr>
+        <p:style>
+          <a:lnRef idx="2">
+            <a:schemeClr val="accent1"/>
+          </a:lnRef>
+          <a:fillRef idx="0">
+            <a:schemeClr val="accent1"/>
+          </a:fillRef>
+          <a:effectRef idx="1">
+            <a:schemeClr val="accent1"/>
+          </a:effectRef>
+          <a:fontRef idx="minor">
+            <a:schemeClr val="tx1"/>
+          </a:fontRef>
+        </p:style>
+      </p:cxnSp>
+      <p:cxnSp>
+        <p:nvCxnSpPr>
+          <p:cNvPr id="23" name="Straight Arrow Connector 22">
+            <a:extLst>
+              <a:ext uri="{FF2B5EF4-FFF2-40B4-BE49-F238E27FC236}">
+                <a16:creationId xmlns:a16="http://schemas.microsoft.com/office/drawing/2014/main" id="{19BD5D59-D6BD-C3BA-C313-5F1EA656DB47}"/>
+              </a:ext>
+            </a:extLst>
+          </p:cNvPr>
+          <p:cNvCxnSpPr>
+            <a:cxnSpLocks/>
+            <a:stCxn id="7" idx="3"/>
+            <a:endCxn id="5" idx="1"/>
+          </p:cNvCxnSpPr>
+          <p:nvPr/>
+        </p:nvCxnSpPr>
+        <p:spPr>
+          <a:xfrm>
+            <a:off x="4829861" y="1941678"/>
+            <a:ext cx="1498439" cy="0"/>
+          </a:xfrm>
+          <a:prstGeom prst="straightConnector1">
+            <a:avLst/>
+          </a:prstGeom>
+          <a:ln>
+            <a:solidFill>
+              <a:schemeClr val="tx1"/>
+            </a:solidFill>
+            <a:prstDash val="solid"/>
+            <a:headEnd type="none" w="lg" len="lg"/>
+            <a:tailEnd type="triangle" w="lg" len="lg"/>
+          </a:ln>
+        </p:spPr>
+        <p:style>
+          <a:lnRef idx="2">
+            <a:schemeClr val="accent1"/>
+          </a:lnRef>
+          <a:fillRef idx="0">
+            <a:schemeClr val="accent1"/>
+          </a:fillRef>
+          <a:effectRef idx="1">
+            <a:schemeClr val="accent1"/>
+          </a:effectRef>
+          <a:fontRef idx="minor">
+            <a:schemeClr val="tx1"/>
+          </a:fontRef>
+        </p:style>
+      </p:cxnSp>
+      <p:sp>
+        <p:nvSpPr>
+          <p:cNvPr id="26" name="Speech Bubble: Rectangle with Corners Rounded 25">
+            <a:extLst>
+              <a:ext uri="{FF2B5EF4-FFF2-40B4-BE49-F238E27FC236}">
+                <a16:creationId xmlns:a16="http://schemas.microsoft.com/office/drawing/2014/main" id="{251CF955-9DB1-0FA1-7E20-6549D911EBF7}"/>
+              </a:ext>
+            </a:extLst>
+          </p:cNvPr>
+          <p:cNvSpPr/>
+          <p:nvPr/>
+        </p:nvSpPr>
+        <p:spPr>
+          <a:xfrm>
+            <a:off x="3785978" y="2794741"/>
+            <a:ext cx="2885222" cy="612648"/>
+          </a:xfrm>
+          <a:prstGeom prst="wedgeRoundRectCallout">
+            <a:avLst>
+              <a:gd name="adj1" fmla="val -25196"/>
+              <a:gd name="adj2" fmla="val -88916"/>
+              <a:gd name="adj3" fmla="val 16667"/>
+            </a:avLst>
+          </a:prstGeom>
+          <a:solidFill>
+            <a:srgbClr val="E5F1F8"/>
+          </a:solidFill>
+        </p:spPr>
+        <p:style>
+          <a:lnRef idx="2">
+            <a:schemeClr val="dk1">
+              <a:shade val="15000"/>
+            </a:schemeClr>
+          </a:lnRef>
+          <a:fillRef idx="1">
+            <a:schemeClr val="dk1"/>
+          </a:fillRef>
+          <a:effectRef idx="0">
+            <a:schemeClr val="dk1"/>
+          </a:effectRef>
+          <a:fontRef idx="minor">
+            <a:schemeClr val="lt1"/>
+          </a:fontRef>
+        </p:style>
+        <p:txBody>
+          <a:bodyPr rtlCol="0" anchor="ctr"/>
+          <a:lstStyle/>
+          <a:p>
+            <a:pPr algn="ctr"/>
+            <a:r>
+              <a:rPr lang="en-US" dirty="0">
+                <a:solidFill>
+                  <a:schemeClr val="tx1"/>
+                </a:solidFill>
+              </a:rPr>
+              <a:t>from </a:t>
+            </a:r>
+            <a:r>
+              <a:rPr lang="en-US" dirty="0" err="1">
+                <a:solidFill>
+                  <a:schemeClr val="tx1"/>
+                </a:solidFill>
+              </a:rPr>
+              <a:t>sklearn</a:t>
+            </a:r>
+            <a:r>
+              <a:rPr lang="en-US" dirty="0">
+                <a:solidFill>
+                  <a:schemeClr val="tx1"/>
+                </a:solidFill>
+              </a:rPr>
+              <a:t> import …</a:t>
+            </a:r>
+          </a:p>
+        </p:txBody>
+      </p:sp>
+      <p:sp>
+        <p:nvSpPr>
+          <p:cNvPr id="27" name="Speech Bubble: Rectangle with Corners Rounded 26">
+            <a:extLst>
+              <a:ext uri="{FF2B5EF4-FFF2-40B4-BE49-F238E27FC236}">
+                <a16:creationId xmlns:a16="http://schemas.microsoft.com/office/drawing/2014/main" id="{171105D8-27A4-BFED-D2CD-C8DA37000511}"/>
+              </a:ext>
+            </a:extLst>
+          </p:cNvPr>
+          <p:cNvSpPr/>
+          <p:nvPr/>
+        </p:nvSpPr>
+        <p:spPr>
+          <a:xfrm>
+            <a:off x="6096000" y="765945"/>
+            <a:ext cx="2885222" cy="612648"/>
+          </a:xfrm>
+          <a:prstGeom prst="wedgeRoundRectCallout">
+            <a:avLst>
+              <a:gd name="adj1" fmla="val -29330"/>
+              <a:gd name="adj2" fmla="val 89539"/>
+              <a:gd name="adj3" fmla="val 16667"/>
+            </a:avLst>
+          </a:prstGeom>
+          <a:solidFill>
+            <a:srgbClr val="E5F1F8"/>
+          </a:solidFill>
+        </p:spPr>
+        <p:style>
+          <a:lnRef idx="2">
+            <a:schemeClr val="dk1">
+              <a:shade val="15000"/>
+            </a:schemeClr>
+          </a:lnRef>
+          <a:fillRef idx="1">
+            <a:schemeClr val="dk1"/>
+          </a:fillRef>
+          <a:effectRef idx="0">
+            <a:schemeClr val="dk1"/>
+          </a:effectRef>
+          <a:fontRef idx="minor">
+            <a:schemeClr val="lt1"/>
+          </a:fontRef>
+        </p:style>
+        <p:txBody>
+          <a:bodyPr rtlCol="0" anchor="ctr"/>
+          <a:lstStyle/>
+          <a:p>
+            <a:pPr algn="ctr"/>
+            <a:r>
+              <a:rPr lang="en-US" dirty="0">
+                <a:solidFill>
+                  <a:schemeClr val="tx1"/>
+                </a:solidFill>
+              </a:rPr>
+              <a:t>Only knows Python</a:t>
+            </a:r>
+          </a:p>
+        </p:txBody>
+      </p:sp>
+      <p:pic>
+        <p:nvPicPr>
+          <p:cNvPr id="28" name="Graphic 27">
+            <a:extLst>
+              <a:ext uri="{FF2B5EF4-FFF2-40B4-BE49-F238E27FC236}">
+                <a16:creationId xmlns:a16="http://schemas.microsoft.com/office/drawing/2014/main" id="{3753D523-5D17-25C2-3E2E-562DC19F42FD}"/>
+              </a:ext>
+            </a:extLst>
+          </p:cNvPr>
+          <p:cNvPicPr>
+            <a:picLocks noChangeAspect="1"/>
+          </p:cNvPicPr>
+          <p:nvPr/>
+        </p:nvPicPr>
+        <p:blipFill>
+          <a:blip>
+            <a:extLst>
+              <a:ext uri="{96DAC541-7B7A-43D3-8B79-37D633B846F1}">
+                <asvg:svgBlip xmlns:asvg="http://schemas.microsoft.com/office/drawing/2016/SVG/main" r:embed="rId2"/>
+              </a:ext>
+            </a:extLst>
+          </a:blip>
+          <a:stretch>
+            <a:fillRect/>
+          </a:stretch>
+        </p:blipFill>
+        <p:spPr>
+          <a:xfrm>
+            <a:off x="6328300" y="4640152"/>
+            <a:ext cx="685800" cy="685800"/>
+          </a:xfrm>
+          <a:prstGeom prst="rect">
+            <a:avLst/>
+          </a:prstGeom>
+        </p:spPr>
+      </p:pic>
+      <p:pic>
+        <p:nvPicPr>
+          <p:cNvPr id="29" name="Graphic 28">
+            <a:extLst>
+              <a:ext uri="{FF2B5EF4-FFF2-40B4-BE49-F238E27FC236}">
+                <a16:creationId xmlns:a16="http://schemas.microsoft.com/office/drawing/2014/main" id="{4FAF1C6E-95B5-32B1-E2B3-661500DADBEE}"/>
+              </a:ext>
+            </a:extLst>
+          </p:cNvPr>
+          <p:cNvPicPr>
+            <a:picLocks noChangeAspect="1"/>
+          </p:cNvPicPr>
+          <p:nvPr/>
+        </p:nvPicPr>
+        <p:blipFill>
+          <a:blip>
+            <a:extLst>
+              <a:ext uri="{96DAC541-7B7A-43D3-8B79-37D633B846F1}">
+                <asvg:svgBlip xmlns:asvg="http://schemas.microsoft.com/office/drawing/2016/SVG/main" r:embed="rId3"/>
+              </a:ext>
+            </a:extLst>
+          </a:blip>
+          <a:stretch>
+            <a:fillRect/>
+          </a:stretch>
+        </p:blipFill>
+        <p:spPr>
+          <a:xfrm>
+            <a:off x="4144061" y="4640152"/>
+            <a:ext cx="685800" cy="685800"/>
+          </a:xfrm>
+          <a:prstGeom prst="rect">
+            <a:avLst/>
+          </a:prstGeom>
+        </p:spPr>
+      </p:pic>
+      <p:pic>
+        <p:nvPicPr>
+          <p:cNvPr id="30" name="Graphic 29" descr="User with solid fill">
+            <a:extLst>
+              <a:ext uri="{FF2B5EF4-FFF2-40B4-BE49-F238E27FC236}">
+                <a16:creationId xmlns:a16="http://schemas.microsoft.com/office/drawing/2014/main" id="{3CFE110E-8813-1FA4-CDD3-2ADB30FCF439}"/>
+              </a:ext>
+            </a:extLst>
+          </p:cNvPr>
+          <p:cNvPicPr>
+            <a:picLocks noChangeAspect="1"/>
+          </p:cNvPicPr>
+          <p:nvPr/>
+        </p:nvPicPr>
+        <p:blipFill>
+          <a:blip>
+            <a:extLst>
+              <a:ext uri="{96DAC541-7B7A-43D3-8B79-37D633B846F1}">
+                <asvg:svgBlip xmlns:asvg="http://schemas.microsoft.com/office/drawing/2016/SVG/main" r:embed="rId4"/>
+              </a:ext>
+            </a:extLst>
+          </a:blip>
+          <a:stretch>
+            <a:fillRect/>
+          </a:stretch>
+        </p:blipFill>
+        <p:spPr>
+          <a:xfrm>
+            <a:off x="1966732" y="4640152"/>
+            <a:ext cx="685800" cy="685800"/>
+          </a:xfrm>
+          <a:prstGeom prst="rect">
+            <a:avLst/>
+          </a:prstGeom>
+        </p:spPr>
+      </p:pic>
+      <p:sp>
+        <p:nvSpPr>
+          <p:cNvPr id="31" name="TextBox 30">
+            <a:extLst>
+              <a:ext uri="{FF2B5EF4-FFF2-40B4-BE49-F238E27FC236}">
+                <a16:creationId xmlns:a16="http://schemas.microsoft.com/office/drawing/2014/main" id="{95FBFC99-2660-1276-0EE8-A4D1E458FAB8}"/>
+              </a:ext>
+            </a:extLst>
+          </p:cNvPr>
+          <p:cNvSpPr txBox="1"/>
+          <p:nvPr/>
+        </p:nvSpPr>
+        <p:spPr>
+          <a:xfrm>
+            <a:off x="2032152" y="5224918"/>
+            <a:ext cx="554960" cy="369332"/>
+          </a:xfrm>
+          <a:prstGeom prst="rect">
+            <a:avLst/>
+          </a:prstGeom>
+          <a:noFill/>
+        </p:spPr>
+        <p:txBody>
+          <a:bodyPr wrap="none" rtlCol="0">
+            <a:spAutoFit/>
+          </a:bodyPr>
+          <a:lstStyle/>
+          <a:p>
+            <a:pPr algn="ctr"/>
+            <a:r>
+              <a:rPr lang="en-US" dirty="0"/>
+              <a:t>User</a:t>
+            </a:r>
+          </a:p>
+        </p:txBody>
+      </p:sp>
+      <p:sp>
+        <p:nvSpPr>
+          <p:cNvPr id="32" name="Rectangle: Rounded Corners 31">
+            <a:extLst>
+              <a:ext uri="{FF2B5EF4-FFF2-40B4-BE49-F238E27FC236}">
+                <a16:creationId xmlns:a16="http://schemas.microsoft.com/office/drawing/2014/main" id="{3FBB97D8-567B-2FB3-A77F-4142991A4776}"/>
+              </a:ext>
+            </a:extLst>
+          </p:cNvPr>
+          <p:cNvSpPr/>
+          <p:nvPr/>
+        </p:nvSpPr>
+        <p:spPr>
+          <a:xfrm>
+            <a:off x="533713" y="5119217"/>
+            <a:ext cx="1078685" cy="369332"/>
+          </a:xfrm>
+          <a:prstGeom prst="roundRect">
+            <a:avLst/>
+          </a:prstGeom>
+          <a:solidFill>
+            <a:srgbClr val="B2D4EB"/>
+          </a:solidFill>
+          <a:ln>
+            <a:solidFill>
+              <a:schemeClr val="tx1"/>
+            </a:solidFill>
+          </a:ln>
+        </p:spPr>
+        <p:style>
+          <a:lnRef idx="2">
+            <a:schemeClr val="accent1">
+              <a:shade val="15000"/>
+            </a:schemeClr>
+          </a:lnRef>
+          <a:fillRef idx="1">
+            <a:schemeClr val="accent1"/>
+          </a:fillRef>
+          <a:effectRef idx="0">
+            <a:schemeClr val="accent1"/>
+          </a:effectRef>
+          <a:fontRef idx="minor">
+            <a:schemeClr val="lt1"/>
+          </a:fontRef>
+        </p:style>
+        <p:txBody>
+          <a:bodyPr rtlCol="0" anchor="ctr"/>
+          <a:lstStyle/>
+          <a:p>
+            <a:pPr algn="ctr"/>
+            <a:r>
+              <a:rPr lang="en-US" dirty="0">
+                <a:solidFill>
+                  <a:schemeClr val="tx1"/>
+                </a:solidFill>
+              </a:rPr>
+              <a:t>Later…</a:t>
+            </a:r>
+            <a:endParaRPr lang="en-US" i="1" dirty="0">
+              <a:solidFill>
+                <a:schemeClr val="tx1"/>
+              </a:solidFill>
+            </a:endParaRPr>
+          </a:p>
+        </p:txBody>
+      </p:sp>
+      <p:sp>
+        <p:nvSpPr>
+          <p:cNvPr id="33" name="TextBox 32">
+            <a:extLst>
+              <a:ext uri="{FF2B5EF4-FFF2-40B4-BE49-F238E27FC236}">
+                <a16:creationId xmlns:a16="http://schemas.microsoft.com/office/drawing/2014/main" id="{C2CFF3AF-6386-1815-7F4B-10773FA4310B}"/>
+              </a:ext>
+            </a:extLst>
+          </p:cNvPr>
+          <p:cNvSpPr txBox="1"/>
+          <p:nvPr/>
+        </p:nvSpPr>
+        <p:spPr>
+          <a:xfrm>
+            <a:off x="4150971" y="5224918"/>
+            <a:ext cx="671980" cy="369332"/>
+          </a:xfrm>
+          <a:prstGeom prst="rect">
+            <a:avLst/>
+          </a:prstGeom>
+          <a:noFill/>
+        </p:spPr>
+        <p:txBody>
+          <a:bodyPr wrap="none" rtlCol="0">
+            <a:spAutoFit/>
+          </a:bodyPr>
+          <a:lstStyle/>
+          <a:p>
+            <a:pPr algn="ctr"/>
+            <a:r>
+              <a:rPr lang="en-US" dirty="0"/>
+              <a:t>Agent</a:t>
+            </a:r>
+          </a:p>
+        </p:txBody>
+      </p:sp>
+      <p:sp>
+        <p:nvSpPr>
+          <p:cNvPr id="34" name="TextBox 33">
+            <a:extLst>
+              <a:ext uri="{FF2B5EF4-FFF2-40B4-BE49-F238E27FC236}">
+                <a16:creationId xmlns:a16="http://schemas.microsoft.com/office/drawing/2014/main" id="{A612CBF8-29C7-89CD-7A59-406C49225BBD}"/>
+              </a:ext>
+            </a:extLst>
+          </p:cNvPr>
+          <p:cNvSpPr txBox="1"/>
+          <p:nvPr/>
+        </p:nvSpPr>
+        <p:spPr>
+          <a:xfrm>
+            <a:off x="6002012" y="5224918"/>
+            <a:ext cx="1338380" cy="369332"/>
+          </a:xfrm>
+          <a:prstGeom prst="rect">
+            <a:avLst/>
+          </a:prstGeom>
+          <a:noFill/>
+        </p:spPr>
+        <p:txBody>
+          <a:bodyPr wrap="none" rtlCol="0">
+            <a:spAutoFit/>
+          </a:bodyPr>
+          <a:lstStyle/>
+          <a:p>
+            <a:pPr algn="ctr"/>
+            <a:r>
+              <a:rPr lang="en-US" dirty="0"/>
+              <a:t>Memory Store</a:t>
+            </a:r>
+          </a:p>
+        </p:txBody>
+      </p:sp>
+      <p:sp>
+        <p:nvSpPr>
+          <p:cNvPr id="35" name="Speech Bubble: Rectangle with Corners Rounded 34">
+            <a:extLst>
+              <a:ext uri="{FF2B5EF4-FFF2-40B4-BE49-F238E27FC236}">
+                <a16:creationId xmlns:a16="http://schemas.microsoft.com/office/drawing/2014/main" id="{135EC79D-0288-3ED4-7298-811262B903D5}"/>
+              </a:ext>
+            </a:extLst>
+          </p:cNvPr>
+          <p:cNvSpPr/>
+          <p:nvPr/>
+        </p:nvSpPr>
+        <p:spPr>
+          <a:xfrm>
+            <a:off x="1770288" y="3807319"/>
+            <a:ext cx="2885222" cy="612648"/>
+          </a:xfrm>
+          <a:prstGeom prst="wedgeRoundRectCallout">
+            <a:avLst>
+              <a:gd name="adj1" fmla="val -29330"/>
+              <a:gd name="adj2" fmla="val 89539"/>
+              <a:gd name="adj3" fmla="val 16667"/>
+            </a:avLst>
+          </a:prstGeom>
+          <a:solidFill>
+            <a:srgbClr val="E5F1F8"/>
+          </a:solidFill>
+        </p:spPr>
+        <p:style>
+          <a:lnRef idx="2">
+            <a:schemeClr val="dk1">
+              <a:shade val="15000"/>
+            </a:schemeClr>
+          </a:lnRef>
+          <a:fillRef idx="1">
+            <a:schemeClr val="dk1"/>
+          </a:fillRef>
+          <a:effectRef idx="0">
+            <a:schemeClr val="dk1"/>
+          </a:effectRef>
+          <a:fontRef idx="minor">
+            <a:schemeClr val="lt1"/>
+          </a:fontRef>
+        </p:style>
+        <p:txBody>
+          <a:bodyPr rtlCol="0" anchor="ctr"/>
+          <a:lstStyle/>
+          <a:p>
+            <a:pPr algn="ctr"/>
+            <a:r>
+              <a:rPr lang="en-US" dirty="0">
+                <a:solidFill>
+                  <a:schemeClr val="tx1"/>
+                </a:solidFill>
+              </a:rPr>
+              <a:t>Help me generate a plot</a:t>
+            </a:r>
+          </a:p>
+          <a:p>
+            <a:pPr algn="ctr"/>
+            <a:r>
+              <a:rPr lang="en-US" dirty="0">
+                <a:solidFill>
+                  <a:schemeClr val="tx1"/>
+                </a:solidFill>
+              </a:rPr>
+              <a:t>for this dataset.</a:t>
+            </a:r>
+          </a:p>
+        </p:txBody>
+      </p:sp>
+      <p:cxnSp>
+        <p:nvCxnSpPr>
+          <p:cNvPr id="36" name="Straight Arrow Connector 35">
+            <a:extLst>
+              <a:ext uri="{FF2B5EF4-FFF2-40B4-BE49-F238E27FC236}">
+                <a16:creationId xmlns:a16="http://schemas.microsoft.com/office/drawing/2014/main" id="{79F506EE-BB26-240B-042A-A2A65C8D06D4}"/>
+              </a:ext>
+            </a:extLst>
+          </p:cNvPr>
+          <p:cNvCxnSpPr>
+            <a:cxnSpLocks/>
+            <a:stCxn id="30" idx="3"/>
+            <a:endCxn id="29" idx="1"/>
+          </p:cNvCxnSpPr>
+          <p:nvPr/>
+        </p:nvCxnSpPr>
+        <p:spPr>
+          <a:xfrm>
+            <a:off x="2652532" y="4983052"/>
+            <a:ext cx="1491529" cy="0"/>
+          </a:xfrm>
+          <a:prstGeom prst="straightConnector1">
+            <a:avLst/>
+          </a:prstGeom>
+          <a:ln>
+            <a:solidFill>
+              <a:schemeClr val="tx1"/>
+            </a:solidFill>
+            <a:prstDash val="solid"/>
+            <a:headEnd type="none" w="lg" len="lg"/>
+            <a:tailEnd type="triangle" w="lg" len="lg"/>
+          </a:ln>
+        </p:spPr>
+        <p:style>
+          <a:lnRef idx="2">
+            <a:schemeClr val="accent1"/>
+          </a:lnRef>
+          <a:fillRef idx="0">
+            <a:schemeClr val="accent1"/>
+          </a:fillRef>
+          <a:effectRef idx="1">
+            <a:schemeClr val="accent1"/>
+          </a:effectRef>
+          <a:fontRef idx="minor">
+            <a:schemeClr val="tx1"/>
+          </a:fontRef>
+        </p:style>
+      </p:cxnSp>
+      <p:cxnSp>
+        <p:nvCxnSpPr>
+          <p:cNvPr id="37" name="Straight Arrow Connector 36">
+            <a:extLst>
+              <a:ext uri="{FF2B5EF4-FFF2-40B4-BE49-F238E27FC236}">
+                <a16:creationId xmlns:a16="http://schemas.microsoft.com/office/drawing/2014/main" id="{574A5733-2C01-3E27-7090-45BD5FB15200}"/>
+              </a:ext>
+            </a:extLst>
+          </p:cNvPr>
+          <p:cNvCxnSpPr>
+            <a:cxnSpLocks/>
+            <a:stCxn id="28" idx="1"/>
+            <a:endCxn id="29" idx="3"/>
+          </p:cNvCxnSpPr>
+          <p:nvPr/>
+        </p:nvCxnSpPr>
+        <p:spPr>
+          <a:xfrm flipH="1">
+            <a:off x="4829861" y="4983052"/>
+            <a:ext cx="1498439" cy="0"/>
+          </a:xfrm>
+          <a:prstGeom prst="straightConnector1">
+            <a:avLst/>
+          </a:prstGeom>
+          <a:ln>
+            <a:solidFill>
+              <a:schemeClr val="tx1"/>
+            </a:solidFill>
+            <a:prstDash val="solid"/>
+            <a:headEnd type="none" w="lg" len="lg"/>
+            <a:tailEnd type="triangle" w="lg" len="lg"/>
+          </a:ln>
+        </p:spPr>
+        <p:style>
+          <a:lnRef idx="2">
+            <a:schemeClr val="accent1"/>
+          </a:lnRef>
+          <a:fillRef idx="0">
+            <a:schemeClr val="accent1"/>
+          </a:fillRef>
+          <a:effectRef idx="1">
+            <a:schemeClr val="accent1"/>
+          </a:effectRef>
+          <a:fontRef idx="minor">
+            <a:schemeClr val="tx1"/>
+          </a:fontRef>
+        </p:style>
+      </p:cxnSp>
+      <p:sp>
+        <p:nvSpPr>
+          <p:cNvPr id="38" name="Speech Bubble: Rectangle with Corners Rounded 37">
+            <a:extLst>
+              <a:ext uri="{FF2B5EF4-FFF2-40B4-BE49-F238E27FC236}">
+                <a16:creationId xmlns:a16="http://schemas.microsoft.com/office/drawing/2014/main" id="{5D85D6AC-48CF-AC5D-C137-4856B7B2D135}"/>
+              </a:ext>
+            </a:extLst>
+          </p:cNvPr>
+          <p:cNvSpPr/>
+          <p:nvPr/>
+        </p:nvSpPr>
+        <p:spPr>
+          <a:xfrm>
+            <a:off x="3785978" y="5836115"/>
+            <a:ext cx="2885222" cy="612648"/>
+          </a:xfrm>
+          <a:prstGeom prst="wedgeRoundRectCallout">
+            <a:avLst>
+              <a:gd name="adj1" fmla="val -25196"/>
+              <a:gd name="adj2" fmla="val -88916"/>
+              <a:gd name="adj3" fmla="val 16667"/>
+            </a:avLst>
+          </a:prstGeom>
+          <a:solidFill>
+            <a:srgbClr val="E5F1F8"/>
+          </a:solidFill>
+        </p:spPr>
+        <p:style>
+          <a:lnRef idx="2">
+            <a:schemeClr val="dk1">
+              <a:shade val="15000"/>
+            </a:schemeClr>
+          </a:lnRef>
+          <a:fillRef idx="1">
+            <a:schemeClr val="dk1"/>
+          </a:fillRef>
+          <a:effectRef idx="0">
+            <a:schemeClr val="dk1"/>
+          </a:effectRef>
+          <a:fontRef idx="minor">
+            <a:schemeClr val="lt1"/>
+          </a:fontRef>
+        </p:style>
+        <p:txBody>
+          <a:bodyPr rtlCol="0" anchor="ctr"/>
+          <a:lstStyle/>
+          <a:p>
+            <a:r>
+              <a:rPr lang="en-US" dirty="0">
+                <a:solidFill>
+                  <a:schemeClr val="tx1"/>
+                </a:solidFill>
+              </a:rPr>
+              <a:t>import </a:t>
+            </a:r>
+            <a:r>
+              <a:rPr lang="en-US" dirty="0" err="1">
+                <a:solidFill>
+                  <a:schemeClr val="tx1"/>
+                </a:solidFill>
+              </a:rPr>
+              <a:t>matplotlib.pyplot</a:t>
+            </a:r>
+            <a:r>
+              <a:rPr lang="en-US" dirty="0">
+                <a:solidFill>
+                  <a:schemeClr val="tx1"/>
+                </a:solidFill>
+              </a:rPr>
+              <a:t> as </a:t>
+            </a:r>
+            <a:r>
+              <a:rPr lang="en-US" dirty="0" err="1">
+                <a:solidFill>
+                  <a:schemeClr val="tx1"/>
+                </a:solidFill>
+              </a:rPr>
+              <a:t>plt</a:t>
+            </a:r>
+            <a:endParaRPr lang="en-US" dirty="0">
+              <a:solidFill>
+                <a:schemeClr val="tx1"/>
+              </a:solidFill>
+            </a:endParaRPr>
+          </a:p>
+        </p:txBody>
+      </p:sp>
+      <p:sp>
+        <p:nvSpPr>
+          <p:cNvPr id="39" name="Speech Bubble: Rectangle with Corners Rounded 38">
+            <a:extLst>
+              <a:ext uri="{FF2B5EF4-FFF2-40B4-BE49-F238E27FC236}">
+                <a16:creationId xmlns:a16="http://schemas.microsoft.com/office/drawing/2014/main" id="{949128A9-77EC-8D4B-219D-7A28229C8AC4}"/>
+              </a:ext>
+            </a:extLst>
+          </p:cNvPr>
+          <p:cNvSpPr/>
+          <p:nvPr/>
+        </p:nvSpPr>
+        <p:spPr>
+          <a:xfrm>
+            <a:off x="6096000" y="3807319"/>
+            <a:ext cx="2885222" cy="612648"/>
+          </a:xfrm>
+          <a:prstGeom prst="wedgeRoundRectCallout">
+            <a:avLst>
+              <a:gd name="adj1" fmla="val -29330"/>
+              <a:gd name="adj2" fmla="val 89539"/>
+              <a:gd name="adj3" fmla="val 16667"/>
+            </a:avLst>
+          </a:prstGeom>
+          <a:solidFill>
+            <a:srgbClr val="E5F1F8"/>
+          </a:solidFill>
+        </p:spPr>
+        <p:style>
+          <a:lnRef idx="2">
+            <a:schemeClr val="dk1">
+              <a:shade val="15000"/>
+            </a:schemeClr>
+          </a:lnRef>
+          <a:fillRef idx="1">
+            <a:schemeClr val="dk1"/>
+          </a:fillRef>
+          <a:effectRef idx="0">
+            <a:schemeClr val="dk1"/>
+          </a:effectRef>
+          <a:fontRef idx="minor">
+            <a:schemeClr val="lt1"/>
+          </a:fontRef>
+        </p:style>
+        <p:txBody>
+          <a:bodyPr rtlCol="0" anchor="ctr"/>
+          <a:lstStyle/>
+          <a:p>
+            <a:pPr algn="ctr"/>
+            <a:r>
+              <a:rPr lang="en-US" dirty="0">
+                <a:solidFill>
+                  <a:schemeClr val="tx1"/>
+                </a:solidFill>
+              </a:rPr>
+              <a:t>Only knows Python</a:t>
+            </a:r>
+          </a:p>
+        </p:txBody>
+      </p:sp>
+    </p:spTree>
+    <p:extLst>
+      <p:ext uri="{BB962C8B-B14F-4D97-AF65-F5344CB8AC3E}">
+        <p14:creationId xmlns:p14="http://schemas.microsoft.com/office/powerpoint/2010/main" val="2395708849"/>
+      </p:ext>
+    </p:extLst>
+  </p:cSld>
+  <p:clrMapOvr>
+    <a:masterClrMapping/>
+  </p:clrMapOvr>
+</p:sld>
+</file>
+
+<file path=ppt/slides/slide25.xml><?xml version="1.0" encoding="utf-8"?>
+<p:sld xmlns:a="http://schemas.openxmlformats.org/drawingml/2006/main" xmlns:r="http://schemas.openxmlformats.org/officeDocument/2006/relationships" xmlns:p="http://schemas.openxmlformats.org/presentationml/2006/main">
+  <p:cSld>
+    <p:spTree>
+      <p:nvGrpSpPr>
+        <p:cNvPr id="1" name=""/>
+        <p:cNvGrpSpPr/>
+        <p:nvPr/>
+      </p:nvGrpSpPr>
+      <p:grpSpPr>
+        <a:xfrm>
+          <a:off x="0" y="0"/>
+          <a:ext cx="0" cy="0"/>
+          <a:chOff x="0" y="0"/>
+          <a:chExt cx="0" cy="0"/>
+        </a:xfrm>
+      </p:grpSpPr>
+      <p:sp>
+        <p:nvSpPr>
+          <p:cNvPr id="29" name="Rectangle 28">
+            <a:extLst>
+              <a:ext uri="{FF2B5EF4-FFF2-40B4-BE49-F238E27FC236}">
+                <a16:creationId xmlns:a16="http://schemas.microsoft.com/office/drawing/2014/main" id="{D09C6FBE-9D75-48BF-C42A-6E39ED978517}"/>
+              </a:ext>
+            </a:extLst>
+          </p:cNvPr>
+          <p:cNvSpPr/>
+          <p:nvPr/>
+        </p:nvSpPr>
+        <p:spPr>
+          <a:xfrm>
+            <a:off x="8773764" y="3207730"/>
+            <a:ext cx="237446" cy="184664"/>
+          </a:xfrm>
+          <a:prstGeom prst="rect">
+            <a:avLst/>
+          </a:prstGeom>
+        </p:spPr>
+        <p:style>
+          <a:lnRef idx="2">
+            <a:schemeClr val="accent1">
+              <a:shade val="15000"/>
+            </a:schemeClr>
+          </a:lnRef>
+          <a:fillRef idx="1">
+            <a:schemeClr val="accent1"/>
+          </a:fillRef>
+          <a:effectRef idx="0">
+            <a:schemeClr val="accent1"/>
+          </a:effectRef>
+          <a:fontRef idx="minor">
+            <a:schemeClr val="lt1"/>
+          </a:fontRef>
+        </p:style>
+        <p:txBody>
+          <a:bodyPr rtlCol="0" anchor="ctr"/>
+          <a:lstStyle/>
+          <a:p>
+            <a:pPr algn="ctr"/>
+            <a:endParaRPr lang="en-US"/>
+          </a:p>
+        </p:txBody>
+      </p:sp>
+      <p:sp>
+        <p:nvSpPr>
+          <p:cNvPr id="2" name="Rectangle: Rounded Corners 1">
+            <a:extLst>
+              <a:ext uri="{FF2B5EF4-FFF2-40B4-BE49-F238E27FC236}">
+                <a16:creationId xmlns:a16="http://schemas.microsoft.com/office/drawing/2014/main" id="{D7D559C0-7BA5-7BA3-7991-88FE92F6985E}"/>
+              </a:ext>
+            </a:extLst>
+          </p:cNvPr>
+          <p:cNvSpPr/>
+          <p:nvPr/>
+        </p:nvSpPr>
+        <p:spPr>
+          <a:xfrm>
+            <a:off x="4028921" y="2284412"/>
+            <a:ext cx="4982297" cy="1817138"/>
+          </a:xfrm>
+          <a:prstGeom prst="roundRect">
+            <a:avLst>
+              <a:gd name="adj" fmla="val 5234"/>
+            </a:avLst>
+          </a:prstGeom>
+          <a:solidFill>
+            <a:schemeClr val="bg1"/>
+          </a:solidFill>
+          <a:ln>
+            <a:solidFill>
+              <a:schemeClr val="tx1"/>
+            </a:solidFill>
+          </a:ln>
+        </p:spPr>
+        <p:style>
+          <a:lnRef idx="2">
+            <a:schemeClr val="accent1">
+              <a:shade val="15000"/>
+            </a:schemeClr>
+          </a:lnRef>
+          <a:fillRef idx="1">
+            <a:schemeClr val="accent1"/>
+          </a:fillRef>
+          <a:effectRef idx="0">
+            <a:schemeClr val="accent1"/>
+          </a:effectRef>
+          <a:fontRef idx="minor">
+            <a:schemeClr val="lt1"/>
+          </a:fontRef>
+        </p:style>
+        <p:txBody>
+          <a:bodyPr rtlCol="0" anchor="ctr"/>
+          <a:lstStyle/>
+          <a:p>
+            <a:pPr algn="ctr"/>
+            <a:endParaRPr lang="en-US" dirty="0">
+              <a:solidFill>
+                <a:schemeClr val="tx1"/>
+              </a:solidFill>
+            </a:endParaRPr>
+          </a:p>
+        </p:txBody>
+      </p:sp>
+      <p:sp>
+        <p:nvSpPr>
+          <p:cNvPr id="3" name="Rectangle: Rounded Corners 2">
+            <a:extLst>
+              <a:ext uri="{FF2B5EF4-FFF2-40B4-BE49-F238E27FC236}">
+                <a16:creationId xmlns:a16="http://schemas.microsoft.com/office/drawing/2014/main" id="{369A92FF-932E-7204-6E1B-ADC372951728}"/>
+              </a:ext>
+            </a:extLst>
+          </p:cNvPr>
+          <p:cNvSpPr/>
+          <p:nvPr/>
+        </p:nvSpPr>
+        <p:spPr>
+          <a:xfrm>
+            <a:off x="5229604" y="2099745"/>
+            <a:ext cx="2580925" cy="369332"/>
+          </a:xfrm>
+          <a:prstGeom prst="roundRect">
+            <a:avLst/>
+          </a:prstGeom>
+          <a:solidFill>
+            <a:srgbClr val="B2D4EB"/>
+          </a:solidFill>
+          <a:ln>
+            <a:solidFill>
+              <a:schemeClr val="tx1"/>
+            </a:solidFill>
+          </a:ln>
+        </p:spPr>
+        <p:style>
+          <a:lnRef idx="2">
+            <a:schemeClr val="accent1">
+              <a:shade val="15000"/>
+            </a:schemeClr>
+          </a:lnRef>
+          <a:fillRef idx="1">
+            <a:schemeClr val="accent1"/>
+          </a:fillRef>
+          <a:effectRef idx="0">
+            <a:schemeClr val="accent1"/>
+          </a:effectRef>
+          <a:fontRef idx="minor">
+            <a:schemeClr val="lt1"/>
+          </a:fontRef>
+        </p:style>
+        <p:txBody>
+          <a:bodyPr rtlCol="0" anchor="ctr"/>
+          <a:lstStyle/>
+          <a:p>
+            <a:pPr algn="ctr"/>
+            <a:r>
+              <a:rPr lang="en-US" dirty="0">
+                <a:solidFill>
+                  <a:schemeClr val="tx1"/>
+                </a:solidFill>
+              </a:rPr>
+              <a:t>Governance Layers</a:t>
+            </a:r>
+            <a:endParaRPr lang="en-US" i="1" dirty="0">
+              <a:solidFill>
+                <a:schemeClr val="tx1"/>
+              </a:solidFill>
+            </a:endParaRPr>
+          </a:p>
+        </p:txBody>
+      </p:sp>
+      <p:sp>
+        <p:nvSpPr>
+          <p:cNvPr id="4" name="Rectangle: Rounded Corners 3">
+            <a:extLst>
+              <a:ext uri="{FF2B5EF4-FFF2-40B4-BE49-F238E27FC236}">
+                <a16:creationId xmlns:a16="http://schemas.microsoft.com/office/drawing/2014/main" id="{BBB68683-7AE1-4C22-DB0B-68CB410C7950}"/>
+              </a:ext>
+            </a:extLst>
+          </p:cNvPr>
+          <p:cNvSpPr/>
+          <p:nvPr/>
+        </p:nvSpPr>
+        <p:spPr>
+          <a:xfrm>
+            <a:off x="5847981" y="2653741"/>
+            <a:ext cx="1344168" cy="553989"/>
+          </a:xfrm>
+          <a:prstGeom prst="roundRect">
+            <a:avLst/>
+          </a:prstGeom>
+          <a:solidFill>
+            <a:srgbClr val="E5F1F8"/>
+          </a:solidFill>
+          <a:ln>
+            <a:solidFill>
+              <a:schemeClr val="tx1"/>
+            </a:solidFill>
+          </a:ln>
+        </p:spPr>
+        <p:style>
+          <a:lnRef idx="2">
+            <a:schemeClr val="accent1">
+              <a:shade val="15000"/>
+            </a:schemeClr>
+          </a:lnRef>
+          <a:fillRef idx="1">
+            <a:schemeClr val="accent1"/>
+          </a:fillRef>
+          <a:effectRef idx="0">
+            <a:schemeClr val="accent1"/>
+          </a:effectRef>
+          <a:fontRef idx="minor">
+            <a:schemeClr val="lt1"/>
+          </a:fontRef>
+        </p:style>
+        <p:txBody>
+          <a:bodyPr rtlCol="0" anchor="ctr"/>
+          <a:lstStyle/>
+          <a:p>
+            <a:pPr algn="ctr"/>
+            <a:r>
+              <a:rPr lang="en-US" dirty="0">
+                <a:solidFill>
+                  <a:schemeClr val="tx1"/>
+                </a:solidFill>
+              </a:rPr>
+              <a:t>Identity &amp; Trust</a:t>
+            </a:r>
+          </a:p>
+        </p:txBody>
+      </p:sp>
+      <p:sp>
+        <p:nvSpPr>
+          <p:cNvPr id="5" name="Rectangle: Rounded Corners 4">
+            <a:extLst>
+              <a:ext uri="{FF2B5EF4-FFF2-40B4-BE49-F238E27FC236}">
+                <a16:creationId xmlns:a16="http://schemas.microsoft.com/office/drawing/2014/main" id="{48AEFC57-5299-7BF2-954C-A15A60632198}"/>
+              </a:ext>
+            </a:extLst>
+          </p:cNvPr>
+          <p:cNvSpPr/>
+          <p:nvPr/>
+        </p:nvSpPr>
+        <p:spPr>
+          <a:xfrm>
+            <a:off x="7429595" y="2653741"/>
+            <a:ext cx="1344168" cy="553989"/>
+          </a:xfrm>
+          <a:prstGeom prst="roundRect">
+            <a:avLst/>
+          </a:prstGeom>
+          <a:solidFill>
+            <a:srgbClr val="E5F1F8"/>
+          </a:solidFill>
+          <a:ln>
+            <a:solidFill>
+              <a:schemeClr val="tx1"/>
+            </a:solidFill>
+          </a:ln>
+        </p:spPr>
+        <p:style>
+          <a:lnRef idx="2">
+            <a:schemeClr val="accent1">
+              <a:shade val="15000"/>
+            </a:schemeClr>
+          </a:lnRef>
+          <a:fillRef idx="1">
+            <a:schemeClr val="accent1"/>
+          </a:fillRef>
+          <a:effectRef idx="0">
+            <a:schemeClr val="accent1"/>
+          </a:effectRef>
+          <a:fontRef idx="minor">
+            <a:schemeClr val="lt1"/>
+          </a:fontRef>
+        </p:style>
+        <p:txBody>
+          <a:bodyPr rtlCol="0" anchor="ctr"/>
+          <a:lstStyle/>
+          <a:p>
+            <a:pPr algn="ctr"/>
+            <a:r>
+              <a:rPr lang="en-US" dirty="0">
+                <a:solidFill>
+                  <a:schemeClr val="tx1"/>
+                </a:solidFill>
+              </a:rPr>
+              <a:t>Prompt Injection</a:t>
+            </a:r>
+          </a:p>
+        </p:txBody>
+      </p:sp>
+      <p:sp>
+        <p:nvSpPr>
+          <p:cNvPr id="6" name="Rectangle: Rounded Corners 5">
+            <a:extLst>
+              <a:ext uri="{FF2B5EF4-FFF2-40B4-BE49-F238E27FC236}">
+                <a16:creationId xmlns:a16="http://schemas.microsoft.com/office/drawing/2014/main" id="{1FB277EF-2BCD-7572-3C0B-F3829ECED8EE}"/>
+              </a:ext>
+            </a:extLst>
+          </p:cNvPr>
+          <p:cNvSpPr/>
+          <p:nvPr/>
+        </p:nvSpPr>
+        <p:spPr>
+          <a:xfrm>
+            <a:off x="4266367" y="2653741"/>
+            <a:ext cx="1344168" cy="553989"/>
+          </a:xfrm>
+          <a:prstGeom prst="roundRect">
+            <a:avLst/>
+          </a:prstGeom>
+          <a:solidFill>
+            <a:srgbClr val="E5F1F8"/>
+          </a:solidFill>
+          <a:ln>
+            <a:solidFill>
+              <a:schemeClr val="tx1"/>
+            </a:solidFill>
+          </a:ln>
+        </p:spPr>
+        <p:style>
+          <a:lnRef idx="2">
+            <a:schemeClr val="accent1">
+              <a:shade val="15000"/>
+            </a:schemeClr>
+          </a:lnRef>
+          <a:fillRef idx="1">
+            <a:schemeClr val="accent1"/>
+          </a:fillRef>
+          <a:effectRef idx="0">
+            <a:schemeClr val="accent1"/>
+          </a:effectRef>
+          <a:fontRef idx="minor">
+            <a:schemeClr val="lt1"/>
+          </a:fontRef>
+        </p:style>
+        <p:txBody>
+          <a:bodyPr rtlCol="0" anchor="ctr"/>
+          <a:lstStyle/>
+          <a:p>
+            <a:pPr algn="ctr"/>
+            <a:r>
+              <a:rPr lang="en-US" dirty="0">
+                <a:solidFill>
+                  <a:schemeClr val="tx1"/>
+                </a:solidFill>
+              </a:rPr>
+              <a:t>Policy Engine</a:t>
+            </a:r>
+          </a:p>
+        </p:txBody>
+      </p:sp>
+      <p:sp>
+        <p:nvSpPr>
+          <p:cNvPr id="7" name="Rectangle: Rounded Corners 6">
+            <a:extLst>
+              <a:ext uri="{FF2B5EF4-FFF2-40B4-BE49-F238E27FC236}">
+                <a16:creationId xmlns:a16="http://schemas.microsoft.com/office/drawing/2014/main" id="{D45AB78B-DEA8-01BB-75CC-60343D2DE3B9}"/>
+              </a:ext>
+            </a:extLst>
+          </p:cNvPr>
+          <p:cNvSpPr/>
+          <p:nvPr/>
+        </p:nvSpPr>
+        <p:spPr>
+          <a:xfrm>
+            <a:off x="811982" y="2284411"/>
+            <a:ext cx="2854044" cy="1817138"/>
+          </a:xfrm>
+          <a:prstGeom prst="roundRect">
+            <a:avLst>
+              <a:gd name="adj" fmla="val 5234"/>
+            </a:avLst>
+          </a:prstGeom>
+          <a:solidFill>
+            <a:schemeClr val="bg1"/>
+          </a:solidFill>
+          <a:ln>
+            <a:solidFill>
+              <a:schemeClr val="tx1"/>
+            </a:solidFill>
+          </a:ln>
+        </p:spPr>
+        <p:style>
+          <a:lnRef idx="2">
+            <a:schemeClr val="accent1">
+              <a:shade val="15000"/>
+            </a:schemeClr>
+          </a:lnRef>
+          <a:fillRef idx="1">
+            <a:schemeClr val="accent1"/>
+          </a:fillRef>
+          <a:effectRef idx="0">
+            <a:schemeClr val="accent1"/>
+          </a:effectRef>
+          <a:fontRef idx="minor">
+            <a:schemeClr val="lt1"/>
+          </a:fontRef>
+        </p:style>
+        <p:txBody>
+          <a:bodyPr rtlCol="0" anchor="ctr"/>
+          <a:lstStyle/>
+          <a:p>
+            <a:pPr algn="ctr"/>
+            <a:endParaRPr lang="en-US" dirty="0">
+              <a:solidFill>
+                <a:schemeClr val="tx1"/>
+              </a:solidFill>
+            </a:endParaRPr>
+          </a:p>
+        </p:txBody>
+      </p:sp>
+      <p:sp>
+        <p:nvSpPr>
+          <p:cNvPr id="8" name="Rectangle: Rounded Corners 7">
+            <a:extLst>
+              <a:ext uri="{FF2B5EF4-FFF2-40B4-BE49-F238E27FC236}">
+                <a16:creationId xmlns:a16="http://schemas.microsoft.com/office/drawing/2014/main" id="{CE8DED82-D37E-2CA9-B8B6-14C77E79F870}"/>
+              </a:ext>
+            </a:extLst>
+          </p:cNvPr>
+          <p:cNvSpPr/>
+          <p:nvPr/>
+        </p:nvSpPr>
+        <p:spPr>
+          <a:xfrm>
+            <a:off x="1210903" y="2099745"/>
+            <a:ext cx="2056202" cy="369332"/>
+          </a:xfrm>
+          <a:prstGeom prst="roundRect">
+            <a:avLst/>
+          </a:prstGeom>
+          <a:solidFill>
+            <a:srgbClr val="B2D4EB"/>
+          </a:solidFill>
+          <a:ln>
+            <a:solidFill>
+              <a:schemeClr val="tx1"/>
+            </a:solidFill>
+          </a:ln>
+        </p:spPr>
+        <p:style>
+          <a:lnRef idx="2">
+            <a:schemeClr val="accent1">
+              <a:shade val="15000"/>
+            </a:schemeClr>
+          </a:lnRef>
+          <a:fillRef idx="1">
+            <a:schemeClr val="accent1"/>
+          </a:fillRef>
+          <a:effectRef idx="0">
+            <a:schemeClr val="accent1"/>
+          </a:effectRef>
+          <a:fontRef idx="minor">
+            <a:schemeClr val="lt1"/>
+          </a:fontRef>
+        </p:style>
+        <p:txBody>
+          <a:bodyPr rtlCol="0" anchor="ctr"/>
+          <a:lstStyle/>
+          <a:p>
+            <a:pPr algn="ctr"/>
+            <a:r>
+              <a:rPr lang="en-US" dirty="0">
+                <a:solidFill>
+                  <a:schemeClr val="tx1"/>
+                </a:solidFill>
+              </a:rPr>
+              <a:t>Agent Framework</a:t>
+            </a:r>
+            <a:endParaRPr lang="en-US" i="1" dirty="0">
+              <a:solidFill>
+                <a:schemeClr val="tx1"/>
+              </a:solidFill>
+            </a:endParaRPr>
+          </a:p>
+        </p:txBody>
+      </p:sp>
+      <p:sp>
+        <p:nvSpPr>
+          <p:cNvPr id="9" name="Rectangle: Rounded Corners 8">
+            <a:extLst>
+              <a:ext uri="{FF2B5EF4-FFF2-40B4-BE49-F238E27FC236}">
+                <a16:creationId xmlns:a16="http://schemas.microsoft.com/office/drawing/2014/main" id="{B21B9E34-2525-7477-715C-A94A9F092864}"/>
+              </a:ext>
+            </a:extLst>
+          </p:cNvPr>
+          <p:cNvSpPr/>
+          <p:nvPr/>
+        </p:nvSpPr>
+        <p:spPr>
+          <a:xfrm>
+            <a:off x="5068128" y="3399767"/>
+            <a:ext cx="1344168" cy="553989"/>
+          </a:xfrm>
+          <a:prstGeom prst="roundRect">
+            <a:avLst/>
+          </a:prstGeom>
+          <a:solidFill>
+            <a:srgbClr val="E5F1F8"/>
+          </a:solidFill>
+          <a:ln>
+            <a:solidFill>
+              <a:schemeClr val="tx1"/>
+            </a:solidFill>
+          </a:ln>
+        </p:spPr>
+        <p:style>
+          <a:lnRef idx="2">
+            <a:schemeClr val="accent1">
+              <a:shade val="15000"/>
+            </a:schemeClr>
+          </a:lnRef>
+          <a:fillRef idx="1">
+            <a:schemeClr val="accent1"/>
+          </a:fillRef>
+          <a:effectRef idx="0">
+            <a:schemeClr val="accent1"/>
+          </a:effectRef>
+          <a:fontRef idx="minor">
+            <a:schemeClr val="lt1"/>
+          </a:fontRef>
+        </p:style>
+        <p:txBody>
+          <a:bodyPr rtlCol="0" anchor="ctr"/>
+          <a:lstStyle/>
+          <a:p>
+            <a:pPr algn="ctr"/>
+            <a:r>
+              <a:rPr lang="en-US" dirty="0">
+                <a:solidFill>
+                  <a:schemeClr val="tx1"/>
+                </a:solidFill>
+              </a:rPr>
+              <a:t>Execution Sandbox</a:t>
+            </a:r>
+          </a:p>
+        </p:txBody>
+      </p:sp>
+      <p:sp>
+        <p:nvSpPr>
+          <p:cNvPr id="10" name="Rectangle: Rounded Corners 9">
+            <a:extLst>
+              <a:ext uri="{FF2B5EF4-FFF2-40B4-BE49-F238E27FC236}">
+                <a16:creationId xmlns:a16="http://schemas.microsoft.com/office/drawing/2014/main" id="{FD185910-FAAE-B9BC-5504-BD859B072DB3}"/>
+              </a:ext>
+            </a:extLst>
+          </p:cNvPr>
+          <p:cNvSpPr/>
+          <p:nvPr/>
+        </p:nvSpPr>
+        <p:spPr>
+          <a:xfrm>
+            <a:off x="6627846" y="3399767"/>
+            <a:ext cx="1344168" cy="553989"/>
+          </a:xfrm>
+          <a:prstGeom prst="roundRect">
+            <a:avLst/>
+          </a:prstGeom>
+          <a:solidFill>
+            <a:srgbClr val="E5F1F8"/>
+          </a:solidFill>
+          <a:ln>
+            <a:solidFill>
+              <a:schemeClr val="tx1"/>
+            </a:solidFill>
+          </a:ln>
+        </p:spPr>
+        <p:style>
+          <a:lnRef idx="2">
+            <a:schemeClr val="accent1">
+              <a:shade val="15000"/>
+            </a:schemeClr>
+          </a:lnRef>
+          <a:fillRef idx="1">
+            <a:schemeClr val="accent1"/>
+          </a:fillRef>
+          <a:effectRef idx="0">
+            <a:schemeClr val="accent1"/>
+          </a:effectRef>
+          <a:fontRef idx="minor">
+            <a:schemeClr val="lt1"/>
+          </a:fontRef>
+        </p:style>
+        <p:txBody>
+          <a:bodyPr rtlCol="0" anchor="ctr"/>
+          <a:lstStyle/>
+          <a:p>
+            <a:pPr algn="ctr"/>
+            <a:r>
+              <a:rPr lang="en-US" dirty="0">
+                <a:solidFill>
+                  <a:schemeClr val="tx1"/>
+                </a:solidFill>
+              </a:rPr>
+              <a:t>Audit Log</a:t>
+            </a:r>
+          </a:p>
+        </p:txBody>
+      </p:sp>
+      <p:sp>
+        <p:nvSpPr>
+          <p:cNvPr id="12" name="Rectangle: Rounded Corners 11">
+            <a:extLst>
+              <a:ext uri="{FF2B5EF4-FFF2-40B4-BE49-F238E27FC236}">
+                <a16:creationId xmlns:a16="http://schemas.microsoft.com/office/drawing/2014/main" id="{642A45A0-4DC2-9B66-4AC8-0E24961EFEB3}"/>
+              </a:ext>
+            </a:extLst>
+          </p:cNvPr>
+          <p:cNvSpPr/>
+          <p:nvPr/>
+        </p:nvSpPr>
+        <p:spPr>
+          <a:xfrm>
+            <a:off x="1024326" y="2653741"/>
+            <a:ext cx="1103842" cy="553989"/>
+          </a:xfrm>
+          <a:prstGeom prst="roundRect">
+            <a:avLst/>
+          </a:prstGeom>
+          <a:solidFill>
+            <a:srgbClr val="E5F1F8"/>
+          </a:solidFill>
+          <a:ln>
+            <a:solidFill>
+              <a:schemeClr val="tx1"/>
+            </a:solidFill>
+          </a:ln>
+        </p:spPr>
+        <p:style>
+          <a:lnRef idx="2">
+            <a:schemeClr val="accent1">
+              <a:shade val="15000"/>
+            </a:schemeClr>
+          </a:lnRef>
+          <a:fillRef idx="1">
+            <a:schemeClr val="accent1"/>
+          </a:fillRef>
+          <a:effectRef idx="0">
+            <a:schemeClr val="accent1"/>
+          </a:effectRef>
+          <a:fontRef idx="minor">
+            <a:schemeClr val="lt1"/>
+          </a:fontRef>
+        </p:style>
+        <p:txBody>
+          <a:bodyPr rtlCol="0" anchor="ctr"/>
+          <a:lstStyle/>
+          <a:p>
+            <a:pPr algn="ctr"/>
+            <a:r>
+              <a:rPr lang="en-US" dirty="0">
+                <a:solidFill>
+                  <a:schemeClr val="tx1"/>
+                </a:solidFill>
+              </a:rPr>
+              <a:t>OpenAI</a:t>
+            </a:r>
+          </a:p>
+        </p:txBody>
+      </p:sp>
+      <p:sp>
+        <p:nvSpPr>
+          <p:cNvPr id="13" name="Rectangle: Rounded Corners 12">
+            <a:extLst>
+              <a:ext uri="{FF2B5EF4-FFF2-40B4-BE49-F238E27FC236}">
+                <a16:creationId xmlns:a16="http://schemas.microsoft.com/office/drawing/2014/main" id="{7EEFFF0A-9698-34DD-AD36-A33BA15E0A7B}"/>
+              </a:ext>
+            </a:extLst>
+          </p:cNvPr>
+          <p:cNvSpPr/>
+          <p:nvPr/>
+        </p:nvSpPr>
+        <p:spPr>
+          <a:xfrm>
+            <a:off x="2340512" y="2653742"/>
+            <a:ext cx="1103842" cy="553989"/>
+          </a:xfrm>
+          <a:prstGeom prst="roundRect">
+            <a:avLst/>
+          </a:prstGeom>
+          <a:solidFill>
+            <a:srgbClr val="E5F1F8"/>
+          </a:solidFill>
+          <a:ln>
+            <a:solidFill>
+              <a:schemeClr val="tx1"/>
+            </a:solidFill>
+          </a:ln>
+        </p:spPr>
+        <p:style>
+          <a:lnRef idx="2">
+            <a:schemeClr val="accent1">
+              <a:shade val="15000"/>
+            </a:schemeClr>
+          </a:lnRef>
+          <a:fillRef idx="1">
+            <a:schemeClr val="accent1"/>
+          </a:fillRef>
+          <a:effectRef idx="0">
+            <a:schemeClr val="accent1"/>
+          </a:effectRef>
+          <a:fontRef idx="minor">
+            <a:schemeClr val="lt1"/>
+          </a:fontRef>
+        </p:style>
+        <p:txBody>
+          <a:bodyPr rtlCol="0" anchor="ctr"/>
+          <a:lstStyle/>
+          <a:p>
+            <a:pPr algn="ctr"/>
+            <a:r>
+              <a:rPr lang="en-US" dirty="0" err="1">
+                <a:solidFill>
+                  <a:schemeClr val="tx1"/>
+                </a:solidFill>
+              </a:rPr>
+              <a:t>LangChain</a:t>
+            </a:r>
+            <a:endParaRPr lang="en-US" dirty="0">
+              <a:solidFill>
+                <a:schemeClr val="tx1"/>
+              </a:solidFill>
+            </a:endParaRPr>
+          </a:p>
+        </p:txBody>
+      </p:sp>
+      <p:sp>
+        <p:nvSpPr>
+          <p:cNvPr id="14" name="Rectangle: Rounded Corners 13">
+            <a:extLst>
+              <a:ext uri="{FF2B5EF4-FFF2-40B4-BE49-F238E27FC236}">
+                <a16:creationId xmlns:a16="http://schemas.microsoft.com/office/drawing/2014/main" id="{81111102-2E81-9A03-3E50-0FB0D2507B7A}"/>
+              </a:ext>
+            </a:extLst>
+          </p:cNvPr>
+          <p:cNvSpPr/>
+          <p:nvPr/>
+        </p:nvSpPr>
+        <p:spPr>
+          <a:xfrm>
+            <a:off x="1024326" y="3392394"/>
+            <a:ext cx="1103842" cy="553989"/>
+          </a:xfrm>
+          <a:prstGeom prst="roundRect">
+            <a:avLst/>
+          </a:prstGeom>
+          <a:solidFill>
+            <a:srgbClr val="E5F1F8"/>
+          </a:solidFill>
+          <a:ln>
+            <a:solidFill>
+              <a:schemeClr val="tx1"/>
+            </a:solidFill>
+          </a:ln>
+        </p:spPr>
+        <p:style>
+          <a:lnRef idx="2">
+            <a:schemeClr val="accent1">
+              <a:shade val="15000"/>
+            </a:schemeClr>
+          </a:lnRef>
+          <a:fillRef idx="1">
+            <a:schemeClr val="accent1"/>
+          </a:fillRef>
+          <a:effectRef idx="0">
+            <a:schemeClr val="accent1"/>
+          </a:effectRef>
+          <a:fontRef idx="minor">
+            <a:schemeClr val="lt1"/>
+          </a:fontRef>
+        </p:style>
+        <p:txBody>
+          <a:bodyPr rtlCol="0" anchor="ctr"/>
+          <a:lstStyle/>
+          <a:p>
+            <a:pPr algn="ctr"/>
+            <a:r>
+              <a:rPr lang="en-US" dirty="0" err="1">
+                <a:solidFill>
+                  <a:schemeClr val="tx1"/>
+                </a:solidFill>
+              </a:rPr>
+              <a:t>CrewAI</a:t>
+            </a:r>
+            <a:endParaRPr lang="en-US" dirty="0">
+              <a:solidFill>
+                <a:schemeClr val="tx1"/>
+              </a:solidFill>
+            </a:endParaRPr>
+          </a:p>
+        </p:txBody>
+      </p:sp>
+      <p:sp>
+        <p:nvSpPr>
+          <p:cNvPr id="15" name="Rectangle: Rounded Corners 14">
+            <a:extLst>
+              <a:ext uri="{FF2B5EF4-FFF2-40B4-BE49-F238E27FC236}">
+                <a16:creationId xmlns:a16="http://schemas.microsoft.com/office/drawing/2014/main" id="{AB7AD7D0-AC7D-3A60-DE81-097E439CC0BD}"/>
+              </a:ext>
+            </a:extLst>
+          </p:cNvPr>
+          <p:cNvSpPr/>
+          <p:nvPr/>
+        </p:nvSpPr>
+        <p:spPr>
+          <a:xfrm>
+            <a:off x="2340512" y="3399767"/>
+            <a:ext cx="1103842" cy="553989"/>
+          </a:xfrm>
+          <a:prstGeom prst="roundRect">
+            <a:avLst/>
+          </a:prstGeom>
+          <a:solidFill>
+            <a:srgbClr val="E5F1F8"/>
+          </a:solidFill>
+          <a:ln>
+            <a:solidFill>
+              <a:schemeClr val="tx1"/>
+            </a:solidFill>
+          </a:ln>
+        </p:spPr>
+        <p:style>
+          <a:lnRef idx="2">
+            <a:schemeClr val="accent1">
+              <a:shade val="15000"/>
+            </a:schemeClr>
+          </a:lnRef>
+          <a:fillRef idx="1">
+            <a:schemeClr val="accent1"/>
+          </a:fillRef>
+          <a:effectRef idx="0">
+            <a:schemeClr val="accent1"/>
+          </a:effectRef>
+          <a:fontRef idx="minor">
+            <a:schemeClr val="lt1"/>
+          </a:fontRef>
+        </p:style>
+        <p:txBody>
+          <a:bodyPr rtlCol="0" anchor="ctr"/>
+          <a:lstStyle/>
+          <a:p>
+            <a:pPr algn="ctr"/>
+            <a:r>
+              <a:rPr lang="en-US" dirty="0" err="1">
+                <a:solidFill>
+                  <a:schemeClr val="tx1"/>
+                </a:solidFill>
+              </a:rPr>
+              <a:t>AutoGen</a:t>
+            </a:r>
+            <a:endParaRPr lang="en-US" dirty="0">
+              <a:solidFill>
+                <a:schemeClr val="tx1"/>
+              </a:solidFill>
+            </a:endParaRPr>
+          </a:p>
+        </p:txBody>
+      </p:sp>
+      <p:cxnSp>
+        <p:nvCxnSpPr>
+          <p:cNvPr id="16" name="Straight Arrow Connector 15">
+            <a:extLst>
+              <a:ext uri="{FF2B5EF4-FFF2-40B4-BE49-F238E27FC236}">
+                <a16:creationId xmlns:a16="http://schemas.microsoft.com/office/drawing/2014/main" id="{9A768D8C-D005-708F-D0B3-75FFA74EC39C}"/>
+              </a:ext>
+            </a:extLst>
+          </p:cNvPr>
+          <p:cNvCxnSpPr>
+            <a:cxnSpLocks/>
+            <a:stCxn id="7" idx="3"/>
+            <a:endCxn id="2" idx="1"/>
+          </p:cNvCxnSpPr>
+          <p:nvPr/>
+        </p:nvCxnSpPr>
+        <p:spPr>
+          <a:xfrm>
+            <a:off x="3666026" y="3192980"/>
+            <a:ext cx="362895" cy="1"/>
+          </a:xfrm>
+          <a:prstGeom prst="straightConnector1">
+            <a:avLst/>
+          </a:prstGeom>
+          <a:ln>
+            <a:solidFill>
+              <a:schemeClr val="tx1"/>
+            </a:solidFill>
+            <a:prstDash val="solid"/>
+            <a:headEnd type="none" w="lg" len="lg"/>
+            <a:tailEnd type="triangle" w="lg" len="lg"/>
+          </a:ln>
+        </p:spPr>
+        <p:style>
+          <a:lnRef idx="2">
+            <a:schemeClr val="accent1"/>
+          </a:lnRef>
+          <a:fillRef idx="0">
+            <a:schemeClr val="accent1"/>
+          </a:fillRef>
+          <a:effectRef idx="1">
+            <a:schemeClr val="accent1"/>
+          </a:effectRef>
+          <a:fontRef idx="minor">
+            <a:schemeClr val="tx1"/>
+          </a:fontRef>
+        </p:style>
+      </p:cxnSp>
+      <p:cxnSp>
+        <p:nvCxnSpPr>
+          <p:cNvPr id="22" name="Connector: Elbow 21">
+            <a:extLst>
+              <a:ext uri="{FF2B5EF4-FFF2-40B4-BE49-F238E27FC236}">
+                <a16:creationId xmlns:a16="http://schemas.microsoft.com/office/drawing/2014/main" id="{9BB7F5A3-619C-4929-B9EE-4A61A71FD193}"/>
+              </a:ext>
+            </a:extLst>
+          </p:cNvPr>
+          <p:cNvCxnSpPr>
+            <a:cxnSpLocks/>
+            <a:stCxn id="29" idx="3"/>
+            <a:endCxn id="20" idx="2"/>
+          </p:cNvCxnSpPr>
+          <p:nvPr/>
+        </p:nvCxnSpPr>
+        <p:spPr>
+          <a:xfrm flipV="1">
+            <a:off x="9011210" y="2749759"/>
+            <a:ext cx="567259" cy="550303"/>
+          </a:xfrm>
+          <a:prstGeom prst="bentConnector3">
+            <a:avLst>
+              <a:gd name="adj1" fmla="val 50000"/>
+            </a:avLst>
+          </a:prstGeom>
+          <a:ln>
+            <a:solidFill>
+              <a:schemeClr val="tx1"/>
+            </a:solidFill>
+            <a:prstDash val="solid"/>
+            <a:headEnd type="none" w="lg" len="lg"/>
+            <a:tailEnd type="triangle" w="lg" len="lg"/>
+          </a:ln>
+        </p:spPr>
+        <p:style>
+          <a:lnRef idx="2">
+            <a:schemeClr val="accent1"/>
+          </a:lnRef>
+          <a:fillRef idx="0">
+            <a:schemeClr val="accent1"/>
+          </a:fillRef>
+          <a:effectRef idx="1">
+            <a:schemeClr val="accent1"/>
+          </a:effectRef>
+          <a:fontRef idx="minor">
+            <a:schemeClr val="tx1"/>
+          </a:fontRef>
+        </p:style>
+      </p:cxnSp>
+      <p:cxnSp>
+        <p:nvCxnSpPr>
+          <p:cNvPr id="25" name="Connector: Elbow 24">
+            <a:extLst>
+              <a:ext uri="{FF2B5EF4-FFF2-40B4-BE49-F238E27FC236}">
+                <a16:creationId xmlns:a16="http://schemas.microsoft.com/office/drawing/2014/main" id="{8FF3F189-78F8-E2E6-3BB4-7D68189CF0D7}"/>
+              </a:ext>
+            </a:extLst>
+          </p:cNvPr>
+          <p:cNvCxnSpPr>
+            <a:cxnSpLocks/>
+            <a:stCxn id="29" idx="3"/>
+            <a:endCxn id="34" idx="2"/>
+          </p:cNvCxnSpPr>
+          <p:nvPr/>
+        </p:nvCxnSpPr>
+        <p:spPr>
+          <a:xfrm>
+            <a:off x="9011210" y="3300062"/>
+            <a:ext cx="567259" cy="524493"/>
+          </a:xfrm>
+          <a:prstGeom prst="bentConnector3">
+            <a:avLst>
+              <a:gd name="adj1" fmla="val 50000"/>
+            </a:avLst>
+          </a:prstGeom>
+          <a:ln>
+            <a:solidFill>
+              <a:schemeClr val="tx1"/>
+            </a:solidFill>
+            <a:prstDash val="solid"/>
+            <a:headEnd type="none" w="lg" len="lg"/>
+            <a:tailEnd type="triangle" w="lg" len="lg"/>
+          </a:ln>
+        </p:spPr>
+        <p:style>
+          <a:lnRef idx="2">
+            <a:schemeClr val="accent1"/>
+          </a:lnRef>
+          <a:fillRef idx="0">
+            <a:schemeClr val="accent1"/>
+          </a:fillRef>
+          <a:effectRef idx="1">
+            <a:schemeClr val="accent1"/>
+          </a:effectRef>
+          <a:fontRef idx="minor">
+            <a:schemeClr val="tx1"/>
+          </a:fontRef>
+        </p:style>
+      </p:cxnSp>
+      <p:grpSp>
+        <p:nvGrpSpPr>
+          <p:cNvPr id="39" name="Group 38">
+            <a:extLst>
+              <a:ext uri="{FF2B5EF4-FFF2-40B4-BE49-F238E27FC236}">
+                <a16:creationId xmlns:a16="http://schemas.microsoft.com/office/drawing/2014/main" id="{91FFC1EC-BE44-BACF-7FF6-36B59D23C045}"/>
+              </a:ext>
+            </a:extLst>
+          </p:cNvPr>
+          <p:cNvGrpSpPr/>
+          <p:nvPr/>
+        </p:nvGrpSpPr>
+        <p:grpSpPr>
+          <a:xfrm>
+            <a:off x="9578469" y="2280728"/>
+            <a:ext cx="1344168" cy="746025"/>
+            <a:chOff x="9154399" y="2746626"/>
+            <a:chExt cx="1344168" cy="746025"/>
+          </a:xfrm>
+        </p:grpSpPr>
+        <p:sp>
+          <p:nvSpPr>
+            <p:cNvPr id="20" name="Rectangle: Top Corners Rounded 19">
+              <a:extLst>
+                <a:ext uri="{FF2B5EF4-FFF2-40B4-BE49-F238E27FC236}">
+                  <a16:creationId xmlns:a16="http://schemas.microsoft.com/office/drawing/2014/main" id="{216307B9-4BD8-168F-42F0-5B3FE0C4D8BF}"/>
+                </a:ext>
+              </a:extLst>
+            </p:cNvPr>
+            <p:cNvSpPr/>
+            <p:nvPr/>
+          </p:nvSpPr>
+          <p:spPr>
+            <a:xfrm>
+              <a:off x="9154399" y="2938662"/>
+              <a:ext cx="1344168" cy="553989"/>
+            </a:xfrm>
+            <a:prstGeom prst="round2SameRect">
+              <a:avLst>
+                <a:gd name="adj1" fmla="val 0"/>
+                <a:gd name="adj2" fmla="val 11961"/>
+              </a:avLst>
+            </a:prstGeom>
+            <a:solidFill>
+              <a:srgbClr val="E5F1F8"/>
+            </a:solidFill>
+            <a:ln>
+              <a:solidFill>
+                <a:schemeClr val="tx1"/>
+              </a:solidFill>
+            </a:ln>
+          </p:spPr>
+          <p:style>
+            <a:lnRef idx="2">
+              <a:schemeClr val="accent1">
+                <a:shade val="15000"/>
+              </a:schemeClr>
+            </a:lnRef>
+            <a:fillRef idx="1">
+              <a:schemeClr val="accent1"/>
+            </a:fillRef>
+            <a:effectRef idx="0">
+              <a:schemeClr val="accent1"/>
+            </a:effectRef>
+            <a:fontRef idx="minor">
+              <a:schemeClr val="lt1"/>
+            </a:fontRef>
+          </p:style>
+          <p:txBody>
+            <a:bodyPr rtlCol="0" anchor="ctr"/>
+            <a:lstStyle/>
+            <a:p>
+              <a:pPr algn="ctr"/>
+              <a:r>
+                <a:rPr lang="en-US" dirty="0">
+                  <a:solidFill>
+                    <a:schemeClr val="tx1"/>
+                  </a:solidFill>
+                </a:rPr>
+                <a:t>Execute Tool</a:t>
+              </a:r>
+            </a:p>
+          </p:txBody>
+        </p:sp>
+        <p:sp>
+          <p:nvSpPr>
+            <p:cNvPr id="32" name="Rectangle: Rounded Corners 31">
+              <a:extLst>
+                <a:ext uri="{FF2B5EF4-FFF2-40B4-BE49-F238E27FC236}">
+                  <a16:creationId xmlns:a16="http://schemas.microsoft.com/office/drawing/2014/main" id="{B6A576D1-C568-D323-02BC-80D25B9907E2}"/>
+                </a:ext>
+              </a:extLst>
+            </p:cNvPr>
+            <p:cNvSpPr/>
+            <p:nvPr/>
+          </p:nvSpPr>
+          <p:spPr>
+            <a:xfrm>
+              <a:off x="9154399" y="2746626"/>
+              <a:ext cx="1344168" cy="230826"/>
+            </a:xfrm>
+            <a:prstGeom prst="roundRect">
+              <a:avLst/>
+            </a:prstGeom>
+            <a:solidFill>
+              <a:srgbClr val="B2D4EB"/>
+            </a:solidFill>
+            <a:ln>
+              <a:solidFill>
+                <a:schemeClr val="tx1"/>
+              </a:solidFill>
+            </a:ln>
+          </p:spPr>
+          <p:style>
+            <a:lnRef idx="2">
+              <a:schemeClr val="accent1">
+                <a:shade val="15000"/>
+              </a:schemeClr>
+            </a:lnRef>
+            <a:fillRef idx="1">
+              <a:schemeClr val="accent1"/>
+            </a:fillRef>
+            <a:effectRef idx="0">
+              <a:schemeClr val="accent1"/>
+            </a:effectRef>
+            <a:fontRef idx="minor">
+              <a:schemeClr val="lt1"/>
+            </a:fontRef>
+          </p:style>
+          <p:txBody>
+            <a:bodyPr rtlCol="0" anchor="ctr"/>
+            <a:lstStyle/>
+            <a:p>
+              <a:pPr algn="ctr"/>
+              <a:r>
+                <a:rPr lang="en-US" dirty="0">
+                  <a:solidFill>
+                    <a:schemeClr val="tx1"/>
+                  </a:solidFill>
+                </a:rPr>
+                <a:t>✓Allow</a:t>
+              </a:r>
+              <a:endParaRPr lang="en-US" i="1" dirty="0">
+                <a:solidFill>
+                  <a:schemeClr val="tx1"/>
+                </a:solidFill>
+              </a:endParaRPr>
+            </a:p>
+          </p:txBody>
+        </p:sp>
+      </p:grpSp>
+      <p:grpSp>
+        <p:nvGrpSpPr>
+          <p:cNvPr id="38" name="Group 37">
+            <a:extLst>
+              <a:ext uri="{FF2B5EF4-FFF2-40B4-BE49-F238E27FC236}">
+                <a16:creationId xmlns:a16="http://schemas.microsoft.com/office/drawing/2014/main" id="{E5783BEB-2611-7D95-DFA0-145D65E89C30}"/>
+              </a:ext>
+            </a:extLst>
+          </p:cNvPr>
+          <p:cNvGrpSpPr/>
+          <p:nvPr/>
+        </p:nvGrpSpPr>
+        <p:grpSpPr>
+          <a:xfrm>
+            <a:off x="9578469" y="3355524"/>
+            <a:ext cx="1344168" cy="746025"/>
+            <a:chOff x="9333303" y="1474489"/>
+            <a:chExt cx="1344168" cy="746025"/>
+          </a:xfrm>
+        </p:grpSpPr>
+        <p:sp>
+          <p:nvSpPr>
+            <p:cNvPr id="34" name="Rectangle: Top Corners Rounded 33">
+              <a:extLst>
+                <a:ext uri="{FF2B5EF4-FFF2-40B4-BE49-F238E27FC236}">
+                  <a16:creationId xmlns:a16="http://schemas.microsoft.com/office/drawing/2014/main" id="{CC177FAA-2FF8-49CA-1C5D-DC1D03EF165E}"/>
+                </a:ext>
+              </a:extLst>
+            </p:cNvPr>
+            <p:cNvSpPr/>
+            <p:nvPr/>
+          </p:nvSpPr>
+          <p:spPr>
+            <a:xfrm>
+              <a:off x="9333303" y="1666525"/>
+              <a:ext cx="1344168" cy="553989"/>
+            </a:xfrm>
+            <a:prstGeom prst="round2SameRect">
+              <a:avLst>
+                <a:gd name="adj1" fmla="val 0"/>
+                <a:gd name="adj2" fmla="val 11961"/>
+              </a:avLst>
+            </a:prstGeom>
+            <a:solidFill>
+              <a:srgbClr val="E5F1F8"/>
+            </a:solidFill>
+            <a:ln>
+              <a:solidFill>
+                <a:schemeClr val="tx1"/>
+              </a:solidFill>
+            </a:ln>
+          </p:spPr>
+          <p:style>
+            <a:lnRef idx="2">
+              <a:schemeClr val="accent1">
+                <a:shade val="15000"/>
+              </a:schemeClr>
+            </a:lnRef>
+            <a:fillRef idx="1">
+              <a:schemeClr val="accent1"/>
+            </a:fillRef>
+            <a:effectRef idx="0">
+              <a:schemeClr val="accent1"/>
+            </a:effectRef>
+            <a:fontRef idx="minor">
+              <a:schemeClr val="lt1"/>
+            </a:fontRef>
+          </p:style>
+          <p:txBody>
+            <a:bodyPr rtlCol="0" anchor="ctr"/>
+            <a:lstStyle/>
+            <a:p>
+              <a:pPr algn="ctr"/>
+              <a:r>
+                <a:rPr lang="en-US" dirty="0">
+                  <a:solidFill>
+                    <a:schemeClr val="tx1"/>
+                  </a:solidFill>
+                </a:rPr>
+                <a:t>Block &amp; Log</a:t>
+              </a:r>
+            </a:p>
+          </p:txBody>
+        </p:sp>
+        <p:sp>
+          <p:nvSpPr>
+            <p:cNvPr id="35" name="Rectangle: Rounded Corners 34">
+              <a:extLst>
+                <a:ext uri="{FF2B5EF4-FFF2-40B4-BE49-F238E27FC236}">
+                  <a16:creationId xmlns:a16="http://schemas.microsoft.com/office/drawing/2014/main" id="{F0E8F2DE-1F77-929B-EE42-882361C60C5D}"/>
+                </a:ext>
+              </a:extLst>
+            </p:cNvPr>
+            <p:cNvSpPr/>
+            <p:nvPr/>
+          </p:nvSpPr>
+          <p:spPr>
+            <a:xfrm>
+              <a:off x="9333303" y="1474489"/>
+              <a:ext cx="1344168" cy="230826"/>
+            </a:xfrm>
+            <a:prstGeom prst="roundRect">
+              <a:avLst/>
+            </a:prstGeom>
+            <a:solidFill>
+              <a:srgbClr val="B2D4EB"/>
+            </a:solidFill>
+            <a:ln>
+              <a:solidFill>
+                <a:schemeClr val="tx1"/>
+              </a:solidFill>
+            </a:ln>
+          </p:spPr>
+          <p:style>
+            <a:lnRef idx="2">
+              <a:schemeClr val="accent1">
+                <a:shade val="15000"/>
+              </a:schemeClr>
+            </a:lnRef>
+            <a:fillRef idx="1">
+              <a:schemeClr val="accent1"/>
+            </a:fillRef>
+            <a:effectRef idx="0">
+              <a:schemeClr val="accent1"/>
+            </a:effectRef>
+            <a:fontRef idx="minor">
+              <a:schemeClr val="lt1"/>
+            </a:fontRef>
+          </p:style>
+          <p:txBody>
+            <a:bodyPr rtlCol="0" anchor="ctr"/>
+            <a:lstStyle/>
+            <a:p>
+              <a:pPr algn="ctr"/>
+              <a:r>
+                <a:rPr lang="en-US" dirty="0">
+                  <a:solidFill>
+                    <a:schemeClr val="tx1"/>
+                  </a:solidFill>
+                </a:rPr>
+                <a:t>✗Deny </a:t>
+              </a:r>
+              <a:endParaRPr lang="en-US" i="1" dirty="0">
+                <a:solidFill>
+                  <a:schemeClr val="tx1"/>
+                </a:solidFill>
+              </a:endParaRPr>
+            </a:p>
+          </p:txBody>
+        </p:sp>
+      </p:grpSp>
+    </p:spTree>
+    <p:extLst>
+      <p:ext uri="{BB962C8B-B14F-4D97-AF65-F5344CB8AC3E}">
+        <p14:creationId xmlns:p14="http://schemas.microsoft.com/office/powerpoint/2010/main" val="4196770489"/>
+      </p:ext>
+    </p:extLst>
+  </p:cSld>
+  <p:clrMapOvr>
+    <a:masterClrMapping/>
+  </p:clrMapOvr>
+</p:sld>
+</file>
+
+<file path=ppt/slides/slide26.xml><?xml version="1.0" encoding="utf-8"?>
+<p:sld xmlns:a="http://schemas.openxmlformats.org/drawingml/2006/main" xmlns:r="http://schemas.openxmlformats.org/officeDocument/2006/relationships" xmlns:p="http://schemas.openxmlformats.org/presentationml/2006/main">
+  <p:cSld>
+    <p:spTree>
+      <p:nvGrpSpPr>
+        <p:cNvPr id="1" name=""/>
+        <p:cNvGrpSpPr/>
+        <p:nvPr/>
+      </p:nvGrpSpPr>
+      <p:grpSpPr>
+        <a:xfrm>
+          <a:off x="0" y="0"/>
+          <a:ext cx="0" cy="0"/>
+          <a:chOff x="0" y="0"/>
+          <a:chExt cx="0" cy="0"/>
+        </a:xfrm>
+      </p:grpSpPr>
+      <p:sp>
+        <p:nvSpPr>
+          <p:cNvPr id="8" name="Oval 7">
+            <a:extLst>
+              <a:ext uri="{FF2B5EF4-FFF2-40B4-BE49-F238E27FC236}">
+                <a16:creationId xmlns:a16="http://schemas.microsoft.com/office/drawing/2014/main" id="{CF80C86E-58D4-B174-1E73-0A50246E20A4}"/>
+              </a:ext>
+            </a:extLst>
+          </p:cNvPr>
+          <p:cNvSpPr/>
+          <p:nvPr/>
+        </p:nvSpPr>
+        <p:spPr>
+          <a:xfrm>
+            <a:off x="815009" y="1480931"/>
+            <a:ext cx="3657600" cy="3657600"/>
+          </a:xfrm>
+          <a:prstGeom prst="ellipse">
+            <a:avLst/>
+          </a:prstGeom>
+          <a:solidFill>
+            <a:schemeClr val="bg1"/>
+          </a:solidFill>
+        </p:spPr>
+        <p:style>
+          <a:lnRef idx="2">
+            <a:schemeClr val="dk1">
+              <a:shade val="15000"/>
+            </a:schemeClr>
+          </a:lnRef>
+          <a:fillRef idx="1">
+            <a:schemeClr val="dk1"/>
+          </a:fillRef>
+          <a:effectRef idx="0">
+            <a:schemeClr val="dk1"/>
+          </a:effectRef>
+          <a:fontRef idx="minor">
+            <a:schemeClr val="lt1"/>
+          </a:fontRef>
+        </p:style>
+        <p:txBody>
+          <a:bodyPr lIns="0" tIns="0" rIns="0" bIns="0" rtlCol="0" anchor="ctr"/>
+          <a:lstStyle/>
+          <a:p>
+            <a:pPr algn="ctr"/>
+            <a:endParaRPr lang="en-US"/>
+          </a:p>
+        </p:txBody>
+      </p:sp>
+      <p:sp>
+        <p:nvSpPr>
+          <p:cNvPr id="7" name="Oval 6">
+            <a:extLst>
+              <a:ext uri="{FF2B5EF4-FFF2-40B4-BE49-F238E27FC236}">
+                <a16:creationId xmlns:a16="http://schemas.microsoft.com/office/drawing/2014/main" id="{7CC98AF7-F22C-249A-306C-516F719A4DD5}"/>
+              </a:ext>
+            </a:extLst>
+          </p:cNvPr>
+          <p:cNvSpPr/>
+          <p:nvPr/>
+        </p:nvSpPr>
+        <p:spPr>
+          <a:xfrm>
+            <a:off x="1272209" y="1938131"/>
+            <a:ext cx="2743200" cy="2743200"/>
+          </a:xfrm>
+          <a:prstGeom prst="ellipse">
+            <a:avLst/>
+          </a:prstGeom>
+          <a:solidFill>
+            <a:schemeClr val="tx2">
+              <a:lumMod val="10000"/>
+              <a:lumOff val="90000"/>
+            </a:schemeClr>
+          </a:solidFill>
+        </p:spPr>
+        <p:style>
+          <a:lnRef idx="2">
+            <a:schemeClr val="accent1">
+              <a:shade val="15000"/>
+            </a:schemeClr>
+          </a:lnRef>
+          <a:fillRef idx="1">
+            <a:schemeClr val="accent1"/>
+          </a:fillRef>
+          <a:effectRef idx="0">
+            <a:schemeClr val="accent1"/>
+          </a:effectRef>
+          <a:fontRef idx="minor">
+            <a:schemeClr val="lt1"/>
+          </a:fontRef>
+        </p:style>
+        <p:txBody>
+          <a:bodyPr lIns="0" tIns="0" rIns="0" bIns="0" rtlCol="0" anchor="ctr"/>
+          <a:lstStyle/>
+          <a:p>
+            <a:pPr algn="ctr"/>
+            <a:endParaRPr lang="en-US"/>
+          </a:p>
+        </p:txBody>
+      </p:sp>
+      <p:sp>
+        <p:nvSpPr>
+          <p:cNvPr id="6" name="Oval 5">
+            <a:extLst>
+              <a:ext uri="{FF2B5EF4-FFF2-40B4-BE49-F238E27FC236}">
+                <a16:creationId xmlns:a16="http://schemas.microsoft.com/office/drawing/2014/main" id="{7CC548FE-C725-F21F-EECE-27D62F1F833A}"/>
+              </a:ext>
+            </a:extLst>
+          </p:cNvPr>
+          <p:cNvSpPr/>
+          <p:nvPr/>
+        </p:nvSpPr>
+        <p:spPr>
+          <a:xfrm>
+            <a:off x="1729409" y="2395331"/>
+            <a:ext cx="1828800" cy="1828800"/>
+          </a:xfrm>
+          <a:prstGeom prst="ellipse">
+            <a:avLst/>
+          </a:prstGeom>
+          <a:solidFill>
+            <a:srgbClr val="B0D3EA"/>
+          </a:solidFill>
+        </p:spPr>
+        <p:style>
+          <a:lnRef idx="2">
+            <a:schemeClr val="accent1">
+              <a:shade val="15000"/>
+            </a:schemeClr>
+          </a:lnRef>
+          <a:fillRef idx="1">
+            <a:schemeClr val="accent1"/>
+          </a:fillRef>
+          <a:effectRef idx="0">
+            <a:schemeClr val="accent1"/>
+          </a:effectRef>
+          <a:fontRef idx="minor">
+            <a:schemeClr val="lt1"/>
+          </a:fontRef>
+        </p:style>
+        <p:txBody>
+          <a:bodyPr lIns="0" tIns="0" rIns="0" bIns="0" rtlCol="0" anchor="ctr"/>
+          <a:lstStyle/>
+          <a:p>
+            <a:pPr algn="ctr"/>
+            <a:endParaRPr lang="en-US" dirty="0"/>
+          </a:p>
+        </p:txBody>
+      </p:sp>
+      <p:sp>
+        <p:nvSpPr>
+          <p:cNvPr id="5" name="Oval 4">
+            <a:extLst>
+              <a:ext uri="{FF2B5EF4-FFF2-40B4-BE49-F238E27FC236}">
+                <a16:creationId xmlns:a16="http://schemas.microsoft.com/office/drawing/2014/main" id="{50415412-7E1B-2ECC-0786-4A6132CDD673}"/>
+              </a:ext>
+            </a:extLst>
+          </p:cNvPr>
+          <p:cNvSpPr/>
+          <p:nvPr/>
+        </p:nvSpPr>
+        <p:spPr>
+          <a:xfrm>
+            <a:off x="2186609" y="2852531"/>
+            <a:ext cx="914400" cy="914400"/>
+          </a:xfrm>
+          <a:prstGeom prst="ellipse">
+            <a:avLst/>
+          </a:prstGeom>
+          <a:solidFill>
+            <a:schemeClr val="tx2">
+              <a:lumMod val="50000"/>
+              <a:lumOff val="50000"/>
+            </a:schemeClr>
+          </a:solidFill>
+        </p:spPr>
+        <p:style>
+          <a:lnRef idx="2">
+            <a:schemeClr val="accent1">
+              <a:shade val="15000"/>
+            </a:schemeClr>
+          </a:lnRef>
+          <a:fillRef idx="1">
+            <a:schemeClr val="accent1"/>
+          </a:fillRef>
+          <a:effectRef idx="0">
+            <a:schemeClr val="accent1"/>
+          </a:effectRef>
+          <a:fontRef idx="minor">
+            <a:schemeClr val="lt1"/>
+          </a:fontRef>
+        </p:style>
+        <p:txBody>
+          <a:bodyPr lIns="0" tIns="0" rIns="0" bIns="0" rtlCol="0" anchor="ctr"/>
+          <a:lstStyle/>
+          <a:p>
+            <a:pPr algn="ctr"/>
+            <a:endParaRPr lang="en-US" dirty="0"/>
+          </a:p>
+        </p:txBody>
+      </p:sp>
+      <p:sp>
+        <p:nvSpPr>
+          <p:cNvPr id="9" name="Oval 8">
+            <a:extLst>
+              <a:ext uri="{FF2B5EF4-FFF2-40B4-BE49-F238E27FC236}">
+                <a16:creationId xmlns:a16="http://schemas.microsoft.com/office/drawing/2014/main" id="{DB189114-68FB-4B8E-BF07-F84D9A019160}"/>
+              </a:ext>
+            </a:extLst>
+          </p:cNvPr>
+          <p:cNvSpPr/>
+          <p:nvPr/>
+        </p:nvSpPr>
+        <p:spPr>
+          <a:xfrm>
+            <a:off x="2506649" y="3172571"/>
+            <a:ext cx="274320" cy="274320"/>
+          </a:xfrm>
+          <a:prstGeom prst="ellipse">
+            <a:avLst/>
+          </a:prstGeom>
+        </p:spPr>
+        <p:style>
+          <a:lnRef idx="2">
+            <a:schemeClr val="dk1">
+              <a:shade val="15000"/>
+            </a:schemeClr>
+          </a:lnRef>
+          <a:fillRef idx="1">
+            <a:schemeClr val="dk1"/>
+          </a:fillRef>
+          <a:effectRef idx="0">
+            <a:schemeClr val="dk1"/>
+          </a:effectRef>
+          <a:fontRef idx="minor">
+            <a:schemeClr val="lt1"/>
+          </a:fontRef>
+        </p:style>
+        <p:txBody>
+          <a:bodyPr lIns="0" tIns="0" rIns="0" bIns="0" rtlCol="0" anchor="ctr"/>
+          <a:lstStyle/>
+          <a:p>
+            <a:pPr algn="ctr"/>
+            <a:r>
+              <a:rPr lang="en-US" dirty="0"/>
+              <a:t>1</a:t>
+            </a:r>
+          </a:p>
+        </p:txBody>
+      </p:sp>
+      <p:sp>
+        <p:nvSpPr>
+          <p:cNvPr id="10" name="Oval 9">
+            <a:extLst>
+              <a:ext uri="{FF2B5EF4-FFF2-40B4-BE49-F238E27FC236}">
+                <a16:creationId xmlns:a16="http://schemas.microsoft.com/office/drawing/2014/main" id="{27051D7B-1B88-BB29-E835-7E9AD2C81E13}"/>
+              </a:ext>
+            </a:extLst>
+          </p:cNvPr>
+          <p:cNvSpPr/>
+          <p:nvPr/>
+        </p:nvSpPr>
+        <p:spPr>
+          <a:xfrm>
+            <a:off x="2506649" y="3858371"/>
+            <a:ext cx="274320" cy="274320"/>
+          </a:xfrm>
+          <a:prstGeom prst="ellipse">
+            <a:avLst/>
+          </a:prstGeom>
+        </p:spPr>
+        <p:style>
+          <a:lnRef idx="2">
+            <a:schemeClr val="dk1">
+              <a:shade val="15000"/>
+            </a:schemeClr>
+          </a:lnRef>
+          <a:fillRef idx="1">
+            <a:schemeClr val="dk1"/>
+          </a:fillRef>
+          <a:effectRef idx="0">
+            <a:schemeClr val="dk1"/>
+          </a:effectRef>
+          <a:fontRef idx="minor">
+            <a:schemeClr val="lt1"/>
+          </a:fontRef>
+        </p:style>
+        <p:txBody>
+          <a:bodyPr lIns="0" tIns="0" rIns="0" bIns="0" rtlCol="0" anchor="ctr"/>
+          <a:lstStyle/>
+          <a:p>
+            <a:pPr algn="ctr"/>
+            <a:r>
+              <a:rPr lang="en-US" dirty="0"/>
+              <a:t>2</a:t>
+            </a:r>
+          </a:p>
+        </p:txBody>
+      </p:sp>
+      <p:sp>
+        <p:nvSpPr>
+          <p:cNvPr id="11" name="Oval 10">
+            <a:extLst>
+              <a:ext uri="{FF2B5EF4-FFF2-40B4-BE49-F238E27FC236}">
+                <a16:creationId xmlns:a16="http://schemas.microsoft.com/office/drawing/2014/main" id="{7017C1FB-B9B0-A544-018A-40F5602ADB75}"/>
+              </a:ext>
+            </a:extLst>
+          </p:cNvPr>
+          <p:cNvSpPr/>
+          <p:nvPr/>
+        </p:nvSpPr>
+        <p:spPr>
+          <a:xfrm>
+            <a:off x="2506649" y="4306243"/>
+            <a:ext cx="274320" cy="274320"/>
+          </a:xfrm>
+          <a:prstGeom prst="ellipse">
+            <a:avLst/>
+          </a:prstGeom>
+        </p:spPr>
+        <p:style>
+          <a:lnRef idx="2">
+            <a:schemeClr val="dk1">
+              <a:shade val="15000"/>
+            </a:schemeClr>
+          </a:lnRef>
+          <a:fillRef idx="1">
+            <a:schemeClr val="dk1"/>
+          </a:fillRef>
+          <a:effectRef idx="0">
+            <a:schemeClr val="dk1"/>
+          </a:effectRef>
+          <a:fontRef idx="minor">
+            <a:schemeClr val="lt1"/>
+          </a:fontRef>
+        </p:style>
+        <p:txBody>
+          <a:bodyPr lIns="0" tIns="0" rIns="0" bIns="0" rtlCol="0" anchor="ctr"/>
+          <a:lstStyle/>
+          <a:p>
+            <a:pPr algn="ctr"/>
+            <a:r>
+              <a:rPr lang="en-US" dirty="0"/>
+              <a:t>3</a:t>
+            </a:r>
+          </a:p>
+        </p:txBody>
+      </p:sp>
+      <p:sp>
+        <p:nvSpPr>
+          <p:cNvPr id="12" name="Oval 11">
+            <a:extLst>
+              <a:ext uri="{FF2B5EF4-FFF2-40B4-BE49-F238E27FC236}">
+                <a16:creationId xmlns:a16="http://schemas.microsoft.com/office/drawing/2014/main" id="{73BB3504-9CE8-67D2-DD11-EDFB3DF1A9D2}"/>
+              </a:ext>
+            </a:extLst>
+          </p:cNvPr>
+          <p:cNvSpPr/>
+          <p:nvPr/>
+        </p:nvSpPr>
+        <p:spPr>
+          <a:xfrm>
+            <a:off x="2506649" y="4763443"/>
+            <a:ext cx="274320" cy="274320"/>
+          </a:xfrm>
+          <a:prstGeom prst="ellipse">
+            <a:avLst/>
+          </a:prstGeom>
+        </p:spPr>
+        <p:style>
+          <a:lnRef idx="2">
+            <a:schemeClr val="dk1">
+              <a:shade val="15000"/>
+            </a:schemeClr>
+          </a:lnRef>
+          <a:fillRef idx="1">
+            <a:schemeClr val="dk1"/>
+          </a:fillRef>
+          <a:effectRef idx="0">
+            <a:schemeClr val="dk1"/>
+          </a:effectRef>
+          <a:fontRef idx="minor">
+            <a:schemeClr val="lt1"/>
+          </a:fontRef>
+        </p:style>
+        <p:txBody>
+          <a:bodyPr lIns="0" tIns="0" rIns="0" bIns="0" rtlCol="0" anchor="ctr"/>
+          <a:lstStyle/>
+          <a:p>
+            <a:pPr algn="ctr"/>
+            <a:r>
+              <a:rPr lang="en-US" dirty="0"/>
+              <a:t>4</a:t>
+            </a:r>
+          </a:p>
+        </p:txBody>
+      </p:sp>
+      <p:grpSp>
+        <p:nvGrpSpPr>
+          <p:cNvPr id="13" name="Group 12">
+            <a:extLst>
+              <a:ext uri="{FF2B5EF4-FFF2-40B4-BE49-F238E27FC236}">
+                <a16:creationId xmlns:a16="http://schemas.microsoft.com/office/drawing/2014/main" id="{EFAE7B39-0D6E-2F49-E761-6510D66859F7}"/>
+              </a:ext>
+            </a:extLst>
+          </p:cNvPr>
+          <p:cNvGrpSpPr/>
+          <p:nvPr/>
+        </p:nvGrpSpPr>
+        <p:grpSpPr>
+          <a:xfrm>
+            <a:off x="4792648" y="2325322"/>
+            <a:ext cx="1818401" cy="746025"/>
+            <a:chOff x="9154399" y="2746626"/>
+            <a:chExt cx="1344168" cy="746025"/>
+          </a:xfrm>
+        </p:grpSpPr>
+        <p:sp>
+          <p:nvSpPr>
+            <p:cNvPr id="14" name="Rectangle: Top Corners Rounded 13">
+              <a:extLst>
+                <a:ext uri="{FF2B5EF4-FFF2-40B4-BE49-F238E27FC236}">
+                  <a16:creationId xmlns:a16="http://schemas.microsoft.com/office/drawing/2014/main" id="{147BB980-3222-2816-AA45-8F53BFAB799C}"/>
+                </a:ext>
+              </a:extLst>
+            </p:cNvPr>
+            <p:cNvSpPr/>
+            <p:nvPr/>
+          </p:nvSpPr>
+          <p:spPr>
+            <a:xfrm>
+              <a:off x="9154399" y="2938662"/>
+              <a:ext cx="1344168" cy="553989"/>
+            </a:xfrm>
+            <a:prstGeom prst="round2SameRect">
+              <a:avLst>
+                <a:gd name="adj1" fmla="val 0"/>
+                <a:gd name="adj2" fmla="val 11961"/>
+              </a:avLst>
+            </a:prstGeom>
+            <a:solidFill>
+              <a:srgbClr val="E5F1F8"/>
+            </a:solidFill>
+            <a:ln>
+              <a:solidFill>
+                <a:schemeClr val="tx1"/>
+              </a:solidFill>
+            </a:ln>
+          </p:spPr>
+          <p:style>
+            <a:lnRef idx="2">
+              <a:schemeClr val="accent1">
+                <a:shade val="15000"/>
+              </a:schemeClr>
+            </a:lnRef>
+            <a:fillRef idx="1">
+              <a:schemeClr val="accent1"/>
+            </a:fillRef>
+            <a:effectRef idx="0">
+              <a:schemeClr val="accent1"/>
+            </a:effectRef>
+            <a:fontRef idx="minor">
+              <a:schemeClr val="lt1"/>
+            </a:fontRef>
+          </p:style>
+          <p:txBody>
+            <a:bodyPr rtlCol="0" anchor="ctr"/>
+            <a:lstStyle/>
+            <a:p>
+              <a:pPr algn="ctr"/>
+              <a:r>
+                <a:rPr lang="en-US" dirty="0">
+                  <a:solidFill>
+                    <a:schemeClr val="tx1"/>
+                  </a:solidFill>
+                </a:rPr>
+                <a:t>Vetted, can write</a:t>
+              </a:r>
+            </a:p>
+          </p:txBody>
+        </p:sp>
+        <p:sp>
+          <p:nvSpPr>
+            <p:cNvPr id="15" name="Rectangle: Rounded Corners 14">
+              <a:extLst>
+                <a:ext uri="{FF2B5EF4-FFF2-40B4-BE49-F238E27FC236}">
+                  <a16:creationId xmlns:a16="http://schemas.microsoft.com/office/drawing/2014/main" id="{2C9488A8-8BEB-7C4B-06D7-BBA89E69E3A4}"/>
+                </a:ext>
+              </a:extLst>
+            </p:cNvPr>
+            <p:cNvSpPr/>
+            <p:nvPr/>
+          </p:nvSpPr>
+          <p:spPr>
+            <a:xfrm>
+              <a:off x="9154399" y="2746626"/>
+              <a:ext cx="1344168" cy="230826"/>
+            </a:xfrm>
+            <a:prstGeom prst="roundRect">
+              <a:avLst/>
+            </a:prstGeom>
+            <a:solidFill>
+              <a:srgbClr val="B2D4EB"/>
+            </a:solidFill>
+            <a:ln>
+              <a:solidFill>
+                <a:schemeClr val="tx1"/>
+              </a:solidFill>
+            </a:ln>
+          </p:spPr>
+          <p:style>
+            <a:lnRef idx="2">
+              <a:schemeClr val="accent1">
+                <a:shade val="15000"/>
+              </a:schemeClr>
+            </a:lnRef>
+            <a:fillRef idx="1">
+              <a:schemeClr val="accent1"/>
+            </a:fillRef>
+            <a:effectRef idx="0">
+              <a:schemeClr val="accent1"/>
+            </a:effectRef>
+            <a:fontRef idx="minor">
+              <a:schemeClr val="lt1"/>
+            </a:fontRef>
+          </p:style>
+          <p:txBody>
+            <a:bodyPr rtlCol="0" anchor="ctr"/>
+            <a:lstStyle/>
+            <a:p>
+              <a:pPr algn="ctr"/>
+              <a:r>
+                <a:rPr lang="en-US" dirty="0">
+                  <a:solidFill>
+                    <a:schemeClr val="tx1"/>
+                  </a:solidFill>
+                </a:rPr>
+                <a:t>Supervisor</a:t>
+              </a:r>
+              <a:endParaRPr lang="en-US" i="1" dirty="0">
+                <a:solidFill>
+                  <a:schemeClr val="tx1"/>
+                </a:solidFill>
+              </a:endParaRPr>
+            </a:p>
+          </p:txBody>
+        </p:sp>
+      </p:grpSp>
+      <p:grpSp>
+        <p:nvGrpSpPr>
+          <p:cNvPr id="19" name="Group 18">
+            <a:extLst>
+              <a:ext uri="{FF2B5EF4-FFF2-40B4-BE49-F238E27FC236}">
+                <a16:creationId xmlns:a16="http://schemas.microsoft.com/office/drawing/2014/main" id="{061399A9-7756-5106-74E4-8039284BD6F9}"/>
+              </a:ext>
+            </a:extLst>
+          </p:cNvPr>
+          <p:cNvGrpSpPr/>
+          <p:nvPr/>
+        </p:nvGrpSpPr>
+        <p:grpSpPr>
+          <a:xfrm>
+            <a:off x="4792649" y="1480931"/>
+            <a:ext cx="1818401" cy="746025"/>
+            <a:chOff x="9154399" y="2746626"/>
+            <a:chExt cx="1344168" cy="746025"/>
+          </a:xfrm>
+        </p:grpSpPr>
+        <p:sp>
+          <p:nvSpPr>
+            <p:cNvPr id="20" name="Rectangle: Top Corners Rounded 19">
+              <a:extLst>
+                <a:ext uri="{FF2B5EF4-FFF2-40B4-BE49-F238E27FC236}">
+                  <a16:creationId xmlns:a16="http://schemas.microsoft.com/office/drawing/2014/main" id="{B9C15A88-3F88-44B9-1AC2-BB1472D41859}"/>
+                </a:ext>
+              </a:extLst>
+            </p:cNvPr>
+            <p:cNvSpPr/>
+            <p:nvPr/>
+          </p:nvSpPr>
+          <p:spPr>
+            <a:xfrm>
+              <a:off x="9154399" y="2938662"/>
+              <a:ext cx="1344168" cy="553989"/>
+            </a:xfrm>
+            <a:prstGeom prst="round2SameRect">
+              <a:avLst>
+                <a:gd name="adj1" fmla="val 0"/>
+                <a:gd name="adj2" fmla="val 11961"/>
+              </a:avLst>
+            </a:prstGeom>
+            <a:solidFill>
+              <a:srgbClr val="E5F1F8"/>
+            </a:solidFill>
+            <a:ln>
+              <a:solidFill>
+                <a:schemeClr val="tx1"/>
+              </a:solidFill>
+            </a:ln>
+          </p:spPr>
+          <p:style>
+            <a:lnRef idx="2">
+              <a:schemeClr val="accent1">
+                <a:shade val="15000"/>
+              </a:schemeClr>
+            </a:lnRef>
+            <a:fillRef idx="1">
+              <a:schemeClr val="accent1"/>
+            </a:fillRef>
+            <a:effectRef idx="0">
+              <a:schemeClr val="accent1"/>
+            </a:effectRef>
+            <a:fontRef idx="minor">
+              <a:schemeClr val="lt1"/>
+            </a:fontRef>
+          </p:style>
+          <p:txBody>
+            <a:bodyPr rtlCol="0" anchor="ctr"/>
+            <a:lstStyle/>
+            <a:p>
+              <a:pPr algn="ctr"/>
+              <a:r>
+                <a:rPr lang="en-US" dirty="0">
+                  <a:solidFill>
+                    <a:schemeClr val="tx1"/>
+                  </a:solidFill>
+                </a:rPr>
+                <a:t>Policy engine only</a:t>
+              </a:r>
+            </a:p>
+          </p:txBody>
+        </p:sp>
+        <p:sp>
+          <p:nvSpPr>
+            <p:cNvPr id="21" name="Rectangle: Rounded Corners 20">
+              <a:extLst>
+                <a:ext uri="{FF2B5EF4-FFF2-40B4-BE49-F238E27FC236}">
+                  <a16:creationId xmlns:a16="http://schemas.microsoft.com/office/drawing/2014/main" id="{C8B1ED5E-7029-8479-1352-ACFBF15B5279}"/>
+                </a:ext>
+              </a:extLst>
+            </p:cNvPr>
+            <p:cNvSpPr/>
+            <p:nvPr/>
+          </p:nvSpPr>
+          <p:spPr>
+            <a:xfrm>
+              <a:off x="9154399" y="2746626"/>
+              <a:ext cx="1344168" cy="230826"/>
+            </a:xfrm>
+            <a:prstGeom prst="roundRect">
+              <a:avLst/>
+            </a:prstGeom>
+            <a:solidFill>
+              <a:srgbClr val="B2D4EB"/>
+            </a:solidFill>
+            <a:ln>
+              <a:solidFill>
+                <a:schemeClr val="tx1"/>
+              </a:solidFill>
+            </a:ln>
+          </p:spPr>
+          <p:style>
+            <a:lnRef idx="2">
+              <a:schemeClr val="accent1">
+                <a:shade val="15000"/>
+              </a:schemeClr>
+            </a:lnRef>
+            <a:fillRef idx="1">
+              <a:schemeClr val="accent1"/>
+            </a:fillRef>
+            <a:effectRef idx="0">
+              <a:schemeClr val="accent1"/>
+            </a:effectRef>
+            <a:fontRef idx="minor">
+              <a:schemeClr val="lt1"/>
+            </a:fontRef>
+          </p:style>
+          <p:txBody>
+            <a:bodyPr rtlCol="0" anchor="ctr"/>
+            <a:lstStyle/>
+            <a:p>
+              <a:pPr algn="ctr"/>
+              <a:r>
+                <a:rPr lang="en-US" dirty="0">
+                  <a:solidFill>
+                    <a:schemeClr val="tx1"/>
+                  </a:solidFill>
+                </a:rPr>
+                <a:t>Kernel</a:t>
+              </a:r>
+              <a:endParaRPr lang="en-US" i="1" dirty="0">
+                <a:solidFill>
+                  <a:schemeClr val="tx1"/>
+                </a:solidFill>
+              </a:endParaRPr>
+            </a:p>
+          </p:txBody>
+        </p:sp>
+      </p:grpSp>
+      <p:grpSp>
+        <p:nvGrpSpPr>
+          <p:cNvPr id="22" name="Group 21">
+            <a:extLst>
+              <a:ext uri="{FF2B5EF4-FFF2-40B4-BE49-F238E27FC236}">
+                <a16:creationId xmlns:a16="http://schemas.microsoft.com/office/drawing/2014/main" id="{2E13D34C-09BE-AB71-4F6E-A98DED831C08}"/>
+              </a:ext>
+            </a:extLst>
+          </p:cNvPr>
+          <p:cNvGrpSpPr/>
+          <p:nvPr/>
+        </p:nvGrpSpPr>
+        <p:grpSpPr>
+          <a:xfrm>
+            <a:off x="4792648" y="3169714"/>
+            <a:ext cx="1818401" cy="746025"/>
+            <a:chOff x="9154399" y="2746626"/>
+            <a:chExt cx="1344168" cy="746025"/>
+          </a:xfrm>
+        </p:grpSpPr>
+        <p:sp>
+          <p:nvSpPr>
+            <p:cNvPr id="23" name="Rectangle: Top Corners Rounded 22">
+              <a:extLst>
+                <a:ext uri="{FF2B5EF4-FFF2-40B4-BE49-F238E27FC236}">
+                  <a16:creationId xmlns:a16="http://schemas.microsoft.com/office/drawing/2014/main" id="{52FD50CD-760C-883D-C943-5372574A74FF}"/>
+                </a:ext>
+              </a:extLst>
+            </p:cNvPr>
+            <p:cNvSpPr/>
+            <p:nvPr/>
+          </p:nvSpPr>
+          <p:spPr>
+            <a:xfrm>
+              <a:off x="9154399" y="2938662"/>
+              <a:ext cx="1344168" cy="553989"/>
+            </a:xfrm>
+            <a:prstGeom prst="round2SameRect">
+              <a:avLst>
+                <a:gd name="adj1" fmla="val 0"/>
+                <a:gd name="adj2" fmla="val 11961"/>
+              </a:avLst>
+            </a:prstGeom>
+            <a:solidFill>
+              <a:srgbClr val="E5F1F8"/>
+            </a:solidFill>
+            <a:ln>
+              <a:solidFill>
+                <a:schemeClr val="tx1"/>
+              </a:solidFill>
+            </a:ln>
+          </p:spPr>
+          <p:style>
+            <a:lnRef idx="2">
+              <a:schemeClr val="accent1">
+                <a:shade val="15000"/>
+              </a:schemeClr>
+            </a:lnRef>
+            <a:fillRef idx="1">
+              <a:schemeClr val="accent1"/>
+            </a:fillRef>
+            <a:effectRef idx="0">
+              <a:schemeClr val="accent1"/>
+            </a:effectRef>
+            <a:fontRef idx="minor">
+              <a:schemeClr val="lt1"/>
+            </a:fontRef>
+          </p:style>
+          <p:txBody>
+            <a:bodyPr rtlCol="0" anchor="ctr"/>
+            <a:lstStyle/>
+            <a:p>
+              <a:pPr algn="ctr"/>
+              <a:r>
+                <a:rPr lang="en-US" dirty="0">
+                  <a:solidFill>
+                    <a:schemeClr val="tx1"/>
+                  </a:solidFill>
+                </a:rPr>
+                <a:t>Standard agent</a:t>
+              </a:r>
+            </a:p>
+          </p:txBody>
+        </p:sp>
+        <p:sp>
+          <p:nvSpPr>
+            <p:cNvPr id="24" name="Rectangle: Rounded Corners 23">
+              <a:extLst>
+                <a:ext uri="{FF2B5EF4-FFF2-40B4-BE49-F238E27FC236}">
+                  <a16:creationId xmlns:a16="http://schemas.microsoft.com/office/drawing/2014/main" id="{BFF9C8C6-191E-39B7-1611-4972B37E34D0}"/>
+                </a:ext>
+              </a:extLst>
+            </p:cNvPr>
+            <p:cNvSpPr/>
+            <p:nvPr/>
+          </p:nvSpPr>
+          <p:spPr>
+            <a:xfrm>
+              <a:off x="9154399" y="2746626"/>
+              <a:ext cx="1344168" cy="230826"/>
+            </a:xfrm>
+            <a:prstGeom prst="roundRect">
+              <a:avLst/>
+            </a:prstGeom>
+            <a:solidFill>
+              <a:srgbClr val="B2D4EB"/>
+            </a:solidFill>
+            <a:ln>
+              <a:solidFill>
+                <a:schemeClr val="tx1"/>
+              </a:solidFill>
+            </a:ln>
+          </p:spPr>
+          <p:style>
+            <a:lnRef idx="2">
+              <a:schemeClr val="accent1">
+                <a:shade val="15000"/>
+              </a:schemeClr>
+            </a:lnRef>
+            <a:fillRef idx="1">
+              <a:schemeClr val="accent1"/>
+            </a:fillRef>
+            <a:effectRef idx="0">
+              <a:schemeClr val="accent1"/>
+            </a:effectRef>
+            <a:fontRef idx="minor">
+              <a:schemeClr val="lt1"/>
+            </a:fontRef>
+          </p:style>
+          <p:txBody>
+            <a:bodyPr rtlCol="0" anchor="ctr"/>
+            <a:lstStyle/>
+            <a:p>
+              <a:pPr algn="ctr"/>
+              <a:r>
+                <a:rPr lang="en-US" dirty="0">
+                  <a:solidFill>
+                    <a:schemeClr val="tx1"/>
+                  </a:solidFill>
+                </a:rPr>
+                <a:t>User</a:t>
+              </a:r>
+              <a:endParaRPr lang="en-US" i="1" dirty="0">
+                <a:solidFill>
+                  <a:schemeClr val="tx1"/>
+                </a:solidFill>
+              </a:endParaRPr>
+            </a:p>
+          </p:txBody>
+        </p:sp>
+      </p:grpSp>
+      <p:grpSp>
+        <p:nvGrpSpPr>
+          <p:cNvPr id="25" name="Group 24">
+            <a:extLst>
+              <a:ext uri="{FF2B5EF4-FFF2-40B4-BE49-F238E27FC236}">
+                <a16:creationId xmlns:a16="http://schemas.microsoft.com/office/drawing/2014/main" id="{99062568-FA8E-F589-1C12-98954AC4D417}"/>
+              </a:ext>
+            </a:extLst>
+          </p:cNvPr>
+          <p:cNvGrpSpPr/>
+          <p:nvPr/>
+        </p:nvGrpSpPr>
+        <p:grpSpPr>
+          <a:xfrm>
+            <a:off x="4792647" y="4014105"/>
+            <a:ext cx="1818401" cy="746025"/>
+            <a:chOff x="9154399" y="2746626"/>
+            <a:chExt cx="1344168" cy="746025"/>
+          </a:xfrm>
+        </p:grpSpPr>
+        <p:sp>
+          <p:nvSpPr>
+            <p:cNvPr id="26" name="Rectangle: Top Corners Rounded 25">
+              <a:extLst>
+                <a:ext uri="{FF2B5EF4-FFF2-40B4-BE49-F238E27FC236}">
+                  <a16:creationId xmlns:a16="http://schemas.microsoft.com/office/drawing/2014/main" id="{7A6B1112-EEBD-21AA-3321-692ED735351E}"/>
+                </a:ext>
+              </a:extLst>
+            </p:cNvPr>
+            <p:cNvSpPr/>
+            <p:nvPr/>
+          </p:nvSpPr>
+          <p:spPr>
+            <a:xfrm>
+              <a:off x="9154399" y="2938662"/>
+              <a:ext cx="1344168" cy="553989"/>
+            </a:xfrm>
+            <a:prstGeom prst="round2SameRect">
+              <a:avLst>
+                <a:gd name="adj1" fmla="val 0"/>
+                <a:gd name="adj2" fmla="val 11961"/>
+              </a:avLst>
+            </a:prstGeom>
+            <a:solidFill>
+              <a:srgbClr val="E5F1F8"/>
+            </a:solidFill>
+            <a:ln>
+              <a:solidFill>
+                <a:schemeClr val="tx1"/>
+              </a:solidFill>
+            </a:ln>
+          </p:spPr>
+          <p:style>
+            <a:lnRef idx="2">
+              <a:schemeClr val="accent1">
+                <a:shade val="15000"/>
+              </a:schemeClr>
+            </a:lnRef>
+            <a:fillRef idx="1">
+              <a:schemeClr val="accent1"/>
+            </a:fillRef>
+            <a:effectRef idx="0">
+              <a:schemeClr val="accent1"/>
+            </a:effectRef>
+            <a:fontRef idx="minor">
+              <a:schemeClr val="lt1"/>
+            </a:fontRef>
+          </p:style>
+          <p:txBody>
+            <a:bodyPr rtlCol="0" anchor="ctr"/>
+            <a:lstStyle/>
+            <a:p>
+              <a:pPr algn="ctr"/>
+              <a:r>
+                <a:rPr lang="en-US" dirty="0">
+                  <a:solidFill>
+                    <a:schemeClr val="tx1"/>
+                  </a:solidFill>
+                </a:rPr>
+                <a:t>Sandbox, read-only</a:t>
+              </a:r>
+            </a:p>
+          </p:txBody>
+        </p:sp>
+        <p:sp>
+          <p:nvSpPr>
+            <p:cNvPr id="27" name="Rectangle: Rounded Corners 26">
+              <a:extLst>
+                <a:ext uri="{FF2B5EF4-FFF2-40B4-BE49-F238E27FC236}">
+                  <a16:creationId xmlns:a16="http://schemas.microsoft.com/office/drawing/2014/main" id="{AB723828-D5F7-AD98-0255-8EF3A2D01ACD}"/>
+                </a:ext>
+              </a:extLst>
+            </p:cNvPr>
+            <p:cNvSpPr/>
+            <p:nvPr/>
+          </p:nvSpPr>
+          <p:spPr>
+            <a:xfrm>
+              <a:off x="9154399" y="2746626"/>
+              <a:ext cx="1344168" cy="230826"/>
+            </a:xfrm>
+            <a:prstGeom prst="roundRect">
+              <a:avLst/>
+            </a:prstGeom>
+            <a:solidFill>
+              <a:srgbClr val="B2D4EB"/>
+            </a:solidFill>
+            <a:ln>
+              <a:solidFill>
+                <a:schemeClr val="tx1"/>
+              </a:solidFill>
+            </a:ln>
+          </p:spPr>
+          <p:style>
+            <a:lnRef idx="2">
+              <a:schemeClr val="accent1">
+                <a:shade val="15000"/>
+              </a:schemeClr>
+            </a:lnRef>
+            <a:fillRef idx="1">
+              <a:schemeClr val="accent1"/>
+            </a:fillRef>
+            <a:effectRef idx="0">
+              <a:schemeClr val="accent1"/>
+            </a:effectRef>
+            <a:fontRef idx="minor">
+              <a:schemeClr val="lt1"/>
+            </a:fontRef>
+          </p:style>
+          <p:txBody>
+            <a:bodyPr rtlCol="0" anchor="ctr"/>
+            <a:lstStyle/>
+            <a:p>
+              <a:pPr algn="ctr"/>
+              <a:r>
+                <a:rPr lang="en-US" dirty="0">
+                  <a:solidFill>
+                    <a:schemeClr val="tx1"/>
+                  </a:solidFill>
+                </a:rPr>
+                <a:t>Untrusted</a:t>
+              </a:r>
+              <a:endParaRPr lang="en-US" i="1" dirty="0">
+                <a:solidFill>
+                  <a:schemeClr val="tx1"/>
+                </a:solidFill>
+              </a:endParaRPr>
+            </a:p>
+          </p:txBody>
+        </p:sp>
+      </p:grpSp>
+      <p:cxnSp>
+        <p:nvCxnSpPr>
+          <p:cNvPr id="29" name="Straight Arrow Connector 28">
+            <a:extLst>
+              <a:ext uri="{FF2B5EF4-FFF2-40B4-BE49-F238E27FC236}">
+                <a16:creationId xmlns:a16="http://schemas.microsoft.com/office/drawing/2014/main" id="{EDA9A562-A639-0290-4A8F-2191FEFD3543}"/>
+              </a:ext>
+            </a:extLst>
+          </p:cNvPr>
+          <p:cNvCxnSpPr>
+            <a:cxnSpLocks/>
+            <a:stCxn id="21" idx="1"/>
+            <a:endCxn id="9" idx="6"/>
+          </p:cNvCxnSpPr>
+          <p:nvPr/>
+        </p:nvCxnSpPr>
+        <p:spPr>
+          <a:xfrm flipH="1">
+            <a:off x="2780969" y="1596344"/>
+            <a:ext cx="2011680" cy="1713387"/>
+          </a:xfrm>
+          <a:prstGeom prst="straightConnector1">
+            <a:avLst/>
+          </a:prstGeom>
+          <a:ln>
+            <a:solidFill>
+              <a:schemeClr val="tx1"/>
+            </a:solidFill>
+            <a:prstDash val="solid"/>
+            <a:headEnd type="none" w="lg" len="lg"/>
+            <a:tailEnd type="triangle" w="lg" len="lg"/>
+          </a:ln>
+        </p:spPr>
+        <p:style>
+          <a:lnRef idx="2">
+            <a:schemeClr val="accent1"/>
+          </a:lnRef>
+          <a:fillRef idx="0">
+            <a:schemeClr val="accent1"/>
+          </a:fillRef>
+          <a:effectRef idx="1">
+            <a:schemeClr val="accent1"/>
+          </a:effectRef>
+          <a:fontRef idx="minor">
+            <a:schemeClr val="tx1"/>
+          </a:fontRef>
+        </p:style>
+      </p:cxnSp>
+      <p:cxnSp>
+        <p:nvCxnSpPr>
+          <p:cNvPr id="32" name="Straight Arrow Connector 31">
+            <a:extLst>
+              <a:ext uri="{FF2B5EF4-FFF2-40B4-BE49-F238E27FC236}">
+                <a16:creationId xmlns:a16="http://schemas.microsoft.com/office/drawing/2014/main" id="{9979D161-0A00-5FB8-B949-F291626722CB}"/>
+              </a:ext>
+            </a:extLst>
+          </p:cNvPr>
+          <p:cNvCxnSpPr>
+            <a:cxnSpLocks/>
+            <a:stCxn id="15" idx="1"/>
+            <a:endCxn id="10" idx="6"/>
+          </p:cNvCxnSpPr>
+          <p:nvPr/>
+        </p:nvCxnSpPr>
+        <p:spPr>
+          <a:xfrm flipH="1">
+            <a:off x="2780969" y="2440735"/>
+            <a:ext cx="2011679" cy="1554796"/>
+          </a:xfrm>
+          <a:prstGeom prst="straightConnector1">
+            <a:avLst/>
+          </a:prstGeom>
+          <a:ln>
+            <a:solidFill>
+              <a:schemeClr val="tx1"/>
+            </a:solidFill>
+            <a:prstDash val="solid"/>
+            <a:headEnd type="none" w="lg" len="lg"/>
+            <a:tailEnd type="triangle" w="lg" len="lg"/>
+          </a:ln>
+        </p:spPr>
+        <p:style>
+          <a:lnRef idx="2">
+            <a:schemeClr val="accent1"/>
+          </a:lnRef>
+          <a:fillRef idx="0">
+            <a:schemeClr val="accent1"/>
+          </a:fillRef>
+          <a:effectRef idx="1">
+            <a:schemeClr val="accent1"/>
+          </a:effectRef>
+          <a:fontRef idx="minor">
+            <a:schemeClr val="tx1"/>
+          </a:fontRef>
+        </p:style>
+      </p:cxnSp>
+      <p:cxnSp>
+        <p:nvCxnSpPr>
+          <p:cNvPr id="37" name="Straight Arrow Connector 36">
+            <a:extLst>
+              <a:ext uri="{FF2B5EF4-FFF2-40B4-BE49-F238E27FC236}">
+                <a16:creationId xmlns:a16="http://schemas.microsoft.com/office/drawing/2014/main" id="{B3C74887-A269-0023-3251-BF5F26080FE7}"/>
+              </a:ext>
+            </a:extLst>
+          </p:cNvPr>
+          <p:cNvCxnSpPr>
+            <a:cxnSpLocks/>
+            <a:stCxn id="24" idx="1"/>
+            <a:endCxn id="11" idx="6"/>
+          </p:cNvCxnSpPr>
+          <p:nvPr/>
+        </p:nvCxnSpPr>
+        <p:spPr>
+          <a:xfrm flipH="1">
+            <a:off x="2780969" y="3285127"/>
+            <a:ext cx="2011679" cy="1158276"/>
+          </a:xfrm>
+          <a:prstGeom prst="straightConnector1">
+            <a:avLst/>
+          </a:prstGeom>
+          <a:ln>
+            <a:solidFill>
+              <a:schemeClr val="tx1"/>
+            </a:solidFill>
+            <a:prstDash val="solid"/>
+            <a:headEnd type="none" w="lg" len="lg"/>
+            <a:tailEnd type="triangle" w="lg" len="lg"/>
+          </a:ln>
+        </p:spPr>
+        <p:style>
+          <a:lnRef idx="2">
+            <a:schemeClr val="accent1"/>
+          </a:lnRef>
+          <a:fillRef idx="0">
+            <a:schemeClr val="accent1"/>
+          </a:fillRef>
+          <a:effectRef idx="1">
+            <a:schemeClr val="accent1"/>
+          </a:effectRef>
+          <a:fontRef idx="minor">
+            <a:schemeClr val="tx1"/>
+          </a:fontRef>
+        </p:style>
+      </p:cxnSp>
+      <p:cxnSp>
+        <p:nvCxnSpPr>
+          <p:cNvPr id="40" name="Straight Arrow Connector 39">
+            <a:extLst>
+              <a:ext uri="{FF2B5EF4-FFF2-40B4-BE49-F238E27FC236}">
+                <a16:creationId xmlns:a16="http://schemas.microsoft.com/office/drawing/2014/main" id="{A2D1CCDD-6A9B-27D0-1997-3B216D317AAC}"/>
+              </a:ext>
+            </a:extLst>
+          </p:cNvPr>
+          <p:cNvCxnSpPr>
+            <a:cxnSpLocks/>
+            <a:stCxn id="27" idx="1"/>
+            <a:endCxn id="12" idx="6"/>
+          </p:cNvCxnSpPr>
+          <p:nvPr/>
+        </p:nvCxnSpPr>
+        <p:spPr>
+          <a:xfrm flipH="1">
+            <a:off x="2780969" y="4129518"/>
+            <a:ext cx="2011678" cy="771085"/>
+          </a:xfrm>
+          <a:prstGeom prst="straightConnector1">
+            <a:avLst/>
+          </a:prstGeom>
+          <a:ln>
+            <a:solidFill>
+              <a:schemeClr val="tx1"/>
+            </a:solidFill>
+            <a:prstDash val="solid"/>
+            <a:headEnd type="none" w="lg" len="lg"/>
+            <a:tailEnd type="triangle" w="lg" len="lg"/>
+          </a:ln>
+        </p:spPr>
+        <p:style>
+          <a:lnRef idx="2">
+            <a:schemeClr val="accent1"/>
+          </a:lnRef>
+          <a:fillRef idx="0">
+            <a:schemeClr val="accent1"/>
+          </a:fillRef>
+          <a:effectRef idx="1">
+            <a:schemeClr val="accent1"/>
+          </a:effectRef>
+          <a:fontRef idx="minor">
+            <a:schemeClr val="tx1"/>
+          </a:fontRef>
+        </p:style>
+      </p:cxnSp>
+    </p:spTree>
+    <p:extLst>
+      <p:ext uri="{BB962C8B-B14F-4D97-AF65-F5344CB8AC3E}">
+        <p14:creationId xmlns:p14="http://schemas.microsoft.com/office/powerpoint/2010/main" val="1019345337"/>
+      </p:ext>
+    </p:extLst>
+  </p:cSld>
+  <p:clrMapOvr>
+    <a:masterClrMapping/>
+  </p:clrMapOvr>
+</p:sld>
+</file>
+
+<file path=ppt/slides/slide27.xml><?xml version="1.0" encoding="utf-8"?>
+<p:sld xmlns:a="http://schemas.openxmlformats.org/drawingml/2006/main" xmlns:r="http://schemas.openxmlformats.org/officeDocument/2006/relationships" xmlns:p="http://schemas.openxmlformats.org/presentationml/2006/main">
+  <p:cSld>
+    <p:spTree>
+      <p:nvGrpSpPr>
+        <p:cNvPr id="1" name=""/>
+        <p:cNvGrpSpPr/>
+        <p:nvPr/>
+      </p:nvGrpSpPr>
+      <p:grpSpPr>
+        <a:xfrm>
+          <a:off x="0" y="0"/>
+          <a:ext cx="0" cy="0"/>
+          <a:chOff x="0" y="0"/>
+          <a:chExt cx="0" cy="0"/>
+        </a:xfrm>
+      </p:grpSpPr>
       <p:pic>
         <p:nvPicPr>
           <p:cNvPr id="1026" name="Picture 2">

</xml_diff>

<commit_message>
Add architecture info to Ch09
</commit_message>
<xml_diff>
--- a/figures/figures.pptx
+++ b/figures/figures.pptx
@@ -5,7 +5,7 @@
     <p:sldMasterId id="2147483660" r:id="rId1"/>
   </p:sldMasterIdLst>
   <p:notesMasterIdLst>
-    <p:notesMasterId r:id="rId29"/>
+    <p:notesMasterId r:id="rId30"/>
   </p:notesMasterIdLst>
   <p:sldIdLst>
     <p:sldId id="258" r:id="rId2"/>
@@ -34,7 +34,8 @@
     <p:sldId id="284" r:id="rId25"/>
     <p:sldId id="282" r:id="rId26"/>
     <p:sldId id="283" r:id="rId27"/>
-    <p:sldId id="257" r:id="rId28"/>
+    <p:sldId id="285" r:id="rId28"/>
+    <p:sldId id="257" r:id="rId29"/>
   </p:sldIdLst>
   <p:sldSz cx="12192000" cy="6858000"/>
   <p:notesSz cx="6858000" cy="9144000"/>
@@ -200,6 +201,7 @@
             <p14:sldId id="284"/>
             <p14:sldId id="282"/>
             <p14:sldId id="283"/>
+            <p14:sldId id="285"/>
           </p14:sldIdLst>
         </p14:section>
         <p14:section name="Examples" id="{2CEADF37-2C1D-4DE6-BB08-5D838E707A13}">
@@ -20953,6 +20955,909 @@
       </p:grpSpPr>
       <p:pic>
         <p:nvPicPr>
+          <p:cNvPr id="23" name="Graphic 22">
+            <a:extLst>
+              <a:ext uri="{FF2B5EF4-FFF2-40B4-BE49-F238E27FC236}">
+                <a16:creationId xmlns:a16="http://schemas.microsoft.com/office/drawing/2014/main" id="{DA88F6D7-4C9A-4185-3D36-7EB0922EE285}"/>
+              </a:ext>
+            </a:extLst>
+          </p:cNvPr>
+          <p:cNvPicPr>
+            <a:picLocks noChangeAspect="1"/>
+          </p:cNvPicPr>
+          <p:nvPr/>
+        </p:nvPicPr>
+        <p:blipFill>
+          <a:blip>
+            <a:extLst>
+              <a:ext uri="{96DAC541-7B7A-43D3-8B79-37D633B846F1}">
+                <asvg:svgBlip xmlns:asvg="http://schemas.microsoft.com/office/drawing/2016/SVG/main" r:embed="rId2"/>
+              </a:ext>
+            </a:extLst>
+          </a:blip>
+          <a:stretch>
+            <a:fillRect/>
+          </a:stretch>
+        </p:blipFill>
+        <p:spPr>
+          <a:xfrm>
+            <a:off x="6813470" y="1708181"/>
+            <a:ext cx="685800" cy="685800"/>
+          </a:xfrm>
+          <a:prstGeom prst="rect">
+            <a:avLst/>
+          </a:prstGeom>
+        </p:spPr>
+      </p:pic>
+      <p:pic>
+        <p:nvPicPr>
+          <p:cNvPr id="24" name="Graphic 23">
+            <a:extLst>
+              <a:ext uri="{FF2B5EF4-FFF2-40B4-BE49-F238E27FC236}">
+                <a16:creationId xmlns:a16="http://schemas.microsoft.com/office/drawing/2014/main" id="{726C5A85-790B-25A5-93E5-BFC1714EB9F1}"/>
+              </a:ext>
+            </a:extLst>
+          </p:cNvPr>
+          <p:cNvPicPr>
+            <a:picLocks noChangeAspect="1"/>
+          </p:cNvPicPr>
+          <p:nvPr/>
+        </p:nvPicPr>
+        <p:blipFill>
+          <a:blip>
+            <a:extLst>
+              <a:ext uri="{96DAC541-7B7A-43D3-8B79-37D633B846F1}">
+                <asvg:svgBlip xmlns:asvg="http://schemas.microsoft.com/office/drawing/2016/SVG/main" r:embed="rId3"/>
+              </a:ext>
+            </a:extLst>
+          </a:blip>
+          <a:stretch>
+            <a:fillRect/>
+          </a:stretch>
+        </p:blipFill>
+        <p:spPr>
+          <a:xfrm>
+            <a:off x="6813470" y="3522041"/>
+            <a:ext cx="685800" cy="685800"/>
+          </a:xfrm>
+          <a:prstGeom prst="rect">
+            <a:avLst/>
+          </a:prstGeom>
+        </p:spPr>
+      </p:pic>
+      <p:pic>
+        <p:nvPicPr>
+          <p:cNvPr id="26" name="Graphic 25">
+            <a:extLst>
+              <a:ext uri="{FF2B5EF4-FFF2-40B4-BE49-F238E27FC236}">
+                <a16:creationId xmlns:a16="http://schemas.microsoft.com/office/drawing/2014/main" id="{6F2CBAE6-3682-C7A5-095F-B47294275DAF}"/>
+              </a:ext>
+            </a:extLst>
+          </p:cNvPr>
+          <p:cNvPicPr>
+            <a:picLocks noChangeAspect="1"/>
+          </p:cNvPicPr>
+          <p:nvPr/>
+        </p:nvPicPr>
+        <p:blipFill>
+          <a:blip>
+            <a:extLst>
+              <a:ext uri="{96DAC541-7B7A-43D3-8B79-37D633B846F1}">
+                <asvg:svgBlip xmlns:asvg="http://schemas.microsoft.com/office/drawing/2016/SVG/main" r:embed="rId4"/>
+              </a:ext>
+            </a:extLst>
+          </a:blip>
+          <a:stretch>
+            <a:fillRect/>
+          </a:stretch>
+        </p:blipFill>
+        <p:spPr>
+          <a:xfrm>
+            <a:off x="4465557" y="3522041"/>
+            <a:ext cx="685800" cy="685800"/>
+          </a:xfrm>
+          <a:prstGeom prst="rect">
+            <a:avLst/>
+          </a:prstGeom>
+        </p:spPr>
+      </p:pic>
+      <p:sp>
+        <p:nvSpPr>
+          <p:cNvPr id="27" name="TextBox 26">
+            <a:extLst>
+              <a:ext uri="{FF2B5EF4-FFF2-40B4-BE49-F238E27FC236}">
+                <a16:creationId xmlns:a16="http://schemas.microsoft.com/office/drawing/2014/main" id="{F744DB5A-CC57-F1A8-E429-B66BEEC007AF}"/>
+              </a:ext>
+            </a:extLst>
+          </p:cNvPr>
+          <p:cNvSpPr txBox="1"/>
+          <p:nvPr/>
+        </p:nvSpPr>
+        <p:spPr>
+          <a:xfrm>
+            <a:off x="6659823" y="2473787"/>
+            <a:ext cx="993092" cy="492443"/>
+          </a:xfrm>
+          <a:prstGeom prst="rect">
+            <a:avLst/>
+          </a:prstGeom>
+          <a:noFill/>
+        </p:spPr>
+        <p:txBody>
+          <a:bodyPr wrap="none" lIns="0" tIns="0" rIns="0" bIns="0" rtlCol="0">
+            <a:spAutoFit/>
+          </a:bodyPr>
+          <a:lstStyle/>
+          <a:p>
+            <a:pPr algn="ctr" defTabSz="914400"/>
+            <a:r>
+              <a:rPr lang="en-US" sz="1600" dirty="0">
+                <a:latin typeface="+mj-lt"/>
+              </a:rPr>
+              <a:t>Cosmos DB</a:t>
+            </a:r>
+          </a:p>
+          <a:p>
+            <a:pPr algn="ctr" defTabSz="914400"/>
+            <a:r>
+              <a:rPr lang="en-US" sz="1600" dirty="0">
+                <a:latin typeface="+mj-lt"/>
+              </a:rPr>
+              <a:t>(Vector Data)</a:t>
+            </a:r>
+          </a:p>
+        </p:txBody>
+      </p:sp>
+      <p:sp>
+        <p:nvSpPr>
+          <p:cNvPr id="30" name="TextBox 29">
+            <a:extLst>
+              <a:ext uri="{FF2B5EF4-FFF2-40B4-BE49-F238E27FC236}">
+                <a16:creationId xmlns:a16="http://schemas.microsoft.com/office/drawing/2014/main" id="{C95D7447-BD22-D2C6-40B9-7995CB109180}"/>
+              </a:ext>
+            </a:extLst>
+          </p:cNvPr>
+          <p:cNvSpPr txBox="1"/>
+          <p:nvPr/>
+        </p:nvSpPr>
+        <p:spPr>
+          <a:xfrm>
+            <a:off x="6475765" y="4207841"/>
+            <a:ext cx="1361205" cy="492443"/>
+          </a:xfrm>
+          <a:prstGeom prst="rect">
+            <a:avLst/>
+          </a:prstGeom>
+          <a:noFill/>
+        </p:spPr>
+        <p:txBody>
+          <a:bodyPr wrap="none" lIns="0" tIns="0" rIns="0" bIns="0" rtlCol="0">
+            <a:spAutoFit/>
+          </a:bodyPr>
+          <a:lstStyle/>
+          <a:p>
+            <a:pPr algn="ctr" defTabSz="914400"/>
+            <a:r>
+              <a:rPr lang="en-US" sz="1600" dirty="0">
+                <a:latin typeface="+mj-lt"/>
+              </a:rPr>
+              <a:t>AI Search</a:t>
+            </a:r>
+          </a:p>
+          <a:p>
+            <a:pPr algn="ctr" defTabSz="914400"/>
+            <a:r>
+              <a:rPr lang="en-US" sz="1600" dirty="0">
+                <a:latin typeface="+mj-lt"/>
+              </a:rPr>
+              <a:t>(Indexed Content)</a:t>
+            </a:r>
+          </a:p>
+        </p:txBody>
+      </p:sp>
+      <p:sp>
+        <p:nvSpPr>
+          <p:cNvPr id="31" name="TextBox 30">
+            <a:extLst>
+              <a:ext uri="{FF2B5EF4-FFF2-40B4-BE49-F238E27FC236}">
+                <a16:creationId xmlns:a16="http://schemas.microsoft.com/office/drawing/2014/main" id="{8D88BA5D-AF5C-BD20-022B-994D0191FC68}"/>
+              </a:ext>
+            </a:extLst>
+          </p:cNvPr>
+          <p:cNvSpPr txBox="1"/>
+          <p:nvPr/>
+        </p:nvSpPr>
+        <p:spPr>
+          <a:xfrm>
+            <a:off x="4197584" y="4206755"/>
+            <a:ext cx="1221745" cy="492443"/>
+          </a:xfrm>
+          <a:prstGeom prst="rect">
+            <a:avLst/>
+          </a:prstGeom>
+          <a:noFill/>
+        </p:spPr>
+        <p:txBody>
+          <a:bodyPr wrap="none" lIns="0" tIns="0" rIns="0" bIns="0" rtlCol="0">
+            <a:spAutoFit/>
+          </a:bodyPr>
+          <a:lstStyle/>
+          <a:p>
+            <a:pPr algn="ctr" defTabSz="914400"/>
+            <a:r>
+              <a:rPr lang="en-US" sz="1600" dirty="0">
+                <a:latin typeface="+mj-lt"/>
+              </a:rPr>
+              <a:t>Storage Account</a:t>
+            </a:r>
+          </a:p>
+          <a:p>
+            <a:pPr algn="ctr" defTabSz="914400"/>
+            <a:r>
+              <a:rPr lang="en-US" sz="1600" dirty="0">
+                <a:latin typeface="+mj-lt"/>
+              </a:rPr>
+              <a:t>(Data Lake)</a:t>
+            </a:r>
+          </a:p>
+        </p:txBody>
+      </p:sp>
+      <p:cxnSp>
+        <p:nvCxnSpPr>
+          <p:cNvPr id="32" name="Straight Arrow Connector 31">
+            <a:extLst>
+              <a:ext uri="{FF2B5EF4-FFF2-40B4-BE49-F238E27FC236}">
+                <a16:creationId xmlns:a16="http://schemas.microsoft.com/office/drawing/2014/main" id="{4588F750-AAF4-DA5E-DD5C-8929A68CF8E7}"/>
+              </a:ext>
+            </a:extLst>
+          </p:cNvPr>
+          <p:cNvCxnSpPr>
+            <a:cxnSpLocks/>
+            <a:stCxn id="24" idx="0"/>
+            <a:endCxn id="27" idx="2"/>
+          </p:cNvCxnSpPr>
+          <p:nvPr/>
+        </p:nvCxnSpPr>
+        <p:spPr>
+          <a:xfrm flipH="1" flipV="1">
+            <a:off x="7156369" y="2966230"/>
+            <a:ext cx="1" cy="555811"/>
+          </a:xfrm>
+          <a:prstGeom prst="straightConnector1">
+            <a:avLst/>
+          </a:prstGeom>
+          <a:ln>
+            <a:solidFill>
+              <a:schemeClr val="tx1"/>
+            </a:solidFill>
+            <a:prstDash val="solid"/>
+            <a:headEnd type="triangle" w="lg" len="lg"/>
+            <a:tailEnd type="triangle" w="lg" len="lg"/>
+          </a:ln>
+        </p:spPr>
+        <p:style>
+          <a:lnRef idx="2">
+            <a:schemeClr val="accent1"/>
+          </a:lnRef>
+          <a:fillRef idx="0">
+            <a:schemeClr val="accent1"/>
+          </a:fillRef>
+          <a:effectRef idx="1">
+            <a:schemeClr val="accent1"/>
+          </a:effectRef>
+          <a:fontRef idx="minor">
+            <a:schemeClr val="tx1"/>
+          </a:fontRef>
+        </p:style>
+      </p:cxnSp>
+      <p:pic>
+        <p:nvPicPr>
+          <p:cNvPr id="33" name="Graphic 32">
+            <a:extLst>
+              <a:ext uri="{FF2B5EF4-FFF2-40B4-BE49-F238E27FC236}">
+                <a16:creationId xmlns:a16="http://schemas.microsoft.com/office/drawing/2014/main" id="{8F0C0947-C1EB-B5EF-FD9E-D7EF4D3625FE}"/>
+              </a:ext>
+            </a:extLst>
+          </p:cNvPr>
+          <p:cNvPicPr>
+            <a:picLocks noChangeAspect="1"/>
+          </p:cNvPicPr>
+          <p:nvPr/>
+        </p:nvPicPr>
+        <p:blipFill>
+          <a:blip>
+            <a:extLst>
+              <a:ext uri="{96DAC541-7B7A-43D3-8B79-37D633B846F1}">
+                <asvg:svgBlip xmlns:asvg="http://schemas.microsoft.com/office/drawing/2016/SVG/main" r:embed="rId5"/>
+              </a:ext>
+            </a:extLst>
+          </a:blip>
+          <a:srcRect/>
+          <a:stretch/>
+        </p:blipFill>
+        <p:spPr>
+          <a:xfrm>
+            <a:off x="2117644" y="3522041"/>
+            <a:ext cx="685800" cy="685800"/>
+          </a:xfrm>
+          <a:prstGeom prst="rect">
+            <a:avLst/>
+          </a:prstGeom>
+        </p:spPr>
+      </p:pic>
+      <p:sp>
+        <p:nvSpPr>
+          <p:cNvPr id="34" name="TextBox 33">
+            <a:extLst>
+              <a:ext uri="{FF2B5EF4-FFF2-40B4-BE49-F238E27FC236}">
+                <a16:creationId xmlns:a16="http://schemas.microsoft.com/office/drawing/2014/main" id="{C43E140A-36A7-4878-E24B-DCAA226DE6DF}"/>
+              </a:ext>
+            </a:extLst>
+          </p:cNvPr>
+          <p:cNvSpPr txBox="1"/>
+          <p:nvPr/>
+        </p:nvSpPr>
+        <p:spPr>
+          <a:xfrm>
+            <a:off x="1913952" y="4206755"/>
+            <a:ext cx="1093184" cy="492443"/>
+          </a:xfrm>
+          <a:prstGeom prst="rect">
+            <a:avLst/>
+          </a:prstGeom>
+          <a:noFill/>
+        </p:spPr>
+        <p:txBody>
+          <a:bodyPr wrap="none" lIns="0" tIns="0" rIns="0" bIns="0" rtlCol="0">
+            <a:spAutoFit/>
+          </a:bodyPr>
+          <a:lstStyle/>
+          <a:p>
+            <a:pPr algn="ctr" defTabSz="914400"/>
+            <a:r>
+              <a:rPr lang="en-US" sz="1600" dirty="0">
+                <a:latin typeface="+mj-lt"/>
+              </a:rPr>
+              <a:t>Data Factory</a:t>
+            </a:r>
+          </a:p>
+          <a:p>
+            <a:pPr algn="ctr" defTabSz="914400"/>
+            <a:r>
+              <a:rPr lang="en-US" sz="1600" dirty="0">
+                <a:latin typeface="+mj-lt"/>
+              </a:rPr>
+              <a:t>(ELT Pipelines)</a:t>
+            </a:r>
+          </a:p>
+        </p:txBody>
+      </p:sp>
+      <p:cxnSp>
+        <p:nvCxnSpPr>
+          <p:cNvPr id="35" name="Straight Arrow Connector 34">
+            <a:extLst>
+              <a:ext uri="{FF2B5EF4-FFF2-40B4-BE49-F238E27FC236}">
+                <a16:creationId xmlns:a16="http://schemas.microsoft.com/office/drawing/2014/main" id="{20B14887-F904-9314-8BE7-8163DAC58D11}"/>
+              </a:ext>
+            </a:extLst>
+          </p:cNvPr>
+          <p:cNvCxnSpPr>
+            <a:cxnSpLocks/>
+            <a:stCxn id="33" idx="3"/>
+            <a:endCxn id="26" idx="1"/>
+          </p:cNvCxnSpPr>
+          <p:nvPr/>
+        </p:nvCxnSpPr>
+        <p:spPr>
+          <a:xfrm>
+            <a:off x="2803444" y="3864941"/>
+            <a:ext cx="1662113" cy="0"/>
+          </a:xfrm>
+          <a:prstGeom prst="straightConnector1">
+            <a:avLst/>
+          </a:prstGeom>
+          <a:ln>
+            <a:solidFill>
+              <a:schemeClr val="tx1"/>
+            </a:solidFill>
+            <a:prstDash val="solid"/>
+            <a:headEnd type="none" w="lg" len="lg"/>
+            <a:tailEnd type="triangle" w="lg" len="lg"/>
+          </a:ln>
+        </p:spPr>
+        <p:style>
+          <a:lnRef idx="2">
+            <a:schemeClr val="accent1"/>
+          </a:lnRef>
+          <a:fillRef idx="0">
+            <a:schemeClr val="accent1"/>
+          </a:fillRef>
+          <a:effectRef idx="1">
+            <a:schemeClr val="accent1"/>
+          </a:effectRef>
+          <a:fontRef idx="minor">
+            <a:schemeClr val="tx1"/>
+          </a:fontRef>
+        </p:style>
+      </p:cxnSp>
+      <p:cxnSp>
+        <p:nvCxnSpPr>
+          <p:cNvPr id="36" name="Straight Arrow Connector 35">
+            <a:extLst>
+              <a:ext uri="{FF2B5EF4-FFF2-40B4-BE49-F238E27FC236}">
+                <a16:creationId xmlns:a16="http://schemas.microsoft.com/office/drawing/2014/main" id="{C477D93D-D115-B266-EB48-15C4DDE59387}"/>
+              </a:ext>
+            </a:extLst>
+          </p:cNvPr>
+          <p:cNvCxnSpPr>
+            <a:cxnSpLocks/>
+            <a:stCxn id="26" idx="3"/>
+            <a:endCxn id="24" idx="1"/>
+          </p:cNvCxnSpPr>
+          <p:nvPr/>
+        </p:nvCxnSpPr>
+        <p:spPr>
+          <a:xfrm>
+            <a:off x="5151357" y="3864941"/>
+            <a:ext cx="1662113" cy="0"/>
+          </a:xfrm>
+          <a:prstGeom prst="straightConnector1">
+            <a:avLst/>
+          </a:prstGeom>
+          <a:ln>
+            <a:solidFill>
+              <a:schemeClr val="tx1"/>
+            </a:solidFill>
+            <a:prstDash val="solid"/>
+            <a:headEnd type="none" w="lg" len="lg"/>
+            <a:tailEnd type="triangle" w="lg" len="lg"/>
+          </a:ln>
+        </p:spPr>
+        <p:style>
+          <a:lnRef idx="2">
+            <a:schemeClr val="accent1"/>
+          </a:lnRef>
+          <a:fillRef idx="0">
+            <a:schemeClr val="accent1"/>
+          </a:fillRef>
+          <a:effectRef idx="1">
+            <a:schemeClr val="accent1"/>
+          </a:effectRef>
+          <a:fontRef idx="minor">
+            <a:schemeClr val="tx1"/>
+          </a:fontRef>
+        </p:style>
+      </p:cxnSp>
+      <p:cxnSp>
+        <p:nvCxnSpPr>
+          <p:cNvPr id="37" name="Straight Arrow Connector 36">
+            <a:extLst>
+              <a:ext uri="{FF2B5EF4-FFF2-40B4-BE49-F238E27FC236}">
+                <a16:creationId xmlns:a16="http://schemas.microsoft.com/office/drawing/2014/main" id="{0217BDEA-C10B-A321-428F-0C1826880F36}"/>
+              </a:ext>
+            </a:extLst>
+          </p:cNvPr>
+          <p:cNvCxnSpPr>
+            <a:cxnSpLocks/>
+            <a:stCxn id="24" idx="3"/>
+            <a:endCxn id="48" idx="1"/>
+          </p:cNvCxnSpPr>
+          <p:nvPr/>
+        </p:nvCxnSpPr>
+        <p:spPr>
+          <a:xfrm>
+            <a:off x="7499270" y="3864941"/>
+            <a:ext cx="1499337" cy="0"/>
+          </a:xfrm>
+          <a:prstGeom prst="straightConnector1">
+            <a:avLst/>
+          </a:prstGeom>
+          <a:ln>
+            <a:solidFill>
+              <a:schemeClr val="tx1"/>
+            </a:solidFill>
+            <a:prstDash val="solid"/>
+            <a:headEnd type="triangle" w="lg" len="lg"/>
+            <a:tailEnd type="triangle" w="lg" len="lg"/>
+          </a:ln>
+        </p:spPr>
+        <p:style>
+          <a:lnRef idx="2">
+            <a:schemeClr val="accent1"/>
+          </a:lnRef>
+          <a:fillRef idx="0">
+            <a:schemeClr val="accent1"/>
+          </a:fillRef>
+          <a:effectRef idx="1">
+            <a:schemeClr val="accent1"/>
+          </a:effectRef>
+          <a:fontRef idx="minor">
+            <a:schemeClr val="tx1"/>
+          </a:fontRef>
+        </p:style>
+      </p:cxnSp>
+      <p:cxnSp>
+        <p:nvCxnSpPr>
+          <p:cNvPr id="38" name="Straight Arrow Connector 37">
+            <a:extLst>
+              <a:ext uri="{FF2B5EF4-FFF2-40B4-BE49-F238E27FC236}">
+                <a16:creationId xmlns:a16="http://schemas.microsoft.com/office/drawing/2014/main" id="{E158D239-5F5F-C9C7-726D-66FD0BA23F18}"/>
+              </a:ext>
+            </a:extLst>
+          </p:cNvPr>
+          <p:cNvCxnSpPr>
+            <a:cxnSpLocks/>
+          </p:cNvCxnSpPr>
+          <p:nvPr/>
+        </p:nvCxnSpPr>
+        <p:spPr>
+          <a:xfrm flipV="1">
+            <a:off x="9347120" y="2966230"/>
+            <a:ext cx="2" cy="555811"/>
+          </a:xfrm>
+          <a:prstGeom prst="straightConnector1">
+            <a:avLst/>
+          </a:prstGeom>
+          <a:ln>
+            <a:solidFill>
+              <a:schemeClr val="tx1"/>
+            </a:solidFill>
+            <a:prstDash val="solid"/>
+            <a:headEnd type="triangle" w="lg" len="lg"/>
+            <a:tailEnd type="triangle" w="lg" len="lg"/>
+          </a:ln>
+        </p:spPr>
+        <p:style>
+          <a:lnRef idx="2">
+            <a:schemeClr val="accent1"/>
+          </a:lnRef>
+          <a:fillRef idx="0">
+            <a:schemeClr val="accent1"/>
+          </a:fillRef>
+          <a:effectRef idx="1">
+            <a:schemeClr val="accent1"/>
+          </a:effectRef>
+          <a:fontRef idx="minor">
+            <a:schemeClr val="tx1"/>
+          </a:fontRef>
+        </p:style>
+      </p:cxnSp>
+      <p:sp>
+        <p:nvSpPr>
+          <p:cNvPr id="39" name="TextBox 38">
+            <a:extLst>
+              <a:ext uri="{FF2B5EF4-FFF2-40B4-BE49-F238E27FC236}">
+                <a16:creationId xmlns:a16="http://schemas.microsoft.com/office/drawing/2014/main" id="{7700DCB8-4817-4DCD-4A1A-A83089C25977}"/>
+              </a:ext>
+            </a:extLst>
+          </p:cNvPr>
+          <p:cNvSpPr txBox="1"/>
+          <p:nvPr/>
+        </p:nvSpPr>
+        <p:spPr>
+          <a:xfrm>
+            <a:off x="1884489" y="2473787"/>
+            <a:ext cx="1152110" cy="246221"/>
+          </a:xfrm>
+          <a:prstGeom prst="rect">
+            <a:avLst/>
+          </a:prstGeom>
+          <a:noFill/>
+        </p:spPr>
+        <p:txBody>
+          <a:bodyPr wrap="none" lIns="0" tIns="0" rIns="0" bIns="0" rtlCol="0">
+            <a:spAutoFit/>
+          </a:bodyPr>
+          <a:lstStyle/>
+          <a:p>
+            <a:pPr algn="ctr" defTabSz="914400"/>
+            <a:r>
+              <a:rPr lang="en-US" sz="1600" dirty="0">
+                <a:latin typeface="+mj-lt"/>
+              </a:rPr>
+              <a:t>Enterprise Data</a:t>
+            </a:r>
+          </a:p>
+        </p:txBody>
+      </p:sp>
+      <p:cxnSp>
+        <p:nvCxnSpPr>
+          <p:cNvPr id="40" name="Straight Arrow Connector 39">
+            <a:extLst>
+              <a:ext uri="{FF2B5EF4-FFF2-40B4-BE49-F238E27FC236}">
+                <a16:creationId xmlns:a16="http://schemas.microsoft.com/office/drawing/2014/main" id="{B381B268-3003-9E19-6433-B1769E5D8438}"/>
+              </a:ext>
+            </a:extLst>
+          </p:cNvPr>
+          <p:cNvCxnSpPr>
+            <a:cxnSpLocks/>
+            <a:stCxn id="39" idx="2"/>
+            <a:endCxn id="33" idx="0"/>
+          </p:cNvCxnSpPr>
+          <p:nvPr/>
+        </p:nvCxnSpPr>
+        <p:spPr>
+          <a:xfrm>
+            <a:off x="2460544" y="2720008"/>
+            <a:ext cx="0" cy="802033"/>
+          </a:xfrm>
+          <a:prstGeom prst="straightConnector1">
+            <a:avLst/>
+          </a:prstGeom>
+          <a:ln>
+            <a:solidFill>
+              <a:schemeClr val="tx1"/>
+            </a:solidFill>
+            <a:prstDash val="solid"/>
+            <a:headEnd type="none" w="lg" len="lg"/>
+            <a:tailEnd type="triangle" w="lg" len="lg"/>
+          </a:ln>
+        </p:spPr>
+        <p:style>
+          <a:lnRef idx="2">
+            <a:schemeClr val="accent1"/>
+          </a:lnRef>
+          <a:fillRef idx="0">
+            <a:schemeClr val="accent1"/>
+          </a:fillRef>
+          <a:effectRef idx="1">
+            <a:schemeClr val="accent1"/>
+          </a:effectRef>
+          <a:fontRef idx="minor">
+            <a:schemeClr val="tx1"/>
+          </a:fontRef>
+        </p:style>
+      </p:cxnSp>
+      <p:pic>
+        <p:nvPicPr>
+          <p:cNvPr id="41" name="Picture 40" descr="A blue paper with white text&#10;&#10;AI-generated content may be incorrect.">
+            <a:extLst>
+              <a:ext uri="{FF2B5EF4-FFF2-40B4-BE49-F238E27FC236}">
+                <a16:creationId xmlns:a16="http://schemas.microsoft.com/office/drawing/2014/main" id="{78714A7F-3440-9910-18BB-B2A338E04862}"/>
+              </a:ext>
+            </a:extLst>
+          </p:cNvPr>
+          <p:cNvPicPr>
+            <a:picLocks noChangeAspect="1"/>
+          </p:cNvPicPr>
+          <p:nvPr/>
+        </p:nvPicPr>
+        <p:blipFill>
+          <a:blip r:embed="rId6">
+            <a:duotone>
+              <a:srgbClr val="C03BC4">
+                <a:shade val="45000"/>
+                <a:satMod val="135000"/>
+              </a:srgbClr>
+              <a:prstClr val="white"/>
+            </a:duotone>
+            <a:extLst>
+              <a:ext uri="{28A0092B-C50C-407E-A947-70E740481C1C}">
+                <a14:useLocalDpi xmlns:a14="http://schemas.microsoft.com/office/drawing/2010/main" val="0"/>
+              </a:ext>
+            </a:extLst>
+          </a:blip>
+          <a:stretch>
+            <a:fillRect/>
+          </a:stretch>
+        </p:blipFill>
+        <p:spPr>
+          <a:xfrm>
+            <a:off x="2117644" y="1708181"/>
+            <a:ext cx="685800" cy="685800"/>
+          </a:xfrm>
+          <a:prstGeom prst="rect">
+            <a:avLst/>
+          </a:prstGeom>
+        </p:spPr>
+      </p:pic>
+      <p:pic>
+        <p:nvPicPr>
+          <p:cNvPr id="46" name="Graphic 45">
+            <a:extLst>
+              <a:ext uri="{FF2B5EF4-FFF2-40B4-BE49-F238E27FC236}">
+                <a16:creationId xmlns:a16="http://schemas.microsoft.com/office/drawing/2014/main" id="{AB28493D-0059-A8C8-7A3A-F22A5AB63EED}"/>
+              </a:ext>
+            </a:extLst>
+          </p:cNvPr>
+          <p:cNvPicPr>
+            <a:picLocks noChangeAspect="1"/>
+          </p:cNvPicPr>
+          <p:nvPr/>
+        </p:nvPicPr>
+        <p:blipFill>
+          <a:blip>
+            <a:extLst>
+              <a:ext uri="{96DAC541-7B7A-43D3-8B79-37D633B846F1}">
+                <asvg:svgBlip xmlns:asvg="http://schemas.microsoft.com/office/drawing/2016/SVG/main" r:embed="rId7"/>
+              </a:ext>
+            </a:extLst>
+          </a:blip>
+          <a:stretch>
+            <a:fillRect/>
+          </a:stretch>
+        </p:blipFill>
+        <p:spPr>
+          <a:xfrm>
+            <a:off x="9004220" y="1787987"/>
+            <a:ext cx="685800" cy="685800"/>
+          </a:xfrm>
+          <a:prstGeom prst="rect">
+            <a:avLst/>
+          </a:prstGeom>
+        </p:spPr>
+      </p:pic>
+      <p:sp>
+        <p:nvSpPr>
+          <p:cNvPr id="47" name="TextBox 46">
+            <a:extLst>
+              <a:ext uri="{FF2B5EF4-FFF2-40B4-BE49-F238E27FC236}">
+                <a16:creationId xmlns:a16="http://schemas.microsoft.com/office/drawing/2014/main" id="{A13B9753-C103-20D5-C8E5-2E3B09911743}"/>
+              </a:ext>
+            </a:extLst>
+          </p:cNvPr>
+          <p:cNvSpPr txBox="1"/>
+          <p:nvPr/>
+        </p:nvSpPr>
+        <p:spPr>
+          <a:xfrm>
+            <a:off x="8739902" y="2472701"/>
+            <a:ext cx="1214435" cy="492443"/>
+          </a:xfrm>
+          <a:prstGeom prst="rect">
+            <a:avLst/>
+          </a:prstGeom>
+          <a:noFill/>
+        </p:spPr>
+        <p:txBody>
+          <a:bodyPr wrap="none" lIns="0" tIns="0" rIns="0" bIns="0" rtlCol="0">
+            <a:spAutoFit/>
+          </a:bodyPr>
+          <a:lstStyle/>
+          <a:p>
+            <a:pPr algn="ctr" defTabSz="914400"/>
+            <a:r>
+              <a:rPr lang="en-US" sz="1600" dirty="0">
+                <a:latin typeface="+mj-lt"/>
+              </a:rPr>
+              <a:t>App Service</a:t>
+            </a:r>
+          </a:p>
+          <a:p>
+            <a:pPr algn="ctr" defTabSz="914400"/>
+            <a:r>
+              <a:rPr lang="en-US" sz="1600" dirty="0">
+                <a:latin typeface="+mj-lt"/>
+              </a:rPr>
+              <a:t>(Web Front End)</a:t>
+            </a:r>
+          </a:p>
+        </p:txBody>
+      </p:sp>
+      <p:pic>
+        <p:nvPicPr>
+          <p:cNvPr id="48" name="Picture 4">
+            <a:extLst>
+              <a:ext uri="{FF2B5EF4-FFF2-40B4-BE49-F238E27FC236}">
+                <a16:creationId xmlns:a16="http://schemas.microsoft.com/office/drawing/2014/main" id="{846CAA7C-59A7-6ED0-F3C6-FAC25B8BD9CF}"/>
+              </a:ext>
+            </a:extLst>
+          </p:cNvPr>
+          <p:cNvPicPr>
+            <a:picLocks noChangeAspect="1" noChangeArrowheads="1"/>
+          </p:cNvPicPr>
+          <p:nvPr/>
+        </p:nvPicPr>
+        <p:blipFill>
+          <a:blip r:embed="rId8">
+            <a:extLst>
+              <a:ext uri="{28A0092B-C50C-407E-A947-70E740481C1C}">
+                <a14:useLocalDpi xmlns:a14="http://schemas.microsoft.com/office/drawing/2010/main" val="0"/>
+              </a:ext>
+            </a:extLst>
+          </a:blip>
+          <a:srcRect/>
+          <a:stretch/>
+        </p:blipFill>
+        <p:spPr bwMode="auto">
+          <a:xfrm>
+            <a:off x="8998607" y="3551663"/>
+            <a:ext cx="685800" cy="626555"/>
+          </a:xfrm>
+          <a:prstGeom prst="rect">
+            <a:avLst/>
+          </a:prstGeom>
+          <a:noFill/>
+          <a:extLst>
+            <a:ext uri="{909E8E84-426E-40DD-AFC4-6F175D3DCCD1}">
+              <a14:hiddenFill xmlns:a14="http://schemas.microsoft.com/office/drawing/2010/main">
+                <a:solidFill>
+                  <a:srgbClr val="FFFFFF"/>
+                </a:solidFill>
+              </a14:hiddenFill>
+            </a:ext>
+          </a:extLst>
+        </p:spPr>
+      </p:pic>
+      <p:sp>
+        <p:nvSpPr>
+          <p:cNvPr id="49" name="TextBox 48">
+            <a:extLst>
+              <a:ext uri="{FF2B5EF4-FFF2-40B4-BE49-F238E27FC236}">
+                <a16:creationId xmlns:a16="http://schemas.microsoft.com/office/drawing/2014/main" id="{A2812E0E-399D-5F4A-E5DE-C3088B2B364D}"/>
+              </a:ext>
+            </a:extLst>
+          </p:cNvPr>
+          <p:cNvSpPr txBox="1"/>
+          <p:nvPr/>
+        </p:nvSpPr>
+        <p:spPr>
+          <a:xfrm>
+            <a:off x="8687482" y="4206754"/>
+            <a:ext cx="1308050" cy="492443"/>
+          </a:xfrm>
+          <a:prstGeom prst="rect">
+            <a:avLst/>
+          </a:prstGeom>
+          <a:noFill/>
+        </p:spPr>
+        <p:txBody>
+          <a:bodyPr wrap="none" lIns="0" tIns="0" rIns="0" bIns="0" rtlCol="0">
+            <a:spAutoFit/>
+          </a:bodyPr>
+          <a:lstStyle/>
+          <a:p>
+            <a:pPr algn="ctr" defTabSz="914400"/>
+            <a:r>
+              <a:rPr lang="en-US" sz="1600" dirty="0">
+                <a:latin typeface="+mj-lt"/>
+              </a:rPr>
+              <a:t>Foundry</a:t>
+            </a:r>
+          </a:p>
+          <a:p>
+            <a:pPr algn="ctr" defTabSz="914400"/>
+            <a:r>
+              <a:rPr lang="en-US" sz="1600" dirty="0">
+                <a:latin typeface="+mj-lt"/>
+              </a:rPr>
+              <a:t>(Model Endpoint)</a:t>
+            </a:r>
+          </a:p>
+        </p:txBody>
+      </p:sp>
+    </p:spTree>
+    <p:extLst>
+      <p:ext uri="{BB962C8B-B14F-4D97-AF65-F5344CB8AC3E}">
+        <p14:creationId xmlns:p14="http://schemas.microsoft.com/office/powerpoint/2010/main" val="3284386239"/>
+      </p:ext>
+    </p:extLst>
+  </p:cSld>
+  <p:clrMapOvr>
+    <a:masterClrMapping/>
+  </p:clrMapOvr>
+</p:sld>
+</file>
+
+<file path=ppt/slides/slide28.xml><?xml version="1.0" encoding="utf-8"?>
+<p:sld xmlns:a="http://schemas.openxmlformats.org/drawingml/2006/main" xmlns:r="http://schemas.openxmlformats.org/officeDocument/2006/relationships" xmlns:p="http://schemas.openxmlformats.org/presentationml/2006/main">
+  <p:cSld>
+    <p:spTree>
+      <p:nvGrpSpPr>
+        <p:cNvPr id="1" name=""/>
+        <p:cNvGrpSpPr/>
+        <p:nvPr/>
+      </p:nvGrpSpPr>
+      <p:grpSpPr>
+        <a:xfrm>
+          <a:off x="0" y="0"/>
+          <a:ext cx="0" cy="0"/>
+          <a:chOff x="0" y="0"/>
+          <a:chExt cx="0" cy="0"/>
+        </a:xfrm>
+      </p:grpSpPr>
+      <p:pic>
+        <p:nvPicPr>
           <p:cNvPr id="1026" name="Picture 2">
             <a:extLst>
               <a:ext uri="{FF2B5EF4-FFF2-40B4-BE49-F238E27FC236}">

</xml_diff>

<commit_message>
Update Chapters 1-4 based on CER1
</commit_message>
<xml_diff>
--- a/figures/figures.pptx
+++ b/figures/figures.pptx
@@ -293,7 +293,7 @@
           <a:p>
             <a:fld id="{DAABB0E5-6D8D-4DEE-B75F-67010CF2307C}" type="datetimeFigureOut">
               <a:rPr lang="en-US" smtClean="0"/>
-              <a:t>6/17/2026</a:t>
+              <a:t>7/14/2026</a:t>
             </a:fld>
             <a:endParaRPr lang="en-US"/>
           </a:p>
@@ -1062,7 +1062,7 @@
           <a:p>
             <a:fld id="{B84C5C40-2055-49AF-9028-5DA79E75E391}" type="datetimeFigureOut">
               <a:rPr lang="en-US" smtClean="0"/>
-              <a:t>6/17/2026</a:t>
+              <a:t>7/14/2026</a:t>
             </a:fld>
             <a:endParaRPr lang="en-US"/>
           </a:p>
@@ -1232,7 +1232,7 @@
           <a:p>
             <a:fld id="{B84C5C40-2055-49AF-9028-5DA79E75E391}" type="datetimeFigureOut">
               <a:rPr lang="en-US" smtClean="0"/>
-              <a:t>6/17/2026</a:t>
+              <a:t>7/14/2026</a:t>
             </a:fld>
             <a:endParaRPr lang="en-US"/>
           </a:p>
@@ -1412,7 +1412,7 @@
           <a:p>
             <a:fld id="{B84C5C40-2055-49AF-9028-5DA79E75E391}" type="datetimeFigureOut">
               <a:rPr lang="en-US" smtClean="0"/>
-              <a:t>6/17/2026</a:t>
+              <a:t>7/14/2026</a:t>
             </a:fld>
             <a:endParaRPr lang="en-US"/>
           </a:p>
@@ -1582,7 +1582,7 @@
           <a:p>
             <a:fld id="{B84C5C40-2055-49AF-9028-5DA79E75E391}" type="datetimeFigureOut">
               <a:rPr lang="en-US" smtClean="0"/>
-              <a:t>6/17/2026</a:t>
+              <a:t>7/14/2026</a:t>
             </a:fld>
             <a:endParaRPr lang="en-US"/>
           </a:p>
@@ -1828,7 +1828,7 @@
           <a:p>
             <a:fld id="{B84C5C40-2055-49AF-9028-5DA79E75E391}" type="datetimeFigureOut">
               <a:rPr lang="en-US" smtClean="0"/>
-              <a:t>6/17/2026</a:t>
+              <a:t>7/14/2026</a:t>
             </a:fld>
             <a:endParaRPr lang="en-US"/>
           </a:p>
@@ -2060,7 +2060,7 @@
           <a:p>
             <a:fld id="{B84C5C40-2055-49AF-9028-5DA79E75E391}" type="datetimeFigureOut">
               <a:rPr lang="en-US" smtClean="0"/>
-              <a:t>6/17/2026</a:t>
+              <a:t>7/14/2026</a:t>
             </a:fld>
             <a:endParaRPr lang="en-US"/>
           </a:p>
@@ -2427,7 +2427,7 @@
           <a:p>
             <a:fld id="{B84C5C40-2055-49AF-9028-5DA79E75E391}" type="datetimeFigureOut">
               <a:rPr lang="en-US" smtClean="0"/>
-              <a:t>6/17/2026</a:t>
+              <a:t>7/14/2026</a:t>
             </a:fld>
             <a:endParaRPr lang="en-US"/>
           </a:p>
@@ -2545,7 +2545,7 @@
           <a:p>
             <a:fld id="{B84C5C40-2055-49AF-9028-5DA79E75E391}" type="datetimeFigureOut">
               <a:rPr lang="en-US" smtClean="0"/>
-              <a:t>6/17/2026</a:t>
+              <a:t>7/14/2026</a:t>
             </a:fld>
             <a:endParaRPr lang="en-US"/>
           </a:p>
@@ -2640,7 +2640,7 @@
           <a:p>
             <a:fld id="{B84C5C40-2055-49AF-9028-5DA79E75E391}" type="datetimeFigureOut">
               <a:rPr lang="en-US" smtClean="0"/>
-              <a:t>6/17/2026</a:t>
+              <a:t>7/14/2026</a:t>
             </a:fld>
             <a:endParaRPr lang="en-US"/>
           </a:p>
@@ -2917,7 +2917,7 @@
           <a:p>
             <a:fld id="{B84C5C40-2055-49AF-9028-5DA79E75E391}" type="datetimeFigureOut">
               <a:rPr lang="en-US" smtClean="0"/>
-              <a:t>6/17/2026</a:t>
+              <a:t>7/14/2026</a:t>
             </a:fld>
             <a:endParaRPr lang="en-US"/>
           </a:p>
@@ -3174,7 +3174,7 @@
           <a:p>
             <a:fld id="{B84C5C40-2055-49AF-9028-5DA79E75E391}" type="datetimeFigureOut">
               <a:rPr lang="en-US" smtClean="0"/>
-              <a:t>6/17/2026</a:t>
+              <a:t>7/14/2026</a:t>
             </a:fld>
             <a:endParaRPr lang="en-US"/>
           </a:p>
@@ -3387,7 +3387,7 @@
           <a:p>
             <a:fld id="{B84C5C40-2055-49AF-9028-5DA79E75E391}" type="datetimeFigureOut">
               <a:rPr lang="en-US" smtClean="0"/>
-              <a:t>6/17/2026</a:t>
+              <a:t>7/14/2026</a:t>
             </a:fld>
             <a:endParaRPr lang="en-US"/>
           </a:p>
@@ -34100,7 +34100,7 @@
         </p:blipFill>
         <p:spPr bwMode="auto">
           <a:xfrm>
-            <a:off x="-32280" y="4799453"/>
+            <a:off x="-228600" y="5077748"/>
             <a:ext cx="12192000" cy="3873500"/>
           </a:xfrm>
           <a:prstGeom prst="rect">
@@ -34267,7 +34267,7 @@
           <p:nvPr>
             <p:extLst>
               <p:ext uri="{D42A27DB-BD31-4B8C-83A1-F6EECF244321}">
-                <p14:modId xmlns:p14="http://schemas.microsoft.com/office/powerpoint/2010/main" val="4267279013"/>
+                <p14:modId xmlns:p14="http://schemas.microsoft.com/office/powerpoint/2010/main" val="2088363739"/>
               </p:ext>
             </p:extLst>
           </p:nvPr>
@@ -34406,7 +34406,7 @@
                             <a:sysClr val="windowText" lastClr="000000"/>
                           </a:solidFill>
                         </a:rPr>
-                        <a:t>Onelake</a:t>
+                        <a:t>OneLake</a:t>
                       </a:r>
                       <a:endParaRPr lang="en-US" b="0" dirty="0">
                         <a:solidFill>
@@ -35005,7 +35005,7 @@
           <p:nvPr>
             <p:extLst>
               <p:ext uri="{D42A27DB-BD31-4B8C-83A1-F6EECF244321}">
-                <p14:modId xmlns:p14="http://schemas.microsoft.com/office/powerpoint/2010/main" val="2690640093"/>
+                <p14:modId xmlns:p14="http://schemas.microsoft.com/office/powerpoint/2010/main" val="779357497"/>
               </p:ext>
             </p:extLst>
           </p:nvPr>

</xml_diff>

<commit_message>
Update Chapters 5-9 based on CER1
</commit_message>
<xml_diff>
--- a/figures/figures.pptx
+++ b/figures/figures.pptx
@@ -293,7 +293,7 @@
           <a:p>
             <a:fld id="{DAABB0E5-6D8D-4DEE-B75F-67010CF2307C}" type="datetimeFigureOut">
               <a:rPr lang="en-US" smtClean="0"/>
-              <a:t>7/14/2026</a:t>
+              <a:t>7/15/2026</a:t>
             </a:fld>
             <a:endParaRPr lang="en-US"/>
           </a:p>
@@ -1062,7 +1062,7 @@
           <a:p>
             <a:fld id="{B84C5C40-2055-49AF-9028-5DA79E75E391}" type="datetimeFigureOut">
               <a:rPr lang="en-US" smtClean="0"/>
-              <a:t>7/14/2026</a:t>
+              <a:t>7/15/2026</a:t>
             </a:fld>
             <a:endParaRPr lang="en-US"/>
           </a:p>
@@ -1232,7 +1232,7 @@
           <a:p>
             <a:fld id="{B84C5C40-2055-49AF-9028-5DA79E75E391}" type="datetimeFigureOut">
               <a:rPr lang="en-US" smtClean="0"/>
-              <a:t>7/14/2026</a:t>
+              <a:t>7/15/2026</a:t>
             </a:fld>
             <a:endParaRPr lang="en-US"/>
           </a:p>
@@ -1412,7 +1412,7 @@
           <a:p>
             <a:fld id="{B84C5C40-2055-49AF-9028-5DA79E75E391}" type="datetimeFigureOut">
               <a:rPr lang="en-US" smtClean="0"/>
-              <a:t>7/14/2026</a:t>
+              <a:t>7/15/2026</a:t>
             </a:fld>
             <a:endParaRPr lang="en-US"/>
           </a:p>
@@ -1582,7 +1582,7 @@
           <a:p>
             <a:fld id="{B84C5C40-2055-49AF-9028-5DA79E75E391}" type="datetimeFigureOut">
               <a:rPr lang="en-US" smtClean="0"/>
-              <a:t>7/14/2026</a:t>
+              <a:t>7/15/2026</a:t>
             </a:fld>
             <a:endParaRPr lang="en-US"/>
           </a:p>
@@ -1828,7 +1828,7 @@
           <a:p>
             <a:fld id="{B84C5C40-2055-49AF-9028-5DA79E75E391}" type="datetimeFigureOut">
               <a:rPr lang="en-US" smtClean="0"/>
-              <a:t>7/14/2026</a:t>
+              <a:t>7/15/2026</a:t>
             </a:fld>
             <a:endParaRPr lang="en-US"/>
           </a:p>
@@ -2060,7 +2060,7 @@
           <a:p>
             <a:fld id="{B84C5C40-2055-49AF-9028-5DA79E75E391}" type="datetimeFigureOut">
               <a:rPr lang="en-US" smtClean="0"/>
-              <a:t>7/14/2026</a:t>
+              <a:t>7/15/2026</a:t>
             </a:fld>
             <a:endParaRPr lang="en-US"/>
           </a:p>
@@ -2427,7 +2427,7 @@
           <a:p>
             <a:fld id="{B84C5C40-2055-49AF-9028-5DA79E75E391}" type="datetimeFigureOut">
               <a:rPr lang="en-US" smtClean="0"/>
-              <a:t>7/14/2026</a:t>
+              <a:t>7/15/2026</a:t>
             </a:fld>
             <a:endParaRPr lang="en-US"/>
           </a:p>
@@ -2545,7 +2545,7 @@
           <a:p>
             <a:fld id="{B84C5C40-2055-49AF-9028-5DA79E75E391}" type="datetimeFigureOut">
               <a:rPr lang="en-US" smtClean="0"/>
-              <a:t>7/14/2026</a:t>
+              <a:t>7/15/2026</a:t>
             </a:fld>
             <a:endParaRPr lang="en-US"/>
           </a:p>
@@ -2640,7 +2640,7 @@
           <a:p>
             <a:fld id="{B84C5C40-2055-49AF-9028-5DA79E75E391}" type="datetimeFigureOut">
               <a:rPr lang="en-US" smtClean="0"/>
-              <a:t>7/14/2026</a:t>
+              <a:t>7/15/2026</a:t>
             </a:fld>
             <a:endParaRPr lang="en-US"/>
           </a:p>
@@ -2917,7 +2917,7 @@
           <a:p>
             <a:fld id="{B84C5C40-2055-49AF-9028-5DA79E75E391}" type="datetimeFigureOut">
               <a:rPr lang="en-US" smtClean="0"/>
-              <a:t>7/14/2026</a:t>
+              <a:t>7/15/2026</a:t>
             </a:fld>
             <a:endParaRPr lang="en-US"/>
           </a:p>
@@ -3174,7 +3174,7 @@
           <a:p>
             <a:fld id="{B84C5C40-2055-49AF-9028-5DA79E75E391}" type="datetimeFigureOut">
               <a:rPr lang="en-US" smtClean="0"/>
-              <a:t>7/14/2026</a:t>
+              <a:t>7/15/2026</a:t>
             </a:fld>
             <a:endParaRPr lang="en-US"/>
           </a:p>
@@ -3387,7 +3387,7 @@
           <a:p>
             <a:fld id="{B84C5C40-2055-49AF-9028-5DA79E75E391}" type="datetimeFigureOut">
               <a:rPr lang="en-US" smtClean="0"/>
-              <a:t>7/14/2026</a:t>
+              <a:t>7/15/2026</a:t>
             </a:fld>
             <a:endParaRPr lang="en-US"/>
           </a:p>
@@ -10815,7 +10815,7 @@
           <p:nvPr>
             <p:extLst>
               <p:ext uri="{D42A27DB-BD31-4B8C-83A1-F6EECF244321}">
-                <p14:modId xmlns:p14="http://schemas.microsoft.com/office/powerpoint/2010/main" val="2686571618"/>
+                <p14:modId xmlns:p14="http://schemas.microsoft.com/office/powerpoint/2010/main" val="3520250163"/>
               </p:ext>
             </p:extLst>
           </p:nvPr>
@@ -10946,7 +10946,7 @@
                             <a:sysClr val="windowText" lastClr="000000"/>
                           </a:solidFill>
                         </a:rPr>
-                        <a:t>Works Offline</a:t>
+                        <a:t>Works offline</a:t>
                       </a:r>
                     </a:p>
                   </a:txBody>
@@ -11125,7 +11125,7 @@
           <p:nvPr>
             <p:extLst>
               <p:ext uri="{D42A27DB-BD31-4B8C-83A1-F6EECF244321}">
-                <p14:modId xmlns:p14="http://schemas.microsoft.com/office/powerpoint/2010/main" val="3340926545"/>
+                <p14:modId xmlns:p14="http://schemas.microsoft.com/office/powerpoint/2010/main" val="2677451251"/>
               </p:ext>
             </p:extLst>
           </p:nvPr>
@@ -11435,7 +11435,7 @@
           <p:nvPr>
             <p:extLst>
               <p:ext uri="{D42A27DB-BD31-4B8C-83A1-F6EECF244321}">
-                <p14:modId xmlns:p14="http://schemas.microsoft.com/office/powerpoint/2010/main" val="1308394595"/>
+                <p14:modId xmlns:p14="http://schemas.microsoft.com/office/powerpoint/2010/main" val="2609140854"/>
               </p:ext>
             </p:extLst>
           </p:nvPr>
@@ -11486,23 +11486,7 @@
                             <a:sysClr val="windowText" lastClr="000000"/>
                           </a:solidFill>
                         </a:rPr>
-                        <a:t>SDKs for </a:t>
-                      </a:r>
-                      <a:r>
-                        <a:rPr lang="en-US" b="0" dirty="0" err="1">
-                          <a:solidFill>
-                            <a:sysClr val="windowText" lastClr="000000"/>
-                          </a:solidFill>
-                        </a:rPr>
-                        <a:t>Javascript</a:t>
-                      </a:r>
-                      <a:r>
-                        <a:rPr lang="en-US" b="0" dirty="0">
-                          <a:solidFill>
-                            <a:sysClr val="windowText" lastClr="000000"/>
-                          </a:solidFill>
-                        </a:rPr>
-                        <a:t>, Python, &amp; C#</a:t>
+                        <a:t>SDKs for JavaScript, Python, &amp; C#</a:t>
                       </a:r>
                     </a:p>
                   </a:txBody>
@@ -16814,7 +16798,7 @@
               <a:pPr algn="ctr"/>
               <a:r>
                 <a:rPr lang="en-US" sz="1600" dirty="0"/>
-                <a:t>Entities (nodes) are discreet objects of a domain.</a:t>
+                <a:t>Entities (nodes) are discrete objects of a domain.</a:t>
               </a:r>
             </a:p>
             <a:p>
@@ -22004,7 +21988,7 @@
             <a:pPr algn="ctr"/>
             <a:r>
               <a:rPr lang="en-US" dirty="0"/>
-              <a:t>1</a:t>
+              <a:t>0</a:t>
             </a:r>
           </a:p>
         </p:txBody>
@@ -22053,7 +22037,7 @@
             <a:pPr algn="ctr"/>
             <a:r>
               <a:rPr lang="en-US" dirty="0"/>
-              <a:t>2</a:t>
+              <a:t>1</a:t>
             </a:r>
           </a:p>
         </p:txBody>
@@ -22102,7 +22086,7 @@
             <a:pPr algn="ctr"/>
             <a:r>
               <a:rPr lang="en-US" dirty="0"/>
-              <a:t>3</a:t>
+              <a:t>2</a:t>
             </a:r>
           </a:p>
         </p:txBody>
@@ -22151,7 +22135,7 @@
             <a:pPr algn="ctr"/>
             <a:r>
               <a:rPr lang="en-US" dirty="0"/>
-              <a:t>4</a:t>
+              <a:t>3</a:t>
             </a:r>
           </a:p>
         </p:txBody>

</xml_diff>